<commit_message>
data: update 2026-05-23 (data.json publicaciones_semana.pptx)
</commit_message>
<xml_diff>
--- a/publicaciones_semana.pptx
+++ b/publicaciones_semana.pptx
@@ -13,6 +13,7 @@
     <p:sldId id="261" r:id="rId12"/>
     <p:sldId id="262" r:id="rId13"/>
     <p:sldId id="263" r:id="rId14"/>
+    <p:sldId id="264" r:id="rId15"/>
   </p:sldIdLst>
   <p:sldSz cx="12191695" cy="6858000" type="screen4x3"/>
   <p:notesSz cx="6858000" cy="9144000"/>
@@ -3278,7 +3279,7 @@
                 </a:solidFill>
                 <a:latin typeface="Encode Sans"/>
               </a:rPr>
-              <a:t>7 publicaciones · datos oficiales INDEC / BCRA / Hacienda</a:t>
+              <a:t>8 publicaciones · datos oficiales INDEC / BCRA / Hacienda</a:t>
             </a:r>
           </a:p>
         </p:txBody>
@@ -9661,6 +9662,1013 @@
                           <a:latin typeface="Encode Sans"/>
                         </a:rPr>
                         <a:t>152,7</a:t>
+                      </a:r>
+                    </a:p>
+                  </a:txBody>
+                  <a:tcPr marL="36576" marR="36576" marT="18288" marB="18288">
+                    <a:solidFill>
+                      <a:srgbClr val="F8F8F6"/>
+                    </a:solidFill>
+                  </a:tcPr>
+                </a:tc>
+              </a:tr>
+            </a:tbl>
+          </a:graphicData>
+        </a:graphic>
+      </p:graphicFrame>
+      <p:sp>
+        <p:nvSpPr>
+          <p:cNvPr id="9" name="TextBox 8"/>
+          <p:cNvSpPr txBox="1"/>
+          <p:nvPr/>
+        </p:nvSpPr>
+        <p:spPr>
+          <a:xfrm>
+            <a:off x="411480" y="6492240"/>
+            <a:ext cx="11368735" cy="274320"/>
+          </a:xfrm>
+          <a:prstGeom prst="rect">
+            <a:avLst/>
+          </a:prstGeom>
+          <a:noFill/>
+        </p:spPr>
+        <p:txBody>
+          <a:bodyPr wrap="none">
+            <a:spAutoFit/>
+          </a:bodyPr>
+          <a:lstStyle/>
+          <a:p>
+            <a:r>
+              <a:rPr sz="1000" b="0" i="1">
+                <a:solidFill>
+                  <a:srgbClr val="6A6760"/>
+                </a:solidFill>
+                <a:latin typeface="Encode Sans"/>
+              </a:rPr>
+              <a:t>Fuente: elaboración propia en base a INDEC</a:t>
+            </a:r>
+          </a:p>
+        </p:txBody>
+      </p:sp>
+    </p:spTree>
+  </p:cSld>
+  <p:clrMapOvr>
+    <a:masterClrMapping/>
+  </p:clrMapOvr>
+</p:sld>
+</file>
+
+<file path=ppt/slides/slide9.xml><?xml version="1.0" encoding="utf-8"?>
+<p:sld xmlns:a="http://schemas.openxmlformats.org/drawingml/2006/main" xmlns:p="http://schemas.openxmlformats.org/presentationml/2006/main" xmlns:r="http://schemas.openxmlformats.org/officeDocument/2006/relationships">
+  <p:cSld>
+    <p:spTree>
+      <p:nvGrpSpPr>
+        <p:cNvPr id="1" name=""/>
+        <p:cNvGrpSpPr/>
+        <p:nvPr/>
+      </p:nvGrpSpPr>
+      <p:grpSpPr/>
+      <p:sp>
+        <p:nvSpPr>
+          <p:cNvPr id="2" name="Rectangle 1"/>
+          <p:cNvSpPr/>
+          <p:nvPr/>
+        </p:nvSpPr>
+        <p:spPr>
+          <a:xfrm>
+            <a:off x="0" y="0"/>
+            <a:ext cx="12191695" cy="274320"/>
+          </a:xfrm>
+          <a:prstGeom prst="rect">
+            <a:avLst/>
+          </a:prstGeom>
+          <a:solidFill>
+            <a:srgbClr val="00B2C9"/>
+          </a:solidFill>
+          <a:ln>
+            <a:noFill/>
+          </a:ln>
+        </p:spPr>
+        <p:style>
+          <a:lnRef idx="1">
+            <a:schemeClr val="accent1"/>
+          </a:lnRef>
+          <a:fillRef idx="3">
+            <a:schemeClr val="accent1"/>
+          </a:fillRef>
+          <a:effectRef idx="2">
+            <a:schemeClr val="accent1"/>
+          </a:effectRef>
+          <a:fontRef idx="minor">
+            <a:schemeClr val="lt1"/>
+          </a:fontRef>
+        </p:style>
+        <p:txBody>
+          <a:bodyPr rtlCol="0" anchor="ctr"/>
+          <a:lstStyle/>
+          <a:p>
+            <a:pPr algn="ctr"/>
+          </a:p>
+        </p:txBody>
+      </p:sp>
+      <p:sp>
+        <p:nvSpPr>
+          <p:cNvPr id="3" name="TextBox 2"/>
+          <p:cNvSpPr txBox="1"/>
+          <p:nvPr/>
+        </p:nvSpPr>
+        <p:spPr>
+          <a:xfrm>
+            <a:off x="411480" y="457200"/>
+            <a:ext cx="11368735" cy="914400"/>
+          </a:xfrm>
+          <a:prstGeom prst="rect">
+            <a:avLst/>
+          </a:prstGeom>
+          <a:noFill/>
+        </p:spPr>
+        <p:txBody>
+          <a:bodyPr wrap="square" lIns="0" rIns="0">
+            <a:spAutoFit/>
+          </a:bodyPr>
+          <a:lstStyle/>
+          <a:p>
+            <a:pPr algn="l"/>
+            <a:r>
+              <a:rPr sz="2600" b="1" i="0">
+                <a:solidFill>
+                  <a:srgbClr val="00B2C9"/>
+                </a:solidFill>
+                <a:latin typeface="Encode Sans"/>
+              </a:rPr>
+              <a:t>SUPERMERCADOS MARZO 2026: VENTAS REALES CAYERON -5.1%</a:t>
+            </a:r>
+          </a:p>
+        </p:txBody>
+      </p:sp>
+      <p:sp>
+        <p:nvSpPr>
+          <p:cNvPr id="4" name="TextBox 3"/>
+          <p:cNvSpPr txBox="1"/>
+          <p:nvPr/>
+        </p:nvSpPr>
+        <p:spPr>
+          <a:xfrm>
+            <a:off x="411480" y="1280160"/>
+            <a:ext cx="11368735" cy="274320"/>
+          </a:xfrm>
+          <a:prstGeom prst="rect">
+            <a:avLst/>
+          </a:prstGeom>
+          <a:noFill/>
+        </p:spPr>
+        <p:txBody>
+          <a:bodyPr wrap="none">
+            <a:spAutoFit/>
+          </a:bodyPr>
+          <a:lstStyle/>
+          <a:p>
+            <a:r>
+              <a:rPr sz="1100" b="0" i="1">
+                <a:solidFill>
+                  <a:srgbClr val="6A6760"/>
+                </a:solidFill>
+                <a:latin typeface="Encode Sans"/>
+              </a:rPr>
+              <a:t>INDEC · período 2026-03</a:t>
+            </a:r>
+          </a:p>
+        </p:txBody>
+      </p:sp>
+      <p:sp>
+        <p:nvSpPr>
+          <p:cNvPr id="5" name="TextBox 4"/>
+          <p:cNvSpPr txBox="1"/>
+          <p:nvPr/>
+        </p:nvSpPr>
+        <p:spPr>
+          <a:xfrm>
+            <a:off x="411480" y="1691640"/>
+            <a:ext cx="5486400" cy="1645920"/>
+          </a:xfrm>
+          <a:prstGeom prst="rect">
+            <a:avLst/>
+          </a:prstGeom>
+          <a:noFill/>
+        </p:spPr>
+        <p:txBody>
+          <a:bodyPr wrap="square" lIns="0" rIns="0">
+            <a:spAutoFit/>
+          </a:bodyPr>
+          <a:lstStyle/>
+          <a:p>
+            <a:pPr algn="just"/>
+            <a:r>
+              <a:rPr sz="1300" b="0" i="0">
+                <a:solidFill>
+                  <a:srgbClr val="3F3F3F"/>
+                </a:solidFill>
+                <a:latin typeface="Encode Sans"/>
+              </a:rPr>
+              <a:t>Las ventas de supermercados a precios constantes registraron una variación interanual real de -5.1% en marzo 2026. Desestacionalizada: -0.0% m/m.</a:t>
+            </a:r>
+          </a:p>
+        </p:txBody>
+      </p:sp>
+      <p:sp>
+        <p:nvSpPr>
+          <p:cNvPr id="6" name="TextBox 5"/>
+          <p:cNvSpPr txBox="1"/>
+          <p:nvPr/>
+        </p:nvSpPr>
+        <p:spPr>
+          <a:xfrm>
+            <a:off x="411480" y="3520440"/>
+            <a:ext cx="5486400" cy="2743200"/>
+          </a:xfrm>
+          <a:prstGeom prst="rect">
+            <a:avLst/>
+          </a:prstGeom>
+          <a:noFill/>
+        </p:spPr>
+        <p:txBody>
+          <a:bodyPr wrap="square" lIns="0" rIns="0">
+            <a:spAutoFit/>
+          </a:bodyPr>
+          <a:lstStyle/>
+          <a:p>
+            <a:pPr algn="l">
+              <a:spcAft>
+                <a:spcPts val="800"/>
+              </a:spcAft>
+            </a:pPr>
+            <a:r>
+              <a:rPr sz="1300" b="1" i="0">
+                <a:solidFill>
+                  <a:srgbClr val="00B2C9"/>
+                </a:solidFill>
+                <a:latin typeface="Encode Sans"/>
+              </a:rPr>
+              <a:t>●  </a:t>
+            </a:r>
+            <a:r>
+              <a:rPr sz="1300" b="0" i="0">
+                <a:solidFill>
+                  <a:srgbClr val="3F3F3F"/>
+                </a:solidFill>
+                <a:latin typeface="Encode Sans"/>
+              </a:rPr>
+              <a:t>Variación interanual real: -5.1%</a:t>
+            </a:r>
+          </a:p>
+          <a:p>
+            <a:pPr algn="l">
+              <a:spcAft>
+                <a:spcPts val="800"/>
+              </a:spcAft>
+            </a:pPr>
+            <a:r>
+              <a:rPr sz="1300" b="1" i="0">
+                <a:solidFill>
+                  <a:srgbClr val="00B2C9"/>
+                </a:solidFill>
+                <a:latin typeface="Encode Sans"/>
+              </a:rPr>
+              <a:t>●  </a:t>
+            </a:r>
+            <a:r>
+              <a:rPr sz="1300" b="0" i="0">
+                <a:solidFill>
+                  <a:srgbClr val="3F3F3F"/>
+                </a:solidFill>
+                <a:latin typeface="Encode Sans"/>
+              </a:rPr>
+              <a:t>Variación mensual desestacionalizada: -0.0%</a:t>
+            </a:r>
+          </a:p>
+          <a:p>
+            <a:pPr algn="l">
+              <a:spcAft>
+                <a:spcPts val="800"/>
+              </a:spcAft>
+            </a:pPr>
+            <a:r>
+              <a:rPr sz="1300" b="1" i="0">
+                <a:solidFill>
+                  <a:srgbClr val="00B2C9"/>
+                </a:solidFill>
+                <a:latin typeface="Encode Sans"/>
+              </a:rPr>
+              <a:t>●  </a:t>
+            </a:r>
+            <a:r>
+              <a:rPr sz="1300" b="0" i="0">
+                <a:solidFill>
+                  <a:srgbClr val="3F3F3F"/>
+                </a:solidFill>
+                <a:latin typeface="Encode Sans"/>
+              </a:rPr>
+              <a:t>Acumulado del año: -3.1%</a:t>
+            </a:r>
+          </a:p>
+        </p:txBody>
+      </p:sp>
+      <p:pic>
+        <p:nvPicPr>
+          <p:cNvPr id="7" name="Picture 6" descr="image.png"/>
+          <p:cNvPicPr>
+            <a:picLocks noChangeAspect="1"/>
+          </p:cNvPicPr>
+          <p:nvPr/>
+        </p:nvPicPr>
+        <p:blipFill>
+          <a:blip r:embed="rId2"/>
+          <a:stretch>
+            <a:fillRect/>
+          </a:stretch>
+        </p:blipFill>
+        <p:spPr>
+          <a:xfrm>
+            <a:off x="6080760" y="1691640"/>
+            <a:ext cx="5669280" cy="2560320"/>
+          </a:xfrm>
+          <a:prstGeom prst="rect">
+            <a:avLst/>
+          </a:prstGeom>
+        </p:spPr>
+      </p:pic>
+      <p:graphicFrame>
+        <p:nvGraphicFramePr>
+          <p:cNvPr id="8" name="Table 7"/>
+          <p:cNvGraphicFramePr>
+            <a:graphicFrameLocks noGrp="1"/>
+          </p:cNvGraphicFramePr>
+          <p:nvPr/>
+        </p:nvGraphicFramePr>
+        <p:xfrm>
+          <a:off x="6080760" y="4434840"/>
+          <a:ext cx="5669280" cy="2048256"/>
+        </p:xfrm>
+        <a:graphic>
+          <a:graphicData uri="http://schemas.openxmlformats.org/drawingml/2006/table">
+            <a:tbl>
+              <a:tblPr firstRow="1" bandRow="1">
+                <a:tableStyleId>{5C22544A-7EE6-4342-B048-85BDC9FD1C3A}</a:tableStyleId>
+              </a:tblPr>
+              <a:tblGrid>
+                <a:gridCol w="1417320"/>
+                <a:gridCol w="1417320"/>
+                <a:gridCol w="1417320"/>
+                <a:gridCol w="1417320"/>
+              </a:tblGrid>
+              <a:tr h="292608">
+                <a:tc>
+                  <a:txBody>
+                    <a:bodyPr/>
+                    <a:lstStyle/>
+                    <a:p>
+                      <a:pPr algn="l"/>
+                      <a:r>
+                        <a:rPr sz="1000" b="1">
+                          <a:solidFill>
+                            <a:srgbClr val="FFFFFF"/>
+                          </a:solidFill>
+                          <a:latin typeface="Encode Sans"/>
+                        </a:rPr>
+                        <a:t>Mes</a:t>
+                      </a:r>
+                    </a:p>
+                  </a:txBody>
+                  <a:tcPr marL="36576" marR="36576" marT="18288" marB="18288">
+                    <a:solidFill>
+                      <a:srgbClr val="00B2C9"/>
+                    </a:solidFill>
+                  </a:tcPr>
+                </a:tc>
+                <a:tc>
+                  <a:txBody>
+                    <a:bodyPr/>
+                    <a:lstStyle/>
+                    <a:p>
+                      <a:pPr algn="r"/>
+                      <a:r>
+                        <a:rPr sz="1000" b="1">
+                          <a:solidFill>
+                            <a:srgbClr val="FFFFFF"/>
+                          </a:solidFill>
+                          <a:latin typeface="Encode Sans"/>
+                        </a:rPr>
+                        <a:t>Índice real</a:t>
+                      </a:r>
+                    </a:p>
+                  </a:txBody>
+                  <a:tcPr marL="36576" marR="36576" marT="18288" marB="18288">
+                    <a:solidFill>
+                      <a:srgbClr val="00B2C9"/>
+                    </a:solidFill>
+                  </a:tcPr>
+                </a:tc>
+                <a:tc>
+                  <a:txBody>
+                    <a:bodyPr/>
+                    <a:lstStyle/>
+                    <a:p>
+                      <a:pPr algn="r"/>
+                      <a:r>
+                        <a:rPr sz="1000" b="1">
+                          <a:solidFill>
+                            <a:srgbClr val="FFFFFF"/>
+                          </a:solidFill>
+                          <a:latin typeface="Encode Sans"/>
+                        </a:rPr>
+                        <a:t>VIA real %</a:t>
+                      </a:r>
+                    </a:p>
+                  </a:txBody>
+                  <a:tcPr marL="36576" marR="36576" marT="18288" marB="18288">
+                    <a:solidFill>
+                      <a:srgbClr val="00B2C9"/>
+                    </a:solidFill>
+                  </a:tcPr>
+                </a:tc>
+                <a:tc>
+                  <a:txBody>
+                    <a:bodyPr/>
+                    <a:lstStyle/>
+                    <a:p>
+                      <a:pPr algn="r"/>
+                      <a:r>
+                        <a:rPr sz="1000" b="1">
+                          <a:solidFill>
+                            <a:srgbClr val="FFFFFF"/>
+                          </a:solidFill>
+                          <a:latin typeface="Encode Sans"/>
+                        </a:rPr>
+                        <a:t>Acumulado %</a:t>
+                      </a:r>
+                    </a:p>
+                  </a:txBody>
+                  <a:tcPr marL="36576" marR="36576" marT="18288" marB="18288">
+                    <a:solidFill>
+                      <a:srgbClr val="00B2C9"/>
+                    </a:solidFill>
+                  </a:tcPr>
+                </a:tc>
+              </a:tr>
+              <a:tr h="292608">
+                <a:tc>
+                  <a:txBody>
+                    <a:bodyPr/>
+                    <a:lstStyle/>
+                    <a:p>
+                      <a:pPr algn="l"/>
+                      <a:r>
+                        <a:rPr sz="1000">
+                          <a:solidFill>
+                            <a:srgbClr val="3F3F3F"/>
+                          </a:solidFill>
+                          <a:latin typeface="Encode Sans"/>
+                        </a:rPr>
+                        <a:t>Marzo 2026</a:t>
+                      </a:r>
+                    </a:p>
+                  </a:txBody>
+                  <a:tcPr marL="36576" marR="36576" marT="18288" marB="18288">
+                    <a:solidFill>
+                      <a:srgbClr val="FFFFFF"/>
+                    </a:solidFill>
+                  </a:tcPr>
+                </a:tc>
+                <a:tc>
+                  <a:txBody>
+                    <a:bodyPr/>
+                    <a:lstStyle/>
+                    <a:p>
+                      <a:pPr algn="r"/>
+                      <a:r>
+                        <a:rPr sz="1000">
+                          <a:solidFill>
+                            <a:srgbClr val="3F3F3F"/>
+                          </a:solidFill>
+                          <a:latin typeface="Encode Sans"/>
+                        </a:rPr>
+                        <a:t>82,4</a:t>
+                      </a:r>
+                    </a:p>
+                  </a:txBody>
+                  <a:tcPr marL="36576" marR="36576" marT="18288" marB="18288">
+                    <a:solidFill>
+                      <a:srgbClr val="FFFFFF"/>
+                    </a:solidFill>
+                  </a:tcPr>
+                </a:tc>
+                <a:tc>
+                  <a:txBody>
+                    <a:bodyPr/>
+                    <a:lstStyle/>
+                    <a:p>
+                      <a:pPr algn="r"/>
+                      <a:r>
+                        <a:rPr sz="1000">
+                          <a:solidFill>
+                            <a:srgbClr val="3F3F3F"/>
+                          </a:solidFill>
+                          <a:latin typeface="Encode Sans"/>
+                        </a:rPr>
+                        <a:t>-5.1%</a:t>
+                      </a:r>
+                    </a:p>
+                  </a:txBody>
+                  <a:tcPr marL="36576" marR="36576" marT="18288" marB="18288">
+                    <a:solidFill>
+                      <a:srgbClr val="FFFFFF"/>
+                    </a:solidFill>
+                  </a:tcPr>
+                </a:tc>
+                <a:tc>
+                  <a:txBody>
+                    <a:bodyPr/>
+                    <a:lstStyle/>
+                    <a:p>
+                      <a:pPr algn="r"/>
+                      <a:r>
+                        <a:rPr sz="1000">
+                          <a:solidFill>
+                            <a:srgbClr val="3F3F3F"/>
+                          </a:solidFill>
+                          <a:latin typeface="Encode Sans"/>
+                        </a:rPr>
+                        <a:t>-3.1%</a:t>
+                      </a:r>
+                    </a:p>
+                  </a:txBody>
+                  <a:tcPr marL="36576" marR="36576" marT="18288" marB="18288">
+                    <a:solidFill>
+                      <a:srgbClr val="FFFFFF"/>
+                    </a:solidFill>
+                  </a:tcPr>
+                </a:tc>
+              </a:tr>
+              <a:tr h="292608">
+                <a:tc>
+                  <a:txBody>
+                    <a:bodyPr/>
+                    <a:lstStyle/>
+                    <a:p>
+                      <a:pPr algn="l"/>
+                      <a:r>
+                        <a:rPr sz="1000">
+                          <a:solidFill>
+                            <a:srgbClr val="3F3F3F"/>
+                          </a:solidFill>
+                          <a:latin typeface="Encode Sans"/>
+                        </a:rPr>
+                        <a:t>Febrero 2026</a:t>
+                      </a:r>
+                    </a:p>
+                  </a:txBody>
+                  <a:tcPr marL="36576" marR="36576" marT="18288" marB="18288">
+                    <a:solidFill>
+                      <a:srgbClr val="F8F8F6"/>
+                    </a:solidFill>
+                  </a:tcPr>
+                </a:tc>
+                <a:tc>
+                  <a:txBody>
+                    <a:bodyPr/>
+                    <a:lstStyle/>
+                    <a:p>
+                      <a:pPr algn="r"/>
+                      <a:r>
+                        <a:rPr sz="1000">
+                          <a:solidFill>
+                            <a:srgbClr val="3F3F3F"/>
+                          </a:solidFill>
+                          <a:latin typeface="Encode Sans"/>
+                        </a:rPr>
+                        <a:t>76,1</a:t>
+                      </a:r>
+                    </a:p>
+                  </a:txBody>
+                  <a:tcPr marL="36576" marR="36576" marT="18288" marB="18288">
+                    <a:solidFill>
+                      <a:srgbClr val="F8F8F6"/>
+                    </a:solidFill>
+                  </a:tcPr>
+                </a:tc>
+                <a:tc>
+                  <a:txBody>
+                    <a:bodyPr/>
+                    <a:lstStyle/>
+                    <a:p>
+                      <a:pPr algn="r"/>
+                      <a:r>
+                        <a:rPr sz="1000">
+                          <a:solidFill>
+                            <a:srgbClr val="3F3F3F"/>
+                          </a:solidFill>
+                          <a:latin typeface="Encode Sans"/>
+                        </a:rPr>
+                        <a:t>-3.1%</a:t>
+                      </a:r>
+                    </a:p>
+                  </a:txBody>
+                  <a:tcPr marL="36576" marR="36576" marT="18288" marB="18288">
+                    <a:solidFill>
+                      <a:srgbClr val="F8F8F6"/>
+                    </a:solidFill>
+                  </a:tcPr>
+                </a:tc>
+                <a:tc>
+                  <a:txBody>
+                    <a:bodyPr/>
+                    <a:lstStyle/>
+                    <a:p>
+                      <a:pPr algn="r"/>
+                      <a:r>
+                        <a:rPr sz="1000">
+                          <a:solidFill>
+                            <a:srgbClr val="3F3F3F"/>
+                          </a:solidFill>
+                          <a:latin typeface="Encode Sans"/>
+                        </a:rPr>
+                        <a:t>-2.1%</a:t>
+                      </a:r>
+                    </a:p>
+                  </a:txBody>
+                  <a:tcPr marL="36576" marR="36576" marT="18288" marB="18288">
+                    <a:solidFill>
+                      <a:srgbClr val="F8F8F6"/>
+                    </a:solidFill>
+                  </a:tcPr>
+                </a:tc>
+              </a:tr>
+              <a:tr h="292608">
+                <a:tc>
+                  <a:txBody>
+                    <a:bodyPr/>
+                    <a:lstStyle/>
+                    <a:p>
+                      <a:pPr algn="l"/>
+                      <a:r>
+                        <a:rPr sz="1000">
+                          <a:solidFill>
+                            <a:srgbClr val="3F3F3F"/>
+                          </a:solidFill>
+                          <a:latin typeface="Encode Sans"/>
+                        </a:rPr>
+                        <a:t>Enero 2026</a:t>
+                      </a:r>
+                    </a:p>
+                  </a:txBody>
+                  <a:tcPr marL="36576" marR="36576" marT="18288" marB="18288">
+                    <a:solidFill>
+                      <a:srgbClr val="FFFFFF"/>
+                    </a:solidFill>
+                  </a:tcPr>
+                </a:tc>
+                <a:tc>
+                  <a:txBody>
+                    <a:bodyPr/>
+                    <a:lstStyle/>
+                    <a:p>
+                      <a:pPr algn="r"/>
+                      <a:r>
+                        <a:rPr sz="1000">
+                          <a:solidFill>
+                            <a:srgbClr val="3F3F3F"/>
+                          </a:solidFill>
+                          <a:latin typeface="Encode Sans"/>
+                        </a:rPr>
+                        <a:t>82,8</a:t>
+                      </a:r>
+                    </a:p>
+                  </a:txBody>
+                  <a:tcPr marL="36576" marR="36576" marT="18288" marB="18288">
+                    <a:solidFill>
+                      <a:srgbClr val="FFFFFF"/>
+                    </a:solidFill>
+                  </a:tcPr>
+                </a:tc>
+                <a:tc>
+                  <a:txBody>
+                    <a:bodyPr/>
+                    <a:lstStyle/>
+                    <a:p>
+                      <a:pPr algn="r"/>
+                      <a:r>
+                        <a:rPr sz="1000">
+                          <a:solidFill>
+                            <a:srgbClr val="3F3F3F"/>
+                          </a:solidFill>
+                          <a:latin typeface="Encode Sans"/>
+                        </a:rPr>
+                        <a:t>-1.2%</a:t>
+                      </a:r>
+                    </a:p>
+                  </a:txBody>
+                  <a:tcPr marL="36576" marR="36576" marT="18288" marB="18288">
+                    <a:solidFill>
+                      <a:srgbClr val="FFFFFF"/>
+                    </a:solidFill>
+                  </a:tcPr>
+                </a:tc>
+                <a:tc>
+                  <a:txBody>
+                    <a:bodyPr/>
+                    <a:lstStyle/>
+                    <a:p>
+                      <a:pPr algn="r"/>
+                      <a:r>
+                        <a:rPr sz="1000">
+                          <a:solidFill>
+                            <a:srgbClr val="3F3F3F"/>
+                          </a:solidFill>
+                          <a:latin typeface="Encode Sans"/>
+                        </a:rPr>
+                        <a:t>-1.2%</a:t>
+                      </a:r>
+                    </a:p>
+                  </a:txBody>
+                  <a:tcPr marL="36576" marR="36576" marT="18288" marB="18288">
+                    <a:solidFill>
+                      <a:srgbClr val="FFFFFF"/>
+                    </a:solidFill>
+                  </a:tcPr>
+                </a:tc>
+              </a:tr>
+              <a:tr h="292608">
+                <a:tc>
+                  <a:txBody>
+                    <a:bodyPr/>
+                    <a:lstStyle/>
+                    <a:p>
+                      <a:pPr algn="l"/>
+                      <a:r>
+                        <a:rPr sz="1000">
+                          <a:solidFill>
+                            <a:srgbClr val="3F3F3F"/>
+                          </a:solidFill>
+                          <a:latin typeface="Encode Sans"/>
+                        </a:rPr>
+                        <a:t>Diciembre 2025</a:t>
+                      </a:r>
+                    </a:p>
+                  </a:txBody>
+                  <a:tcPr marL="36576" marR="36576" marT="18288" marB="18288">
+                    <a:solidFill>
+                      <a:srgbClr val="F8F8F6"/>
+                    </a:solidFill>
+                  </a:tcPr>
+                </a:tc>
+                <a:tc>
+                  <a:txBody>
+                    <a:bodyPr/>
+                    <a:lstStyle/>
+                    <a:p>
+                      <a:pPr algn="r"/>
+                      <a:r>
+                        <a:rPr sz="1000">
+                          <a:solidFill>
+                            <a:srgbClr val="3F3F3F"/>
+                          </a:solidFill>
+                          <a:latin typeface="Encode Sans"/>
+                        </a:rPr>
+                        <a:t>102,3</a:t>
+                      </a:r>
+                    </a:p>
+                  </a:txBody>
+                  <a:tcPr marL="36576" marR="36576" marT="18288" marB="18288">
+                    <a:solidFill>
+                      <a:srgbClr val="F8F8F6"/>
+                    </a:solidFill>
+                  </a:tcPr>
+                </a:tc>
+                <a:tc>
+                  <a:txBody>
+                    <a:bodyPr/>
+                    <a:lstStyle/>
+                    <a:p>
+                      <a:pPr algn="r"/>
+                      <a:r>
+                        <a:rPr sz="1000">
+                          <a:solidFill>
+                            <a:srgbClr val="3F3F3F"/>
+                          </a:solidFill>
+                          <a:latin typeface="Encode Sans"/>
+                        </a:rPr>
+                        <a:t>+0.5%</a:t>
+                      </a:r>
+                    </a:p>
+                  </a:txBody>
+                  <a:tcPr marL="36576" marR="36576" marT="18288" marB="18288">
+                    <a:solidFill>
+                      <a:srgbClr val="F8F8F6"/>
+                    </a:solidFill>
+                  </a:tcPr>
+                </a:tc>
+                <a:tc>
+                  <a:txBody>
+                    <a:bodyPr/>
+                    <a:lstStyle/>
+                    <a:p>
+                      <a:pPr algn="r"/>
+                      <a:r>
+                        <a:rPr sz="1000">
+                          <a:solidFill>
+                            <a:srgbClr val="3F3F3F"/>
+                          </a:solidFill>
+                          <a:latin typeface="Encode Sans"/>
+                        </a:rPr>
+                        <a:t>+2.0%</a:t>
+                      </a:r>
+                    </a:p>
+                  </a:txBody>
+                  <a:tcPr marL="36576" marR="36576" marT="18288" marB="18288">
+                    <a:solidFill>
+                      <a:srgbClr val="F8F8F6"/>
+                    </a:solidFill>
+                  </a:tcPr>
+                </a:tc>
+              </a:tr>
+              <a:tr h="292608">
+                <a:tc>
+                  <a:txBody>
+                    <a:bodyPr/>
+                    <a:lstStyle/>
+                    <a:p>
+                      <a:pPr algn="l"/>
+                      <a:r>
+                        <a:rPr sz="1000">
+                          <a:solidFill>
+                            <a:srgbClr val="3F3F3F"/>
+                          </a:solidFill>
+                          <a:latin typeface="Encode Sans"/>
+                        </a:rPr>
+                        <a:t>Noviembre 2025</a:t>
+                      </a:r>
+                    </a:p>
+                  </a:txBody>
+                  <a:tcPr marL="36576" marR="36576" marT="18288" marB="18288">
+                    <a:solidFill>
+                      <a:srgbClr val="FFFFFF"/>
+                    </a:solidFill>
+                  </a:tcPr>
+                </a:tc>
+                <a:tc>
+                  <a:txBody>
+                    <a:bodyPr/>
+                    <a:lstStyle/>
+                    <a:p>
+                      <a:pPr algn="r"/>
+                      <a:r>
+                        <a:rPr sz="1000">
+                          <a:solidFill>
+                            <a:srgbClr val="3F3F3F"/>
+                          </a:solidFill>
+                          <a:latin typeface="Encode Sans"/>
+                        </a:rPr>
+                        <a:t>82,3</a:t>
+                      </a:r>
+                    </a:p>
+                  </a:txBody>
+                  <a:tcPr marL="36576" marR="36576" marT="18288" marB="18288">
+                    <a:solidFill>
+                      <a:srgbClr val="FFFFFF"/>
+                    </a:solidFill>
+                  </a:tcPr>
+                </a:tc>
+                <a:tc>
+                  <a:txBody>
+                    <a:bodyPr/>
+                    <a:lstStyle/>
+                    <a:p>
+                      <a:pPr algn="r"/>
+                      <a:r>
+                        <a:rPr sz="1000">
+                          <a:solidFill>
+                            <a:srgbClr val="3F3F3F"/>
+                          </a:solidFill>
+                          <a:latin typeface="Encode Sans"/>
+                        </a:rPr>
+                        <a:t>-2.8%</a:t>
+                      </a:r>
+                    </a:p>
+                  </a:txBody>
+                  <a:tcPr marL="36576" marR="36576" marT="18288" marB="18288">
+                    <a:solidFill>
+                      <a:srgbClr val="FFFFFF"/>
+                    </a:solidFill>
+                  </a:tcPr>
+                </a:tc>
+                <a:tc>
+                  <a:txBody>
+                    <a:bodyPr/>
+                    <a:lstStyle/>
+                    <a:p>
+                      <a:pPr algn="r"/>
+                      <a:r>
+                        <a:rPr sz="1000">
+                          <a:solidFill>
+                            <a:srgbClr val="3F3F3F"/>
+                          </a:solidFill>
+                          <a:latin typeface="Encode Sans"/>
+                        </a:rPr>
+                        <a:t>+2.2%</a:t>
+                      </a:r>
+                    </a:p>
+                  </a:txBody>
+                  <a:tcPr marL="36576" marR="36576" marT="18288" marB="18288">
+                    <a:solidFill>
+                      <a:srgbClr val="FFFFFF"/>
+                    </a:solidFill>
+                  </a:tcPr>
+                </a:tc>
+              </a:tr>
+              <a:tr h="292608">
+                <a:tc>
+                  <a:txBody>
+                    <a:bodyPr/>
+                    <a:lstStyle/>
+                    <a:p>
+                      <a:pPr algn="l"/>
+                      <a:r>
+                        <a:rPr sz="1000">
+                          <a:solidFill>
+                            <a:srgbClr val="3F3F3F"/>
+                          </a:solidFill>
+                          <a:latin typeface="Encode Sans"/>
+                        </a:rPr>
+                        <a:t>Octubre 2025</a:t>
+                      </a:r>
+                    </a:p>
+                  </a:txBody>
+                  <a:tcPr marL="36576" marR="36576" marT="18288" marB="18288">
+                    <a:solidFill>
+                      <a:srgbClr val="F8F8F6"/>
+                    </a:solidFill>
+                  </a:tcPr>
+                </a:tc>
+                <a:tc>
+                  <a:txBody>
+                    <a:bodyPr/>
+                    <a:lstStyle/>
+                    <a:p>
+                      <a:pPr algn="r"/>
+                      <a:r>
+                        <a:rPr sz="1000">
+                          <a:solidFill>
+                            <a:srgbClr val="3F3F3F"/>
+                          </a:solidFill>
+                          <a:latin typeface="Encode Sans"/>
+                        </a:rPr>
+                        <a:t>82,2</a:t>
+                      </a:r>
+                    </a:p>
+                  </a:txBody>
+                  <a:tcPr marL="36576" marR="36576" marT="18288" marB="18288">
+                    <a:solidFill>
+                      <a:srgbClr val="F8F8F6"/>
+                    </a:solidFill>
+                  </a:tcPr>
+                </a:tc>
+                <a:tc>
+                  <a:txBody>
+                    <a:bodyPr/>
+                    <a:lstStyle/>
+                    <a:p>
+                      <a:pPr algn="r"/>
+                      <a:r>
+                        <a:rPr sz="1000">
+                          <a:solidFill>
+                            <a:srgbClr val="3F3F3F"/>
+                          </a:solidFill>
+                          <a:latin typeface="Encode Sans"/>
+                        </a:rPr>
+                        <a:t>+2.7%</a:t>
+                      </a:r>
+                    </a:p>
+                  </a:txBody>
+                  <a:tcPr marL="36576" marR="36576" marT="18288" marB="18288">
+                    <a:solidFill>
+                      <a:srgbClr val="F8F8F6"/>
+                    </a:solidFill>
+                  </a:tcPr>
+                </a:tc>
+                <a:tc>
+                  <a:txBody>
+                    <a:bodyPr/>
+                    <a:lstStyle/>
+                    <a:p>
+                      <a:pPr algn="r"/>
+                      <a:r>
+                        <a:rPr sz="1000">
+                          <a:solidFill>
+                            <a:srgbClr val="3F3F3F"/>
+                          </a:solidFill>
+                          <a:latin typeface="Encode Sans"/>
+                        </a:rPr>
+                        <a:t>+2.7%</a:t>
                       </a:r>
                     </a:p>
                   </a:txBody>

</xml_diff>

<commit_message>
data: update 2026-05-27 ( data.json despidos.json scraper/historical_despidos.json publicaciones_semana.pptx)
</commit_message>
<xml_diff>
--- a/publicaciones_semana.pptx
+++ b/publicaciones_semana.pptx
@@ -8,6 +8,7 @@
     <p:sldId id="256" r:id="rId7"/>
     <p:sldId id="257" r:id="rId8"/>
     <p:sldId id="258" r:id="rId9"/>
+    <p:sldId id="259" r:id="rId10"/>
   </p:sldIdLst>
   <p:sldSz cx="12191695" cy="6858000" type="screen4x3"/>
   <p:notesSz cx="6858000" cy="9144000"/>
@@ -3273,7 +3274,7 @@
                 </a:solidFill>
                 <a:latin typeface="Encode Sans"/>
               </a:rPr>
-              <a:t>2 publicaciones · datos oficiales INDEC / BCRA / Hacienda</a:t>
+              <a:t>3 publicaciones · datos oficiales INDEC / BCRA / Hacienda</a:t>
             </a:r>
           </a:p>
         </p:txBody>
@@ -5300,6 +5301,303 @@
 </p:sld>
 </file>
 
+<file path=ppt/slides/slide4.xml><?xml version="1.0" encoding="utf-8"?>
+<p:sld xmlns:a="http://schemas.openxmlformats.org/drawingml/2006/main" xmlns:p="http://schemas.openxmlformats.org/presentationml/2006/main" xmlns:r="http://schemas.openxmlformats.org/officeDocument/2006/relationships">
+  <p:cSld>
+    <p:spTree>
+      <p:nvGrpSpPr>
+        <p:cNvPr id="1" name=""/>
+        <p:cNvGrpSpPr/>
+        <p:nvPr/>
+      </p:nvGrpSpPr>
+      <p:grpSpPr/>
+      <p:sp>
+        <p:nvSpPr>
+          <p:cNvPr id="2" name="Rectangle 1"/>
+          <p:cNvSpPr/>
+          <p:nvPr/>
+        </p:nvSpPr>
+        <p:spPr>
+          <a:xfrm>
+            <a:off x="0" y="0"/>
+            <a:ext cx="12191695" cy="274320"/>
+          </a:xfrm>
+          <a:prstGeom prst="rect">
+            <a:avLst/>
+          </a:prstGeom>
+          <a:solidFill>
+            <a:srgbClr val="00B2C9"/>
+          </a:solidFill>
+          <a:ln>
+            <a:noFill/>
+          </a:ln>
+        </p:spPr>
+        <p:style>
+          <a:lnRef idx="1">
+            <a:schemeClr val="accent1"/>
+          </a:lnRef>
+          <a:fillRef idx="3">
+            <a:schemeClr val="accent1"/>
+          </a:fillRef>
+          <a:effectRef idx="2">
+            <a:schemeClr val="accent1"/>
+          </a:effectRef>
+          <a:fontRef idx="minor">
+            <a:schemeClr val="lt1"/>
+          </a:fontRef>
+        </p:style>
+        <p:txBody>
+          <a:bodyPr rtlCol="0" anchor="ctr"/>
+          <a:lstStyle/>
+          <a:p>
+            <a:pPr algn="ctr"/>
+          </a:p>
+        </p:txBody>
+      </p:sp>
+      <p:sp>
+        <p:nvSpPr>
+          <p:cNvPr id="3" name="TextBox 2"/>
+          <p:cNvSpPr txBox="1"/>
+          <p:nvPr/>
+        </p:nvSpPr>
+        <p:spPr>
+          <a:xfrm>
+            <a:off x="411480" y="457200"/>
+            <a:ext cx="11368735" cy="914400"/>
+          </a:xfrm>
+          <a:prstGeom prst="rect">
+            <a:avLst/>
+          </a:prstGeom>
+          <a:noFill/>
+        </p:spPr>
+        <p:txBody>
+          <a:bodyPr wrap="square" lIns="0" rIns="0">
+            <a:spAutoFit/>
+          </a:bodyPr>
+          <a:lstStyle/>
+          <a:p>
+            <a:pPr algn="l"/>
+            <a:r>
+              <a:rPr sz="2600" b="1" i="0">
+                <a:solidFill>
+                  <a:srgbClr val="00B2C9"/>
+                </a:solidFill>
+                <a:latin typeface="Encode Sans"/>
+              </a:rPr>
+              <a:t>TURISMO INTERNACIONAL ABRIL 2026</a:t>
+            </a:r>
+          </a:p>
+        </p:txBody>
+      </p:sp>
+      <p:sp>
+        <p:nvSpPr>
+          <p:cNvPr id="4" name="TextBox 3"/>
+          <p:cNvSpPr txBox="1"/>
+          <p:nvPr/>
+        </p:nvSpPr>
+        <p:spPr>
+          <a:xfrm>
+            <a:off x="411480" y="1280160"/>
+            <a:ext cx="11368735" cy="274320"/>
+          </a:xfrm>
+          <a:prstGeom prst="rect">
+            <a:avLst/>
+          </a:prstGeom>
+          <a:noFill/>
+        </p:spPr>
+        <p:txBody>
+          <a:bodyPr wrap="none">
+            <a:spAutoFit/>
+          </a:bodyPr>
+          <a:lstStyle/>
+          <a:p>
+            <a:r>
+              <a:rPr sz="1100" b="0" i="1">
+                <a:solidFill>
+                  <a:srgbClr val="6A6760"/>
+                </a:solidFill>
+                <a:latin typeface="Encode Sans"/>
+              </a:rPr>
+              <a:t>INDEC · período 2026-04</a:t>
+            </a:r>
+          </a:p>
+        </p:txBody>
+      </p:sp>
+      <p:sp>
+        <p:nvSpPr>
+          <p:cNvPr id="5" name="TextBox 4"/>
+          <p:cNvSpPr txBox="1"/>
+          <p:nvPr/>
+        </p:nvSpPr>
+        <p:spPr>
+          <a:xfrm>
+            <a:off x="411480" y="1691640"/>
+            <a:ext cx="5486400" cy="1645920"/>
+          </a:xfrm>
+          <a:prstGeom prst="rect">
+            <a:avLst/>
+          </a:prstGeom>
+          <a:noFill/>
+        </p:spPr>
+        <p:txBody>
+          <a:bodyPr wrap="square" lIns="0" rIns="0">
+            <a:spAutoFit/>
+          </a:bodyPr>
+          <a:lstStyle/>
+          <a:p>
+            <a:pPr algn="just"/>
+            <a:r>
+              <a:rPr sz="1300" b="0" i="0">
+                <a:solidFill>
+                  <a:srgbClr val="3F3F3F"/>
+                </a:solidFill>
+                <a:latin typeface="Encode Sans"/>
+              </a:rPr>
+              <a:t>Se publicó la actualización de Turismo internacional para abril 2026. Fuente: INDEC.</a:t>
+            </a:r>
+          </a:p>
+        </p:txBody>
+      </p:sp>
+      <p:sp>
+        <p:nvSpPr>
+          <p:cNvPr id="6" name="TextBox 5"/>
+          <p:cNvSpPr txBox="1"/>
+          <p:nvPr/>
+        </p:nvSpPr>
+        <p:spPr>
+          <a:xfrm>
+            <a:off x="411480" y="3520440"/>
+            <a:ext cx="5486400" cy="2743200"/>
+          </a:xfrm>
+          <a:prstGeom prst="rect">
+            <a:avLst/>
+          </a:prstGeom>
+          <a:noFill/>
+        </p:spPr>
+        <p:txBody>
+          <a:bodyPr wrap="square" lIns="0" rIns="0">
+            <a:spAutoFit/>
+          </a:bodyPr>
+          <a:lstStyle/>
+          <a:p>
+            <a:pPr algn="l">
+              <a:spcAft>
+                <a:spcPts val="800"/>
+              </a:spcAft>
+            </a:pPr>
+            <a:r>
+              <a:rPr sz="1300" b="1" i="0">
+                <a:solidFill>
+                  <a:srgbClr val="00B2C9"/>
+                </a:solidFill>
+                <a:latin typeface="Encode Sans"/>
+              </a:rPr>
+              <a:t>●  </a:t>
+            </a:r>
+            <a:r>
+              <a:rPr sz="1300" b="0" i="0">
+                <a:solidFill>
+                  <a:srgbClr val="3F3F3F"/>
+                </a:solidFill>
+                <a:latin typeface="Encode Sans"/>
+              </a:rPr>
+              <a:t>rec: 463.072,00</a:t>
+            </a:r>
+          </a:p>
+          <a:p>
+            <a:pPr algn="l">
+              <a:spcAft>
+                <a:spcPts val="800"/>
+              </a:spcAft>
+            </a:pPr>
+            <a:r>
+              <a:rPr sz="1300" b="1" i="0">
+                <a:solidFill>
+                  <a:srgbClr val="00B2C9"/>
+                </a:solidFill>
+                <a:latin typeface="Encode Sans"/>
+              </a:rPr>
+              <a:t>●  </a:t>
+            </a:r>
+            <a:r>
+              <a:rPr sz="1300" b="0" i="0">
+                <a:solidFill>
+                  <a:srgbClr val="3F3F3F"/>
+                </a:solidFill>
+                <a:latin typeface="Encode Sans"/>
+              </a:rPr>
+              <a:t>em: 764.757,00</a:t>
+            </a:r>
+          </a:p>
+          <a:p>
+            <a:pPr algn="l">
+              <a:spcAft>
+                <a:spcPts val="800"/>
+              </a:spcAft>
+            </a:pPr>
+            <a:r>
+              <a:rPr sz="1300" b="1" i="0">
+                <a:solidFill>
+                  <a:srgbClr val="00B2C9"/>
+                </a:solidFill>
+                <a:latin typeface="Encode Sans"/>
+              </a:rPr>
+              <a:t>●  </a:t>
+            </a:r>
+            <a:r>
+              <a:rPr sz="1300" b="0" i="0">
+                <a:solidFill>
+                  <a:srgbClr val="3F3F3F"/>
+                </a:solidFill>
+                <a:latin typeface="Encode Sans"/>
+              </a:rPr>
+              <a:t>sal: -301.685,00</a:t>
+            </a:r>
+          </a:p>
+        </p:txBody>
+      </p:sp>
+      <p:sp>
+        <p:nvSpPr>
+          <p:cNvPr id="7" name="TextBox 6"/>
+          <p:cNvSpPr txBox="1"/>
+          <p:nvPr/>
+        </p:nvSpPr>
+        <p:spPr>
+          <a:xfrm>
+            <a:off x="411480" y="6492240"/>
+            <a:ext cx="11368735" cy="274320"/>
+          </a:xfrm>
+          <a:prstGeom prst="rect">
+            <a:avLst/>
+          </a:prstGeom>
+          <a:noFill/>
+        </p:spPr>
+        <p:txBody>
+          <a:bodyPr wrap="none">
+            <a:spAutoFit/>
+          </a:bodyPr>
+          <a:lstStyle/>
+          <a:p>
+            <a:r>
+              <a:rPr sz="1000" b="0" i="1">
+                <a:solidFill>
+                  <a:srgbClr val="6A6760"/>
+                </a:solidFill>
+                <a:latin typeface="Encode Sans"/>
+              </a:rPr>
+              <a:t>Fuente: elaboración propia en base a INDEC</a:t>
+            </a:r>
+          </a:p>
+        </p:txBody>
+      </p:sp>
+    </p:spTree>
+  </p:cSld>
+  <p:clrMapOvr>
+    <a:masterClrMapping/>
+  </p:clrMapOvr>
+</p:sld>
+</file>
+
 <file path=ppt/theme/theme1.xml><?xml version="1.0" encoding="utf-8"?>
 <a:theme xmlns:a="http://schemas.openxmlformats.org/drawingml/2006/main" name="Office Theme">
   <a:themeElements>

</xml_diff>

<commit_message>
data: update 2026-05-29 ( data.json despidos.json scraper/historical_despidos.json publicaciones_semana.pptx)
</commit_message>
<xml_diff>
--- a/publicaciones_semana.pptx
+++ b/publicaciones_semana.pptx
@@ -7,8 +7,6 @@
   <p:sldIdLst>
     <p:sldId id="256" r:id="rId7"/>
     <p:sldId id="257" r:id="rId8"/>
-    <p:sldId id="258" r:id="rId9"/>
-    <p:sldId id="259" r:id="rId10"/>
   </p:sldIdLst>
   <p:sldSz cx="12191695" cy="6858000" type="screen4x3"/>
   <p:notesSz cx="6858000" cy="9144000"/>
@@ -3274,7 +3272,7 @@
                 </a:solidFill>
                 <a:latin typeface="Encode Sans"/>
               </a:rPr>
-              <a:t>3 publicaciones · datos oficiales INDEC / BCRA / Hacienda</a:t>
+              <a:t>1 publicaciones · datos oficiales INDEC / BCRA / Hacienda</a:t>
             </a:r>
           </a:p>
         </p:txBody>
@@ -3288,2020 +3286,6 @@
 </file>
 
 <file path=ppt/slides/slide2.xml><?xml version="1.0" encoding="utf-8"?>
-<p:sld xmlns:a="http://schemas.openxmlformats.org/drawingml/2006/main" xmlns:p="http://schemas.openxmlformats.org/presentationml/2006/main" xmlns:r="http://schemas.openxmlformats.org/officeDocument/2006/relationships">
-  <p:cSld>
-    <p:spTree>
-      <p:nvGrpSpPr>
-        <p:cNvPr id="1" name=""/>
-        <p:cNvGrpSpPr/>
-        <p:nvPr/>
-      </p:nvGrpSpPr>
-      <p:grpSpPr/>
-      <p:sp>
-        <p:nvSpPr>
-          <p:cNvPr id="2" name="Rectangle 1"/>
-          <p:cNvSpPr/>
-          <p:nvPr/>
-        </p:nvSpPr>
-        <p:spPr>
-          <a:xfrm>
-            <a:off x="0" y="0"/>
-            <a:ext cx="12191695" cy="274320"/>
-          </a:xfrm>
-          <a:prstGeom prst="rect">
-            <a:avLst/>
-          </a:prstGeom>
-          <a:solidFill>
-            <a:srgbClr val="00B2C9"/>
-          </a:solidFill>
-          <a:ln>
-            <a:noFill/>
-          </a:ln>
-        </p:spPr>
-        <p:style>
-          <a:lnRef idx="1">
-            <a:schemeClr val="accent1"/>
-          </a:lnRef>
-          <a:fillRef idx="3">
-            <a:schemeClr val="accent1"/>
-          </a:fillRef>
-          <a:effectRef idx="2">
-            <a:schemeClr val="accent1"/>
-          </a:effectRef>
-          <a:fontRef idx="minor">
-            <a:schemeClr val="lt1"/>
-          </a:fontRef>
-        </p:style>
-        <p:txBody>
-          <a:bodyPr rtlCol="0" anchor="ctr"/>
-          <a:lstStyle/>
-          <a:p>
-            <a:pPr algn="ctr"/>
-          </a:p>
-        </p:txBody>
-      </p:sp>
-      <p:sp>
-        <p:nvSpPr>
-          <p:cNvPr id="3" name="TextBox 2"/>
-          <p:cNvSpPr txBox="1"/>
-          <p:nvPr/>
-        </p:nvSpPr>
-        <p:spPr>
-          <a:xfrm>
-            <a:off x="411480" y="457200"/>
-            <a:ext cx="11368735" cy="914400"/>
-          </a:xfrm>
-          <a:prstGeom prst="rect">
-            <a:avLst/>
-          </a:prstGeom>
-          <a:noFill/>
-        </p:spPr>
-        <p:txBody>
-          <a:bodyPr wrap="square" lIns="0" rIns="0">
-            <a:spAutoFit/>
-          </a:bodyPr>
-          <a:lstStyle/>
-          <a:p>
-            <a:pPr algn="l"/>
-            <a:r>
-              <a:rPr sz="2600" b="1" i="0">
-                <a:solidFill>
-                  <a:srgbClr val="00B2C9"/>
-                </a:solidFill>
-                <a:latin typeface="Encode Sans"/>
-              </a:rPr>
-              <a:t>EMAE MARZO 2026: ACTIVIDAD CRECIÓ +5.5% I.A.</a:t>
-            </a:r>
-          </a:p>
-        </p:txBody>
-      </p:sp>
-      <p:sp>
-        <p:nvSpPr>
-          <p:cNvPr id="4" name="TextBox 3"/>
-          <p:cNvSpPr txBox="1"/>
-          <p:nvPr/>
-        </p:nvSpPr>
-        <p:spPr>
-          <a:xfrm>
-            <a:off x="411480" y="1280160"/>
-            <a:ext cx="11368735" cy="274320"/>
-          </a:xfrm>
-          <a:prstGeom prst="rect">
-            <a:avLst/>
-          </a:prstGeom>
-          <a:noFill/>
-        </p:spPr>
-        <p:txBody>
-          <a:bodyPr wrap="none">
-            <a:spAutoFit/>
-          </a:bodyPr>
-          <a:lstStyle/>
-          <a:p>
-            <a:r>
-              <a:rPr sz="1100" b="0" i="1">
-                <a:solidFill>
-                  <a:srgbClr val="6A6760"/>
-                </a:solidFill>
-                <a:latin typeface="Encode Sans"/>
-              </a:rPr>
-              <a:t>INDEC · período 2026-03</a:t>
-            </a:r>
-          </a:p>
-        </p:txBody>
-      </p:sp>
-      <p:sp>
-        <p:nvSpPr>
-          <p:cNvPr id="5" name="TextBox 4"/>
-          <p:cNvSpPr txBox="1"/>
-          <p:nvPr/>
-        </p:nvSpPr>
-        <p:spPr>
-          <a:xfrm>
-            <a:off x="411480" y="1691640"/>
-            <a:ext cx="5486400" cy="1645920"/>
-          </a:xfrm>
-          <a:prstGeom prst="rect">
-            <a:avLst/>
-          </a:prstGeom>
-          <a:noFill/>
-        </p:spPr>
-        <p:txBody>
-          <a:bodyPr wrap="square" lIns="0" rIns="0">
-            <a:spAutoFit/>
-          </a:bodyPr>
-          <a:lstStyle/>
-          <a:p>
-            <a:pPr algn="just"/>
-            <a:r>
-              <a:rPr sz="1300" b="0" i="0">
-                <a:solidFill>
-                  <a:srgbClr val="3F3F3F"/>
-                </a:solidFill>
-                <a:latin typeface="Encode Sans"/>
-              </a:rPr>
-              <a:t>El Estimador Mensual de Actividad Económica (EMAE) registró una variación interanual de +5.5% en marzo 2026. En la medición desestacionalizada, el indicador se movió +3.5% respecto al mes anterior.</a:t>
-            </a:r>
-          </a:p>
-        </p:txBody>
-      </p:sp>
-      <p:sp>
-        <p:nvSpPr>
-          <p:cNvPr id="6" name="TextBox 5"/>
-          <p:cNvSpPr txBox="1"/>
-          <p:nvPr/>
-        </p:nvSpPr>
-        <p:spPr>
-          <a:xfrm>
-            <a:off x="411480" y="3520440"/>
-            <a:ext cx="5486400" cy="2743200"/>
-          </a:xfrm>
-          <a:prstGeom prst="rect">
-            <a:avLst/>
-          </a:prstGeom>
-          <a:noFill/>
-        </p:spPr>
-        <p:txBody>
-          <a:bodyPr wrap="square" lIns="0" rIns="0">
-            <a:spAutoFit/>
-          </a:bodyPr>
-          <a:lstStyle/>
-          <a:p>
-            <a:pPr algn="l">
-              <a:spcAft>
-                <a:spcPts val="800"/>
-              </a:spcAft>
-            </a:pPr>
-            <a:r>
-              <a:rPr sz="1300" b="1" i="0">
-                <a:solidFill>
-                  <a:srgbClr val="00B2C9"/>
-                </a:solidFill>
-                <a:latin typeface="Encode Sans"/>
-              </a:rPr>
-              <a:t>●  </a:t>
-            </a:r>
-            <a:r>
-              <a:rPr sz="1300" b="0" i="0">
-                <a:solidFill>
-                  <a:srgbClr val="3F3F3F"/>
-                </a:solidFill>
-                <a:latin typeface="Encode Sans"/>
-              </a:rPr>
-              <a:t>Variación interanual: +5.5%</a:t>
-            </a:r>
-          </a:p>
-          <a:p>
-            <a:pPr algn="l">
-              <a:spcAft>
-                <a:spcPts val="800"/>
-              </a:spcAft>
-            </a:pPr>
-            <a:r>
-              <a:rPr sz="1300" b="1" i="0">
-                <a:solidFill>
-                  <a:srgbClr val="00B2C9"/>
-                </a:solidFill>
-                <a:latin typeface="Encode Sans"/>
-              </a:rPr>
-              <a:t>●  </a:t>
-            </a:r>
-            <a:r>
-              <a:rPr sz="1300" b="0" i="0">
-                <a:solidFill>
-                  <a:srgbClr val="3F3F3F"/>
-                </a:solidFill>
-                <a:latin typeface="Encode Sans"/>
-              </a:rPr>
-              <a:t>Variación mensual desestacionalizada: +3.5%</a:t>
-            </a:r>
-          </a:p>
-          <a:p>
-            <a:pPr algn="l">
-              <a:spcAft>
-                <a:spcPts val="800"/>
-              </a:spcAft>
-            </a:pPr>
-            <a:r>
-              <a:rPr sz="1300" b="1" i="0">
-                <a:solidFill>
-                  <a:srgbClr val="00B2C9"/>
-                </a:solidFill>
-                <a:latin typeface="Encode Sans"/>
-              </a:rPr>
-              <a:t>●  </a:t>
-            </a:r>
-            <a:r>
-              <a:rPr sz="1300" b="0" i="0">
-                <a:solidFill>
-                  <a:srgbClr val="3F3F3F"/>
-                </a:solidFill>
-                <a:latin typeface="Encode Sans"/>
-              </a:rPr>
-              <a:t>Serie INDEC, base 2004=100. Mide el nivel general de actividad.</a:t>
-            </a:r>
-          </a:p>
-        </p:txBody>
-      </p:sp>
-      <p:pic>
-        <p:nvPicPr>
-          <p:cNvPr id="7" name="Picture 6" descr="image.png"/>
-          <p:cNvPicPr>
-            <a:picLocks noChangeAspect="1"/>
-          </p:cNvPicPr>
-          <p:nvPr/>
-        </p:nvPicPr>
-        <p:blipFill>
-          <a:blip r:embed="rId2"/>
-          <a:stretch>
-            <a:fillRect/>
-          </a:stretch>
-        </p:blipFill>
-        <p:spPr>
-          <a:xfrm>
-            <a:off x="6080760" y="1691640"/>
-            <a:ext cx="5669280" cy="2560320"/>
-          </a:xfrm>
-          <a:prstGeom prst="rect">
-            <a:avLst/>
-          </a:prstGeom>
-        </p:spPr>
-      </p:pic>
-      <p:graphicFrame>
-        <p:nvGraphicFramePr>
-          <p:cNvPr id="8" name="Table 7"/>
-          <p:cNvGraphicFramePr>
-            <a:graphicFrameLocks noGrp="1"/>
-          </p:cNvGraphicFramePr>
-          <p:nvPr/>
-        </p:nvGraphicFramePr>
-        <p:xfrm>
-          <a:off x="6080760" y="4434840"/>
-          <a:ext cx="5669280" cy="2048256"/>
-        </p:xfrm>
-        <a:graphic>
-          <a:graphicData uri="http://schemas.openxmlformats.org/drawingml/2006/table">
-            <a:tbl>
-              <a:tblPr firstRow="1" bandRow="1">
-                <a:tableStyleId>{5C22544A-7EE6-4342-B048-85BDC9FD1C3A}</a:tableStyleId>
-              </a:tblPr>
-              <a:tblGrid>
-                <a:gridCol w="1417320"/>
-                <a:gridCol w="1417320"/>
-                <a:gridCol w="1417320"/>
-                <a:gridCol w="1417320"/>
-              </a:tblGrid>
-              <a:tr h="292608">
-                <a:tc>
-                  <a:txBody>
-                    <a:bodyPr/>
-                    <a:lstStyle/>
-                    <a:p>
-                      <a:pPr algn="l"/>
-                      <a:r>
-                        <a:rPr sz="1000" b="1">
-                          <a:solidFill>
-                            <a:srgbClr val="FFFFFF"/>
-                          </a:solidFill>
-                          <a:latin typeface="Encode Sans"/>
-                        </a:rPr>
-                        <a:t>Mes</a:t>
-                      </a:r>
-                    </a:p>
-                  </a:txBody>
-                  <a:tcPr marL="36576" marR="36576" marT="18288" marB="18288">
-                    <a:solidFill>
-                      <a:srgbClr val="00B2C9"/>
-                    </a:solidFill>
-                  </a:tcPr>
-                </a:tc>
-                <a:tc>
-                  <a:txBody>
-                    <a:bodyPr/>
-                    <a:lstStyle/>
-                    <a:p>
-                      <a:pPr algn="r"/>
-                      <a:r>
-                        <a:rPr sz="1000" b="1">
-                          <a:solidFill>
-                            <a:srgbClr val="FFFFFF"/>
-                          </a:solidFill>
-                          <a:latin typeface="Encode Sans"/>
-                        </a:rPr>
-                        <a:t>Original</a:t>
-                      </a:r>
-                    </a:p>
-                  </a:txBody>
-                  <a:tcPr marL="36576" marR="36576" marT="18288" marB="18288">
-                    <a:solidFill>
-                      <a:srgbClr val="00B2C9"/>
-                    </a:solidFill>
-                  </a:tcPr>
-                </a:tc>
-                <a:tc>
-                  <a:txBody>
-                    <a:bodyPr/>
-                    <a:lstStyle/>
-                    <a:p>
-                      <a:pPr algn="r"/>
-                      <a:r>
-                        <a:rPr sz="1000" b="1">
-                          <a:solidFill>
-                            <a:srgbClr val="FFFFFF"/>
-                          </a:solidFill>
-                          <a:latin typeface="Encode Sans"/>
-                        </a:rPr>
-                        <a:t>VIA %</a:t>
-                      </a:r>
-                    </a:p>
-                  </a:txBody>
-                  <a:tcPr marL="36576" marR="36576" marT="18288" marB="18288">
-                    <a:solidFill>
-                      <a:srgbClr val="00B2C9"/>
-                    </a:solidFill>
-                  </a:tcPr>
-                </a:tc>
-                <a:tc>
-                  <a:txBody>
-                    <a:bodyPr/>
-                    <a:lstStyle/>
-                    <a:p>
-                      <a:pPr algn="r"/>
-                      <a:r>
-                        <a:rPr sz="1000" b="1">
-                          <a:solidFill>
-                            <a:srgbClr val="FFFFFF"/>
-                          </a:solidFill>
-                          <a:latin typeface="Encode Sans"/>
-                        </a:rPr>
-                        <a:t>Desest.</a:t>
-                      </a:r>
-                    </a:p>
-                  </a:txBody>
-                  <a:tcPr marL="36576" marR="36576" marT="18288" marB="18288">
-                    <a:solidFill>
-                      <a:srgbClr val="00B2C9"/>
-                    </a:solidFill>
-                  </a:tcPr>
-                </a:tc>
-              </a:tr>
-              <a:tr h="292608">
-                <a:tc>
-                  <a:txBody>
-                    <a:bodyPr/>
-                    <a:lstStyle/>
-                    <a:p>
-                      <a:pPr algn="l"/>
-                      <a:r>
-                        <a:rPr sz="1000">
-                          <a:solidFill>
-                            <a:srgbClr val="3F3F3F"/>
-                          </a:solidFill>
-                          <a:latin typeface="Encode Sans"/>
-                        </a:rPr>
-                        <a:t>Marzo 2026</a:t>
-                      </a:r>
-                    </a:p>
-                  </a:txBody>
-                  <a:tcPr marL="36576" marR="36576" marT="18288" marB="18288">
-                    <a:solidFill>
-                      <a:srgbClr val="FFFFFF"/>
-                    </a:solidFill>
-                  </a:tcPr>
-                </a:tc>
-                <a:tc>
-                  <a:txBody>
-                    <a:bodyPr/>
-                    <a:lstStyle/>
-                    <a:p>
-                      <a:pPr algn="r"/>
-                      <a:r>
-                        <a:rPr sz="1000">
-                          <a:solidFill>
-                            <a:srgbClr val="3F3F3F"/>
-                          </a:solidFill>
-                          <a:latin typeface="Encode Sans"/>
-                        </a:rPr>
-                        <a:t>158,7</a:t>
-                      </a:r>
-                    </a:p>
-                  </a:txBody>
-                  <a:tcPr marL="36576" marR="36576" marT="18288" marB="18288">
-                    <a:solidFill>
-                      <a:srgbClr val="FFFFFF"/>
-                    </a:solidFill>
-                  </a:tcPr>
-                </a:tc>
-                <a:tc>
-                  <a:txBody>
-                    <a:bodyPr/>
-                    <a:lstStyle/>
-                    <a:p>
-                      <a:pPr algn="r"/>
-                      <a:r>
-                        <a:rPr sz="1000">
-                          <a:solidFill>
-                            <a:srgbClr val="3F3F3F"/>
-                          </a:solidFill>
-                          <a:latin typeface="Encode Sans"/>
-                        </a:rPr>
-                        <a:t>+5.5%</a:t>
-                      </a:r>
-                    </a:p>
-                  </a:txBody>
-                  <a:tcPr marL="36576" marR="36576" marT="18288" marB="18288">
-                    <a:solidFill>
-                      <a:srgbClr val="FFFFFF"/>
-                    </a:solidFill>
-                  </a:tcPr>
-                </a:tc>
-                <a:tc>
-                  <a:txBody>
-                    <a:bodyPr/>
-                    <a:lstStyle/>
-                    <a:p>
-                      <a:pPr algn="r"/>
-                      <a:r>
-                        <a:rPr sz="1000">
-                          <a:solidFill>
-                            <a:srgbClr val="3F3F3F"/>
-                          </a:solidFill>
-                          <a:latin typeface="Encode Sans"/>
-                        </a:rPr>
-                        <a:t>156,3</a:t>
-                      </a:r>
-                    </a:p>
-                  </a:txBody>
-                  <a:tcPr marL="36576" marR="36576" marT="18288" marB="18288">
-                    <a:solidFill>
-                      <a:srgbClr val="FFFFFF"/>
-                    </a:solidFill>
-                  </a:tcPr>
-                </a:tc>
-              </a:tr>
-              <a:tr h="292608">
-                <a:tc>
-                  <a:txBody>
-                    <a:bodyPr/>
-                    <a:lstStyle/>
-                    <a:p>
-                      <a:pPr algn="l"/>
-                      <a:r>
-                        <a:rPr sz="1000">
-                          <a:solidFill>
-                            <a:srgbClr val="3F3F3F"/>
-                          </a:solidFill>
-                          <a:latin typeface="Encode Sans"/>
-                        </a:rPr>
-                        <a:t>Febrero 2026</a:t>
-                      </a:r>
-                    </a:p>
-                  </a:txBody>
-                  <a:tcPr marL="36576" marR="36576" marT="18288" marB="18288">
-                    <a:solidFill>
-                      <a:srgbClr val="F8F8F6"/>
-                    </a:solidFill>
-                  </a:tcPr>
-                </a:tc>
-                <a:tc>
-                  <a:txBody>
-                    <a:bodyPr/>
-                    <a:lstStyle/>
-                    <a:p>
-                      <a:pPr algn="r"/>
-                      <a:r>
-                        <a:rPr sz="1000">
-                          <a:solidFill>
-                            <a:srgbClr val="3F3F3F"/>
-                          </a:solidFill>
-                          <a:latin typeface="Encode Sans"/>
-                        </a:rPr>
-                        <a:t>138,3</a:t>
-                      </a:r>
-                    </a:p>
-                  </a:txBody>
-                  <a:tcPr marL="36576" marR="36576" marT="18288" marB="18288">
-                    <a:solidFill>
-                      <a:srgbClr val="F8F8F6"/>
-                    </a:solidFill>
-                  </a:tcPr>
-                </a:tc>
-                <a:tc>
-                  <a:txBody>
-                    <a:bodyPr/>
-                    <a:lstStyle/>
-                    <a:p>
-                      <a:pPr algn="r"/>
-                      <a:r>
-                        <a:rPr sz="1000">
-                          <a:solidFill>
-                            <a:srgbClr val="3F3F3F"/>
-                          </a:solidFill>
-                          <a:latin typeface="Encode Sans"/>
-                        </a:rPr>
-                        <a:t>-2.0%</a:t>
-                      </a:r>
-                    </a:p>
-                  </a:txBody>
-                  <a:tcPr marL="36576" marR="36576" marT="18288" marB="18288">
-                    <a:solidFill>
-                      <a:srgbClr val="F8F8F6"/>
-                    </a:solidFill>
-                  </a:tcPr>
-                </a:tc>
-                <a:tc>
-                  <a:txBody>
-                    <a:bodyPr/>
-                    <a:lstStyle/>
-                    <a:p>
-                      <a:pPr algn="r"/>
-                      <a:r>
-                        <a:rPr sz="1000">
-                          <a:solidFill>
-                            <a:srgbClr val="3F3F3F"/>
-                          </a:solidFill>
-                          <a:latin typeface="Encode Sans"/>
-                        </a:rPr>
-                        <a:t>151,0</a:t>
-                      </a:r>
-                    </a:p>
-                  </a:txBody>
-                  <a:tcPr marL="36576" marR="36576" marT="18288" marB="18288">
-                    <a:solidFill>
-                      <a:srgbClr val="F8F8F6"/>
-                    </a:solidFill>
-                  </a:tcPr>
-                </a:tc>
-              </a:tr>
-              <a:tr h="292608">
-                <a:tc>
-                  <a:txBody>
-                    <a:bodyPr/>
-                    <a:lstStyle/>
-                    <a:p>
-                      <a:pPr algn="l"/>
-                      <a:r>
-                        <a:rPr sz="1000">
-                          <a:solidFill>
-                            <a:srgbClr val="3F3F3F"/>
-                          </a:solidFill>
-                          <a:latin typeface="Encode Sans"/>
-                        </a:rPr>
-                        <a:t>Enero 2026</a:t>
-                      </a:r>
-                    </a:p>
-                  </a:txBody>
-                  <a:tcPr marL="36576" marR="36576" marT="18288" marB="18288">
-                    <a:solidFill>
-                      <a:srgbClr val="FFFFFF"/>
-                    </a:solidFill>
-                  </a:tcPr>
-                </a:tc>
-                <a:tc>
-                  <a:txBody>
-                    <a:bodyPr/>
-                    <a:lstStyle/>
-                    <a:p>
-                      <a:pPr algn="r"/>
-                      <a:r>
-                        <a:rPr sz="1000">
-                          <a:solidFill>
-                            <a:srgbClr val="3F3F3F"/>
-                          </a:solidFill>
-                          <a:latin typeface="Encode Sans"/>
-                        </a:rPr>
-                        <a:t>148,6</a:t>
-                      </a:r>
-                    </a:p>
-                  </a:txBody>
-                  <a:tcPr marL="36576" marR="36576" marT="18288" marB="18288">
-                    <a:solidFill>
-                      <a:srgbClr val="FFFFFF"/>
-                    </a:solidFill>
-                  </a:tcPr>
-                </a:tc>
-                <a:tc>
-                  <a:txBody>
-                    <a:bodyPr/>
-                    <a:lstStyle/>
-                    <a:p>
-                      <a:pPr algn="r"/>
-                      <a:r>
-                        <a:rPr sz="1000">
-                          <a:solidFill>
-                            <a:srgbClr val="3F3F3F"/>
-                          </a:solidFill>
-                          <a:latin typeface="Encode Sans"/>
-                        </a:rPr>
-                        <a:t>+1.5%</a:t>
-                      </a:r>
-                    </a:p>
-                  </a:txBody>
-                  <a:tcPr marL="36576" marR="36576" marT="18288" marB="18288">
-                    <a:solidFill>
-                      <a:srgbClr val="FFFFFF"/>
-                    </a:solidFill>
-                  </a:tcPr>
-                </a:tc>
-                <a:tc>
-                  <a:txBody>
-                    <a:bodyPr/>
-                    <a:lstStyle/>
-                    <a:p>
-                      <a:pPr algn="r"/>
-                      <a:r>
-                        <a:rPr sz="1000">
-                          <a:solidFill>
-                            <a:srgbClr val="3F3F3F"/>
-                          </a:solidFill>
-                          <a:latin typeface="Encode Sans"/>
-                        </a:rPr>
-                        <a:t>155,2</a:t>
-                      </a:r>
-                    </a:p>
-                  </a:txBody>
-                  <a:tcPr marL="36576" marR="36576" marT="18288" marB="18288">
-                    <a:solidFill>
-                      <a:srgbClr val="FFFFFF"/>
-                    </a:solidFill>
-                  </a:tcPr>
-                </a:tc>
-              </a:tr>
-              <a:tr h="292608">
-                <a:tc>
-                  <a:txBody>
-                    <a:bodyPr/>
-                    <a:lstStyle/>
-                    <a:p>
-                      <a:pPr algn="l"/>
-                      <a:r>
-                        <a:rPr sz="1000">
-                          <a:solidFill>
-                            <a:srgbClr val="3F3F3F"/>
-                          </a:solidFill>
-                          <a:latin typeface="Encode Sans"/>
-                        </a:rPr>
-                        <a:t>Diciembre 2025</a:t>
-                      </a:r>
-                    </a:p>
-                  </a:txBody>
-                  <a:tcPr marL="36576" marR="36576" marT="18288" marB="18288">
-                    <a:solidFill>
-                      <a:srgbClr val="F8F8F6"/>
-                    </a:solidFill>
-                  </a:tcPr>
-                </a:tc>
-                <a:tc>
-                  <a:txBody>
-                    <a:bodyPr/>
-                    <a:lstStyle/>
-                    <a:p>
-                      <a:pPr algn="r"/>
-                      <a:r>
-                        <a:rPr sz="1000">
-                          <a:solidFill>
-                            <a:srgbClr val="3F3F3F"/>
-                          </a:solidFill>
-                          <a:latin typeface="Encode Sans"/>
-                        </a:rPr>
-                        <a:t>153,5</a:t>
-                      </a:r>
-                    </a:p>
-                  </a:txBody>
-                  <a:tcPr marL="36576" marR="36576" marT="18288" marB="18288">
-                    <a:solidFill>
-                      <a:srgbClr val="F8F8F6"/>
-                    </a:solidFill>
-                  </a:tcPr>
-                </a:tc>
-                <a:tc>
-                  <a:txBody>
-                    <a:bodyPr/>
-                    <a:lstStyle/>
-                    <a:p>
-                      <a:pPr algn="r"/>
-                      <a:r>
-                        <a:rPr sz="1000">
-                          <a:solidFill>
-                            <a:srgbClr val="3F3F3F"/>
-                          </a:solidFill>
-                          <a:latin typeface="Encode Sans"/>
-                        </a:rPr>
-                        <a:t>+3.3%</a:t>
-                      </a:r>
-                    </a:p>
-                  </a:txBody>
-                  <a:tcPr marL="36576" marR="36576" marT="18288" marB="18288">
-                    <a:solidFill>
-                      <a:srgbClr val="F8F8F6"/>
-                    </a:solidFill>
-                  </a:tcPr>
-                </a:tc>
-                <a:tc>
-                  <a:txBody>
-                    <a:bodyPr/>
-                    <a:lstStyle/>
-                    <a:p>
-                      <a:pPr algn="r"/>
-                      <a:r>
-                        <a:rPr sz="1000">
-                          <a:solidFill>
-                            <a:srgbClr val="3F3F3F"/>
-                          </a:solidFill>
-                          <a:latin typeface="Encode Sans"/>
-                        </a:rPr>
-                        <a:t>155,5</a:t>
-                      </a:r>
-                    </a:p>
-                  </a:txBody>
-                  <a:tcPr marL="36576" marR="36576" marT="18288" marB="18288">
-                    <a:solidFill>
-                      <a:srgbClr val="F8F8F6"/>
-                    </a:solidFill>
-                  </a:tcPr>
-                </a:tc>
-              </a:tr>
-              <a:tr h="292608">
-                <a:tc>
-                  <a:txBody>
-                    <a:bodyPr/>
-                    <a:lstStyle/>
-                    <a:p>
-                      <a:pPr algn="l"/>
-                      <a:r>
-                        <a:rPr sz="1000">
-                          <a:solidFill>
-                            <a:srgbClr val="3F3F3F"/>
-                          </a:solidFill>
-                          <a:latin typeface="Encode Sans"/>
-                        </a:rPr>
-                        <a:t>Noviembre 2025</a:t>
-                      </a:r>
-                    </a:p>
-                  </a:txBody>
-                  <a:tcPr marL="36576" marR="36576" marT="18288" marB="18288">
-                    <a:solidFill>
-                      <a:srgbClr val="FFFFFF"/>
-                    </a:solidFill>
-                  </a:tcPr>
-                </a:tc>
-                <a:tc>
-                  <a:txBody>
-                    <a:bodyPr/>
-                    <a:lstStyle/>
-                    <a:p>
-                      <a:pPr algn="r"/>
-                      <a:r>
-                        <a:rPr sz="1000">
-                          <a:solidFill>
-                            <a:srgbClr val="3F3F3F"/>
-                          </a:solidFill>
-                          <a:latin typeface="Encode Sans"/>
-                        </a:rPr>
-                        <a:t>147,7</a:t>
-                      </a:r>
-                    </a:p>
-                  </a:txBody>
-                  <a:tcPr marL="36576" marR="36576" marT="18288" marB="18288">
-                    <a:solidFill>
-                      <a:srgbClr val="FFFFFF"/>
-                    </a:solidFill>
-                  </a:tcPr>
-                </a:tc>
-                <a:tc>
-                  <a:txBody>
-                    <a:bodyPr/>
-                    <a:lstStyle/>
-                    <a:p>
-                      <a:pPr algn="r"/>
-                      <a:r>
-                        <a:rPr sz="1000">
-                          <a:solidFill>
-                            <a:srgbClr val="3F3F3F"/>
-                          </a:solidFill>
-                          <a:latin typeface="Encode Sans"/>
-                        </a:rPr>
-                        <a:t>-0.2%</a:t>
-                      </a:r>
-                    </a:p>
-                  </a:txBody>
-                  <a:tcPr marL="36576" marR="36576" marT="18288" marB="18288">
-                    <a:solidFill>
-                      <a:srgbClr val="FFFFFF"/>
-                    </a:solidFill>
-                  </a:tcPr>
-                </a:tc>
-                <a:tc>
-                  <a:txBody>
-                    <a:bodyPr/>
-                    <a:lstStyle/>
-                    <a:p>
-                      <a:pPr algn="r"/>
-                      <a:r>
-                        <a:rPr sz="1000">
-                          <a:solidFill>
-                            <a:srgbClr val="3F3F3F"/>
-                          </a:solidFill>
-                          <a:latin typeface="Encode Sans"/>
-                        </a:rPr>
-                        <a:t>152,7</a:t>
-                      </a:r>
-                    </a:p>
-                  </a:txBody>
-                  <a:tcPr marL="36576" marR="36576" marT="18288" marB="18288">
-                    <a:solidFill>
-                      <a:srgbClr val="FFFFFF"/>
-                    </a:solidFill>
-                  </a:tcPr>
-                </a:tc>
-              </a:tr>
-              <a:tr h="292608">
-                <a:tc>
-                  <a:txBody>
-                    <a:bodyPr/>
-                    <a:lstStyle/>
-                    <a:p>
-                      <a:pPr algn="l"/>
-                      <a:r>
-                        <a:rPr sz="1000">
-                          <a:solidFill>
-                            <a:srgbClr val="3F3F3F"/>
-                          </a:solidFill>
-                          <a:latin typeface="Encode Sans"/>
-                        </a:rPr>
-                        <a:t>Octubre 2025</a:t>
-                      </a:r>
-                    </a:p>
-                  </a:txBody>
-                  <a:tcPr marL="36576" marR="36576" marT="18288" marB="18288">
-                    <a:solidFill>
-                      <a:srgbClr val="F8F8F6"/>
-                    </a:solidFill>
-                  </a:tcPr>
-                </a:tc>
-                <a:tc>
-                  <a:txBody>
-                    <a:bodyPr/>
-                    <a:lstStyle/>
-                    <a:p>
-                      <a:pPr algn="r"/>
-                      <a:r>
-                        <a:rPr sz="1000">
-                          <a:solidFill>
-                            <a:srgbClr val="3F3F3F"/>
-                          </a:solidFill>
-                          <a:latin typeface="Encode Sans"/>
-                        </a:rPr>
-                        <a:t>152,6</a:t>
-                      </a:r>
-                    </a:p>
-                  </a:txBody>
-                  <a:tcPr marL="36576" marR="36576" marT="18288" marB="18288">
-                    <a:solidFill>
-                      <a:srgbClr val="F8F8F6"/>
-                    </a:solidFill>
-                  </a:tcPr>
-                </a:tc>
-                <a:tc>
-                  <a:txBody>
-                    <a:bodyPr/>
-                    <a:lstStyle/>
-                    <a:p>
-                      <a:pPr algn="r"/>
-                      <a:r>
-                        <a:rPr sz="1000">
-                          <a:solidFill>
-                            <a:srgbClr val="3F3F3F"/>
-                          </a:solidFill>
-                          <a:latin typeface="Encode Sans"/>
-                        </a:rPr>
-                        <a:t>+3.1%</a:t>
-                      </a:r>
-                    </a:p>
-                  </a:txBody>
-                  <a:tcPr marL="36576" marR="36576" marT="18288" marB="18288">
-                    <a:solidFill>
-                      <a:srgbClr val="F8F8F6"/>
-                    </a:solidFill>
-                  </a:tcPr>
-                </a:tc>
-                <a:tc>
-                  <a:txBody>
-                    <a:bodyPr/>
-                    <a:lstStyle/>
-                    <a:p>
-                      <a:pPr algn="r"/>
-                      <a:r>
-                        <a:rPr sz="1000">
-                          <a:solidFill>
-                            <a:srgbClr val="3F3F3F"/>
-                          </a:solidFill>
-                          <a:latin typeface="Encode Sans"/>
-                        </a:rPr>
-                        <a:t>152,7</a:t>
-                      </a:r>
-                    </a:p>
-                  </a:txBody>
-                  <a:tcPr marL="36576" marR="36576" marT="18288" marB="18288">
-                    <a:solidFill>
-                      <a:srgbClr val="F8F8F6"/>
-                    </a:solidFill>
-                  </a:tcPr>
-                </a:tc>
-              </a:tr>
-            </a:tbl>
-          </a:graphicData>
-        </a:graphic>
-      </p:graphicFrame>
-      <p:sp>
-        <p:nvSpPr>
-          <p:cNvPr id="9" name="TextBox 8"/>
-          <p:cNvSpPr txBox="1"/>
-          <p:nvPr/>
-        </p:nvSpPr>
-        <p:spPr>
-          <a:xfrm>
-            <a:off x="411480" y="6492240"/>
-            <a:ext cx="11368735" cy="274320"/>
-          </a:xfrm>
-          <a:prstGeom prst="rect">
-            <a:avLst/>
-          </a:prstGeom>
-          <a:noFill/>
-        </p:spPr>
-        <p:txBody>
-          <a:bodyPr wrap="none">
-            <a:spAutoFit/>
-          </a:bodyPr>
-          <a:lstStyle/>
-          <a:p>
-            <a:r>
-              <a:rPr sz="1000" b="0" i="1">
-                <a:solidFill>
-                  <a:srgbClr val="6A6760"/>
-                </a:solidFill>
-                <a:latin typeface="Encode Sans"/>
-              </a:rPr>
-              <a:t>Fuente: elaboración propia en base a INDEC</a:t>
-            </a:r>
-          </a:p>
-        </p:txBody>
-      </p:sp>
-    </p:spTree>
-  </p:cSld>
-  <p:clrMapOvr>
-    <a:masterClrMapping/>
-  </p:clrMapOvr>
-</p:sld>
-</file>
-
-<file path=ppt/slides/slide3.xml><?xml version="1.0" encoding="utf-8"?>
-<p:sld xmlns:a="http://schemas.openxmlformats.org/drawingml/2006/main" xmlns:p="http://schemas.openxmlformats.org/presentationml/2006/main" xmlns:r="http://schemas.openxmlformats.org/officeDocument/2006/relationships">
-  <p:cSld>
-    <p:spTree>
-      <p:nvGrpSpPr>
-        <p:cNvPr id="1" name=""/>
-        <p:cNvGrpSpPr/>
-        <p:nvPr/>
-      </p:nvGrpSpPr>
-      <p:grpSpPr/>
-      <p:sp>
-        <p:nvSpPr>
-          <p:cNvPr id="2" name="Rectangle 1"/>
-          <p:cNvSpPr/>
-          <p:nvPr/>
-        </p:nvSpPr>
-        <p:spPr>
-          <a:xfrm>
-            <a:off x="0" y="0"/>
-            <a:ext cx="12191695" cy="274320"/>
-          </a:xfrm>
-          <a:prstGeom prst="rect">
-            <a:avLst/>
-          </a:prstGeom>
-          <a:solidFill>
-            <a:srgbClr val="00B2C9"/>
-          </a:solidFill>
-          <a:ln>
-            <a:noFill/>
-          </a:ln>
-        </p:spPr>
-        <p:style>
-          <a:lnRef idx="1">
-            <a:schemeClr val="accent1"/>
-          </a:lnRef>
-          <a:fillRef idx="3">
-            <a:schemeClr val="accent1"/>
-          </a:fillRef>
-          <a:effectRef idx="2">
-            <a:schemeClr val="accent1"/>
-          </a:effectRef>
-          <a:fontRef idx="minor">
-            <a:schemeClr val="lt1"/>
-          </a:fontRef>
-        </p:style>
-        <p:txBody>
-          <a:bodyPr rtlCol="0" anchor="ctr"/>
-          <a:lstStyle/>
-          <a:p>
-            <a:pPr algn="ctr"/>
-          </a:p>
-        </p:txBody>
-      </p:sp>
-      <p:sp>
-        <p:nvSpPr>
-          <p:cNvPr id="3" name="TextBox 2"/>
-          <p:cNvSpPr txBox="1"/>
-          <p:nvPr/>
-        </p:nvSpPr>
-        <p:spPr>
-          <a:xfrm>
-            <a:off x="411480" y="457200"/>
-            <a:ext cx="11368735" cy="914400"/>
-          </a:xfrm>
-          <a:prstGeom prst="rect">
-            <a:avLst/>
-          </a:prstGeom>
-          <a:noFill/>
-        </p:spPr>
-        <p:txBody>
-          <a:bodyPr wrap="square" lIns="0" rIns="0">
-            <a:spAutoFit/>
-          </a:bodyPr>
-          <a:lstStyle/>
-          <a:p>
-            <a:pPr algn="l"/>
-            <a:r>
-              <a:rPr sz="2600" b="1" i="0">
-                <a:solidFill>
-                  <a:srgbClr val="00B2C9"/>
-                </a:solidFill>
-                <a:latin typeface="Encode Sans"/>
-              </a:rPr>
-              <a:t>SUPERMERCADOS MARZO 2026: VENTAS REALES CAYERON -5.1%</a:t>
-            </a:r>
-          </a:p>
-        </p:txBody>
-      </p:sp>
-      <p:sp>
-        <p:nvSpPr>
-          <p:cNvPr id="4" name="TextBox 3"/>
-          <p:cNvSpPr txBox="1"/>
-          <p:nvPr/>
-        </p:nvSpPr>
-        <p:spPr>
-          <a:xfrm>
-            <a:off x="411480" y="1280160"/>
-            <a:ext cx="11368735" cy="274320"/>
-          </a:xfrm>
-          <a:prstGeom prst="rect">
-            <a:avLst/>
-          </a:prstGeom>
-          <a:noFill/>
-        </p:spPr>
-        <p:txBody>
-          <a:bodyPr wrap="none">
-            <a:spAutoFit/>
-          </a:bodyPr>
-          <a:lstStyle/>
-          <a:p>
-            <a:r>
-              <a:rPr sz="1100" b="0" i="1">
-                <a:solidFill>
-                  <a:srgbClr val="6A6760"/>
-                </a:solidFill>
-                <a:latin typeface="Encode Sans"/>
-              </a:rPr>
-              <a:t>INDEC · período 2026-03</a:t>
-            </a:r>
-          </a:p>
-        </p:txBody>
-      </p:sp>
-      <p:sp>
-        <p:nvSpPr>
-          <p:cNvPr id="5" name="TextBox 4"/>
-          <p:cNvSpPr txBox="1"/>
-          <p:nvPr/>
-        </p:nvSpPr>
-        <p:spPr>
-          <a:xfrm>
-            <a:off x="411480" y="1691640"/>
-            <a:ext cx="5486400" cy="1645920"/>
-          </a:xfrm>
-          <a:prstGeom prst="rect">
-            <a:avLst/>
-          </a:prstGeom>
-          <a:noFill/>
-        </p:spPr>
-        <p:txBody>
-          <a:bodyPr wrap="square" lIns="0" rIns="0">
-            <a:spAutoFit/>
-          </a:bodyPr>
-          <a:lstStyle/>
-          <a:p>
-            <a:pPr algn="just"/>
-            <a:r>
-              <a:rPr sz="1300" b="0" i="0">
-                <a:solidFill>
-                  <a:srgbClr val="3F3F3F"/>
-                </a:solidFill>
-                <a:latin typeface="Encode Sans"/>
-              </a:rPr>
-              <a:t>Las ventas de supermercados a precios constantes registraron una variación interanual real de -5.1% en marzo 2026. Desestacionalizada: -0.0% m/m.</a:t>
-            </a:r>
-          </a:p>
-        </p:txBody>
-      </p:sp>
-      <p:sp>
-        <p:nvSpPr>
-          <p:cNvPr id="6" name="TextBox 5"/>
-          <p:cNvSpPr txBox="1"/>
-          <p:nvPr/>
-        </p:nvSpPr>
-        <p:spPr>
-          <a:xfrm>
-            <a:off x="411480" y="3520440"/>
-            <a:ext cx="5486400" cy="2743200"/>
-          </a:xfrm>
-          <a:prstGeom prst="rect">
-            <a:avLst/>
-          </a:prstGeom>
-          <a:noFill/>
-        </p:spPr>
-        <p:txBody>
-          <a:bodyPr wrap="square" lIns="0" rIns="0">
-            <a:spAutoFit/>
-          </a:bodyPr>
-          <a:lstStyle/>
-          <a:p>
-            <a:pPr algn="l">
-              <a:spcAft>
-                <a:spcPts val="800"/>
-              </a:spcAft>
-            </a:pPr>
-            <a:r>
-              <a:rPr sz="1300" b="1" i="0">
-                <a:solidFill>
-                  <a:srgbClr val="00B2C9"/>
-                </a:solidFill>
-                <a:latin typeface="Encode Sans"/>
-              </a:rPr>
-              <a:t>●  </a:t>
-            </a:r>
-            <a:r>
-              <a:rPr sz="1300" b="0" i="0">
-                <a:solidFill>
-                  <a:srgbClr val="3F3F3F"/>
-                </a:solidFill>
-                <a:latin typeface="Encode Sans"/>
-              </a:rPr>
-              <a:t>Variación interanual real: -5.1%</a:t>
-            </a:r>
-          </a:p>
-          <a:p>
-            <a:pPr algn="l">
-              <a:spcAft>
-                <a:spcPts val="800"/>
-              </a:spcAft>
-            </a:pPr>
-            <a:r>
-              <a:rPr sz="1300" b="1" i="0">
-                <a:solidFill>
-                  <a:srgbClr val="00B2C9"/>
-                </a:solidFill>
-                <a:latin typeface="Encode Sans"/>
-              </a:rPr>
-              <a:t>●  </a:t>
-            </a:r>
-            <a:r>
-              <a:rPr sz="1300" b="0" i="0">
-                <a:solidFill>
-                  <a:srgbClr val="3F3F3F"/>
-                </a:solidFill>
-                <a:latin typeface="Encode Sans"/>
-              </a:rPr>
-              <a:t>Variación mensual desestacionalizada: -0.0%</a:t>
-            </a:r>
-          </a:p>
-          <a:p>
-            <a:pPr algn="l">
-              <a:spcAft>
-                <a:spcPts val="800"/>
-              </a:spcAft>
-            </a:pPr>
-            <a:r>
-              <a:rPr sz="1300" b="1" i="0">
-                <a:solidFill>
-                  <a:srgbClr val="00B2C9"/>
-                </a:solidFill>
-                <a:latin typeface="Encode Sans"/>
-              </a:rPr>
-              <a:t>●  </a:t>
-            </a:r>
-            <a:r>
-              <a:rPr sz="1300" b="0" i="0">
-                <a:solidFill>
-                  <a:srgbClr val="3F3F3F"/>
-                </a:solidFill>
-                <a:latin typeface="Encode Sans"/>
-              </a:rPr>
-              <a:t>Acumulado del año: -3.1%</a:t>
-            </a:r>
-          </a:p>
-        </p:txBody>
-      </p:sp>
-      <p:pic>
-        <p:nvPicPr>
-          <p:cNvPr id="7" name="Picture 6" descr="image.png"/>
-          <p:cNvPicPr>
-            <a:picLocks noChangeAspect="1"/>
-          </p:cNvPicPr>
-          <p:nvPr/>
-        </p:nvPicPr>
-        <p:blipFill>
-          <a:blip r:embed="rId2"/>
-          <a:stretch>
-            <a:fillRect/>
-          </a:stretch>
-        </p:blipFill>
-        <p:spPr>
-          <a:xfrm>
-            <a:off x="6080760" y="1691640"/>
-            <a:ext cx="5669280" cy="2560320"/>
-          </a:xfrm>
-          <a:prstGeom prst="rect">
-            <a:avLst/>
-          </a:prstGeom>
-        </p:spPr>
-      </p:pic>
-      <p:graphicFrame>
-        <p:nvGraphicFramePr>
-          <p:cNvPr id="8" name="Table 7"/>
-          <p:cNvGraphicFramePr>
-            <a:graphicFrameLocks noGrp="1"/>
-          </p:cNvGraphicFramePr>
-          <p:nvPr/>
-        </p:nvGraphicFramePr>
-        <p:xfrm>
-          <a:off x="6080760" y="4434840"/>
-          <a:ext cx="5669280" cy="2048256"/>
-        </p:xfrm>
-        <a:graphic>
-          <a:graphicData uri="http://schemas.openxmlformats.org/drawingml/2006/table">
-            <a:tbl>
-              <a:tblPr firstRow="1" bandRow="1">
-                <a:tableStyleId>{5C22544A-7EE6-4342-B048-85BDC9FD1C3A}</a:tableStyleId>
-              </a:tblPr>
-              <a:tblGrid>
-                <a:gridCol w="1417320"/>
-                <a:gridCol w="1417320"/>
-                <a:gridCol w="1417320"/>
-                <a:gridCol w="1417320"/>
-              </a:tblGrid>
-              <a:tr h="292608">
-                <a:tc>
-                  <a:txBody>
-                    <a:bodyPr/>
-                    <a:lstStyle/>
-                    <a:p>
-                      <a:pPr algn="l"/>
-                      <a:r>
-                        <a:rPr sz="1000" b="1">
-                          <a:solidFill>
-                            <a:srgbClr val="FFFFFF"/>
-                          </a:solidFill>
-                          <a:latin typeface="Encode Sans"/>
-                        </a:rPr>
-                        <a:t>Mes</a:t>
-                      </a:r>
-                    </a:p>
-                  </a:txBody>
-                  <a:tcPr marL="36576" marR="36576" marT="18288" marB="18288">
-                    <a:solidFill>
-                      <a:srgbClr val="00B2C9"/>
-                    </a:solidFill>
-                  </a:tcPr>
-                </a:tc>
-                <a:tc>
-                  <a:txBody>
-                    <a:bodyPr/>
-                    <a:lstStyle/>
-                    <a:p>
-                      <a:pPr algn="r"/>
-                      <a:r>
-                        <a:rPr sz="1000" b="1">
-                          <a:solidFill>
-                            <a:srgbClr val="FFFFFF"/>
-                          </a:solidFill>
-                          <a:latin typeface="Encode Sans"/>
-                        </a:rPr>
-                        <a:t>Índice real</a:t>
-                      </a:r>
-                    </a:p>
-                  </a:txBody>
-                  <a:tcPr marL="36576" marR="36576" marT="18288" marB="18288">
-                    <a:solidFill>
-                      <a:srgbClr val="00B2C9"/>
-                    </a:solidFill>
-                  </a:tcPr>
-                </a:tc>
-                <a:tc>
-                  <a:txBody>
-                    <a:bodyPr/>
-                    <a:lstStyle/>
-                    <a:p>
-                      <a:pPr algn="r"/>
-                      <a:r>
-                        <a:rPr sz="1000" b="1">
-                          <a:solidFill>
-                            <a:srgbClr val="FFFFFF"/>
-                          </a:solidFill>
-                          <a:latin typeface="Encode Sans"/>
-                        </a:rPr>
-                        <a:t>VIA real %</a:t>
-                      </a:r>
-                    </a:p>
-                  </a:txBody>
-                  <a:tcPr marL="36576" marR="36576" marT="18288" marB="18288">
-                    <a:solidFill>
-                      <a:srgbClr val="00B2C9"/>
-                    </a:solidFill>
-                  </a:tcPr>
-                </a:tc>
-                <a:tc>
-                  <a:txBody>
-                    <a:bodyPr/>
-                    <a:lstStyle/>
-                    <a:p>
-                      <a:pPr algn="r"/>
-                      <a:r>
-                        <a:rPr sz="1000" b="1">
-                          <a:solidFill>
-                            <a:srgbClr val="FFFFFF"/>
-                          </a:solidFill>
-                          <a:latin typeface="Encode Sans"/>
-                        </a:rPr>
-                        <a:t>Acumulado %</a:t>
-                      </a:r>
-                    </a:p>
-                  </a:txBody>
-                  <a:tcPr marL="36576" marR="36576" marT="18288" marB="18288">
-                    <a:solidFill>
-                      <a:srgbClr val="00B2C9"/>
-                    </a:solidFill>
-                  </a:tcPr>
-                </a:tc>
-              </a:tr>
-              <a:tr h="292608">
-                <a:tc>
-                  <a:txBody>
-                    <a:bodyPr/>
-                    <a:lstStyle/>
-                    <a:p>
-                      <a:pPr algn="l"/>
-                      <a:r>
-                        <a:rPr sz="1000">
-                          <a:solidFill>
-                            <a:srgbClr val="3F3F3F"/>
-                          </a:solidFill>
-                          <a:latin typeface="Encode Sans"/>
-                        </a:rPr>
-                        <a:t>Marzo 2026</a:t>
-                      </a:r>
-                    </a:p>
-                  </a:txBody>
-                  <a:tcPr marL="36576" marR="36576" marT="18288" marB="18288">
-                    <a:solidFill>
-                      <a:srgbClr val="FFFFFF"/>
-                    </a:solidFill>
-                  </a:tcPr>
-                </a:tc>
-                <a:tc>
-                  <a:txBody>
-                    <a:bodyPr/>
-                    <a:lstStyle/>
-                    <a:p>
-                      <a:pPr algn="r"/>
-                      <a:r>
-                        <a:rPr sz="1000">
-                          <a:solidFill>
-                            <a:srgbClr val="3F3F3F"/>
-                          </a:solidFill>
-                          <a:latin typeface="Encode Sans"/>
-                        </a:rPr>
-                        <a:t>82,4</a:t>
-                      </a:r>
-                    </a:p>
-                  </a:txBody>
-                  <a:tcPr marL="36576" marR="36576" marT="18288" marB="18288">
-                    <a:solidFill>
-                      <a:srgbClr val="FFFFFF"/>
-                    </a:solidFill>
-                  </a:tcPr>
-                </a:tc>
-                <a:tc>
-                  <a:txBody>
-                    <a:bodyPr/>
-                    <a:lstStyle/>
-                    <a:p>
-                      <a:pPr algn="r"/>
-                      <a:r>
-                        <a:rPr sz="1000">
-                          <a:solidFill>
-                            <a:srgbClr val="3F3F3F"/>
-                          </a:solidFill>
-                          <a:latin typeface="Encode Sans"/>
-                        </a:rPr>
-                        <a:t>-5.1%</a:t>
-                      </a:r>
-                    </a:p>
-                  </a:txBody>
-                  <a:tcPr marL="36576" marR="36576" marT="18288" marB="18288">
-                    <a:solidFill>
-                      <a:srgbClr val="FFFFFF"/>
-                    </a:solidFill>
-                  </a:tcPr>
-                </a:tc>
-                <a:tc>
-                  <a:txBody>
-                    <a:bodyPr/>
-                    <a:lstStyle/>
-                    <a:p>
-                      <a:pPr algn="r"/>
-                      <a:r>
-                        <a:rPr sz="1000">
-                          <a:solidFill>
-                            <a:srgbClr val="3F3F3F"/>
-                          </a:solidFill>
-                          <a:latin typeface="Encode Sans"/>
-                        </a:rPr>
-                        <a:t>-3.1%</a:t>
-                      </a:r>
-                    </a:p>
-                  </a:txBody>
-                  <a:tcPr marL="36576" marR="36576" marT="18288" marB="18288">
-                    <a:solidFill>
-                      <a:srgbClr val="FFFFFF"/>
-                    </a:solidFill>
-                  </a:tcPr>
-                </a:tc>
-              </a:tr>
-              <a:tr h="292608">
-                <a:tc>
-                  <a:txBody>
-                    <a:bodyPr/>
-                    <a:lstStyle/>
-                    <a:p>
-                      <a:pPr algn="l"/>
-                      <a:r>
-                        <a:rPr sz="1000">
-                          <a:solidFill>
-                            <a:srgbClr val="3F3F3F"/>
-                          </a:solidFill>
-                          <a:latin typeface="Encode Sans"/>
-                        </a:rPr>
-                        <a:t>Febrero 2026</a:t>
-                      </a:r>
-                    </a:p>
-                  </a:txBody>
-                  <a:tcPr marL="36576" marR="36576" marT="18288" marB="18288">
-                    <a:solidFill>
-                      <a:srgbClr val="F8F8F6"/>
-                    </a:solidFill>
-                  </a:tcPr>
-                </a:tc>
-                <a:tc>
-                  <a:txBody>
-                    <a:bodyPr/>
-                    <a:lstStyle/>
-                    <a:p>
-                      <a:pPr algn="r"/>
-                      <a:r>
-                        <a:rPr sz="1000">
-                          <a:solidFill>
-                            <a:srgbClr val="3F3F3F"/>
-                          </a:solidFill>
-                          <a:latin typeface="Encode Sans"/>
-                        </a:rPr>
-                        <a:t>76,1</a:t>
-                      </a:r>
-                    </a:p>
-                  </a:txBody>
-                  <a:tcPr marL="36576" marR="36576" marT="18288" marB="18288">
-                    <a:solidFill>
-                      <a:srgbClr val="F8F8F6"/>
-                    </a:solidFill>
-                  </a:tcPr>
-                </a:tc>
-                <a:tc>
-                  <a:txBody>
-                    <a:bodyPr/>
-                    <a:lstStyle/>
-                    <a:p>
-                      <a:pPr algn="r"/>
-                      <a:r>
-                        <a:rPr sz="1000">
-                          <a:solidFill>
-                            <a:srgbClr val="3F3F3F"/>
-                          </a:solidFill>
-                          <a:latin typeface="Encode Sans"/>
-                        </a:rPr>
-                        <a:t>-3.1%</a:t>
-                      </a:r>
-                    </a:p>
-                  </a:txBody>
-                  <a:tcPr marL="36576" marR="36576" marT="18288" marB="18288">
-                    <a:solidFill>
-                      <a:srgbClr val="F8F8F6"/>
-                    </a:solidFill>
-                  </a:tcPr>
-                </a:tc>
-                <a:tc>
-                  <a:txBody>
-                    <a:bodyPr/>
-                    <a:lstStyle/>
-                    <a:p>
-                      <a:pPr algn="r"/>
-                      <a:r>
-                        <a:rPr sz="1000">
-                          <a:solidFill>
-                            <a:srgbClr val="3F3F3F"/>
-                          </a:solidFill>
-                          <a:latin typeface="Encode Sans"/>
-                        </a:rPr>
-                        <a:t>-2.1%</a:t>
-                      </a:r>
-                    </a:p>
-                  </a:txBody>
-                  <a:tcPr marL="36576" marR="36576" marT="18288" marB="18288">
-                    <a:solidFill>
-                      <a:srgbClr val="F8F8F6"/>
-                    </a:solidFill>
-                  </a:tcPr>
-                </a:tc>
-              </a:tr>
-              <a:tr h="292608">
-                <a:tc>
-                  <a:txBody>
-                    <a:bodyPr/>
-                    <a:lstStyle/>
-                    <a:p>
-                      <a:pPr algn="l"/>
-                      <a:r>
-                        <a:rPr sz="1000">
-                          <a:solidFill>
-                            <a:srgbClr val="3F3F3F"/>
-                          </a:solidFill>
-                          <a:latin typeface="Encode Sans"/>
-                        </a:rPr>
-                        <a:t>Enero 2026</a:t>
-                      </a:r>
-                    </a:p>
-                  </a:txBody>
-                  <a:tcPr marL="36576" marR="36576" marT="18288" marB="18288">
-                    <a:solidFill>
-                      <a:srgbClr val="FFFFFF"/>
-                    </a:solidFill>
-                  </a:tcPr>
-                </a:tc>
-                <a:tc>
-                  <a:txBody>
-                    <a:bodyPr/>
-                    <a:lstStyle/>
-                    <a:p>
-                      <a:pPr algn="r"/>
-                      <a:r>
-                        <a:rPr sz="1000">
-                          <a:solidFill>
-                            <a:srgbClr val="3F3F3F"/>
-                          </a:solidFill>
-                          <a:latin typeface="Encode Sans"/>
-                        </a:rPr>
-                        <a:t>82,8</a:t>
-                      </a:r>
-                    </a:p>
-                  </a:txBody>
-                  <a:tcPr marL="36576" marR="36576" marT="18288" marB="18288">
-                    <a:solidFill>
-                      <a:srgbClr val="FFFFFF"/>
-                    </a:solidFill>
-                  </a:tcPr>
-                </a:tc>
-                <a:tc>
-                  <a:txBody>
-                    <a:bodyPr/>
-                    <a:lstStyle/>
-                    <a:p>
-                      <a:pPr algn="r"/>
-                      <a:r>
-                        <a:rPr sz="1000">
-                          <a:solidFill>
-                            <a:srgbClr val="3F3F3F"/>
-                          </a:solidFill>
-                          <a:latin typeface="Encode Sans"/>
-                        </a:rPr>
-                        <a:t>-1.2%</a:t>
-                      </a:r>
-                    </a:p>
-                  </a:txBody>
-                  <a:tcPr marL="36576" marR="36576" marT="18288" marB="18288">
-                    <a:solidFill>
-                      <a:srgbClr val="FFFFFF"/>
-                    </a:solidFill>
-                  </a:tcPr>
-                </a:tc>
-                <a:tc>
-                  <a:txBody>
-                    <a:bodyPr/>
-                    <a:lstStyle/>
-                    <a:p>
-                      <a:pPr algn="r"/>
-                      <a:r>
-                        <a:rPr sz="1000">
-                          <a:solidFill>
-                            <a:srgbClr val="3F3F3F"/>
-                          </a:solidFill>
-                          <a:latin typeface="Encode Sans"/>
-                        </a:rPr>
-                        <a:t>-1.2%</a:t>
-                      </a:r>
-                    </a:p>
-                  </a:txBody>
-                  <a:tcPr marL="36576" marR="36576" marT="18288" marB="18288">
-                    <a:solidFill>
-                      <a:srgbClr val="FFFFFF"/>
-                    </a:solidFill>
-                  </a:tcPr>
-                </a:tc>
-              </a:tr>
-              <a:tr h="292608">
-                <a:tc>
-                  <a:txBody>
-                    <a:bodyPr/>
-                    <a:lstStyle/>
-                    <a:p>
-                      <a:pPr algn="l"/>
-                      <a:r>
-                        <a:rPr sz="1000">
-                          <a:solidFill>
-                            <a:srgbClr val="3F3F3F"/>
-                          </a:solidFill>
-                          <a:latin typeface="Encode Sans"/>
-                        </a:rPr>
-                        <a:t>Diciembre 2025</a:t>
-                      </a:r>
-                    </a:p>
-                  </a:txBody>
-                  <a:tcPr marL="36576" marR="36576" marT="18288" marB="18288">
-                    <a:solidFill>
-                      <a:srgbClr val="F8F8F6"/>
-                    </a:solidFill>
-                  </a:tcPr>
-                </a:tc>
-                <a:tc>
-                  <a:txBody>
-                    <a:bodyPr/>
-                    <a:lstStyle/>
-                    <a:p>
-                      <a:pPr algn="r"/>
-                      <a:r>
-                        <a:rPr sz="1000">
-                          <a:solidFill>
-                            <a:srgbClr val="3F3F3F"/>
-                          </a:solidFill>
-                          <a:latin typeface="Encode Sans"/>
-                        </a:rPr>
-                        <a:t>102,3</a:t>
-                      </a:r>
-                    </a:p>
-                  </a:txBody>
-                  <a:tcPr marL="36576" marR="36576" marT="18288" marB="18288">
-                    <a:solidFill>
-                      <a:srgbClr val="F8F8F6"/>
-                    </a:solidFill>
-                  </a:tcPr>
-                </a:tc>
-                <a:tc>
-                  <a:txBody>
-                    <a:bodyPr/>
-                    <a:lstStyle/>
-                    <a:p>
-                      <a:pPr algn="r"/>
-                      <a:r>
-                        <a:rPr sz="1000">
-                          <a:solidFill>
-                            <a:srgbClr val="3F3F3F"/>
-                          </a:solidFill>
-                          <a:latin typeface="Encode Sans"/>
-                        </a:rPr>
-                        <a:t>+0.5%</a:t>
-                      </a:r>
-                    </a:p>
-                  </a:txBody>
-                  <a:tcPr marL="36576" marR="36576" marT="18288" marB="18288">
-                    <a:solidFill>
-                      <a:srgbClr val="F8F8F6"/>
-                    </a:solidFill>
-                  </a:tcPr>
-                </a:tc>
-                <a:tc>
-                  <a:txBody>
-                    <a:bodyPr/>
-                    <a:lstStyle/>
-                    <a:p>
-                      <a:pPr algn="r"/>
-                      <a:r>
-                        <a:rPr sz="1000">
-                          <a:solidFill>
-                            <a:srgbClr val="3F3F3F"/>
-                          </a:solidFill>
-                          <a:latin typeface="Encode Sans"/>
-                        </a:rPr>
-                        <a:t>+2.0%</a:t>
-                      </a:r>
-                    </a:p>
-                  </a:txBody>
-                  <a:tcPr marL="36576" marR="36576" marT="18288" marB="18288">
-                    <a:solidFill>
-                      <a:srgbClr val="F8F8F6"/>
-                    </a:solidFill>
-                  </a:tcPr>
-                </a:tc>
-              </a:tr>
-              <a:tr h="292608">
-                <a:tc>
-                  <a:txBody>
-                    <a:bodyPr/>
-                    <a:lstStyle/>
-                    <a:p>
-                      <a:pPr algn="l"/>
-                      <a:r>
-                        <a:rPr sz="1000">
-                          <a:solidFill>
-                            <a:srgbClr val="3F3F3F"/>
-                          </a:solidFill>
-                          <a:latin typeface="Encode Sans"/>
-                        </a:rPr>
-                        <a:t>Noviembre 2025</a:t>
-                      </a:r>
-                    </a:p>
-                  </a:txBody>
-                  <a:tcPr marL="36576" marR="36576" marT="18288" marB="18288">
-                    <a:solidFill>
-                      <a:srgbClr val="FFFFFF"/>
-                    </a:solidFill>
-                  </a:tcPr>
-                </a:tc>
-                <a:tc>
-                  <a:txBody>
-                    <a:bodyPr/>
-                    <a:lstStyle/>
-                    <a:p>
-                      <a:pPr algn="r"/>
-                      <a:r>
-                        <a:rPr sz="1000">
-                          <a:solidFill>
-                            <a:srgbClr val="3F3F3F"/>
-                          </a:solidFill>
-                          <a:latin typeface="Encode Sans"/>
-                        </a:rPr>
-                        <a:t>82,3</a:t>
-                      </a:r>
-                    </a:p>
-                  </a:txBody>
-                  <a:tcPr marL="36576" marR="36576" marT="18288" marB="18288">
-                    <a:solidFill>
-                      <a:srgbClr val="FFFFFF"/>
-                    </a:solidFill>
-                  </a:tcPr>
-                </a:tc>
-                <a:tc>
-                  <a:txBody>
-                    <a:bodyPr/>
-                    <a:lstStyle/>
-                    <a:p>
-                      <a:pPr algn="r"/>
-                      <a:r>
-                        <a:rPr sz="1000">
-                          <a:solidFill>
-                            <a:srgbClr val="3F3F3F"/>
-                          </a:solidFill>
-                          <a:latin typeface="Encode Sans"/>
-                        </a:rPr>
-                        <a:t>-2.8%</a:t>
-                      </a:r>
-                    </a:p>
-                  </a:txBody>
-                  <a:tcPr marL="36576" marR="36576" marT="18288" marB="18288">
-                    <a:solidFill>
-                      <a:srgbClr val="FFFFFF"/>
-                    </a:solidFill>
-                  </a:tcPr>
-                </a:tc>
-                <a:tc>
-                  <a:txBody>
-                    <a:bodyPr/>
-                    <a:lstStyle/>
-                    <a:p>
-                      <a:pPr algn="r"/>
-                      <a:r>
-                        <a:rPr sz="1000">
-                          <a:solidFill>
-                            <a:srgbClr val="3F3F3F"/>
-                          </a:solidFill>
-                          <a:latin typeface="Encode Sans"/>
-                        </a:rPr>
-                        <a:t>+2.2%</a:t>
-                      </a:r>
-                    </a:p>
-                  </a:txBody>
-                  <a:tcPr marL="36576" marR="36576" marT="18288" marB="18288">
-                    <a:solidFill>
-                      <a:srgbClr val="FFFFFF"/>
-                    </a:solidFill>
-                  </a:tcPr>
-                </a:tc>
-              </a:tr>
-              <a:tr h="292608">
-                <a:tc>
-                  <a:txBody>
-                    <a:bodyPr/>
-                    <a:lstStyle/>
-                    <a:p>
-                      <a:pPr algn="l"/>
-                      <a:r>
-                        <a:rPr sz="1000">
-                          <a:solidFill>
-                            <a:srgbClr val="3F3F3F"/>
-                          </a:solidFill>
-                          <a:latin typeface="Encode Sans"/>
-                        </a:rPr>
-                        <a:t>Octubre 2025</a:t>
-                      </a:r>
-                    </a:p>
-                  </a:txBody>
-                  <a:tcPr marL="36576" marR="36576" marT="18288" marB="18288">
-                    <a:solidFill>
-                      <a:srgbClr val="F8F8F6"/>
-                    </a:solidFill>
-                  </a:tcPr>
-                </a:tc>
-                <a:tc>
-                  <a:txBody>
-                    <a:bodyPr/>
-                    <a:lstStyle/>
-                    <a:p>
-                      <a:pPr algn="r"/>
-                      <a:r>
-                        <a:rPr sz="1000">
-                          <a:solidFill>
-                            <a:srgbClr val="3F3F3F"/>
-                          </a:solidFill>
-                          <a:latin typeface="Encode Sans"/>
-                        </a:rPr>
-                        <a:t>82,2</a:t>
-                      </a:r>
-                    </a:p>
-                  </a:txBody>
-                  <a:tcPr marL="36576" marR="36576" marT="18288" marB="18288">
-                    <a:solidFill>
-                      <a:srgbClr val="F8F8F6"/>
-                    </a:solidFill>
-                  </a:tcPr>
-                </a:tc>
-                <a:tc>
-                  <a:txBody>
-                    <a:bodyPr/>
-                    <a:lstStyle/>
-                    <a:p>
-                      <a:pPr algn="r"/>
-                      <a:r>
-                        <a:rPr sz="1000">
-                          <a:solidFill>
-                            <a:srgbClr val="3F3F3F"/>
-                          </a:solidFill>
-                          <a:latin typeface="Encode Sans"/>
-                        </a:rPr>
-                        <a:t>+2.7%</a:t>
-                      </a:r>
-                    </a:p>
-                  </a:txBody>
-                  <a:tcPr marL="36576" marR="36576" marT="18288" marB="18288">
-                    <a:solidFill>
-                      <a:srgbClr val="F8F8F6"/>
-                    </a:solidFill>
-                  </a:tcPr>
-                </a:tc>
-                <a:tc>
-                  <a:txBody>
-                    <a:bodyPr/>
-                    <a:lstStyle/>
-                    <a:p>
-                      <a:pPr algn="r"/>
-                      <a:r>
-                        <a:rPr sz="1000">
-                          <a:solidFill>
-                            <a:srgbClr val="3F3F3F"/>
-                          </a:solidFill>
-                          <a:latin typeface="Encode Sans"/>
-                        </a:rPr>
-                        <a:t>+2.7%</a:t>
-                      </a:r>
-                    </a:p>
-                  </a:txBody>
-                  <a:tcPr marL="36576" marR="36576" marT="18288" marB="18288">
-                    <a:solidFill>
-                      <a:srgbClr val="F8F8F6"/>
-                    </a:solidFill>
-                  </a:tcPr>
-                </a:tc>
-              </a:tr>
-            </a:tbl>
-          </a:graphicData>
-        </a:graphic>
-      </p:graphicFrame>
-      <p:sp>
-        <p:nvSpPr>
-          <p:cNvPr id="9" name="TextBox 8"/>
-          <p:cNvSpPr txBox="1"/>
-          <p:nvPr/>
-        </p:nvSpPr>
-        <p:spPr>
-          <a:xfrm>
-            <a:off x="411480" y="6492240"/>
-            <a:ext cx="11368735" cy="274320"/>
-          </a:xfrm>
-          <a:prstGeom prst="rect">
-            <a:avLst/>
-          </a:prstGeom>
-          <a:noFill/>
-        </p:spPr>
-        <p:txBody>
-          <a:bodyPr wrap="none">
-            <a:spAutoFit/>
-          </a:bodyPr>
-          <a:lstStyle/>
-          <a:p>
-            <a:r>
-              <a:rPr sz="1000" b="0" i="1">
-                <a:solidFill>
-                  <a:srgbClr val="6A6760"/>
-                </a:solidFill>
-                <a:latin typeface="Encode Sans"/>
-              </a:rPr>
-              <a:t>Fuente: elaboración propia en base a INDEC</a:t>
-            </a:r>
-          </a:p>
-        </p:txBody>
-      </p:sp>
-    </p:spTree>
-  </p:cSld>
-  <p:clrMapOvr>
-    <a:masterClrMapping/>
-  </p:clrMapOvr>
-</p:sld>
-</file>
-
-<file path=ppt/slides/slide4.xml><?xml version="1.0" encoding="utf-8"?>
 <p:sld xmlns:a="http://schemas.openxmlformats.org/drawingml/2006/main" xmlns:p="http://schemas.openxmlformats.org/presentationml/2006/main" xmlns:r="http://schemas.openxmlformats.org/officeDocument/2006/relationships">
   <p:cSld>
     <p:spTree>

</xml_diff>

<commit_message>
pipeline: PPTX self-consistent + templates rec/turismo + mora preliminar
build_slides.py:
- tpl_rec: recaudacion con var nominal/real i.a. (deflactor IPC oficial o REM proy.)
  + deteccion de quiebre de tendencia tras meses de caida real
- tpl_turismo: receptivo + emisivo + saldo con var i.a.
- tpl_mora: badge PRELIMINAR, delta vs mes anterior, marca fila * en tabla
- TEMPLATES: registra rec, turismo, ripte

scraper/update_all.py:
- Wrapper que corre scrape.py + build_slides.py en orden
- El workflow daily-update.yml YA hace ambos pasos; este es para corridas locales

publicaciones_semana.pptx regenerado con rec mayo + mora abril preliminar.
</commit_message>
<xml_diff>
--- a/publicaciones_semana.pptx
+++ b/publicaciones_semana.pptx
@@ -7,6 +7,7 @@
   <p:sldIdLst>
     <p:sldId id="256" r:id="rId7"/>
     <p:sldId id="257" r:id="rId8"/>
+    <p:sldId id="258" r:id="rId9"/>
   </p:sldIdLst>
   <p:sldSz cx="12191695" cy="6858000" type="screen4x3"/>
   <p:notesSz cx="6858000" cy="9144000"/>
@@ -3238,7 +3239,7 @@
                 </a:solidFill>
                 <a:latin typeface="Encode Sans"/>
               </a:rPr>
-              <a:t>Publicaciones de la semana del 25 de mayo de 2026</a:t>
+              <a:t>Publicaciones de la semana del 01 de junio de 2026</a:t>
             </a:r>
           </a:p>
         </p:txBody>
@@ -3272,7 +3273,7 @@
                 </a:solidFill>
                 <a:latin typeface="Encode Sans"/>
               </a:rPr>
-              <a:t>1 publicaciones · datos oficiales INDEC / BCRA / Hacienda</a:t>
+              <a:t>2 publicaciones · datos oficiales INDEC / BCRA / Hacienda</a:t>
             </a:r>
           </a:p>
         </p:txBody>
@@ -3368,7 +3369,7 @@
                 </a:solidFill>
                 <a:latin typeface="Encode Sans"/>
               </a:rPr>
-              <a:t>TURISMO INTERNACIONAL ABRIL 2026</a:t>
+              <a:t>RECAUDACIÓN MAYO 2026: CRECIÓ +3.2% REAL I.A.</a:t>
             </a:r>
           </a:p>
         </p:txBody>
@@ -3402,7 +3403,7 @@
                 </a:solidFill>
                 <a:latin typeface="Encode Sans"/>
               </a:rPr>
-              <a:t>INDEC · período 2026-04</a:t>
+              <a:t>AFIP/ARCA · período 2026-05</a:t>
             </a:r>
           </a:p>
         </p:txBody>
@@ -3437,7 +3438,7 @@
                 </a:solidFill>
                 <a:latin typeface="Encode Sans"/>
               </a:rPr>
-              <a:t>Se publicó la actualización de Turismo internacional para abril 2026. Fuente: INDEC.</a:t>
+              <a:t>AFIP/ARCA recaudó $21.514K millones en mayo 2026. Variación nominal interanual: +35.6%. En términos reales (deflactado por REM): +3.2% i.a. Quiebre de tendencia: venía con 6 meses de caída real interanual.</a:t>
             </a:r>
           </a:p>
         </p:txBody>
@@ -3485,7 +3486,7 @@
                 </a:solidFill>
                 <a:latin typeface="Encode Sans"/>
               </a:rPr>
-              <a:t>rec: 463.072,00</a:t>
+              <a:t>Total: $21.514K M$</a:t>
             </a:r>
           </a:p>
           <a:p>
@@ -3510,7 +3511,7 @@
                 </a:solidFill>
                 <a:latin typeface="Encode Sans"/>
               </a:rPr>
-              <a:t>em: 764.757,00</a:t>
+              <a:t>Variación nominal i.a.: +35.6%</a:t>
             </a:r>
           </a:p>
           <a:p>
@@ -3535,14 +3536,749 @@
                 </a:solidFill>
                 <a:latin typeface="Encode Sans"/>
               </a:rPr>
-              <a:t>sal: -301.685,00</a:t>
-            </a:r>
-          </a:p>
-        </p:txBody>
-      </p:sp>
-      <p:sp>
-        <p:nvSpPr>
-          <p:cNvPr id="7" name="TextBox 6"/>
+              <a:t>Variación real i.a.: +3.2% (deflactor: REM)</a:t>
+            </a:r>
+          </a:p>
+          <a:p>
+            <a:pPr algn="l">
+              <a:spcAft>
+                <a:spcPts val="800"/>
+              </a:spcAft>
+            </a:pPr>
+            <a:r>
+              <a:rPr sz="1300" b="1" i="0">
+                <a:solidFill>
+                  <a:srgbClr val="00B2C9"/>
+                </a:solidFill>
+                <a:latin typeface="Encode Sans"/>
+              </a:rPr>
+              <a:t>●  </a:t>
+            </a:r>
+            <a:r>
+              <a:rPr sz="1300" b="0" i="0">
+                <a:solidFill>
+                  <a:srgbClr val="3F3F3F"/>
+                </a:solidFill>
+                <a:latin typeface="Encode Sans"/>
+              </a:rPr>
+              <a:t>Fuente: ARCA (ex AFIP) · indec.gob.ar series</a:t>
+            </a:r>
+          </a:p>
+        </p:txBody>
+      </p:sp>
+      <p:pic>
+        <p:nvPicPr>
+          <p:cNvPr id="7" name="Picture 6" descr="image.png"/>
+          <p:cNvPicPr>
+            <a:picLocks noChangeAspect="1"/>
+          </p:cNvPicPr>
+          <p:nvPr/>
+        </p:nvPicPr>
+        <p:blipFill>
+          <a:blip r:embed="rId2"/>
+          <a:stretch>
+            <a:fillRect/>
+          </a:stretch>
+        </p:blipFill>
+        <p:spPr>
+          <a:xfrm>
+            <a:off x="6080760" y="1691640"/>
+            <a:ext cx="5669280" cy="2560320"/>
+          </a:xfrm>
+          <a:prstGeom prst="rect">
+            <a:avLst/>
+          </a:prstGeom>
+        </p:spPr>
+      </p:pic>
+      <p:graphicFrame>
+        <p:nvGraphicFramePr>
+          <p:cNvPr id="8" name="Table 7"/>
+          <p:cNvGraphicFramePr>
+            <a:graphicFrameLocks noGrp="1"/>
+          </p:cNvGraphicFramePr>
+          <p:nvPr/>
+        </p:nvGraphicFramePr>
+        <p:xfrm>
+          <a:off x="6080760" y="4434840"/>
+          <a:ext cx="5669280" cy="2048256"/>
+        </p:xfrm>
+        <a:graphic>
+          <a:graphicData uri="http://schemas.openxmlformats.org/drawingml/2006/table">
+            <a:tbl>
+              <a:tblPr firstRow="1" bandRow="1">
+                <a:tableStyleId>{5C22544A-7EE6-4342-B048-85BDC9FD1C3A}</a:tableStyleId>
+              </a:tblPr>
+              <a:tblGrid>
+                <a:gridCol w="1417320"/>
+                <a:gridCol w="1417320"/>
+                <a:gridCol w="1417320"/>
+                <a:gridCol w="1417320"/>
+              </a:tblGrid>
+              <a:tr h="292608">
+                <a:tc>
+                  <a:txBody>
+                    <a:bodyPr/>
+                    <a:lstStyle/>
+                    <a:p>
+                      <a:pPr algn="l"/>
+                      <a:r>
+                        <a:rPr sz="1000" b="1">
+                          <a:solidFill>
+                            <a:srgbClr val="FFFFFF"/>
+                          </a:solidFill>
+                          <a:latin typeface="Encode Sans"/>
+                        </a:rPr>
+                        <a:t>Mes</a:t>
+                      </a:r>
+                    </a:p>
+                  </a:txBody>
+                  <a:tcPr marL="36576" marR="36576" marT="18288" marB="18288">
+                    <a:solidFill>
+                      <a:srgbClr val="00B2C9"/>
+                    </a:solidFill>
+                  </a:tcPr>
+                </a:tc>
+                <a:tc>
+                  <a:txBody>
+                    <a:bodyPr/>
+                    <a:lstStyle/>
+                    <a:p>
+                      <a:pPr algn="r"/>
+                      <a:r>
+                        <a:rPr sz="1000" b="1">
+                          <a:solidFill>
+                            <a:srgbClr val="FFFFFF"/>
+                          </a:solidFill>
+                          <a:latin typeface="Encode Sans"/>
+                        </a:rPr>
+                        <a:t>Total M$</a:t>
+                      </a:r>
+                    </a:p>
+                  </a:txBody>
+                  <a:tcPr marL="36576" marR="36576" marT="18288" marB="18288">
+                    <a:solidFill>
+                      <a:srgbClr val="00B2C9"/>
+                    </a:solidFill>
+                  </a:tcPr>
+                </a:tc>
+                <a:tc>
+                  <a:txBody>
+                    <a:bodyPr/>
+                    <a:lstStyle/>
+                    <a:p>
+                      <a:pPr algn="r"/>
+                      <a:r>
+                        <a:rPr sz="1000" b="1">
+                          <a:solidFill>
+                            <a:srgbClr val="FFFFFF"/>
+                          </a:solidFill>
+                          <a:latin typeface="Encode Sans"/>
+                        </a:rPr>
+                        <a:t>Var. nom. i.a.</a:t>
+                      </a:r>
+                    </a:p>
+                  </a:txBody>
+                  <a:tcPr marL="36576" marR="36576" marT="18288" marB="18288">
+                    <a:solidFill>
+                      <a:srgbClr val="00B2C9"/>
+                    </a:solidFill>
+                  </a:tcPr>
+                </a:tc>
+                <a:tc>
+                  <a:txBody>
+                    <a:bodyPr/>
+                    <a:lstStyle/>
+                    <a:p>
+                      <a:pPr algn="r"/>
+                      <a:r>
+                        <a:rPr sz="1000" b="1">
+                          <a:solidFill>
+                            <a:srgbClr val="FFFFFF"/>
+                          </a:solidFill>
+                          <a:latin typeface="Encode Sans"/>
+                        </a:rPr>
+                        <a:t>Var. real i.a.</a:t>
+                      </a:r>
+                    </a:p>
+                  </a:txBody>
+                  <a:tcPr marL="36576" marR="36576" marT="18288" marB="18288">
+                    <a:solidFill>
+                      <a:srgbClr val="00B2C9"/>
+                    </a:solidFill>
+                  </a:tcPr>
+                </a:tc>
+              </a:tr>
+              <a:tr h="292608">
+                <a:tc>
+                  <a:txBody>
+                    <a:bodyPr/>
+                    <a:lstStyle/>
+                    <a:p>
+                      <a:pPr algn="l"/>
+                      <a:r>
+                        <a:rPr sz="1000">
+                          <a:solidFill>
+                            <a:srgbClr val="3F3F3F"/>
+                          </a:solidFill>
+                          <a:latin typeface="Encode Sans"/>
+                        </a:rPr>
+                        <a:t>Mayo 2026</a:t>
+                      </a:r>
+                    </a:p>
+                  </a:txBody>
+                  <a:tcPr marL="36576" marR="36576" marT="18288" marB="18288">
+                    <a:solidFill>
+                      <a:srgbClr val="FFFFFF"/>
+                    </a:solidFill>
+                  </a:tcPr>
+                </a:tc>
+                <a:tc>
+                  <a:txBody>
+                    <a:bodyPr/>
+                    <a:lstStyle/>
+                    <a:p>
+                      <a:pPr algn="r"/>
+                      <a:r>
+                        <a:rPr sz="1000">
+                          <a:solidFill>
+                            <a:srgbClr val="3F3F3F"/>
+                          </a:solidFill>
+                          <a:latin typeface="Encode Sans"/>
+                        </a:rPr>
+                        <a:t>21.514K</a:t>
+                      </a:r>
+                    </a:p>
+                  </a:txBody>
+                  <a:tcPr marL="36576" marR="36576" marT="18288" marB="18288">
+                    <a:solidFill>
+                      <a:srgbClr val="FFFFFF"/>
+                    </a:solidFill>
+                  </a:tcPr>
+                </a:tc>
+                <a:tc>
+                  <a:txBody>
+                    <a:bodyPr/>
+                    <a:lstStyle/>
+                    <a:p>
+                      <a:pPr algn="r"/>
+                      <a:r>
+                        <a:rPr sz="1000">
+                          <a:solidFill>
+                            <a:srgbClr val="3F3F3F"/>
+                          </a:solidFill>
+                          <a:latin typeface="Encode Sans"/>
+                        </a:rPr>
+                        <a:t>—</a:t>
+                      </a:r>
+                    </a:p>
+                  </a:txBody>
+                  <a:tcPr marL="36576" marR="36576" marT="18288" marB="18288">
+                    <a:solidFill>
+                      <a:srgbClr val="FFFFFF"/>
+                    </a:solidFill>
+                  </a:tcPr>
+                </a:tc>
+                <a:tc>
+                  <a:txBody>
+                    <a:bodyPr/>
+                    <a:lstStyle/>
+                    <a:p>
+                      <a:pPr algn="r"/>
+                      <a:r>
+                        <a:rPr sz="1000">
+                          <a:solidFill>
+                            <a:srgbClr val="3F3F3F"/>
+                          </a:solidFill>
+                          <a:latin typeface="Encode Sans"/>
+                        </a:rPr>
+                        <a:t>—</a:t>
+                      </a:r>
+                    </a:p>
+                  </a:txBody>
+                  <a:tcPr marL="36576" marR="36576" marT="18288" marB="18288">
+                    <a:solidFill>
+                      <a:srgbClr val="FFFFFF"/>
+                    </a:solidFill>
+                  </a:tcPr>
+                </a:tc>
+              </a:tr>
+              <a:tr h="292608">
+                <a:tc>
+                  <a:txBody>
+                    <a:bodyPr/>
+                    <a:lstStyle/>
+                    <a:p>
+                      <a:pPr algn="l"/>
+                      <a:r>
+                        <a:rPr sz="1000">
+                          <a:solidFill>
+                            <a:srgbClr val="3F3F3F"/>
+                          </a:solidFill>
+                          <a:latin typeface="Encode Sans"/>
+                        </a:rPr>
+                        <a:t>Abril 2026</a:t>
+                      </a:r>
+                    </a:p>
+                  </a:txBody>
+                  <a:tcPr marL="36576" marR="36576" marT="18288" marB="18288">
+                    <a:solidFill>
+                      <a:srgbClr val="F8F8F6"/>
+                    </a:solidFill>
+                  </a:tcPr>
+                </a:tc>
+                <a:tc>
+                  <a:txBody>
+                    <a:bodyPr/>
+                    <a:lstStyle/>
+                    <a:p>
+                      <a:pPr algn="r"/>
+                      <a:r>
+                        <a:rPr sz="1000">
+                          <a:solidFill>
+                            <a:srgbClr val="3F3F3F"/>
+                          </a:solidFill>
+                          <a:latin typeface="Encode Sans"/>
+                        </a:rPr>
+                        <a:t>17.401K</a:t>
+                      </a:r>
+                    </a:p>
+                  </a:txBody>
+                  <a:tcPr marL="36576" marR="36576" marT="18288" marB="18288">
+                    <a:solidFill>
+                      <a:srgbClr val="F8F8F6"/>
+                    </a:solidFill>
+                  </a:tcPr>
+                </a:tc>
+                <a:tc>
+                  <a:txBody>
+                    <a:bodyPr/>
+                    <a:lstStyle/>
+                    <a:p>
+                      <a:pPr algn="r"/>
+                      <a:r>
+                        <a:rPr sz="1000">
+                          <a:solidFill>
+                            <a:srgbClr val="3F3F3F"/>
+                          </a:solidFill>
+                          <a:latin typeface="Encode Sans"/>
+                        </a:rPr>
+                        <a:t>—</a:t>
+                      </a:r>
+                    </a:p>
+                  </a:txBody>
+                  <a:tcPr marL="36576" marR="36576" marT="18288" marB="18288">
+                    <a:solidFill>
+                      <a:srgbClr val="F8F8F6"/>
+                    </a:solidFill>
+                  </a:tcPr>
+                </a:tc>
+                <a:tc>
+                  <a:txBody>
+                    <a:bodyPr/>
+                    <a:lstStyle/>
+                    <a:p>
+                      <a:pPr algn="r"/>
+                      <a:r>
+                        <a:rPr sz="1000">
+                          <a:solidFill>
+                            <a:srgbClr val="3F3F3F"/>
+                          </a:solidFill>
+                          <a:latin typeface="Encode Sans"/>
+                        </a:rPr>
+                        <a:t>—</a:t>
+                      </a:r>
+                    </a:p>
+                  </a:txBody>
+                  <a:tcPr marL="36576" marR="36576" marT="18288" marB="18288">
+                    <a:solidFill>
+                      <a:srgbClr val="F8F8F6"/>
+                    </a:solidFill>
+                  </a:tcPr>
+                </a:tc>
+              </a:tr>
+              <a:tr h="292608">
+                <a:tc>
+                  <a:txBody>
+                    <a:bodyPr/>
+                    <a:lstStyle/>
+                    <a:p>
+                      <a:pPr algn="l"/>
+                      <a:r>
+                        <a:rPr sz="1000">
+                          <a:solidFill>
+                            <a:srgbClr val="3F3F3F"/>
+                          </a:solidFill>
+                          <a:latin typeface="Encode Sans"/>
+                        </a:rPr>
+                        <a:t>Marzo 2026</a:t>
+                      </a:r>
+                    </a:p>
+                  </a:txBody>
+                  <a:tcPr marL="36576" marR="36576" marT="18288" marB="18288">
+                    <a:solidFill>
+                      <a:srgbClr val="FFFFFF"/>
+                    </a:solidFill>
+                  </a:tcPr>
+                </a:tc>
+                <a:tc>
+                  <a:txBody>
+                    <a:bodyPr/>
+                    <a:lstStyle/>
+                    <a:p>
+                      <a:pPr algn="r"/>
+                      <a:r>
+                        <a:rPr sz="1000">
+                          <a:solidFill>
+                            <a:srgbClr val="3F3F3F"/>
+                          </a:solidFill>
+                          <a:latin typeface="Encode Sans"/>
+                        </a:rPr>
+                        <a:t>16.071K</a:t>
+                      </a:r>
+                    </a:p>
+                  </a:txBody>
+                  <a:tcPr marL="36576" marR="36576" marT="18288" marB="18288">
+                    <a:solidFill>
+                      <a:srgbClr val="FFFFFF"/>
+                    </a:solidFill>
+                  </a:tcPr>
+                </a:tc>
+                <a:tc>
+                  <a:txBody>
+                    <a:bodyPr/>
+                    <a:lstStyle/>
+                    <a:p>
+                      <a:pPr algn="r"/>
+                      <a:r>
+                        <a:rPr sz="1000">
+                          <a:solidFill>
+                            <a:srgbClr val="3F3F3F"/>
+                          </a:solidFill>
+                          <a:latin typeface="Encode Sans"/>
+                        </a:rPr>
+                        <a:t>26.21%</a:t>
+                      </a:r>
+                    </a:p>
+                  </a:txBody>
+                  <a:tcPr marL="36576" marR="36576" marT="18288" marB="18288">
+                    <a:solidFill>
+                      <a:srgbClr val="FFFFFF"/>
+                    </a:solidFill>
+                  </a:tcPr>
+                </a:tc>
+                <a:tc>
+                  <a:txBody>
+                    <a:bodyPr/>
+                    <a:lstStyle/>
+                    <a:p>
+                      <a:pPr algn="r"/>
+                      <a:r>
+                        <a:rPr sz="1000">
+                          <a:solidFill>
+                            <a:srgbClr val="3F3F3F"/>
+                          </a:solidFill>
+                          <a:latin typeface="Encode Sans"/>
+                        </a:rPr>
+                        <a:t>—</a:t>
+                      </a:r>
+                    </a:p>
+                  </a:txBody>
+                  <a:tcPr marL="36576" marR="36576" marT="18288" marB="18288">
+                    <a:solidFill>
+                      <a:srgbClr val="FFFFFF"/>
+                    </a:solidFill>
+                  </a:tcPr>
+                </a:tc>
+              </a:tr>
+              <a:tr h="292608">
+                <a:tc>
+                  <a:txBody>
+                    <a:bodyPr/>
+                    <a:lstStyle/>
+                    <a:p>
+                      <a:pPr algn="l"/>
+                      <a:r>
+                        <a:rPr sz="1000">
+                          <a:solidFill>
+                            <a:srgbClr val="3F3F3F"/>
+                          </a:solidFill>
+                          <a:latin typeface="Encode Sans"/>
+                        </a:rPr>
+                        <a:t>Febrero 2026</a:t>
+                      </a:r>
+                    </a:p>
+                  </a:txBody>
+                  <a:tcPr marL="36576" marR="36576" marT="18288" marB="18288">
+                    <a:solidFill>
+                      <a:srgbClr val="F8F8F6"/>
+                    </a:solidFill>
+                  </a:tcPr>
+                </a:tc>
+                <a:tc>
+                  <a:txBody>
+                    <a:bodyPr/>
+                    <a:lstStyle/>
+                    <a:p>
+                      <a:pPr algn="r"/>
+                      <a:r>
+                        <a:rPr sz="1000">
+                          <a:solidFill>
+                            <a:srgbClr val="3F3F3F"/>
+                          </a:solidFill>
+                          <a:latin typeface="Encode Sans"/>
+                        </a:rPr>
+                        <a:t>16.232K</a:t>
+                      </a:r>
+                    </a:p>
+                  </a:txBody>
+                  <a:tcPr marL="36576" marR="36576" marT="18288" marB="18288">
+                    <a:solidFill>
+                      <a:srgbClr val="F8F8F6"/>
+                    </a:solidFill>
+                  </a:tcPr>
+                </a:tc>
+                <a:tc>
+                  <a:txBody>
+                    <a:bodyPr/>
+                    <a:lstStyle/>
+                    <a:p>
+                      <a:pPr algn="r"/>
+                      <a:r>
+                        <a:rPr sz="1000">
+                          <a:solidFill>
+                            <a:srgbClr val="3F3F3F"/>
+                          </a:solidFill>
+                          <a:latin typeface="Encode Sans"/>
+                        </a:rPr>
+                        <a:t>20.05%</a:t>
+                      </a:r>
+                    </a:p>
+                  </a:txBody>
+                  <a:tcPr marL="36576" marR="36576" marT="18288" marB="18288">
+                    <a:solidFill>
+                      <a:srgbClr val="F8F8F6"/>
+                    </a:solidFill>
+                  </a:tcPr>
+                </a:tc>
+                <a:tc>
+                  <a:txBody>
+                    <a:bodyPr/>
+                    <a:lstStyle/>
+                    <a:p>
+                      <a:pPr algn="r"/>
+                      <a:r>
+                        <a:rPr sz="1000">
+                          <a:solidFill>
+                            <a:srgbClr val="3F3F3F"/>
+                          </a:solidFill>
+                          <a:latin typeface="Encode Sans"/>
+                        </a:rPr>
+                        <a:t>-9.77%</a:t>
+                      </a:r>
+                    </a:p>
+                  </a:txBody>
+                  <a:tcPr marL="36576" marR="36576" marT="18288" marB="18288">
+                    <a:solidFill>
+                      <a:srgbClr val="F8F8F6"/>
+                    </a:solidFill>
+                  </a:tcPr>
+                </a:tc>
+              </a:tr>
+              <a:tr h="292608">
+                <a:tc>
+                  <a:txBody>
+                    <a:bodyPr/>
+                    <a:lstStyle/>
+                    <a:p>
+                      <a:pPr algn="l"/>
+                      <a:r>
+                        <a:rPr sz="1000">
+                          <a:solidFill>
+                            <a:srgbClr val="3F3F3F"/>
+                          </a:solidFill>
+                          <a:latin typeface="Encode Sans"/>
+                        </a:rPr>
+                        <a:t>Enero 2026</a:t>
+                      </a:r>
+                    </a:p>
+                  </a:txBody>
+                  <a:tcPr marL="36576" marR="36576" marT="18288" marB="18288">
+                    <a:solidFill>
+                      <a:srgbClr val="FFFFFF"/>
+                    </a:solidFill>
+                  </a:tcPr>
+                </a:tc>
+                <a:tc>
+                  <a:txBody>
+                    <a:bodyPr/>
+                    <a:lstStyle/>
+                    <a:p>
+                      <a:pPr algn="r"/>
+                      <a:r>
+                        <a:rPr sz="1000">
+                          <a:solidFill>
+                            <a:srgbClr val="3F3F3F"/>
+                          </a:solidFill>
+                          <a:latin typeface="Encode Sans"/>
+                        </a:rPr>
+                        <a:t>18.338K</a:t>
+                      </a:r>
+                    </a:p>
+                  </a:txBody>
+                  <a:tcPr marL="36576" marR="36576" marT="18288" marB="18288">
+                    <a:solidFill>
+                      <a:srgbClr val="FFFFFF"/>
+                    </a:solidFill>
+                  </a:tcPr>
+                </a:tc>
+                <a:tc>
+                  <a:txBody>
+                    <a:bodyPr/>
+                    <a:lstStyle/>
+                    <a:p>
+                      <a:pPr algn="r"/>
+                      <a:r>
+                        <a:rPr sz="1000">
+                          <a:solidFill>
+                            <a:srgbClr val="3F3F3F"/>
+                          </a:solidFill>
+                          <a:latin typeface="Encode Sans"/>
+                        </a:rPr>
+                        <a:t>21.99%</a:t>
+                      </a:r>
+                    </a:p>
+                  </a:txBody>
+                  <a:tcPr marL="36576" marR="36576" marT="18288" marB="18288">
+                    <a:solidFill>
+                      <a:srgbClr val="FFFFFF"/>
+                    </a:solidFill>
+                  </a:tcPr>
+                </a:tc>
+                <a:tc>
+                  <a:txBody>
+                    <a:bodyPr/>
+                    <a:lstStyle/>
+                    <a:p>
+                      <a:pPr algn="r"/>
+                      <a:r>
+                        <a:rPr sz="1000">
+                          <a:solidFill>
+                            <a:srgbClr val="3F3F3F"/>
+                          </a:solidFill>
+                          <a:latin typeface="Encode Sans"/>
+                        </a:rPr>
+                        <a:t>-7.87%</a:t>
+                      </a:r>
+                    </a:p>
+                  </a:txBody>
+                  <a:tcPr marL="36576" marR="36576" marT="18288" marB="18288">
+                    <a:solidFill>
+                      <a:srgbClr val="FFFFFF"/>
+                    </a:solidFill>
+                  </a:tcPr>
+                </a:tc>
+              </a:tr>
+              <a:tr h="292608">
+                <a:tc>
+                  <a:txBody>
+                    <a:bodyPr/>
+                    <a:lstStyle/>
+                    <a:p>
+                      <a:pPr algn="l"/>
+                      <a:r>
+                        <a:rPr sz="1000">
+                          <a:solidFill>
+                            <a:srgbClr val="3F3F3F"/>
+                          </a:solidFill>
+                          <a:latin typeface="Encode Sans"/>
+                        </a:rPr>
+                        <a:t>Diciembre 2025</a:t>
+                      </a:r>
+                    </a:p>
+                  </a:txBody>
+                  <a:tcPr marL="36576" marR="36576" marT="18288" marB="18288">
+                    <a:solidFill>
+                      <a:srgbClr val="F8F8F6"/>
+                    </a:solidFill>
+                  </a:tcPr>
+                </a:tc>
+                <a:tc>
+                  <a:txBody>
+                    <a:bodyPr/>
+                    <a:lstStyle/>
+                    <a:p>
+                      <a:pPr algn="r"/>
+                      <a:r>
+                        <a:rPr sz="1000">
+                          <a:solidFill>
+                            <a:srgbClr val="3F3F3F"/>
+                          </a:solidFill>
+                          <a:latin typeface="Encode Sans"/>
+                        </a:rPr>
+                        <a:t>16.527K</a:t>
+                      </a:r>
+                    </a:p>
+                  </a:txBody>
+                  <a:tcPr marL="36576" marR="36576" marT="18288" marB="18288">
+                    <a:solidFill>
+                      <a:srgbClr val="F8F8F6"/>
+                    </a:solidFill>
+                  </a:tcPr>
+                </a:tc>
+                <a:tc>
+                  <a:txBody>
+                    <a:bodyPr/>
+                    <a:lstStyle/>
+                    <a:p>
+                      <a:pPr algn="r"/>
+                      <a:r>
+                        <a:rPr sz="1000">
+                          <a:solidFill>
+                            <a:srgbClr val="3F3F3F"/>
+                          </a:solidFill>
+                          <a:latin typeface="Encode Sans"/>
+                        </a:rPr>
+                        <a:t>26.98%</a:t>
+                      </a:r>
+                    </a:p>
+                  </a:txBody>
+                  <a:tcPr marL="36576" marR="36576" marT="18288" marB="18288">
+                    <a:solidFill>
+                      <a:srgbClr val="F8F8F6"/>
+                    </a:solidFill>
+                  </a:tcPr>
+                </a:tc>
+                <a:tc>
+                  <a:txBody>
+                    <a:bodyPr/>
+                    <a:lstStyle/>
+                    <a:p>
+                      <a:pPr algn="r"/>
+                      <a:r>
+                        <a:rPr sz="1000">
+                          <a:solidFill>
+                            <a:srgbClr val="3F3F3F"/>
+                          </a:solidFill>
+                          <a:latin typeface="Encode Sans"/>
+                        </a:rPr>
+                        <a:t>-3.47%</a:t>
+                      </a:r>
+                    </a:p>
+                  </a:txBody>
+                  <a:tcPr marL="36576" marR="36576" marT="18288" marB="18288">
+                    <a:solidFill>
+                      <a:srgbClr val="F8F8F6"/>
+                    </a:solidFill>
+                  </a:tcPr>
+                </a:tc>
+              </a:tr>
+            </a:tbl>
+          </a:graphicData>
+        </a:graphic>
+      </p:graphicFrame>
+      <p:sp>
+        <p:nvSpPr>
+          <p:cNvPr id="9" name="TextBox 8"/>
           <p:cNvSpPr txBox="1"/>
           <p:nvPr/>
         </p:nvSpPr>
@@ -3569,7 +4305,877 @@
                 </a:solidFill>
                 <a:latin typeface="Encode Sans"/>
               </a:rPr>
-              <a:t>Fuente: elaboración propia en base a INDEC</a:t>
+              <a:t>Fuente: elaboración propia en base a AFIP/ARCA</a:t>
+            </a:r>
+          </a:p>
+        </p:txBody>
+      </p:sp>
+    </p:spTree>
+  </p:cSld>
+  <p:clrMapOvr>
+    <a:masterClrMapping/>
+  </p:clrMapOvr>
+</p:sld>
+</file>
+
+<file path=ppt/slides/slide3.xml><?xml version="1.0" encoding="utf-8"?>
+<p:sld xmlns:a="http://schemas.openxmlformats.org/drawingml/2006/main" xmlns:p="http://schemas.openxmlformats.org/presentationml/2006/main" xmlns:r="http://schemas.openxmlformats.org/officeDocument/2006/relationships">
+  <p:cSld>
+    <p:spTree>
+      <p:nvGrpSpPr>
+        <p:cNvPr id="1" name=""/>
+        <p:cNvGrpSpPr/>
+        <p:nvPr/>
+      </p:nvGrpSpPr>
+      <p:grpSpPr/>
+      <p:sp>
+        <p:nvSpPr>
+          <p:cNvPr id="2" name="Rectangle 1"/>
+          <p:cNvSpPr/>
+          <p:nvPr/>
+        </p:nvSpPr>
+        <p:spPr>
+          <a:xfrm>
+            <a:off x="0" y="0"/>
+            <a:ext cx="12191695" cy="274320"/>
+          </a:xfrm>
+          <a:prstGeom prst="rect">
+            <a:avLst/>
+          </a:prstGeom>
+          <a:solidFill>
+            <a:srgbClr val="00B2C9"/>
+          </a:solidFill>
+          <a:ln>
+            <a:noFill/>
+          </a:ln>
+        </p:spPr>
+        <p:style>
+          <a:lnRef idx="1">
+            <a:schemeClr val="accent1"/>
+          </a:lnRef>
+          <a:fillRef idx="3">
+            <a:schemeClr val="accent1"/>
+          </a:fillRef>
+          <a:effectRef idx="2">
+            <a:schemeClr val="accent1"/>
+          </a:effectRef>
+          <a:fontRef idx="minor">
+            <a:schemeClr val="lt1"/>
+          </a:fontRef>
+        </p:style>
+        <p:txBody>
+          <a:bodyPr rtlCol="0" anchor="ctr"/>
+          <a:lstStyle/>
+          <a:p>
+            <a:pPr algn="ctr"/>
+          </a:p>
+        </p:txBody>
+      </p:sp>
+      <p:sp>
+        <p:nvSpPr>
+          <p:cNvPr id="3" name="TextBox 2"/>
+          <p:cNvSpPr txBox="1"/>
+          <p:nvPr/>
+        </p:nvSpPr>
+        <p:spPr>
+          <a:xfrm>
+            <a:off x="411480" y="457200"/>
+            <a:ext cx="11368735" cy="914400"/>
+          </a:xfrm>
+          <a:prstGeom prst="rect">
+            <a:avLst/>
+          </a:prstGeom>
+          <a:noFill/>
+        </p:spPr>
+        <p:txBody>
+          <a:bodyPr wrap="square" lIns="0" rIns="0">
+            <a:spAutoFit/>
+          </a:bodyPr>
+          <a:lstStyle/>
+          <a:p>
+            <a:pPr algn="l"/>
+            <a:r>
+              <a:rPr sz="2600" b="1" i="0">
+                <a:solidFill>
+                  <a:srgbClr val="00B2C9"/>
+                </a:solidFill>
+                <a:latin typeface="Encode Sans"/>
+              </a:rPr>
+              <a:t>MORA BANCARIA ABRIL 2026: FAMILIAS 12.0% · EMPRESAS 3.3% (PRELIMINAR)</a:t>
+            </a:r>
+          </a:p>
+        </p:txBody>
+      </p:sp>
+      <p:sp>
+        <p:nvSpPr>
+          <p:cNvPr id="4" name="TextBox 3"/>
+          <p:cNvSpPr txBox="1"/>
+          <p:nvPr/>
+        </p:nvSpPr>
+        <p:spPr>
+          <a:xfrm>
+            <a:off x="411480" y="1280160"/>
+            <a:ext cx="11368735" cy="274320"/>
+          </a:xfrm>
+          <a:prstGeom prst="rect">
+            <a:avLst/>
+          </a:prstGeom>
+          <a:noFill/>
+        </p:spPr>
+        <p:txBody>
+          <a:bodyPr wrap="none">
+            <a:spAutoFit/>
+          </a:bodyPr>
+          <a:lstStyle/>
+          <a:p>
+            <a:r>
+              <a:rPr sz="1100" b="0" i="1">
+                <a:solidFill>
+                  <a:srgbClr val="6A6760"/>
+                </a:solidFill>
+                <a:latin typeface="Encode Sans"/>
+              </a:rPr>
+              <a:t>BCRA Informe sobre Bancos · período 2026-04</a:t>
+            </a:r>
+          </a:p>
+        </p:txBody>
+      </p:sp>
+      <p:sp>
+        <p:nvSpPr>
+          <p:cNvPr id="5" name="TextBox 4"/>
+          <p:cNvSpPr txBox="1"/>
+          <p:nvPr/>
+        </p:nvSpPr>
+        <p:spPr>
+          <a:xfrm>
+            <a:off x="411480" y="1691640"/>
+            <a:ext cx="5486400" cy="1645920"/>
+          </a:xfrm>
+          <a:prstGeom prst="rect">
+            <a:avLst/>
+          </a:prstGeom>
+          <a:noFill/>
+        </p:spPr>
+        <p:txBody>
+          <a:bodyPr wrap="square" lIns="0" rIns="0">
+            <a:spAutoFit/>
+          </a:bodyPr>
+          <a:lstStyle/>
+          <a:p>
+            <a:pPr algn="just"/>
+            <a:r>
+              <a:rPr sz="1300" b="0" i="0">
+                <a:solidFill>
+                  <a:srgbClr val="3F3F3F"/>
+                </a:solidFill>
+                <a:latin typeface="Encode Sans"/>
+              </a:rPr>
+              <a:t>La irregularidad de cartera alcanzó 12.0% en familias y 3.3% en empresas en abril 2026 (venía de 11.54% en marzo 2026, +0.46 pp). Dato preliminar reportado por Infobae/1816 via CENDEU; el BCRA publicará el oficial en su próximo Informe sobre Bancos.</a:t>
+            </a:r>
+          </a:p>
+        </p:txBody>
+      </p:sp>
+      <p:sp>
+        <p:nvSpPr>
+          <p:cNvPr id="6" name="TextBox 5"/>
+          <p:cNvSpPr txBox="1"/>
+          <p:nvPr/>
+        </p:nvSpPr>
+        <p:spPr>
+          <a:xfrm>
+            <a:off x="411480" y="3520440"/>
+            <a:ext cx="5486400" cy="2743200"/>
+          </a:xfrm>
+          <a:prstGeom prst="rect">
+            <a:avLst/>
+          </a:prstGeom>
+          <a:noFill/>
+        </p:spPr>
+        <p:txBody>
+          <a:bodyPr wrap="square" lIns="0" rIns="0">
+            <a:spAutoFit/>
+          </a:bodyPr>
+          <a:lstStyle/>
+          <a:p>
+            <a:pPr algn="l">
+              <a:spcAft>
+                <a:spcPts val="800"/>
+              </a:spcAft>
+            </a:pPr>
+            <a:r>
+              <a:rPr sz="1300" b="1" i="0">
+                <a:solidFill>
+                  <a:srgbClr val="00B2C9"/>
+                </a:solidFill>
+                <a:latin typeface="Encode Sans"/>
+              </a:rPr>
+              <a:t>●  </a:t>
+            </a:r>
+            <a:r>
+              <a:rPr sz="1300" b="0" i="0">
+                <a:solidFill>
+                  <a:srgbClr val="3F3F3F"/>
+                </a:solidFill>
+                <a:latin typeface="Encode Sans"/>
+              </a:rPr>
+              <a:t>Familias: 12.0% del total de préstamos en situación irregular</a:t>
+            </a:r>
+          </a:p>
+          <a:p>
+            <a:pPr algn="l">
+              <a:spcAft>
+                <a:spcPts val="800"/>
+              </a:spcAft>
+            </a:pPr>
+            <a:r>
+              <a:rPr sz="1300" b="1" i="0">
+                <a:solidFill>
+                  <a:srgbClr val="00B2C9"/>
+                </a:solidFill>
+                <a:latin typeface="Encode Sans"/>
+              </a:rPr>
+              <a:t>●  </a:t>
+            </a:r>
+            <a:r>
+              <a:rPr sz="1300" b="0" i="0">
+                <a:solidFill>
+                  <a:srgbClr val="3F3F3F"/>
+                </a:solidFill>
+                <a:latin typeface="Encode Sans"/>
+              </a:rPr>
+              <a:t>Empresas: 3.3%</a:t>
+            </a:r>
+          </a:p>
+          <a:p>
+            <a:pPr algn="l">
+              <a:spcAft>
+                <a:spcPts val="800"/>
+              </a:spcAft>
+            </a:pPr>
+            <a:r>
+              <a:rPr sz="1300" b="1" i="0">
+                <a:solidFill>
+                  <a:srgbClr val="00B2C9"/>
+                </a:solidFill>
+                <a:latin typeface="Encode Sans"/>
+              </a:rPr>
+              <a:t>●  </a:t>
+            </a:r>
+            <a:r>
+              <a:rPr sz="1300" b="0" i="0">
+                <a:solidFill>
+                  <a:srgbClr val="3F3F3F"/>
+                </a:solidFill>
+                <a:latin typeface="Encode Sans"/>
+              </a:rPr>
+              <a:t>Fuente: Infobae/1816 via CENDEU</a:t>
+            </a:r>
+          </a:p>
+          <a:p>
+            <a:pPr algn="l">
+              <a:spcAft>
+                <a:spcPts val="800"/>
+              </a:spcAft>
+            </a:pPr>
+            <a:r>
+              <a:rPr sz="1300" b="1" i="0">
+                <a:solidFill>
+                  <a:srgbClr val="00B2C9"/>
+                </a:solidFill>
+                <a:latin typeface="Encode Sans"/>
+              </a:rPr>
+              <a:t>●  </a:t>
+            </a:r>
+            <a:r>
+              <a:rPr sz="1300" b="0" i="0">
+                <a:solidFill>
+                  <a:srgbClr val="3F3F3F"/>
+                </a:solidFill>
+                <a:latin typeface="Encode Sans"/>
+              </a:rPr>
+              <a:t>⚠ Dato preliminar — sujeto a revisión cuando el BCRA publique el Informe oficial</a:t>
+            </a:r>
+          </a:p>
+        </p:txBody>
+      </p:sp>
+      <p:pic>
+        <p:nvPicPr>
+          <p:cNvPr id="7" name="Picture 6" descr="image.png"/>
+          <p:cNvPicPr>
+            <a:picLocks noChangeAspect="1"/>
+          </p:cNvPicPr>
+          <p:nvPr/>
+        </p:nvPicPr>
+        <p:blipFill>
+          <a:blip r:embed="rId2"/>
+          <a:stretch>
+            <a:fillRect/>
+          </a:stretch>
+        </p:blipFill>
+        <p:spPr>
+          <a:xfrm>
+            <a:off x="6080760" y="1691640"/>
+            <a:ext cx="5669280" cy="2560320"/>
+          </a:xfrm>
+          <a:prstGeom prst="rect">
+            <a:avLst/>
+          </a:prstGeom>
+        </p:spPr>
+      </p:pic>
+      <p:graphicFrame>
+        <p:nvGraphicFramePr>
+          <p:cNvPr id="8" name="Table 7"/>
+          <p:cNvGraphicFramePr>
+            <a:graphicFrameLocks noGrp="1"/>
+          </p:cNvGraphicFramePr>
+          <p:nvPr/>
+        </p:nvGraphicFramePr>
+        <p:xfrm>
+          <a:off x="6080760" y="4434840"/>
+          <a:ext cx="5669280" cy="2048256"/>
+        </p:xfrm>
+        <a:graphic>
+          <a:graphicData uri="http://schemas.openxmlformats.org/drawingml/2006/table">
+            <a:tbl>
+              <a:tblPr firstRow="1" bandRow="1">
+                <a:tableStyleId>{5C22544A-7EE6-4342-B048-85BDC9FD1C3A}</a:tableStyleId>
+              </a:tblPr>
+              <a:tblGrid>
+                <a:gridCol w="1889760"/>
+                <a:gridCol w="1889760"/>
+                <a:gridCol w="1889760"/>
+              </a:tblGrid>
+              <a:tr h="292608">
+                <a:tc>
+                  <a:txBody>
+                    <a:bodyPr/>
+                    <a:lstStyle/>
+                    <a:p>
+                      <a:pPr algn="l"/>
+                      <a:r>
+                        <a:rPr sz="1000" b="1">
+                          <a:solidFill>
+                            <a:srgbClr val="FFFFFF"/>
+                          </a:solidFill>
+                          <a:latin typeface="Encode Sans"/>
+                        </a:rPr>
+                        <a:t>Mes</a:t>
+                      </a:r>
+                    </a:p>
+                  </a:txBody>
+                  <a:tcPr marL="36576" marR="36576" marT="18288" marB="18288">
+                    <a:solidFill>
+                      <a:srgbClr val="00B2C9"/>
+                    </a:solidFill>
+                  </a:tcPr>
+                </a:tc>
+                <a:tc>
+                  <a:txBody>
+                    <a:bodyPr/>
+                    <a:lstStyle/>
+                    <a:p>
+                      <a:pPr algn="r"/>
+                      <a:r>
+                        <a:rPr sz="1000" b="1">
+                          <a:solidFill>
+                            <a:srgbClr val="FFFFFF"/>
+                          </a:solidFill>
+                          <a:latin typeface="Encode Sans"/>
+                        </a:rPr>
+                        <a:t>Familias %</a:t>
+                      </a:r>
+                    </a:p>
+                  </a:txBody>
+                  <a:tcPr marL="36576" marR="36576" marT="18288" marB="18288">
+                    <a:solidFill>
+                      <a:srgbClr val="00B2C9"/>
+                    </a:solidFill>
+                  </a:tcPr>
+                </a:tc>
+                <a:tc>
+                  <a:txBody>
+                    <a:bodyPr/>
+                    <a:lstStyle/>
+                    <a:p>
+                      <a:pPr algn="r"/>
+                      <a:r>
+                        <a:rPr sz="1000" b="1">
+                          <a:solidFill>
+                            <a:srgbClr val="FFFFFF"/>
+                          </a:solidFill>
+                          <a:latin typeface="Encode Sans"/>
+                        </a:rPr>
+                        <a:t>Empresas %</a:t>
+                      </a:r>
+                    </a:p>
+                  </a:txBody>
+                  <a:tcPr marL="36576" marR="36576" marT="18288" marB="18288">
+                    <a:solidFill>
+                      <a:srgbClr val="00B2C9"/>
+                    </a:solidFill>
+                  </a:tcPr>
+                </a:tc>
+              </a:tr>
+              <a:tr h="292608">
+                <a:tc>
+                  <a:txBody>
+                    <a:bodyPr/>
+                    <a:lstStyle/>
+                    <a:p>
+                      <a:pPr algn="l"/>
+                      <a:r>
+                        <a:rPr sz="1000">
+                          <a:solidFill>
+                            <a:srgbClr val="3F3F3F"/>
+                          </a:solidFill>
+                          <a:latin typeface="Encode Sans"/>
+                        </a:rPr>
+                        <a:t>Abril 2026 *</a:t>
+                      </a:r>
+                    </a:p>
+                  </a:txBody>
+                  <a:tcPr marL="36576" marR="36576" marT="18288" marB="18288">
+                    <a:solidFill>
+                      <a:srgbClr val="FFFFFF"/>
+                    </a:solidFill>
+                  </a:tcPr>
+                </a:tc>
+                <a:tc>
+                  <a:txBody>
+                    <a:bodyPr/>
+                    <a:lstStyle/>
+                    <a:p>
+                      <a:pPr algn="r"/>
+                      <a:r>
+                        <a:rPr sz="1000">
+                          <a:solidFill>
+                            <a:srgbClr val="3F3F3F"/>
+                          </a:solidFill>
+                          <a:latin typeface="Encode Sans"/>
+                        </a:rPr>
+                        <a:t>12.0%</a:t>
+                      </a:r>
+                    </a:p>
+                  </a:txBody>
+                  <a:tcPr marL="36576" marR="36576" marT="18288" marB="18288">
+                    <a:solidFill>
+                      <a:srgbClr val="FFFFFF"/>
+                    </a:solidFill>
+                  </a:tcPr>
+                </a:tc>
+                <a:tc>
+                  <a:txBody>
+                    <a:bodyPr/>
+                    <a:lstStyle/>
+                    <a:p>
+                      <a:pPr algn="r"/>
+                      <a:r>
+                        <a:rPr sz="1000">
+                          <a:solidFill>
+                            <a:srgbClr val="3F3F3F"/>
+                          </a:solidFill>
+                          <a:latin typeface="Encode Sans"/>
+                        </a:rPr>
+                        <a:t>3.3%</a:t>
+                      </a:r>
+                    </a:p>
+                  </a:txBody>
+                  <a:tcPr marL="36576" marR="36576" marT="18288" marB="18288">
+                    <a:solidFill>
+                      <a:srgbClr val="FFFFFF"/>
+                    </a:solidFill>
+                  </a:tcPr>
+                </a:tc>
+              </a:tr>
+              <a:tr h="292608">
+                <a:tc>
+                  <a:txBody>
+                    <a:bodyPr/>
+                    <a:lstStyle/>
+                    <a:p>
+                      <a:pPr algn="l"/>
+                      <a:r>
+                        <a:rPr sz="1000">
+                          <a:solidFill>
+                            <a:srgbClr val="3F3F3F"/>
+                          </a:solidFill>
+                          <a:latin typeface="Encode Sans"/>
+                        </a:rPr>
+                        <a:t>Marzo 2026</a:t>
+                      </a:r>
+                    </a:p>
+                  </a:txBody>
+                  <a:tcPr marL="36576" marR="36576" marT="18288" marB="18288">
+                    <a:solidFill>
+                      <a:srgbClr val="F8F8F6"/>
+                    </a:solidFill>
+                  </a:tcPr>
+                </a:tc>
+                <a:tc>
+                  <a:txBody>
+                    <a:bodyPr/>
+                    <a:lstStyle/>
+                    <a:p>
+                      <a:pPr algn="r"/>
+                      <a:r>
+                        <a:rPr sz="1000">
+                          <a:solidFill>
+                            <a:srgbClr val="3F3F3F"/>
+                          </a:solidFill>
+                          <a:latin typeface="Encode Sans"/>
+                        </a:rPr>
+                        <a:t>11.54%</a:t>
+                      </a:r>
+                    </a:p>
+                  </a:txBody>
+                  <a:tcPr marL="36576" marR="36576" marT="18288" marB="18288">
+                    <a:solidFill>
+                      <a:srgbClr val="F8F8F6"/>
+                    </a:solidFill>
+                  </a:tcPr>
+                </a:tc>
+                <a:tc>
+                  <a:txBody>
+                    <a:bodyPr/>
+                    <a:lstStyle/>
+                    <a:p>
+                      <a:pPr algn="r"/>
+                      <a:r>
+                        <a:rPr sz="1000">
+                          <a:solidFill>
+                            <a:srgbClr val="3F3F3F"/>
+                          </a:solidFill>
+                          <a:latin typeface="Encode Sans"/>
+                        </a:rPr>
+                        <a:t>3.13%</a:t>
+                      </a:r>
+                    </a:p>
+                  </a:txBody>
+                  <a:tcPr marL="36576" marR="36576" marT="18288" marB="18288">
+                    <a:solidFill>
+                      <a:srgbClr val="F8F8F6"/>
+                    </a:solidFill>
+                  </a:tcPr>
+                </a:tc>
+              </a:tr>
+              <a:tr h="292608">
+                <a:tc>
+                  <a:txBody>
+                    <a:bodyPr/>
+                    <a:lstStyle/>
+                    <a:p>
+                      <a:pPr algn="l"/>
+                      <a:r>
+                        <a:rPr sz="1000">
+                          <a:solidFill>
+                            <a:srgbClr val="3F3F3F"/>
+                          </a:solidFill>
+                          <a:latin typeface="Encode Sans"/>
+                        </a:rPr>
+                        <a:t>Febrero 2026</a:t>
+                      </a:r>
+                    </a:p>
+                  </a:txBody>
+                  <a:tcPr marL="36576" marR="36576" marT="18288" marB="18288">
+                    <a:solidFill>
+                      <a:srgbClr val="FFFFFF"/>
+                    </a:solidFill>
+                  </a:tcPr>
+                </a:tc>
+                <a:tc>
+                  <a:txBody>
+                    <a:bodyPr/>
+                    <a:lstStyle/>
+                    <a:p>
+                      <a:pPr algn="r"/>
+                      <a:r>
+                        <a:rPr sz="1000">
+                          <a:solidFill>
+                            <a:srgbClr val="3F3F3F"/>
+                          </a:solidFill>
+                          <a:latin typeface="Encode Sans"/>
+                        </a:rPr>
+                        <a:t>11.22%</a:t>
+                      </a:r>
+                    </a:p>
+                  </a:txBody>
+                  <a:tcPr marL="36576" marR="36576" marT="18288" marB="18288">
+                    <a:solidFill>
+                      <a:srgbClr val="FFFFFF"/>
+                    </a:solidFill>
+                  </a:tcPr>
+                </a:tc>
+                <a:tc>
+                  <a:txBody>
+                    <a:bodyPr/>
+                    <a:lstStyle/>
+                    <a:p>
+                      <a:pPr algn="r"/>
+                      <a:r>
+                        <a:rPr sz="1000">
+                          <a:solidFill>
+                            <a:srgbClr val="3F3F3F"/>
+                          </a:solidFill>
+                          <a:latin typeface="Encode Sans"/>
+                        </a:rPr>
+                        <a:t>2.92%</a:t>
+                      </a:r>
+                    </a:p>
+                  </a:txBody>
+                  <a:tcPr marL="36576" marR="36576" marT="18288" marB="18288">
+                    <a:solidFill>
+                      <a:srgbClr val="FFFFFF"/>
+                    </a:solidFill>
+                  </a:tcPr>
+                </a:tc>
+              </a:tr>
+              <a:tr h="292608">
+                <a:tc>
+                  <a:txBody>
+                    <a:bodyPr/>
+                    <a:lstStyle/>
+                    <a:p>
+                      <a:pPr algn="l"/>
+                      <a:r>
+                        <a:rPr sz="1000">
+                          <a:solidFill>
+                            <a:srgbClr val="3F3F3F"/>
+                          </a:solidFill>
+                          <a:latin typeface="Encode Sans"/>
+                        </a:rPr>
+                        <a:t>Enero 2026</a:t>
+                      </a:r>
+                    </a:p>
+                  </a:txBody>
+                  <a:tcPr marL="36576" marR="36576" marT="18288" marB="18288">
+                    <a:solidFill>
+                      <a:srgbClr val="F8F8F6"/>
+                    </a:solidFill>
+                  </a:tcPr>
+                </a:tc>
+                <a:tc>
+                  <a:txBody>
+                    <a:bodyPr/>
+                    <a:lstStyle/>
+                    <a:p>
+                      <a:pPr algn="r"/>
+                      <a:r>
+                        <a:rPr sz="1000">
+                          <a:solidFill>
+                            <a:srgbClr val="3F3F3F"/>
+                          </a:solidFill>
+                          <a:latin typeface="Encode Sans"/>
+                        </a:rPr>
+                        <a:t>10.61%</a:t>
+                      </a:r>
+                    </a:p>
+                  </a:txBody>
+                  <a:tcPr marL="36576" marR="36576" marT="18288" marB="18288">
+                    <a:solidFill>
+                      <a:srgbClr val="F8F8F6"/>
+                    </a:solidFill>
+                  </a:tcPr>
+                </a:tc>
+                <a:tc>
+                  <a:txBody>
+                    <a:bodyPr/>
+                    <a:lstStyle/>
+                    <a:p>
+                      <a:pPr algn="r"/>
+                      <a:r>
+                        <a:rPr sz="1000">
+                          <a:solidFill>
+                            <a:srgbClr val="3F3F3F"/>
+                          </a:solidFill>
+                          <a:latin typeface="Encode Sans"/>
+                        </a:rPr>
+                        <a:t>2.85%</a:t>
+                      </a:r>
+                    </a:p>
+                  </a:txBody>
+                  <a:tcPr marL="36576" marR="36576" marT="18288" marB="18288">
+                    <a:solidFill>
+                      <a:srgbClr val="F8F8F6"/>
+                    </a:solidFill>
+                  </a:tcPr>
+                </a:tc>
+              </a:tr>
+              <a:tr h="292608">
+                <a:tc>
+                  <a:txBody>
+                    <a:bodyPr/>
+                    <a:lstStyle/>
+                    <a:p>
+                      <a:pPr algn="l"/>
+                      <a:r>
+                        <a:rPr sz="1000">
+                          <a:solidFill>
+                            <a:srgbClr val="3F3F3F"/>
+                          </a:solidFill>
+                          <a:latin typeface="Encode Sans"/>
+                        </a:rPr>
+                        <a:t>Diciembre 2025</a:t>
+                      </a:r>
+                    </a:p>
+                  </a:txBody>
+                  <a:tcPr marL="36576" marR="36576" marT="18288" marB="18288">
+                    <a:solidFill>
+                      <a:srgbClr val="FFFFFF"/>
+                    </a:solidFill>
+                  </a:tcPr>
+                </a:tc>
+                <a:tc>
+                  <a:txBody>
+                    <a:bodyPr/>
+                    <a:lstStyle/>
+                    <a:p>
+                      <a:pPr algn="r"/>
+                      <a:r>
+                        <a:rPr sz="1000">
+                          <a:solidFill>
+                            <a:srgbClr val="3F3F3F"/>
+                          </a:solidFill>
+                          <a:latin typeface="Encode Sans"/>
+                        </a:rPr>
+                        <a:t>9.33%</a:t>
+                      </a:r>
+                    </a:p>
+                  </a:txBody>
+                  <a:tcPr marL="36576" marR="36576" marT="18288" marB="18288">
+                    <a:solidFill>
+                      <a:srgbClr val="FFFFFF"/>
+                    </a:solidFill>
+                  </a:tcPr>
+                </a:tc>
+                <a:tc>
+                  <a:txBody>
+                    <a:bodyPr/>
+                    <a:lstStyle/>
+                    <a:p>
+                      <a:pPr algn="r"/>
+                      <a:r>
+                        <a:rPr sz="1000">
+                          <a:solidFill>
+                            <a:srgbClr val="3F3F3F"/>
+                          </a:solidFill>
+                          <a:latin typeface="Encode Sans"/>
+                        </a:rPr>
+                        <a:t>2.53%</a:t>
+                      </a:r>
+                    </a:p>
+                  </a:txBody>
+                  <a:tcPr marL="36576" marR="36576" marT="18288" marB="18288">
+                    <a:solidFill>
+                      <a:srgbClr val="FFFFFF"/>
+                    </a:solidFill>
+                  </a:tcPr>
+                </a:tc>
+              </a:tr>
+              <a:tr h="292608">
+                <a:tc>
+                  <a:txBody>
+                    <a:bodyPr/>
+                    <a:lstStyle/>
+                    <a:p>
+                      <a:pPr algn="l"/>
+                      <a:r>
+                        <a:rPr sz="1000">
+                          <a:solidFill>
+                            <a:srgbClr val="3F3F3F"/>
+                          </a:solidFill>
+                          <a:latin typeface="Encode Sans"/>
+                        </a:rPr>
+                        <a:t>Noviembre 2025</a:t>
+                      </a:r>
+                    </a:p>
+                  </a:txBody>
+                  <a:tcPr marL="36576" marR="36576" marT="18288" marB="18288">
+                    <a:solidFill>
+                      <a:srgbClr val="F8F8F6"/>
+                    </a:solidFill>
+                  </a:tcPr>
+                </a:tc>
+                <a:tc>
+                  <a:txBody>
+                    <a:bodyPr/>
+                    <a:lstStyle/>
+                    <a:p>
+                      <a:pPr algn="r"/>
+                      <a:r>
+                        <a:rPr sz="1000">
+                          <a:solidFill>
+                            <a:srgbClr val="3F3F3F"/>
+                          </a:solidFill>
+                          <a:latin typeface="Encode Sans"/>
+                        </a:rPr>
+                        <a:t>8.82%</a:t>
+                      </a:r>
+                    </a:p>
+                  </a:txBody>
+                  <a:tcPr marL="36576" marR="36576" marT="18288" marB="18288">
+                    <a:solidFill>
+                      <a:srgbClr val="F8F8F6"/>
+                    </a:solidFill>
+                  </a:tcPr>
+                </a:tc>
+                <a:tc>
+                  <a:txBody>
+                    <a:bodyPr/>
+                    <a:lstStyle/>
+                    <a:p>
+                      <a:pPr algn="r"/>
+                      <a:r>
+                        <a:rPr sz="1000">
+                          <a:solidFill>
+                            <a:srgbClr val="3F3F3F"/>
+                          </a:solidFill>
+                          <a:latin typeface="Encode Sans"/>
+                        </a:rPr>
+                        <a:t>2.29%</a:t>
+                      </a:r>
+                    </a:p>
+                  </a:txBody>
+                  <a:tcPr marL="36576" marR="36576" marT="18288" marB="18288">
+                    <a:solidFill>
+                      <a:srgbClr val="F8F8F6"/>
+                    </a:solidFill>
+                  </a:tcPr>
+                </a:tc>
+              </a:tr>
+            </a:tbl>
+          </a:graphicData>
+        </a:graphic>
+      </p:graphicFrame>
+      <p:sp>
+        <p:nvSpPr>
+          <p:cNvPr id="9" name="TextBox 8"/>
+          <p:cNvSpPr txBox="1"/>
+          <p:nvPr/>
+        </p:nvSpPr>
+        <p:spPr>
+          <a:xfrm>
+            <a:off x="411480" y="6492240"/>
+            <a:ext cx="11368735" cy="274320"/>
+          </a:xfrm>
+          <a:prstGeom prst="rect">
+            <a:avLst/>
+          </a:prstGeom>
+          <a:noFill/>
+        </p:spPr>
+        <p:txBody>
+          <a:bodyPr wrap="none">
+            <a:spAutoFit/>
+          </a:bodyPr>
+          <a:lstStyle/>
+          <a:p>
+            <a:r>
+              <a:rPr sz="1000" b="0" i="1">
+                <a:solidFill>
+                  <a:srgbClr val="6A6760"/>
+                </a:solidFill>
+                <a:latin typeface="Encode Sans"/>
+              </a:rPr>
+              <a:t>Fuente: elaboración propia en base a BCRA Informe sobre Bancos</a:t>
             </a:r>
           </a:p>
         </p:txBody>

</xml_diff>

<commit_message>
data: update 2026-06-03 ( data.json despidos.json scraper/historical_despidos.json publicaciones_semana.pptx)
</commit_message>
<xml_diff>
--- a/publicaciones_semana.pptx
+++ b/publicaciones_semana.pptx
@@ -4470,7 +4470,7 @@
                 </a:solidFill>
                 <a:latin typeface="Encode Sans"/>
               </a:rPr>
-              <a:t>La irregularidad de cartera alcanzó 12.0% en familias y 3.3% en empresas en abril 2026 (venía de 11.54% en marzo 2026, +0.46 pp). Dato preliminar reportado por Infobae/1816 via CENDEU; el BCRA publicará el oficial en su próximo Informe sobre Bancos.</a:t>
+              <a:t>La irregularidad de cartera alcanzó 12.0% en familias y 3.3% en empresas en abril 2026. Dato preliminar reportado por Infobae/1816 via CENDEU; el BCRA publicará el oficial en su próximo Informe sobre Bancos.</a:t>
             </a:r>
           </a:p>
         </p:txBody>
@@ -4632,7 +4632,7 @@
         </p:nvGraphicFramePr>
         <p:xfrm>
           <a:off x="6080760" y="4434840"/>
-          <a:ext cx="5669280" cy="2048256"/>
+          <a:ext cx="5669280" cy="585216"/>
         </p:xfrm>
         <a:graphic>
           <a:graphicData uri="http://schemas.openxmlformats.org/drawingml/2006/table">
@@ -4783,361 +4783,6 @@
                   <a:tcPr marL="36576" marR="36576" marT="18288" marB="18288">
                     <a:solidFill>
                       <a:srgbClr val="FFFFFF"/>
-                    </a:solidFill>
-                  </a:tcPr>
-                </a:tc>
-              </a:tr>
-              <a:tr h="292608">
-                <a:tc>
-                  <a:txBody>
-                    <a:bodyPr/>
-                    <a:lstStyle/>
-                    <a:p>
-                      <a:pPr algn="l"/>
-                      <a:r>
-                        <a:rPr sz="1000">
-                          <a:solidFill>
-                            <a:srgbClr val="3F3F3F"/>
-                          </a:solidFill>
-                          <a:latin typeface="Encode Sans"/>
-                        </a:rPr>
-                        <a:t>Marzo 2026</a:t>
-                      </a:r>
-                    </a:p>
-                  </a:txBody>
-                  <a:tcPr marL="36576" marR="36576" marT="18288" marB="18288">
-                    <a:solidFill>
-                      <a:srgbClr val="F8F8F6"/>
-                    </a:solidFill>
-                  </a:tcPr>
-                </a:tc>
-                <a:tc>
-                  <a:txBody>
-                    <a:bodyPr/>
-                    <a:lstStyle/>
-                    <a:p>
-                      <a:pPr algn="r"/>
-                      <a:r>
-                        <a:rPr sz="1000">
-                          <a:solidFill>
-                            <a:srgbClr val="3F3F3F"/>
-                          </a:solidFill>
-                          <a:latin typeface="Encode Sans"/>
-                        </a:rPr>
-                        <a:t>11.54%</a:t>
-                      </a:r>
-                    </a:p>
-                  </a:txBody>
-                  <a:tcPr marL="36576" marR="36576" marT="18288" marB="18288">
-                    <a:solidFill>
-                      <a:srgbClr val="F8F8F6"/>
-                    </a:solidFill>
-                  </a:tcPr>
-                </a:tc>
-                <a:tc>
-                  <a:txBody>
-                    <a:bodyPr/>
-                    <a:lstStyle/>
-                    <a:p>
-                      <a:pPr algn="r"/>
-                      <a:r>
-                        <a:rPr sz="1000">
-                          <a:solidFill>
-                            <a:srgbClr val="3F3F3F"/>
-                          </a:solidFill>
-                          <a:latin typeface="Encode Sans"/>
-                        </a:rPr>
-                        <a:t>3.13%</a:t>
-                      </a:r>
-                    </a:p>
-                  </a:txBody>
-                  <a:tcPr marL="36576" marR="36576" marT="18288" marB="18288">
-                    <a:solidFill>
-                      <a:srgbClr val="F8F8F6"/>
-                    </a:solidFill>
-                  </a:tcPr>
-                </a:tc>
-              </a:tr>
-              <a:tr h="292608">
-                <a:tc>
-                  <a:txBody>
-                    <a:bodyPr/>
-                    <a:lstStyle/>
-                    <a:p>
-                      <a:pPr algn="l"/>
-                      <a:r>
-                        <a:rPr sz="1000">
-                          <a:solidFill>
-                            <a:srgbClr val="3F3F3F"/>
-                          </a:solidFill>
-                          <a:latin typeface="Encode Sans"/>
-                        </a:rPr>
-                        <a:t>Febrero 2026</a:t>
-                      </a:r>
-                    </a:p>
-                  </a:txBody>
-                  <a:tcPr marL="36576" marR="36576" marT="18288" marB="18288">
-                    <a:solidFill>
-                      <a:srgbClr val="FFFFFF"/>
-                    </a:solidFill>
-                  </a:tcPr>
-                </a:tc>
-                <a:tc>
-                  <a:txBody>
-                    <a:bodyPr/>
-                    <a:lstStyle/>
-                    <a:p>
-                      <a:pPr algn="r"/>
-                      <a:r>
-                        <a:rPr sz="1000">
-                          <a:solidFill>
-                            <a:srgbClr val="3F3F3F"/>
-                          </a:solidFill>
-                          <a:latin typeface="Encode Sans"/>
-                        </a:rPr>
-                        <a:t>11.22%</a:t>
-                      </a:r>
-                    </a:p>
-                  </a:txBody>
-                  <a:tcPr marL="36576" marR="36576" marT="18288" marB="18288">
-                    <a:solidFill>
-                      <a:srgbClr val="FFFFFF"/>
-                    </a:solidFill>
-                  </a:tcPr>
-                </a:tc>
-                <a:tc>
-                  <a:txBody>
-                    <a:bodyPr/>
-                    <a:lstStyle/>
-                    <a:p>
-                      <a:pPr algn="r"/>
-                      <a:r>
-                        <a:rPr sz="1000">
-                          <a:solidFill>
-                            <a:srgbClr val="3F3F3F"/>
-                          </a:solidFill>
-                          <a:latin typeface="Encode Sans"/>
-                        </a:rPr>
-                        <a:t>2.92%</a:t>
-                      </a:r>
-                    </a:p>
-                  </a:txBody>
-                  <a:tcPr marL="36576" marR="36576" marT="18288" marB="18288">
-                    <a:solidFill>
-                      <a:srgbClr val="FFFFFF"/>
-                    </a:solidFill>
-                  </a:tcPr>
-                </a:tc>
-              </a:tr>
-              <a:tr h="292608">
-                <a:tc>
-                  <a:txBody>
-                    <a:bodyPr/>
-                    <a:lstStyle/>
-                    <a:p>
-                      <a:pPr algn="l"/>
-                      <a:r>
-                        <a:rPr sz="1000">
-                          <a:solidFill>
-                            <a:srgbClr val="3F3F3F"/>
-                          </a:solidFill>
-                          <a:latin typeface="Encode Sans"/>
-                        </a:rPr>
-                        <a:t>Enero 2026</a:t>
-                      </a:r>
-                    </a:p>
-                  </a:txBody>
-                  <a:tcPr marL="36576" marR="36576" marT="18288" marB="18288">
-                    <a:solidFill>
-                      <a:srgbClr val="F8F8F6"/>
-                    </a:solidFill>
-                  </a:tcPr>
-                </a:tc>
-                <a:tc>
-                  <a:txBody>
-                    <a:bodyPr/>
-                    <a:lstStyle/>
-                    <a:p>
-                      <a:pPr algn="r"/>
-                      <a:r>
-                        <a:rPr sz="1000">
-                          <a:solidFill>
-                            <a:srgbClr val="3F3F3F"/>
-                          </a:solidFill>
-                          <a:latin typeface="Encode Sans"/>
-                        </a:rPr>
-                        <a:t>10.61%</a:t>
-                      </a:r>
-                    </a:p>
-                  </a:txBody>
-                  <a:tcPr marL="36576" marR="36576" marT="18288" marB="18288">
-                    <a:solidFill>
-                      <a:srgbClr val="F8F8F6"/>
-                    </a:solidFill>
-                  </a:tcPr>
-                </a:tc>
-                <a:tc>
-                  <a:txBody>
-                    <a:bodyPr/>
-                    <a:lstStyle/>
-                    <a:p>
-                      <a:pPr algn="r"/>
-                      <a:r>
-                        <a:rPr sz="1000">
-                          <a:solidFill>
-                            <a:srgbClr val="3F3F3F"/>
-                          </a:solidFill>
-                          <a:latin typeface="Encode Sans"/>
-                        </a:rPr>
-                        <a:t>2.85%</a:t>
-                      </a:r>
-                    </a:p>
-                  </a:txBody>
-                  <a:tcPr marL="36576" marR="36576" marT="18288" marB="18288">
-                    <a:solidFill>
-                      <a:srgbClr val="F8F8F6"/>
-                    </a:solidFill>
-                  </a:tcPr>
-                </a:tc>
-              </a:tr>
-              <a:tr h="292608">
-                <a:tc>
-                  <a:txBody>
-                    <a:bodyPr/>
-                    <a:lstStyle/>
-                    <a:p>
-                      <a:pPr algn="l"/>
-                      <a:r>
-                        <a:rPr sz="1000">
-                          <a:solidFill>
-                            <a:srgbClr val="3F3F3F"/>
-                          </a:solidFill>
-                          <a:latin typeface="Encode Sans"/>
-                        </a:rPr>
-                        <a:t>Diciembre 2025</a:t>
-                      </a:r>
-                    </a:p>
-                  </a:txBody>
-                  <a:tcPr marL="36576" marR="36576" marT="18288" marB="18288">
-                    <a:solidFill>
-                      <a:srgbClr val="FFFFFF"/>
-                    </a:solidFill>
-                  </a:tcPr>
-                </a:tc>
-                <a:tc>
-                  <a:txBody>
-                    <a:bodyPr/>
-                    <a:lstStyle/>
-                    <a:p>
-                      <a:pPr algn="r"/>
-                      <a:r>
-                        <a:rPr sz="1000">
-                          <a:solidFill>
-                            <a:srgbClr val="3F3F3F"/>
-                          </a:solidFill>
-                          <a:latin typeface="Encode Sans"/>
-                        </a:rPr>
-                        <a:t>9.33%</a:t>
-                      </a:r>
-                    </a:p>
-                  </a:txBody>
-                  <a:tcPr marL="36576" marR="36576" marT="18288" marB="18288">
-                    <a:solidFill>
-                      <a:srgbClr val="FFFFFF"/>
-                    </a:solidFill>
-                  </a:tcPr>
-                </a:tc>
-                <a:tc>
-                  <a:txBody>
-                    <a:bodyPr/>
-                    <a:lstStyle/>
-                    <a:p>
-                      <a:pPr algn="r"/>
-                      <a:r>
-                        <a:rPr sz="1000">
-                          <a:solidFill>
-                            <a:srgbClr val="3F3F3F"/>
-                          </a:solidFill>
-                          <a:latin typeface="Encode Sans"/>
-                        </a:rPr>
-                        <a:t>2.53%</a:t>
-                      </a:r>
-                    </a:p>
-                  </a:txBody>
-                  <a:tcPr marL="36576" marR="36576" marT="18288" marB="18288">
-                    <a:solidFill>
-                      <a:srgbClr val="FFFFFF"/>
-                    </a:solidFill>
-                  </a:tcPr>
-                </a:tc>
-              </a:tr>
-              <a:tr h="292608">
-                <a:tc>
-                  <a:txBody>
-                    <a:bodyPr/>
-                    <a:lstStyle/>
-                    <a:p>
-                      <a:pPr algn="l"/>
-                      <a:r>
-                        <a:rPr sz="1000">
-                          <a:solidFill>
-                            <a:srgbClr val="3F3F3F"/>
-                          </a:solidFill>
-                          <a:latin typeface="Encode Sans"/>
-                        </a:rPr>
-                        <a:t>Noviembre 2025</a:t>
-                      </a:r>
-                    </a:p>
-                  </a:txBody>
-                  <a:tcPr marL="36576" marR="36576" marT="18288" marB="18288">
-                    <a:solidFill>
-                      <a:srgbClr val="F8F8F6"/>
-                    </a:solidFill>
-                  </a:tcPr>
-                </a:tc>
-                <a:tc>
-                  <a:txBody>
-                    <a:bodyPr/>
-                    <a:lstStyle/>
-                    <a:p>
-                      <a:pPr algn="r"/>
-                      <a:r>
-                        <a:rPr sz="1000">
-                          <a:solidFill>
-                            <a:srgbClr val="3F3F3F"/>
-                          </a:solidFill>
-                          <a:latin typeface="Encode Sans"/>
-                        </a:rPr>
-                        <a:t>8.82%</a:t>
-                      </a:r>
-                    </a:p>
-                  </a:txBody>
-                  <a:tcPr marL="36576" marR="36576" marT="18288" marB="18288">
-                    <a:solidFill>
-                      <a:srgbClr val="F8F8F6"/>
-                    </a:solidFill>
-                  </a:tcPr>
-                </a:tc>
-                <a:tc>
-                  <a:txBody>
-                    <a:bodyPr/>
-                    <a:lstStyle/>
-                    <a:p>
-                      <a:pPr algn="r"/>
-                      <a:r>
-                        <a:rPr sz="1000">
-                          <a:solidFill>
-                            <a:srgbClr val="3F3F3F"/>
-                          </a:solidFill>
-                          <a:latin typeface="Encode Sans"/>
-                        </a:rPr>
-                        <a:t>2.29%</a:t>
-                      </a:r>
-                    </a:p>
-                  </a:txBody>
-                  <a:tcPr marL="36576" marR="36576" marT="18288" marB="18288">
-                    <a:solidFill>
-                      <a:srgbClr val="F8F8F6"/>
                     </a:solidFill>
                   </a:tcPr>
                 </a:tc>

</xml_diff>

<commit_message>
data.json: restaurar serie completa mora (196 records) tras fix scraper
El cron del 3-4 jun habia commiteado data.json con mora=[1 record] (solo prov).
Esta corrida con scraper fixed regenera con 196 registros completos.
</commit_message>
<xml_diff>
--- a/publicaciones_semana.pptx
+++ b/publicaciones_semana.pptx
@@ -4470,7 +4470,7 @@
                 </a:solidFill>
                 <a:latin typeface="Encode Sans"/>
               </a:rPr>
-              <a:t>La irregularidad de cartera alcanzó 12.0% en familias y 3.3% en empresas en abril 2026. Dato preliminar reportado por Infobae/1816 via CENDEU; el BCRA publicará el oficial en su próximo Informe sobre Bancos.</a:t>
+              <a:t>La irregularidad de cartera alcanzó 12.0% en familias y 3.3% en empresas en abril 2026 (venía de 11.54% en marzo 2026, +0.46 pp). Dato preliminar reportado por Infobae/1816 via CENDEU; el BCRA publicará el oficial en su próximo Informe sobre Bancos.</a:t>
             </a:r>
           </a:p>
         </p:txBody>
@@ -4632,7 +4632,7 @@
         </p:nvGraphicFramePr>
         <p:xfrm>
           <a:off x="6080760" y="4434840"/>
-          <a:ext cx="5669280" cy="585216"/>
+          <a:ext cx="5669280" cy="2048256"/>
         </p:xfrm>
         <a:graphic>
           <a:graphicData uri="http://schemas.openxmlformats.org/drawingml/2006/table">
@@ -4783,6 +4783,361 @@
                   <a:tcPr marL="36576" marR="36576" marT="18288" marB="18288">
                     <a:solidFill>
                       <a:srgbClr val="FFFFFF"/>
+                    </a:solidFill>
+                  </a:tcPr>
+                </a:tc>
+              </a:tr>
+              <a:tr h="292608">
+                <a:tc>
+                  <a:txBody>
+                    <a:bodyPr/>
+                    <a:lstStyle/>
+                    <a:p>
+                      <a:pPr algn="l"/>
+                      <a:r>
+                        <a:rPr sz="1000">
+                          <a:solidFill>
+                            <a:srgbClr val="3F3F3F"/>
+                          </a:solidFill>
+                          <a:latin typeface="Encode Sans"/>
+                        </a:rPr>
+                        <a:t>Marzo 2026</a:t>
+                      </a:r>
+                    </a:p>
+                  </a:txBody>
+                  <a:tcPr marL="36576" marR="36576" marT="18288" marB="18288">
+                    <a:solidFill>
+                      <a:srgbClr val="F8F8F6"/>
+                    </a:solidFill>
+                  </a:tcPr>
+                </a:tc>
+                <a:tc>
+                  <a:txBody>
+                    <a:bodyPr/>
+                    <a:lstStyle/>
+                    <a:p>
+                      <a:pPr algn="r"/>
+                      <a:r>
+                        <a:rPr sz="1000">
+                          <a:solidFill>
+                            <a:srgbClr val="3F3F3F"/>
+                          </a:solidFill>
+                          <a:latin typeface="Encode Sans"/>
+                        </a:rPr>
+                        <a:t>11.54%</a:t>
+                      </a:r>
+                    </a:p>
+                  </a:txBody>
+                  <a:tcPr marL="36576" marR="36576" marT="18288" marB="18288">
+                    <a:solidFill>
+                      <a:srgbClr val="F8F8F6"/>
+                    </a:solidFill>
+                  </a:tcPr>
+                </a:tc>
+                <a:tc>
+                  <a:txBody>
+                    <a:bodyPr/>
+                    <a:lstStyle/>
+                    <a:p>
+                      <a:pPr algn="r"/>
+                      <a:r>
+                        <a:rPr sz="1000">
+                          <a:solidFill>
+                            <a:srgbClr val="3F3F3F"/>
+                          </a:solidFill>
+                          <a:latin typeface="Encode Sans"/>
+                        </a:rPr>
+                        <a:t>3.13%</a:t>
+                      </a:r>
+                    </a:p>
+                  </a:txBody>
+                  <a:tcPr marL="36576" marR="36576" marT="18288" marB="18288">
+                    <a:solidFill>
+                      <a:srgbClr val="F8F8F6"/>
+                    </a:solidFill>
+                  </a:tcPr>
+                </a:tc>
+              </a:tr>
+              <a:tr h="292608">
+                <a:tc>
+                  <a:txBody>
+                    <a:bodyPr/>
+                    <a:lstStyle/>
+                    <a:p>
+                      <a:pPr algn="l"/>
+                      <a:r>
+                        <a:rPr sz="1000">
+                          <a:solidFill>
+                            <a:srgbClr val="3F3F3F"/>
+                          </a:solidFill>
+                          <a:latin typeface="Encode Sans"/>
+                        </a:rPr>
+                        <a:t>Febrero 2026</a:t>
+                      </a:r>
+                    </a:p>
+                  </a:txBody>
+                  <a:tcPr marL="36576" marR="36576" marT="18288" marB="18288">
+                    <a:solidFill>
+                      <a:srgbClr val="FFFFFF"/>
+                    </a:solidFill>
+                  </a:tcPr>
+                </a:tc>
+                <a:tc>
+                  <a:txBody>
+                    <a:bodyPr/>
+                    <a:lstStyle/>
+                    <a:p>
+                      <a:pPr algn="r"/>
+                      <a:r>
+                        <a:rPr sz="1000">
+                          <a:solidFill>
+                            <a:srgbClr val="3F3F3F"/>
+                          </a:solidFill>
+                          <a:latin typeface="Encode Sans"/>
+                        </a:rPr>
+                        <a:t>11.22%</a:t>
+                      </a:r>
+                    </a:p>
+                  </a:txBody>
+                  <a:tcPr marL="36576" marR="36576" marT="18288" marB="18288">
+                    <a:solidFill>
+                      <a:srgbClr val="FFFFFF"/>
+                    </a:solidFill>
+                  </a:tcPr>
+                </a:tc>
+                <a:tc>
+                  <a:txBody>
+                    <a:bodyPr/>
+                    <a:lstStyle/>
+                    <a:p>
+                      <a:pPr algn="r"/>
+                      <a:r>
+                        <a:rPr sz="1000">
+                          <a:solidFill>
+                            <a:srgbClr val="3F3F3F"/>
+                          </a:solidFill>
+                          <a:latin typeface="Encode Sans"/>
+                        </a:rPr>
+                        <a:t>2.92%</a:t>
+                      </a:r>
+                    </a:p>
+                  </a:txBody>
+                  <a:tcPr marL="36576" marR="36576" marT="18288" marB="18288">
+                    <a:solidFill>
+                      <a:srgbClr val="FFFFFF"/>
+                    </a:solidFill>
+                  </a:tcPr>
+                </a:tc>
+              </a:tr>
+              <a:tr h="292608">
+                <a:tc>
+                  <a:txBody>
+                    <a:bodyPr/>
+                    <a:lstStyle/>
+                    <a:p>
+                      <a:pPr algn="l"/>
+                      <a:r>
+                        <a:rPr sz="1000">
+                          <a:solidFill>
+                            <a:srgbClr val="3F3F3F"/>
+                          </a:solidFill>
+                          <a:latin typeface="Encode Sans"/>
+                        </a:rPr>
+                        <a:t>Enero 2026</a:t>
+                      </a:r>
+                    </a:p>
+                  </a:txBody>
+                  <a:tcPr marL="36576" marR="36576" marT="18288" marB="18288">
+                    <a:solidFill>
+                      <a:srgbClr val="F8F8F6"/>
+                    </a:solidFill>
+                  </a:tcPr>
+                </a:tc>
+                <a:tc>
+                  <a:txBody>
+                    <a:bodyPr/>
+                    <a:lstStyle/>
+                    <a:p>
+                      <a:pPr algn="r"/>
+                      <a:r>
+                        <a:rPr sz="1000">
+                          <a:solidFill>
+                            <a:srgbClr val="3F3F3F"/>
+                          </a:solidFill>
+                          <a:latin typeface="Encode Sans"/>
+                        </a:rPr>
+                        <a:t>10.61%</a:t>
+                      </a:r>
+                    </a:p>
+                  </a:txBody>
+                  <a:tcPr marL="36576" marR="36576" marT="18288" marB="18288">
+                    <a:solidFill>
+                      <a:srgbClr val="F8F8F6"/>
+                    </a:solidFill>
+                  </a:tcPr>
+                </a:tc>
+                <a:tc>
+                  <a:txBody>
+                    <a:bodyPr/>
+                    <a:lstStyle/>
+                    <a:p>
+                      <a:pPr algn="r"/>
+                      <a:r>
+                        <a:rPr sz="1000">
+                          <a:solidFill>
+                            <a:srgbClr val="3F3F3F"/>
+                          </a:solidFill>
+                          <a:latin typeface="Encode Sans"/>
+                        </a:rPr>
+                        <a:t>2.85%</a:t>
+                      </a:r>
+                    </a:p>
+                  </a:txBody>
+                  <a:tcPr marL="36576" marR="36576" marT="18288" marB="18288">
+                    <a:solidFill>
+                      <a:srgbClr val="F8F8F6"/>
+                    </a:solidFill>
+                  </a:tcPr>
+                </a:tc>
+              </a:tr>
+              <a:tr h="292608">
+                <a:tc>
+                  <a:txBody>
+                    <a:bodyPr/>
+                    <a:lstStyle/>
+                    <a:p>
+                      <a:pPr algn="l"/>
+                      <a:r>
+                        <a:rPr sz="1000">
+                          <a:solidFill>
+                            <a:srgbClr val="3F3F3F"/>
+                          </a:solidFill>
+                          <a:latin typeface="Encode Sans"/>
+                        </a:rPr>
+                        <a:t>Diciembre 2025</a:t>
+                      </a:r>
+                    </a:p>
+                  </a:txBody>
+                  <a:tcPr marL="36576" marR="36576" marT="18288" marB="18288">
+                    <a:solidFill>
+                      <a:srgbClr val="FFFFFF"/>
+                    </a:solidFill>
+                  </a:tcPr>
+                </a:tc>
+                <a:tc>
+                  <a:txBody>
+                    <a:bodyPr/>
+                    <a:lstStyle/>
+                    <a:p>
+                      <a:pPr algn="r"/>
+                      <a:r>
+                        <a:rPr sz="1000">
+                          <a:solidFill>
+                            <a:srgbClr val="3F3F3F"/>
+                          </a:solidFill>
+                          <a:latin typeface="Encode Sans"/>
+                        </a:rPr>
+                        <a:t>9.33%</a:t>
+                      </a:r>
+                    </a:p>
+                  </a:txBody>
+                  <a:tcPr marL="36576" marR="36576" marT="18288" marB="18288">
+                    <a:solidFill>
+                      <a:srgbClr val="FFFFFF"/>
+                    </a:solidFill>
+                  </a:tcPr>
+                </a:tc>
+                <a:tc>
+                  <a:txBody>
+                    <a:bodyPr/>
+                    <a:lstStyle/>
+                    <a:p>
+                      <a:pPr algn="r"/>
+                      <a:r>
+                        <a:rPr sz="1000">
+                          <a:solidFill>
+                            <a:srgbClr val="3F3F3F"/>
+                          </a:solidFill>
+                          <a:latin typeface="Encode Sans"/>
+                        </a:rPr>
+                        <a:t>2.53%</a:t>
+                      </a:r>
+                    </a:p>
+                  </a:txBody>
+                  <a:tcPr marL="36576" marR="36576" marT="18288" marB="18288">
+                    <a:solidFill>
+                      <a:srgbClr val="FFFFFF"/>
+                    </a:solidFill>
+                  </a:tcPr>
+                </a:tc>
+              </a:tr>
+              <a:tr h="292608">
+                <a:tc>
+                  <a:txBody>
+                    <a:bodyPr/>
+                    <a:lstStyle/>
+                    <a:p>
+                      <a:pPr algn="l"/>
+                      <a:r>
+                        <a:rPr sz="1000">
+                          <a:solidFill>
+                            <a:srgbClr val="3F3F3F"/>
+                          </a:solidFill>
+                          <a:latin typeface="Encode Sans"/>
+                        </a:rPr>
+                        <a:t>Noviembre 2025</a:t>
+                      </a:r>
+                    </a:p>
+                  </a:txBody>
+                  <a:tcPr marL="36576" marR="36576" marT="18288" marB="18288">
+                    <a:solidFill>
+                      <a:srgbClr val="F8F8F6"/>
+                    </a:solidFill>
+                  </a:tcPr>
+                </a:tc>
+                <a:tc>
+                  <a:txBody>
+                    <a:bodyPr/>
+                    <a:lstStyle/>
+                    <a:p>
+                      <a:pPr algn="r"/>
+                      <a:r>
+                        <a:rPr sz="1000">
+                          <a:solidFill>
+                            <a:srgbClr val="3F3F3F"/>
+                          </a:solidFill>
+                          <a:latin typeface="Encode Sans"/>
+                        </a:rPr>
+                        <a:t>8.82%</a:t>
+                      </a:r>
+                    </a:p>
+                  </a:txBody>
+                  <a:tcPr marL="36576" marR="36576" marT="18288" marB="18288">
+                    <a:solidFill>
+                      <a:srgbClr val="F8F8F6"/>
+                    </a:solidFill>
+                  </a:tcPr>
+                </a:tc>
+                <a:tc>
+                  <a:txBody>
+                    <a:bodyPr/>
+                    <a:lstStyle/>
+                    <a:p>
+                      <a:pPr algn="r"/>
+                      <a:r>
+                        <a:rPr sz="1000">
+                          <a:solidFill>
+                            <a:srgbClr val="3F3F3F"/>
+                          </a:solidFill>
+                          <a:latin typeface="Encode Sans"/>
+                        </a:rPr>
+                        <a:t>2.29%</a:t>
+                      </a:r>
+                    </a:p>
+                  </a:txBody>
+                  <a:tcPr marL="36576" marR="36576" marT="18288" marB="18288">
+                    <a:solidFill>
+                      <a:srgbClr val="F8F8F6"/>
                     </a:solidFill>
                   </a:tcPr>
                 </a:tc>

</xml_diff>

<commit_message>
data: update 2026-06-10 ( data.json despidos.json scraper/historical_despidos.json scraper/calendar_oficial.json publicaciones_semana.pptx)
</commit_message>
<xml_diff>
--- a/publicaciones_semana.pptx
+++ b/publicaciones_semana.pptx
@@ -7,7 +7,6 @@
   <p:sldIdLst>
     <p:sldId id="256" r:id="rId7"/>
     <p:sldId id="257" r:id="rId8"/>
-    <p:sldId id="258" r:id="rId9"/>
   </p:sldIdLst>
   <p:sldSz cx="12191695" cy="6858000" type="screen4x3"/>
   <p:notesSz cx="6858000" cy="9144000"/>
@@ -3239,7 +3238,7 @@
                 </a:solidFill>
                 <a:latin typeface="Encode Sans"/>
               </a:rPr>
-              <a:t>Publicaciones de la semana del 01 de junio de 2026</a:t>
+              <a:t>Publicaciones de la semana del 08 de junio de 2026</a:t>
             </a:r>
           </a:p>
         </p:txBody>
@@ -3273,7 +3272,7 @@
                 </a:solidFill>
                 <a:latin typeface="Encode Sans"/>
               </a:rPr>
-              <a:t>2 publicaciones · datos oficiales INDEC / BCRA / Hacienda</a:t>
+              <a:t>1 publicaciones · datos oficiales INDEC / BCRA / Hacienda</a:t>
             </a:r>
           </a:p>
         </p:txBody>
@@ -3369,7 +3368,7 @@
                 </a:solidFill>
                 <a:latin typeface="Encode Sans"/>
               </a:rPr>
-              <a:t>RECAUDACIÓN MAYO 2026: CRECIÓ +3.2% REAL I.A.</a:t>
+              <a:t>INDUSTRIA ABRIL 2026: IPI CAYÓ -2.8% I.A.</a:t>
             </a:r>
           </a:p>
         </p:txBody>
@@ -3403,7 +3402,7 @@
                 </a:solidFill>
                 <a:latin typeface="Encode Sans"/>
               </a:rPr>
-              <a:t>AFIP/ARCA · período 2026-05</a:t>
+              <a:t>INDEC · período 2026-04</a:t>
             </a:r>
           </a:p>
         </p:txBody>
@@ -3438,7 +3437,7 @@
                 </a:solidFill>
                 <a:latin typeface="Encode Sans"/>
               </a:rPr>
-              <a:t>AFIP/ARCA recaudó $21.514K millones en mayo 2026. Variación nominal interanual: +35.6%. En términos reales (deflactado por REM): +3.2% i.a. Quiebre de tendencia: venía con 6 meses de caída real interanual.</a:t>
+              <a:t>El Índice de Producción Industrial Manufacturero (IPI) registró una variación interanual de -2.8% en abril 2026.</a:t>
             </a:r>
           </a:p>
         </p:txBody>
@@ -3486,7 +3485,7 @@
                 </a:solidFill>
                 <a:latin typeface="Encode Sans"/>
               </a:rPr>
-              <a:t>Total: $21.514K M$</a:t>
+              <a:t>Variación interanual: -2.8%</a:t>
             </a:r>
           </a:p>
           <a:p>
@@ -3511,1089 +3510,7 @@
                 </a:solidFill>
                 <a:latin typeface="Encode Sans"/>
               </a:rPr>
-              <a:t>Variación nominal i.a.: +35.6%</a:t>
-            </a:r>
-          </a:p>
-          <a:p>
-            <a:pPr algn="l">
-              <a:spcAft>
-                <a:spcPts val="800"/>
-              </a:spcAft>
-            </a:pPr>
-            <a:r>
-              <a:rPr sz="1300" b="1" i="0">
-                <a:solidFill>
-                  <a:srgbClr val="00B2C9"/>
-                </a:solidFill>
-                <a:latin typeface="Encode Sans"/>
-              </a:rPr>
-              <a:t>●  </a:t>
-            </a:r>
-            <a:r>
-              <a:rPr sz="1300" b="0" i="0">
-                <a:solidFill>
-                  <a:srgbClr val="3F3F3F"/>
-                </a:solidFill>
-                <a:latin typeface="Encode Sans"/>
-              </a:rPr>
-              <a:t>Variación real i.a.: +3.2% (deflactor: REM)</a:t>
-            </a:r>
-          </a:p>
-          <a:p>
-            <a:pPr algn="l">
-              <a:spcAft>
-                <a:spcPts val="800"/>
-              </a:spcAft>
-            </a:pPr>
-            <a:r>
-              <a:rPr sz="1300" b="1" i="0">
-                <a:solidFill>
-                  <a:srgbClr val="00B2C9"/>
-                </a:solidFill>
-                <a:latin typeface="Encode Sans"/>
-              </a:rPr>
-              <a:t>●  </a:t>
-            </a:r>
-            <a:r>
-              <a:rPr sz="1300" b="0" i="0">
-                <a:solidFill>
-                  <a:srgbClr val="3F3F3F"/>
-                </a:solidFill>
-                <a:latin typeface="Encode Sans"/>
-              </a:rPr>
-              <a:t>Fuente: ARCA (ex AFIP) · indec.gob.ar series</a:t>
-            </a:r>
-          </a:p>
-        </p:txBody>
-      </p:sp>
-      <p:pic>
-        <p:nvPicPr>
-          <p:cNvPr id="7" name="Picture 6" descr="image.png"/>
-          <p:cNvPicPr>
-            <a:picLocks noChangeAspect="1"/>
-          </p:cNvPicPr>
-          <p:nvPr/>
-        </p:nvPicPr>
-        <p:blipFill>
-          <a:blip r:embed="rId2"/>
-          <a:stretch>
-            <a:fillRect/>
-          </a:stretch>
-        </p:blipFill>
-        <p:spPr>
-          <a:xfrm>
-            <a:off x="6080760" y="1691640"/>
-            <a:ext cx="5669280" cy="2560320"/>
-          </a:xfrm>
-          <a:prstGeom prst="rect">
-            <a:avLst/>
-          </a:prstGeom>
-        </p:spPr>
-      </p:pic>
-      <p:graphicFrame>
-        <p:nvGraphicFramePr>
-          <p:cNvPr id="8" name="Table 7"/>
-          <p:cNvGraphicFramePr>
-            <a:graphicFrameLocks noGrp="1"/>
-          </p:cNvGraphicFramePr>
-          <p:nvPr/>
-        </p:nvGraphicFramePr>
-        <p:xfrm>
-          <a:off x="6080760" y="4434840"/>
-          <a:ext cx="5669280" cy="2048256"/>
-        </p:xfrm>
-        <a:graphic>
-          <a:graphicData uri="http://schemas.openxmlformats.org/drawingml/2006/table">
-            <a:tbl>
-              <a:tblPr firstRow="1" bandRow="1">
-                <a:tableStyleId>{5C22544A-7EE6-4342-B048-85BDC9FD1C3A}</a:tableStyleId>
-              </a:tblPr>
-              <a:tblGrid>
-                <a:gridCol w="1417320"/>
-                <a:gridCol w="1417320"/>
-                <a:gridCol w="1417320"/>
-                <a:gridCol w="1417320"/>
-              </a:tblGrid>
-              <a:tr h="292608">
-                <a:tc>
-                  <a:txBody>
-                    <a:bodyPr/>
-                    <a:lstStyle/>
-                    <a:p>
-                      <a:pPr algn="l"/>
-                      <a:r>
-                        <a:rPr sz="1000" b="1">
-                          <a:solidFill>
-                            <a:srgbClr val="FFFFFF"/>
-                          </a:solidFill>
-                          <a:latin typeface="Encode Sans"/>
-                        </a:rPr>
-                        <a:t>Mes</a:t>
-                      </a:r>
-                    </a:p>
-                  </a:txBody>
-                  <a:tcPr marL="36576" marR="36576" marT="18288" marB="18288">
-                    <a:solidFill>
-                      <a:srgbClr val="00B2C9"/>
-                    </a:solidFill>
-                  </a:tcPr>
-                </a:tc>
-                <a:tc>
-                  <a:txBody>
-                    <a:bodyPr/>
-                    <a:lstStyle/>
-                    <a:p>
-                      <a:pPr algn="r"/>
-                      <a:r>
-                        <a:rPr sz="1000" b="1">
-                          <a:solidFill>
-                            <a:srgbClr val="FFFFFF"/>
-                          </a:solidFill>
-                          <a:latin typeface="Encode Sans"/>
-                        </a:rPr>
-                        <a:t>Total M$</a:t>
-                      </a:r>
-                    </a:p>
-                  </a:txBody>
-                  <a:tcPr marL="36576" marR="36576" marT="18288" marB="18288">
-                    <a:solidFill>
-                      <a:srgbClr val="00B2C9"/>
-                    </a:solidFill>
-                  </a:tcPr>
-                </a:tc>
-                <a:tc>
-                  <a:txBody>
-                    <a:bodyPr/>
-                    <a:lstStyle/>
-                    <a:p>
-                      <a:pPr algn="r"/>
-                      <a:r>
-                        <a:rPr sz="1000" b="1">
-                          <a:solidFill>
-                            <a:srgbClr val="FFFFFF"/>
-                          </a:solidFill>
-                          <a:latin typeface="Encode Sans"/>
-                        </a:rPr>
-                        <a:t>Var. nom. i.a.</a:t>
-                      </a:r>
-                    </a:p>
-                  </a:txBody>
-                  <a:tcPr marL="36576" marR="36576" marT="18288" marB="18288">
-                    <a:solidFill>
-                      <a:srgbClr val="00B2C9"/>
-                    </a:solidFill>
-                  </a:tcPr>
-                </a:tc>
-                <a:tc>
-                  <a:txBody>
-                    <a:bodyPr/>
-                    <a:lstStyle/>
-                    <a:p>
-                      <a:pPr algn="r"/>
-                      <a:r>
-                        <a:rPr sz="1000" b="1">
-                          <a:solidFill>
-                            <a:srgbClr val="FFFFFF"/>
-                          </a:solidFill>
-                          <a:latin typeface="Encode Sans"/>
-                        </a:rPr>
-                        <a:t>Var. real i.a.</a:t>
-                      </a:r>
-                    </a:p>
-                  </a:txBody>
-                  <a:tcPr marL="36576" marR="36576" marT="18288" marB="18288">
-                    <a:solidFill>
-                      <a:srgbClr val="00B2C9"/>
-                    </a:solidFill>
-                  </a:tcPr>
-                </a:tc>
-              </a:tr>
-              <a:tr h="292608">
-                <a:tc>
-                  <a:txBody>
-                    <a:bodyPr/>
-                    <a:lstStyle/>
-                    <a:p>
-                      <a:pPr algn="l"/>
-                      <a:r>
-                        <a:rPr sz="1000">
-                          <a:solidFill>
-                            <a:srgbClr val="3F3F3F"/>
-                          </a:solidFill>
-                          <a:latin typeface="Encode Sans"/>
-                        </a:rPr>
-                        <a:t>Mayo 2026</a:t>
-                      </a:r>
-                    </a:p>
-                  </a:txBody>
-                  <a:tcPr marL="36576" marR="36576" marT="18288" marB="18288">
-                    <a:solidFill>
-                      <a:srgbClr val="FFFFFF"/>
-                    </a:solidFill>
-                  </a:tcPr>
-                </a:tc>
-                <a:tc>
-                  <a:txBody>
-                    <a:bodyPr/>
-                    <a:lstStyle/>
-                    <a:p>
-                      <a:pPr algn="r"/>
-                      <a:r>
-                        <a:rPr sz="1000">
-                          <a:solidFill>
-                            <a:srgbClr val="3F3F3F"/>
-                          </a:solidFill>
-                          <a:latin typeface="Encode Sans"/>
-                        </a:rPr>
-                        <a:t>21.514K</a:t>
-                      </a:r>
-                    </a:p>
-                  </a:txBody>
-                  <a:tcPr marL="36576" marR="36576" marT="18288" marB="18288">
-                    <a:solidFill>
-                      <a:srgbClr val="FFFFFF"/>
-                    </a:solidFill>
-                  </a:tcPr>
-                </a:tc>
-                <a:tc>
-                  <a:txBody>
-                    <a:bodyPr/>
-                    <a:lstStyle/>
-                    <a:p>
-                      <a:pPr algn="r"/>
-                      <a:r>
-                        <a:rPr sz="1000">
-                          <a:solidFill>
-                            <a:srgbClr val="3F3F3F"/>
-                          </a:solidFill>
-                          <a:latin typeface="Encode Sans"/>
-                        </a:rPr>
-                        <a:t>—</a:t>
-                      </a:r>
-                    </a:p>
-                  </a:txBody>
-                  <a:tcPr marL="36576" marR="36576" marT="18288" marB="18288">
-                    <a:solidFill>
-                      <a:srgbClr val="FFFFFF"/>
-                    </a:solidFill>
-                  </a:tcPr>
-                </a:tc>
-                <a:tc>
-                  <a:txBody>
-                    <a:bodyPr/>
-                    <a:lstStyle/>
-                    <a:p>
-                      <a:pPr algn="r"/>
-                      <a:r>
-                        <a:rPr sz="1000">
-                          <a:solidFill>
-                            <a:srgbClr val="3F3F3F"/>
-                          </a:solidFill>
-                          <a:latin typeface="Encode Sans"/>
-                        </a:rPr>
-                        <a:t>—</a:t>
-                      </a:r>
-                    </a:p>
-                  </a:txBody>
-                  <a:tcPr marL="36576" marR="36576" marT="18288" marB="18288">
-                    <a:solidFill>
-                      <a:srgbClr val="FFFFFF"/>
-                    </a:solidFill>
-                  </a:tcPr>
-                </a:tc>
-              </a:tr>
-              <a:tr h="292608">
-                <a:tc>
-                  <a:txBody>
-                    <a:bodyPr/>
-                    <a:lstStyle/>
-                    <a:p>
-                      <a:pPr algn="l"/>
-                      <a:r>
-                        <a:rPr sz="1000">
-                          <a:solidFill>
-                            <a:srgbClr val="3F3F3F"/>
-                          </a:solidFill>
-                          <a:latin typeface="Encode Sans"/>
-                        </a:rPr>
-                        <a:t>Abril 2026</a:t>
-                      </a:r>
-                    </a:p>
-                  </a:txBody>
-                  <a:tcPr marL="36576" marR="36576" marT="18288" marB="18288">
-                    <a:solidFill>
-                      <a:srgbClr val="F8F8F6"/>
-                    </a:solidFill>
-                  </a:tcPr>
-                </a:tc>
-                <a:tc>
-                  <a:txBody>
-                    <a:bodyPr/>
-                    <a:lstStyle/>
-                    <a:p>
-                      <a:pPr algn="r"/>
-                      <a:r>
-                        <a:rPr sz="1000">
-                          <a:solidFill>
-                            <a:srgbClr val="3F3F3F"/>
-                          </a:solidFill>
-                          <a:latin typeface="Encode Sans"/>
-                        </a:rPr>
-                        <a:t>17.401K</a:t>
-                      </a:r>
-                    </a:p>
-                  </a:txBody>
-                  <a:tcPr marL="36576" marR="36576" marT="18288" marB="18288">
-                    <a:solidFill>
-                      <a:srgbClr val="F8F8F6"/>
-                    </a:solidFill>
-                  </a:tcPr>
-                </a:tc>
-                <a:tc>
-                  <a:txBody>
-                    <a:bodyPr/>
-                    <a:lstStyle/>
-                    <a:p>
-                      <a:pPr algn="r"/>
-                      <a:r>
-                        <a:rPr sz="1000">
-                          <a:solidFill>
-                            <a:srgbClr val="3F3F3F"/>
-                          </a:solidFill>
-                          <a:latin typeface="Encode Sans"/>
-                        </a:rPr>
-                        <a:t>—</a:t>
-                      </a:r>
-                    </a:p>
-                  </a:txBody>
-                  <a:tcPr marL="36576" marR="36576" marT="18288" marB="18288">
-                    <a:solidFill>
-                      <a:srgbClr val="F8F8F6"/>
-                    </a:solidFill>
-                  </a:tcPr>
-                </a:tc>
-                <a:tc>
-                  <a:txBody>
-                    <a:bodyPr/>
-                    <a:lstStyle/>
-                    <a:p>
-                      <a:pPr algn="r"/>
-                      <a:r>
-                        <a:rPr sz="1000">
-                          <a:solidFill>
-                            <a:srgbClr val="3F3F3F"/>
-                          </a:solidFill>
-                          <a:latin typeface="Encode Sans"/>
-                        </a:rPr>
-                        <a:t>—</a:t>
-                      </a:r>
-                    </a:p>
-                  </a:txBody>
-                  <a:tcPr marL="36576" marR="36576" marT="18288" marB="18288">
-                    <a:solidFill>
-                      <a:srgbClr val="F8F8F6"/>
-                    </a:solidFill>
-                  </a:tcPr>
-                </a:tc>
-              </a:tr>
-              <a:tr h="292608">
-                <a:tc>
-                  <a:txBody>
-                    <a:bodyPr/>
-                    <a:lstStyle/>
-                    <a:p>
-                      <a:pPr algn="l"/>
-                      <a:r>
-                        <a:rPr sz="1000">
-                          <a:solidFill>
-                            <a:srgbClr val="3F3F3F"/>
-                          </a:solidFill>
-                          <a:latin typeface="Encode Sans"/>
-                        </a:rPr>
-                        <a:t>Marzo 2026</a:t>
-                      </a:r>
-                    </a:p>
-                  </a:txBody>
-                  <a:tcPr marL="36576" marR="36576" marT="18288" marB="18288">
-                    <a:solidFill>
-                      <a:srgbClr val="FFFFFF"/>
-                    </a:solidFill>
-                  </a:tcPr>
-                </a:tc>
-                <a:tc>
-                  <a:txBody>
-                    <a:bodyPr/>
-                    <a:lstStyle/>
-                    <a:p>
-                      <a:pPr algn="r"/>
-                      <a:r>
-                        <a:rPr sz="1000">
-                          <a:solidFill>
-                            <a:srgbClr val="3F3F3F"/>
-                          </a:solidFill>
-                          <a:latin typeface="Encode Sans"/>
-                        </a:rPr>
-                        <a:t>16.071K</a:t>
-                      </a:r>
-                    </a:p>
-                  </a:txBody>
-                  <a:tcPr marL="36576" marR="36576" marT="18288" marB="18288">
-                    <a:solidFill>
-                      <a:srgbClr val="FFFFFF"/>
-                    </a:solidFill>
-                  </a:tcPr>
-                </a:tc>
-                <a:tc>
-                  <a:txBody>
-                    <a:bodyPr/>
-                    <a:lstStyle/>
-                    <a:p>
-                      <a:pPr algn="r"/>
-                      <a:r>
-                        <a:rPr sz="1000">
-                          <a:solidFill>
-                            <a:srgbClr val="3F3F3F"/>
-                          </a:solidFill>
-                          <a:latin typeface="Encode Sans"/>
-                        </a:rPr>
-                        <a:t>26.21%</a:t>
-                      </a:r>
-                    </a:p>
-                  </a:txBody>
-                  <a:tcPr marL="36576" marR="36576" marT="18288" marB="18288">
-                    <a:solidFill>
-                      <a:srgbClr val="FFFFFF"/>
-                    </a:solidFill>
-                  </a:tcPr>
-                </a:tc>
-                <a:tc>
-                  <a:txBody>
-                    <a:bodyPr/>
-                    <a:lstStyle/>
-                    <a:p>
-                      <a:pPr algn="r"/>
-                      <a:r>
-                        <a:rPr sz="1000">
-                          <a:solidFill>
-                            <a:srgbClr val="3F3F3F"/>
-                          </a:solidFill>
-                          <a:latin typeface="Encode Sans"/>
-                        </a:rPr>
-                        <a:t>—</a:t>
-                      </a:r>
-                    </a:p>
-                  </a:txBody>
-                  <a:tcPr marL="36576" marR="36576" marT="18288" marB="18288">
-                    <a:solidFill>
-                      <a:srgbClr val="FFFFFF"/>
-                    </a:solidFill>
-                  </a:tcPr>
-                </a:tc>
-              </a:tr>
-              <a:tr h="292608">
-                <a:tc>
-                  <a:txBody>
-                    <a:bodyPr/>
-                    <a:lstStyle/>
-                    <a:p>
-                      <a:pPr algn="l"/>
-                      <a:r>
-                        <a:rPr sz="1000">
-                          <a:solidFill>
-                            <a:srgbClr val="3F3F3F"/>
-                          </a:solidFill>
-                          <a:latin typeface="Encode Sans"/>
-                        </a:rPr>
-                        <a:t>Febrero 2026</a:t>
-                      </a:r>
-                    </a:p>
-                  </a:txBody>
-                  <a:tcPr marL="36576" marR="36576" marT="18288" marB="18288">
-                    <a:solidFill>
-                      <a:srgbClr val="F8F8F6"/>
-                    </a:solidFill>
-                  </a:tcPr>
-                </a:tc>
-                <a:tc>
-                  <a:txBody>
-                    <a:bodyPr/>
-                    <a:lstStyle/>
-                    <a:p>
-                      <a:pPr algn="r"/>
-                      <a:r>
-                        <a:rPr sz="1000">
-                          <a:solidFill>
-                            <a:srgbClr val="3F3F3F"/>
-                          </a:solidFill>
-                          <a:latin typeface="Encode Sans"/>
-                        </a:rPr>
-                        <a:t>16.232K</a:t>
-                      </a:r>
-                    </a:p>
-                  </a:txBody>
-                  <a:tcPr marL="36576" marR="36576" marT="18288" marB="18288">
-                    <a:solidFill>
-                      <a:srgbClr val="F8F8F6"/>
-                    </a:solidFill>
-                  </a:tcPr>
-                </a:tc>
-                <a:tc>
-                  <a:txBody>
-                    <a:bodyPr/>
-                    <a:lstStyle/>
-                    <a:p>
-                      <a:pPr algn="r"/>
-                      <a:r>
-                        <a:rPr sz="1000">
-                          <a:solidFill>
-                            <a:srgbClr val="3F3F3F"/>
-                          </a:solidFill>
-                          <a:latin typeface="Encode Sans"/>
-                        </a:rPr>
-                        <a:t>20.05%</a:t>
-                      </a:r>
-                    </a:p>
-                  </a:txBody>
-                  <a:tcPr marL="36576" marR="36576" marT="18288" marB="18288">
-                    <a:solidFill>
-                      <a:srgbClr val="F8F8F6"/>
-                    </a:solidFill>
-                  </a:tcPr>
-                </a:tc>
-                <a:tc>
-                  <a:txBody>
-                    <a:bodyPr/>
-                    <a:lstStyle/>
-                    <a:p>
-                      <a:pPr algn="r"/>
-                      <a:r>
-                        <a:rPr sz="1000">
-                          <a:solidFill>
-                            <a:srgbClr val="3F3F3F"/>
-                          </a:solidFill>
-                          <a:latin typeface="Encode Sans"/>
-                        </a:rPr>
-                        <a:t>-9.77%</a:t>
-                      </a:r>
-                    </a:p>
-                  </a:txBody>
-                  <a:tcPr marL="36576" marR="36576" marT="18288" marB="18288">
-                    <a:solidFill>
-                      <a:srgbClr val="F8F8F6"/>
-                    </a:solidFill>
-                  </a:tcPr>
-                </a:tc>
-              </a:tr>
-              <a:tr h="292608">
-                <a:tc>
-                  <a:txBody>
-                    <a:bodyPr/>
-                    <a:lstStyle/>
-                    <a:p>
-                      <a:pPr algn="l"/>
-                      <a:r>
-                        <a:rPr sz="1000">
-                          <a:solidFill>
-                            <a:srgbClr val="3F3F3F"/>
-                          </a:solidFill>
-                          <a:latin typeface="Encode Sans"/>
-                        </a:rPr>
-                        <a:t>Enero 2026</a:t>
-                      </a:r>
-                    </a:p>
-                  </a:txBody>
-                  <a:tcPr marL="36576" marR="36576" marT="18288" marB="18288">
-                    <a:solidFill>
-                      <a:srgbClr val="FFFFFF"/>
-                    </a:solidFill>
-                  </a:tcPr>
-                </a:tc>
-                <a:tc>
-                  <a:txBody>
-                    <a:bodyPr/>
-                    <a:lstStyle/>
-                    <a:p>
-                      <a:pPr algn="r"/>
-                      <a:r>
-                        <a:rPr sz="1000">
-                          <a:solidFill>
-                            <a:srgbClr val="3F3F3F"/>
-                          </a:solidFill>
-                          <a:latin typeface="Encode Sans"/>
-                        </a:rPr>
-                        <a:t>18.338K</a:t>
-                      </a:r>
-                    </a:p>
-                  </a:txBody>
-                  <a:tcPr marL="36576" marR="36576" marT="18288" marB="18288">
-                    <a:solidFill>
-                      <a:srgbClr val="FFFFFF"/>
-                    </a:solidFill>
-                  </a:tcPr>
-                </a:tc>
-                <a:tc>
-                  <a:txBody>
-                    <a:bodyPr/>
-                    <a:lstStyle/>
-                    <a:p>
-                      <a:pPr algn="r"/>
-                      <a:r>
-                        <a:rPr sz="1000">
-                          <a:solidFill>
-                            <a:srgbClr val="3F3F3F"/>
-                          </a:solidFill>
-                          <a:latin typeface="Encode Sans"/>
-                        </a:rPr>
-                        <a:t>21.99%</a:t>
-                      </a:r>
-                    </a:p>
-                  </a:txBody>
-                  <a:tcPr marL="36576" marR="36576" marT="18288" marB="18288">
-                    <a:solidFill>
-                      <a:srgbClr val="FFFFFF"/>
-                    </a:solidFill>
-                  </a:tcPr>
-                </a:tc>
-                <a:tc>
-                  <a:txBody>
-                    <a:bodyPr/>
-                    <a:lstStyle/>
-                    <a:p>
-                      <a:pPr algn="r"/>
-                      <a:r>
-                        <a:rPr sz="1000">
-                          <a:solidFill>
-                            <a:srgbClr val="3F3F3F"/>
-                          </a:solidFill>
-                          <a:latin typeface="Encode Sans"/>
-                        </a:rPr>
-                        <a:t>-7.87%</a:t>
-                      </a:r>
-                    </a:p>
-                  </a:txBody>
-                  <a:tcPr marL="36576" marR="36576" marT="18288" marB="18288">
-                    <a:solidFill>
-                      <a:srgbClr val="FFFFFF"/>
-                    </a:solidFill>
-                  </a:tcPr>
-                </a:tc>
-              </a:tr>
-              <a:tr h="292608">
-                <a:tc>
-                  <a:txBody>
-                    <a:bodyPr/>
-                    <a:lstStyle/>
-                    <a:p>
-                      <a:pPr algn="l"/>
-                      <a:r>
-                        <a:rPr sz="1000">
-                          <a:solidFill>
-                            <a:srgbClr val="3F3F3F"/>
-                          </a:solidFill>
-                          <a:latin typeface="Encode Sans"/>
-                        </a:rPr>
-                        <a:t>Diciembre 2025</a:t>
-                      </a:r>
-                    </a:p>
-                  </a:txBody>
-                  <a:tcPr marL="36576" marR="36576" marT="18288" marB="18288">
-                    <a:solidFill>
-                      <a:srgbClr val="F8F8F6"/>
-                    </a:solidFill>
-                  </a:tcPr>
-                </a:tc>
-                <a:tc>
-                  <a:txBody>
-                    <a:bodyPr/>
-                    <a:lstStyle/>
-                    <a:p>
-                      <a:pPr algn="r"/>
-                      <a:r>
-                        <a:rPr sz="1000">
-                          <a:solidFill>
-                            <a:srgbClr val="3F3F3F"/>
-                          </a:solidFill>
-                          <a:latin typeface="Encode Sans"/>
-                        </a:rPr>
-                        <a:t>16.527K</a:t>
-                      </a:r>
-                    </a:p>
-                  </a:txBody>
-                  <a:tcPr marL="36576" marR="36576" marT="18288" marB="18288">
-                    <a:solidFill>
-                      <a:srgbClr val="F8F8F6"/>
-                    </a:solidFill>
-                  </a:tcPr>
-                </a:tc>
-                <a:tc>
-                  <a:txBody>
-                    <a:bodyPr/>
-                    <a:lstStyle/>
-                    <a:p>
-                      <a:pPr algn="r"/>
-                      <a:r>
-                        <a:rPr sz="1000">
-                          <a:solidFill>
-                            <a:srgbClr val="3F3F3F"/>
-                          </a:solidFill>
-                          <a:latin typeface="Encode Sans"/>
-                        </a:rPr>
-                        <a:t>26.98%</a:t>
-                      </a:r>
-                    </a:p>
-                  </a:txBody>
-                  <a:tcPr marL="36576" marR="36576" marT="18288" marB="18288">
-                    <a:solidFill>
-                      <a:srgbClr val="F8F8F6"/>
-                    </a:solidFill>
-                  </a:tcPr>
-                </a:tc>
-                <a:tc>
-                  <a:txBody>
-                    <a:bodyPr/>
-                    <a:lstStyle/>
-                    <a:p>
-                      <a:pPr algn="r"/>
-                      <a:r>
-                        <a:rPr sz="1000">
-                          <a:solidFill>
-                            <a:srgbClr val="3F3F3F"/>
-                          </a:solidFill>
-                          <a:latin typeface="Encode Sans"/>
-                        </a:rPr>
-                        <a:t>-3.47%</a:t>
-                      </a:r>
-                    </a:p>
-                  </a:txBody>
-                  <a:tcPr marL="36576" marR="36576" marT="18288" marB="18288">
-                    <a:solidFill>
-                      <a:srgbClr val="F8F8F6"/>
-                    </a:solidFill>
-                  </a:tcPr>
-                </a:tc>
-              </a:tr>
-            </a:tbl>
-          </a:graphicData>
-        </a:graphic>
-      </p:graphicFrame>
-      <p:sp>
-        <p:nvSpPr>
-          <p:cNvPr id="9" name="TextBox 8"/>
-          <p:cNvSpPr txBox="1"/>
-          <p:nvPr/>
-        </p:nvSpPr>
-        <p:spPr>
-          <a:xfrm>
-            <a:off x="411480" y="6492240"/>
-            <a:ext cx="11368735" cy="274320"/>
-          </a:xfrm>
-          <a:prstGeom prst="rect">
-            <a:avLst/>
-          </a:prstGeom>
-          <a:noFill/>
-        </p:spPr>
-        <p:txBody>
-          <a:bodyPr wrap="none">
-            <a:spAutoFit/>
-          </a:bodyPr>
-          <a:lstStyle/>
-          <a:p>
-            <a:r>
-              <a:rPr sz="1000" b="0" i="1">
-                <a:solidFill>
-                  <a:srgbClr val="6A6760"/>
-                </a:solidFill>
-                <a:latin typeface="Encode Sans"/>
-              </a:rPr>
-              <a:t>Fuente: elaboración propia en base a AFIP/ARCA</a:t>
-            </a:r>
-          </a:p>
-        </p:txBody>
-      </p:sp>
-    </p:spTree>
-  </p:cSld>
-  <p:clrMapOvr>
-    <a:masterClrMapping/>
-  </p:clrMapOvr>
-</p:sld>
-</file>
-
-<file path=ppt/slides/slide3.xml><?xml version="1.0" encoding="utf-8"?>
-<p:sld xmlns:a="http://schemas.openxmlformats.org/drawingml/2006/main" xmlns:p="http://schemas.openxmlformats.org/presentationml/2006/main" xmlns:r="http://schemas.openxmlformats.org/officeDocument/2006/relationships">
-  <p:cSld>
-    <p:spTree>
-      <p:nvGrpSpPr>
-        <p:cNvPr id="1" name=""/>
-        <p:cNvGrpSpPr/>
-        <p:nvPr/>
-      </p:nvGrpSpPr>
-      <p:grpSpPr/>
-      <p:sp>
-        <p:nvSpPr>
-          <p:cNvPr id="2" name="Rectangle 1"/>
-          <p:cNvSpPr/>
-          <p:nvPr/>
-        </p:nvSpPr>
-        <p:spPr>
-          <a:xfrm>
-            <a:off x="0" y="0"/>
-            <a:ext cx="12191695" cy="274320"/>
-          </a:xfrm>
-          <a:prstGeom prst="rect">
-            <a:avLst/>
-          </a:prstGeom>
-          <a:solidFill>
-            <a:srgbClr val="00B2C9"/>
-          </a:solidFill>
-          <a:ln>
-            <a:noFill/>
-          </a:ln>
-        </p:spPr>
-        <p:style>
-          <a:lnRef idx="1">
-            <a:schemeClr val="accent1"/>
-          </a:lnRef>
-          <a:fillRef idx="3">
-            <a:schemeClr val="accent1"/>
-          </a:fillRef>
-          <a:effectRef idx="2">
-            <a:schemeClr val="accent1"/>
-          </a:effectRef>
-          <a:fontRef idx="minor">
-            <a:schemeClr val="lt1"/>
-          </a:fontRef>
-        </p:style>
-        <p:txBody>
-          <a:bodyPr rtlCol="0" anchor="ctr"/>
-          <a:lstStyle/>
-          <a:p>
-            <a:pPr algn="ctr"/>
-          </a:p>
-        </p:txBody>
-      </p:sp>
-      <p:sp>
-        <p:nvSpPr>
-          <p:cNvPr id="3" name="TextBox 2"/>
-          <p:cNvSpPr txBox="1"/>
-          <p:nvPr/>
-        </p:nvSpPr>
-        <p:spPr>
-          <a:xfrm>
-            <a:off x="411480" y="457200"/>
-            <a:ext cx="11368735" cy="914400"/>
-          </a:xfrm>
-          <a:prstGeom prst="rect">
-            <a:avLst/>
-          </a:prstGeom>
-          <a:noFill/>
-        </p:spPr>
-        <p:txBody>
-          <a:bodyPr wrap="square" lIns="0" rIns="0">
-            <a:spAutoFit/>
-          </a:bodyPr>
-          <a:lstStyle/>
-          <a:p>
-            <a:pPr algn="l"/>
-            <a:r>
-              <a:rPr sz="2600" b="1" i="0">
-                <a:solidFill>
-                  <a:srgbClr val="00B2C9"/>
-                </a:solidFill>
-                <a:latin typeface="Encode Sans"/>
-              </a:rPr>
-              <a:t>MORA BANCARIA ABRIL 2026: FAMILIAS 12.0% · EMPRESAS 3.3% (PRELIMINAR)</a:t>
-            </a:r>
-          </a:p>
-        </p:txBody>
-      </p:sp>
-      <p:sp>
-        <p:nvSpPr>
-          <p:cNvPr id="4" name="TextBox 3"/>
-          <p:cNvSpPr txBox="1"/>
-          <p:nvPr/>
-        </p:nvSpPr>
-        <p:spPr>
-          <a:xfrm>
-            <a:off x="411480" y="1280160"/>
-            <a:ext cx="11368735" cy="274320"/>
-          </a:xfrm>
-          <a:prstGeom prst="rect">
-            <a:avLst/>
-          </a:prstGeom>
-          <a:noFill/>
-        </p:spPr>
-        <p:txBody>
-          <a:bodyPr wrap="none">
-            <a:spAutoFit/>
-          </a:bodyPr>
-          <a:lstStyle/>
-          <a:p>
-            <a:r>
-              <a:rPr sz="1100" b="0" i="1">
-                <a:solidFill>
-                  <a:srgbClr val="6A6760"/>
-                </a:solidFill>
-                <a:latin typeface="Encode Sans"/>
-              </a:rPr>
-              <a:t>BCRA Informe sobre Bancos · período 2026-04</a:t>
-            </a:r>
-          </a:p>
-        </p:txBody>
-      </p:sp>
-      <p:sp>
-        <p:nvSpPr>
-          <p:cNvPr id="5" name="TextBox 4"/>
-          <p:cNvSpPr txBox="1"/>
-          <p:nvPr/>
-        </p:nvSpPr>
-        <p:spPr>
-          <a:xfrm>
-            <a:off x="411480" y="1691640"/>
-            <a:ext cx="5486400" cy="1645920"/>
-          </a:xfrm>
-          <a:prstGeom prst="rect">
-            <a:avLst/>
-          </a:prstGeom>
-          <a:noFill/>
-        </p:spPr>
-        <p:txBody>
-          <a:bodyPr wrap="square" lIns="0" rIns="0">
-            <a:spAutoFit/>
-          </a:bodyPr>
-          <a:lstStyle/>
-          <a:p>
-            <a:pPr algn="just"/>
-            <a:r>
-              <a:rPr sz="1300" b="0" i="0">
-                <a:solidFill>
-                  <a:srgbClr val="3F3F3F"/>
-                </a:solidFill>
-                <a:latin typeface="Encode Sans"/>
-              </a:rPr>
-              <a:t>La irregularidad de cartera alcanzó 12.0% en familias y 3.3% en empresas en abril 2026 (venía de 11.54% en marzo 2026, +0.46 pp). Dato preliminar reportado por Infobae/1816 via CENDEU; el BCRA publicará el oficial en su próximo Informe sobre Bancos.</a:t>
-            </a:r>
-          </a:p>
-        </p:txBody>
-      </p:sp>
-      <p:sp>
-        <p:nvSpPr>
-          <p:cNvPr id="6" name="TextBox 5"/>
-          <p:cNvSpPr txBox="1"/>
-          <p:nvPr/>
-        </p:nvSpPr>
-        <p:spPr>
-          <a:xfrm>
-            <a:off x="411480" y="3520440"/>
-            <a:ext cx="5486400" cy="2743200"/>
-          </a:xfrm>
-          <a:prstGeom prst="rect">
-            <a:avLst/>
-          </a:prstGeom>
-          <a:noFill/>
-        </p:spPr>
-        <p:txBody>
-          <a:bodyPr wrap="square" lIns="0" rIns="0">
-            <a:spAutoFit/>
-          </a:bodyPr>
-          <a:lstStyle/>
-          <a:p>
-            <a:pPr algn="l">
-              <a:spcAft>
-                <a:spcPts val="800"/>
-              </a:spcAft>
-            </a:pPr>
-            <a:r>
-              <a:rPr sz="1300" b="1" i="0">
-                <a:solidFill>
-                  <a:srgbClr val="00B2C9"/>
-                </a:solidFill>
-                <a:latin typeface="Encode Sans"/>
-              </a:rPr>
-              <a:t>●  </a:t>
-            </a:r>
-            <a:r>
-              <a:rPr sz="1300" b="0" i="0">
-                <a:solidFill>
-                  <a:srgbClr val="3F3F3F"/>
-                </a:solidFill>
-                <a:latin typeface="Encode Sans"/>
-              </a:rPr>
-              <a:t>Familias: 12.0% del total de préstamos en situación irregular</a:t>
-            </a:r>
-          </a:p>
-          <a:p>
-            <a:pPr algn="l">
-              <a:spcAft>
-                <a:spcPts val="800"/>
-              </a:spcAft>
-            </a:pPr>
-            <a:r>
-              <a:rPr sz="1300" b="1" i="0">
-                <a:solidFill>
-                  <a:srgbClr val="00B2C9"/>
-                </a:solidFill>
-                <a:latin typeface="Encode Sans"/>
-              </a:rPr>
-              <a:t>●  </a:t>
-            </a:r>
-            <a:r>
-              <a:rPr sz="1300" b="0" i="0">
-                <a:solidFill>
-                  <a:srgbClr val="3F3F3F"/>
-                </a:solidFill>
-                <a:latin typeface="Encode Sans"/>
-              </a:rPr>
-              <a:t>Empresas: 3.3%</a:t>
-            </a:r>
-          </a:p>
-          <a:p>
-            <a:pPr algn="l">
-              <a:spcAft>
-                <a:spcPts val="800"/>
-              </a:spcAft>
-            </a:pPr>
-            <a:r>
-              <a:rPr sz="1300" b="1" i="0">
-                <a:solidFill>
-                  <a:srgbClr val="00B2C9"/>
-                </a:solidFill>
-                <a:latin typeface="Encode Sans"/>
-              </a:rPr>
-              <a:t>●  </a:t>
-            </a:r>
-            <a:r>
-              <a:rPr sz="1300" b="0" i="0">
-                <a:solidFill>
-                  <a:srgbClr val="3F3F3F"/>
-                </a:solidFill>
-                <a:latin typeface="Encode Sans"/>
-              </a:rPr>
-              <a:t>Fuente: Infobae/1816 via CENDEU</a:t>
-            </a:r>
-          </a:p>
-          <a:p>
-            <a:pPr algn="l">
-              <a:spcAft>
-                <a:spcPts val="800"/>
-              </a:spcAft>
-            </a:pPr>
-            <a:r>
-              <a:rPr sz="1300" b="1" i="0">
-                <a:solidFill>
-                  <a:srgbClr val="00B2C9"/>
-                </a:solidFill>
-                <a:latin typeface="Encode Sans"/>
-              </a:rPr>
-              <a:t>●  </a:t>
-            </a:r>
-            <a:r>
-              <a:rPr sz="1300" b="0" i="0">
-                <a:solidFill>
-                  <a:srgbClr val="3F3F3F"/>
-                </a:solidFill>
-                <a:latin typeface="Encode Sans"/>
-              </a:rPr>
-              <a:t>⚠ Dato preliminar — sujeto a revisión cuando el BCRA publique el Informe oficial</a:t>
+              <a:t>Serie INDEC, base 2004=100. Mide la producción manufacturera (16 ramas).</a:t>
             </a:r>
           </a:p>
         </p:txBody>
@@ -4682,7 +3599,7 @@
                           </a:solidFill>
                           <a:latin typeface="Encode Sans"/>
                         </a:rPr>
-                        <a:t>Familias %</a:t>
+                        <a:t>Original</a:t>
                       </a:r>
                     </a:p>
                   </a:txBody>
@@ -4705,7 +3622,7 @@
                           </a:solidFill>
                           <a:latin typeface="Encode Sans"/>
                         </a:rPr>
-                        <a:t>Empresas %</a:t>
+                        <a:t>VIA %</a:t>
                       </a:r>
                     </a:p>
                   </a:txBody>
@@ -4730,7 +3647,7 @@
                           </a:solidFill>
                           <a:latin typeface="Encode Sans"/>
                         </a:rPr>
-                        <a:t>Abril 2026 *</a:t>
+                        <a:t>Abril 2026</a:t>
                       </a:r>
                     </a:p>
                   </a:txBody>
@@ -4753,7 +3670,7 @@
                           </a:solidFill>
                           <a:latin typeface="Encode Sans"/>
                         </a:rPr>
-                        <a:t>12.0%</a:t>
+                        <a:t>118,1</a:t>
                       </a:r>
                     </a:p>
                   </a:txBody>
@@ -4776,7 +3693,7 @@
                           </a:solidFill>
                           <a:latin typeface="Encode Sans"/>
                         </a:rPr>
-                        <a:t>3.3%</a:t>
+                        <a:t>-2.8%</a:t>
                       </a:r>
                     </a:p>
                   </a:txBody>
@@ -4824,7 +3741,7 @@
                           </a:solidFill>
                           <a:latin typeface="Encode Sans"/>
                         </a:rPr>
-                        <a:t>11.54%</a:t>
+                        <a:t>122,2</a:t>
                       </a:r>
                     </a:p>
                   </a:txBody>
@@ -4847,7 +3764,7 @@
                           </a:solidFill>
                           <a:latin typeface="Encode Sans"/>
                         </a:rPr>
-                        <a:t>3.13%</a:t>
+                        <a:t>+5.1%</a:t>
                       </a:r>
                     </a:p>
                   </a:txBody>
@@ -4895,7 +3812,7 @@
                           </a:solidFill>
                           <a:latin typeface="Encode Sans"/>
                         </a:rPr>
-                        <a:t>11.22%</a:t>
+                        <a:t>100,3</a:t>
                       </a:r>
                     </a:p>
                   </a:txBody>
@@ -4918,7 +3835,7 @@
                           </a:solidFill>
                           <a:latin typeface="Encode Sans"/>
                         </a:rPr>
-                        <a:t>2.92%</a:t>
+                        <a:t>-8.8%</a:t>
                       </a:r>
                     </a:p>
                   </a:txBody>
@@ -4966,7 +3883,7 @@
                           </a:solidFill>
                           <a:latin typeface="Encode Sans"/>
                         </a:rPr>
-                        <a:t>10.61%</a:t>
+                        <a:t>106,6</a:t>
                       </a:r>
                     </a:p>
                   </a:txBody>
@@ -4989,7 +3906,7 @@
                           </a:solidFill>
                           <a:latin typeface="Encode Sans"/>
                         </a:rPr>
-                        <a:t>2.85%</a:t>
+                        <a:t>-3.7%</a:t>
                       </a:r>
                     </a:p>
                   </a:txBody>
@@ -5037,7 +3954,7 @@
                           </a:solidFill>
                           <a:latin typeface="Encode Sans"/>
                         </a:rPr>
-                        <a:t>9.33%</a:t>
+                        <a:t>112,0</a:t>
                       </a:r>
                     </a:p>
                   </a:txBody>
@@ -5060,7 +3977,7 @@
                           </a:solidFill>
                           <a:latin typeface="Encode Sans"/>
                         </a:rPr>
-                        <a:t>2.53%</a:t>
+                        <a:t>-4.0%</a:t>
                       </a:r>
                     </a:p>
                   </a:txBody>
@@ -5108,7 +4025,7 @@
                           </a:solidFill>
                           <a:latin typeface="Encode Sans"/>
                         </a:rPr>
-                        <a:t>8.82%</a:t>
+                        <a:t>114,4</a:t>
                       </a:r>
                     </a:p>
                   </a:txBody>
@@ -5131,7 +4048,7 @@
                           </a:solidFill>
                           <a:latin typeface="Encode Sans"/>
                         </a:rPr>
-                        <a:t>2.29%</a:t>
+                        <a:t>-8.8%</a:t>
                       </a:r>
                     </a:p>
                   </a:txBody>
@@ -5175,7 +4092,7 @@
                 </a:solidFill>
                 <a:latin typeface="Encode Sans"/>
               </a:rPr>
-              <a:t>Fuente: elaboración propia en base a BCRA Informe sobre Bancos</a:t>
+              <a:t>Fuente: elaboración propia en base a INDEC</a:t>
             </a:r>
           </a:p>
         </p:txBody>

</xml_diff>

<commit_message>
data: IPC mayo + ISAC abril publicado correcto (calendario INDEC)
</commit_message>
<xml_diff>
--- a/publicaciones_semana.pptx
+++ b/publicaciones_semana.pptx
@@ -7,6 +7,8 @@
   <p:sldIdLst>
     <p:sldId id="256" r:id="rId7"/>
     <p:sldId id="257" r:id="rId8"/>
+    <p:sldId id="258" r:id="rId9"/>
+    <p:sldId id="259" r:id="rId10"/>
   </p:sldIdLst>
   <p:sldSz cx="12191695" cy="6858000" type="screen4x3"/>
   <p:notesSz cx="6858000" cy="9144000"/>
@@ -3272,7 +3274,7 @@
                 </a:solidFill>
                 <a:latin typeface="Encode Sans"/>
               </a:rPr>
-              <a:t>1 publicaciones · datos oficiales INDEC / BCRA / Hacienda</a:t>
+              <a:t>3 publicaciones · datos oficiales INDEC / BCRA / Hacienda</a:t>
             </a:r>
           </a:p>
         </p:txBody>
@@ -4049,6 +4051,1671 @@
                           <a:latin typeface="Encode Sans"/>
                         </a:rPr>
                         <a:t>-8.8%</a:t>
+                      </a:r>
+                    </a:p>
+                  </a:txBody>
+                  <a:tcPr marL="36576" marR="36576" marT="18288" marB="18288">
+                    <a:solidFill>
+                      <a:srgbClr val="F8F8F6"/>
+                    </a:solidFill>
+                  </a:tcPr>
+                </a:tc>
+              </a:tr>
+            </a:tbl>
+          </a:graphicData>
+        </a:graphic>
+      </p:graphicFrame>
+      <p:sp>
+        <p:nvSpPr>
+          <p:cNvPr id="9" name="TextBox 8"/>
+          <p:cNvSpPr txBox="1"/>
+          <p:nvPr/>
+        </p:nvSpPr>
+        <p:spPr>
+          <a:xfrm>
+            <a:off x="411480" y="6492240"/>
+            <a:ext cx="11368735" cy="274320"/>
+          </a:xfrm>
+          <a:prstGeom prst="rect">
+            <a:avLst/>
+          </a:prstGeom>
+          <a:noFill/>
+        </p:spPr>
+        <p:txBody>
+          <a:bodyPr wrap="none">
+            <a:spAutoFit/>
+          </a:bodyPr>
+          <a:lstStyle/>
+          <a:p>
+            <a:r>
+              <a:rPr sz="1000" b="0" i="1">
+                <a:solidFill>
+                  <a:srgbClr val="6A6760"/>
+                </a:solidFill>
+                <a:latin typeface="Encode Sans"/>
+              </a:rPr>
+              <a:t>Fuente: elaboración propia en base a INDEC</a:t>
+            </a:r>
+          </a:p>
+        </p:txBody>
+      </p:sp>
+    </p:spTree>
+  </p:cSld>
+  <p:clrMapOvr>
+    <a:masterClrMapping/>
+  </p:clrMapOvr>
+</p:sld>
+</file>
+
+<file path=ppt/slides/slide3.xml><?xml version="1.0" encoding="utf-8"?>
+<p:sld xmlns:a="http://schemas.openxmlformats.org/drawingml/2006/main" xmlns:p="http://schemas.openxmlformats.org/presentationml/2006/main" xmlns:r="http://schemas.openxmlformats.org/officeDocument/2006/relationships">
+  <p:cSld>
+    <p:spTree>
+      <p:nvGrpSpPr>
+        <p:cNvPr id="1" name=""/>
+        <p:cNvGrpSpPr/>
+        <p:nvPr/>
+      </p:nvGrpSpPr>
+      <p:grpSpPr/>
+      <p:sp>
+        <p:nvSpPr>
+          <p:cNvPr id="2" name="Rectangle 1"/>
+          <p:cNvSpPr/>
+          <p:nvPr/>
+        </p:nvSpPr>
+        <p:spPr>
+          <a:xfrm>
+            <a:off x="0" y="0"/>
+            <a:ext cx="12191695" cy="274320"/>
+          </a:xfrm>
+          <a:prstGeom prst="rect">
+            <a:avLst/>
+          </a:prstGeom>
+          <a:solidFill>
+            <a:srgbClr val="00B2C9"/>
+          </a:solidFill>
+          <a:ln>
+            <a:noFill/>
+          </a:ln>
+        </p:spPr>
+        <p:style>
+          <a:lnRef idx="1">
+            <a:schemeClr val="accent1"/>
+          </a:lnRef>
+          <a:fillRef idx="3">
+            <a:schemeClr val="accent1"/>
+          </a:fillRef>
+          <a:effectRef idx="2">
+            <a:schemeClr val="accent1"/>
+          </a:effectRef>
+          <a:fontRef idx="minor">
+            <a:schemeClr val="lt1"/>
+          </a:fontRef>
+        </p:style>
+        <p:txBody>
+          <a:bodyPr rtlCol="0" anchor="ctr"/>
+          <a:lstStyle/>
+          <a:p>
+            <a:pPr algn="ctr"/>
+          </a:p>
+        </p:txBody>
+      </p:sp>
+      <p:sp>
+        <p:nvSpPr>
+          <p:cNvPr id="3" name="TextBox 2"/>
+          <p:cNvSpPr txBox="1"/>
+          <p:nvPr/>
+        </p:nvSpPr>
+        <p:spPr>
+          <a:xfrm>
+            <a:off x="411480" y="457200"/>
+            <a:ext cx="11368735" cy="914400"/>
+          </a:xfrm>
+          <a:prstGeom prst="rect">
+            <a:avLst/>
+          </a:prstGeom>
+          <a:noFill/>
+        </p:spPr>
+        <p:txBody>
+          <a:bodyPr wrap="square" lIns="0" rIns="0">
+            <a:spAutoFit/>
+          </a:bodyPr>
+          <a:lstStyle/>
+          <a:p>
+            <a:pPr algn="l"/>
+            <a:r>
+              <a:rPr sz="2600" b="1" i="0">
+                <a:solidFill>
+                  <a:srgbClr val="00B2C9"/>
+                </a:solidFill>
+                <a:latin typeface="Encode Sans"/>
+              </a:rPr>
+              <a:t>INDUSTRIA ABRIL 2026: IPI CRECIÓ +0.0% I.A.</a:t>
+            </a:r>
+          </a:p>
+        </p:txBody>
+      </p:sp>
+      <p:sp>
+        <p:nvSpPr>
+          <p:cNvPr id="4" name="TextBox 3"/>
+          <p:cNvSpPr txBox="1"/>
+          <p:nvPr/>
+        </p:nvSpPr>
+        <p:spPr>
+          <a:xfrm>
+            <a:off x="411480" y="1280160"/>
+            <a:ext cx="11368735" cy="274320"/>
+          </a:xfrm>
+          <a:prstGeom prst="rect">
+            <a:avLst/>
+          </a:prstGeom>
+          <a:noFill/>
+        </p:spPr>
+        <p:txBody>
+          <a:bodyPr wrap="none">
+            <a:spAutoFit/>
+          </a:bodyPr>
+          <a:lstStyle/>
+          <a:p>
+            <a:r>
+              <a:rPr sz="1100" b="0" i="1">
+                <a:solidFill>
+                  <a:srgbClr val="6A6760"/>
+                </a:solidFill>
+                <a:latin typeface="Encode Sans"/>
+              </a:rPr>
+              <a:t>INDEC · período 2026-04</a:t>
+            </a:r>
+          </a:p>
+        </p:txBody>
+      </p:sp>
+      <p:sp>
+        <p:nvSpPr>
+          <p:cNvPr id="5" name="TextBox 4"/>
+          <p:cNvSpPr txBox="1"/>
+          <p:nvPr/>
+        </p:nvSpPr>
+        <p:spPr>
+          <a:xfrm>
+            <a:off x="411480" y="1691640"/>
+            <a:ext cx="5486400" cy="1645920"/>
+          </a:xfrm>
+          <a:prstGeom prst="rect">
+            <a:avLst/>
+          </a:prstGeom>
+          <a:noFill/>
+        </p:spPr>
+        <p:txBody>
+          <a:bodyPr wrap="square" lIns="0" rIns="0">
+            <a:spAutoFit/>
+          </a:bodyPr>
+          <a:lstStyle/>
+          <a:p>
+            <a:pPr algn="just"/>
+            <a:r>
+              <a:rPr sz="1300" b="0" i="0">
+                <a:solidFill>
+                  <a:srgbClr val="3F3F3F"/>
+                </a:solidFill>
+                <a:latin typeface="Encode Sans"/>
+              </a:rPr>
+              <a:t>El Índice de Producción Industrial Manufacturero (IPI) registró una variación interanual de +0.0% en abril 2026.</a:t>
+            </a:r>
+          </a:p>
+        </p:txBody>
+      </p:sp>
+      <p:sp>
+        <p:nvSpPr>
+          <p:cNvPr id="6" name="TextBox 5"/>
+          <p:cNvSpPr txBox="1"/>
+          <p:nvPr/>
+        </p:nvSpPr>
+        <p:spPr>
+          <a:xfrm>
+            <a:off x="411480" y="3520440"/>
+            <a:ext cx="5486400" cy="2743200"/>
+          </a:xfrm>
+          <a:prstGeom prst="rect">
+            <a:avLst/>
+          </a:prstGeom>
+          <a:noFill/>
+        </p:spPr>
+        <p:txBody>
+          <a:bodyPr wrap="square" lIns="0" rIns="0">
+            <a:spAutoFit/>
+          </a:bodyPr>
+          <a:lstStyle/>
+          <a:p>
+            <a:pPr algn="l">
+              <a:spcAft>
+                <a:spcPts val="800"/>
+              </a:spcAft>
+            </a:pPr>
+            <a:r>
+              <a:rPr sz="1300" b="1" i="0">
+                <a:solidFill>
+                  <a:srgbClr val="00B2C9"/>
+                </a:solidFill>
+                <a:latin typeface="Encode Sans"/>
+              </a:rPr>
+              <a:t>●  </a:t>
+            </a:r>
+            <a:r>
+              <a:rPr sz="1300" b="0" i="0">
+                <a:solidFill>
+                  <a:srgbClr val="3F3F3F"/>
+                </a:solidFill>
+                <a:latin typeface="Encode Sans"/>
+              </a:rPr>
+              <a:t>Variación interanual: +0.0%</a:t>
+            </a:r>
+          </a:p>
+          <a:p>
+            <a:pPr algn="l">
+              <a:spcAft>
+                <a:spcPts val="800"/>
+              </a:spcAft>
+            </a:pPr>
+            <a:r>
+              <a:rPr sz="1300" b="1" i="0">
+                <a:solidFill>
+                  <a:srgbClr val="00B2C9"/>
+                </a:solidFill>
+                <a:latin typeface="Encode Sans"/>
+              </a:rPr>
+              <a:t>●  </a:t>
+            </a:r>
+            <a:r>
+              <a:rPr sz="1300" b="0" i="0">
+                <a:solidFill>
+                  <a:srgbClr val="3F3F3F"/>
+                </a:solidFill>
+                <a:latin typeface="Encode Sans"/>
+              </a:rPr>
+              <a:t>Serie INDEC, base 2004=100. Mide la producción manufacturera (16 ramas).</a:t>
+            </a:r>
+          </a:p>
+        </p:txBody>
+      </p:sp>
+      <p:pic>
+        <p:nvPicPr>
+          <p:cNvPr id="7" name="Picture 6" descr="image.png"/>
+          <p:cNvPicPr>
+            <a:picLocks noChangeAspect="1"/>
+          </p:cNvPicPr>
+          <p:nvPr/>
+        </p:nvPicPr>
+        <p:blipFill>
+          <a:blip r:embed="rId2"/>
+          <a:stretch>
+            <a:fillRect/>
+          </a:stretch>
+        </p:blipFill>
+        <p:spPr>
+          <a:xfrm>
+            <a:off x="6080760" y="1691640"/>
+            <a:ext cx="5669280" cy="2560320"/>
+          </a:xfrm>
+          <a:prstGeom prst="rect">
+            <a:avLst/>
+          </a:prstGeom>
+        </p:spPr>
+      </p:pic>
+      <p:graphicFrame>
+        <p:nvGraphicFramePr>
+          <p:cNvPr id="8" name="Table 7"/>
+          <p:cNvGraphicFramePr>
+            <a:graphicFrameLocks noGrp="1"/>
+          </p:cNvGraphicFramePr>
+          <p:nvPr/>
+        </p:nvGraphicFramePr>
+        <p:xfrm>
+          <a:off x="6080760" y="4434840"/>
+          <a:ext cx="5669280" cy="2048256"/>
+        </p:xfrm>
+        <a:graphic>
+          <a:graphicData uri="http://schemas.openxmlformats.org/drawingml/2006/table">
+            <a:tbl>
+              <a:tblPr firstRow="1" bandRow="1">
+                <a:tableStyleId>{5C22544A-7EE6-4342-B048-85BDC9FD1C3A}</a:tableStyleId>
+              </a:tblPr>
+              <a:tblGrid>
+                <a:gridCol w="1889760"/>
+                <a:gridCol w="1889760"/>
+                <a:gridCol w="1889760"/>
+              </a:tblGrid>
+              <a:tr h="292608">
+                <a:tc>
+                  <a:txBody>
+                    <a:bodyPr/>
+                    <a:lstStyle/>
+                    <a:p>
+                      <a:pPr algn="l"/>
+                      <a:r>
+                        <a:rPr sz="1000" b="1">
+                          <a:solidFill>
+                            <a:srgbClr val="FFFFFF"/>
+                          </a:solidFill>
+                          <a:latin typeface="Encode Sans"/>
+                        </a:rPr>
+                        <a:t>Mes</a:t>
+                      </a:r>
+                    </a:p>
+                  </a:txBody>
+                  <a:tcPr marL="36576" marR="36576" marT="18288" marB="18288">
+                    <a:solidFill>
+                      <a:srgbClr val="00B2C9"/>
+                    </a:solidFill>
+                  </a:tcPr>
+                </a:tc>
+                <a:tc>
+                  <a:txBody>
+                    <a:bodyPr/>
+                    <a:lstStyle/>
+                    <a:p>
+                      <a:pPr algn="r"/>
+                      <a:r>
+                        <a:rPr sz="1000" b="1">
+                          <a:solidFill>
+                            <a:srgbClr val="FFFFFF"/>
+                          </a:solidFill>
+                          <a:latin typeface="Encode Sans"/>
+                        </a:rPr>
+                        <a:t>Original</a:t>
+                      </a:r>
+                    </a:p>
+                  </a:txBody>
+                  <a:tcPr marL="36576" marR="36576" marT="18288" marB="18288">
+                    <a:solidFill>
+                      <a:srgbClr val="00B2C9"/>
+                    </a:solidFill>
+                  </a:tcPr>
+                </a:tc>
+                <a:tc>
+                  <a:txBody>
+                    <a:bodyPr/>
+                    <a:lstStyle/>
+                    <a:p>
+                      <a:pPr algn="r"/>
+                      <a:r>
+                        <a:rPr sz="1000" b="1">
+                          <a:solidFill>
+                            <a:srgbClr val="FFFFFF"/>
+                          </a:solidFill>
+                          <a:latin typeface="Encode Sans"/>
+                        </a:rPr>
+                        <a:t>VIA %</a:t>
+                      </a:r>
+                    </a:p>
+                  </a:txBody>
+                  <a:tcPr marL="36576" marR="36576" marT="18288" marB="18288">
+                    <a:solidFill>
+                      <a:srgbClr val="00B2C9"/>
+                    </a:solidFill>
+                  </a:tcPr>
+                </a:tc>
+              </a:tr>
+              <a:tr h="292608">
+                <a:tc>
+                  <a:txBody>
+                    <a:bodyPr/>
+                    <a:lstStyle/>
+                    <a:p>
+                      <a:pPr algn="l"/>
+                      <a:r>
+                        <a:rPr sz="1000">
+                          <a:solidFill>
+                            <a:srgbClr val="3F3F3F"/>
+                          </a:solidFill>
+                          <a:latin typeface="Encode Sans"/>
+                        </a:rPr>
+                        <a:t>Abril 2026</a:t>
+                      </a:r>
+                    </a:p>
+                  </a:txBody>
+                  <a:tcPr marL="36576" marR="36576" marT="18288" marB="18288">
+                    <a:solidFill>
+                      <a:srgbClr val="FFFFFF"/>
+                    </a:solidFill>
+                  </a:tcPr>
+                </a:tc>
+                <a:tc>
+                  <a:txBody>
+                    <a:bodyPr/>
+                    <a:lstStyle/>
+                    <a:p>
+                      <a:pPr algn="r"/>
+                      <a:r>
+                        <a:rPr sz="1000">
+                          <a:solidFill>
+                            <a:srgbClr val="3F3F3F"/>
+                          </a:solidFill>
+                          <a:latin typeface="Encode Sans"/>
+                        </a:rPr>
+                        <a:t>118,1</a:t>
+                      </a:r>
+                    </a:p>
+                  </a:txBody>
+                  <a:tcPr marL="36576" marR="36576" marT="18288" marB="18288">
+                    <a:solidFill>
+                      <a:srgbClr val="FFFFFF"/>
+                    </a:solidFill>
+                  </a:tcPr>
+                </a:tc>
+                <a:tc>
+                  <a:txBody>
+                    <a:bodyPr/>
+                    <a:lstStyle/>
+                    <a:p>
+                      <a:pPr algn="r"/>
+                      <a:r>
+                        <a:rPr sz="1000">
+                          <a:solidFill>
+                            <a:srgbClr val="3F3F3F"/>
+                          </a:solidFill>
+                          <a:latin typeface="Encode Sans"/>
+                        </a:rPr>
+                        <a:t>-2.8%</a:t>
+                      </a:r>
+                    </a:p>
+                  </a:txBody>
+                  <a:tcPr marL="36576" marR="36576" marT="18288" marB="18288">
+                    <a:solidFill>
+                      <a:srgbClr val="FFFFFF"/>
+                    </a:solidFill>
+                  </a:tcPr>
+                </a:tc>
+              </a:tr>
+              <a:tr h="292608">
+                <a:tc>
+                  <a:txBody>
+                    <a:bodyPr/>
+                    <a:lstStyle/>
+                    <a:p>
+                      <a:pPr algn="l"/>
+                      <a:r>
+                        <a:rPr sz="1000">
+                          <a:solidFill>
+                            <a:srgbClr val="3F3F3F"/>
+                          </a:solidFill>
+                          <a:latin typeface="Encode Sans"/>
+                        </a:rPr>
+                        <a:t>Marzo 2026</a:t>
+                      </a:r>
+                    </a:p>
+                  </a:txBody>
+                  <a:tcPr marL="36576" marR="36576" marT="18288" marB="18288">
+                    <a:solidFill>
+                      <a:srgbClr val="F8F8F6"/>
+                    </a:solidFill>
+                  </a:tcPr>
+                </a:tc>
+                <a:tc>
+                  <a:txBody>
+                    <a:bodyPr/>
+                    <a:lstStyle/>
+                    <a:p>
+                      <a:pPr algn="r"/>
+                      <a:r>
+                        <a:rPr sz="1000">
+                          <a:solidFill>
+                            <a:srgbClr val="3F3F3F"/>
+                          </a:solidFill>
+                          <a:latin typeface="Encode Sans"/>
+                        </a:rPr>
+                        <a:t>122,2</a:t>
+                      </a:r>
+                    </a:p>
+                  </a:txBody>
+                  <a:tcPr marL="36576" marR="36576" marT="18288" marB="18288">
+                    <a:solidFill>
+                      <a:srgbClr val="F8F8F6"/>
+                    </a:solidFill>
+                  </a:tcPr>
+                </a:tc>
+                <a:tc>
+                  <a:txBody>
+                    <a:bodyPr/>
+                    <a:lstStyle/>
+                    <a:p>
+                      <a:pPr algn="r"/>
+                      <a:r>
+                        <a:rPr sz="1000">
+                          <a:solidFill>
+                            <a:srgbClr val="3F3F3F"/>
+                          </a:solidFill>
+                          <a:latin typeface="Encode Sans"/>
+                        </a:rPr>
+                        <a:t>+5.1%</a:t>
+                      </a:r>
+                    </a:p>
+                  </a:txBody>
+                  <a:tcPr marL="36576" marR="36576" marT="18288" marB="18288">
+                    <a:solidFill>
+                      <a:srgbClr val="F8F8F6"/>
+                    </a:solidFill>
+                  </a:tcPr>
+                </a:tc>
+              </a:tr>
+              <a:tr h="292608">
+                <a:tc>
+                  <a:txBody>
+                    <a:bodyPr/>
+                    <a:lstStyle/>
+                    <a:p>
+                      <a:pPr algn="l"/>
+                      <a:r>
+                        <a:rPr sz="1000">
+                          <a:solidFill>
+                            <a:srgbClr val="3F3F3F"/>
+                          </a:solidFill>
+                          <a:latin typeface="Encode Sans"/>
+                        </a:rPr>
+                        <a:t>Febrero 2026</a:t>
+                      </a:r>
+                    </a:p>
+                  </a:txBody>
+                  <a:tcPr marL="36576" marR="36576" marT="18288" marB="18288">
+                    <a:solidFill>
+                      <a:srgbClr val="FFFFFF"/>
+                    </a:solidFill>
+                  </a:tcPr>
+                </a:tc>
+                <a:tc>
+                  <a:txBody>
+                    <a:bodyPr/>
+                    <a:lstStyle/>
+                    <a:p>
+                      <a:pPr algn="r"/>
+                      <a:r>
+                        <a:rPr sz="1000">
+                          <a:solidFill>
+                            <a:srgbClr val="3F3F3F"/>
+                          </a:solidFill>
+                          <a:latin typeface="Encode Sans"/>
+                        </a:rPr>
+                        <a:t>100,3</a:t>
+                      </a:r>
+                    </a:p>
+                  </a:txBody>
+                  <a:tcPr marL="36576" marR="36576" marT="18288" marB="18288">
+                    <a:solidFill>
+                      <a:srgbClr val="FFFFFF"/>
+                    </a:solidFill>
+                  </a:tcPr>
+                </a:tc>
+                <a:tc>
+                  <a:txBody>
+                    <a:bodyPr/>
+                    <a:lstStyle/>
+                    <a:p>
+                      <a:pPr algn="r"/>
+                      <a:r>
+                        <a:rPr sz="1000">
+                          <a:solidFill>
+                            <a:srgbClr val="3F3F3F"/>
+                          </a:solidFill>
+                          <a:latin typeface="Encode Sans"/>
+                        </a:rPr>
+                        <a:t>-8.8%</a:t>
+                      </a:r>
+                    </a:p>
+                  </a:txBody>
+                  <a:tcPr marL="36576" marR="36576" marT="18288" marB="18288">
+                    <a:solidFill>
+                      <a:srgbClr val="FFFFFF"/>
+                    </a:solidFill>
+                  </a:tcPr>
+                </a:tc>
+              </a:tr>
+              <a:tr h="292608">
+                <a:tc>
+                  <a:txBody>
+                    <a:bodyPr/>
+                    <a:lstStyle/>
+                    <a:p>
+                      <a:pPr algn="l"/>
+                      <a:r>
+                        <a:rPr sz="1000">
+                          <a:solidFill>
+                            <a:srgbClr val="3F3F3F"/>
+                          </a:solidFill>
+                          <a:latin typeface="Encode Sans"/>
+                        </a:rPr>
+                        <a:t>Enero 2026</a:t>
+                      </a:r>
+                    </a:p>
+                  </a:txBody>
+                  <a:tcPr marL="36576" marR="36576" marT="18288" marB="18288">
+                    <a:solidFill>
+                      <a:srgbClr val="F8F8F6"/>
+                    </a:solidFill>
+                  </a:tcPr>
+                </a:tc>
+                <a:tc>
+                  <a:txBody>
+                    <a:bodyPr/>
+                    <a:lstStyle/>
+                    <a:p>
+                      <a:pPr algn="r"/>
+                      <a:r>
+                        <a:rPr sz="1000">
+                          <a:solidFill>
+                            <a:srgbClr val="3F3F3F"/>
+                          </a:solidFill>
+                          <a:latin typeface="Encode Sans"/>
+                        </a:rPr>
+                        <a:t>106,6</a:t>
+                      </a:r>
+                    </a:p>
+                  </a:txBody>
+                  <a:tcPr marL="36576" marR="36576" marT="18288" marB="18288">
+                    <a:solidFill>
+                      <a:srgbClr val="F8F8F6"/>
+                    </a:solidFill>
+                  </a:tcPr>
+                </a:tc>
+                <a:tc>
+                  <a:txBody>
+                    <a:bodyPr/>
+                    <a:lstStyle/>
+                    <a:p>
+                      <a:pPr algn="r"/>
+                      <a:r>
+                        <a:rPr sz="1000">
+                          <a:solidFill>
+                            <a:srgbClr val="3F3F3F"/>
+                          </a:solidFill>
+                          <a:latin typeface="Encode Sans"/>
+                        </a:rPr>
+                        <a:t>-3.7%</a:t>
+                      </a:r>
+                    </a:p>
+                  </a:txBody>
+                  <a:tcPr marL="36576" marR="36576" marT="18288" marB="18288">
+                    <a:solidFill>
+                      <a:srgbClr val="F8F8F6"/>
+                    </a:solidFill>
+                  </a:tcPr>
+                </a:tc>
+              </a:tr>
+              <a:tr h="292608">
+                <a:tc>
+                  <a:txBody>
+                    <a:bodyPr/>
+                    <a:lstStyle/>
+                    <a:p>
+                      <a:pPr algn="l"/>
+                      <a:r>
+                        <a:rPr sz="1000">
+                          <a:solidFill>
+                            <a:srgbClr val="3F3F3F"/>
+                          </a:solidFill>
+                          <a:latin typeface="Encode Sans"/>
+                        </a:rPr>
+                        <a:t>Diciembre 2025</a:t>
+                      </a:r>
+                    </a:p>
+                  </a:txBody>
+                  <a:tcPr marL="36576" marR="36576" marT="18288" marB="18288">
+                    <a:solidFill>
+                      <a:srgbClr val="FFFFFF"/>
+                    </a:solidFill>
+                  </a:tcPr>
+                </a:tc>
+                <a:tc>
+                  <a:txBody>
+                    <a:bodyPr/>
+                    <a:lstStyle/>
+                    <a:p>
+                      <a:pPr algn="r"/>
+                      <a:r>
+                        <a:rPr sz="1000">
+                          <a:solidFill>
+                            <a:srgbClr val="3F3F3F"/>
+                          </a:solidFill>
+                          <a:latin typeface="Encode Sans"/>
+                        </a:rPr>
+                        <a:t>112,0</a:t>
+                      </a:r>
+                    </a:p>
+                  </a:txBody>
+                  <a:tcPr marL="36576" marR="36576" marT="18288" marB="18288">
+                    <a:solidFill>
+                      <a:srgbClr val="FFFFFF"/>
+                    </a:solidFill>
+                  </a:tcPr>
+                </a:tc>
+                <a:tc>
+                  <a:txBody>
+                    <a:bodyPr/>
+                    <a:lstStyle/>
+                    <a:p>
+                      <a:pPr algn="r"/>
+                      <a:r>
+                        <a:rPr sz="1000">
+                          <a:solidFill>
+                            <a:srgbClr val="3F3F3F"/>
+                          </a:solidFill>
+                          <a:latin typeface="Encode Sans"/>
+                        </a:rPr>
+                        <a:t>-4.0%</a:t>
+                      </a:r>
+                    </a:p>
+                  </a:txBody>
+                  <a:tcPr marL="36576" marR="36576" marT="18288" marB="18288">
+                    <a:solidFill>
+                      <a:srgbClr val="FFFFFF"/>
+                    </a:solidFill>
+                  </a:tcPr>
+                </a:tc>
+              </a:tr>
+              <a:tr h="292608">
+                <a:tc>
+                  <a:txBody>
+                    <a:bodyPr/>
+                    <a:lstStyle/>
+                    <a:p>
+                      <a:pPr algn="l"/>
+                      <a:r>
+                        <a:rPr sz="1000">
+                          <a:solidFill>
+                            <a:srgbClr val="3F3F3F"/>
+                          </a:solidFill>
+                          <a:latin typeface="Encode Sans"/>
+                        </a:rPr>
+                        <a:t>Noviembre 2025</a:t>
+                      </a:r>
+                    </a:p>
+                  </a:txBody>
+                  <a:tcPr marL="36576" marR="36576" marT="18288" marB="18288">
+                    <a:solidFill>
+                      <a:srgbClr val="F8F8F6"/>
+                    </a:solidFill>
+                  </a:tcPr>
+                </a:tc>
+                <a:tc>
+                  <a:txBody>
+                    <a:bodyPr/>
+                    <a:lstStyle/>
+                    <a:p>
+                      <a:pPr algn="r"/>
+                      <a:r>
+                        <a:rPr sz="1000">
+                          <a:solidFill>
+                            <a:srgbClr val="3F3F3F"/>
+                          </a:solidFill>
+                          <a:latin typeface="Encode Sans"/>
+                        </a:rPr>
+                        <a:t>114,4</a:t>
+                      </a:r>
+                    </a:p>
+                  </a:txBody>
+                  <a:tcPr marL="36576" marR="36576" marT="18288" marB="18288">
+                    <a:solidFill>
+                      <a:srgbClr val="F8F8F6"/>
+                    </a:solidFill>
+                  </a:tcPr>
+                </a:tc>
+                <a:tc>
+                  <a:txBody>
+                    <a:bodyPr/>
+                    <a:lstStyle/>
+                    <a:p>
+                      <a:pPr algn="r"/>
+                      <a:r>
+                        <a:rPr sz="1000">
+                          <a:solidFill>
+                            <a:srgbClr val="3F3F3F"/>
+                          </a:solidFill>
+                          <a:latin typeface="Encode Sans"/>
+                        </a:rPr>
+                        <a:t>-8.8%</a:t>
+                      </a:r>
+                    </a:p>
+                  </a:txBody>
+                  <a:tcPr marL="36576" marR="36576" marT="18288" marB="18288">
+                    <a:solidFill>
+                      <a:srgbClr val="F8F8F6"/>
+                    </a:solidFill>
+                  </a:tcPr>
+                </a:tc>
+              </a:tr>
+            </a:tbl>
+          </a:graphicData>
+        </a:graphic>
+      </p:graphicFrame>
+      <p:sp>
+        <p:nvSpPr>
+          <p:cNvPr id="9" name="TextBox 8"/>
+          <p:cNvSpPr txBox="1"/>
+          <p:nvPr/>
+        </p:nvSpPr>
+        <p:spPr>
+          <a:xfrm>
+            <a:off x="411480" y="6492240"/>
+            <a:ext cx="11368735" cy="274320"/>
+          </a:xfrm>
+          <a:prstGeom prst="rect">
+            <a:avLst/>
+          </a:prstGeom>
+          <a:noFill/>
+        </p:spPr>
+        <p:txBody>
+          <a:bodyPr wrap="none">
+            <a:spAutoFit/>
+          </a:bodyPr>
+          <a:lstStyle/>
+          <a:p>
+            <a:r>
+              <a:rPr sz="1000" b="0" i="1">
+                <a:solidFill>
+                  <a:srgbClr val="6A6760"/>
+                </a:solidFill>
+                <a:latin typeface="Encode Sans"/>
+              </a:rPr>
+              <a:t>Fuente: elaboración propia en base a INDEC</a:t>
+            </a:r>
+          </a:p>
+        </p:txBody>
+      </p:sp>
+    </p:spTree>
+  </p:cSld>
+  <p:clrMapOvr>
+    <a:masterClrMapping/>
+  </p:clrMapOvr>
+</p:sld>
+</file>
+
+<file path=ppt/slides/slide4.xml><?xml version="1.0" encoding="utf-8"?>
+<p:sld xmlns:a="http://schemas.openxmlformats.org/drawingml/2006/main" xmlns:p="http://schemas.openxmlformats.org/presentationml/2006/main" xmlns:r="http://schemas.openxmlformats.org/officeDocument/2006/relationships">
+  <p:cSld>
+    <p:spTree>
+      <p:nvGrpSpPr>
+        <p:cNvPr id="1" name=""/>
+        <p:cNvGrpSpPr/>
+        <p:nvPr/>
+      </p:nvGrpSpPr>
+      <p:grpSpPr/>
+      <p:sp>
+        <p:nvSpPr>
+          <p:cNvPr id="2" name="Rectangle 1"/>
+          <p:cNvSpPr/>
+          <p:nvPr/>
+        </p:nvSpPr>
+        <p:spPr>
+          <a:xfrm>
+            <a:off x="0" y="0"/>
+            <a:ext cx="12191695" cy="274320"/>
+          </a:xfrm>
+          <a:prstGeom prst="rect">
+            <a:avLst/>
+          </a:prstGeom>
+          <a:solidFill>
+            <a:srgbClr val="00B2C9"/>
+          </a:solidFill>
+          <a:ln>
+            <a:noFill/>
+          </a:ln>
+        </p:spPr>
+        <p:style>
+          <a:lnRef idx="1">
+            <a:schemeClr val="accent1"/>
+          </a:lnRef>
+          <a:fillRef idx="3">
+            <a:schemeClr val="accent1"/>
+          </a:fillRef>
+          <a:effectRef idx="2">
+            <a:schemeClr val="accent1"/>
+          </a:effectRef>
+          <a:fontRef idx="minor">
+            <a:schemeClr val="lt1"/>
+          </a:fontRef>
+        </p:style>
+        <p:txBody>
+          <a:bodyPr rtlCol="0" anchor="ctr"/>
+          <a:lstStyle/>
+          <a:p>
+            <a:pPr algn="ctr"/>
+          </a:p>
+        </p:txBody>
+      </p:sp>
+      <p:sp>
+        <p:nvSpPr>
+          <p:cNvPr id="3" name="TextBox 2"/>
+          <p:cNvSpPr txBox="1"/>
+          <p:nvPr/>
+        </p:nvSpPr>
+        <p:spPr>
+          <a:xfrm>
+            <a:off x="411480" y="457200"/>
+            <a:ext cx="11368735" cy="914400"/>
+          </a:xfrm>
+          <a:prstGeom prst="rect">
+            <a:avLst/>
+          </a:prstGeom>
+          <a:noFill/>
+        </p:spPr>
+        <p:txBody>
+          <a:bodyPr wrap="square" lIns="0" rIns="0">
+            <a:spAutoFit/>
+          </a:bodyPr>
+          <a:lstStyle/>
+          <a:p>
+            <a:pPr algn="l"/>
+            <a:r>
+              <a:rPr sz="2600" b="1" i="0">
+                <a:solidFill>
+                  <a:srgbClr val="00B2C9"/>
+                </a:solidFill>
+                <a:latin typeface="Encode Sans"/>
+              </a:rPr>
+              <a:t>INFLACIÓN MAYO 2026: +2.1%</a:t>
+            </a:r>
+          </a:p>
+        </p:txBody>
+      </p:sp>
+      <p:sp>
+        <p:nvSpPr>
+          <p:cNvPr id="4" name="TextBox 3"/>
+          <p:cNvSpPr txBox="1"/>
+          <p:nvPr/>
+        </p:nvSpPr>
+        <p:spPr>
+          <a:xfrm>
+            <a:off x="411480" y="1280160"/>
+            <a:ext cx="11368735" cy="274320"/>
+          </a:xfrm>
+          <a:prstGeom prst="rect">
+            <a:avLst/>
+          </a:prstGeom>
+          <a:noFill/>
+        </p:spPr>
+        <p:txBody>
+          <a:bodyPr wrap="none">
+            <a:spAutoFit/>
+          </a:bodyPr>
+          <a:lstStyle/>
+          <a:p>
+            <a:r>
+              <a:rPr sz="1100" b="0" i="1">
+                <a:solidFill>
+                  <a:srgbClr val="6A6760"/>
+                </a:solidFill>
+                <a:latin typeface="Encode Sans"/>
+              </a:rPr>
+              <a:t>INDEC · período 2026-05</a:t>
+            </a:r>
+          </a:p>
+        </p:txBody>
+      </p:sp>
+      <p:sp>
+        <p:nvSpPr>
+          <p:cNvPr id="5" name="TextBox 4"/>
+          <p:cNvSpPr txBox="1"/>
+          <p:nvPr/>
+        </p:nvSpPr>
+        <p:spPr>
+          <a:xfrm>
+            <a:off x="411480" y="1691640"/>
+            <a:ext cx="5486400" cy="1645920"/>
+          </a:xfrm>
+          <a:prstGeom prst="rect">
+            <a:avLst/>
+          </a:prstGeom>
+          <a:noFill/>
+        </p:spPr>
+        <p:txBody>
+          <a:bodyPr wrap="square" lIns="0" rIns="0">
+            <a:spAutoFit/>
+          </a:bodyPr>
+          <a:lstStyle/>
+          <a:p>
+            <a:pPr algn="just"/>
+            <a:r>
+              <a:rPr sz="1300" b="0" i="0">
+                <a:solidFill>
+                  <a:srgbClr val="3F3F3F"/>
+                </a:solidFill>
+                <a:latin typeface="Encode Sans"/>
+              </a:rPr>
+              <a:t>El IPC nivel general aumentó +2.1% mensual en mayo 2026, acumulando 33.13% interanual. INDEC publicó el indicador con la metodología vigente.</a:t>
+            </a:r>
+          </a:p>
+        </p:txBody>
+      </p:sp>
+      <p:sp>
+        <p:nvSpPr>
+          <p:cNvPr id="6" name="TextBox 5"/>
+          <p:cNvSpPr txBox="1"/>
+          <p:nvPr/>
+        </p:nvSpPr>
+        <p:spPr>
+          <a:xfrm>
+            <a:off x="411480" y="3520440"/>
+            <a:ext cx="5486400" cy="2743200"/>
+          </a:xfrm>
+          <a:prstGeom prst="rect">
+            <a:avLst/>
+          </a:prstGeom>
+          <a:noFill/>
+        </p:spPr>
+        <p:txBody>
+          <a:bodyPr wrap="square" lIns="0" rIns="0">
+            <a:spAutoFit/>
+          </a:bodyPr>
+          <a:lstStyle/>
+          <a:p>
+            <a:pPr algn="l">
+              <a:spcAft>
+                <a:spcPts val="800"/>
+              </a:spcAft>
+            </a:pPr>
+            <a:r>
+              <a:rPr sz="1300" b="1" i="0">
+                <a:solidFill>
+                  <a:srgbClr val="00B2C9"/>
+                </a:solidFill>
+                <a:latin typeface="Encode Sans"/>
+              </a:rPr>
+              <a:t>●  </a:t>
+            </a:r>
+            <a:r>
+              <a:rPr sz="1300" b="0" i="0">
+                <a:solidFill>
+                  <a:srgbClr val="3F3F3F"/>
+                </a:solidFill>
+                <a:latin typeface="Encode Sans"/>
+              </a:rPr>
+              <a:t>Variación mensual: +2.1%</a:t>
+            </a:r>
+          </a:p>
+          <a:p>
+            <a:pPr algn="l">
+              <a:spcAft>
+                <a:spcPts val="800"/>
+              </a:spcAft>
+            </a:pPr>
+            <a:r>
+              <a:rPr sz="1300" b="1" i="0">
+                <a:solidFill>
+                  <a:srgbClr val="00B2C9"/>
+                </a:solidFill>
+                <a:latin typeface="Encode Sans"/>
+              </a:rPr>
+              <a:t>●  </a:t>
+            </a:r>
+            <a:r>
+              <a:rPr sz="1300" b="0" i="0">
+                <a:solidFill>
+                  <a:srgbClr val="3F3F3F"/>
+                </a:solidFill>
+                <a:latin typeface="Encode Sans"/>
+              </a:rPr>
+              <a:t>Variación interanual: 33.13%</a:t>
+            </a:r>
+          </a:p>
+          <a:p>
+            <a:pPr algn="l">
+              <a:spcAft>
+                <a:spcPts val="800"/>
+              </a:spcAft>
+            </a:pPr>
+            <a:r>
+              <a:rPr sz="1300" b="1" i="0">
+                <a:solidFill>
+                  <a:srgbClr val="00B2C9"/>
+                </a:solidFill>
+                <a:latin typeface="Encode Sans"/>
+              </a:rPr>
+              <a:t>●  </a:t>
+            </a:r>
+            <a:r>
+              <a:rPr sz="1300" b="0" i="0">
+                <a:solidFill>
+                  <a:srgbClr val="3F3F3F"/>
+                </a:solidFill>
+                <a:latin typeface="Encode Sans"/>
+              </a:rPr>
+              <a:t>Acumulado últimos 6 meses: 16.7% (suma simple)</a:t>
+            </a:r>
+          </a:p>
+        </p:txBody>
+      </p:sp>
+      <p:pic>
+        <p:nvPicPr>
+          <p:cNvPr id="7" name="Picture 6" descr="image.png"/>
+          <p:cNvPicPr>
+            <a:picLocks noChangeAspect="1"/>
+          </p:cNvPicPr>
+          <p:nvPr/>
+        </p:nvPicPr>
+        <p:blipFill>
+          <a:blip r:embed="rId2"/>
+          <a:stretch>
+            <a:fillRect/>
+          </a:stretch>
+        </p:blipFill>
+        <p:spPr>
+          <a:xfrm>
+            <a:off x="6080760" y="1691640"/>
+            <a:ext cx="5669280" cy="2560320"/>
+          </a:xfrm>
+          <a:prstGeom prst="rect">
+            <a:avLst/>
+          </a:prstGeom>
+        </p:spPr>
+      </p:pic>
+      <p:graphicFrame>
+        <p:nvGraphicFramePr>
+          <p:cNvPr id="8" name="Table 7"/>
+          <p:cNvGraphicFramePr>
+            <a:graphicFrameLocks noGrp="1"/>
+          </p:cNvGraphicFramePr>
+          <p:nvPr/>
+        </p:nvGraphicFramePr>
+        <p:xfrm>
+          <a:off x="6080760" y="4434840"/>
+          <a:ext cx="5669280" cy="2048256"/>
+        </p:xfrm>
+        <a:graphic>
+          <a:graphicData uri="http://schemas.openxmlformats.org/drawingml/2006/table">
+            <a:tbl>
+              <a:tblPr firstRow="1" bandRow="1">
+                <a:tableStyleId>{5C22544A-7EE6-4342-B048-85BDC9FD1C3A}</a:tableStyleId>
+              </a:tblPr>
+              <a:tblGrid>
+                <a:gridCol w="1889760"/>
+                <a:gridCol w="1889760"/>
+                <a:gridCol w="1889760"/>
+              </a:tblGrid>
+              <a:tr h="292608">
+                <a:tc>
+                  <a:txBody>
+                    <a:bodyPr/>
+                    <a:lstStyle/>
+                    <a:p>
+                      <a:pPr algn="l"/>
+                      <a:r>
+                        <a:rPr sz="1000" b="1">
+                          <a:solidFill>
+                            <a:srgbClr val="FFFFFF"/>
+                          </a:solidFill>
+                          <a:latin typeface="Encode Sans"/>
+                        </a:rPr>
+                        <a:t>Mes</a:t>
+                      </a:r>
+                    </a:p>
+                  </a:txBody>
+                  <a:tcPr marL="36576" marR="36576" marT="18288" marB="18288">
+                    <a:solidFill>
+                      <a:srgbClr val="00B2C9"/>
+                    </a:solidFill>
+                  </a:tcPr>
+                </a:tc>
+                <a:tc>
+                  <a:txBody>
+                    <a:bodyPr/>
+                    <a:lstStyle/>
+                    <a:p>
+                      <a:pPr algn="r"/>
+                      <a:r>
+                        <a:rPr sz="1000" b="1">
+                          <a:solidFill>
+                            <a:srgbClr val="FFFFFF"/>
+                          </a:solidFill>
+                          <a:latin typeface="Encode Sans"/>
+                        </a:rPr>
+                        <a:t>VM %</a:t>
+                      </a:r>
+                    </a:p>
+                  </a:txBody>
+                  <a:tcPr marL="36576" marR="36576" marT="18288" marB="18288">
+                    <a:solidFill>
+                      <a:srgbClr val="00B2C9"/>
+                    </a:solidFill>
+                  </a:tcPr>
+                </a:tc>
+                <a:tc>
+                  <a:txBody>
+                    <a:bodyPr/>
+                    <a:lstStyle/>
+                    <a:p>
+                      <a:pPr algn="r"/>
+                      <a:r>
+                        <a:rPr sz="1000" b="1">
+                          <a:solidFill>
+                            <a:srgbClr val="FFFFFF"/>
+                          </a:solidFill>
+                          <a:latin typeface="Encode Sans"/>
+                        </a:rPr>
+                        <a:t>VIA %</a:t>
+                      </a:r>
+                    </a:p>
+                  </a:txBody>
+                  <a:tcPr marL="36576" marR="36576" marT="18288" marB="18288">
+                    <a:solidFill>
+                      <a:srgbClr val="00B2C9"/>
+                    </a:solidFill>
+                  </a:tcPr>
+                </a:tc>
+              </a:tr>
+              <a:tr h="292608">
+                <a:tc>
+                  <a:txBody>
+                    <a:bodyPr/>
+                    <a:lstStyle/>
+                    <a:p>
+                      <a:pPr algn="l"/>
+                      <a:r>
+                        <a:rPr sz="1000">
+                          <a:solidFill>
+                            <a:srgbClr val="3F3F3F"/>
+                          </a:solidFill>
+                          <a:latin typeface="Encode Sans"/>
+                        </a:rPr>
+                        <a:t>Mayo 2026</a:t>
+                      </a:r>
+                    </a:p>
+                  </a:txBody>
+                  <a:tcPr marL="36576" marR="36576" marT="18288" marB="18288">
+                    <a:solidFill>
+                      <a:srgbClr val="FFFFFF"/>
+                    </a:solidFill>
+                  </a:tcPr>
+                </a:tc>
+                <a:tc>
+                  <a:txBody>
+                    <a:bodyPr/>
+                    <a:lstStyle/>
+                    <a:p>
+                      <a:pPr algn="r"/>
+                      <a:r>
+                        <a:rPr sz="1000">
+                          <a:solidFill>
+                            <a:srgbClr val="3F3F3F"/>
+                          </a:solidFill>
+                          <a:latin typeface="Encode Sans"/>
+                        </a:rPr>
+                        <a:t>+2.1%</a:t>
+                      </a:r>
+                    </a:p>
+                  </a:txBody>
+                  <a:tcPr marL="36576" marR="36576" marT="18288" marB="18288">
+                    <a:solidFill>
+                      <a:srgbClr val="FFFFFF"/>
+                    </a:solidFill>
+                  </a:tcPr>
+                </a:tc>
+                <a:tc>
+                  <a:txBody>
+                    <a:bodyPr/>
+                    <a:lstStyle/>
+                    <a:p>
+                      <a:pPr algn="r"/>
+                      <a:r>
+                        <a:rPr sz="1000">
+                          <a:solidFill>
+                            <a:srgbClr val="3F3F3F"/>
+                          </a:solidFill>
+                          <a:latin typeface="Encode Sans"/>
+                        </a:rPr>
+                        <a:t>+33.1%</a:t>
+                      </a:r>
+                    </a:p>
+                  </a:txBody>
+                  <a:tcPr marL="36576" marR="36576" marT="18288" marB="18288">
+                    <a:solidFill>
+                      <a:srgbClr val="FFFFFF"/>
+                    </a:solidFill>
+                  </a:tcPr>
+                </a:tc>
+              </a:tr>
+              <a:tr h="292608">
+                <a:tc>
+                  <a:txBody>
+                    <a:bodyPr/>
+                    <a:lstStyle/>
+                    <a:p>
+                      <a:pPr algn="l"/>
+                      <a:r>
+                        <a:rPr sz="1000">
+                          <a:solidFill>
+                            <a:srgbClr val="3F3F3F"/>
+                          </a:solidFill>
+                          <a:latin typeface="Encode Sans"/>
+                        </a:rPr>
+                        <a:t>Abril 2026</a:t>
+                      </a:r>
+                    </a:p>
+                  </a:txBody>
+                  <a:tcPr marL="36576" marR="36576" marT="18288" marB="18288">
+                    <a:solidFill>
+                      <a:srgbClr val="F8F8F6"/>
+                    </a:solidFill>
+                  </a:tcPr>
+                </a:tc>
+                <a:tc>
+                  <a:txBody>
+                    <a:bodyPr/>
+                    <a:lstStyle/>
+                    <a:p>
+                      <a:pPr algn="r"/>
+                      <a:r>
+                        <a:rPr sz="1000">
+                          <a:solidFill>
+                            <a:srgbClr val="3F3F3F"/>
+                          </a:solidFill>
+                          <a:latin typeface="Encode Sans"/>
+                        </a:rPr>
+                        <a:t>+2.6%</a:t>
+                      </a:r>
+                    </a:p>
+                  </a:txBody>
+                  <a:tcPr marL="36576" marR="36576" marT="18288" marB="18288">
+                    <a:solidFill>
+                      <a:srgbClr val="F8F8F6"/>
+                    </a:solidFill>
+                  </a:tcPr>
+                </a:tc>
+                <a:tc>
+                  <a:txBody>
+                    <a:bodyPr/>
+                    <a:lstStyle/>
+                    <a:p>
+                      <a:pPr algn="r"/>
+                      <a:r>
+                        <a:rPr sz="1000">
+                          <a:solidFill>
+                            <a:srgbClr val="3F3F3F"/>
+                          </a:solidFill>
+                          <a:latin typeface="Encode Sans"/>
+                        </a:rPr>
+                        <a:t>+32.4%</a:t>
+                      </a:r>
+                    </a:p>
+                  </a:txBody>
+                  <a:tcPr marL="36576" marR="36576" marT="18288" marB="18288">
+                    <a:solidFill>
+                      <a:srgbClr val="F8F8F6"/>
+                    </a:solidFill>
+                  </a:tcPr>
+                </a:tc>
+              </a:tr>
+              <a:tr h="292608">
+                <a:tc>
+                  <a:txBody>
+                    <a:bodyPr/>
+                    <a:lstStyle/>
+                    <a:p>
+                      <a:pPr algn="l"/>
+                      <a:r>
+                        <a:rPr sz="1000">
+                          <a:solidFill>
+                            <a:srgbClr val="3F3F3F"/>
+                          </a:solidFill>
+                          <a:latin typeface="Encode Sans"/>
+                        </a:rPr>
+                        <a:t>Marzo 2026</a:t>
+                      </a:r>
+                    </a:p>
+                  </a:txBody>
+                  <a:tcPr marL="36576" marR="36576" marT="18288" marB="18288">
+                    <a:solidFill>
+                      <a:srgbClr val="FFFFFF"/>
+                    </a:solidFill>
+                  </a:tcPr>
+                </a:tc>
+                <a:tc>
+                  <a:txBody>
+                    <a:bodyPr/>
+                    <a:lstStyle/>
+                    <a:p>
+                      <a:pPr algn="r"/>
+                      <a:r>
+                        <a:rPr sz="1000">
+                          <a:solidFill>
+                            <a:srgbClr val="3F3F3F"/>
+                          </a:solidFill>
+                          <a:latin typeface="Encode Sans"/>
+                        </a:rPr>
+                        <a:t>+3.4%</a:t>
+                      </a:r>
+                    </a:p>
+                  </a:txBody>
+                  <a:tcPr marL="36576" marR="36576" marT="18288" marB="18288">
+                    <a:solidFill>
+                      <a:srgbClr val="FFFFFF"/>
+                    </a:solidFill>
+                  </a:tcPr>
+                </a:tc>
+                <a:tc>
+                  <a:txBody>
+                    <a:bodyPr/>
+                    <a:lstStyle/>
+                    <a:p>
+                      <a:pPr algn="r"/>
+                      <a:r>
+                        <a:rPr sz="1000">
+                          <a:solidFill>
+                            <a:srgbClr val="3F3F3F"/>
+                          </a:solidFill>
+                          <a:latin typeface="Encode Sans"/>
+                        </a:rPr>
+                        <a:t>+32.6%</a:t>
+                      </a:r>
+                    </a:p>
+                  </a:txBody>
+                  <a:tcPr marL="36576" marR="36576" marT="18288" marB="18288">
+                    <a:solidFill>
+                      <a:srgbClr val="FFFFFF"/>
+                    </a:solidFill>
+                  </a:tcPr>
+                </a:tc>
+              </a:tr>
+              <a:tr h="292608">
+                <a:tc>
+                  <a:txBody>
+                    <a:bodyPr/>
+                    <a:lstStyle/>
+                    <a:p>
+                      <a:pPr algn="l"/>
+                      <a:r>
+                        <a:rPr sz="1000">
+                          <a:solidFill>
+                            <a:srgbClr val="3F3F3F"/>
+                          </a:solidFill>
+                          <a:latin typeface="Encode Sans"/>
+                        </a:rPr>
+                        <a:t>Febrero 2026</a:t>
+                      </a:r>
+                    </a:p>
+                  </a:txBody>
+                  <a:tcPr marL="36576" marR="36576" marT="18288" marB="18288">
+                    <a:solidFill>
+                      <a:srgbClr val="F8F8F6"/>
+                    </a:solidFill>
+                  </a:tcPr>
+                </a:tc>
+                <a:tc>
+                  <a:txBody>
+                    <a:bodyPr/>
+                    <a:lstStyle/>
+                    <a:p>
+                      <a:pPr algn="r"/>
+                      <a:r>
+                        <a:rPr sz="1000">
+                          <a:solidFill>
+                            <a:srgbClr val="3F3F3F"/>
+                          </a:solidFill>
+                          <a:latin typeface="Encode Sans"/>
+                        </a:rPr>
+                        <a:t>+2.9%</a:t>
+                      </a:r>
+                    </a:p>
+                  </a:txBody>
+                  <a:tcPr marL="36576" marR="36576" marT="18288" marB="18288">
+                    <a:solidFill>
+                      <a:srgbClr val="F8F8F6"/>
+                    </a:solidFill>
+                  </a:tcPr>
+                </a:tc>
+                <a:tc>
+                  <a:txBody>
+                    <a:bodyPr/>
+                    <a:lstStyle/>
+                    <a:p>
+                      <a:pPr algn="r"/>
+                      <a:r>
+                        <a:rPr sz="1000">
+                          <a:solidFill>
+                            <a:srgbClr val="3F3F3F"/>
+                          </a:solidFill>
+                          <a:latin typeface="Encode Sans"/>
+                        </a:rPr>
+                        <a:t>+33.0%</a:t>
+                      </a:r>
+                    </a:p>
+                  </a:txBody>
+                  <a:tcPr marL="36576" marR="36576" marT="18288" marB="18288">
+                    <a:solidFill>
+                      <a:srgbClr val="F8F8F6"/>
+                    </a:solidFill>
+                  </a:tcPr>
+                </a:tc>
+              </a:tr>
+              <a:tr h="292608">
+                <a:tc>
+                  <a:txBody>
+                    <a:bodyPr/>
+                    <a:lstStyle/>
+                    <a:p>
+                      <a:pPr algn="l"/>
+                      <a:r>
+                        <a:rPr sz="1000">
+                          <a:solidFill>
+                            <a:srgbClr val="3F3F3F"/>
+                          </a:solidFill>
+                          <a:latin typeface="Encode Sans"/>
+                        </a:rPr>
+                        <a:t>Enero 2026</a:t>
+                      </a:r>
+                    </a:p>
+                  </a:txBody>
+                  <a:tcPr marL="36576" marR="36576" marT="18288" marB="18288">
+                    <a:solidFill>
+                      <a:srgbClr val="FFFFFF"/>
+                    </a:solidFill>
+                  </a:tcPr>
+                </a:tc>
+                <a:tc>
+                  <a:txBody>
+                    <a:bodyPr/>
+                    <a:lstStyle/>
+                    <a:p>
+                      <a:pPr algn="r"/>
+                      <a:r>
+                        <a:rPr sz="1000">
+                          <a:solidFill>
+                            <a:srgbClr val="3F3F3F"/>
+                          </a:solidFill>
+                          <a:latin typeface="Encode Sans"/>
+                        </a:rPr>
+                        <a:t>+2.9%</a:t>
+                      </a:r>
+                    </a:p>
+                  </a:txBody>
+                  <a:tcPr marL="36576" marR="36576" marT="18288" marB="18288">
+                    <a:solidFill>
+                      <a:srgbClr val="FFFFFF"/>
+                    </a:solidFill>
+                  </a:tcPr>
+                </a:tc>
+                <a:tc>
+                  <a:txBody>
+                    <a:bodyPr/>
+                    <a:lstStyle/>
+                    <a:p>
+                      <a:pPr algn="r"/>
+                      <a:r>
+                        <a:rPr sz="1000">
+                          <a:solidFill>
+                            <a:srgbClr val="3F3F3F"/>
+                          </a:solidFill>
+                          <a:latin typeface="Encode Sans"/>
+                        </a:rPr>
+                        <a:t>+32.4%</a:t>
+                      </a:r>
+                    </a:p>
+                  </a:txBody>
+                  <a:tcPr marL="36576" marR="36576" marT="18288" marB="18288">
+                    <a:solidFill>
+                      <a:srgbClr val="FFFFFF"/>
+                    </a:solidFill>
+                  </a:tcPr>
+                </a:tc>
+              </a:tr>
+              <a:tr h="292608">
+                <a:tc>
+                  <a:txBody>
+                    <a:bodyPr/>
+                    <a:lstStyle/>
+                    <a:p>
+                      <a:pPr algn="l"/>
+                      <a:r>
+                        <a:rPr sz="1000">
+                          <a:solidFill>
+                            <a:srgbClr val="3F3F3F"/>
+                          </a:solidFill>
+                          <a:latin typeface="Encode Sans"/>
+                        </a:rPr>
+                        <a:t>Diciembre 2025</a:t>
+                      </a:r>
+                    </a:p>
+                  </a:txBody>
+                  <a:tcPr marL="36576" marR="36576" marT="18288" marB="18288">
+                    <a:solidFill>
+                      <a:srgbClr val="F8F8F6"/>
+                    </a:solidFill>
+                  </a:tcPr>
+                </a:tc>
+                <a:tc>
+                  <a:txBody>
+                    <a:bodyPr/>
+                    <a:lstStyle/>
+                    <a:p>
+                      <a:pPr algn="r"/>
+                      <a:r>
+                        <a:rPr sz="1000">
+                          <a:solidFill>
+                            <a:srgbClr val="3F3F3F"/>
+                          </a:solidFill>
+                          <a:latin typeface="Encode Sans"/>
+                        </a:rPr>
+                        <a:t>+2.9%</a:t>
+                      </a:r>
+                    </a:p>
+                  </a:txBody>
+                  <a:tcPr marL="36576" marR="36576" marT="18288" marB="18288">
+                    <a:solidFill>
+                      <a:srgbClr val="F8F8F6"/>
+                    </a:solidFill>
+                  </a:tcPr>
+                </a:tc>
+                <a:tc>
+                  <a:txBody>
+                    <a:bodyPr/>
+                    <a:lstStyle/>
+                    <a:p>
+                      <a:pPr algn="r"/>
+                      <a:r>
+                        <a:rPr sz="1000">
+                          <a:solidFill>
+                            <a:srgbClr val="3F3F3F"/>
+                          </a:solidFill>
+                          <a:latin typeface="Encode Sans"/>
+                        </a:rPr>
+                        <a:t>+31.6%</a:t>
                       </a:r>
                     </a:p>
                   </a:txBody>

</xml_diff>

<commit_message>
data: update 2026-06-12 ( data.json despidos.json scraper/historical_despidos.json publicaciones_semana.pptx rrii_brutas.xlsx)
</commit_message>
<xml_diff>
--- a/publicaciones_semana.pptx
+++ b/publicaciones_semana.pptx
@@ -5079,7 +5079,7 @@
                 </a:solidFill>
                 <a:latin typeface="Encode Sans"/>
               </a:rPr>
-              <a:t>El IPC nivel general aumentó +2.1% mensual en mayo 2026, acumulando 33.13% interanual. INDEC publicó el indicador con la metodología vigente.</a:t>
+              <a:t>El IPC nivel general aumentó +2.1% mensual en mayo 2026, acumulando 33.2% interanual. INDEC publicó el indicador con la metodología vigente.</a:t>
             </a:r>
           </a:p>
         </p:txBody>
@@ -5152,7 +5152,7 @@
                 </a:solidFill>
                 <a:latin typeface="Encode Sans"/>
               </a:rPr>
-              <a:t>Variación interanual: 33.13%</a:t>
+              <a:t>Variación interanual: 33.2%</a:t>
             </a:r>
           </a:p>
           <a:p>
@@ -5360,7 +5360,7 @@
                           </a:solidFill>
                           <a:latin typeface="Encode Sans"/>
                         </a:rPr>
-                        <a:t>+33.1%</a:t>
+                        <a:t>+33.2%</a:t>
                       </a:r>
                     </a:p>
                   </a:txBody>

</xml_diff>

<commit_message>
data: update 2026-06-16 ( data.json despidos.json scraper/historical_despidos.json publicaciones_semana.pptx rrii_brutas.xlsx)
</commit_message>
<xml_diff>
--- a/publicaciones_semana.pptx
+++ b/publicaciones_semana.pptx
@@ -7,8 +7,6 @@
   <p:sldIdLst>
     <p:sldId id="256" r:id="rId7"/>
     <p:sldId id="257" r:id="rId8"/>
-    <p:sldId id="258" r:id="rId9"/>
-    <p:sldId id="259" r:id="rId10"/>
   </p:sldIdLst>
   <p:sldSz cx="12191695" cy="6858000" type="screen4x3"/>
   <p:notesSz cx="6858000" cy="9144000"/>
@@ -3240,7 +3238,7 @@
                 </a:solidFill>
                 <a:latin typeface="Encode Sans"/>
               </a:rPr>
-              <a:t>Publicaciones de la semana del 08 de junio de 2026</a:t>
+              <a:t>Publicaciones de la semana del 15 de junio de 2026</a:t>
             </a:r>
           </a:p>
         </p:txBody>
@@ -3274,7 +3272,7 @@
                 </a:solidFill>
                 <a:latin typeface="Encode Sans"/>
               </a:rPr>
-              <a:t>3 publicaciones · datos oficiales INDEC / BCRA / Hacienda</a:t>
+              <a:t>1 publicaciones · datos oficiales INDEC / BCRA / Hacienda</a:t>
             </a:r>
           </a:p>
         </p:txBody>
@@ -3370,7 +3368,7 @@
                 </a:solidFill>
                 <a:latin typeface="Encode Sans"/>
               </a:rPr>
-              <a:t>INDUSTRIA ABRIL 2026: IPI CAYÓ -2.8% I.A.</a:t>
+              <a:t>INDUSTRIA ABRIL 2026: IPI CRECIÓ +0.0% I.A.</a:t>
             </a:r>
           </a:p>
         </p:txBody>
@@ -3439,7 +3437,7 @@
                 </a:solidFill>
                 <a:latin typeface="Encode Sans"/>
               </a:rPr>
-              <a:t>El Índice de Producción Industrial Manufacturero (IPI) registró una variación interanual de -2.8% en abril 2026.</a:t>
+              <a:t>El Índice de Producción Industrial Manufacturero (IPI) registró una variación interanual de +0.0% en abril 2026.</a:t>
             </a:r>
           </a:p>
         </p:txBody>
@@ -3487,7 +3485,7 @@
                 </a:solidFill>
                 <a:latin typeface="Encode Sans"/>
               </a:rPr>
-              <a:t>Variación interanual: -2.8%</a:t>
+              <a:t>Variación interanual: +0.0%</a:t>
             </a:r>
           </a:p>
           <a:p>
@@ -4107,1671 +4105,6 @@
 </p:sld>
 </file>
 
-<file path=ppt/slides/slide3.xml><?xml version="1.0" encoding="utf-8"?>
-<p:sld xmlns:a="http://schemas.openxmlformats.org/drawingml/2006/main" xmlns:p="http://schemas.openxmlformats.org/presentationml/2006/main" xmlns:r="http://schemas.openxmlformats.org/officeDocument/2006/relationships">
-  <p:cSld>
-    <p:spTree>
-      <p:nvGrpSpPr>
-        <p:cNvPr id="1" name=""/>
-        <p:cNvGrpSpPr/>
-        <p:nvPr/>
-      </p:nvGrpSpPr>
-      <p:grpSpPr/>
-      <p:sp>
-        <p:nvSpPr>
-          <p:cNvPr id="2" name="Rectangle 1"/>
-          <p:cNvSpPr/>
-          <p:nvPr/>
-        </p:nvSpPr>
-        <p:spPr>
-          <a:xfrm>
-            <a:off x="0" y="0"/>
-            <a:ext cx="12191695" cy="274320"/>
-          </a:xfrm>
-          <a:prstGeom prst="rect">
-            <a:avLst/>
-          </a:prstGeom>
-          <a:solidFill>
-            <a:srgbClr val="00B2C9"/>
-          </a:solidFill>
-          <a:ln>
-            <a:noFill/>
-          </a:ln>
-        </p:spPr>
-        <p:style>
-          <a:lnRef idx="1">
-            <a:schemeClr val="accent1"/>
-          </a:lnRef>
-          <a:fillRef idx="3">
-            <a:schemeClr val="accent1"/>
-          </a:fillRef>
-          <a:effectRef idx="2">
-            <a:schemeClr val="accent1"/>
-          </a:effectRef>
-          <a:fontRef idx="minor">
-            <a:schemeClr val="lt1"/>
-          </a:fontRef>
-        </p:style>
-        <p:txBody>
-          <a:bodyPr rtlCol="0" anchor="ctr"/>
-          <a:lstStyle/>
-          <a:p>
-            <a:pPr algn="ctr"/>
-          </a:p>
-        </p:txBody>
-      </p:sp>
-      <p:sp>
-        <p:nvSpPr>
-          <p:cNvPr id="3" name="TextBox 2"/>
-          <p:cNvSpPr txBox="1"/>
-          <p:nvPr/>
-        </p:nvSpPr>
-        <p:spPr>
-          <a:xfrm>
-            <a:off x="411480" y="457200"/>
-            <a:ext cx="11368735" cy="914400"/>
-          </a:xfrm>
-          <a:prstGeom prst="rect">
-            <a:avLst/>
-          </a:prstGeom>
-          <a:noFill/>
-        </p:spPr>
-        <p:txBody>
-          <a:bodyPr wrap="square" lIns="0" rIns="0">
-            <a:spAutoFit/>
-          </a:bodyPr>
-          <a:lstStyle/>
-          <a:p>
-            <a:pPr algn="l"/>
-            <a:r>
-              <a:rPr sz="2600" b="1" i="0">
-                <a:solidFill>
-                  <a:srgbClr val="00B2C9"/>
-                </a:solidFill>
-                <a:latin typeface="Encode Sans"/>
-              </a:rPr>
-              <a:t>INDUSTRIA ABRIL 2026: IPI CRECIÓ +0.0% I.A.</a:t>
-            </a:r>
-          </a:p>
-        </p:txBody>
-      </p:sp>
-      <p:sp>
-        <p:nvSpPr>
-          <p:cNvPr id="4" name="TextBox 3"/>
-          <p:cNvSpPr txBox="1"/>
-          <p:nvPr/>
-        </p:nvSpPr>
-        <p:spPr>
-          <a:xfrm>
-            <a:off x="411480" y="1280160"/>
-            <a:ext cx="11368735" cy="274320"/>
-          </a:xfrm>
-          <a:prstGeom prst="rect">
-            <a:avLst/>
-          </a:prstGeom>
-          <a:noFill/>
-        </p:spPr>
-        <p:txBody>
-          <a:bodyPr wrap="none">
-            <a:spAutoFit/>
-          </a:bodyPr>
-          <a:lstStyle/>
-          <a:p>
-            <a:r>
-              <a:rPr sz="1100" b="0" i="1">
-                <a:solidFill>
-                  <a:srgbClr val="6A6760"/>
-                </a:solidFill>
-                <a:latin typeface="Encode Sans"/>
-              </a:rPr>
-              <a:t>INDEC · período 2026-04</a:t>
-            </a:r>
-          </a:p>
-        </p:txBody>
-      </p:sp>
-      <p:sp>
-        <p:nvSpPr>
-          <p:cNvPr id="5" name="TextBox 4"/>
-          <p:cNvSpPr txBox="1"/>
-          <p:nvPr/>
-        </p:nvSpPr>
-        <p:spPr>
-          <a:xfrm>
-            <a:off x="411480" y="1691640"/>
-            <a:ext cx="5486400" cy="1645920"/>
-          </a:xfrm>
-          <a:prstGeom prst="rect">
-            <a:avLst/>
-          </a:prstGeom>
-          <a:noFill/>
-        </p:spPr>
-        <p:txBody>
-          <a:bodyPr wrap="square" lIns="0" rIns="0">
-            <a:spAutoFit/>
-          </a:bodyPr>
-          <a:lstStyle/>
-          <a:p>
-            <a:pPr algn="just"/>
-            <a:r>
-              <a:rPr sz="1300" b="0" i="0">
-                <a:solidFill>
-                  <a:srgbClr val="3F3F3F"/>
-                </a:solidFill>
-                <a:latin typeface="Encode Sans"/>
-              </a:rPr>
-              <a:t>El Índice de Producción Industrial Manufacturero (IPI) registró una variación interanual de +0.0% en abril 2026.</a:t>
-            </a:r>
-          </a:p>
-        </p:txBody>
-      </p:sp>
-      <p:sp>
-        <p:nvSpPr>
-          <p:cNvPr id="6" name="TextBox 5"/>
-          <p:cNvSpPr txBox="1"/>
-          <p:nvPr/>
-        </p:nvSpPr>
-        <p:spPr>
-          <a:xfrm>
-            <a:off x="411480" y="3520440"/>
-            <a:ext cx="5486400" cy="2743200"/>
-          </a:xfrm>
-          <a:prstGeom prst="rect">
-            <a:avLst/>
-          </a:prstGeom>
-          <a:noFill/>
-        </p:spPr>
-        <p:txBody>
-          <a:bodyPr wrap="square" lIns="0" rIns="0">
-            <a:spAutoFit/>
-          </a:bodyPr>
-          <a:lstStyle/>
-          <a:p>
-            <a:pPr algn="l">
-              <a:spcAft>
-                <a:spcPts val="800"/>
-              </a:spcAft>
-            </a:pPr>
-            <a:r>
-              <a:rPr sz="1300" b="1" i="0">
-                <a:solidFill>
-                  <a:srgbClr val="00B2C9"/>
-                </a:solidFill>
-                <a:latin typeface="Encode Sans"/>
-              </a:rPr>
-              <a:t>●  </a:t>
-            </a:r>
-            <a:r>
-              <a:rPr sz="1300" b="0" i="0">
-                <a:solidFill>
-                  <a:srgbClr val="3F3F3F"/>
-                </a:solidFill>
-                <a:latin typeface="Encode Sans"/>
-              </a:rPr>
-              <a:t>Variación interanual: +0.0%</a:t>
-            </a:r>
-          </a:p>
-          <a:p>
-            <a:pPr algn="l">
-              <a:spcAft>
-                <a:spcPts val="800"/>
-              </a:spcAft>
-            </a:pPr>
-            <a:r>
-              <a:rPr sz="1300" b="1" i="0">
-                <a:solidFill>
-                  <a:srgbClr val="00B2C9"/>
-                </a:solidFill>
-                <a:latin typeface="Encode Sans"/>
-              </a:rPr>
-              <a:t>●  </a:t>
-            </a:r>
-            <a:r>
-              <a:rPr sz="1300" b="0" i="0">
-                <a:solidFill>
-                  <a:srgbClr val="3F3F3F"/>
-                </a:solidFill>
-                <a:latin typeface="Encode Sans"/>
-              </a:rPr>
-              <a:t>Serie INDEC, base 2004=100. Mide la producción manufacturera (16 ramas).</a:t>
-            </a:r>
-          </a:p>
-        </p:txBody>
-      </p:sp>
-      <p:pic>
-        <p:nvPicPr>
-          <p:cNvPr id="7" name="Picture 6" descr="image.png"/>
-          <p:cNvPicPr>
-            <a:picLocks noChangeAspect="1"/>
-          </p:cNvPicPr>
-          <p:nvPr/>
-        </p:nvPicPr>
-        <p:blipFill>
-          <a:blip r:embed="rId2"/>
-          <a:stretch>
-            <a:fillRect/>
-          </a:stretch>
-        </p:blipFill>
-        <p:spPr>
-          <a:xfrm>
-            <a:off x="6080760" y="1691640"/>
-            <a:ext cx="5669280" cy="2560320"/>
-          </a:xfrm>
-          <a:prstGeom prst="rect">
-            <a:avLst/>
-          </a:prstGeom>
-        </p:spPr>
-      </p:pic>
-      <p:graphicFrame>
-        <p:nvGraphicFramePr>
-          <p:cNvPr id="8" name="Table 7"/>
-          <p:cNvGraphicFramePr>
-            <a:graphicFrameLocks noGrp="1"/>
-          </p:cNvGraphicFramePr>
-          <p:nvPr/>
-        </p:nvGraphicFramePr>
-        <p:xfrm>
-          <a:off x="6080760" y="4434840"/>
-          <a:ext cx="5669280" cy="2048256"/>
-        </p:xfrm>
-        <a:graphic>
-          <a:graphicData uri="http://schemas.openxmlformats.org/drawingml/2006/table">
-            <a:tbl>
-              <a:tblPr firstRow="1" bandRow="1">
-                <a:tableStyleId>{5C22544A-7EE6-4342-B048-85BDC9FD1C3A}</a:tableStyleId>
-              </a:tblPr>
-              <a:tblGrid>
-                <a:gridCol w="1889760"/>
-                <a:gridCol w="1889760"/>
-                <a:gridCol w="1889760"/>
-              </a:tblGrid>
-              <a:tr h="292608">
-                <a:tc>
-                  <a:txBody>
-                    <a:bodyPr/>
-                    <a:lstStyle/>
-                    <a:p>
-                      <a:pPr algn="l"/>
-                      <a:r>
-                        <a:rPr sz="1000" b="1">
-                          <a:solidFill>
-                            <a:srgbClr val="FFFFFF"/>
-                          </a:solidFill>
-                          <a:latin typeface="Encode Sans"/>
-                        </a:rPr>
-                        <a:t>Mes</a:t>
-                      </a:r>
-                    </a:p>
-                  </a:txBody>
-                  <a:tcPr marL="36576" marR="36576" marT="18288" marB="18288">
-                    <a:solidFill>
-                      <a:srgbClr val="00B2C9"/>
-                    </a:solidFill>
-                  </a:tcPr>
-                </a:tc>
-                <a:tc>
-                  <a:txBody>
-                    <a:bodyPr/>
-                    <a:lstStyle/>
-                    <a:p>
-                      <a:pPr algn="r"/>
-                      <a:r>
-                        <a:rPr sz="1000" b="1">
-                          <a:solidFill>
-                            <a:srgbClr val="FFFFFF"/>
-                          </a:solidFill>
-                          <a:latin typeface="Encode Sans"/>
-                        </a:rPr>
-                        <a:t>Original</a:t>
-                      </a:r>
-                    </a:p>
-                  </a:txBody>
-                  <a:tcPr marL="36576" marR="36576" marT="18288" marB="18288">
-                    <a:solidFill>
-                      <a:srgbClr val="00B2C9"/>
-                    </a:solidFill>
-                  </a:tcPr>
-                </a:tc>
-                <a:tc>
-                  <a:txBody>
-                    <a:bodyPr/>
-                    <a:lstStyle/>
-                    <a:p>
-                      <a:pPr algn="r"/>
-                      <a:r>
-                        <a:rPr sz="1000" b="1">
-                          <a:solidFill>
-                            <a:srgbClr val="FFFFFF"/>
-                          </a:solidFill>
-                          <a:latin typeface="Encode Sans"/>
-                        </a:rPr>
-                        <a:t>VIA %</a:t>
-                      </a:r>
-                    </a:p>
-                  </a:txBody>
-                  <a:tcPr marL="36576" marR="36576" marT="18288" marB="18288">
-                    <a:solidFill>
-                      <a:srgbClr val="00B2C9"/>
-                    </a:solidFill>
-                  </a:tcPr>
-                </a:tc>
-              </a:tr>
-              <a:tr h="292608">
-                <a:tc>
-                  <a:txBody>
-                    <a:bodyPr/>
-                    <a:lstStyle/>
-                    <a:p>
-                      <a:pPr algn="l"/>
-                      <a:r>
-                        <a:rPr sz="1000">
-                          <a:solidFill>
-                            <a:srgbClr val="3F3F3F"/>
-                          </a:solidFill>
-                          <a:latin typeface="Encode Sans"/>
-                        </a:rPr>
-                        <a:t>Abril 2026</a:t>
-                      </a:r>
-                    </a:p>
-                  </a:txBody>
-                  <a:tcPr marL="36576" marR="36576" marT="18288" marB="18288">
-                    <a:solidFill>
-                      <a:srgbClr val="FFFFFF"/>
-                    </a:solidFill>
-                  </a:tcPr>
-                </a:tc>
-                <a:tc>
-                  <a:txBody>
-                    <a:bodyPr/>
-                    <a:lstStyle/>
-                    <a:p>
-                      <a:pPr algn="r"/>
-                      <a:r>
-                        <a:rPr sz="1000">
-                          <a:solidFill>
-                            <a:srgbClr val="3F3F3F"/>
-                          </a:solidFill>
-                          <a:latin typeface="Encode Sans"/>
-                        </a:rPr>
-                        <a:t>118,1</a:t>
-                      </a:r>
-                    </a:p>
-                  </a:txBody>
-                  <a:tcPr marL="36576" marR="36576" marT="18288" marB="18288">
-                    <a:solidFill>
-                      <a:srgbClr val="FFFFFF"/>
-                    </a:solidFill>
-                  </a:tcPr>
-                </a:tc>
-                <a:tc>
-                  <a:txBody>
-                    <a:bodyPr/>
-                    <a:lstStyle/>
-                    <a:p>
-                      <a:pPr algn="r"/>
-                      <a:r>
-                        <a:rPr sz="1000">
-                          <a:solidFill>
-                            <a:srgbClr val="3F3F3F"/>
-                          </a:solidFill>
-                          <a:latin typeface="Encode Sans"/>
-                        </a:rPr>
-                        <a:t>-2.8%</a:t>
-                      </a:r>
-                    </a:p>
-                  </a:txBody>
-                  <a:tcPr marL="36576" marR="36576" marT="18288" marB="18288">
-                    <a:solidFill>
-                      <a:srgbClr val="FFFFFF"/>
-                    </a:solidFill>
-                  </a:tcPr>
-                </a:tc>
-              </a:tr>
-              <a:tr h="292608">
-                <a:tc>
-                  <a:txBody>
-                    <a:bodyPr/>
-                    <a:lstStyle/>
-                    <a:p>
-                      <a:pPr algn="l"/>
-                      <a:r>
-                        <a:rPr sz="1000">
-                          <a:solidFill>
-                            <a:srgbClr val="3F3F3F"/>
-                          </a:solidFill>
-                          <a:latin typeface="Encode Sans"/>
-                        </a:rPr>
-                        <a:t>Marzo 2026</a:t>
-                      </a:r>
-                    </a:p>
-                  </a:txBody>
-                  <a:tcPr marL="36576" marR="36576" marT="18288" marB="18288">
-                    <a:solidFill>
-                      <a:srgbClr val="F8F8F6"/>
-                    </a:solidFill>
-                  </a:tcPr>
-                </a:tc>
-                <a:tc>
-                  <a:txBody>
-                    <a:bodyPr/>
-                    <a:lstStyle/>
-                    <a:p>
-                      <a:pPr algn="r"/>
-                      <a:r>
-                        <a:rPr sz="1000">
-                          <a:solidFill>
-                            <a:srgbClr val="3F3F3F"/>
-                          </a:solidFill>
-                          <a:latin typeface="Encode Sans"/>
-                        </a:rPr>
-                        <a:t>122,2</a:t>
-                      </a:r>
-                    </a:p>
-                  </a:txBody>
-                  <a:tcPr marL="36576" marR="36576" marT="18288" marB="18288">
-                    <a:solidFill>
-                      <a:srgbClr val="F8F8F6"/>
-                    </a:solidFill>
-                  </a:tcPr>
-                </a:tc>
-                <a:tc>
-                  <a:txBody>
-                    <a:bodyPr/>
-                    <a:lstStyle/>
-                    <a:p>
-                      <a:pPr algn="r"/>
-                      <a:r>
-                        <a:rPr sz="1000">
-                          <a:solidFill>
-                            <a:srgbClr val="3F3F3F"/>
-                          </a:solidFill>
-                          <a:latin typeface="Encode Sans"/>
-                        </a:rPr>
-                        <a:t>+5.1%</a:t>
-                      </a:r>
-                    </a:p>
-                  </a:txBody>
-                  <a:tcPr marL="36576" marR="36576" marT="18288" marB="18288">
-                    <a:solidFill>
-                      <a:srgbClr val="F8F8F6"/>
-                    </a:solidFill>
-                  </a:tcPr>
-                </a:tc>
-              </a:tr>
-              <a:tr h="292608">
-                <a:tc>
-                  <a:txBody>
-                    <a:bodyPr/>
-                    <a:lstStyle/>
-                    <a:p>
-                      <a:pPr algn="l"/>
-                      <a:r>
-                        <a:rPr sz="1000">
-                          <a:solidFill>
-                            <a:srgbClr val="3F3F3F"/>
-                          </a:solidFill>
-                          <a:latin typeface="Encode Sans"/>
-                        </a:rPr>
-                        <a:t>Febrero 2026</a:t>
-                      </a:r>
-                    </a:p>
-                  </a:txBody>
-                  <a:tcPr marL="36576" marR="36576" marT="18288" marB="18288">
-                    <a:solidFill>
-                      <a:srgbClr val="FFFFFF"/>
-                    </a:solidFill>
-                  </a:tcPr>
-                </a:tc>
-                <a:tc>
-                  <a:txBody>
-                    <a:bodyPr/>
-                    <a:lstStyle/>
-                    <a:p>
-                      <a:pPr algn="r"/>
-                      <a:r>
-                        <a:rPr sz="1000">
-                          <a:solidFill>
-                            <a:srgbClr val="3F3F3F"/>
-                          </a:solidFill>
-                          <a:latin typeface="Encode Sans"/>
-                        </a:rPr>
-                        <a:t>100,3</a:t>
-                      </a:r>
-                    </a:p>
-                  </a:txBody>
-                  <a:tcPr marL="36576" marR="36576" marT="18288" marB="18288">
-                    <a:solidFill>
-                      <a:srgbClr val="FFFFFF"/>
-                    </a:solidFill>
-                  </a:tcPr>
-                </a:tc>
-                <a:tc>
-                  <a:txBody>
-                    <a:bodyPr/>
-                    <a:lstStyle/>
-                    <a:p>
-                      <a:pPr algn="r"/>
-                      <a:r>
-                        <a:rPr sz="1000">
-                          <a:solidFill>
-                            <a:srgbClr val="3F3F3F"/>
-                          </a:solidFill>
-                          <a:latin typeface="Encode Sans"/>
-                        </a:rPr>
-                        <a:t>-8.8%</a:t>
-                      </a:r>
-                    </a:p>
-                  </a:txBody>
-                  <a:tcPr marL="36576" marR="36576" marT="18288" marB="18288">
-                    <a:solidFill>
-                      <a:srgbClr val="FFFFFF"/>
-                    </a:solidFill>
-                  </a:tcPr>
-                </a:tc>
-              </a:tr>
-              <a:tr h="292608">
-                <a:tc>
-                  <a:txBody>
-                    <a:bodyPr/>
-                    <a:lstStyle/>
-                    <a:p>
-                      <a:pPr algn="l"/>
-                      <a:r>
-                        <a:rPr sz="1000">
-                          <a:solidFill>
-                            <a:srgbClr val="3F3F3F"/>
-                          </a:solidFill>
-                          <a:latin typeface="Encode Sans"/>
-                        </a:rPr>
-                        <a:t>Enero 2026</a:t>
-                      </a:r>
-                    </a:p>
-                  </a:txBody>
-                  <a:tcPr marL="36576" marR="36576" marT="18288" marB="18288">
-                    <a:solidFill>
-                      <a:srgbClr val="F8F8F6"/>
-                    </a:solidFill>
-                  </a:tcPr>
-                </a:tc>
-                <a:tc>
-                  <a:txBody>
-                    <a:bodyPr/>
-                    <a:lstStyle/>
-                    <a:p>
-                      <a:pPr algn="r"/>
-                      <a:r>
-                        <a:rPr sz="1000">
-                          <a:solidFill>
-                            <a:srgbClr val="3F3F3F"/>
-                          </a:solidFill>
-                          <a:latin typeface="Encode Sans"/>
-                        </a:rPr>
-                        <a:t>106,6</a:t>
-                      </a:r>
-                    </a:p>
-                  </a:txBody>
-                  <a:tcPr marL="36576" marR="36576" marT="18288" marB="18288">
-                    <a:solidFill>
-                      <a:srgbClr val="F8F8F6"/>
-                    </a:solidFill>
-                  </a:tcPr>
-                </a:tc>
-                <a:tc>
-                  <a:txBody>
-                    <a:bodyPr/>
-                    <a:lstStyle/>
-                    <a:p>
-                      <a:pPr algn="r"/>
-                      <a:r>
-                        <a:rPr sz="1000">
-                          <a:solidFill>
-                            <a:srgbClr val="3F3F3F"/>
-                          </a:solidFill>
-                          <a:latin typeface="Encode Sans"/>
-                        </a:rPr>
-                        <a:t>-3.7%</a:t>
-                      </a:r>
-                    </a:p>
-                  </a:txBody>
-                  <a:tcPr marL="36576" marR="36576" marT="18288" marB="18288">
-                    <a:solidFill>
-                      <a:srgbClr val="F8F8F6"/>
-                    </a:solidFill>
-                  </a:tcPr>
-                </a:tc>
-              </a:tr>
-              <a:tr h="292608">
-                <a:tc>
-                  <a:txBody>
-                    <a:bodyPr/>
-                    <a:lstStyle/>
-                    <a:p>
-                      <a:pPr algn="l"/>
-                      <a:r>
-                        <a:rPr sz="1000">
-                          <a:solidFill>
-                            <a:srgbClr val="3F3F3F"/>
-                          </a:solidFill>
-                          <a:latin typeface="Encode Sans"/>
-                        </a:rPr>
-                        <a:t>Diciembre 2025</a:t>
-                      </a:r>
-                    </a:p>
-                  </a:txBody>
-                  <a:tcPr marL="36576" marR="36576" marT="18288" marB="18288">
-                    <a:solidFill>
-                      <a:srgbClr val="FFFFFF"/>
-                    </a:solidFill>
-                  </a:tcPr>
-                </a:tc>
-                <a:tc>
-                  <a:txBody>
-                    <a:bodyPr/>
-                    <a:lstStyle/>
-                    <a:p>
-                      <a:pPr algn="r"/>
-                      <a:r>
-                        <a:rPr sz="1000">
-                          <a:solidFill>
-                            <a:srgbClr val="3F3F3F"/>
-                          </a:solidFill>
-                          <a:latin typeface="Encode Sans"/>
-                        </a:rPr>
-                        <a:t>112,0</a:t>
-                      </a:r>
-                    </a:p>
-                  </a:txBody>
-                  <a:tcPr marL="36576" marR="36576" marT="18288" marB="18288">
-                    <a:solidFill>
-                      <a:srgbClr val="FFFFFF"/>
-                    </a:solidFill>
-                  </a:tcPr>
-                </a:tc>
-                <a:tc>
-                  <a:txBody>
-                    <a:bodyPr/>
-                    <a:lstStyle/>
-                    <a:p>
-                      <a:pPr algn="r"/>
-                      <a:r>
-                        <a:rPr sz="1000">
-                          <a:solidFill>
-                            <a:srgbClr val="3F3F3F"/>
-                          </a:solidFill>
-                          <a:latin typeface="Encode Sans"/>
-                        </a:rPr>
-                        <a:t>-4.0%</a:t>
-                      </a:r>
-                    </a:p>
-                  </a:txBody>
-                  <a:tcPr marL="36576" marR="36576" marT="18288" marB="18288">
-                    <a:solidFill>
-                      <a:srgbClr val="FFFFFF"/>
-                    </a:solidFill>
-                  </a:tcPr>
-                </a:tc>
-              </a:tr>
-              <a:tr h="292608">
-                <a:tc>
-                  <a:txBody>
-                    <a:bodyPr/>
-                    <a:lstStyle/>
-                    <a:p>
-                      <a:pPr algn="l"/>
-                      <a:r>
-                        <a:rPr sz="1000">
-                          <a:solidFill>
-                            <a:srgbClr val="3F3F3F"/>
-                          </a:solidFill>
-                          <a:latin typeface="Encode Sans"/>
-                        </a:rPr>
-                        <a:t>Noviembre 2025</a:t>
-                      </a:r>
-                    </a:p>
-                  </a:txBody>
-                  <a:tcPr marL="36576" marR="36576" marT="18288" marB="18288">
-                    <a:solidFill>
-                      <a:srgbClr val="F8F8F6"/>
-                    </a:solidFill>
-                  </a:tcPr>
-                </a:tc>
-                <a:tc>
-                  <a:txBody>
-                    <a:bodyPr/>
-                    <a:lstStyle/>
-                    <a:p>
-                      <a:pPr algn="r"/>
-                      <a:r>
-                        <a:rPr sz="1000">
-                          <a:solidFill>
-                            <a:srgbClr val="3F3F3F"/>
-                          </a:solidFill>
-                          <a:latin typeface="Encode Sans"/>
-                        </a:rPr>
-                        <a:t>114,4</a:t>
-                      </a:r>
-                    </a:p>
-                  </a:txBody>
-                  <a:tcPr marL="36576" marR="36576" marT="18288" marB="18288">
-                    <a:solidFill>
-                      <a:srgbClr val="F8F8F6"/>
-                    </a:solidFill>
-                  </a:tcPr>
-                </a:tc>
-                <a:tc>
-                  <a:txBody>
-                    <a:bodyPr/>
-                    <a:lstStyle/>
-                    <a:p>
-                      <a:pPr algn="r"/>
-                      <a:r>
-                        <a:rPr sz="1000">
-                          <a:solidFill>
-                            <a:srgbClr val="3F3F3F"/>
-                          </a:solidFill>
-                          <a:latin typeface="Encode Sans"/>
-                        </a:rPr>
-                        <a:t>-8.8%</a:t>
-                      </a:r>
-                    </a:p>
-                  </a:txBody>
-                  <a:tcPr marL="36576" marR="36576" marT="18288" marB="18288">
-                    <a:solidFill>
-                      <a:srgbClr val="F8F8F6"/>
-                    </a:solidFill>
-                  </a:tcPr>
-                </a:tc>
-              </a:tr>
-            </a:tbl>
-          </a:graphicData>
-        </a:graphic>
-      </p:graphicFrame>
-      <p:sp>
-        <p:nvSpPr>
-          <p:cNvPr id="9" name="TextBox 8"/>
-          <p:cNvSpPr txBox="1"/>
-          <p:nvPr/>
-        </p:nvSpPr>
-        <p:spPr>
-          <a:xfrm>
-            <a:off x="411480" y="6492240"/>
-            <a:ext cx="11368735" cy="274320"/>
-          </a:xfrm>
-          <a:prstGeom prst="rect">
-            <a:avLst/>
-          </a:prstGeom>
-          <a:noFill/>
-        </p:spPr>
-        <p:txBody>
-          <a:bodyPr wrap="none">
-            <a:spAutoFit/>
-          </a:bodyPr>
-          <a:lstStyle/>
-          <a:p>
-            <a:r>
-              <a:rPr sz="1000" b="0" i="1">
-                <a:solidFill>
-                  <a:srgbClr val="6A6760"/>
-                </a:solidFill>
-                <a:latin typeface="Encode Sans"/>
-              </a:rPr>
-              <a:t>Fuente: elaboración propia en base a INDEC</a:t>
-            </a:r>
-          </a:p>
-        </p:txBody>
-      </p:sp>
-    </p:spTree>
-  </p:cSld>
-  <p:clrMapOvr>
-    <a:masterClrMapping/>
-  </p:clrMapOvr>
-</p:sld>
-</file>
-
-<file path=ppt/slides/slide4.xml><?xml version="1.0" encoding="utf-8"?>
-<p:sld xmlns:a="http://schemas.openxmlformats.org/drawingml/2006/main" xmlns:p="http://schemas.openxmlformats.org/presentationml/2006/main" xmlns:r="http://schemas.openxmlformats.org/officeDocument/2006/relationships">
-  <p:cSld>
-    <p:spTree>
-      <p:nvGrpSpPr>
-        <p:cNvPr id="1" name=""/>
-        <p:cNvGrpSpPr/>
-        <p:nvPr/>
-      </p:nvGrpSpPr>
-      <p:grpSpPr/>
-      <p:sp>
-        <p:nvSpPr>
-          <p:cNvPr id="2" name="Rectangle 1"/>
-          <p:cNvSpPr/>
-          <p:nvPr/>
-        </p:nvSpPr>
-        <p:spPr>
-          <a:xfrm>
-            <a:off x="0" y="0"/>
-            <a:ext cx="12191695" cy="274320"/>
-          </a:xfrm>
-          <a:prstGeom prst="rect">
-            <a:avLst/>
-          </a:prstGeom>
-          <a:solidFill>
-            <a:srgbClr val="00B2C9"/>
-          </a:solidFill>
-          <a:ln>
-            <a:noFill/>
-          </a:ln>
-        </p:spPr>
-        <p:style>
-          <a:lnRef idx="1">
-            <a:schemeClr val="accent1"/>
-          </a:lnRef>
-          <a:fillRef idx="3">
-            <a:schemeClr val="accent1"/>
-          </a:fillRef>
-          <a:effectRef idx="2">
-            <a:schemeClr val="accent1"/>
-          </a:effectRef>
-          <a:fontRef idx="minor">
-            <a:schemeClr val="lt1"/>
-          </a:fontRef>
-        </p:style>
-        <p:txBody>
-          <a:bodyPr rtlCol="0" anchor="ctr"/>
-          <a:lstStyle/>
-          <a:p>
-            <a:pPr algn="ctr"/>
-          </a:p>
-        </p:txBody>
-      </p:sp>
-      <p:sp>
-        <p:nvSpPr>
-          <p:cNvPr id="3" name="TextBox 2"/>
-          <p:cNvSpPr txBox="1"/>
-          <p:nvPr/>
-        </p:nvSpPr>
-        <p:spPr>
-          <a:xfrm>
-            <a:off x="411480" y="457200"/>
-            <a:ext cx="11368735" cy="914400"/>
-          </a:xfrm>
-          <a:prstGeom prst="rect">
-            <a:avLst/>
-          </a:prstGeom>
-          <a:noFill/>
-        </p:spPr>
-        <p:txBody>
-          <a:bodyPr wrap="square" lIns="0" rIns="0">
-            <a:spAutoFit/>
-          </a:bodyPr>
-          <a:lstStyle/>
-          <a:p>
-            <a:pPr algn="l"/>
-            <a:r>
-              <a:rPr sz="2600" b="1" i="0">
-                <a:solidFill>
-                  <a:srgbClr val="00B2C9"/>
-                </a:solidFill>
-                <a:latin typeface="Encode Sans"/>
-              </a:rPr>
-              <a:t>INFLACIÓN MAYO 2026: +2.1%</a:t>
-            </a:r>
-          </a:p>
-        </p:txBody>
-      </p:sp>
-      <p:sp>
-        <p:nvSpPr>
-          <p:cNvPr id="4" name="TextBox 3"/>
-          <p:cNvSpPr txBox="1"/>
-          <p:nvPr/>
-        </p:nvSpPr>
-        <p:spPr>
-          <a:xfrm>
-            <a:off x="411480" y="1280160"/>
-            <a:ext cx="11368735" cy="274320"/>
-          </a:xfrm>
-          <a:prstGeom prst="rect">
-            <a:avLst/>
-          </a:prstGeom>
-          <a:noFill/>
-        </p:spPr>
-        <p:txBody>
-          <a:bodyPr wrap="none">
-            <a:spAutoFit/>
-          </a:bodyPr>
-          <a:lstStyle/>
-          <a:p>
-            <a:r>
-              <a:rPr sz="1100" b="0" i="1">
-                <a:solidFill>
-                  <a:srgbClr val="6A6760"/>
-                </a:solidFill>
-                <a:latin typeface="Encode Sans"/>
-              </a:rPr>
-              <a:t>INDEC · período 2026-05</a:t>
-            </a:r>
-          </a:p>
-        </p:txBody>
-      </p:sp>
-      <p:sp>
-        <p:nvSpPr>
-          <p:cNvPr id="5" name="TextBox 4"/>
-          <p:cNvSpPr txBox="1"/>
-          <p:nvPr/>
-        </p:nvSpPr>
-        <p:spPr>
-          <a:xfrm>
-            <a:off x="411480" y="1691640"/>
-            <a:ext cx="5486400" cy="1645920"/>
-          </a:xfrm>
-          <a:prstGeom prst="rect">
-            <a:avLst/>
-          </a:prstGeom>
-          <a:noFill/>
-        </p:spPr>
-        <p:txBody>
-          <a:bodyPr wrap="square" lIns="0" rIns="0">
-            <a:spAutoFit/>
-          </a:bodyPr>
-          <a:lstStyle/>
-          <a:p>
-            <a:pPr algn="just"/>
-            <a:r>
-              <a:rPr sz="1300" b="0" i="0">
-                <a:solidFill>
-                  <a:srgbClr val="3F3F3F"/>
-                </a:solidFill>
-                <a:latin typeface="Encode Sans"/>
-              </a:rPr>
-              <a:t>El IPC nivel general aumentó +2.1% mensual en mayo 2026, acumulando 33.2% interanual. INDEC publicó el indicador con la metodología vigente.</a:t>
-            </a:r>
-          </a:p>
-        </p:txBody>
-      </p:sp>
-      <p:sp>
-        <p:nvSpPr>
-          <p:cNvPr id="6" name="TextBox 5"/>
-          <p:cNvSpPr txBox="1"/>
-          <p:nvPr/>
-        </p:nvSpPr>
-        <p:spPr>
-          <a:xfrm>
-            <a:off x="411480" y="3520440"/>
-            <a:ext cx="5486400" cy="2743200"/>
-          </a:xfrm>
-          <a:prstGeom prst="rect">
-            <a:avLst/>
-          </a:prstGeom>
-          <a:noFill/>
-        </p:spPr>
-        <p:txBody>
-          <a:bodyPr wrap="square" lIns="0" rIns="0">
-            <a:spAutoFit/>
-          </a:bodyPr>
-          <a:lstStyle/>
-          <a:p>
-            <a:pPr algn="l">
-              <a:spcAft>
-                <a:spcPts val="800"/>
-              </a:spcAft>
-            </a:pPr>
-            <a:r>
-              <a:rPr sz="1300" b="1" i="0">
-                <a:solidFill>
-                  <a:srgbClr val="00B2C9"/>
-                </a:solidFill>
-                <a:latin typeface="Encode Sans"/>
-              </a:rPr>
-              <a:t>●  </a:t>
-            </a:r>
-            <a:r>
-              <a:rPr sz="1300" b="0" i="0">
-                <a:solidFill>
-                  <a:srgbClr val="3F3F3F"/>
-                </a:solidFill>
-                <a:latin typeface="Encode Sans"/>
-              </a:rPr>
-              <a:t>Variación mensual: +2.1%</a:t>
-            </a:r>
-          </a:p>
-          <a:p>
-            <a:pPr algn="l">
-              <a:spcAft>
-                <a:spcPts val="800"/>
-              </a:spcAft>
-            </a:pPr>
-            <a:r>
-              <a:rPr sz="1300" b="1" i="0">
-                <a:solidFill>
-                  <a:srgbClr val="00B2C9"/>
-                </a:solidFill>
-                <a:latin typeface="Encode Sans"/>
-              </a:rPr>
-              <a:t>●  </a:t>
-            </a:r>
-            <a:r>
-              <a:rPr sz="1300" b="0" i="0">
-                <a:solidFill>
-                  <a:srgbClr val="3F3F3F"/>
-                </a:solidFill>
-                <a:latin typeface="Encode Sans"/>
-              </a:rPr>
-              <a:t>Variación interanual: 33.2%</a:t>
-            </a:r>
-          </a:p>
-          <a:p>
-            <a:pPr algn="l">
-              <a:spcAft>
-                <a:spcPts val="800"/>
-              </a:spcAft>
-            </a:pPr>
-            <a:r>
-              <a:rPr sz="1300" b="1" i="0">
-                <a:solidFill>
-                  <a:srgbClr val="00B2C9"/>
-                </a:solidFill>
-                <a:latin typeface="Encode Sans"/>
-              </a:rPr>
-              <a:t>●  </a:t>
-            </a:r>
-            <a:r>
-              <a:rPr sz="1300" b="0" i="0">
-                <a:solidFill>
-                  <a:srgbClr val="3F3F3F"/>
-                </a:solidFill>
-                <a:latin typeface="Encode Sans"/>
-              </a:rPr>
-              <a:t>Acumulado últimos 6 meses: 16.7% (suma simple)</a:t>
-            </a:r>
-          </a:p>
-        </p:txBody>
-      </p:sp>
-      <p:pic>
-        <p:nvPicPr>
-          <p:cNvPr id="7" name="Picture 6" descr="image.png"/>
-          <p:cNvPicPr>
-            <a:picLocks noChangeAspect="1"/>
-          </p:cNvPicPr>
-          <p:nvPr/>
-        </p:nvPicPr>
-        <p:blipFill>
-          <a:blip r:embed="rId2"/>
-          <a:stretch>
-            <a:fillRect/>
-          </a:stretch>
-        </p:blipFill>
-        <p:spPr>
-          <a:xfrm>
-            <a:off x="6080760" y="1691640"/>
-            <a:ext cx="5669280" cy="2560320"/>
-          </a:xfrm>
-          <a:prstGeom prst="rect">
-            <a:avLst/>
-          </a:prstGeom>
-        </p:spPr>
-      </p:pic>
-      <p:graphicFrame>
-        <p:nvGraphicFramePr>
-          <p:cNvPr id="8" name="Table 7"/>
-          <p:cNvGraphicFramePr>
-            <a:graphicFrameLocks noGrp="1"/>
-          </p:cNvGraphicFramePr>
-          <p:nvPr/>
-        </p:nvGraphicFramePr>
-        <p:xfrm>
-          <a:off x="6080760" y="4434840"/>
-          <a:ext cx="5669280" cy="2048256"/>
-        </p:xfrm>
-        <a:graphic>
-          <a:graphicData uri="http://schemas.openxmlformats.org/drawingml/2006/table">
-            <a:tbl>
-              <a:tblPr firstRow="1" bandRow="1">
-                <a:tableStyleId>{5C22544A-7EE6-4342-B048-85BDC9FD1C3A}</a:tableStyleId>
-              </a:tblPr>
-              <a:tblGrid>
-                <a:gridCol w="1889760"/>
-                <a:gridCol w="1889760"/>
-                <a:gridCol w="1889760"/>
-              </a:tblGrid>
-              <a:tr h="292608">
-                <a:tc>
-                  <a:txBody>
-                    <a:bodyPr/>
-                    <a:lstStyle/>
-                    <a:p>
-                      <a:pPr algn="l"/>
-                      <a:r>
-                        <a:rPr sz="1000" b="1">
-                          <a:solidFill>
-                            <a:srgbClr val="FFFFFF"/>
-                          </a:solidFill>
-                          <a:latin typeface="Encode Sans"/>
-                        </a:rPr>
-                        <a:t>Mes</a:t>
-                      </a:r>
-                    </a:p>
-                  </a:txBody>
-                  <a:tcPr marL="36576" marR="36576" marT="18288" marB="18288">
-                    <a:solidFill>
-                      <a:srgbClr val="00B2C9"/>
-                    </a:solidFill>
-                  </a:tcPr>
-                </a:tc>
-                <a:tc>
-                  <a:txBody>
-                    <a:bodyPr/>
-                    <a:lstStyle/>
-                    <a:p>
-                      <a:pPr algn="r"/>
-                      <a:r>
-                        <a:rPr sz="1000" b="1">
-                          <a:solidFill>
-                            <a:srgbClr val="FFFFFF"/>
-                          </a:solidFill>
-                          <a:latin typeface="Encode Sans"/>
-                        </a:rPr>
-                        <a:t>VM %</a:t>
-                      </a:r>
-                    </a:p>
-                  </a:txBody>
-                  <a:tcPr marL="36576" marR="36576" marT="18288" marB="18288">
-                    <a:solidFill>
-                      <a:srgbClr val="00B2C9"/>
-                    </a:solidFill>
-                  </a:tcPr>
-                </a:tc>
-                <a:tc>
-                  <a:txBody>
-                    <a:bodyPr/>
-                    <a:lstStyle/>
-                    <a:p>
-                      <a:pPr algn="r"/>
-                      <a:r>
-                        <a:rPr sz="1000" b="1">
-                          <a:solidFill>
-                            <a:srgbClr val="FFFFFF"/>
-                          </a:solidFill>
-                          <a:latin typeface="Encode Sans"/>
-                        </a:rPr>
-                        <a:t>VIA %</a:t>
-                      </a:r>
-                    </a:p>
-                  </a:txBody>
-                  <a:tcPr marL="36576" marR="36576" marT="18288" marB="18288">
-                    <a:solidFill>
-                      <a:srgbClr val="00B2C9"/>
-                    </a:solidFill>
-                  </a:tcPr>
-                </a:tc>
-              </a:tr>
-              <a:tr h="292608">
-                <a:tc>
-                  <a:txBody>
-                    <a:bodyPr/>
-                    <a:lstStyle/>
-                    <a:p>
-                      <a:pPr algn="l"/>
-                      <a:r>
-                        <a:rPr sz="1000">
-                          <a:solidFill>
-                            <a:srgbClr val="3F3F3F"/>
-                          </a:solidFill>
-                          <a:latin typeface="Encode Sans"/>
-                        </a:rPr>
-                        <a:t>Mayo 2026</a:t>
-                      </a:r>
-                    </a:p>
-                  </a:txBody>
-                  <a:tcPr marL="36576" marR="36576" marT="18288" marB="18288">
-                    <a:solidFill>
-                      <a:srgbClr val="FFFFFF"/>
-                    </a:solidFill>
-                  </a:tcPr>
-                </a:tc>
-                <a:tc>
-                  <a:txBody>
-                    <a:bodyPr/>
-                    <a:lstStyle/>
-                    <a:p>
-                      <a:pPr algn="r"/>
-                      <a:r>
-                        <a:rPr sz="1000">
-                          <a:solidFill>
-                            <a:srgbClr val="3F3F3F"/>
-                          </a:solidFill>
-                          <a:latin typeface="Encode Sans"/>
-                        </a:rPr>
-                        <a:t>+2.1%</a:t>
-                      </a:r>
-                    </a:p>
-                  </a:txBody>
-                  <a:tcPr marL="36576" marR="36576" marT="18288" marB="18288">
-                    <a:solidFill>
-                      <a:srgbClr val="FFFFFF"/>
-                    </a:solidFill>
-                  </a:tcPr>
-                </a:tc>
-                <a:tc>
-                  <a:txBody>
-                    <a:bodyPr/>
-                    <a:lstStyle/>
-                    <a:p>
-                      <a:pPr algn="r"/>
-                      <a:r>
-                        <a:rPr sz="1000">
-                          <a:solidFill>
-                            <a:srgbClr val="3F3F3F"/>
-                          </a:solidFill>
-                          <a:latin typeface="Encode Sans"/>
-                        </a:rPr>
-                        <a:t>+33.2%</a:t>
-                      </a:r>
-                    </a:p>
-                  </a:txBody>
-                  <a:tcPr marL="36576" marR="36576" marT="18288" marB="18288">
-                    <a:solidFill>
-                      <a:srgbClr val="FFFFFF"/>
-                    </a:solidFill>
-                  </a:tcPr>
-                </a:tc>
-              </a:tr>
-              <a:tr h="292608">
-                <a:tc>
-                  <a:txBody>
-                    <a:bodyPr/>
-                    <a:lstStyle/>
-                    <a:p>
-                      <a:pPr algn="l"/>
-                      <a:r>
-                        <a:rPr sz="1000">
-                          <a:solidFill>
-                            <a:srgbClr val="3F3F3F"/>
-                          </a:solidFill>
-                          <a:latin typeface="Encode Sans"/>
-                        </a:rPr>
-                        <a:t>Abril 2026</a:t>
-                      </a:r>
-                    </a:p>
-                  </a:txBody>
-                  <a:tcPr marL="36576" marR="36576" marT="18288" marB="18288">
-                    <a:solidFill>
-                      <a:srgbClr val="F8F8F6"/>
-                    </a:solidFill>
-                  </a:tcPr>
-                </a:tc>
-                <a:tc>
-                  <a:txBody>
-                    <a:bodyPr/>
-                    <a:lstStyle/>
-                    <a:p>
-                      <a:pPr algn="r"/>
-                      <a:r>
-                        <a:rPr sz="1000">
-                          <a:solidFill>
-                            <a:srgbClr val="3F3F3F"/>
-                          </a:solidFill>
-                          <a:latin typeface="Encode Sans"/>
-                        </a:rPr>
-                        <a:t>+2.6%</a:t>
-                      </a:r>
-                    </a:p>
-                  </a:txBody>
-                  <a:tcPr marL="36576" marR="36576" marT="18288" marB="18288">
-                    <a:solidFill>
-                      <a:srgbClr val="F8F8F6"/>
-                    </a:solidFill>
-                  </a:tcPr>
-                </a:tc>
-                <a:tc>
-                  <a:txBody>
-                    <a:bodyPr/>
-                    <a:lstStyle/>
-                    <a:p>
-                      <a:pPr algn="r"/>
-                      <a:r>
-                        <a:rPr sz="1000">
-                          <a:solidFill>
-                            <a:srgbClr val="3F3F3F"/>
-                          </a:solidFill>
-                          <a:latin typeface="Encode Sans"/>
-                        </a:rPr>
-                        <a:t>+32.4%</a:t>
-                      </a:r>
-                    </a:p>
-                  </a:txBody>
-                  <a:tcPr marL="36576" marR="36576" marT="18288" marB="18288">
-                    <a:solidFill>
-                      <a:srgbClr val="F8F8F6"/>
-                    </a:solidFill>
-                  </a:tcPr>
-                </a:tc>
-              </a:tr>
-              <a:tr h="292608">
-                <a:tc>
-                  <a:txBody>
-                    <a:bodyPr/>
-                    <a:lstStyle/>
-                    <a:p>
-                      <a:pPr algn="l"/>
-                      <a:r>
-                        <a:rPr sz="1000">
-                          <a:solidFill>
-                            <a:srgbClr val="3F3F3F"/>
-                          </a:solidFill>
-                          <a:latin typeface="Encode Sans"/>
-                        </a:rPr>
-                        <a:t>Marzo 2026</a:t>
-                      </a:r>
-                    </a:p>
-                  </a:txBody>
-                  <a:tcPr marL="36576" marR="36576" marT="18288" marB="18288">
-                    <a:solidFill>
-                      <a:srgbClr val="FFFFFF"/>
-                    </a:solidFill>
-                  </a:tcPr>
-                </a:tc>
-                <a:tc>
-                  <a:txBody>
-                    <a:bodyPr/>
-                    <a:lstStyle/>
-                    <a:p>
-                      <a:pPr algn="r"/>
-                      <a:r>
-                        <a:rPr sz="1000">
-                          <a:solidFill>
-                            <a:srgbClr val="3F3F3F"/>
-                          </a:solidFill>
-                          <a:latin typeface="Encode Sans"/>
-                        </a:rPr>
-                        <a:t>+3.4%</a:t>
-                      </a:r>
-                    </a:p>
-                  </a:txBody>
-                  <a:tcPr marL="36576" marR="36576" marT="18288" marB="18288">
-                    <a:solidFill>
-                      <a:srgbClr val="FFFFFF"/>
-                    </a:solidFill>
-                  </a:tcPr>
-                </a:tc>
-                <a:tc>
-                  <a:txBody>
-                    <a:bodyPr/>
-                    <a:lstStyle/>
-                    <a:p>
-                      <a:pPr algn="r"/>
-                      <a:r>
-                        <a:rPr sz="1000">
-                          <a:solidFill>
-                            <a:srgbClr val="3F3F3F"/>
-                          </a:solidFill>
-                          <a:latin typeface="Encode Sans"/>
-                        </a:rPr>
-                        <a:t>+32.6%</a:t>
-                      </a:r>
-                    </a:p>
-                  </a:txBody>
-                  <a:tcPr marL="36576" marR="36576" marT="18288" marB="18288">
-                    <a:solidFill>
-                      <a:srgbClr val="FFFFFF"/>
-                    </a:solidFill>
-                  </a:tcPr>
-                </a:tc>
-              </a:tr>
-              <a:tr h="292608">
-                <a:tc>
-                  <a:txBody>
-                    <a:bodyPr/>
-                    <a:lstStyle/>
-                    <a:p>
-                      <a:pPr algn="l"/>
-                      <a:r>
-                        <a:rPr sz="1000">
-                          <a:solidFill>
-                            <a:srgbClr val="3F3F3F"/>
-                          </a:solidFill>
-                          <a:latin typeface="Encode Sans"/>
-                        </a:rPr>
-                        <a:t>Febrero 2026</a:t>
-                      </a:r>
-                    </a:p>
-                  </a:txBody>
-                  <a:tcPr marL="36576" marR="36576" marT="18288" marB="18288">
-                    <a:solidFill>
-                      <a:srgbClr val="F8F8F6"/>
-                    </a:solidFill>
-                  </a:tcPr>
-                </a:tc>
-                <a:tc>
-                  <a:txBody>
-                    <a:bodyPr/>
-                    <a:lstStyle/>
-                    <a:p>
-                      <a:pPr algn="r"/>
-                      <a:r>
-                        <a:rPr sz="1000">
-                          <a:solidFill>
-                            <a:srgbClr val="3F3F3F"/>
-                          </a:solidFill>
-                          <a:latin typeface="Encode Sans"/>
-                        </a:rPr>
-                        <a:t>+2.9%</a:t>
-                      </a:r>
-                    </a:p>
-                  </a:txBody>
-                  <a:tcPr marL="36576" marR="36576" marT="18288" marB="18288">
-                    <a:solidFill>
-                      <a:srgbClr val="F8F8F6"/>
-                    </a:solidFill>
-                  </a:tcPr>
-                </a:tc>
-                <a:tc>
-                  <a:txBody>
-                    <a:bodyPr/>
-                    <a:lstStyle/>
-                    <a:p>
-                      <a:pPr algn="r"/>
-                      <a:r>
-                        <a:rPr sz="1000">
-                          <a:solidFill>
-                            <a:srgbClr val="3F3F3F"/>
-                          </a:solidFill>
-                          <a:latin typeface="Encode Sans"/>
-                        </a:rPr>
-                        <a:t>+33.0%</a:t>
-                      </a:r>
-                    </a:p>
-                  </a:txBody>
-                  <a:tcPr marL="36576" marR="36576" marT="18288" marB="18288">
-                    <a:solidFill>
-                      <a:srgbClr val="F8F8F6"/>
-                    </a:solidFill>
-                  </a:tcPr>
-                </a:tc>
-              </a:tr>
-              <a:tr h="292608">
-                <a:tc>
-                  <a:txBody>
-                    <a:bodyPr/>
-                    <a:lstStyle/>
-                    <a:p>
-                      <a:pPr algn="l"/>
-                      <a:r>
-                        <a:rPr sz="1000">
-                          <a:solidFill>
-                            <a:srgbClr val="3F3F3F"/>
-                          </a:solidFill>
-                          <a:latin typeface="Encode Sans"/>
-                        </a:rPr>
-                        <a:t>Enero 2026</a:t>
-                      </a:r>
-                    </a:p>
-                  </a:txBody>
-                  <a:tcPr marL="36576" marR="36576" marT="18288" marB="18288">
-                    <a:solidFill>
-                      <a:srgbClr val="FFFFFF"/>
-                    </a:solidFill>
-                  </a:tcPr>
-                </a:tc>
-                <a:tc>
-                  <a:txBody>
-                    <a:bodyPr/>
-                    <a:lstStyle/>
-                    <a:p>
-                      <a:pPr algn="r"/>
-                      <a:r>
-                        <a:rPr sz="1000">
-                          <a:solidFill>
-                            <a:srgbClr val="3F3F3F"/>
-                          </a:solidFill>
-                          <a:latin typeface="Encode Sans"/>
-                        </a:rPr>
-                        <a:t>+2.9%</a:t>
-                      </a:r>
-                    </a:p>
-                  </a:txBody>
-                  <a:tcPr marL="36576" marR="36576" marT="18288" marB="18288">
-                    <a:solidFill>
-                      <a:srgbClr val="FFFFFF"/>
-                    </a:solidFill>
-                  </a:tcPr>
-                </a:tc>
-                <a:tc>
-                  <a:txBody>
-                    <a:bodyPr/>
-                    <a:lstStyle/>
-                    <a:p>
-                      <a:pPr algn="r"/>
-                      <a:r>
-                        <a:rPr sz="1000">
-                          <a:solidFill>
-                            <a:srgbClr val="3F3F3F"/>
-                          </a:solidFill>
-                          <a:latin typeface="Encode Sans"/>
-                        </a:rPr>
-                        <a:t>+32.4%</a:t>
-                      </a:r>
-                    </a:p>
-                  </a:txBody>
-                  <a:tcPr marL="36576" marR="36576" marT="18288" marB="18288">
-                    <a:solidFill>
-                      <a:srgbClr val="FFFFFF"/>
-                    </a:solidFill>
-                  </a:tcPr>
-                </a:tc>
-              </a:tr>
-              <a:tr h="292608">
-                <a:tc>
-                  <a:txBody>
-                    <a:bodyPr/>
-                    <a:lstStyle/>
-                    <a:p>
-                      <a:pPr algn="l"/>
-                      <a:r>
-                        <a:rPr sz="1000">
-                          <a:solidFill>
-                            <a:srgbClr val="3F3F3F"/>
-                          </a:solidFill>
-                          <a:latin typeface="Encode Sans"/>
-                        </a:rPr>
-                        <a:t>Diciembre 2025</a:t>
-                      </a:r>
-                    </a:p>
-                  </a:txBody>
-                  <a:tcPr marL="36576" marR="36576" marT="18288" marB="18288">
-                    <a:solidFill>
-                      <a:srgbClr val="F8F8F6"/>
-                    </a:solidFill>
-                  </a:tcPr>
-                </a:tc>
-                <a:tc>
-                  <a:txBody>
-                    <a:bodyPr/>
-                    <a:lstStyle/>
-                    <a:p>
-                      <a:pPr algn="r"/>
-                      <a:r>
-                        <a:rPr sz="1000">
-                          <a:solidFill>
-                            <a:srgbClr val="3F3F3F"/>
-                          </a:solidFill>
-                          <a:latin typeface="Encode Sans"/>
-                        </a:rPr>
-                        <a:t>+2.9%</a:t>
-                      </a:r>
-                    </a:p>
-                  </a:txBody>
-                  <a:tcPr marL="36576" marR="36576" marT="18288" marB="18288">
-                    <a:solidFill>
-                      <a:srgbClr val="F8F8F6"/>
-                    </a:solidFill>
-                  </a:tcPr>
-                </a:tc>
-                <a:tc>
-                  <a:txBody>
-                    <a:bodyPr/>
-                    <a:lstStyle/>
-                    <a:p>
-                      <a:pPr algn="r"/>
-                      <a:r>
-                        <a:rPr sz="1000">
-                          <a:solidFill>
-                            <a:srgbClr val="3F3F3F"/>
-                          </a:solidFill>
-                          <a:latin typeface="Encode Sans"/>
-                        </a:rPr>
-                        <a:t>+31.6%</a:t>
-                      </a:r>
-                    </a:p>
-                  </a:txBody>
-                  <a:tcPr marL="36576" marR="36576" marT="18288" marB="18288">
-                    <a:solidFill>
-                      <a:srgbClr val="F8F8F6"/>
-                    </a:solidFill>
-                  </a:tcPr>
-                </a:tc>
-              </a:tr>
-            </a:tbl>
-          </a:graphicData>
-        </a:graphic>
-      </p:graphicFrame>
-      <p:sp>
-        <p:nvSpPr>
-          <p:cNvPr id="9" name="TextBox 8"/>
-          <p:cNvSpPr txBox="1"/>
-          <p:nvPr/>
-        </p:nvSpPr>
-        <p:spPr>
-          <a:xfrm>
-            <a:off x="411480" y="6492240"/>
-            <a:ext cx="11368735" cy="274320"/>
-          </a:xfrm>
-          <a:prstGeom prst="rect">
-            <a:avLst/>
-          </a:prstGeom>
-          <a:noFill/>
-        </p:spPr>
-        <p:txBody>
-          <a:bodyPr wrap="none">
-            <a:spAutoFit/>
-          </a:bodyPr>
-          <a:lstStyle/>
-          <a:p>
-            <a:r>
-              <a:rPr sz="1000" b="0" i="1">
-                <a:solidFill>
-                  <a:srgbClr val="6A6760"/>
-                </a:solidFill>
-                <a:latin typeface="Encode Sans"/>
-              </a:rPr>
-              <a:t>Fuente: elaboración propia en base a INDEC</a:t>
-            </a:r>
-          </a:p>
-        </p:txBody>
-      </p:sp>
-    </p:spTree>
-  </p:cSld>
-  <p:clrMapOvr>
-    <a:masterClrMapping/>
-  </p:clrMapOvr>
-</p:sld>
-</file>
-
 <file path=ppt/theme/theme1.xml><?xml version="1.0" encoding="utf-8"?>
 <a:theme xmlns:a="http://schemas.openxmlformats.org/drawingml/2006/main" name="Office Theme">
   <a:themeElements>

</xml_diff>

<commit_message>
data: update 2026-06-16 ( data.json despidos.json scraper/historical_despidos.json scraper/calendar_oficial.json publicaciones_semana.pptx rrii_brutas.xlsx)
</commit_message>
<xml_diff>
--- a/publicaciones_semana.pptx
+++ b/publicaciones_semana.pptx
@@ -3954,7 +3954,7 @@
                           </a:solidFill>
                           <a:latin typeface="Encode Sans"/>
                         </a:rPr>
-                        <a:t>112,0</a:t>
+                        <a:t>112,2</a:t>
                       </a:r>
                     </a:p>
                   </a:txBody>
@@ -3977,7 +3977,7 @@
                           </a:solidFill>
                           <a:latin typeface="Encode Sans"/>
                         </a:rPr>
-                        <a:t>-4.0%</a:t>
+                        <a:t>-3.9%</a:t>
                       </a:r>
                     </a:p>
                   </a:txBody>
@@ -4025,7 +4025,7 @@
                           </a:solidFill>
                           <a:latin typeface="Encode Sans"/>
                         </a:rPr>
-                        <a:t>114,4</a:t>
+                        <a:t>114,5</a:t>
                       </a:r>
                     </a:p>
                   </a:txBody>
@@ -4048,7 +4048,7 @@
                           </a:solidFill>
                           <a:latin typeface="Encode Sans"/>
                         </a:rPr>
-                        <a:t>-8.8%</a:t>
+                        <a:t>-8.7%</a:t>
                       </a:r>
                     </a:p>
                   </a:txBody>

</xml_diff>

<commit_message>
data: update 2026-06-17 ( data.json despidos.json scraper/historical_despidos.json scraper/calendar_oficial.json publicaciones_semana.pptx rrii_brutas.xlsx)
</commit_message>
<xml_diff>
--- a/publicaciones_semana.pptx
+++ b/publicaciones_semana.pptx
@@ -3954,7 +3954,7 @@
                           </a:solidFill>
                           <a:latin typeface="Encode Sans"/>
                         </a:rPr>
-                        <a:t>112,2</a:t>
+                        <a:t>112,0</a:t>
                       </a:r>
                     </a:p>
                   </a:txBody>
@@ -3977,7 +3977,7 @@
                           </a:solidFill>
                           <a:latin typeface="Encode Sans"/>
                         </a:rPr>
-                        <a:t>-3.9%</a:t>
+                        <a:t>-4.0%</a:t>
                       </a:r>
                     </a:p>
                   </a:txBody>
@@ -4025,7 +4025,7 @@
                           </a:solidFill>
                           <a:latin typeface="Encode Sans"/>
                         </a:rPr>
-                        <a:t>114,5</a:t>
+                        <a:t>114,4</a:t>
                       </a:r>
                     </a:p>
                   </a:txBody>
@@ -4048,7 +4048,7 @@
                           </a:solidFill>
                           <a:latin typeface="Encode Sans"/>
                         </a:rPr>
-                        <a:t>-8.7%</a:t>
+                        <a:t>-8.8%</a:t>
                       </a:r>
                     </a:p>
                   </a:txBody>

</xml_diff>

<commit_message>
data: update 2026-06-19 ( data.json despidos.json scraper/historical_despidos.json publicaciones_semana.pptx rrii_brutas.xlsx)
</commit_message>
<xml_diff>
--- a/publicaciones_semana.pptx
+++ b/publicaciones_semana.pptx
@@ -12,6 +12,9 @@
     <p:sldId id="260" r:id="rId11"/>
     <p:sldId id="261" r:id="rId12"/>
     <p:sldId id="262" r:id="rId13"/>
+    <p:sldId id="263" r:id="rId14"/>
+    <p:sldId id="264" r:id="rId15"/>
+    <p:sldId id="265" r:id="rId16"/>
   </p:sldIdLst>
   <p:sldSz cx="12191695" cy="6858000" type="screen4x3"/>
   <p:notesSz cx="6858000" cy="9144000"/>
@@ -3277,7 +3280,1014 @@
                 </a:solidFill>
                 <a:latin typeface="Encode Sans"/>
               </a:rPr>
-              <a:t>6 publicaciones · datos oficiales INDEC / BCRA / Hacienda</a:t>
+              <a:t>9 publicaciones · datos oficiales INDEC / BCRA / Hacienda</a:t>
+            </a:r>
+          </a:p>
+        </p:txBody>
+      </p:sp>
+    </p:spTree>
+  </p:cSld>
+  <p:clrMapOvr>
+    <a:masterClrMapping/>
+  </p:clrMapOvr>
+</p:sld>
+</file>
+
+<file path=ppt/slides/slide10.xml><?xml version="1.0" encoding="utf-8"?>
+<p:sld xmlns:a="http://schemas.openxmlformats.org/drawingml/2006/main" xmlns:p="http://schemas.openxmlformats.org/presentationml/2006/main" xmlns:r="http://schemas.openxmlformats.org/officeDocument/2006/relationships">
+  <p:cSld>
+    <p:spTree>
+      <p:nvGrpSpPr>
+        <p:cNvPr id="1" name=""/>
+        <p:cNvGrpSpPr/>
+        <p:nvPr/>
+      </p:nvGrpSpPr>
+      <p:grpSpPr/>
+      <p:sp>
+        <p:nvSpPr>
+          <p:cNvPr id="2" name="Rectangle 1"/>
+          <p:cNvSpPr/>
+          <p:nvPr/>
+        </p:nvSpPr>
+        <p:spPr>
+          <a:xfrm>
+            <a:off x="0" y="0"/>
+            <a:ext cx="12191695" cy="274320"/>
+          </a:xfrm>
+          <a:prstGeom prst="rect">
+            <a:avLst/>
+          </a:prstGeom>
+          <a:solidFill>
+            <a:srgbClr val="00B2C9"/>
+          </a:solidFill>
+          <a:ln>
+            <a:noFill/>
+          </a:ln>
+        </p:spPr>
+        <p:style>
+          <a:lnRef idx="1">
+            <a:schemeClr val="accent1"/>
+          </a:lnRef>
+          <a:fillRef idx="3">
+            <a:schemeClr val="accent1"/>
+          </a:fillRef>
+          <a:effectRef idx="2">
+            <a:schemeClr val="accent1"/>
+          </a:effectRef>
+          <a:fontRef idx="minor">
+            <a:schemeClr val="lt1"/>
+          </a:fontRef>
+        </p:style>
+        <p:txBody>
+          <a:bodyPr rtlCol="0" anchor="ctr"/>
+          <a:lstStyle/>
+          <a:p>
+            <a:pPr algn="ctr"/>
+          </a:p>
+        </p:txBody>
+      </p:sp>
+      <p:sp>
+        <p:nvSpPr>
+          <p:cNvPr id="3" name="TextBox 2"/>
+          <p:cNvSpPr txBox="1"/>
+          <p:nvPr/>
+        </p:nvSpPr>
+        <p:spPr>
+          <a:xfrm>
+            <a:off x="411480" y="457200"/>
+            <a:ext cx="11368735" cy="914400"/>
+          </a:xfrm>
+          <a:prstGeom prst="rect">
+            <a:avLst/>
+          </a:prstGeom>
+          <a:noFill/>
+        </p:spPr>
+        <p:txBody>
+          <a:bodyPr wrap="square" lIns="0" rIns="0">
+            <a:spAutoFit/>
+          </a:bodyPr>
+          <a:lstStyle/>
+          <a:p>
+            <a:pPr algn="l"/>
+            <a:r>
+              <a:rPr sz="2600" b="1" i="0">
+                <a:solidFill>
+                  <a:srgbClr val="00B2C9"/>
+                </a:solidFill>
+                <a:latin typeface="Encode Sans"/>
+              </a:rPr>
+              <a:t>SUPERMERCADOS ABRIL 2026: VENTAS REALES CAYERON -3.7%</a:t>
+            </a:r>
+          </a:p>
+        </p:txBody>
+      </p:sp>
+      <p:sp>
+        <p:nvSpPr>
+          <p:cNvPr id="4" name="TextBox 3"/>
+          <p:cNvSpPr txBox="1"/>
+          <p:nvPr/>
+        </p:nvSpPr>
+        <p:spPr>
+          <a:xfrm>
+            <a:off x="411480" y="1280160"/>
+            <a:ext cx="11368735" cy="274320"/>
+          </a:xfrm>
+          <a:prstGeom prst="rect">
+            <a:avLst/>
+          </a:prstGeom>
+          <a:noFill/>
+        </p:spPr>
+        <p:txBody>
+          <a:bodyPr wrap="none">
+            <a:spAutoFit/>
+          </a:bodyPr>
+          <a:lstStyle/>
+          <a:p>
+            <a:r>
+              <a:rPr sz="1100" b="0" i="1">
+                <a:solidFill>
+                  <a:srgbClr val="6A6760"/>
+                </a:solidFill>
+                <a:latin typeface="Encode Sans"/>
+              </a:rPr>
+              <a:t>INDEC · período 2026-04</a:t>
+            </a:r>
+          </a:p>
+        </p:txBody>
+      </p:sp>
+      <p:sp>
+        <p:nvSpPr>
+          <p:cNvPr id="5" name="TextBox 4"/>
+          <p:cNvSpPr txBox="1"/>
+          <p:nvPr/>
+        </p:nvSpPr>
+        <p:spPr>
+          <a:xfrm>
+            <a:off x="411480" y="1691640"/>
+            <a:ext cx="5486400" cy="1645920"/>
+          </a:xfrm>
+          <a:prstGeom prst="rect">
+            <a:avLst/>
+          </a:prstGeom>
+          <a:noFill/>
+        </p:spPr>
+        <p:txBody>
+          <a:bodyPr wrap="square" lIns="0" rIns="0">
+            <a:spAutoFit/>
+          </a:bodyPr>
+          <a:lstStyle/>
+          <a:p>
+            <a:pPr algn="just"/>
+            <a:r>
+              <a:rPr sz="1300" b="0" i="0">
+                <a:solidFill>
+                  <a:srgbClr val="3F3F3F"/>
+                </a:solidFill>
+                <a:latin typeface="Encode Sans"/>
+              </a:rPr>
+              <a:t>Las ventas de supermercados a precios constantes registraron una variación interanual real de -3.7% en abril 2026. Desestacionalizada: +0.8% m/m.</a:t>
+            </a:r>
+          </a:p>
+        </p:txBody>
+      </p:sp>
+      <p:sp>
+        <p:nvSpPr>
+          <p:cNvPr id="6" name="TextBox 5"/>
+          <p:cNvSpPr txBox="1"/>
+          <p:nvPr/>
+        </p:nvSpPr>
+        <p:spPr>
+          <a:xfrm>
+            <a:off x="411480" y="3520440"/>
+            <a:ext cx="5486400" cy="2743200"/>
+          </a:xfrm>
+          <a:prstGeom prst="rect">
+            <a:avLst/>
+          </a:prstGeom>
+          <a:noFill/>
+        </p:spPr>
+        <p:txBody>
+          <a:bodyPr wrap="square" lIns="0" rIns="0">
+            <a:spAutoFit/>
+          </a:bodyPr>
+          <a:lstStyle/>
+          <a:p>
+            <a:pPr algn="l">
+              <a:spcAft>
+                <a:spcPts val="800"/>
+              </a:spcAft>
+            </a:pPr>
+            <a:r>
+              <a:rPr sz="1300" b="1" i="0">
+                <a:solidFill>
+                  <a:srgbClr val="00B2C9"/>
+                </a:solidFill>
+                <a:latin typeface="Encode Sans"/>
+              </a:rPr>
+              <a:t>●  </a:t>
+            </a:r>
+            <a:r>
+              <a:rPr sz="1300" b="0" i="0">
+                <a:solidFill>
+                  <a:srgbClr val="3F3F3F"/>
+                </a:solidFill>
+                <a:latin typeface="Encode Sans"/>
+              </a:rPr>
+              <a:t>Variación interanual real: -3.7%</a:t>
+            </a:r>
+          </a:p>
+          <a:p>
+            <a:pPr algn="l">
+              <a:spcAft>
+                <a:spcPts val="800"/>
+              </a:spcAft>
+            </a:pPr>
+            <a:r>
+              <a:rPr sz="1300" b="1" i="0">
+                <a:solidFill>
+                  <a:srgbClr val="00B2C9"/>
+                </a:solidFill>
+                <a:latin typeface="Encode Sans"/>
+              </a:rPr>
+              <a:t>●  </a:t>
+            </a:r>
+            <a:r>
+              <a:rPr sz="1300" b="0" i="0">
+                <a:solidFill>
+                  <a:srgbClr val="3F3F3F"/>
+                </a:solidFill>
+                <a:latin typeface="Encode Sans"/>
+              </a:rPr>
+              <a:t>Variación mensual desestacionalizada: +0.8%</a:t>
+            </a:r>
+          </a:p>
+          <a:p>
+            <a:pPr algn="l">
+              <a:spcAft>
+                <a:spcPts val="800"/>
+              </a:spcAft>
+            </a:pPr>
+            <a:r>
+              <a:rPr sz="1300" b="1" i="0">
+                <a:solidFill>
+                  <a:srgbClr val="00B2C9"/>
+                </a:solidFill>
+                <a:latin typeface="Encode Sans"/>
+              </a:rPr>
+              <a:t>●  </a:t>
+            </a:r>
+            <a:r>
+              <a:rPr sz="1300" b="0" i="0">
+                <a:solidFill>
+                  <a:srgbClr val="3F3F3F"/>
+                </a:solidFill>
+                <a:latin typeface="Encode Sans"/>
+              </a:rPr>
+              <a:t>Acumulado del año: -3.3%</a:t>
+            </a:r>
+          </a:p>
+        </p:txBody>
+      </p:sp>
+      <p:pic>
+        <p:nvPicPr>
+          <p:cNvPr id="7" name="Picture 6" descr="image.png"/>
+          <p:cNvPicPr>
+            <a:picLocks noChangeAspect="1"/>
+          </p:cNvPicPr>
+          <p:nvPr/>
+        </p:nvPicPr>
+        <p:blipFill>
+          <a:blip r:embed="rId2"/>
+          <a:stretch>
+            <a:fillRect/>
+          </a:stretch>
+        </p:blipFill>
+        <p:spPr>
+          <a:xfrm>
+            <a:off x="6080760" y="1691640"/>
+            <a:ext cx="5669280" cy="2560320"/>
+          </a:xfrm>
+          <a:prstGeom prst="rect">
+            <a:avLst/>
+          </a:prstGeom>
+        </p:spPr>
+      </p:pic>
+      <p:graphicFrame>
+        <p:nvGraphicFramePr>
+          <p:cNvPr id="8" name="Table 7"/>
+          <p:cNvGraphicFramePr>
+            <a:graphicFrameLocks noGrp="1"/>
+          </p:cNvGraphicFramePr>
+          <p:nvPr/>
+        </p:nvGraphicFramePr>
+        <p:xfrm>
+          <a:off x="6080760" y="4434840"/>
+          <a:ext cx="5669280" cy="2048256"/>
+        </p:xfrm>
+        <a:graphic>
+          <a:graphicData uri="http://schemas.openxmlformats.org/drawingml/2006/table">
+            <a:tbl>
+              <a:tblPr firstRow="1" bandRow="1">
+                <a:tableStyleId>{5C22544A-7EE6-4342-B048-85BDC9FD1C3A}</a:tableStyleId>
+              </a:tblPr>
+              <a:tblGrid>
+                <a:gridCol w="1417320"/>
+                <a:gridCol w="1417320"/>
+                <a:gridCol w="1417320"/>
+                <a:gridCol w="1417320"/>
+              </a:tblGrid>
+              <a:tr h="292608">
+                <a:tc>
+                  <a:txBody>
+                    <a:bodyPr/>
+                    <a:lstStyle/>
+                    <a:p>
+                      <a:pPr algn="l"/>
+                      <a:r>
+                        <a:rPr sz="1000" b="1">
+                          <a:solidFill>
+                            <a:srgbClr val="FFFFFF"/>
+                          </a:solidFill>
+                          <a:latin typeface="Encode Sans"/>
+                        </a:rPr>
+                        <a:t>Mes</a:t>
+                      </a:r>
+                    </a:p>
+                  </a:txBody>
+                  <a:tcPr marL="36576" marR="36576" marT="18288" marB="18288">
+                    <a:solidFill>
+                      <a:srgbClr val="00B2C9"/>
+                    </a:solidFill>
+                  </a:tcPr>
+                </a:tc>
+                <a:tc>
+                  <a:txBody>
+                    <a:bodyPr/>
+                    <a:lstStyle/>
+                    <a:p>
+                      <a:pPr algn="r"/>
+                      <a:r>
+                        <a:rPr sz="1000" b="1">
+                          <a:solidFill>
+                            <a:srgbClr val="FFFFFF"/>
+                          </a:solidFill>
+                          <a:latin typeface="Encode Sans"/>
+                        </a:rPr>
+                        <a:t>Índice real</a:t>
+                      </a:r>
+                    </a:p>
+                  </a:txBody>
+                  <a:tcPr marL="36576" marR="36576" marT="18288" marB="18288">
+                    <a:solidFill>
+                      <a:srgbClr val="00B2C9"/>
+                    </a:solidFill>
+                  </a:tcPr>
+                </a:tc>
+                <a:tc>
+                  <a:txBody>
+                    <a:bodyPr/>
+                    <a:lstStyle/>
+                    <a:p>
+                      <a:pPr algn="r"/>
+                      <a:r>
+                        <a:rPr sz="1000" b="1">
+                          <a:solidFill>
+                            <a:srgbClr val="FFFFFF"/>
+                          </a:solidFill>
+                          <a:latin typeface="Encode Sans"/>
+                        </a:rPr>
+                        <a:t>VIA real %</a:t>
+                      </a:r>
+                    </a:p>
+                  </a:txBody>
+                  <a:tcPr marL="36576" marR="36576" marT="18288" marB="18288">
+                    <a:solidFill>
+                      <a:srgbClr val="00B2C9"/>
+                    </a:solidFill>
+                  </a:tcPr>
+                </a:tc>
+                <a:tc>
+                  <a:txBody>
+                    <a:bodyPr/>
+                    <a:lstStyle/>
+                    <a:p>
+                      <a:pPr algn="r"/>
+                      <a:r>
+                        <a:rPr sz="1000" b="1">
+                          <a:solidFill>
+                            <a:srgbClr val="FFFFFF"/>
+                          </a:solidFill>
+                          <a:latin typeface="Encode Sans"/>
+                        </a:rPr>
+                        <a:t>Acumulado %</a:t>
+                      </a:r>
+                    </a:p>
+                  </a:txBody>
+                  <a:tcPr marL="36576" marR="36576" marT="18288" marB="18288">
+                    <a:solidFill>
+                      <a:srgbClr val="00B2C9"/>
+                    </a:solidFill>
+                  </a:tcPr>
+                </a:tc>
+              </a:tr>
+              <a:tr h="292608">
+                <a:tc>
+                  <a:txBody>
+                    <a:bodyPr/>
+                    <a:lstStyle/>
+                    <a:p>
+                      <a:pPr algn="l"/>
+                      <a:r>
+                        <a:rPr sz="1000">
+                          <a:solidFill>
+                            <a:srgbClr val="3F3F3F"/>
+                          </a:solidFill>
+                          <a:latin typeface="Encode Sans"/>
+                        </a:rPr>
+                        <a:t>Abril 2026</a:t>
+                      </a:r>
+                    </a:p>
+                  </a:txBody>
+                  <a:tcPr marL="36576" marR="36576" marT="18288" marB="18288">
+                    <a:solidFill>
+                      <a:srgbClr val="FFFFFF"/>
+                    </a:solidFill>
+                  </a:tcPr>
+                </a:tc>
+                <a:tc>
+                  <a:txBody>
+                    <a:bodyPr/>
+                    <a:lstStyle/>
+                    <a:p>
+                      <a:pPr algn="r"/>
+                      <a:r>
+                        <a:rPr sz="1000">
+                          <a:solidFill>
+                            <a:srgbClr val="3F3F3F"/>
+                          </a:solidFill>
+                          <a:latin typeface="Encode Sans"/>
+                        </a:rPr>
+                        <a:t>78,5</a:t>
+                      </a:r>
+                    </a:p>
+                  </a:txBody>
+                  <a:tcPr marL="36576" marR="36576" marT="18288" marB="18288">
+                    <a:solidFill>
+                      <a:srgbClr val="FFFFFF"/>
+                    </a:solidFill>
+                  </a:tcPr>
+                </a:tc>
+                <a:tc>
+                  <a:txBody>
+                    <a:bodyPr/>
+                    <a:lstStyle/>
+                    <a:p>
+                      <a:pPr algn="r"/>
+                      <a:r>
+                        <a:rPr sz="1000">
+                          <a:solidFill>
+                            <a:srgbClr val="3F3F3F"/>
+                          </a:solidFill>
+                          <a:latin typeface="Encode Sans"/>
+                        </a:rPr>
+                        <a:t>-3.7%</a:t>
+                      </a:r>
+                    </a:p>
+                  </a:txBody>
+                  <a:tcPr marL="36576" marR="36576" marT="18288" marB="18288">
+                    <a:solidFill>
+                      <a:srgbClr val="FFFFFF"/>
+                    </a:solidFill>
+                  </a:tcPr>
+                </a:tc>
+                <a:tc>
+                  <a:txBody>
+                    <a:bodyPr/>
+                    <a:lstStyle/>
+                    <a:p>
+                      <a:pPr algn="r"/>
+                      <a:r>
+                        <a:rPr sz="1000">
+                          <a:solidFill>
+                            <a:srgbClr val="3F3F3F"/>
+                          </a:solidFill>
+                          <a:latin typeface="Encode Sans"/>
+                        </a:rPr>
+                        <a:t>-3.3%</a:t>
+                      </a:r>
+                    </a:p>
+                  </a:txBody>
+                  <a:tcPr marL="36576" marR="36576" marT="18288" marB="18288">
+                    <a:solidFill>
+                      <a:srgbClr val="FFFFFF"/>
+                    </a:solidFill>
+                  </a:tcPr>
+                </a:tc>
+              </a:tr>
+              <a:tr h="292608">
+                <a:tc>
+                  <a:txBody>
+                    <a:bodyPr/>
+                    <a:lstStyle/>
+                    <a:p>
+                      <a:pPr algn="l"/>
+                      <a:r>
+                        <a:rPr sz="1000">
+                          <a:solidFill>
+                            <a:srgbClr val="3F3F3F"/>
+                          </a:solidFill>
+                          <a:latin typeface="Encode Sans"/>
+                        </a:rPr>
+                        <a:t>Marzo 2026</a:t>
+                      </a:r>
+                    </a:p>
+                  </a:txBody>
+                  <a:tcPr marL="36576" marR="36576" marT="18288" marB="18288">
+                    <a:solidFill>
+                      <a:srgbClr val="F8F8F6"/>
+                    </a:solidFill>
+                  </a:tcPr>
+                </a:tc>
+                <a:tc>
+                  <a:txBody>
+                    <a:bodyPr/>
+                    <a:lstStyle/>
+                    <a:p>
+                      <a:pPr algn="r"/>
+                      <a:r>
+                        <a:rPr sz="1000">
+                          <a:solidFill>
+                            <a:srgbClr val="3F3F3F"/>
+                          </a:solidFill>
+                          <a:latin typeface="Encode Sans"/>
+                        </a:rPr>
+                        <a:t>82,4</a:t>
+                      </a:r>
+                    </a:p>
+                  </a:txBody>
+                  <a:tcPr marL="36576" marR="36576" marT="18288" marB="18288">
+                    <a:solidFill>
+                      <a:srgbClr val="F8F8F6"/>
+                    </a:solidFill>
+                  </a:tcPr>
+                </a:tc>
+                <a:tc>
+                  <a:txBody>
+                    <a:bodyPr/>
+                    <a:lstStyle/>
+                    <a:p>
+                      <a:pPr algn="r"/>
+                      <a:r>
+                        <a:rPr sz="1000">
+                          <a:solidFill>
+                            <a:srgbClr val="3F3F3F"/>
+                          </a:solidFill>
+                          <a:latin typeface="Encode Sans"/>
+                        </a:rPr>
+                        <a:t>-5.1%</a:t>
+                      </a:r>
+                    </a:p>
+                  </a:txBody>
+                  <a:tcPr marL="36576" marR="36576" marT="18288" marB="18288">
+                    <a:solidFill>
+                      <a:srgbClr val="F8F8F6"/>
+                    </a:solidFill>
+                  </a:tcPr>
+                </a:tc>
+                <a:tc>
+                  <a:txBody>
+                    <a:bodyPr/>
+                    <a:lstStyle/>
+                    <a:p>
+                      <a:pPr algn="r"/>
+                      <a:r>
+                        <a:rPr sz="1000">
+                          <a:solidFill>
+                            <a:srgbClr val="3F3F3F"/>
+                          </a:solidFill>
+                          <a:latin typeface="Encode Sans"/>
+                        </a:rPr>
+                        <a:t>-3.1%</a:t>
+                      </a:r>
+                    </a:p>
+                  </a:txBody>
+                  <a:tcPr marL="36576" marR="36576" marT="18288" marB="18288">
+                    <a:solidFill>
+                      <a:srgbClr val="F8F8F6"/>
+                    </a:solidFill>
+                  </a:tcPr>
+                </a:tc>
+              </a:tr>
+              <a:tr h="292608">
+                <a:tc>
+                  <a:txBody>
+                    <a:bodyPr/>
+                    <a:lstStyle/>
+                    <a:p>
+                      <a:pPr algn="l"/>
+                      <a:r>
+                        <a:rPr sz="1000">
+                          <a:solidFill>
+                            <a:srgbClr val="3F3F3F"/>
+                          </a:solidFill>
+                          <a:latin typeface="Encode Sans"/>
+                        </a:rPr>
+                        <a:t>Febrero 2026</a:t>
+                      </a:r>
+                    </a:p>
+                  </a:txBody>
+                  <a:tcPr marL="36576" marR="36576" marT="18288" marB="18288">
+                    <a:solidFill>
+                      <a:srgbClr val="FFFFFF"/>
+                    </a:solidFill>
+                  </a:tcPr>
+                </a:tc>
+                <a:tc>
+                  <a:txBody>
+                    <a:bodyPr/>
+                    <a:lstStyle/>
+                    <a:p>
+                      <a:pPr algn="r"/>
+                      <a:r>
+                        <a:rPr sz="1000">
+                          <a:solidFill>
+                            <a:srgbClr val="3F3F3F"/>
+                          </a:solidFill>
+                          <a:latin typeface="Encode Sans"/>
+                        </a:rPr>
+                        <a:t>76,1</a:t>
+                      </a:r>
+                    </a:p>
+                  </a:txBody>
+                  <a:tcPr marL="36576" marR="36576" marT="18288" marB="18288">
+                    <a:solidFill>
+                      <a:srgbClr val="FFFFFF"/>
+                    </a:solidFill>
+                  </a:tcPr>
+                </a:tc>
+                <a:tc>
+                  <a:txBody>
+                    <a:bodyPr/>
+                    <a:lstStyle/>
+                    <a:p>
+                      <a:pPr algn="r"/>
+                      <a:r>
+                        <a:rPr sz="1000">
+                          <a:solidFill>
+                            <a:srgbClr val="3F3F3F"/>
+                          </a:solidFill>
+                          <a:latin typeface="Encode Sans"/>
+                        </a:rPr>
+                        <a:t>-3.1%</a:t>
+                      </a:r>
+                    </a:p>
+                  </a:txBody>
+                  <a:tcPr marL="36576" marR="36576" marT="18288" marB="18288">
+                    <a:solidFill>
+                      <a:srgbClr val="FFFFFF"/>
+                    </a:solidFill>
+                  </a:tcPr>
+                </a:tc>
+                <a:tc>
+                  <a:txBody>
+                    <a:bodyPr/>
+                    <a:lstStyle/>
+                    <a:p>
+                      <a:pPr algn="r"/>
+                      <a:r>
+                        <a:rPr sz="1000">
+                          <a:solidFill>
+                            <a:srgbClr val="3F3F3F"/>
+                          </a:solidFill>
+                          <a:latin typeface="Encode Sans"/>
+                        </a:rPr>
+                        <a:t>-2.1%</a:t>
+                      </a:r>
+                    </a:p>
+                  </a:txBody>
+                  <a:tcPr marL="36576" marR="36576" marT="18288" marB="18288">
+                    <a:solidFill>
+                      <a:srgbClr val="FFFFFF"/>
+                    </a:solidFill>
+                  </a:tcPr>
+                </a:tc>
+              </a:tr>
+              <a:tr h="292608">
+                <a:tc>
+                  <a:txBody>
+                    <a:bodyPr/>
+                    <a:lstStyle/>
+                    <a:p>
+                      <a:pPr algn="l"/>
+                      <a:r>
+                        <a:rPr sz="1000">
+                          <a:solidFill>
+                            <a:srgbClr val="3F3F3F"/>
+                          </a:solidFill>
+                          <a:latin typeface="Encode Sans"/>
+                        </a:rPr>
+                        <a:t>Enero 2026</a:t>
+                      </a:r>
+                    </a:p>
+                  </a:txBody>
+                  <a:tcPr marL="36576" marR="36576" marT="18288" marB="18288">
+                    <a:solidFill>
+                      <a:srgbClr val="F8F8F6"/>
+                    </a:solidFill>
+                  </a:tcPr>
+                </a:tc>
+                <a:tc>
+                  <a:txBody>
+                    <a:bodyPr/>
+                    <a:lstStyle/>
+                    <a:p>
+                      <a:pPr algn="r"/>
+                      <a:r>
+                        <a:rPr sz="1000">
+                          <a:solidFill>
+                            <a:srgbClr val="3F3F3F"/>
+                          </a:solidFill>
+                          <a:latin typeface="Encode Sans"/>
+                        </a:rPr>
+                        <a:t>82,8</a:t>
+                      </a:r>
+                    </a:p>
+                  </a:txBody>
+                  <a:tcPr marL="36576" marR="36576" marT="18288" marB="18288">
+                    <a:solidFill>
+                      <a:srgbClr val="F8F8F6"/>
+                    </a:solidFill>
+                  </a:tcPr>
+                </a:tc>
+                <a:tc>
+                  <a:txBody>
+                    <a:bodyPr/>
+                    <a:lstStyle/>
+                    <a:p>
+                      <a:pPr algn="r"/>
+                      <a:r>
+                        <a:rPr sz="1000">
+                          <a:solidFill>
+                            <a:srgbClr val="3F3F3F"/>
+                          </a:solidFill>
+                          <a:latin typeface="Encode Sans"/>
+                        </a:rPr>
+                        <a:t>-1.2%</a:t>
+                      </a:r>
+                    </a:p>
+                  </a:txBody>
+                  <a:tcPr marL="36576" marR="36576" marT="18288" marB="18288">
+                    <a:solidFill>
+                      <a:srgbClr val="F8F8F6"/>
+                    </a:solidFill>
+                  </a:tcPr>
+                </a:tc>
+                <a:tc>
+                  <a:txBody>
+                    <a:bodyPr/>
+                    <a:lstStyle/>
+                    <a:p>
+                      <a:pPr algn="r"/>
+                      <a:r>
+                        <a:rPr sz="1000">
+                          <a:solidFill>
+                            <a:srgbClr val="3F3F3F"/>
+                          </a:solidFill>
+                          <a:latin typeface="Encode Sans"/>
+                        </a:rPr>
+                        <a:t>-1.2%</a:t>
+                      </a:r>
+                    </a:p>
+                  </a:txBody>
+                  <a:tcPr marL="36576" marR="36576" marT="18288" marB="18288">
+                    <a:solidFill>
+                      <a:srgbClr val="F8F8F6"/>
+                    </a:solidFill>
+                  </a:tcPr>
+                </a:tc>
+              </a:tr>
+              <a:tr h="292608">
+                <a:tc>
+                  <a:txBody>
+                    <a:bodyPr/>
+                    <a:lstStyle/>
+                    <a:p>
+                      <a:pPr algn="l"/>
+                      <a:r>
+                        <a:rPr sz="1000">
+                          <a:solidFill>
+                            <a:srgbClr val="3F3F3F"/>
+                          </a:solidFill>
+                          <a:latin typeface="Encode Sans"/>
+                        </a:rPr>
+                        <a:t>Diciembre 2025</a:t>
+                      </a:r>
+                    </a:p>
+                  </a:txBody>
+                  <a:tcPr marL="36576" marR="36576" marT="18288" marB="18288">
+                    <a:solidFill>
+                      <a:srgbClr val="FFFFFF"/>
+                    </a:solidFill>
+                  </a:tcPr>
+                </a:tc>
+                <a:tc>
+                  <a:txBody>
+                    <a:bodyPr/>
+                    <a:lstStyle/>
+                    <a:p>
+                      <a:pPr algn="r"/>
+                      <a:r>
+                        <a:rPr sz="1000">
+                          <a:solidFill>
+                            <a:srgbClr val="3F3F3F"/>
+                          </a:solidFill>
+                          <a:latin typeface="Encode Sans"/>
+                        </a:rPr>
+                        <a:t>102,3</a:t>
+                      </a:r>
+                    </a:p>
+                  </a:txBody>
+                  <a:tcPr marL="36576" marR="36576" marT="18288" marB="18288">
+                    <a:solidFill>
+                      <a:srgbClr val="FFFFFF"/>
+                    </a:solidFill>
+                  </a:tcPr>
+                </a:tc>
+                <a:tc>
+                  <a:txBody>
+                    <a:bodyPr/>
+                    <a:lstStyle/>
+                    <a:p>
+                      <a:pPr algn="r"/>
+                      <a:r>
+                        <a:rPr sz="1000">
+                          <a:solidFill>
+                            <a:srgbClr val="3F3F3F"/>
+                          </a:solidFill>
+                          <a:latin typeface="Encode Sans"/>
+                        </a:rPr>
+                        <a:t>+0.5%</a:t>
+                      </a:r>
+                    </a:p>
+                  </a:txBody>
+                  <a:tcPr marL="36576" marR="36576" marT="18288" marB="18288">
+                    <a:solidFill>
+                      <a:srgbClr val="FFFFFF"/>
+                    </a:solidFill>
+                  </a:tcPr>
+                </a:tc>
+                <a:tc>
+                  <a:txBody>
+                    <a:bodyPr/>
+                    <a:lstStyle/>
+                    <a:p>
+                      <a:pPr algn="r"/>
+                      <a:r>
+                        <a:rPr sz="1000">
+                          <a:solidFill>
+                            <a:srgbClr val="3F3F3F"/>
+                          </a:solidFill>
+                          <a:latin typeface="Encode Sans"/>
+                        </a:rPr>
+                        <a:t>+2.0%</a:t>
+                      </a:r>
+                    </a:p>
+                  </a:txBody>
+                  <a:tcPr marL="36576" marR="36576" marT="18288" marB="18288">
+                    <a:solidFill>
+                      <a:srgbClr val="FFFFFF"/>
+                    </a:solidFill>
+                  </a:tcPr>
+                </a:tc>
+              </a:tr>
+              <a:tr h="292608">
+                <a:tc>
+                  <a:txBody>
+                    <a:bodyPr/>
+                    <a:lstStyle/>
+                    <a:p>
+                      <a:pPr algn="l"/>
+                      <a:r>
+                        <a:rPr sz="1000">
+                          <a:solidFill>
+                            <a:srgbClr val="3F3F3F"/>
+                          </a:solidFill>
+                          <a:latin typeface="Encode Sans"/>
+                        </a:rPr>
+                        <a:t>Noviembre 2025</a:t>
+                      </a:r>
+                    </a:p>
+                  </a:txBody>
+                  <a:tcPr marL="36576" marR="36576" marT="18288" marB="18288">
+                    <a:solidFill>
+                      <a:srgbClr val="F8F8F6"/>
+                    </a:solidFill>
+                  </a:tcPr>
+                </a:tc>
+                <a:tc>
+                  <a:txBody>
+                    <a:bodyPr/>
+                    <a:lstStyle/>
+                    <a:p>
+                      <a:pPr algn="r"/>
+                      <a:r>
+                        <a:rPr sz="1000">
+                          <a:solidFill>
+                            <a:srgbClr val="3F3F3F"/>
+                          </a:solidFill>
+                          <a:latin typeface="Encode Sans"/>
+                        </a:rPr>
+                        <a:t>82,3</a:t>
+                      </a:r>
+                    </a:p>
+                  </a:txBody>
+                  <a:tcPr marL="36576" marR="36576" marT="18288" marB="18288">
+                    <a:solidFill>
+                      <a:srgbClr val="F8F8F6"/>
+                    </a:solidFill>
+                  </a:tcPr>
+                </a:tc>
+                <a:tc>
+                  <a:txBody>
+                    <a:bodyPr/>
+                    <a:lstStyle/>
+                    <a:p>
+                      <a:pPr algn="r"/>
+                      <a:r>
+                        <a:rPr sz="1000">
+                          <a:solidFill>
+                            <a:srgbClr val="3F3F3F"/>
+                          </a:solidFill>
+                          <a:latin typeface="Encode Sans"/>
+                        </a:rPr>
+                        <a:t>-2.8%</a:t>
+                      </a:r>
+                    </a:p>
+                  </a:txBody>
+                  <a:tcPr marL="36576" marR="36576" marT="18288" marB="18288">
+                    <a:solidFill>
+                      <a:srgbClr val="F8F8F6"/>
+                    </a:solidFill>
+                  </a:tcPr>
+                </a:tc>
+                <a:tc>
+                  <a:txBody>
+                    <a:bodyPr/>
+                    <a:lstStyle/>
+                    <a:p>
+                      <a:pPr algn="r"/>
+                      <a:r>
+                        <a:rPr sz="1000">
+                          <a:solidFill>
+                            <a:srgbClr val="3F3F3F"/>
+                          </a:solidFill>
+                          <a:latin typeface="Encode Sans"/>
+                        </a:rPr>
+                        <a:t>+2.2%</a:t>
+                      </a:r>
+                    </a:p>
+                  </a:txBody>
+                  <a:tcPr marL="36576" marR="36576" marT="18288" marB="18288">
+                    <a:solidFill>
+                      <a:srgbClr val="F8F8F6"/>
+                    </a:solidFill>
+                  </a:tcPr>
+                </a:tc>
+              </a:tr>
+            </a:tbl>
+          </a:graphicData>
+        </a:graphic>
+      </p:graphicFrame>
+      <p:sp>
+        <p:nvSpPr>
+          <p:cNvPr id="9" name="TextBox 8"/>
+          <p:cNvSpPr txBox="1"/>
+          <p:nvPr/>
+        </p:nvSpPr>
+        <p:spPr>
+          <a:xfrm>
+            <a:off x="411480" y="6492240"/>
+            <a:ext cx="11368735" cy="274320"/>
+          </a:xfrm>
+          <a:prstGeom prst="rect">
+            <a:avLst/>
+          </a:prstGeom>
+          <a:noFill/>
+        </p:spPr>
+        <p:txBody>
+          <a:bodyPr wrap="none">
+            <a:spAutoFit/>
+          </a:bodyPr>
+          <a:lstStyle/>
+          <a:p>
+            <a:r>
+              <a:rPr sz="1000" b="0" i="1">
+                <a:solidFill>
+                  <a:srgbClr val="6A6760"/>
+                </a:solidFill>
+                <a:latin typeface="Encode Sans"/>
+              </a:rPr>
+              <a:t>Fuente: elaboración propia en base a INDEC</a:t>
             </a:r>
           </a:p>
         </p:txBody>
@@ -5038,7 +6048,7 @@
                 </a:solidFill>
                 <a:latin typeface="Encode Sans"/>
               </a:rPr>
-              <a:t>IPIB BÁSICOS ABRIL 2026: +4.76%</a:t>
+              <a:t>FISCAL MAYO 2026: SUPERÁVIT PRIMARIO $1.924K M$</a:t>
             </a:r>
           </a:p>
         </p:txBody>
@@ -5072,7 +6082,7 @@
                 </a:solidFill>
                 <a:latin typeface="Encode Sans"/>
               </a:rPr>
-              <a:t>INDEC · período 2026-04</a:t>
+              <a:t>Hacienda (vía INDEC IMIG) · período 2026-05</a:t>
             </a:r>
           </a:p>
         </p:txBody>
@@ -5107,7 +6117,7 @@
                 </a:solidFill>
                 <a:latin typeface="Encode Sans"/>
               </a:rPr>
-              <a:t>El IPIB básicos registró un aumento de +4.76% mensual en abril 2026, acumulando 29.59% interanual. Suele anticipar el IPC minorista.</a:t>
+              <a:t>El Sector Público Nacional No Financiero registró un resultado primario de +1.924 mil millones de pesos en mayo 2026. El resultado financiero alcanzó +479K M$.</a:t>
             </a:r>
           </a:p>
         </p:txBody>
@@ -5155,7 +6165,7 @@
                 </a:solidFill>
                 <a:latin typeface="Encode Sans"/>
               </a:rPr>
-              <a:t>Nivel general: +4.76% mensual</a:t>
+              <a:t>Resultado primario: +1.924 mil millones de pesos</a:t>
             </a:r>
           </a:p>
           <a:p>
@@ -5180,7 +6190,7 @@
                 </a:solidFill>
                 <a:latin typeface="Encode Sans"/>
               </a:rPr>
-              <a:t>Interanual: 29.59%</a:t>
+              <a:t>Resultado financiero: +479 mil millones</a:t>
             </a:r>
           </a:p>
           <a:p>
@@ -5205,7 +6215,7 @@
                 </a:solidFill>
                 <a:latin typeface="Encode Sans"/>
               </a:rPr>
-              <a:t>Brecha vs IPC minorista: +2.2% pp (IPC +2.6%)</a:t>
+              <a:t>Fuente: Secretaría de Hacienda, base caja (Metodología 2017)</a:t>
             </a:r>
           </a:p>
         </p:txBody>
@@ -5294,7 +6304,7 @@
                           </a:solidFill>
                           <a:latin typeface="Encode Sans"/>
                         </a:rPr>
-                        <a:t>VM %</a:t>
+                        <a:t>Primario M$</a:t>
                       </a:r>
                     </a:p>
                   </a:txBody>
@@ -5317,7 +6327,7 @@
                           </a:solidFill>
                           <a:latin typeface="Encode Sans"/>
                         </a:rPr>
-                        <a:t>VIA %</a:t>
+                        <a:t>Financiero M$</a:t>
                       </a:r>
                     </a:p>
                   </a:txBody>
@@ -5365,7 +6375,7 @@
                           </a:solidFill>
                           <a:latin typeface="Encode Sans"/>
                         </a:rPr>
-                        <a:t>+2.68%</a:t>
+                        <a:t>1.924.367</a:t>
                       </a:r>
                     </a:p>
                   </a:txBody>
@@ -5388,7 +6398,7 @@
                           </a:solidFill>
                           <a:latin typeface="Encode Sans"/>
                         </a:rPr>
-                        <a:t>+33.5%</a:t>
+                        <a:t>478.613</a:t>
                       </a:r>
                     </a:p>
                   </a:txBody>
@@ -5436,7 +6446,7 @@
                           </a:solidFill>
                           <a:latin typeface="Encode Sans"/>
                         </a:rPr>
-                        <a:t>+4.76%</a:t>
+                        <a:t>632.844</a:t>
                       </a:r>
                     </a:p>
                   </a:txBody>
@@ -5459,7 +6469,7 @@
                           </a:solidFill>
                           <a:latin typeface="Encode Sans"/>
                         </a:rPr>
-                        <a:t>+29.6%</a:t>
+                        <a:t>268.103</a:t>
                       </a:r>
                     </a:p>
                   </a:txBody>
@@ -5507,7 +6517,7 @@
                           </a:solidFill>
                           <a:latin typeface="Encode Sans"/>
                         </a:rPr>
-                        <a:t>+3.00%</a:t>
+                        <a:t>930.284</a:t>
                       </a:r>
                     </a:p>
                   </a:txBody>
@@ -5530,7 +6540,7 @@
                           </a:solidFill>
                           <a:latin typeface="Encode Sans"/>
                         </a:rPr>
-                        <a:t>+27.1%</a:t>
+                        <a:t>484.789</a:t>
                       </a:r>
                     </a:p>
                   </a:txBody>
@@ -5578,7 +6588,7 @@
                           </a:solidFill>
                           <a:latin typeface="Encode Sans"/>
                         </a:rPr>
-                        <a:t>+0.67%</a:t>
+                        <a:t>1.410.640</a:t>
                       </a:r>
                     </a:p>
                   </a:txBody>
@@ -5601,7 +6611,7 @@
                           </a:solidFill>
                           <a:latin typeface="Encode Sans"/>
                         </a:rPr>
-                        <a:t>+25.1%</a:t>
+                        <a:t>297.224</a:t>
                       </a:r>
                     </a:p>
                   </a:txBody>
@@ -5649,7 +6659,7 @@
                           </a:solidFill>
                           <a:latin typeface="Encode Sans"/>
                         </a:rPr>
-                        <a:t>+1.56%</a:t>
+                        <a:t>3.125.737</a:t>
                       </a:r>
                     </a:p>
                   </a:txBody>
@@ -5672,7 +6682,7 @@
                           </a:solidFill>
                           <a:latin typeface="Encode Sans"/>
                         </a:rPr>
-                        <a:t>+26.6%</a:t>
+                        <a:t>-166.961</a:t>
                       </a:r>
                     </a:p>
                   </a:txBody>
@@ -5720,7 +6730,7 @@
                           </a:solidFill>
                           <a:latin typeface="Encode Sans"/>
                         </a:rPr>
-                        <a:t>+2.20%</a:t>
+                        <a:t>-2.876.450</a:t>
                       </a:r>
                     </a:p>
                   </a:txBody>
@@ -5743,7 +6753,7 @@
                           </a:solidFill>
                           <a:latin typeface="Encode Sans"/>
                         </a:rPr>
-                        <a:t>+26.6%</a:t>
+                        <a:t>612.810</a:t>
                       </a:r>
                     </a:p>
                   </a:txBody>
@@ -5787,7 +6797,7 @@
                 </a:solidFill>
                 <a:latin typeface="Encode Sans"/>
               </a:rPr>
-              <a:t>Fuente: elaboración propia en base a INDEC</a:t>
+              <a:t>Fuente: elaboración propia en base a Hacienda (vía INDEC IMIG)</a:t>
             </a:r>
           </a:p>
         </p:txBody>
@@ -5883,7 +6893,7 @@
                 </a:solidFill>
                 <a:latin typeface="Encode Sans"/>
               </a:rPr>
-              <a:t>IPIB BÁSICOS MAYO 2026: +2.68%</a:t>
+              <a:t>IPIB BÁSICOS ABRIL 2026: +4.76%</a:t>
             </a:r>
           </a:p>
         </p:txBody>
@@ -5917,7 +6927,7 @@
                 </a:solidFill>
                 <a:latin typeface="Encode Sans"/>
               </a:rPr>
-              <a:t>INDEC · período 2026-05</a:t>
+              <a:t>INDEC · período 2026-04</a:t>
             </a:r>
           </a:p>
         </p:txBody>
@@ -5952,7 +6962,7 @@
                 </a:solidFill>
                 <a:latin typeface="Encode Sans"/>
               </a:rPr>
-              <a:t>El IPIB básicos registró un aumento de +2.68% mensual en mayo 2026, acumulando 33.47% interanual. Suele anticipar el IPC minorista.</a:t>
+              <a:t>El IPIB básicos registró un aumento de +4.76% mensual en abril 2026, acumulando 29.59% interanual. Suele anticipar el IPC minorista.</a:t>
             </a:r>
           </a:p>
         </p:txBody>
@@ -6000,7 +7010,7 @@
                 </a:solidFill>
                 <a:latin typeface="Encode Sans"/>
               </a:rPr>
-              <a:t>Nivel general: +2.68% mensual</a:t>
+              <a:t>Nivel general: +4.76% mensual</a:t>
             </a:r>
           </a:p>
           <a:p>
@@ -6025,7 +7035,7 @@
                 </a:solidFill>
                 <a:latin typeface="Encode Sans"/>
               </a:rPr>
-              <a:t>Interanual: 33.47%</a:t>
+              <a:t>Interanual: 29.59%</a:t>
             </a:r>
           </a:p>
           <a:p>
@@ -6050,7 +7060,7 @@
                 </a:solidFill>
                 <a:latin typeface="Encode Sans"/>
               </a:rPr>
-              <a:t>Brecha vs IPC minorista: +0.5% pp (IPC +2.1%)</a:t>
+              <a:t>Brecha vs IPC minorista: +2.2% pp (IPC +2.6%)</a:t>
             </a:r>
           </a:p>
         </p:txBody>
@@ -6728,7 +7738,7 @@
                 </a:solidFill>
                 <a:latin typeface="Encode Sans"/>
               </a:rPr>
-              <a:t>IPP PRODUCTOR ABRIL 2026: +4.79%</a:t>
+              <a:t>IPIB BÁSICOS MAYO 2026: +2.68%</a:t>
             </a:r>
           </a:p>
         </p:txBody>
@@ -6762,7 +7772,7 @@
                 </a:solidFill>
                 <a:latin typeface="Encode Sans"/>
               </a:rPr>
-              <a:t>INDEC · período 2026-04</a:t>
+              <a:t>INDEC · período 2026-05</a:t>
             </a:r>
           </a:p>
         </p:txBody>
@@ -6797,7 +7807,7 @@
                 </a:solidFill>
                 <a:latin typeface="Encode Sans"/>
               </a:rPr>
-              <a:t>El IPP productor registró un aumento de +4.79% mensual en abril 2026, acumulando 30.89% interanual. Suele anticipar el IPC minorista.</a:t>
+              <a:t>El IPIB básicos registró un aumento de +2.68% mensual en mayo 2026, acumulando 33.47% interanual. Suele anticipar el IPC minorista.</a:t>
             </a:r>
           </a:p>
         </p:txBody>
@@ -6845,7 +7855,7 @@
                 </a:solidFill>
                 <a:latin typeface="Encode Sans"/>
               </a:rPr>
-              <a:t>Nivel general: +4.79% mensual</a:t>
+              <a:t>Nivel general: +2.68% mensual</a:t>
             </a:r>
           </a:p>
           <a:p>
@@ -6870,7 +7880,7 @@
                 </a:solidFill>
                 <a:latin typeface="Encode Sans"/>
               </a:rPr>
-              <a:t>Interanual: 30.89%</a:t>
+              <a:t>Interanual: 33.47%</a:t>
             </a:r>
           </a:p>
           <a:p>
@@ -6895,7 +7905,7 @@
                 </a:solidFill>
                 <a:latin typeface="Encode Sans"/>
               </a:rPr>
-              <a:t>Brecha vs IPC minorista: +2.2% pp (IPC +2.6%)</a:t>
+              <a:t>Brecha vs IPC minorista: +0.5% pp (IPC +2.1%)</a:t>
             </a:r>
           </a:p>
         </p:txBody>
@@ -7055,7 +8065,7 @@
                           </a:solidFill>
                           <a:latin typeface="Encode Sans"/>
                         </a:rPr>
-                        <a:t>+2.67%</a:t>
+                        <a:t>+2.68%</a:t>
                       </a:r>
                     </a:p>
                   </a:txBody>
@@ -7078,7 +8088,7 @@
                           </a:solidFill>
                           <a:latin typeface="Encode Sans"/>
                         </a:rPr>
-                        <a:t>+34.6%</a:t>
+                        <a:t>+33.5%</a:t>
                       </a:r>
                     </a:p>
                   </a:txBody>
@@ -7126,7 +8136,7 @@
                           </a:solidFill>
                           <a:latin typeface="Encode Sans"/>
                         </a:rPr>
-                        <a:t>+4.79%</a:t>
+                        <a:t>+4.76%</a:t>
                       </a:r>
                     </a:p>
                   </a:txBody>
@@ -7149,7 +8159,7 @@
                           </a:solidFill>
                           <a:latin typeface="Encode Sans"/>
                         </a:rPr>
-                        <a:t>+30.9%</a:t>
+                        <a:t>+29.6%</a:t>
                       </a:r>
                     </a:p>
                   </a:txBody>
@@ -7197,7 +8207,7 @@
                           </a:solidFill>
                           <a:latin typeface="Encode Sans"/>
                         </a:rPr>
-                        <a:t>+2.95%</a:t>
+                        <a:t>+3.00%</a:t>
                       </a:r>
                     </a:p>
                   </a:txBody>
@@ -7220,7 +8230,7 @@
                           </a:solidFill>
                           <a:latin typeface="Encode Sans"/>
                         </a:rPr>
-                        <a:t>+28.1%</a:t>
+                        <a:t>+27.1%</a:t>
                       </a:r>
                     </a:p>
                   </a:txBody>
@@ -7268,7 +8278,7 @@
                           </a:solidFill>
                           <a:latin typeface="Encode Sans"/>
                         </a:rPr>
-                        <a:t>+0.69%</a:t>
+                        <a:t>+0.67%</a:t>
                       </a:r>
                     </a:p>
                   </a:txBody>
@@ -7291,7 +8301,7 @@
                           </a:solidFill>
                           <a:latin typeface="Encode Sans"/>
                         </a:rPr>
-                        <a:t>+26.0%</a:t>
+                        <a:t>+25.1%</a:t>
                       </a:r>
                     </a:p>
                   </a:txBody>
@@ -7339,7 +8349,7 @@
                           </a:solidFill>
                           <a:latin typeface="Encode Sans"/>
                         </a:rPr>
-                        <a:t>+1.58%</a:t>
+                        <a:t>+1.56%</a:t>
                       </a:r>
                     </a:p>
                   </a:txBody>
@@ -7362,7 +8372,7 @@
                           </a:solidFill>
                           <a:latin typeface="Encode Sans"/>
                         </a:rPr>
-                        <a:t>+27.7%</a:t>
+                        <a:t>+26.6%</a:t>
                       </a:r>
                     </a:p>
                   </a:txBody>
@@ -7410,7 +8420,7 @@
                           </a:solidFill>
                           <a:latin typeface="Encode Sans"/>
                         </a:rPr>
-                        <a:t>+2.43%</a:t>
+                        <a:t>+2.20%</a:t>
                       </a:r>
                     </a:p>
                   </a:txBody>
@@ -7433,7 +8443,7 @@
                           </a:solidFill>
                           <a:latin typeface="Encode Sans"/>
                         </a:rPr>
-                        <a:t>+28.0%</a:t>
+                        <a:t>+26.6%</a:t>
                       </a:r>
                     </a:p>
                   </a:txBody>
@@ -7573,7 +8583,7 @@
                 </a:solidFill>
                 <a:latin typeface="Encode Sans"/>
               </a:rPr>
-              <a:t>IPP PRODUCTOR MAYO 2026: +2.67%</a:t>
+              <a:t>IPP PRODUCTOR ABRIL 2026: +4.79%</a:t>
             </a:r>
           </a:p>
         </p:txBody>
@@ -7607,7 +8617,7 @@
                 </a:solidFill>
                 <a:latin typeface="Encode Sans"/>
               </a:rPr>
-              <a:t>INDEC · período 2026-05</a:t>
+              <a:t>INDEC · período 2026-04</a:t>
             </a:r>
           </a:p>
         </p:txBody>
@@ -7642,7 +8652,7 @@
                 </a:solidFill>
                 <a:latin typeface="Encode Sans"/>
               </a:rPr>
-              <a:t>El IPP productor registró un aumento de +2.67% mensual en mayo 2026, acumulando 34.65% interanual. Suele anticipar el IPC minorista.</a:t>
+              <a:t>El IPP productor registró un aumento de +4.79% mensual en abril 2026, acumulando 30.89% interanual. Suele anticipar el IPC minorista.</a:t>
             </a:r>
           </a:p>
         </p:txBody>
@@ -7690,7 +8700,7 @@
                 </a:solidFill>
                 <a:latin typeface="Encode Sans"/>
               </a:rPr>
-              <a:t>Nivel general: +2.67% mensual</a:t>
+              <a:t>Nivel general: +4.79% mensual</a:t>
             </a:r>
           </a:p>
           <a:p>
@@ -7715,7 +8725,7 @@
                 </a:solidFill>
                 <a:latin typeface="Encode Sans"/>
               </a:rPr>
-              <a:t>Interanual: 34.65%</a:t>
+              <a:t>Interanual: 30.89%</a:t>
             </a:r>
           </a:p>
           <a:p>
@@ -7740,7 +8750,7 @@
                 </a:solidFill>
                 <a:latin typeface="Encode Sans"/>
               </a:rPr>
-              <a:t>Brecha vs IPC minorista: +0.5% pp (IPC +2.1%)</a:t>
+              <a:t>Brecha vs IPC minorista: +2.2% pp (IPC +2.6%)</a:t>
             </a:r>
           </a:p>
         </p:txBody>
@@ -8279,6 +9289,1858 @@
                           <a:latin typeface="Encode Sans"/>
                         </a:rPr>
                         <a:t>+28.0%</a:t>
+                      </a:r>
+                    </a:p>
+                  </a:txBody>
+                  <a:tcPr marL="36576" marR="36576" marT="18288" marB="18288">
+                    <a:solidFill>
+                      <a:srgbClr val="F8F8F6"/>
+                    </a:solidFill>
+                  </a:tcPr>
+                </a:tc>
+              </a:tr>
+            </a:tbl>
+          </a:graphicData>
+        </a:graphic>
+      </p:graphicFrame>
+      <p:sp>
+        <p:nvSpPr>
+          <p:cNvPr id="9" name="TextBox 8"/>
+          <p:cNvSpPr txBox="1"/>
+          <p:nvPr/>
+        </p:nvSpPr>
+        <p:spPr>
+          <a:xfrm>
+            <a:off x="411480" y="6492240"/>
+            <a:ext cx="11368735" cy="274320"/>
+          </a:xfrm>
+          <a:prstGeom prst="rect">
+            <a:avLst/>
+          </a:prstGeom>
+          <a:noFill/>
+        </p:spPr>
+        <p:txBody>
+          <a:bodyPr wrap="none">
+            <a:spAutoFit/>
+          </a:bodyPr>
+          <a:lstStyle/>
+          <a:p>
+            <a:r>
+              <a:rPr sz="1000" b="0" i="1">
+                <a:solidFill>
+                  <a:srgbClr val="6A6760"/>
+                </a:solidFill>
+                <a:latin typeface="Encode Sans"/>
+              </a:rPr>
+              <a:t>Fuente: elaboración propia en base a INDEC</a:t>
+            </a:r>
+          </a:p>
+        </p:txBody>
+      </p:sp>
+    </p:spTree>
+  </p:cSld>
+  <p:clrMapOvr>
+    <a:masterClrMapping/>
+  </p:clrMapOvr>
+</p:sld>
+</file>
+
+<file path=ppt/slides/slide8.xml><?xml version="1.0" encoding="utf-8"?>
+<p:sld xmlns:a="http://schemas.openxmlformats.org/drawingml/2006/main" xmlns:p="http://schemas.openxmlformats.org/presentationml/2006/main" xmlns:r="http://schemas.openxmlformats.org/officeDocument/2006/relationships">
+  <p:cSld>
+    <p:spTree>
+      <p:nvGrpSpPr>
+        <p:cNvPr id="1" name=""/>
+        <p:cNvGrpSpPr/>
+        <p:nvPr/>
+      </p:nvGrpSpPr>
+      <p:grpSpPr/>
+      <p:sp>
+        <p:nvSpPr>
+          <p:cNvPr id="2" name="Rectangle 1"/>
+          <p:cNvSpPr/>
+          <p:nvPr/>
+        </p:nvSpPr>
+        <p:spPr>
+          <a:xfrm>
+            <a:off x="0" y="0"/>
+            <a:ext cx="12191695" cy="274320"/>
+          </a:xfrm>
+          <a:prstGeom prst="rect">
+            <a:avLst/>
+          </a:prstGeom>
+          <a:solidFill>
+            <a:srgbClr val="00B2C9"/>
+          </a:solidFill>
+          <a:ln>
+            <a:noFill/>
+          </a:ln>
+        </p:spPr>
+        <p:style>
+          <a:lnRef idx="1">
+            <a:schemeClr val="accent1"/>
+          </a:lnRef>
+          <a:fillRef idx="3">
+            <a:schemeClr val="accent1"/>
+          </a:fillRef>
+          <a:effectRef idx="2">
+            <a:schemeClr val="accent1"/>
+          </a:effectRef>
+          <a:fontRef idx="minor">
+            <a:schemeClr val="lt1"/>
+          </a:fontRef>
+        </p:style>
+        <p:txBody>
+          <a:bodyPr rtlCol="0" anchor="ctr"/>
+          <a:lstStyle/>
+          <a:p>
+            <a:pPr algn="ctr"/>
+          </a:p>
+        </p:txBody>
+      </p:sp>
+      <p:sp>
+        <p:nvSpPr>
+          <p:cNvPr id="3" name="TextBox 2"/>
+          <p:cNvSpPr txBox="1"/>
+          <p:nvPr/>
+        </p:nvSpPr>
+        <p:spPr>
+          <a:xfrm>
+            <a:off x="411480" y="457200"/>
+            <a:ext cx="11368735" cy="914400"/>
+          </a:xfrm>
+          <a:prstGeom prst="rect">
+            <a:avLst/>
+          </a:prstGeom>
+          <a:noFill/>
+        </p:spPr>
+        <p:txBody>
+          <a:bodyPr wrap="square" lIns="0" rIns="0">
+            <a:spAutoFit/>
+          </a:bodyPr>
+          <a:lstStyle/>
+          <a:p>
+            <a:pPr algn="l"/>
+            <a:r>
+              <a:rPr sz="2600" b="1" i="0">
+                <a:solidFill>
+                  <a:srgbClr val="00B2C9"/>
+                </a:solidFill>
+                <a:latin typeface="Encode Sans"/>
+              </a:rPr>
+              <a:t>IPP PRODUCTOR MAYO 2026: +2.67%</a:t>
+            </a:r>
+          </a:p>
+        </p:txBody>
+      </p:sp>
+      <p:sp>
+        <p:nvSpPr>
+          <p:cNvPr id="4" name="TextBox 3"/>
+          <p:cNvSpPr txBox="1"/>
+          <p:nvPr/>
+        </p:nvSpPr>
+        <p:spPr>
+          <a:xfrm>
+            <a:off x="411480" y="1280160"/>
+            <a:ext cx="11368735" cy="274320"/>
+          </a:xfrm>
+          <a:prstGeom prst="rect">
+            <a:avLst/>
+          </a:prstGeom>
+          <a:noFill/>
+        </p:spPr>
+        <p:txBody>
+          <a:bodyPr wrap="none">
+            <a:spAutoFit/>
+          </a:bodyPr>
+          <a:lstStyle/>
+          <a:p>
+            <a:r>
+              <a:rPr sz="1100" b="0" i="1">
+                <a:solidFill>
+                  <a:srgbClr val="6A6760"/>
+                </a:solidFill>
+                <a:latin typeface="Encode Sans"/>
+              </a:rPr>
+              <a:t>INDEC · período 2026-05</a:t>
+            </a:r>
+          </a:p>
+        </p:txBody>
+      </p:sp>
+      <p:sp>
+        <p:nvSpPr>
+          <p:cNvPr id="5" name="TextBox 4"/>
+          <p:cNvSpPr txBox="1"/>
+          <p:nvPr/>
+        </p:nvSpPr>
+        <p:spPr>
+          <a:xfrm>
+            <a:off x="411480" y="1691640"/>
+            <a:ext cx="5486400" cy="1645920"/>
+          </a:xfrm>
+          <a:prstGeom prst="rect">
+            <a:avLst/>
+          </a:prstGeom>
+          <a:noFill/>
+        </p:spPr>
+        <p:txBody>
+          <a:bodyPr wrap="square" lIns="0" rIns="0">
+            <a:spAutoFit/>
+          </a:bodyPr>
+          <a:lstStyle/>
+          <a:p>
+            <a:pPr algn="just"/>
+            <a:r>
+              <a:rPr sz="1300" b="0" i="0">
+                <a:solidFill>
+                  <a:srgbClr val="3F3F3F"/>
+                </a:solidFill>
+                <a:latin typeface="Encode Sans"/>
+              </a:rPr>
+              <a:t>El IPP productor registró un aumento de +2.67% mensual en mayo 2026, acumulando 34.65% interanual. Suele anticipar el IPC minorista.</a:t>
+            </a:r>
+          </a:p>
+        </p:txBody>
+      </p:sp>
+      <p:sp>
+        <p:nvSpPr>
+          <p:cNvPr id="6" name="TextBox 5"/>
+          <p:cNvSpPr txBox="1"/>
+          <p:nvPr/>
+        </p:nvSpPr>
+        <p:spPr>
+          <a:xfrm>
+            <a:off x="411480" y="3520440"/>
+            <a:ext cx="5486400" cy="2743200"/>
+          </a:xfrm>
+          <a:prstGeom prst="rect">
+            <a:avLst/>
+          </a:prstGeom>
+          <a:noFill/>
+        </p:spPr>
+        <p:txBody>
+          <a:bodyPr wrap="square" lIns="0" rIns="0">
+            <a:spAutoFit/>
+          </a:bodyPr>
+          <a:lstStyle/>
+          <a:p>
+            <a:pPr algn="l">
+              <a:spcAft>
+                <a:spcPts val="800"/>
+              </a:spcAft>
+            </a:pPr>
+            <a:r>
+              <a:rPr sz="1300" b="1" i="0">
+                <a:solidFill>
+                  <a:srgbClr val="00B2C9"/>
+                </a:solidFill>
+                <a:latin typeface="Encode Sans"/>
+              </a:rPr>
+              <a:t>●  </a:t>
+            </a:r>
+            <a:r>
+              <a:rPr sz="1300" b="0" i="0">
+                <a:solidFill>
+                  <a:srgbClr val="3F3F3F"/>
+                </a:solidFill>
+                <a:latin typeface="Encode Sans"/>
+              </a:rPr>
+              <a:t>Nivel general: +2.67% mensual</a:t>
+            </a:r>
+          </a:p>
+          <a:p>
+            <a:pPr algn="l">
+              <a:spcAft>
+                <a:spcPts val="800"/>
+              </a:spcAft>
+            </a:pPr>
+            <a:r>
+              <a:rPr sz="1300" b="1" i="0">
+                <a:solidFill>
+                  <a:srgbClr val="00B2C9"/>
+                </a:solidFill>
+                <a:latin typeface="Encode Sans"/>
+              </a:rPr>
+              <a:t>●  </a:t>
+            </a:r>
+            <a:r>
+              <a:rPr sz="1300" b="0" i="0">
+                <a:solidFill>
+                  <a:srgbClr val="3F3F3F"/>
+                </a:solidFill>
+                <a:latin typeface="Encode Sans"/>
+              </a:rPr>
+              <a:t>Interanual: 34.65%</a:t>
+            </a:r>
+          </a:p>
+          <a:p>
+            <a:pPr algn="l">
+              <a:spcAft>
+                <a:spcPts val="800"/>
+              </a:spcAft>
+            </a:pPr>
+            <a:r>
+              <a:rPr sz="1300" b="1" i="0">
+                <a:solidFill>
+                  <a:srgbClr val="00B2C9"/>
+                </a:solidFill>
+                <a:latin typeface="Encode Sans"/>
+              </a:rPr>
+              <a:t>●  </a:t>
+            </a:r>
+            <a:r>
+              <a:rPr sz="1300" b="0" i="0">
+                <a:solidFill>
+                  <a:srgbClr val="3F3F3F"/>
+                </a:solidFill>
+                <a:latin typeface="Encode Sans"/>
+              </a:rPr>
+              <a:t>Brecha vs IPC minorista: +0.5% pp (IPC +2.1%)</a:t>
+            </a:r>
+          </a:p>
+        </p:txBody>
+      </p:sp>
+      <p:pic>
+        <p:nvPicPr>
+          <p:cNvPr id="7" name="Picture 6" descr="image.png"/>
+          <p:cNvPicPr>
+            <a:picLocks noChangeAspect="1"/>
+          </p:cNvPicPr>
+          <p:nvPr/>
+        </p:nvPicPr>
+        <p:blipFill>
+          <a:blip r:embed="rId2"/>
+          <a:stretch>
+            <a:fillRect/>
+          </a:stretch>
+        </p:blipFill>
+        <p:spPr>
+          <a:xfrm>
+            <a:off x="6080760" y="1691640"/>
+            <a:ext cx="5669280" cy="2560320"/>
+          </a:xfrm>
+          <a:prstGeom prst="rect">
+            <a:avLst/>
+          </a:prstGeom>
+        </p:spPr>
+      </p:pic>
+      <p:graphicFrame>
+        <p:nvGraphicFramePr>
+          <p:cNvPr id="8" name="Table 7"/>
+          <p:cNvGraphicFramePr>
+            <a:graphicFrameLocks noGrp="1"/>
+          </p:cNvGraphicFramePr>
+          <p:nvPr/>
+        </p:nvGraphicFramePr>
+        <p:xfrm>
+          <a:off x="6080760" y="4434840"/>
+          <a:ext cx="5669280" cy="2048256"/>
+        </p:xfrm>
+        <a:graphic>
+          <a:graphicData uri="http://schemas.openxmlformats.org/drawingml/2006/table">
+            <a:tbl>
+              <a:tblPr firstRow="1" bandRow="1">
+                <a:tableStyleId>{5C22544A-7EE6-4342-B048-85BDC9FD1C3A}</a:tableStyleId>
+              </a:tblPr>
+              <a:tblGrid>
+                <a:gridCol w="1889760"/>
+                <a:gridCol w="1889760"/>
+                <a:gridCol w="1889760"/>
+              </a:tblGrid>
+              <a:tr h="292608">
+                <a:tc>
+                  <a:txBody>
+                    <a:bodyPr/>
+                    <a:lstStyle/>
+                    <a:p>
+                      <a:pPr algn="l"/>
+                      <a:r>
+                        <a:rPr sz="1000" b="1">
+                          <a:solidFill>
+                            <a:srgbClr val="FFFFFF"/>
+                          </a:solidFill>
+                          <a:latin typeface="Encode Sans"/>
+                        </a:rPr>
+                        <a:t>Mes</a:t>
+                      </a:r>
+                    </a:p>
+                  </a:txBody>
+                  <a:tcPr marL="36576" marR="36576" marT="18288" marB="18288">
+                    <a:solidFill>
+                      <a:srgbClr val="00B2C9"/>
+                    </a:solidFill>
+                  </a:tcPr>
+                </a:tc>
+                <a:tc>
+                  <a:txBody>
+                    <a:bodyPr/>
+                    <a:lstStyle/>
+                    <a:p>
+                      <a:pPr algn="r"/>
+                      <a:r>
+                        <a:rPr sz="1000" b="1">
+                          <a:solidFill>
+                            <a:srgbClr val="FFFFFF"/>
+                          </a:solidFill>
+                          <a:latin typeface="Encode Sans"/>
+                        </a:rPr>
+                        <a:t>VM %</a:t>
+                      </a:r>
+                    </a:p>
+                  </a:txBody>
+                  <a:tcPr marL="36576" marR="36576" marT="18288" marB="18288">
+                    <a:solidFill>
+                      <a:srgbClr val="00B2C9"/>
+                    </a:solidFill>
+                  </a:tcPr>
+                </a:tc>
+                <a:tc>
+                  <a:txBody>
+                    <a:bodyPr/>
+                    <a:lstStyle/>
+                    <a:p>
+                      <a:pPr algn="r"/>
+                      <a:r>
+                        <a:rPr sz="1000" b="1">
+                          <a:solidFill>
+                            <a:srgbClr val="FFFFFF"/>
+                          </a:solidFill>
+                          <a:latin typeface="Encode Sans"/>
+                        </a:rPr>
+                        <a:t>VIA %</a:t>
+                      </a:r>
+                    </a:p>
+                  </a:txBody>
+                  <a:tcPr marL="36576" marR="36576" marT="18288" marB="18288">
+                    <a:solidFill>
+                      <a:srgbClr val="00B2C9"/>
+                    </a:solidFill>
+                  </a:tcPr>
+                </a:tc>
+              </a:tr>
+              <a:tr h="292608">
+                <a:tc>
+                  <a:txBody>
+                    <a:bodyPr/>
+                    <a:lstStyle/>
+                    <a:p>
+                      <a:pPr algn="l"/>
+                      <a:r>
+                        <a:rPr sz="1000">
+                          <a:solidFill>
+                            <a:srgbClr val="3F3F3F"/>
+                          </a:solidFill>
+                          <a:latin typeface="Encode Sans"/>
+                        </a:rPr>
+                        <a:t>Mayo 2026</a:t>
+                      </a:r>
+                    </a:p>
+                  </a:txBody>
+                  <a:tcPr marL="36576" marR="36576" marT="18288" marB="18288">
+                    <a:solidFill>
+                      <a:srgbClr val="FFFFFF"/>
+                    </a:solidFill>
+                  </a:tcPr>
+                </a:tc>
+                <a:tc>
+                  <a:txBody>
+                    <a:bodyPr/>
+                    <a:lstStyle/>
+                    <a:p>
+                      <a:pPr algn="r"/>
+                      <a:r>
+                        <a:rPr sz="1000">
+                          <a:solidFill>
+                            <a:srgbClr val="3F3F3F"/>
+                          </a:solidFill>
+                          <a:latin typeface="Encode Sans"/>
+                        </a:rPr>
+                        <a:t>+2.67%</a:t>
+                      </a:r>
+                    </a:p>
+                  </a:txBody>
+                  <a:tcPr marL="36576" marR="36576" marT="18288" marB="18288">
+                    <a:solidFill>
+                      <a:srgbClr val="FFFFFF"/>
+                    </a:solidFill>
+                  </a:tcPr>
+                </a:tc>
+                <a:tc>
+                  <a:txBody>
+                    <a:bodyPr/>
+                    <a:lstStyle/>
+                    <a:p>
+                      <a:pPr algn="r"/>
+                      <a:r>
+                        <a:rPr sz="1000">
+                          <a:solidFill>
+                            <a:srgbClr val="3F3F3F"/>
+                          </a:solidFill>
+                          <a:latin typeface="Encode Sans"/>
+                        </a:rPr>
+                        <a:t>+34.6%</a:t>
+                      </a:r>
+                    </a:p>
+                  </a:txBody>
+                  <a:tcPr marL="36576" marR="36576" marT="18288" marB="18288">
+                    <a:solidFill>
+                      <a:srgbClr val="FFFFFF"/>
+                    </a:solidFill>
+                  </a:tcPr>
+                </a:tc>
+              </a:tr>
+              <a:tr h="292608">
+                <a:tc>
+                  <a:txBody>
+                    <a:bodyPr/>
+                    <a:lstStyle/>
+                    <a:p>
+                      <a:pPr algn="l"/>
+                      <a:r>
+                        <a:rPr sz="1000">
+                          <a:solidFill>
+                            <a:srgbClr val="3F3F3F"/>
+                          </a:solidFill>
+                          <a:latin typeface="Encode Sans"/>
+                        </a:rPr>
+                        <a:t>Abril 2026</a:t>
+                      </a:r>
+                    </a:p>
+                  </a:txBody>
+                  <a:tcPr marL="36576" marR="36576" marT="18288" marB="18288">
+                    <a:solidFill>
+                      <a:srgbClr val="F8F8F6"/>
+                    </a:solidFill>
+                  </a:tcPr>
+                </a:tc>
+                <a:tc>
+                  <a:txBody>
+                    <a:bodyPr/>
+                    <a:lstStyle/>
+                    <a:p>
+                      <a:pPr algn="r"/>
+                      <a:r>
+                        <a:rPr sz="1000">
+                          <a:solidFill>
+                            <a:srgbClr val="3F3F3F"/>
+                          </a:solidFill>
+                          <a:latin typeface="Encode Sans"/>
+                        </a:rPr>
+                        <a:t>+4.79%</a:t>
+                      </a:r>
+                    </a:p>
+                  </a:txBody>
+                  <a:tcPr marL="36576" marR="36576" marT="18288" marB="18288">
+                    <a:solidFill>
+                      <a:srgbClr val="F8F8F6"/>
+                    </a:solidFill>
+                  </a:tcPr>
+                </a:tc>
+                <a:tc>
+                  <a:txBody>
+                    <a:bodyPr/>
+                    <a:lstStyle/>
+                    <a:p>
+                      <a:pPr algn="r"/>
+                      <a:r>
+                        <a:rPr sz="1000">
+                          <a:solidFill>
+                            <a:srgbClr val="3F3F3F"/>
+                          </a:solidFill>
+                          <a:latin typeface="Encode Sans"/>
+                        </a:rPr>
+                        <a:t>+30.9%</a:t>
+                      </a:r>
+                    </a:p>
+                  </a:txBody>
+                  <a:tcPr marL="36576" marR="36576" marT="18288" marB="18288">
+                    <a:solidFill>
+                      <a:srgbClr val="F8F8F6"/>
+                    </a:solidFill>
+                  </a:tcPr>
+                </a:tc>
+              </a:tr>
+              <a:tr h="292608">
+                <a:tc>
+                  <a:txBody>
+                    <a:bodyPr/>
+                    <a:lstStyle/>
+                    <a:p>
+                      <a:pPr algn="l"/>
+                      <a:r>
+                        <a:rPr sz="1000">
+                          <a:solidFill>
+                            <a:srgbClr val="3F3F3F"/>
+                          </a:solidFill>
+                          <a:latin typeface="Encode Sans"/>
+                        </a:rPr>
+                        <a:t>Marzo 2026</a:t>
+                      </a:r>
+                    </a:p>
+                  </a:txBody>
+                  <a:tcPr marL="36576" marR="36576" marT="18288" marB="18288">
+                    <a:solidFill>
+                      <a:srgbClr val="FFFFFF"/>
+                    </a:solidFill>
+                  </a:tcPr>
+                </a:tc>
+                <a:tc>
+                  <a:txBody>
+                    <a:bodyPr/>
+                    <a:lstStyle/>
+                    <a:p>
+                      <a:pPr algn="r"/>
+                      <a:r>
+                        <a:rPr sz="1000">
+                          <a:solidFill>
+                            <a:srgbClr val="3F3F3F"/>
+                          </a:solidFill>
+                          <a:latin typeface="Encode Sans"/>
+                        </a:rPr>
+                        <a:t>+2.95%</a:t>
+                      </a:r>
+                    </a:p>
+                  </a:txBody>
+                  <a:tcPr marL="36576" marR="36576" marT="18288" marB="18288">
+                    <a:solidFill>
+                      <a:srgbClr val="FFFFFF"/>
+                    </a:solidFill>
+                  </a:tcPr>
+                </a:tc>
+                <a:tc>
+                  <a:txBody>
+                    <a:bodyPr/>
+                    <a:lstStyle/>
+                    <a:p>
+                      <a:pPr algn="r"/>
+                      <a:r>
+                        <a:rPr sz="1000">
+                          <a:solidFill>
+                            <a:srgbClr val="3F3F3F"/>
+                          </a:solidFill>
+                          <a:latin typeface="Encode Sans"/>
+                        </a:rPr>
+                        <a:t>+28.1%</a:t>
+                      </a:r>
+                    </a:p>
+                  </a:txBody>
+                  <a:tcPr marL="36576" marR="36576" marT="18288" marB="18288">
+                    <a:solidFill>
+                      <a:srgbClr val="FFFFFF"/>
+                    </a:solidFill>
+                  </a:tcPr>
+                </a:tc>
+              </a:tr>
+              <a:tr h="292608">
+                <a:tc>
+                  <a:txBody>
+                    <a:bodyPr/>
+                    <a:lstStyle/>
+                    <a:p>
+                      <a:pPr algn="l"/>
+                      <a:r>
+                        <a:rPr sz="1000">
+                          <a:solidFill>
+                            <a:srgbClr val="3F3F3F"/>
+                          </a:solidFill>
+                          <a:latin typeface="Encode Sans"/>
+                        </a:rPr>
+                        <a:t>Febrero 2026</a:t>
+                      </a:r>
+                    </a:p>
+                  </a:txBody>
+                  <a:tcPr marL="36576" marR="36576" marT="18288" marB="18288">
+                    <a:solidFill>
+                      <a:srgbClr val="F8F8F6"/>
+                    </a:solidFill>
+                  </a:tcPr>
+                </a:tc>
+                <a:tc>
+                  <a:txBody>
+                    <a:bodyPr/>
+                    <a:lstStyle/>
+                    <a:p>
+                      <a:pPr algn="r"/>
+                      <a:r>
+                        <a:rPr sz="1000">
+                          <a:solidFill>
+                            <a:srgbClr val="3F3F3F"/>
+                          </a:solidFill>
+                          <a:latin typeface="Encode Sans"/>
+                        </a:rPr>
+                        <a:t>+0.69%</a:t>
+                      </a:r>
+                    </a:p>
+                  </a:txBody>
+                  <a:tcPr marL="36576" marR="36576" marT="18288" marB="18288">
+                    <a:solidFill>
+                      <a:srgbClr val="F8F8F6"/>
+                    </a:solidFill>
+                  </a:tcPr>
+                </a:tc>
+                <a:tc>
+                  <a:txBody>
+                    <a:bodyPr/>
+                    <a:lstStyle/>
+                    <a:p>
+                      <a:pPr algn="r"/>
+                      <a:r>
+                        <a:rPr sz="1000">
+                          <a:solidFill>
+                            <a:srgbClr val="3F3F3F"/>
+                          </a:solidFill>
+                          <a:latin typeface="Encode Sans"/>
+                        </a:rPr>
+                        <a:t>+26.0%</a:t>
+                      </a:r>
+                    </a:p>
+                  </a:txBody>
+                  <a:tcPr marL="36576" marR="36576" marT="18288" marB="18288">
+                    <a:solidFill>
+                      <a:srgbClr val="F8F8F6"/>
+                    </a:solidFill>
+                  </a:tcPr>
+                </a:tc>
+              </a:tr>
+              <a:tr h="292608">
+                <a:tc>
+                  <a:txBody>
+                    <a:bodyPr/>
+                    <a:lstStyle/>
+                    <a:p>
+                      <a:pPr algn="l"/>
+                      <a:r>
+                        <a:rPr sz="1000">
+                          <a:solidFill>
+                            <a:srgbClr val="3F3F3F"/>
+                          </a:solidFill>
+                          <a:latin typeface="Encode Sans"/>
+                        </a:rPr>
+                        <a:t>Enero 2026</a:t>
+                      </a:r>
+                    </a:p>
+                  </a:txBody>
+                  <a:tcPr marL="36576" marR="36576" marT="18288" marB="18288">
+                    <a:solidFill>
+                      <a:srgbClr val="FFFFFF"/>
+                    </a:solidFill>
+                  </a:tcPr>
+                </a:tc>
+                <a:tc>
+                  <a:txBody>
+                    <a:bodyPr/>
+                    <a:lstStyle/>
+                    <a:p>
+                      <a:pPr algn="r"/>
+                      <a:r>
+                        <a:rPr sz="1000">
+                          <a:solidFill>
+                            <a:srgbClr val="3F3F3F"/>
+                          </a:solidFill>
+                          <a:latin typeface="Encode Sans"/>
+                        </a:rPr>
+                        <a:t>+1.58%</a:t>
+                      </a:r>
+                    </a:p>
+                  </a:txBody>
+                  <a:tcPr marL="36576" marR="36576" marT="18288" marB="18288">
+                    <a:solidFill>
+                      <a:srgbClr val="FFFFFF"/>
+                    </a:solidFill>
+                  </a:tcPr>
+                </a:tc>
+                <a:tc>
+                  <a:txBody>
+                    <a:bodyPr/>
+                    <a:lstStyle/>
+                    <a:p>
+                      <a:pPr algn="r"/>
+                      <a:r>
+                        <a:rPr sz="1000">
+                          <a:solidFill>
+                            <a:srgbClr val="3F3F3F"/>
+                          </a:solidFill>
+                          <a:latin typeface="Encode Sans"/>
+                        </a:rPr>
+                        <a:t>+27.7%</a:t>
+                      </a:r>
+                    </a:p>
+                  </a:txBody>
+                  <a:tcPr marL="36576" marR="36576" marT="18288" marB="18288">
+                    <a:solidFill>
+                      <a:srgbClr val="FFFFFF"/>
+                    </a:solidFill>
+                  </a:tcPr>
+                </a:tc>
+              </a:tr>
+              <a:tr h="292608">
+                <a:tc>
+                  <a:txBody>
+                    <a:bodyPr/>
+                    <a:lstStyle/>
+                    <a:p>
+                      <a:pPr algn="l"/>
+                      <a:r>
+                        <a:rPr sz="1000">
+                          <a:solidFill>
+                            <a:srgbClr val="3F3F3F"/>
+                          </a:solidFill>
+                          <a:latin typeface="Encode Sans"/>
+                        </a:rPr>
+                        <a:t>Diciembre 2025</a:t>
+                      </a:r>
+                    </a:p>
+                  </a:txBody>
+                  <a:tcPr marL="36576" marR="36576" marT="18288" marB="18288">
+                    <a:solidFill>
+                      <a:srgbClr val="F8F8F6"/>
+                    </a:solidFill>
+                  </a:tcPr>
+                </a:tc>
+                <a:tc>
+                  <a:txBody>
+                    <a:bodyPr/>
+                    <a:lstStyle/>
+                    <a:p>
+                      <a:pPr algn="r"/>
+                      <a:r>
+                        <a:rPr sz="1000">
+                          <a:solidFill>
+                            <a:srgbClr val="3F3F3F"/>
+                          </a:solidFill>
+                          <a:latin typeface="Encode Sans"/>
+                        </a:rPr>
+                        <a:t>+2.43%</a:t>
+                      </a:r>
+                    </a:p>
+                  </a:txBody>
+                  <a:tcPr marL="36576" marR="36576" marT="18288" marB="18288">
+                    <a:solidFill>
+                      <a:srgbClr val="F8F8F6"/>
+                    </a:solidFill>
+                  </a:tcPr>
+                </a:tc>
+                <a:tc>
+                  <a:txBody>
+                    <a:bodyPr/>
+                    <a:lstStyle/>
+                    <a:p>
+                      <a:pPr algn="r"/>
+                      <a:r>
+                        <a:rPr sz="1000">
+                          <a:solidFill>
+                            <a:srgbClr val="3F3F3F"/>
+                          </a:solidFill>
+                          <a:latin typeface="Encode Sans"/>
+                        </a:rPr>
+                        <a:t>+28.0%</a:t>
+                      </a:r>
+                    </a:p>
+                  </a:txBody>
+                  <a:tcPr marL="36576" marR="36576" marT="18288" marB="18288">
+                    <a:solidFill>
+                      <a:srgbClr val="F8F8F6"/>
+                    </a:solidFill>
+                  </a:tcPr>
+                </a:tc>
+              </a:tr>
+            </a:tbl>
+          </a:graphicData>
+        </a:graphic>
+      </p:graphicFrame>
+      <p:sp>
+        <p:nvSpPr>
+          <p:cNvPr id="9" name="TextBox 8"/>
+          <p:cNvSpPr txBox="1"/>
+          <p:nvPr/>
+        </p:nvSpPr>
+        <p:spPr>
+          <a:xfrm>
+            <a:off x="411480" y="6492240"/>
+            <a:ext cx="11368735" cy="274320"/>
+          </a:xfrm>
+          <a:prstGeom prst="rect">
+            <a:avLst/>
+          </a:prstGeom>
+          <a:noFill/>
+        </p:spPr>
+        <p:txBody>
+          <a:bodyPr wrap="none">
+            <a:spAutoFit/>
+          </a:bodyPr>
+          <a:lstStyle/>
+          <a:p>
+            <a:r>
+              <a:rPr sz="1000" b="0" i="1">
+                <a:solidFill>
+                  <a:srgbClr val="6A6760"/>
+                </a:solidFill>
+                <a:latin typeface="Encode Sans"/>
+              </a:rPr>
+              <a:t>Fuente: elaboración propia en base a INDEC</a:t>
+            </a:r>
+          </a:p>
+        </p:txBody>
+      </p:sp>
+    </p:spTree>
+  </p:cSld>
+  <p:clrMapOvr>
+    <a:masterClrMapping/>
+  </p:clrMapOvr>
+</p:sld>
+</file>
+
+<file path=ppt/slides/slide9.xml><?xml version="1.0" encoding="utf-8"?>
+<p:sld xmlns:a="http://schemas.openxmlformats.org/drawingml/2006/main" xmlns:p="http://schemas.openxmlformats.org/presentationml/2006/main" xmlns:r="http://schemas.openxmlformats.org/officeDocument/2006/relationships">
+  <p:cSld>
+    <p:spTree>
+      <p:nvGrpSpPr>
+        <p:cNvPr id="1" name=""/>
+        <p:cNvGrpSpPr/>
+        <p:nvPr/>
+      </p:nvGrpSpPr>
+      <p:grpSpPr/>
+      <p:sp>
+        <p:nvSpPr>
+          <p:cNvPr id="2" name="Rectangle 1"/>
+          <p:cNvSpPr/>
+          <p:nvPr/>
+        </p:nvSpPr>
+        <p:spPr>
+          <a:xfrm>
+            <a:off x="0" y="0"/>
+            <a:ext cx="12191695" cy="274320"/>
+          </a:xfrm>
+          <a:prstGeom prst="rect">
+            <a:avLst/>
+          </a:prstGeom>
+          <a:solidFill>
+            <a:srgbClr val="00B2C9"/>
+          </a:solidFill>
+          <a:ln>
+            <a:noFill/>
+          </a:ln>
+        </p:spPr>
+        <p:style>
+          <a:lnRef idx="1">
+            <a:schemeClr val="accent1"/>
+          </a:lnRef>
+          <a:fillRef idx="3">
+            <a:schemeClr val="accent1"/>
+          </a:fillRef>
+          <a:effectRef idx="2">
+            <a:schemeClr val="accent1"/>
+          </a:effectRef>
+          <a:fontRef idx="minor">
+            <a:schemeClr val="lt1"/>
+          </a:fontRef>
+        </p:style>
+        <p:txBody>
+          <a:bodyPr rtlCol="0" anchor="ctr"/>
+          <a:lstStyle/>
+          <a:p>
+            <a:pPr algn="ctr"/>
+          </a:p>
+        </p:txBody>
+      </p:sp>
+      <p:sp>
+        <p:nvSpPr>
+          <p:cNvPr id="3" name="TextBox 2"/>
+          <p:cNvSpPr txBox="1"/>
+          <p:nvPr/>
+        </p:nvSpPr>
+        <p:spPr>
+          <a:xfrm>
+            <a:off x="411480" y="457200"/>
+            <a:ext cx="11368735" cy="914400"/>
+          </a:xfrm>
+          <a:prstGeom prst="rect">
+            <a:avLst/>
+          </a:prstGeom>
+          <a:noFill/>
+        </p:spPr>
+        <p:txBody>
+          <a:bodyPr wrap="square" lIns="0" rIns="0">
+            <a:spAutoFit/>
+          </a:bodyPr>
+          <a:lstStyle/>
+          <a:p>
+            <a:pPr algn="l"/>
+            <a:r>
+              <a:rPr sz="2600" b="1" i="0">
+                <a:solidFill>
+                  <a:srgbClr val="00B2C9"/>
+                </a:solidFill>
+                <a:latin typeface="Encode Sans"/>
+              </a:rPr>
+              <a:t>BALANZA COMERCIAL MAYO 2026: SUPERÁVIT USD 3.504M</a:t>
+            </a:r>
+          </a:p>
+        </p:txBody>
+      </p:sp>
+      <p:sp>
+        <p:nvSpPr>
+          <p:cNvPr id="4" name="TextBox 3"/>
+          <p:cNvSpPr txBox="1"/>
+          <p:nvPr/>
+        </p:nvSpPr>
+        <p:spPr>
+          <a:xfrm>
+            <a:off x="411480" y="1280160"/>
+            <a:ext cx="11368735" cy="274320"/>
+          </a:xfrm>
+          <a:prstGeom prst="rect">
+            <a:avLst/>
+          </a:prstGeom>
+          <a:noFill/>
+        </p:spPr>
+        <p:txBody>
+          <a:bodyPr wrap="none">
+            <a:spAutoFit/>
+          </a:bodyPr>
+          <a:lstStyle/>
+          <a:p>
+            <a:r>
+              <a:rPr sz="1100" b="0" i="1">
+                <a:solidFill>
+                  <a:srgbClr val="6A6760"/>
+                </a:solidFill>
+                <a:latin typeface="Encode Sans"/>
+              </a:rPr>
+              <a:t>INDEC · período 2026-05</a:t>
+            </a:r>
+          </a:p>
+        </p:txBody>
+      </p:sp>
+      <p:sp>
+        <p:nvSpPr>
+          <p:cNvPr id="5" name="TextBox 4"/>
+          <p:cNvSpPr txBox="1"/>
+          <p:nvPr/>
+        </p:nvSpPr>
+        <p:spPr>
+          <a:xfrm>
+            <a:off x="411480" y="1691640"/>
+            <a:ext cx="5486400" cy="1645920"/>
+          </a:xfrm>
+          <a:prstGeom prst="rect">
+            <a:avLst/>
+          </a:prstGeom>
+          <a:noFill/>
+        </p:spPr>
+        <p:txBody>
+          <a:bodyPr wrap="square" lIns="0" rIns="0">
+            <a:spAutoFit/>
+          </a:bodyPr>
+          <a:lstStyle/>
+          <a:p>
+            <a:pPr algn="just"/>
+            <a:r>
+              <a:rPr sz="1300" b="0" i="0">
+                <a:solidFill>
+                  <a:srgbClr val="3F3F3F"/>
+                </a:solidFill>
+                <a:latin typeface="Encode Sans"/>
+              </a:rPr>
+              <a:t>El intercambio comercial argentino en mayo 2026 arrojó un superávit de USD 3.504 millones. Exportaciones: USD 9.537 M (+34.4% i.a.). Importaciones: USD 6.033 M (-7.0% i.a.).</a:t>
+            </a:r>
+          </a:p>
+        </p:txBody>
+      </p:sp>
+      <p:sp>
+        <p:nvSpPr>
+          <p:cNvPr id="6" name="TextBox 5"/>
+          <p:cNvSpPr txBox="1"/>
+          <p:nvPr/>
+        </p:nvSpPr>
+        <p:spPr>
+          <a:xfrm>
+            <a:off x="411480" y="3520440"/>
+            <a:ext cx="5486400" cy="2743200"/>
+          </a:xfrm>
+          <a:prstGeom prst="rect">
+            <a:avLst/>
+          </a:prstGeom>
+          <a:noFill/>
+        </p:spPr>
+        <p:txBody>
+          <a:bodyPr wrap="square" lIns="0" rIns="0">
+            <a:spAutoFit/>
+          </a:bodyPr>
+          <a:lstStyle/>
+          <a:p>
+            <a:pPr algn="l">
+              <a:spcAft>
+                <a:spcPts val="800"/>
+              </a:spcAft>
+            </a:pPr>
+            <a:r>
+              <a:rPr sz="1300" b="1" i="0">
+                <a:solidFill>
+                  <a:srgbClr val="00B2C9"/>
+                </a:solidFill>
+                <a:latin typeface="Encode Sans"/>
+              </a:rPr>
+              <a:t>●  </a:t>
+            </a:r>
+            <a:r>
+              <a:rPr sz="1300" b="0" i="0">
+                <a:solidFill>
+                  <a:srgbClr val="3F3F3F"/>
+                </a:solidFill>
+                <a:latin typeface="Encode Sans"/>
+              </a:rPr>
+              <a:t>Exportaciones: USD 9.537 millones (+34.4% i.a.)</a:t>
+            </a:r>
+          </a:p>
+          <a:p>
+            <a:pPr algn="l">
+              <a:spcAft>
+                <a:spcPts val="800"/>
+              </a:spcAft>
+            </a:pPr>
+            <a:r>
+              <a:rPr sz="1300" b="1" i="0">
+                <a:solidFill>
+                  <a:srgbClr val="00B2C9"/>
+                </a:solidFill>
+                <a:latin typeface="Encode Sans"/>
+              </a:rPr>
+              <a:t>●  </a:t>
+            </a:r>
+            <a:r>
+              <a:rPr sz="1300" b="0" i="0">
+                <a:solidFill>
+                  <a:srgbClr val="3F3F3F"/>
+                </a:solidFill>
+                <a:latin typeface="Encode Sans"/>
+              </a:rPr>
+              <a:t>Importaciones: USD 6.033 millones (-7.0% i.a.)</a:t>
+            </a:r>
+          </a:p>
+          <a:p>
+            <a:pPr algn="l">
+              <a:spcAft>
+                <a:spcPts val="800"/>
+              </a:spcAft>
+            </a:pPr>
+            <a:r>
+              <a:rPr sz="1300" b="1" i="0">
+                <a:solidFill>
+                  <a:srgbClr val="00B2C9"/>
+                </a:solidFill>
+                <a:latin typeface="Encode Sans"/>
+              </a:rPr>
+              <a:t>●  </a:t>
+            </a:r>
+            <a:r>
+              <a:rPr sz="1300" b="0" i="0">
+                <a:solidFill>
+                  <a:srgbClr val="3F3F3F"/>
+                </a:solidFill>
+                <a:latin typeface="Encode Sans"/>
+              </a:rPr>
+              <a:t>Saldo comercial: USD +3.504 M</a:t>
+            </a:r>
+          </a:p>
+        </p:txBody>
+      </p:sp>
+      <p:pic>
+        <p:nvPicPr>
+          <p:cNvPr id="7" name="Picture 6" descr="image.png"/>
+          <p:cNvPicPr>
+            <a:picLocks noChangeAspect="1"/>
+          </p:cNvPicPr>
+          <p:nvPr/>
+        </p:nvPicPr>
+        <p:blipFill>
+          <a:blip r:embed="rId2"/>
+          <a:stretch>
+            <a:fillRect/>
+          </a:stretch>
+        </p:blipFill>
+        <p:spPr>
+          <a:xfrm>
+            <a:off x="6080760" y="1691640"/>
+            <a:ext cx="5669280" cy="2560320"/>
+          </a:xfrm>
+          <a:prstGeom prst="rect">
+            <a:avLst/>
+          </a:prstGeom>
+        </p:spPr>
+      </p:pic>
+      <p:graphicFrame>
+        <p:nvGraphicFramePr>
+          <p:cNvPr id="8" name="Table 7"/>
+          <p:cNvGraphicFramePr>
+            <a:graphicFrameLocks noGrp="1"/>
+          </p:cNvGraphicFramePr>
+          <p:nvPr/>
+        </p:nvGraphicFramePr>
+        <p:xfrm>
+          <a:off x="6080760" y="4434840"/>
+          <a:ext cx="5669280" cy="2048256"/>
+        </p:xfrm>
+        <a:graphic>
+          <a:graphicData uri="http://schemas.openxmlformats.org/drawingml/2006/table">
+            <a:tbl>
+              <a:tblPr firstRow="1" bandRow="1">
+                <a:tableStyleId>{5C22544A-7EE6-4342-B048-85BDC9FD1C3A}</a:tableStyleId>
+              </a:tblPr>
+              <a:tblGrid>
+                <a:gridCol w="1417320"/>
+                <a:gridCol w="1417320"/>
+                <a:gridCol w="1417320"/>
+                <a:gridCol w="1417320"/>
+              </a:tblGrid>
+              <a:tr h="292608">
+                <a:tc>
+                  <a:txBody>
+                    <a:bodyPr/>
+                    <a:lstStyle/>
+                    <a:p>
+                      <a:pPr algn="l"/>
+                      <a:r>
+                        <a:rPr sz="1000" b="1">
+                          <a:solidFill>
+                            <a:srgbClr val="FFFFFF"/>
+                          </a:solidFill>
+                          <a:latin typeface="Encode Sans"/>
+                        </a:rPr>
+                        <a:t>Mes</a:t>
+                      </a:r>
+                    </a:p>
+                  </a:txBody>
+                  <a:tcPr marL="36576" marR="36576" marT="18288" marB="18288">
+                    <a:solidFill>
+                      <a:srgbClr val="00B2C9"/>
+                    </a:solidFill>
+                  </a:tcPr>
+                </a:tc>
+                <a:tc>
+                  <a:txBody>
+                    <a:bodyPr/>
+                    <a:lstStyle/>
+                    <a:p>
+                      <a:pPr algn="r"/>
+                      <a:r>
+                        <a:rPr sz="1000" b="1">
+                          <a:solidFill>
+                            <a:srgbClr val="FFFFFF"/>
+                          </a:solidFill>
+                          <a:latin typeface="Encode Sans"/>
+                        </a:rPr>
+                        <a:t>Expo USD M</a:t>
+                      </a:r>
+                    </a:p>
+                  </a:txBody>
+                  <a:tcPr marL="36576" marR="36576" marT="18288" marB="18288">
+                    <a:solidFill>
+                      <a:srgbClr val="00B2C9"/>
+                    </a:solidFill>
+                  </a:tcPr>
+                </a:tc>
+                <a:tc>
+                  <a:txBody>
+                    <a:bodyPr/>
+                    <a:lstStyle/>
+                    <a:p>
+                      <a:pPr algn="r"/>
+                      <a:r>
+                        <a:rPr sz="1000" b="1">
+                          <a:solidFill>
+                            <a:srgbClr val="FFFFFF"/>
+                          </a:solidFill>
+                          <a:latin typeface="Encode Sans"/>
+                        </a:rPr>
+                        <a:t>Impo USD M</a:t>
+                      </a:r>
+                    </a:p>
+                  </a:txBody>
+                  <a:tcPr marL="36576" marR="36576" marT="18288" marB="18288">
+                    <a:solidFill>
+                      <a:srgbClr val="00B2C9"/>
+                    </a:solidFill>
+                  </a:tcPr>
+                </a:tc>
+                <a:tc>
+                  <a:txBody>
+                    <a:bodyPr/>
+                    <a:lstStyle/>
+                    <a:p>
+                      <a:pPr algn="r"/>
+                      <a:r>
+                        <a:rPr sz="1000" b="1">
+                          <a:solidFill>
+                            <a:srgbClr val="FFFFFF"/>
+                          </a:solidFill>
+                          <a:latin typeface="Encode Sans"/>
+                        </a:rPr>
+                        <a:t>Saldo USD M</a:t>
+                      </a:r>
+                    </a:p>
+                  </a:txBody>
+                  <a:tcPr marL="36576" marR="36576" marT="18288" marB="18288">
+                    <a:solidFill>
+                      <a:srgbClr val="00B2C9"/>
+                    </a:solidFill>
+                  </a:tcPr>
+                </a:tc>
+              </a:tr>
+              <a:tr h="292608">
+                <a:tc>
+                  <a:txBody>
+                    <a:bodyPr/>
+                    <a:lstStyle/>
+                    <a:p>
+                      <a:pPr algn="l"/>
+                      <a:r>
+                        <a:rPr sz="1000">
+                          <a:solidFill>
+                            <a:srgbClr val="3F3F3F"/>
+                          </a:solidFill>
+                          <a:latin typeface="Encode Sans"/>
+                        </a:rPr>
+                        <a:t>Mayo 2026</a:t>
+                      </a:r>
+                    </a:p>
+                  </a:txBody>
+                  <a:tcPr marL="36576" marR="36576" marT="18288" marB="18288">
+                    <a:solidFill>
+                      <a:srgbClr val="FFFFFF"/>
+                    </a:solidFill>
+                  </a:tcPr>
+                </a:tc>
+                <a:tc>
+                  <a:txBody>
+                    <a:bodyPr/>
+                    <a:lstStyle/>
+                    <a:p>
+                      <a:pPr algn="r"/>
+                      <a:r>
+                        <a:rPr sz="1000">
+                          <a:solidFill>
+                            <a:srgbClr val="3F3F3F"/>
+                          </a:solidFill>
+                          <a:latin typeface="Encode Sans"/>
+                        </a:rPr>
+                        <a:t>9.537</a:t>
+                      </a:r>
+                    </a:p>
+                  </a:txBody>
+                  <a:tcPr marL="36576" marR="36576" marT="18288" marB="18288">
+                    <a:solidFill>
+                      <a:srgbClr val="FFFFFF"/>
+                    </a:solidFill>
+                  </a:tcPr>
+                </a:tc>
+                <a:tc>
+                  <a:txBody>
+                    <a:bodyPr/>
+                    <a:lstStyle/>
+                    <a:p>
+                      <a:pPr algn="r"/>
+                      <a:r>
+                        <a:rPr sz="1000">
+                          <a:solidFill>
+                            <a:srgbClr val="3F3F3F"/>
+                          </a:solidFill>
+                          <a:latin typeface="Encode Sans"/>
+                        </a:rPr>
+                        <a:t>6.033</a:t>
+                      </a:r>
+                    </a:p>
+                  </a:txBody>
+                  <a:tcPr marL="36576" marR="36576" marT="18288" marB="18288">
+                    <a:solidFill>
+                      <a:srgbClr val="FFFFFF"/>
+                    </a:solidFill>
+                  </a:tcPr>
+                </a:tc>
+                <a:tc>
+                  <a:txBody>
+                    <a:bodyPr/>
+                    <a:lstStyle/>
+                    <a:p>
+                      <a:pPr algn="r"/>
+                      <a:r>
+                        <a:rPr sz="1000">
+                          <a:solidFill>
+                            <a:srgbClr val="3F3F3F"/>
+                          </a:solidFill>
+                          <a:latin typeface="Encode Sans"/>
+                        </a:rPr>
+                        <a:t>3.504</a:t>
+                      </a:r>
+                    </a:p>
+                  </a:txBody>
+                  <a:tcPr marL="36576" marR="36576" marT="18288" marB="18288">
+                    <a:solidFill>
+                      <a:srgbClr val="FFFFFF"/>
+                    </a:solidFill>
+                  </a:tcPr>
+                </a:tc>
+              </a:tr>
+              <a:tr h="292608">
+                <a:tc>
+                  <a:txBody>
+                    <a:bodyPr/>
+                    <a:lstStyle/>
+                    <a:p>
+                      <a:pPr algn="l"/>
+                      <a:r>
+                        <a:rPr sz="1000">
+                          <a:solidFill>
+                            <a:srgbClr val="3F3F3F"/>
+                          </a:solidFill>
+                          <a:latin typeface="Encode Sans"/>
+                        </a:rPr>
+                        <a:t>Abril 2026</a:t>
+                      </a:r>
+                    </a:p>
+                  </a:txBody>
+                  <a:tcPr marL="36576" marR="36576" marT="18288" marB="18288">
+                    <a:solidFill>
+                      <a:srgbClr val="F8F8F6"/>
+                    </a:solidFill>
+                  </a:tcPr>
+                </a:tc>
+                <a:tc>
+                  <a:txBody>
+                    <a:bodyPr/>
+                    <a:lstStyle/>
+                    <a:p>
+                      <a:pPr algn="r"/>
+                      <a:r>
+                        <a:rPr sz="1000">
+                          <a:solidFill>
+                            <a:srgbClr val="3F3F3F"/>
+                          </a:solidFill>
+                          <a:latin typeface="Encode Sans"/>
+                        </a:rPr>
+                        <a:t>8.916</a:t>
+                      </a:r>
+                    </a:p>
+                  </a:txBody>
+                  <a:tcPr marL="36576" marR="36576" marT="18288" marB="18288">
+                    <a:solidFill>
+                      <a:srgbClr val="F8F8F6"/>
+                    </a:solidFill>
+                  </a:tcPr>
+                </a:tc>
+                <a:tc>
+                  <a:txBody>
+                    <a:bodyPr/>
+                    <a:lstStyle/>
+                    <a:p>
+                      <a:pPr algn="r"/>
+                      <a:r>
+                        <a:rPr sz="1000">
+                          <a:solidFill>
+                            <a:srgbClr val="3F3F3F"/>
+                          </a:solidFill>
+                          <a:latin typeface="Encode Sans"/>
+                        </a:rPr>
+                        <a:t>6.203</a:t>
+                      </a:r>
+                    </a:p>
+                  </a:txBody>
+                  <a:tcPr marL="36576" marR="36576" marT="18288" marB="18288">
+                    <a:solidFill>
+                      <a:srgbClr val="F8F8F6"/>
+                    </a:solidFill>
+                  </a:tcPr>
+                </a:tc>
+                <a:tc>
+                  <a:txBody>
+                    <a:bodyPr/>
+                    <a:lstStyle/>
+                    <a:p>
+                      <a:pPr algn="r"/>
+                      <a:r>
+                        <a:rPr sz="1000">
+                          <a:solidFill>
+                            <a:srgbClr val="3F3F3F"/>
+                          </a:solidFill>
+                          <a:latin typeface="Encode Sans"/>
+                        </a:rPr>
+                        <a:t>2.713</a:t>
+                      </a:r>
+                    </a:p>
+                  </a:txBody>
+                  <a:tcPr marL="36576" marR="36576" marT="18288" marB="18288">
+                    <a:solidFill>
+                      <a:srgbClr val="F8F8F6"/>
+                    </a:solidFill>
+                  </a:tcPr>
+                </a:tc>
+              </a:tr>
+              <a:tr h="292608">
+                <a:tc>
+                  <a:txBody>
+                    <a:bodyPr/>
+                    <a:lstStyle/>
+                    <a:p>
+                      <a:pPr algn="l"/>
+                      <a:r>
+                        <a:rPr sz="1000">
+                          <a:solidFill>
+                            <a:srgbClr val="3F3F3F"/>
+                          </a:solidFill>
+                          <a:latin typeface="Encode Sans"/>
+                        </a:rPr>
+                        <a:t>Marzo 2026</a:t>
+                      </a:r>
+                    </a:p>
+                  </a:txBody>
+                  <a:tcPr marL="36576" marR="36576" marT="18288" marB="18288">
+                    <a:solidFill>
+                      <a:srgbClr val="FFFFFF"/>
+                    </a:solidFill>
+                  </a:tcPr>
+                </a:tc>
+                <a:tc>
+                  <a:txBody>
+                    <a:bodyPr/>
+                    <a:lstStyle/>
+                    <a:p>
+                      <a:pPr algn="r"/>
+                      <a:r>
+                        <a:rPr sz="1000">
+                          <a:solidFill>
+                            <a:srgbClr val="3F3F3F"/>
+                          </a:solidFill>
+                          <a:latin typeface="Encode Sans"/>
+                        </a:rPr>
+                        <a:t>8.697</a:t>
+                      </a:r>
+                    </a:p>
+                  </a:txBody>
+                  <a:tcPr marL="36576" marR="36576" marT="18288" marB="18288">
+                    <a:solidFill>
+                      <a:srgbClr val="FFFFFF"/>
+                    </a:solidFill>
+                  </a:tcPr>
+                </a:tc>
+                <a:tc>
+                  <a:txBody>
+                    <a:bodyPr/>
+                    <a:lstStyle/>
+                    <a:p>
+                      <a:pPr algn="r"/>
+                      <a:r>
+                        <a:rPr sz="1000">
+                          <a:solidFill>
+                            <a:srgbClr val="3F3F3F"/>
+                          </a:solidFill>
+                          <a:latin typeface="Encode Sans"/>
+                        </a:rPr>
+                        <a:t>6.116</a:t>
+                      </a:r>
+                    </a:p>
+                  </a:txBody>
+                  <a:tcPr marL="36576" marR="36576" marT="18288" marB="18288">
+                    <a:solidFill>
+                      <a:srgbClr val="FFFFFF"/>
+                    </a:solidFill>
+                  </a:tcPr>
+                </a:tc>
+                <a:tc>
+                  <a:txBody>
+                    <a:bodyPr/>
+                    <a:lstStyle/>
+                    <a:p>
+                      <a:pPr algn="r"/>
+                      <a:r>
+                        <a:rPr sz="1000">
+                          <a:solidFill>
+                            <a:srgbClr val="3F3F3F"/>
+                          </a:solidFill>
+                          <a:latin typeface="Encode Sans"/>
+                        </a:rPr>
+                        <a:t>2.581</a:t>
+                      </a:r>
+                    </a:p>
+                  </a:txBody>
+                  <a:tcPr marL="36576" marR="36576" marT="18288" marB="18288">
+                    <a:solidFill>
+                      <a:srgbClr val="FFFFFF"/>
+                    </a:solidFill>
+                  </a:tcPr>
+                </a:tc>
+              </a:tr>
+              <a:tr h="292608">
+                <a:tc>
+                  <a:txBody>
+                    <a:bodyPr/>
+                    <a:lstStyle/>
+                    <a:p>
+                      <a:pPr algn="l"/>
+                      <a:r>
+                        <a:rPr sz="1000">
+                          <a:solidFill>
+                            <a:srgbClr val="3F3F3F"/>
+                          </a:solidFill>
+                          <a:latin typeface="Encode Sans"/>
+                        </a:rPr>
+                        <a:t>Febrero 2026</a:t>
+                      </a:r>
+                    </a:p>
+                  </a:txBody>
+                  <a:tcPr marL="36576" marR="36576" marT="18288" marB="18288">
+                    <a:solidFill>
+                      <a:srgbClr val="F8F8F6"/>
+                    </a:solidFill>
+                  </a:tcPr>
+                </a:tc>
+                <a:tc>
+                  <a:txBody>
+                    <a:bodyPr/>
+                    <a:lstStyle/>
+                    <a:p>
+                      <a:pPr algn="r"/>
+                      <a:r>
+                        <a:rPr sz="1000">
+                          <a:solidFill>
+                            <a:srgbClr val="3F3F3F"/>
+                          </a:solidFill>
+                          <a:latin typeface="Encode Sans"/>
+                        </a:rPr>
+                        <a:t>5.963</a:t>
+                      </a:r>
+                    </a:p>
+                  </a:txBody>
+                  <a:tcPr marL="36576" marR="36576" marT="18288" marB="18288">
+                    <a:solidFill>
+                      <a:srgbClr val="F8F8F6"/>
+                    </a:solidFill>
+                  </a:tcPr>
+                </a:tc>
+                <a:tc>
+                  <a:txBody>
+                    <a:bodyPr/>
+                    <a:lstStyle/>
+                    <a:p>
+                      <a:pPr algn="r"/>
+                      <a:r>
+                        <a:rPr sz="1000">
+                          <a:solidFill>
+                            <a:srgbClr val="3F3F3F"/>
+                          </a:solidFill>
+                          <a:latin typeface="Encode Sans"/>
+                        </a:rPr>
+                        <a:t>5.167</a:t>
+                      </a:r>
+                    </a:p>
+                  </a:txBody>
+                  <a:tcPr marL="36576" marR="36576" marT="18288" marB="18288">
+                    <a:solidFill>
+                      <a:srgbClr val="F8F8F6"/>
+                    </a:solidFill>
+                  </a:tcPr>
+                </a:tc>
+                <a:tc>
+                  <a:txBody>
+                    <a:bodyPr/>
+                    <a:lstStyle/>
+                    <a:p>
+                      <a:pPr algn="r"/>
+                      <a:r>
+                        <a:rPr sz="1000">
+                          <a:solidFill>
+                            <a:srgbClr val="3F3F3F"/>
+                          </a:solidFill>
+                          <a:latin typeface="Encode Sans"/>
+                        </a:rPr>
+                        <a:t>797</a:t>
+                      </a:r>
+                    </a:p>
+                  </a:txBody>
+                  <a:tcPr marL="36576" marR="36576" marT="18288" marB="18288">
+                    <a:solidFill>
+                      <a:srgbClr val="F8F8F6"/>
+                    </a:solidFill>
+                  </a:tcPr>
+                </a:tc>
+              </a:tr>
+              <a:tr h="292608">
+                <a:tc>
+                  <a:txBody>
+                    <a:bodyPr/>
+                    <a:lstStyle/>
+                    <a:p>
+                      <a:pPr algn="l"/>
+                      <a:r>
+                        <a:rPr sz="1000">
+                          <a:solidFill>
+                            <a:srgbClr val="3F3F3F"/>
+                          </a:solidFill>
+                          <a:latin typeface="Encode Sans"/>
+                        </a:rPr>
+                        <a:t>Enero 2026</a:t>
+                      </a:r>
+                    </a:p>
+                  </a:txBody>
+                  <a:tcPr marL="36576" marR="36576" marT="18288" marB="18288">
+                    <a:solidFill>
+                      <a:srgbClr val="FFFFFF"/>
+                    </a:solidFill>
+                  </a:tcPr>
+                </a:tc>
+                <a:tc>
+                  <a:txBody>
+                    <a:bodyPr/>
+                    <a:lstStyle/>
+                    <a:p>
+                      <a:pPr algn="r"/>
+                      <a:r>
+                        <a:rPr sz="1000">
+                          <a:solidFill>
+                            <a:srgbClr val="3F3F3F"/>
+                          </a:solidFill>
+                          <a:latin typeface="Encode Sans"/>
+                        </a:rPr>
+                        <a:t>7.245</a:t>
+                      </a:r>
+                    </a:p>
+                  </a:txBody>
+                  <a:tcPr marL="36576" marR="36576" marT="18288" marB="18288">
+                    <a:solidFill>
+                      <a:srgbClr val="FFFFFF"/>
+                    </a:solidFill>
+                  </a:tcPr>
+                </a:tc>
+                <a:tc>
+                  <a:txBody>
+                    <a:bodyPr/>
+                    <a:lstStyle/>
+                    <a:p>
+                      <a:pPr algn="r"/>
+                      <a:r>
+                        <a:rPr sz="1000">
+                          <a:solidFill>
+                            <a:srgbClr val="3F3F3F"/>
+                          </a:solidFill>
+                          <a:latin typeface="Encode Sans"/>
+                        </a:rPr>
+                        <a:t>5.057</a:t>
+                      </a:r>
+                    </a:p>
+                  </a:txBody>
+                  <a:tcPr marL="36576" marR="36576" marT="18288" marB="18288">
+                    <a:solidFill>
+                      <a:srgbClr val="FFFFFF"/>
+                    </a:solidFill>
+                  </a:tcPr>
+                </a:tc>
+                <a:tc>
+                  <a:txBody>
+                    <a:bodyPr/>
+                    <a:lstStyle/>
+                    <a:p>
+                      <a:pPr algn="r"/>
+                      <a:r>
+                        <a:rPr sz="1000">
+                          <a:solidFill>
+                            <a:srgbClr val="3F3F3F"/>
+                          </a:solidFill>
+                          <a:latin typeface="Encode Sans"/>
+                        </a:rPr>
+                        <a:t>2.189</a:t>
+                      </a:r>
+                    </a:p>
+                  </a:txBody>
+                  <a:tcPr marL="36576" marR="36576" marT="18288" marB="18288">
+                    <a:solidFill>
+                      <a:srgbClr val="FFFFFF"/>
+                    </a:solidFill>
+                  </a:tcPr>
+                </a:tc>
+              </a:tr>
+              <a:tr h="292608">
+                <a:tc>
+                  <a:txBody>
+                    <a:bodyPr/>
+                    <a:lstStyle/>
+                    <a:p>
+                      <a:pPr algn="l"/>
+                      <a:r>
+                        <a:rPr sz="1000">
+                          <a:solidFill>
+                            <a:srgbClr val="3F3F3F"/>
+                          </a:solidFill>
+                          <a:latin typeface="Encode Sans"/>
+                        </a:rPr>
+                        <a:t>Diciembre 2025</a:t>
+                      </a:r>
+                    </a:p>
+                  </a:txBody>
+                  <a:tcPr marL="36576" marR="36576" marT="18288" marB="18288">
+                    <a:solidFill>
+                      <a:srgbClr val="F8F8F6"/>
+                    </a:solidFill>
+                  </a:tcPr>
+                </a:tc>
+                <a:tc>
+                  <a:txBody>
+                    <a:bodyPr/>
+                    <a:lstStyle/>
+                    <a:p>
+                      <a:pPr algn="r"/>
+                      <a:r>
+                        <a:rPr sz="1000">
+                          <a:solidFill>
+                            <a:srgbClr val="3F3F3F"/>
+                          </a:solidFill>
+                          <a:latin typeface="Encode Sans"/>
+                        </a:rPr>
+                        <a:t>7.482</a:t>
+                      </a:r>
+                    </a:p>
+                  </a:txBody>
+                  <a:tcPr marL="36576" marR="36576" marT="18288" marB="18288">
+                    <a:solidFill>
+                      <a:srgbClr val="F8F8F6"/>
+                    </a:solidFill>
+                  </a:tcPr>
+                </a:tc>
+                <a:tc>
+                  <a:txBody>
+                    <a:bodyPr/>
+                    <a:lstStyle/>
+                    <a:p>
+                      <a:pPr algn="r"/>
+                      <a:r>
+                        <a:rPr sz="1000">
+                          <a:solidFill>
+                            <a:srgbClr val="3F3F3F"/>
+                          </a:solidFill>
+                          <a:latin typeface="Encode Sans"/>
+                        </a:rPr>
+                        <a:t>5.556</a:t>
+                      </a:r>
+                    </a:p>
+                  </a:txBody>
+                  <a:tcPr marL="36576" marR="36576" marT="18288" marB="18288">
+                    <a:solidFill>
+                      <a:srgbClr val="F8F8F6"/>
+                    </a:solidFill>
+                  </a:tcPr>
+                </a:tc>
+                <a:tc>
+                  <a:txBody>
+                    <a:bodyPr/>
+                    <a:lstStyle/>
+                    <a:p>
+                      <a:pPr algn="r"/>
+                      <a:r>
+                        <a:rPr sz="1000">
+                          <a:solidFill>
+                            <a:srgbClr val="3F3F3F"/>
+                          </a:solidFill>
+                          <a:latin typeface="Encode Sans"/>
+                        </a:rPr>
+                        <a:t>1.926</a:t>
                       </a:r>
                     </a:p>
                   </a:txBody>

</xml_diff>

<commit_message>
data: regenerar con PBI/EPH/pobreza + PPTX semana
</commit_message>
<xml_diff>
--- a/publicaciones_semana.pptx
+++ b/publicaciones_semana.pptx
@@ -8,6 +8,7 @@
     <p:sldId id="256" r:id="rId7"/>
     <p:sldId id="257" r:id="rId8"/>
     <p:sldId id="258" r:id="rId9"/>
+    <p:sldId id="259" r:id="rId10"/>
   </p:sldIdLst>
   <p:sldSz cx="12191695" cy="6858000" type="screen4x3"/>
   <p:notesSz cx="6858000" cy="9144000"/>
@@ -3273,7 +3274,7 @@
                 </a:solidFill>
                 <a:latin typeface="Encode Sans"/>
               </a:rPr>
-              <a:t>2 publicaciones · datos oficiales INDEC / BCRA / Hacienda</a:t>
+              <a:t>3 publicaciones · datos oficiales INDEC / BCRA / Hacienda</a:t>
             </a:r>
           </a:p>
         </p:txBody>
@@ -5350,6 +5351,278 @@
 </p:sld>
 </file>
 
+<file path=ppt/slides/slide4.xml><?xml version="1.0" encoding="utf-8"?>
+<p:sld xmlns:a="http://schemas.openxmlformats.org/drawingml/2006/main" xmlns:p="http://schemas.openxmlformats.org/presentationml/2006/main" xmlns:r="http://schemas.openxmlformats.org/officeDocument/2006/relationships">
+  <p:cSld>
+    <p:spTree>
+      <p:nvGrpSpPr>
+        <p:cNvPr id="1" name=""/>
+        <p:cNvGrpSpPr/>
+        <p:nvPr/>
+      </p:nvGrpSpPr>
+      <p:grpSpPr/>
+      <p:sp>
+        <p:nvSpPr>
+          <p:cNvPr id="2" name="Rectangle 1"/>
+          <p:cNvSpPr/>
+          <p:nvPr/>
+        </p:nvSpPr>
+        <p:spPr>
+          <a:xfrm>
+            <a:off x="0" y="0"/>
+            <a:ext cx="12191695" cy="274320"/>
+          </a:xfrm>
+          <a:prstGeom prst="rect">
+            <a:avLst/>
+          </a:prstGeom>
+          <a:solidFill>
+            <a:srgbClr val="00B2C9"/>
+          </a:solidFill>
+          <a:ln>
+            <a:noFill/>
+          </a:ln>
+        </p:spPr>
+        <p:style>
+          <a:lnRef idx="1">
+            <a:schemeClr val="accent1"/>
+          </a:lnRef>
+          <a:fillRef idx="3">
+            <a:schemeClr val="accent1"/>
+          </a:fillRef>
+          <a:effectRef idx="2">
+            <a:schemeClr val="accent1"/>
+          </a:effectRef>
+          <a:fontRef idx="minor">
+            <a:schemeClr val="lt1"/>
+          </a:fontRef>
+        </p:style>
+        <p:txBody>
+          <a:bodyPr rtlCol="0" anchor="ctr"/>
+          <a:lstStyle/>
+          <a:p>
+            <a:pPr algn="ctr"/>
+          </a:p>
+        </p:txBody>
+      </p:sp>
+      <p:sp>
+        <p:nvSpPr>
+          <p:cNvPr id="3" name="TextBox 2"/>
+          <p:cNvSpPr txBox="1"/>
+          <p:nvPr/>
+        </p:nvSpPr>
+        <p:spPr>
+          <a:xfrm>
+            <a:off x="411480" y="457200"/>
+            <a:ext cx="11368735" cy="914400"/>
+          </a:xfrm>
+          <a:prstGeom prst="rect">
+            <a:avLst/>
+          </a:prstGeom>
+          <a:noFill/>
+        </p:spPr>
+        <p:txBody>
+          <a:bodyPr wrap="square" lIns="0" rIns="0">
+            <a:spAutoFit/>
+          </a:bodyPr>
+          <a:lstStyle/>
+          <a:p>
+            <a:pPr algn="l"/>
+            <a:r>
+              <a:rPr sz="2600" b="1" i="0">
+                <a:solidFill>
+                  <a:srgbClr val="00B2C9"/>
+                </a:solidFill>
+                <a:latin typeface="Encode Sans"/>
+              </a:rPr>
+              <a:t>PBI TRIMESTRAL 1ER TRIMESTRE 2026</a:t>
+            </a:r>
+          </a:p>
+        </p:txBody>
+      </p:sp>
+      <p:sp>
+        <p:nvSpPr>
+          <p:cNvPr id="4" name="TextBox 3"/>
+          <p:cNvSpPr txBox="1"/>
+          <p:nvPr/>
+        </p:nvSpPr>
+        <p:spPr>
+          <a:xfrm>
+            <a:off x="411480" y="1280160"/>
+            <a:ext cx="11368735" cy="274320"/>
+          </a:xfrm>
+          <a:prstGeom prst="rect">
+            <a:avLst/>
+          </a:prstGeom>
+          <a:noFill/>
+        </p:spPr>
+        <p:txBody>
+          <a:bodyPr wrap="none">
+            <a:spAutoFit/>
+          </a:bodyPr>
+          <a:lstStyle/>
+          <a:p>
+            <a:r>
+              <a:rPr sz="1100" b="0" i="1">
+                <a:solidFill>
+                  <a:srgbClr val="6A6760"/>
+                </a:solidFill>
+                <a:latin typeface="Encode Sans"/>
+              </a:rPr>
+              <a:t>INDEC CCNN · período 1er trimestre 2026</a:t>
+            </a:r>
+          </a:p>
+        </p:txBody>
+      </p:sp>
+      <p:sp>
+        <p:nvSpPr>
+          <p:cNvPr id="5" name="TextBox 4"/>
+          <p:cNvSpPr txBox="1"/>
+          <p:nvPr/>
+        </p:nvSpPr>
+        <p:spPr>
+          <a:xfrm>
+            <a:off x="411480" y="1691640"/>
+            <a:ext cx="5486400" cy="1645920"/>
+          </a:xfrm>
+          <a:prstGeom prst="rect">
+            <a:avLst/>
+          </a:prstGeom>
+          <a:noFill/>
+        </p:spPr>
+        <p:txBody>
+          <a:bodyPr wrap="square" lIns="0" rIns="0">
+            <a:spAutoFit/>
+          </a:bodyPr>
+          <a:lstStyle/>
+          <a:p>
+            <a:pPr algn="just"/>
+            <a:r>
+              <a:rPr sz="1300" b="0" i="0">
+                <a:solidFill>
+                  <a:srgbClr val="3F3F3F"/>
+                </a:solidFill>
+                <a:latin typeface="Encode Sans"/>
+              </a:rPr>
+              <a:t>Se publicó la actualización de PBI trimestral para 1er trimestre 2026. Fuente: INDEC CCNN.</a:t>
+            </a:r>
+          </a:p>
+        </p:txBody>
+      </p:sp>
+      <p:sp>
+        <p:nvSpPr>
+          <p:cNvPr id="6" name="TextBox 5"/>
+          <p:cNvSpPr txBox="1"/>
+          <p:nvPr/>
+        </p:nvSpPr>
+        <p:spPr>
+          <a:xfrm>
+            <a:off x="411480" y="3520440"/>
+            <a:ext cx="5486400" cy="2743200"/>
+          </a:xfrm>
+          <a:prstGeom prst="rect">
+            <a:avLst/>
+          </a:prstGeom>
+          <a:noFill/>
+        </p:spPr>
+        <p:txBody>
+          <a:bodyPr wrap="square" lIns="0" rIns="0">
+            <a:spAutoFit/>
+          </a:bodyPr>
+          <a:lstStyle/>
+          <a:p>
+            <a:pPr algn="l">
+              <a:spcAft>
+                <a:spcPts val="800"/>
+              </a:spcAft>
+            </a:pPr>
+            <a:r>
+              <a:rPr sz="1300" b="1" i="0">
+                <a:solidFill>
+                  <a:srgbClr val="00B2C9"/>
+                </a:solidFill>
+                <a:latin typeface="Encode Sans"/>
+              </a:rPr>
+              <a:t>●  </a:t>
+            </a:r>
+            <a:r>
+              <a:rPr sz="1300" b="0" i="0">
+                <a:solidFill>
+                  <a:srgbClr val="3F3F3F"/>
+                </a:solidFill>
+                <a:latin typeface="Encode Sans"/>
+              </a:rPr>
+              <a:t>pbi: 725.600,00</a:t>
+            </a:r>
+          </a:p>
+          <a:p>
+            <a:pPr algn="l">
+              <a:spcAft>
+                <a:spcPts val="800"/>
+              </a:spcAft>
+            </a:pPr>
+            <a:r>
+              <a:rPr sz="1300" b="1" i="0">
+                <a:solidFill>
+                  <a:srgbClr val="00B2C9"/>
+                </a:solidFill>
+                <a:latin typeface="Encode Sans"/>
+              </a:rPr>
+              <a:t>●  </a:t>
+            </a:r>
+            <a:r>
+              <a:rPr sz="1300" b="0" i="0">
+                <a:solidFill>
+                  <a:srgbClr val="3F3F3F"/>
+                </a:solidFill>
+                <a:latin typeface="Encode Sans"/>
+              </a:rPr>
+              <a:t>via: 2,30</a:t>
+            </a:r>
+          </a:p>
+        </p:txBody>
+      </p:sp>
+      <p:sp>
+        <p:nvSpPr>
+          <p:cNvPr id="7" name="TextBox 6"/>
+          <p:cNvSpPr txBox="1"/>
+          <p:nvPr/>
+        </p:nvSpPr>
+        <p:spPr>
+          <a:xfrm>
+            <a:off x="411480" y="6492240"/>
+            <a:ext cx="11368735" cy="274320"/>
+          </a:xfrm>
+          <a:prstGeom prst="rect">
+            <a:avLst/>
+          </a:prstGeom>
+          <a:noFill/>
+        </p:spPr>
+        <p:txBody>
+          <a:bodyPr wrap="none">
+            <a:spAutoFit/>
+          </a:bodyPr>
+          <a:lstStyle/>
+          <a:p>
+            <a:r>
+              <a:rPr sz="1000" b="0" i="1">
+                <a:solidFill>
+                  <a:srgbClr val="6A6760"/>
+                </a:solidFill>
+                <a:latin typeface="Encode Sans"/>
+              </a:rPr>
+              <a:t>Fuente: elaboración propia en base a INDEC CCNN</a:t>
+            </a:r>
+          </a:p>
+        </p:txBody>
+      </p:sp>
+    </p:spTree>
+  </p:cSld>
+  <p:clrMapOvr>
+    <a:masterClrMapping/>
+  </p:clrMapOvr>
+</p:sld>
+</file>
+
 <file path=ppt/theme/theme1.xml><?xml version="1.0" encoding="utf-8"?>
 <a:theme xmlns:a="http://schemas.openxmlformats.org/drawingml/2006/main" name="Office Theme">
   <a:themeElements>

</xml_diff>

<commit_message>
balanza de pagos INDEC: nueva serie bdp (cuenta corriente trimestral)
Serie nueva, distinta del balance cambiario BCRA: mide transacciones devengadas
(BPM6) vs caja. update_bdp() via API datos.gob.ar dataset 160.2 + override del
trimestre recien publicado (la API rezaga).

cta_cte = bienes + servicios + ingreso primario (rentas) + ingreso secundario.
Q1 2026: deficit -1.651 M USD (bienes +6.339, servicios -4.028, rentas -4.676,
ing.sec +714).

- HTML: chart en Sector externo (barras apiladas componentes + linea cta cte)
- CSV bdp, tracking de publicaciones (figura en 'esta semana', publicado 24-jun)
- calendario INDEC mapea 'balanza de pagos' -> bdp
</commit_message>
<xml_diff>
--- a/publicaciones_semana.pptx
+++ b/publicaciones_semana.pptx
@@ -9,6 +9,7 @@
     <p:sldId id="257" r:id="rId8"/>
     <p:sldId id="258" r:id="rId9"/>
     <p:sldId id="259" r:id="rId10"/>
+    <p:sldId id="260" r:id="rId11"/>
   </p:sldIdLst>
   <p:sldSz cx="12191695" cy="6858000" type="screen4x3"/>
   <p:notesSz cx="6858000" cy="9144000"/>
@@ -3274,7 +3275,7 @@
                 </a:solidFill>
                 <a:latin typeface="Encode Sans"/>
               </a:rPr>
-              <a:t>3 publicaciones · datos oficiales INDEC / BCRA / Hacienda</a:t>
+              <a:t>4 publicaciones · datos oficiales INDEC / BCRA / Hacienda</a:t>
             </a:r>
           </a:p>
         </p:txBody>
@@ -5623,6 +5624,353 @@
 </p:sld>
 </file>
 
+<file path=ppt/slides/slide5.xml><?xml version="1.0" encoding="utf-8"?>
+<p:sld xmlns:a="http://schemas.openxmlformats.org/drawingml/2006/main" xmlns:p="http://schemas.openxmlformats.org/presentationml/2006/main" xmlns:r="http://schemas.openxmlformats.org/officeDocument/2006/relationships">
+  <p:cSld>
+    <p:spTree>
+      <p:nvGrpSpPr>
+        <p:cNvPr id="1" name=""/>
+        <p:cNvGrpSpPr/>
+        <p:nvPr/>
+      </p:nvGrpSpPr>
+      <p:grpSpPr/>
+      <p:sp>
+        <p:nvSpPr>
+          <p:cNvPr id="2" name="Rectangle 1"/>
+          <p:cNvSpPr/>
+          <p:nvPr/>
+        </p:nvSpPr>
+        <p:spPr>
+          <a:xfrm>
+            <a:off x="0" y="0"/>
+            <a:ext cx="12191695" cy="274320"/>
+          </a:xfrm>
+          <a:prstGeom prst="rect">
+            <a:avLst/>
+          </a:prstGeom>
+          <a:solidFill>
+            <a:srgbClr val="00B2C9"/>
+          </a:solidFill>
+          <a:ln>
+            <a:noFill/>
+          </a:ln>
+        </p:spPr>
+        <p:style>
+          <a:lnRef idx="1">
+            <a:schemeClr val="accent1"/>
+          </a:lnRef>
+          <a:fillRef idx="3">
+            <a:schemeClr val="accent1"/>
+          </a:fillRef>
+          <a:effectRef idx="2">
+            <a:schemeClr val="accent1"/>
+          </a:effectRef>
+          <a:fontRef idx="minor">
+            <a:schemeClr val="lt1"/>
+          </a:fontRef>
+        </p:style>
+        <p:txBody>
+          <a:bodyPr rtlCol="0" anchor="ctr"/>
+          <a:lstStyle/>
+          <a:p>
+            <a:pPr algn="ctr"/>
+          </a:p>
+        </p:txBody>
+      </p:sp>
+      <p:sp>
+        <p:nvSpPr>
+          <p:cNvPr id="3" name="TextBox 2"/>
+          <p:cNvSpPr txBox="1"/>
+          <p:nvPr/>
+        </p:nvSpPr>
+        <p:spPr>
+          <a:xfrm>
+            <a:off x="411480" y="457200"/>
+            <a:ext cx="11368735" cy="914400"/>
+          </a:xfrm>
+          <a:prstGeom prst="rect">
+            <a:avLst/>
+          </a:prstGeom>
+          <a:noFill/>
+        </p:spPr>
+        <p:txBody>
+          <a:bodyPr wrap="square" lIns="0" rIns="0">
+            <a:spAutoFit/>
+          </a:bodyPr>
+          <a:lstStyle/>
+          <a:p>
+            <a:pPr algn="l"/>
+            <a:r>
+              <a:rPr sz="2600" b="1" i="0">
+                <a:solidFill>
+                  <a:srgbClr val="00B2C9"/>
+                </a:solidFill>
+                <a:latin typeface="Encode Sans"/>
+              </a:rPr>
+              <a:t>BALANZA DE PAGOS 1ER TRIMESTRE 2026</a:t>
+            </a:r>
+          </a:p>
+        </p:txBody>
+      </p:sp>
+      <p:sp>
+        <p:nvSpPr>
+          <p:cNvPr id="4" name="TextBox 3"/>
+          <p:cNvSpPr txBox="1"/>
+          <p:nvPr/>
+        </p:nvSpPr>
+        <p:spPr>
+          <a:xfrm>
+            <a:off x="411480" y="1280160"/>
+            <a:ext cx="11368735" cy="274320"/>
+          </a:xfrm>
+          <a:prstGeom prst="rect">
+            <a:avLst/>
+          </a:prstGeom>
+          <a:noFill/>
+        </p:spPr>
+        <p:txBody>
+          <a:bodyPr wrap="none">
+            <a:spAutoFit/>
+          </a:bodyPr>
+          <a:lstStyle/>
+          <a:p>
+            <a:r>
+              <a:rPr sz="1100" b="0" i="1">
+                <a:solidFill>
+                  <a:srgbClr val="6A6760"/>
+                </a:solidFill>
+                <a:latin typeface="Encode Sans"/>
+              </a:rPr>
+              <a:t>INDEC · período 1er trimestre 2026</a:t>
+            </a:r>
+          </a:p>
+        </p:txBody>
+      </p:sp>
+      <p:sp>
+        <p:nvSpPr>
+          <p:cNvPr id="5" name="TextBox 4"/>
+          <p:cNvSpPr txBox="1"/>
+          <p:nvPr/>
+        </p:nvSpPr>
+        <p:spPr>
+          <a:xfrm>
+            <a:off x="411480" y="1691640"/>
+            <a:ext cx="5486400" cy="1645920"/>
+          </a:xfrm>
+          <a:prstGeom prst="rect">
+            <a:avLst/>
+          </a:prstGeom>
+          <a:noFill/>
+        </p:spPr>
+        <p:txBody>
+          <a:bodyPr wrap="square" lIns="0" rIns="0">
+            <a:spAutoFit/>
+          </a:bodyPr>
+          <a:lstStyle/>
+          <a:p>
+            <a:pPr algn="just"/>
+            <a:r>
+              <a:rPr sz="1300" b="0" i="0">
+                <a:solidFill>
+                  <a:srgbClr val="3F3F3F"/>
+                </a:solidFill>
+                <a:latin typeface="Encode Sans"/>
+              </a:rPr>
+              <a:t>Se publicó la actualización de Balanza de pagos para 1er trimestre 2026. Fuente: INDEC.</a:t>
+            </a:r>
+          </a:p>
+        </p:txBody>
+      </p:sp>
+      <p:sp>
+        <p:nvSpPr>
+          <p:cNvPr id="6" name="TextBox 5"/>
+          <p:cNvSpPr txBox="1"/>
+          <p:nvPr/>
+        </p:nvSpPr>
+        <p:spPr>
+          <a:xfrm>
+            <a:off x="411480" y="3520440"/>
+            <a:ext cx="5486400" cy="2743200"/>
+          </a:xfrm>
+          <a:prstGeom prst="rect">
+            <a:avLst/>
+          </a:prstGeom>
+          <a:noFill/>
+        </p:spPr>
+        <p:txBody>
+          <a:bodyPr wrap="square" lIns="0" rIns="0">
+            <a:spAutoFit/>
+          </a:bodyPr>
+          <a:lstStyle/>
+          <a:p>
+            <a:pPr algn="l">
+              <a:spcAft>
+                <a:spcPts val="800"/>
+              </a:spcAft>
+            </a:pPr>
+            <a:r>
+              <a:rPr sz="1300" b="1" i="0">
+                <a:solidFill>
+                  <a:srgbClr val="00B2C9"/>
+                </a:solidFill>
+                <a:latin typeface="Encode Sans"/>
+              </a:rPr>
+              <a:t>●  </a:t>
+            </a:r>
+            <a:r>
+              <a:rPr sz="1300" b="0" i="0">
+                <a:solidFill>
+                  <a:srgbClr val="3F3F3F"/>
+                </a:solidFill>
+                <a:latin typeface="Encode Sans"/>
+              </a:rPr>
+              <a:t>cta_cte: -1.651,00</a:t>
+            </a:r>
+          </a:p>
+          <a:p>
+            <a:pPr algn="l">
+              <a:spcAft>
+                <a:spcPts val="800"/>
+              </a:spcAft>
+            </a:pPr>
+            <a:r>
+              <a:rPr sz="1300" b="1" i="0">
+                <a:solidFill>
+                  <a:srgbClr val="00B2C9"/>
+                </a:solidFill>
+                <a:latin typeface="Encode Sans"/>
+              </a:rPr>
+              <a:t>●  </a:t>
+            </a:r>
+            <a:r>
+              <a:rPr sz="1300" b="0" i="0">
+                <a:solidFill>
+                  <a:srgbClr val="3F3F3F"/>
+                </a:solidFill>
+                <a:latin typeface="Encode Sans"/>
+              </a:rPr>
+              <a:t>bienes: 6.339,00</a:t>
+            </a:r>
+          </a:p>
+          <a:p>
+            <a:pPr algn="l">
+              <a:spcAft>
+                <a:spcPts val="800"/>
+              </a:spcAft>
+            </a:pPr>
+            <a:r>
+              <a:rPr sz="1300" b="1" i="0">
+                <a:solidFill>
+                  <a:srgbClr val="00B2C9"/>
+                </a:solidFill>
+                <a:latin typeface="Encode Sans"/>
+              </a:rPr>
+              <a:t>●  </a:t>
+            </a:r>
+            <a:r>
+              <a:rPr sz="1300" b="0" i="0">
+                <a:solidFill>
+                  <a:srgbClr val="3F3F3F"/>
+                </a:solidFill>
+                <a:latin typeface="Encode Sans"/>
+              </a:rPr>
+              <a:t>servicios: -4.028,00</a:t>
+            </a:r>
+          </a:p>
+          <a:p>
+            <a:pPr algn="l">
+              <a:spcAft>
+                <a:spcPts val="800"/>
+              </a:spcAft>
+            </a:pPr>
+            <a:r>
+              <a:rPr sz="1300" b="1" i="0">
+                <a:solidFill>
+                  <a:srgbClr val="00B2C9"/>
+                </a:solidFill>
+                <a:latin typeface="Encode Sans"/>
+              </a:rPr>
+              <a:t>●  </a:t>
+            </a:r>
+            <a:r>
+              <a:rPr sz="1300" b="0" i="0">
+                <a:solidFill>
+                  <a:srgbClr val="3F3F3F"/>
+                </a:solidFill>
+                <a:latin typeface="Encode Sans"/>
+              </a:rPr>
+              <a:t>ing_prim: -4.676,00</a:t>
+            </a:r>
+          </a:p>
+          <a:p>
+            <a:pPr algn="l">
+              <a:spcAft>
+                <a:spcPts val="800"/>
+              </a:spcAft>
+            </a:pPr>
+            <a:r>
+              <a:rPr sz="1300" b="1" i="0">
+                <a:solidFill>
+                  <a:srgbClr val="00B2C9"/>
+                </a:solidFill>
+                <a:latin typeface="Encode Sans"/>
+              </a:rPr>
+              <a:t>●  </a:t>
+            </a:r>
+            <a:r>
+              <a:rPr sz="1300" b="0" i="0">
+                <a:solidFill>
+                  <a:srgbClr val="3F3F3F"/>
+                </a:solidFill>
+                <a:latin typeface="Encode Sans"/>
+              </a:rPr>
+              <a:t>ing_sec: 714,00</a:t>
+            </a:r>
+          </a:p>
+        </p:txBody>
+      </p:sp>
+      <p:sp>
+        <p:nvSpPr>
+          <p:cNvPr id="7" name="TextBox 6"/>
+          <p:cNvSpPr txBox="1"/>
+          <p:nvPr/>
+        </p:nvSpPr>
+        <p:spPr>
+          <a:xfrm>
+            <a:off x="411480" y="6492240"/>
+            <a:ext cx="11368735" cy="274320"/>
+          </a:xfrm>
+          <a:prstGeom prst="rect">
+            <a:avLst/>
+          </a:prstGeom>
+          <a:noFill/>
+        </p:spPr>
+        <p:txBody>
+          <a:bodyPr wrap="none">
+            <a:spAutoFit/>
+          </a:bodyPr>
+          <a:lstStyle/>
+          <a:p>
+            <a:r>
+              <a:rPr sz="1000" b="0" i="1">
+                <a:solidFill>
+                  <a:srgbClr val="6A6760"/>
+                </a:solidFill>
+                <a:latin typeface="Encode Sans"/>
+              </a:rPr>
+              <a:t>Fuente: elaboración propia en base a INDEC</a:t>
+            </a:r>
+          </a:p>
+        </p:txBody>
+      </p:sp>
+    </p:spTree>
+  </p:cSld>
+  <p:clrMapOvr>
+    <a:masterClrMapping/>
+  </p:clrMapOvr>
+</p:sld>
+</file>
+
 <file path=ppt/theme/theme1.xml><?xml version="1.0" encoding="utf-8"?>
 <a:theme xmlns:a="http://schemas.openxmlformats.org/drawingml/2006/main" name="Office Theme">
   <a:themeElements>

</xml_diff>

<commit_message>
data: update 2026-06-25 ( data.json despidos.json scraper/historical_despidos.json publicaciones_semana.pptx rrii_brutas.xlsx)
</commit_message>
<xml_diff>
--- a/publicaciones_semana.pptx
+++ b/publicaciones_semana.pptx
@@ -10,6 +10,7 @@
     <p:sldId id="258" r:id="rId9"/>
     <p:sldId id="259" r:id="rId10"/>
     <p:sldId id="260" r:id="rId11"/>
+    <p:sldId id="261" r:id="rId12"/>
   </p:sldIdLst>
   <p:sldSz cx="12191695" cy="6858000" type="screen4x3"/>
   <p:notesSz cx="6858000" cy="9144000"/>
@@ -3275,7 +3276,7 @@
                 </a:solidFill>
                 <a:latin typeface="Encode Sans"/>
               </a:rPr>
-              <a:t>4 publicaciones · datos oficiales INDEC / BCRA / Hacienda</a:t>
+              <a:t>5 publicaciones · datos oficiales INDEC / BCRA / Hacienda</a:t>
             </a:r>
           </a:p>
         </p:txBody>
@@ -5932,6 +5933,1038 @@
       <p:sp>
         <p:nvSpPr>
           <p:cNvPr id="7" name="TextBox 6"/>
+          <p:cNvSpPr txBox="1"/>
+          <p:nvPr/>
+        </p:nvSpPr>
+        <p:spPr>
+          <a:xfrm>
+            <a:off x="411480" y="6492240"/>
+            <a:ext cx="11368735" cy="274320"/>
+          </a:xfrm>
+          <a:prstGeom prst="rect">
+            <a:avLst/>
+          </a:prstGeom>
+          <a:noFill/>
+        </p:spPr>
+        <p:txBody>
+          <a:bodyPr wrap="none">
+            <a:spAutoFit/>
+          </a:bodyPr>
+          <a:lstStyle/>
+          <a:p>
+            <a:r>
+              <a:rPr sz="1000" b="0" i="1">
+                <a:solidFill>
+                  <a:srgbClr val="6A6760"/>
+                </a:solidFill>
+                <a:latin typeface="Encode Sans"/>
+              </a:rPr>
+              <a:t>Fuente: elaboración propia en base a INDEC</a:t>
+            </a:r>
+          </a:p>
+        </p:txBody>
+      </p:sp>
+    </p:spTree>
+  </p:cSld>
+  <p:clrMapOvr>
+    <a:masterClrMapping/>
+  </p:clrMapOvr>
+</p:sld>
+</file>
+
+<file path=ppt/slides/slide6.xml><?xml version="1.0" encoding="utf-8"?>
+<p:sld xmlns:a="http://schemas.openxmlformats.org/drawingml/2006/main" xmlns:p="http://schemas.openxmlformats.org/presentationml/2006/main" xmlns:r="http://schemas.openxmlformats.org/officeDocument/2006/relationships">
+  <p:cSld>
+    <p:spTree>
+      <p:nvGrpSpPr>
+        <p:cNvPr id="1" name=""/>
+        <p:cNvGrpSpPr/>
+        <p:nvPr/>
+      </p:nvGrpSpPr>
+      <p:grpSpPr/>
+      <p:sp>
+        <p:nvSpPr>
+          <p:cNvPr id="2" name="Rectangle 1"/>
+          <p:cNvSpPr/>
+          <p:nvPr/>
+        </p:nvSpPr>
+        <p:spPr>
+          <a:xfrm>
+            <a:off x="0" y="0"/>
+            <a:ext cx="12191695" cy="274320"/>
+          </a:xfrm>
+          <a:prstGeom prst="rect">
+            <a:avLst/>
+          </a:prstGeom>
+          <a:solidFill>
+            <a:srgbClr val="00B2C9"/>
+          </a:solidFill>
+          <a:ln>
+            <a:noFill/>
+          </a:ln>
+        </p:spPr>
+        <p:style>
+          <a:lnRef idx="1">
+            <a:schemeClr val="accent1"/>
+          </a:lnRef>
+          <a:fillRef idx="3">
+            <a:schemeClr val="accent1"/>
+          </a:fillRef>
+          <a:effectRef idx="2">
+            <a:schemeClr val="accent1"/>
+          </a:effectRef>
+          <a:fontRef idx="minor">
+            <a:schemeClr val="lt1"/>
+          </a:fontRef>
+        </p:style>
+        <p:txBody>
+          <a:bodyPr rtlCol="0" anchor="ctr"/>
+          <a:lstStyle/>
+          <a:p>
+            <a:pPr algn="ctr"/>
+          </a:p>
+        </p:txBody>
+      </p:sp>
+      <p:sp>
+        <p:nvSpPr>
+          <p:cNvPr id="3" name="TextBox 2"/>
+          <p:cNvSpPr txBox="1"/>
+          <p:nvPr/>
+        </p:nvSpPr>
+        <p:spPr>
+          <a:xfrm>
+            <a:off x="411480" y="457200"/>
+            <a:ext cx="11368735" cy="914400"/>
+          </a:xfrm>
+          <a:prstGeom prst="rect">
+            <a:avLst/>
+          </a:prstGeom>
+          <a:noFill/>
+        </p:spPr>
+        <p:txBody>
+          <a:bodyPr wrap="square" lIns="0" rIns="0">
+            <a:spAutoFit/>
+          </a:bodyPr>
+          <a:lstStyle/>
+          <a:p>
+            <a:pPr algn="l"/>
+            <a:r>
+              <a:rPr sz="2600" b="1" i="0">
+                <a:solidFill>
+                  <a:srgbClr val="00B2C9"/>
+                </a:solidFill>
+                <a:latin typeface="Encode Sans"/>
+              </a:rPr>
+              <a:t>TURISMO INTERNACIONAL MAYO 2026: SALDO -281.993 PERSONAS</a:t>
+            </a:r>
+          </a:p>
+        </p:txBody>
+      </p:sp>
+      <p:sp>
+        <p:nvSpPr>
+          <p:cNvPr id="4" name="TextBox 3"/>
+          <p:cNvSpPr txBox="1"/>
+          <p:nvPr/>
+        </p:nvSpPr>
+        <p:spPr>
+          <a:xfrm>
+            <a:off x="411480" y="1280160"/>
+            <a:ext cx="11368735" cy="274320"/>
+          </a:xfrm>
+          <a:prstGeom prst="rect">
+            <a:avLst/>
+          </a:prstGeom>
+          <a:noFill/>
+        </p:spPr>
+        <p:txBody>
+          <a:bodyPr wrap="none">
+            <a:spAutoFit/>
+          </a:bodyPr>
+          <a:lstStyle/>
+          <a:p>
+            <a:r>
+              <a:rPr sz="1100" b="0" i="1">
+                <a:solidFill>
+                  <a:srgbClr val="6A6760"/>
+                </a:solidFill>
+                <a:latin typeface="Encode Sans"/>
+              </a:rPr>
+              <a:t>INDEC · período 2026-05</a:t>
+            </a:r>
+          </a:p>
+        </p:txBody>
+      </p:sp>
+      <p:sp>
+        <p:nvSpPr>
+          <p:cNvPr id="5" name="TextBox 4"/>
+          <p:cNvSpPr txBox="1"/>
+          <p:nvPr/>
+        </p:nvSpPr>
+        <p:spPr>
+          <a:xfrm>
+            <a:off x="411480" y="1691640"/>
+            <a:ext cx="5486400" cy="1645920"/>
+          </a:xfrm>
+          <a:prstGeom prst="rect">
+            <a:avLst/>
+          </a:prstGeom>
+          <a:noFill/>
+        </p:spPr>
+        <p:txBody>
+          <a:bodyPr wrap="square" lIns="0" rIns="0">
+            <a:spAutoFit/>
+          </a:bodyPr>
+          <a:lstStyle/>
+          <a:p>
+            <a:pPr algn="just"/>
+            <a:r>
+              <a:rPr sz="1300" b="0" i="0">
+                <a:solidFill>
+                  <a:srgbClr val="3F3F3F"/>
+                </a:solidFill>
+                <a:latin typeface="Encode Sans"/>
+              </a:rPr>
+              <a:t>En mayo 2026 ingresaron 379.860 turistas no residentes y salieron 661.853 argentinos al exterior, con saldo de -281.993 personas. Receptivo +20.4% i.a., emisivo -12.1% i.a.</a:t>
+            </a:r>
+          </a:p>
+        </p:txBody>
+      </p:sp>
+      <p:sp>
+        <p:nvSpPr>
+          <p:cNvPr id="6" name="TextBox 5"/>
+          <p:cNvSpPr txBox="1"/>
+          <p:nvPr/>
+        </p:nvSpPr>
+        <p:spPr>
+          <a:xfrm>
+            <a:off x="411480" y="3520440"/>
+            <a:ext cx="5486400" cy="2743200"/>
+          </a:xfrm>
+          <a:prstGeom prst="rect">
+            <a:avLst/>
+          </a:prstGeom>
+          <a:noFill/>
+        </p:spPr>
+        <p:txBody>
+          <a:bodyPr wrap="square" lIns="0" rIns="0">
+            <a:spAutoFit/>
+          </a:bodyPr>
+          <a:lstStyle/>
+          <a:p>
+            <a:pPr algn="l">
+              <a:spcAft>
+                <a:spcPts val="800"/>
+              </a:spcAft>
+            </a:pPr>
+            <a:r>
+              <a:rPr sz="1300" b="1" i="0">
+                <a:solidFill>
+                  <a:srgbClr val="00B2C9"/>
+                </a:solidFill>
+                <a:latin typeface="Encode Sans"/>
+              </a:rPr>
+              <a:t>●  </a:t>
+            </a:r>
+            <a:r>
+              <a:rPr sz="1300" b="0" i="0">
+                <a:solidFill>
+                  <a:srgbClr val="3F3F3F"/>
+                </a:solidFill>
+                <a:latin typeface="Encode Sans"/>
+              </a:rPr>
+              <a:t>Receptivo: 379.860 personas</a:t>
+            </a:r>
+          </a:p>
+          <a:p>
+            <a:pPr algn="l">
+              <a:spcAft>
+                <a:spcPts val="800"/>
+              </a:spcAft>
+            </a:pPr>
+            <a:r>
+              <a:rPr sz="1300" b="1" i="0">
+                <a:solidFill>
+                  <a:srgbClr val="00B2C9"/>
+                </a:solidFill>
+                <a:latin typeface="Encode Sans"/>
+              </a:rPr>
+              <a:t>●  </a:t>
+            </a:r>
+            <a:r>
+              <a:rPr sz="1300" b="0" i="0">
+                <a:solidFill>
+                  <a:srgbClr val="3F3F3F"/>
+                </a:solidFill>
+                <a:latin typeface="Encode Sans"/>
+              </a:rPr>
+              <a:t>Emisivo: 661.853 personas</a:t>
+            </a:r>
+          </a:p>
+          <a:p>
+            <a:pPr algn="l">
+              <a:spcAft>
+                <a:spcPts val="800"/>
+              </a:spcAft>
+            </a:pPr>
+            <a:r>
+              <a:rPr sz="1300" b="1" i="0">
+                <a:solidFill>
+                  <a:srgbClr val="00B2C9"/>
+                </a:solidFill>
+                <a:latin typeface="Encode Sans"/>
+              </a:rPr>
+              <a:t>●  </a:t>
+            </a:r>
+            <a:r>
+              <a:rPr sz="1300" b="0" i="0">
+                <a:solidFill>
+                  <a:srgbClr val="3F3F3F"/>
+                </a:solidFill>
+                <a:latin typeface="Encode Sans"/>
+              </a:rPr>
+              <a:t>Saldo (receptivo − emisivo): -281.993 personas</a:t>
+            </a:r>
+          </a:p>
+          <a:p>
+            <a:pPr algn="l">
+              <a:spcAft>
+                <a:spcPts val="800"/>
+              </a:spcAft>
+            </a:pPr>
+            <a:r>
+              <a:rPr sz="1300" b="1" i="0">
+                <a:solidFill>
+                  <a:srgbClr val="00B2C9"/>
+                </a:solidFill>
+                <a:latin typeface="Encode Sans"/>
+              </a:rPr>
+              <a:t>●  </a:t>
+            </a:r>
+            <a:r>
+              <a:rPr sz="1300" b="0" i="0">
+                <a:solidFill>
+                  <a:srgbClr val="3F3F3F"/>
+                </a:solidFill>
+                <a:latin typeface="Encode Sans"/>
+              </a:rPr>
+              <a:t>Fuente: INDEC, Estadísticas de Turismo Internacional (todas las vías)</a:t>
+            </a:r>
+          </a:p>
+        </p:txBody>
+      </p:sp>
+      <p:pic>
+        <p:nvPicPr>
+          <p:cNvPr id="7" name="Picture 6" descr="image.png"/>
+          <p:cNvPicPr>
+            <a:picLocks noChangeAspect="1"/>
+          </p:cNvPicPr>
+          <p:nvPr/>
+        </p:nvPicPr>
+        <p:blipFill>
+          <a:blip r:embed="rId2"/>
+          <a:stretch>
+            <a:fillRect/>
+          </a:stretch>
+        </p:blipFill>
+        <p:spPr>
+          <a:xfrm>
+            <a:off x="6080760" y="1691640"/>
+            <a:ext cx="5669280" cy="2560320"/>
+          </a:xfrm>
+          <a:prstGeom prst="rect">
+            <a:avLst/>
+          </a:prstGeom>
+        </p:spPr>
+      </p:pic>
+      <p:graphicFrame>
+        <p:nvGraphicFramePr>
+          <p:cNvPr id="8" name="Table 7"/>
+          <p:cNvGraphicFramePr>
+            <a:graphicFrameLocks noGrp="1"/>
+          </p:cNvGraphicFramePr>
+          <p:nvPr/>
+        </p:nvGraphicFramePr>
+        <p:xfrm>
+          <a:off x="6080760" y="4434840"/>
+          <a:ext cx="5669280" cy="2048256"/>
+        </p:xfrm>
+        <a:graphic>
+          <a:graphicData uri="http://schemas.openxmlformats.org/drawingml/2006/table">
+            <a:tbl>
+              <a:tblPr firstRow="1" bandRow="1">
+                <a:tableStyleId>{5C22544A-7EE6-4342-B048-85BDC9FD1C3A}</a:tableStyleId>
+              </a:tblPr>
+              <a:tblGrid>
+                <a:gridCol w="1417320"/>
+                <a:gridCol w="1417320"/>
+                <a:gridCol w="1417320"/>
+                <a:gridCol w="1417320"/>
+              </a:tblGrid>
+              <a:tr h="292608">
+                <a:tc>
+                  <a:txBody>
+                    <a:bodyPr/>
+                    <a:lstStyle/>
+                    <a:p>
+                      <a:pPr algn="l"/>
+                      <a:r>
+                        <a:rPr sz="1000" b="1">
+                          <a:solidFill>
+                            <a:srgbClr val="FFFFFF"/>
+                          </a:solidFill>
+                          <a:latin typeface="Encode Sans"/>
+                        </a:rPr>
+                        <a:t>Mes</a:t>
+                      </a:r>
+                    </a:p>
+                  </a:txBody>
+                  <a:tcPr marL="36576" marR="36576" marT="18288" marB="18288">
+                    <a:solidFill>
+                      <a:srgbClr val="00B2C9"/>
+                    </a:solidFill>
+                  </a:tcPr>
+                </a:tc>
+                <a:tc>
+                  <a:txBody>
+                    <a:bodyPr/>
+                    <a:lstStyle/>
+                    <a:p>
+                      <a:pPr algn="r"/>
+                      <a:r>
+                        <a:rPr sz="1000" b="1">
+                          <a:solidFill>
+                            <a:srgbClr val="FFFFFF"/>
+                          </a:solidFill>
+                          <a:latin typeface="Encode Sans"/>
+                        </a:rPr>
+                        <a:t>Receptivo</a:t>
+                      </a:r>
+                    </a:p>
+                  </a:txBody>
+                  <a:tcPr marL="36576" marR="36576" marT="18288" marB="18288">
+                    <a:solidFill>
+                      <a:srgbClr val="00B2C9"/>
+                    </a:solidFill>
+                  </a:tcPr>
+                </a:tc>
+                <a:tc>
+                  <a:txBody>
+                    <a:bodyPr/>
+                    <a:lstStyle/>
+                    <a:p>
+                      <a:pPr algn="r"/>
+                      <a:r>
+                        <a:rPr sz="1000" b="1">
+                          <a:solidFill>
+                            <a:srgbClr val="FFFFFF"/>
+                          </a:solidFill>
+                          <a:latin typeface="Encode Sans"/>
+                        </a:rPr>
+                        <a:t>Emisivo</a:t>
+                      </a:r>
+                    </a:p>
+                  </a:txBody>
+                  <a:tcPr marL="36576" marR="36576" marT="18288" marB="18288">
+                    <a:solidFill>
+                      <a:srgbClr val="00B2C9"/>
+                    </a:solidFill>
+                  </a:tcPr>
+                </a:tc>
+                <a:tc>
+                  <a:txBody>
+                    <a:bodyPr/>
+                    <a:lstStyle/>
+                    <a:p>
+                      <a:pPr algn="r"/>
+                      <a:r>
+                        <a:rPr sz="1000" b="1">
+                          <a:solidFill>
+                            <a:srgbClr val="FFFFFF"/>
+                          </a:solidFill>
+                          <a:latin typeface="Encode Sans"/>
+                        </a:rPr>
+                        <a:t>Saldo</a:t>
+                      </a:r>
+                    </a:p>
+                  </a:txBody>
+                  <a:tcPr marL="36576" marR="36576" marT="18288" marB="18288">
+                    <a:solidFill>
+                      <a:srgbClr val="00B2C9"/>
+                    </a:solidFill>
+                  </a:tcPr>
+                </a:tc>
+              </a:tr>
+              <a:tr h="292608">
+                <a:tc>
+                  <a:txBody>
+                    <a:bodyPr/>
+                    <a:lstStyle/>
+                    <a:p>
+                      <a:pPr algn="l"/>
+                      <a:r>
+                        <a:rPr sz="1000">
+                          <a:solidFill>
+                            <a:srgbClr val="3F3F3F"/>
+                          </a:solidFill>
+                          <a:latin typeface="Encode Sans"/>
+                        </a:rPr>
+                        <a:t>Mayo 2026</a:t>
+                      </a:r>
+                    </a:p>
+                  </a:txBody>
+                  <a:tcPr marL="36576" marR="36576" marT="18288" marB="18288">
+                    <a:solidFill>
+                      <a:srgbClr val="FFFFFF"/>
+                    </a:solidFill>
+                  </a:tcPr>
+                </a:tc>
+                <a:tc>
+                  <a:txBody>
+                    <a:bodyPr/>
+                    <a:lstStyle/>
+                    <a:p>
+                      <a:pPr algn="r"/>
+                      <a:r>
+                        <a:rPr sz="1000">
+                          <a:solidFill>
+                            <a:srgbClr val="3F3F3F"/>
+                          </a:solidFill>
+                          <a:latin typeface="Encode Sans"/>
+                        </a:rPr>
+                        <a:t>379.860</a:t>
+                      </a:r>
+                    </a:p>
+                  </a:txBody>
+                  <a:tcPr marL="36576" marR="36576" marT="18288" marB="18288">
+                    <a:solidFill>
+                      <a:srgbClr val="FFFFFF"/>
+                    </a:solidFill>
+                  </a:tcPr>
+                </a:tc>
+                <a:tc>
+                  <a:txBody>
+                    <a:bodyPr/>
+                    <a:lstStyle/>
+                    <a:p>
+                      <a:pPr algn="r"/>
+                      <a:r>
+                        <a:rPr sz="1000">
+                          <a:solidFill>
+                            <a:srgbClr val="3F3F3F"/>
+                          </a:solidFill>
+                          <a:latin typeface="Encode Sans"/>
+                        </a:rPr>
+                        <a:t>661.853</a:t>
+                      </a:r>
+                    </a:p>
+                  </a:txBody>
+                  <a:tcPr marL="36576" marR="36576" marT="18288" marB="18288">
+                    <a:solidFill>
+                      <a:srgbClr val="FFFFFF"/>
+                    </a:solidFill>
+                  </a:tcPr>
+                </a:tc>
+                <a:tc>
+                  <a:txBody>
+                    <a:bodyPr/>
+                    <a:lstStyle/>
+                    <a:p>
+                      <a:pPr algn="r"/>
+                      <a:r>
+                        <a:rPr sz="1000">
+                          <a:solidFill>
+                            <a:srgbClr val="3F3F3F"/>
+                          </a:solidFill>
+                          <a:latin typeface="Encode Sans"/>
+                        </a:rPr>
+                        <a:t>-281.993</a:t>
+                      </a:r>
+                    </a:p>
+                  </a:txBody>
+                  <a:tcPr marL="36576" marR="36576" marT="18288" marB="18288">
+                    <a:solidFill>
+                      <a:srgbClr val="FFFFFF"/>
+                    </a:solidFill>
+                  </a:tcPr>
+                </a:tc>
+              </a:tr>
+              <a:tr h="292608">
+                <a:tc>
+                  <a:txBody>
+                    <a:bodyPr/>
+                    <a:lstStyle/>
+                    <a:p>
+                      <a:pPr algn="l"/>
+                      <a:r>
+                        <a:rPr sz="1000">
+                          <a:solidFill>
+                            <a:srgbClr val="3F3F3F"/>
+                          </a:solidFill>
+                          <a:latin typeface="Encode Sans"/>
+                        </a:rPr>
+                        <a:t>Abril 2026</a:t>
+                      </a:r>
+                    </a:p>
+                  </a:txBody>
+                  <a:tcPr marL="36576" marR="36576" marT="18288" marB="18288">
+                    <a:solidFill>
+                      <a:srgbClr val="F8F8F6"/>
+                    </a:solidFill>
+                  </a:tcPr>
+                </a:tc>
+                <a:tc>
+                  <a:txBody>
+                    <a:bodyPr/>
+                    <a:lstStyle/>
+                    <a:p>
+                      <a:pPr algn="r"/>
+                      <a:r>
+                        <a:rPr sz="1000">
+                          <a:solidFill>
+                            <a:srgbClr val="3F3F3F"/>
+                          </a:solidFill>
+                          <a:latin typeface="Encode Sans"/>
+                        </a:rPr>
+                        <a:t>463.072</a:t>
+                      </a:r>
+                    </a:p>
+                  </a:txBody>
+                  <a:tcPr marL="36576" marR="36576" marT="18288" marB="18288">
+                    <a:solidFill>
+                      <a:srgbClr val="F8F8F6"/>
+                    </a:solidFill>
+                  </a:tcPr>
+                </a:tc>
+                <a:tc>
+                  <a:txBody>
+                    <a:bodyPr/>
+                    <a:lstStyle/>
+                    <a:p>
+                      <a:pPr algn="r"/>
+                      <a:r>
+                        <a:rPr sz="1000">
+                          <a:solidFill>
+                            <a:srgbClr val="3F3F3F"/>
+                          </a:solidFill>
+                          <a:latin typeface="Encode Sans"/>
+                        </a:rPr>
+                        <a:t>764.757</a:t>
+                      </a:r>
+                    </a:p>
+                  </a:txBody>
+                  <a:tcPr marL="36576" marR="36576" marT="18288" marB="18288">
+                    <a:solidFill>
+                      <a:srgbClr val="F8F8F6"/>
+                    </a:solidFill>
+                  </a:tcPr>
+                </a:tc>
+                <a:tc>
+                  <a:txBody>
+                    <a:bodyPr/>
+                    <a:lstStyle/>
+                    <a:p>
+                      <a:pPr algn="r"/>
+                      <a:r>
+                        <a:rPr sz="1000">
+                          <a:solidFill>
+                            <a:srgbClr val="3F3F3F"/>
+                          </a:solidFill>
+                          <a:latin typeface="Encode Sans"/>
+                        </a:rPr>
+                        <a:t>-301.685</a:t>
+                      </a:r>
+                    </a:p>
+                  </a:txBody>
+                  <a:tcPr marL="36576" marR="36576" marT="18288" marB="18288">
+                    <a:solidFill>
+                      <a:srgbClr val="F8F8F6"/>
+                    </a:solidFill>
+                  </a:tcPr>
+                </a:tc>
+              </a:tr>
+              <a:tr h="292608">
+                <a:tc>
+                  <a:txBody>
+                    <a:bodyPr/>
+                    <a:lstStyle/>
+                    <a:p>
+                      <a:pPr algn="l"/>
+                      <a:r>
+                        <a:rPr sz="1000">
+                          <a:solidFill>
+                            <a:srgbClr val="3F3F3F"/>
+                          </a:solidFill>
+                          <a:latin typeface="Encode Sans"/>
+                        </a:rPr>
+                        <a:t>Marzo 2026</a:t>
+                      </a:r>
+                    </a:p>
+                  </a:txBody>
+                  <a:tcPr marL="36576" marR="36576" marT="18288" marB="18288">
+                    <a:solidFill>
+                      <a:srgbClr val="FFFFFF"/>
+                    </a:solidFill>
+                  </a:tcPr>
+                </a:tc>
+                <a:tc>
+                  <a:txBody>
+                    <a:bodyPr/>
+                    <a:lstStyle/>
+                    <a:p>
+                      <a:pPr algn="r"/>
+                      <a:r>
+                        <a:rPr sz="1000">
+                          <a:solidFill>
+                            <a:srgbClr val="3F3F3F"/>
+                          </a:solidFill>
+                          <a:latin typeface="Encode Sans"/>
+                        </a:rPr>
+                        <a:t>509.625</a:t>
+                      </a:r>
+                    </a:p>
+                  </a:txBody>
+                  <a:tcPr marL="36576" marR="36576" marT="18288" marB="18288">
+                    <a:solidFill>
+                      <a:srgbClr val="FFFFFF"/>
+                    </a:solidFill>
+                  </a:tcPr>
+                </a:tc>
+                <a:tc>
+                  <a:txBody>
+                    <a:bodyPr/>
+                    <a:lstStyle/>
+                    <a:p>
+                      <a:pPr algn="r"/>
+                      <a:r>
+                        <a:rPr sz="1000">
+                          <a:solidFill>
+                            <a:srgbClr val="3F3F3F"/>
+                          </a:solidFill>
+                          <a:latin typeface="Encode Sans"/>
+                        </a:rPr>
+                        <a:t>1.061.777</a:t>
+                      </a:r>
+                    </a:p>
+                  </a:txBody>
+                  <a:tcPr marL="36576" marR="36576" marT="18288" marB="18288">
+                    <a:solidFill>
+                      <a:srgbClr val="FFFFFF"/>
+                    </a:solidFill>
+                  </a:tcPr>
+                </a:tc>
+                <a:tc>
+                  <a:txBody>
+                    <a:bodyPr/>
+                    <a:lstStyle/>
+                    <a:p>
+                      <a:pPr algn="r"/>
+                      <a:r>
+                        <a:rPr sz="1000">
+                          <a:solidFill>
+                            <a:srgbClr val="3F3F3F"/>
+                          </a:solidFill>
+                          <a:latin typeface="Encode Sans"/>
+                        </a:rPr>
+                        <a:t>-552.152</a:t>
+                      </a:r>
+                    </a:p>
+                  </a:txBody>
+                  <a:tcPr marL="36576" marR="36576" marT="18288" marB="18288">
+                    <a:solidFill>
+                      <a:srgbClr val="FFFFFF"/>
+                    </a:solidFill>
+                  </a:tcPr>
+                </a:tc>
+              </a:tr>
+              <a:tr h="292608">
+                <a:tc>
+                  <a:txBody>
+                    <a:bodyPr/>
+                    <a:lstStyle/>
+                    <a:p>
+                      <a:pPr algn="l"/>
+                      <a:r>
+                        <a:rPr sz="1000">
+                          <a:solidFill>
+                            <a:srgbClr val="3F3F3F"/>
+                          </a:solidFill>
+                          <a:latin typeface="Encode Sans"/>
+                        </a:rPr>
+                        <a:t>Febrero 2026</a:t>
+                      </a:r>
+                    </a:p>
+                  </a:txBody>
+                  <a:tcPr marL="36576" marR="36576" marT="18288" marB="18288">
+                    <a:solidFill>
+                      <a:srgbClr val="F8F8F6"/>
+                    </a:solidFill>
+                  </a:tcPr>
+                </a:tc>
+                <a:tc>
+                  <a:txBody>
+                    <a:bodyPr/>
+                    <a:lstStyle/>
+                    <a:p>
+                      <a:pPr algn="r"/>
+                      <a:r>
+                        <a:rPr sz="1000">
+                          <a:solidFill>
+                            <a:srgbClr val="3F3F3F"/>
+                          </a:solidFill>
+                          <a:latin typeface="Encode Sans"/>
+                        </a:rPr>
+                        <a:t>534.223</a:t>
+                      </a:r>
+                    </a:p>
+                  </a:txBody>
+                  <a:tcPr marL="36576" marR="36576" marT="18288" marB="18288">
+                    <a:solidFill>
+                      <a:srgbClr val="F8F8F6"/>
+                    </a:solidFill>
+                  </a:tcPr>
+                </a:tc>
+                <a:tc>
+                  <a:txBody>
+                    <a:bodyPr/>
+                    <a:lstStyle/>
+                    <a:p>
+                      <a:pPr algn="r"/>
+                      <a:r>
+                        <a:rPr sz="1000">
+                          <a:solidFill>
+                            <a:srgbClr val="3F3F3F"/>
+                          </a:solidFill>
+                          <a:latin typeface="Encode Sans"/>
+                        </a:rPr>
+                        <a:t>1.629.180</a:t>
+                      </a:r>
+                    </a:p>
+                  </a:txBody>
+                  <a:tcPr marL="36576" marR="36576" marT="18288" marB="18288">
+                    <a:solidFill>
+                      <a:srgbClr val="F8F8F6"/>
+                    </a:solidFill>
+                  </a:tcPr>
+                </a:tc>
+                <a:tc>
+                  <a:txBody>
+                    <a:bodyPr/>
+                    <a:lstStyle/>
+                    <a:p>
+                      <a:pPr algn="r"/>
+                      <a:r>
+                        <a:rPr sz="1000">
+                          <a:solidFill>
+                            <a:srgbClr val="3F3F3F"/>
+                          </a:solidFill>
+                          <a:latin typeface="Encode Sans"/>
+                        </a:rPr>
+                        <a:t>-1.094.957</a:t>
+                      </a:r>
+                    </a:p>
+                  </a:txBody>
+                  <a:tcPr marL="36576" marR="36576" marT="18288" marB="18288">
+                    <a:solidFill>
+                      <a:srgbClr val="F8F8F6"/>
+                    </a:solidFill>
+                  </a:tcPr>
+                </a:tc>
+              </a:tr>
+              <a:tr h="292608">
+                <a:tc>
+                  <a:txBody>
+                    <a:bodyPr/>
+                    <a:lstStyle/>
+                    <a:p>
+                      <a:pPr algn="l"/>
+                      <a:r>
+                        <a:rPr sz="1000">
+                          <a:solidFill>
+                            <a:srgbClr val="3F3F3F"/>
+                          </a:solidFill>
+                          <a:latin typeface="Encode Sans"/>
+                        </a:rPr>
+                        <a:t>Enero 2026</a:t>
+                      </a:r>
+                    </a:p>
+                  </a:txBody>
+                  <a:tcPr marL="36576" marR="36576" marT="18288" marB="18288">
+                    <a:solidFill>
+                      <a:srgbClr val="FFFFFF"/>
+                    </a:solidFill>
+                  </a:tcPr>
+                </a:tc>
+                <a:tc>
+                  <a:txBody>
+                    <a:bodyPr/>
+                    <a:lstStyle/>
+                    <a:p>
+                      <a:pPr algn="r"/>
+                      <a:r>
+                        <a:rPr sz="1000">
+                          <a:solidFill>
+                            <a:srgbClr val="3F3F3F"/>
+                          </a:solidFill>
+                          <a:latin typeface="Encode Sans"/>
+                        </a:rPr>
+                        <a:t>681.956</a:t>
+                      </a:r>
+                    </a:p>
+                  </a:txBody>
+                  <a:tcPr marL="36576" marR="36576" marT="18288" marB="18288">
+                    <a:solidFill>
+                      <a:srgbClr val="FFFFFF"/>
+                    </a:solidFill>
+                  </a:tcPr>
+                </a:tc>
+                <a:tc>
+                  <a:txBody>
+                    <a:bodyPr/>
+                    <a:lstStyle/>
+                    <a:p>
+                      <a:pPr algn="r"/>
+                      <a:r>
+                        <a:rPr sz="1000">
+                          <a:solidFill>
+                            <a:srgbClr val="3F3F3F"/>
+                          </a:solidFill>
+                          <a:latin typeface="Encode Sans"/>
+                        </a:rPr>
+                        <a:t>1.764.091</a:t>
+                      </a:r>
+                    </a:p>
+                  </a:txBody>
+                  <a:tcPr marL="36576" marR="36576" marT="18288" marB="18288">
+                    <a:solidFill>
+                      <a:srgbClr val="FFFFFF"/>
+                    </a:solidFill>
+                  </a:tcPr>
+                </a:tc>
+                <a:tc>
+                  <a:txBody>
+                    <a:bodyPr/>
+                    <a:lstStyle/>
+                    <a:p>
+                      <a:pPr algn="r"/>
+                      <a:r>
+                        <a:rPr sz="1000">
+                          <a:solidFill>
+                            <a:srgbClr val="3F3F3F"/>
+                          </a:solidFill>
+                          <a:latin typeface="Encode Sans"/>
+                        </a:rPr>
+                        <a:t>-1.082.135</a:t>
+                      </a:r>
+                    </a:p>
+                  </a:txBody>
+                  <a:tcPr marL="36576" marR="36576" marT="18288" marB="18288">
+                    <a:solidFill>
+                      <a:srgbClr val="FFFFFF"/>
+                    </a:solidFill>
+                  </a:tcPr>
+                </a:tc>
+              </a:tr>
+              <a:tr h="292608">
+                <a:tc>
+                  <a:txBody>
+                    <a:bodyPr/>
+                    <a:lstStyle/>
+                    <a:p>
+                      <a:pPr algn="l"/>
+                      <a:r>
+                        <a:rPr sz="1000">
+                          <a:solidFill>
+                            <a:srgbClr val="3F3F3F"/>
+                          </a:solidFill>
+                          <a:latin typeface="Encode Sans"/>
+                        </a:rPr>
+                        <a:t>Diciembre 2025</a:t>
+                      </a:r>
+                    </a:p>
+                  </a:txBody>
+                  <a:tcPr marL="36576" marR="36576" marT="18288" marB="18288">
+                    <a:solidFill>
+                      <a:srgbClr val="F8F8F6"/>
+                    </a:solidFill>
+                  </a:tcPr>
+                </a:tc>
+                <a:tc>
+                  <a:txBody>
+                    <a:bodyPr/>
+                    <a:lstStyle/>
+                    <a:p>
+                      <a:pPr algn="r"/>
+                      <a:r>
+                        <a:rPr sz="1000">
+                          <a:solidFill>
+                            <a:srgbClr val="3F3F3F"/>
+                          </a:solidFill>
+                          <a:latin typeface="Encode Sans"/>
+                        </a:rPr>
+                        <a:t>535.845</a:t>
+                      </a:r>
+                    </a:p>
+                  </a:txBody>
+                  <a:tcPr marL="36576" marR="36576" marT="18288" marB="18288">
+                    <a:solidFill>
+                      <a:srgbClr val="F8F8F6"/>
+                    </a:solidFill>
+                  </a:tcPr>
+                </a:tc>
+                <a:tc>
+                  <a:txBody>
+                    <a:bodyPr/>
+                    <a:lstStyle/>
+                    <a:p>
+                      <a:pPr algn="r"/>
+                      <a:r>
+                        <a:rPr sz="1000">
+                          <a:solidFill>
+                            <a:srgbClr val="3F3F3F"/>
+                          </a:solidFill>
+                          <a:latin typeface="Encode Sans"/>
+                        </a:rPr>
+                        <a:t>705.141</a:t>
+                      </a:r>
+                    </a:p>
+                  </a:txBody>
+                  <a:tcPr marL="36576" marR="36576" marT="18288" marB="18288">
+                    <a:solidFill>
+                      <a:srgbClr val="F8F8F6"/>
+                    </a:solidFill>
+                  </a:tcPr>
+                </a:tc>
+                <a:tc>
+                  <a:txBody>
+                    <a:bodyPr/>
+                    <a:lstStyle/>
+                    <a:p>
+                      <a:pPr algn="r"/>
+                      <a:r>
+                        <a:rPr sz="1000">
+                          <a:solidFill>
+                            <a:srgbClr val="3F3F3F"/>
+                          </a:solidFill>
+                          <a:latin typeface="Encode Sans"/>
+                        </a:rPr>
+                        <a:t>-169.296</a:t>
+                      </a:r>
+                    </a:p>
+                  </a:txBody>
+                  <a:tcPr marL="36576" marR="36576" marT="18288" marB="18288">
+                    <a:solidFill>
+                      <a:srgbClr val="F8F8F6"/>
+                    </a:solidFill>
+                  </a:tcPr>
+                </a:tc>
+              </a:tr>
+            </a:tbl>
+          </a:graphicData>
+        </a:graphic>
+      </p:graphicFrame>
+      <p:sp>
+        <p:nvSpPr>
+          <p:cNvPr id="9" name="TextBox 8"/>
           <p:cNvSpPr txBox="1"/>
           <p:nvPr/>
         </p:nvSpPr>

</xml_diff>

<commit_message>
data: update 2026-06-29 ( data.json despidos.json scraper/historical_despidos.json scraper/calendar_oficial.json publicaciones_semana.pptx rrii_brutas.xlsx)
</commit_message>
<xml_diff>
--- a/publicaciones_semana.pptx
+++ b/publicaciones_semana.pptx
@@ -7,10 +7,6 @@
   <p:sldIdLst>
     <p:sldId id="256" r:id="rId7"/>
     <p:sldId id="257" r:id="rId8"/>
-    <p:sldId id="258" r:id="rId9"/>
-    <p:sldId id="259" r:id="rId10"/>
-    <p:sldId id="260" r:id="rId11"/>
-    <p:sldId id="261" r:id="rId12"/>
   </p:sldIdLst>
   <p:sldSz cx="12191695" cy="6858000" type="screen4x3"/>
   <p:notesSz cx="6858000" cy="9144000"/>
@@ -3242,7 +3238,7 @@
                 </a:solidFill>
                 <a:latin typeface="Encode Sans"/>
               </a:rPr>
-              <a:t>Publicaciones de la semana del 22 de junio de 2026</a:t>
+              <a:t>Publicaciones de la semana del 29 de junio de 2026</a:t>
             </a:r>
           </a:p>
         </p:txBody>
@@ -3276,7 +3272,7 @@
                 </a:solidFill>
                 <a:latin typeface="Encode Sans"/>
               </a:rPr>
-              <a:t>5 publicaciones · datos oficiales INDEC / BCRA / Hacienda</a:t>
+              <a:t>1 publicaciones · datos oficiales INDEC / BCRA / Hacienda</a:t>
             </a:r>
           </a:p>
         </p:txBody>
@@ -3372,7 +3368,7 @@
                 </a:solidFill>
                 <a:latin typeface="Encode Sans"/>
               </a:rPr>
-              <a:t>MERCADO DE TRABAJO 1ER T. 2026: DESOCUPACIÓN 7.8%</a:t>
+              <a:t>EMAE ABRIL 2026: ACTIVIDAD CRECIÓ +1.6% I.A.</a:t>
             </a:r>
           </a:p>
         </p:txBody>
@@ -3406,7 +3402,7 @@
                 </a:solidFill>
                 <a:latin typeface="Encode Sans"/>
               </a:rPr>
-              <a:t>INDEC EPH · período 1er t. 2026</a:t>
+              <a:t>INDEC · período 2026-04</a:t>
             </a:r>
           </a:p>
         </p:txBody>
@@ -3441,7 +3437,7 @@
                 </a:solidFill>
                 <a:latin typeface="Encode Sans"/>
               </a:rPr>
-              <a:t>La tasa de desocupación se ubicó en 7.8% de la PEA en el 1er t. 2026. Tasa de actividad: 48.6%; tasa de empleo: 44.8%. Vs 1er t. 2025: -0.1 pp (7.9%). Cobertura: 31 aglomerados urbanos (EPH-INDEC).</a:t>
+              <a:t>El Estimador Mensual de Actividad Económica (EMAE) registró una variación interanual de +1.6% en abril 2026. En la medición desestacionalizada, el indicador se movió -1.5% respecto al mes anterior.</a:t>
             </a:r>
           </a:p>
         </p:txBody>
@@ -3489,7 +3485,7 @@
                 </a:solidFill>
                 <a:latin typeface="Encode Sans"/>
               </a:rPr>
-              <a:t>Desocupación: 7.8% de la población económicamente activa</a:t>
+              <a:t>Variación interanual: +1.6%</a:t>
             </a:r>
           </a:p>
           <a:p>
@@ -3514,7 +3510,7 @@
                 </a:solidFill>
                 <a:latin typeface="Encode Sans"/>
               </a:rPr>
-              <a:t>Actividad: 48.6% de la población total</a:t>
+              <a:t>Variación mensual desestacionalizada: -1.5%</a:t>
             </a:r>
           </a:p>
           <a:p>
@@ -3539,1064 +3535,7 @@
                 </a:solidFill>
                 <a:latin typeface="Encode Sans"/>
               </a:rPr>
-              <a:t>Empleo: 44.8% de la población total</a:t>
-            </a:r>
-          </a:p>
-          <a:p>
-            <a:pPr algn="l">
-              <a:spcAft>
-                <a:spcPts val="800"/>
-              </a:spcAft>
-            </a:pPr>
-            <a:r>
-              <a:rPr sz="1300" b="1" i="0">
-                <a:solidFill>
-                  <a:srgbClr val="00B2C9"/>
-                </a:solidFill>
-                <a:latin typeface="Encode Sans"/>
-              </a:rPr>
-              <a:t>●  </a:t>
-            </a:r>
-            <a:r>
-              <a:rPr sz="1300" b="0" i="0">
-                <a:solidFill>
-                  <a:srgbClr val="3F3F3F"/>
-                </a:solidFill>
-                <a:latin typeface="Encode Sans"/>
-              </a:rPr>
-              <a:t>Fuente: INDEC, Encuesta Permanente de Hogares (EPH)</a:t>
-            </a:r>
-          </a:p>
-        </p:txBody>
-      </p:sp>
-      <p:pic>
-        <p:nvPicPr>
-          <p:cNvPr id="7" name="Picture 6" descr="image.png"/>
-          <p:cNvPicPr>
-            <a:picLocks noChangeAspect="1"/>
-          </p:cNvPicPr>
-          <p:nvPr/>
-        </p:nvPicPr>
-        <p:blipFill>
-          <a:blip r:embed="rId2"/>
-          <a:stretch>
-            <a:fillRect/>
-          </a:stretch>
-        </p:blipFill>
-        <p:spPr>
-          <a:xfrm>
-            <a:off x="6080760" y="1691640"/>
-            <a:ext cx="5669280" cy="2560320"/>
-          </a:xfrm>
-          <a:prstGeom prst="rect">
-            <a:avLst/>
-          </a:prstGeom>
-        </p:spPr>
-      </p:pic>
-      <p:graphicFrame>
-        <p:nvGraphicFramePr>
-          <p:cNvPr id="8" name="Table 7"/>
-          <p:cNvGraphicFramePr>
-            <a:graphicFrameLocks noGrp="1"/>
-          </p:cNvGraphicFramePr>
-          <p:nvPr/>
-        </p:nvGraphicFramePr>
-        <p:xfrm>
-          <a:off x="6080760" y="4434840"/>
-          <a:ext cx="5669280" cy="2048256"/>
-        </p:xfrm>
-        <a:graphic>
-          <a:graphicData uri="http://schemas.openxmlformats.org/drawingml/2006/table">
-            <a:tbl>
-              <a:tblPr firstRow="1" bandRow="1">
-                <a:tableStyleId>{5C22544A-7EE6-4342-B048-85BDC9FD1C3A}</a:tableStyleId>
-              </a:tblPr>
-              <a:tblGrid>
-                <a:gridCol w="1417320"/>
-                <a:gridCol w="1417320"/>
-                <a:gridCol w="1417320"/>
-                <a:gridCol w="1417320"/>
-              </a:tblGrid>
-              <a:tr h="292608">
-                <a:tc>
-                  <a:txBody>
-                    <a:bodyPr/>
-                    <a:lstStyle/>
-                    <a:p>
-                      <a:pPr algn="l"/>
-                      <a:r>
-                        <a:rPr sz="1000" b="1">
-                          <a:solidFill>
-                            <a:srgbClr val="FFFFFF"/>
-                          </a:solidFill>
-                          <a:latin typeface="Encode Sans"/>
-                        </a:rPr>
-                        <a:t>Trimestre</a:t>
-                      </a:r>
-                    </a:p>
-                  </a:txBody>
-                  <a:tcPr marL="36576" marR="36576" marT="18288" marB="18288">
-                    <a:solidFill>
-                      <a:srgbClr val="00B2C9"/>
-                    </a:solidFill>
-                  </a:tcPr>
-                </a:tc>
-                <a:tc>
-                  <a:txBody>
-                    <a:bodyPr/>
-                    <a:lstStyle/>
-                    <a:p>
-                      <a:pPr algn="r"/>
-                      <a:r>
-                        <a:rPr sz="1000" b="1">
-                          <a:solidFill>
-                            <a:srgbClr val="FFFFFF"/>
-                          </a:solidFill>
-                          <a:latin typeface="Encode Sans"/>
-                        </a:rPr>
-                        <a:t>Desoc. %</a:t>
-                      </a:r>
-                    </a:p>
-                  </a:txBody>
-                  <a:tcPr marL="36576" marR="36576" marT="18288" marB="18288">
-                    <a:solidFill>
-                      <a:srgbClr val="00B2C9"/>
-                    </a:solidFill>
-                  </a:tcPr>
-                </a:tc>
-                <a:tc>
-                  <a:txBody>
-                    <a:bodyPr/>
-                    <a:lstStyle/>
-                    <a:p>
-                      <a:pPr algn="r"/>
-                      <a:r>
-                        <a:rPr sz="1000" b="1">
-                          <a:solidFill>
-                            <a:srgbClr val="FFFFFF"/>
-                          </a:solidFill>
-                          <a:latin typeface="Encode Sans"/>
-                        </a:rPr>
-                        <a:t>Activ. %</a:t>
-                      </a:r>
-                    </a:p>
-                  </a:txBody>
-                  <a:tcPr marL="36576" marR="36576" marT="18288" marB="18288">
-                    <a:solidFill>
-                      <a:srgbClr val="00B2C9"/>
-                    </a:solidFill>
-                  </a:tcPr>
-                </a:tc>
-                <a:tc>
-                  <a:txBody>
-                    <a:bodyPr/>
-                    <a:lstStyle/>
-                    <a:p>
-                      <a:pPr algn="r"/>
-                      <a:r>
-                        <a:rPr sz="1000" b="1">
-                          <a:solidFill>
-                            <a:srgbClr val="FFFFFF"/>
-                          </a:solidFill>
-                          <a:latin typeface="Encode Sans"/>
-                        </a:rPr>
-                        <a:t>Empleo %</a:t>
-                      </a:r>
-                    </a:p>
-                  </a:txBody>
-                  <a:tcPr marL="36576" marR="36576" marT="18288" marB="18288">
-                    <a:solidFill>
-                      <a:srgbClr val="00B2C9"/>
-                    </a:solidFill>
-                  </a:tcPr>
-                </a:tc>
-              </a:tr>
-              <a:tr h="292608">
-                <a:tc>
-                  <a:txBody>
-                    <a:bodyPr/>
-                    <a:lstStyle/>
-                    <a:p>
-                      <a:pPr algn="l"/>
-                      <a:r>
-                        <a:rPr sz="1000">
-                          <a:solidFill>
-                            <a:srgbClr val="3F3F3F"/>
-                          </a:solidFill>
-                          <a:latin typeface="Encode Sans"/>
-                        </a:rPr>
-                        <a:t>1er t. 2026</a:t>
-                      </a:r>
-                    </a:p>
-                  </a:txBody>
-                  <a:tcPr marL="36576" marR="36576" marT="18288" marB="18288">
-                    <a:solidFill>
-                      <a:srgbClr val="FFFFFF"/>
-                    </a:solidFill>
-                  </a:tcPr>
-                </a:tc>
-                <a:tc>
-                  <a:txBody>
-                    <a:bodyPr/>
-                    <a:lstStyle/>
-                    <a:p>
-                      <a:pPr algn="r"/>
-                      <a:r>
-                        <a:rPr sz="1000">
-                          <a:solidFill>
-                            <a:srgbClr val="3F3F3F"/>
-                          </a:solidFill>
-                          <a:latin typeface="Encode Sans"/>
-                        </a:rPr>
-                        <a:t>7.8%</a:t>
-                      </a:r>
-                    </a:p>
-                  </a:txBody>
-                  <a:tcPr marL="36576" marR="36576" marT="18288" marB="18288">
-                    <a:solidFill>
-                      <a:srgbClr val="FFFFFF"/>
-                    </a:solidFill>
-                  </a:tcPr>
-                </a:tc>
-                <a:tc>
-                  <a:txBody>
-                    <a:bodyPr/>
-                    <a:lstStyle/>
-                    <a:p>
-                      <a:pPr algn="r"/>
-                      <a:r>
-                        <a:rPr sz="1000">
-                          <a:solidFill>
-                            <a:srgbClr val="3F3F3F"/>
-                          </a:solidFill>
-                          <a:latin typeface="Encode Sans"/>
-                        </a:rPr>
-                        <a:t>48.6%</a:t>
-                      </a:r>
-                    </a:p>
-                  </a:txBody>
-                  <a:tcPr marL="36576" marR="36576" marT="18288" marB="18288">
-                    <a:solidFill>
-                      <a:srgbClr val="FFFFFF"/>
-                    </a:solidFill>
-                  </a:tcPr>
-                </a:tc>
-                <a:tc>
-                  <a:txBody>
-                    <a:bodyPr/>
-                    <a:lstStyle/>
-                    <a:p>
-                      <a:pPr algn="r"/>
-                      <a:r>
-                        <a:rPr sz="1000">
-                          <a:solidFill>
-                            <a:srgbClr val="3F3F3F"/>
-                          </a:solidFill>
-                          <a:latin typeface="Encode Sans"/>
-                        </a:rPr>
-                        <a:t>44.8%</a:t>
-                      </a:r>
-                    </a:p>
-                  </a:txBody>
-                  <a:tcPr marL="36576" marR="36576" marT="18288" marB="18288">
-                    <a:solidFill>
-                      <a:srgbClr val="FFFFFF"/>
-                    </a:solidFill>
-                  </a:tcPr>
-                </a:tc>
-              </a:tr>
-              <a:tr h="292608">
-                <a:tc>
-                  <a:txBody>
-                    <a:bodyPr/>
-                    <a:lstStyle/>
-                    <a:p>
-                      <a:pPr algn="l"/>
-                      <a:r>
-                        <a:rPr sz="1000">
-                          <a:solidFill>
-                            <a:srgbClr val="3F3F3F"/>
-                          </a:solidFill>
-                          <a:latin typeface="Encode Sans"/>
-                        </a:rPr>
-                        <a:t>4to t. 2025</a:t>
-                      </a:r>
-                    </a:p>
-                  </a:txBody>
-                  <a:tcPr marL="36576" marR="36576" marT="18288" marB="18288">
-                    <a:solidFill>
-                      <a:srgbClr val="F8F8F6"/>
-                    </a:solidFill>
-                  </a:tcPr>
-                </a:tc>
-                <a:tc>
-                  <a:txBody>
-                    <a:bodyPr/>
-                    <a:lstStyle/>
-                    <a:p>
-                      <a:pPr algn="r"/>
-                      <a:r>
-                        <a:rPr sz="1000">
-                          <a:solidFill>
-                            <a:srgbClr val="3F3F3F"/>
-                          </a:solidFill>
-                          <a:latin typeface="Encode Sans"/>
-                        </a:rPr>
-                        <a:t>7.5%</a:t>
-                      </a:r>
-                    </a:p>
-                  </a:txBody>
-                  <a:tcPr marL="36576" marR="36576" marT="18288" marB="18288">
-                    <a:solidFill>
-                      <a:srgbClr val="F8F8F6"/>
-                    </a:solidFill>
-                  </a:tcPr>
-                </a:tc>
-                <a:tc>
-                  <a:txBody>
-                    <a:bodyPr/>
-                    <a:lstStyle/>
-                    <a:p>
-                      <a:pPr algn="r"/>
-                      <a:r>
-                        <a:rPr sz="1000">
-                          <a:solidFill>
-                            <a:srgbClr val="3F3F3F"/>
-                          </a:solidFill>
-                          <a:latin typeface="Encode Sans"/>
-                        </a:rPr>
-                        <a:t>48.6%</a:t>
-                      </a:r>
-                    </a:p>
-                  </a:txBody>
-                  <a:tcPr marL="36576" marR="36576" marT="18288" marB="18288">
-                    <a:solidFill>
-                      <a:srgbClr val="F8F8F6"/>
-                    </a:solidFill>
-                  </a:tcPr>
-                </a:tc>
-                <a:tc>
-                  <a:txBody>
-                    <a:bodyPr/>
-                    <a:lstStyle/>
-                    <a:p>
-                      <a:pPr algn="r"/>
-                      <a:r>
-                        <a:rPr sz="1000">
-                          <a:solidFill>
-                            <a:srgbClr val="3F3F3F"/>
-                          </a:solidFill>
-                          <a:latin typeface="Encode Sans"/>
-                        </a:rPr>
-                        <a:t>45.0%</a:t>
-                      </a:r>
-                    </a:p>
-                  </a:txBody>
-                  <a:tcPr marL="36576" marR="36576" marT="18288" marB="18288">
-                    <a:solidFill>
-                      <a:srgbClr val="F8F8F6"/>
-                    </a:solidFill>
-                  </a:tcPr>
-                </a:tc>
-              </a:tr>
-              <a:tr h="292608">
-                <a:tc>
-                  <a:txBody>
-                    <a:bodyPr/>
-                    <a:lstStyle/>
-                    <a:p>
-                      <a:pPr algn="l"/>
-                      <a:r>
-                        <a:rPr sz="1000">
-                          <a:solidFill>
-                            <a:srgbClr val="3F3F3F"/>
-                          </a:solidFill>
-                          <a:latin typeface="Encode Sans"/>
-                        </a:rPr>
-                        <a:t>3er t. 2025</a:t>
-                      </a:r>
-                    </a:p>
-                  </a:txBody>
-                  <a:tcPr marL="36576" marR="36576" marT="18288" marB="18288">
-                    <a:solidFill>
-                      <a:srgbClr val="FFFFFF"/>
-                    </a:solidFill>
-                  </a:tcPr>
-                </a:tc>
-                <a:tc>
-                  <a:txBody>
-                    <a:bodyPr/>
-                    <a:lstStyle/>
-                    <a:p>
-                      <a:pPr algn="r"/>
-                      <a:r>
-                        <a:rPr sz="1000">
-                          <a:solidFill>
-                            <a:srgbClr val="3F3F3F"/>
-                          </a:solidFill>
-                          <a:latin typeface="Encode Sans"/>
-                        </a:rPr>
-                        <a:t>6.6%</a:t>
-                      </a:r>
-                    </a:p>
-                  </a:txBody>
-                  <a:tcPr marL="36576" marR="36576" marT="18288" marB="18288">
-                    <a:solidFill>
-                      <a:srgbClr val="FFFFFF"/>
-                    </a:solidFill>
-                  </a:tcPr>
-                </a:tc>
-                <a:tc>
-                  <a:txBody>
-                    <a:bodyPr/>
-                    <a:lstStyle/>
-                    <a:p>
-                      <a:pPr algn="r"/>
-                      <a:r>
-                        <a:rPr sz="1000">
-                          <a:solidFill>
-                            <a:srgbClr val="3F3F3F"/>
-                          </a:solidFill>
-                          <a:latin typeface="Encode Sans"/>
-                        </a:rPr>
-                        <a:t>48.6%</a:t>
-                      </a:r>
-                    </a:p>
-                  </a:txBody>
-                  <a:tcPr marL="36576" marR="36576" marT="18288" marB="18288">
-                    <a:solidFill>
-                      <a:srgbClr val="FFFFFF"/>
-                    </a:solidFill>
-                  </a:tcPr>
-                </a:tc>
-                <a:tc>
-                  <a:txBody>
-                    <a:bodyPr/>
-                    <a:lstStyle/>
-                    <a:p>
-                      <a:pPr algn="r"/>
-                      <a:r>
-                        <a:rPr sz="1000">
-                          <a:solidFill>
-                            <a:srgbClr val="3F3F3F"/>
-                          </a:solidFill>
-                          <a:latin typeface="Encode Sans"/>
-                        </a:rPr>
-                        <a:t>45.4%</a:t>
-                      </a:r>
-                    </a:p>
-                  </a:txBody>
-                  <a:tcPr marL="36576" marR="36576" marT="18288" marB="18288">
-                    <a:solidFill>
-                      <a:srgbClr val="FFFFFF"/>
-                    </a:solidFill>
-                  </a:tcPr>
-                </a:tc>
-              </a:tr>
-              <a:tr h="292608">
-                <a:tc>
-                  <a:txBody>
-                    <a:bodyPr/>
-                    <a:lstStyle/>
-                    <a:p>
-                      <a:pPr algn="l"/>
-                      <a:r>
-                        <a:rPr sz="1000">
-                          <a:solidFill>
-                            <a:srgbClr val="3F3F3F"/>
-                          </a:solidFill>
-                          <a:latin typeface="Encode Sans"/>
-                        </a:rPr>
-                        <a:t>2do t. 2025</a:t>
-                      </a:r>
-                    </a:p>
-                  </a:txBody>
-                  <a:tcPr marL="36576" marR="36576" marT="18288" marB="18288">
-                    <a:solidFill>
-                      <a:srgbClr val="F8F8F6"/>
-                    </a:solidFill>
-                  </a:tcPr>
-                </a:tc>
-                <a:tc>
-                  <a:txBody>
-                    <a:bodyPr/>
-                    <a:lstStyle/>
-                    <a:p>
-                      <a:pPr algn="r"/>
-                      <a:r>
-                        <a:rPr sz="1000">
-                          <a:solidFill>
-                            <a:srgbClr val="3F3F3F"/>
-                          </a:solidFill>
-                          <a:latin typeface="Encode Sans"/>
-                        </a:rPr>
-                        <a:t>7.6%</a:t>
-                      </a:r>
-                    </a:p>
-                  </a:txBody>
-                  <a:tcPr marL="36576" marR="36576" marT="18288" marB="18288">
-                    <a:solidFill>
-                      <a:srgbClr val="F8F8F6"/>
-                    </a:solidFill>
-                  </a:tcPr>
-                </a:tc>
-                <a:tc>
-                  <a:txBody>
-                    <a:bodyPr/>
-                    <a:lstStyle/>
-                    <a:p>
-                      <a:pPr algn="r"/>
-                      <a:r>
-                        <a:rPr sz="1000">
-                          <a:solidFill>
-                            <a:srgbClr val="3F3F3F"/>
-                          </a:solidFill>
-                          <a:latin typeface="Encode Sans"/>
-                        </a:rPr>
-                        <a:t>48.1%</a:t>
-                      </a:r>
-                    </a:p>
-                  </a:txBody>
-                  <a:tcPr marL="36576" marR="36576" marT="18288" marB="18288">
-                    <a:solidFill>
-                      <a:srgbClr val="F8F8F6"/>
-                    </a:solidFill>
-                  </a:tcPr>
-                </a:tc>
-                <a:tc>
-                  <a:txBody>
-                    <a:bodyPr/>
-                    <a:lstStyle/>
-                    <a:p>
-                      <a:pPr algn="r"/>
-                      <a:r>
-                        <a:rPr sz="1000">
-                          <a:solidFill>
-                            <a:srgbClr val="3F3F3F"/>
-                          </a:solidFill>
-                          <a:latin typeface="Encode Sans"/>
-                        </a:rPr>
-                        <a:t>44.5%</a:t>
-                      </a:r>
-                    </a:p>
-                  </a:txBody>
-                  <a:tcPr marL="36576" marR="36576" marT="18288" marB="18288">
-                    <a:solidFill>
-                      <a:srgbClr val="F8F8F6"/>
-                    </a:solidFill>
-                  </a:tcPr>
-                </a:tc>
-              </a:tr>
-              <a:tr h="292608">
-                <a:tc>
-                  <a:txBody>
-                    <a:bodyPr/>
-                    <a:lstStyle/>
-                    <a:p>
-                      <a:pPr algn="l"/>
-                      <a:r>
-                        <a:rPr sz="1000">
-                          <a:solidFill>
-                            <a:srgbClr val="3F3F3F"/>
-                          </a:solidFill>
-                          <a:latin typeface="Encode Sans"/>
-                        </a:rPr>
-                        <a:t>1er t. 2025</a:t>
-                      </a:r>
-                    </a:p>
-                  </a:txBody>
-                  <a:tcPr marL="36576" marR="36576" marT="18288" marB="18288">
-                    <a:solidFill>
-                      <a:srgbClr val="FFFFFF"/>
-                    </a:solidFill>
-                  </a:tcPr>
-                </a:tc>
-                <a:tc>
-                  <a:txBody>
-                    <a:bodyPr/>
-                    <a:lstStyle/>
-                    <a:p>
-                      <a:pPr algn="r"/>
-                      <a:r>
-                        <a:rPr sz="1000">
-                          <a:solidFill>
-                            <a:srgbClr val="3F3F3F"/>
-                          </a:solidFill>
-                          <a:latin typeface="Encode Sans"/>
-                        </a:rPr>
-                        <a:t>7.9%</a:t>
-                      </a:r>
-                    </a:p>
-                  </a:txBody>
-                  <a:tcPr marL="36576" marR="36576" marT="18288" marB="18288">
-                    <a:solidFill>
-                      <a:srgbClr val="FFFFFF"/>
-                    </a:solidFill>
-                  </a:tcPr>
-                </a:tc>
-                <a:tc>
-                  <a:txBody>
-                    <a:bodyPr/>
-                    <a:lstStyle/>
-                    <a:p>
-                      <a:pPr algn="r"/>
-                      <a:r>
-                        <a:rPr sz="1000">
-                          <a:solidFill>
-                            <a:srgbClr val="3F3F3F"/>
-                          </a:solidFill>
-                          <a:latin typeface="Encode Sans"/>
-                        </a:rPr>
-                        <a:t>48.2%</a:t>
-                      </a:r>
-                    </a:p>
-                  </a:txBody>
-                  <a:tcPr marL="36576" marR="36576" marT="18288" marB="18288">
-                    <a:solidFill>
-                      <a:srgbClr val="FFFFFF"/>
-                    </a:solidFill>
-                  </a:tcPr>
-                </a:tc>
-                <a:tc>
-                  <a:txBody>
-                    <a:bodyPr/>
-                    <a:lstStyle/>
-                    <a:p>
-                      <a:pPr algn="r"/>
-                      <a:r>
-                        <a:rPr sz="1000">
-                          <a:solidFill>
-                            <a:srgbClr val="3F3F3F"/>
-                          </a:solidFill>
-                          <a:latin typeface="Encode Sans"/>
-                        </a:rPr>
-                        <a:t>44.4%</a:t>
-                      </a:r>
-                    </a:p>
-                  </a:txBody>
-                  <a:tcPr marL="36576" marR="36576" marT="18288" marB="18288">
-                    <a:solidFill>
-                      <a:srgbClr val="FFFFFF"/>
-                    </a:solidFill>
-                  </a:tcPr>
-                </a:tc>
-              </a:tr>
-              <a:tr h="292608">
-                <a:tc>
-                  <a:txBody>
-                    <a:bodyPr/>
-                    <a:lstStyle/>
-                    <a:p>
-                      <a:pPr algn="l"/>
-                      <a:r>
-                        <a:rPr sz="1000">
-                          <a:solidFill>
-                            <a:srgbClr val="3F3F3F"/>
-                          </a:solidFill>
-                          <a:latin typeface="Encode Sans"/>
-                        </a:rPr>
-                        <a:t>4to t. 2024</a:t>
-                      </a:r>
-                    </a:p>
-                  </a:txBody>
-                  <a:tcPr marL="36576" marR="36576" marT="18288" marB="18288">
-                    <a:solidFill>
-                      <a:srgbClr val="F8F8F6"/>
-                    </a:solidFill>
-                  </a:tcPr>
-                </a:tc>
-                <a:tc>
-                  <a:txBody>
-                    <a:bodyPr/>
-                    <a:lstStyle/>
-                    <a:p>
-                      <a:pPr algn="r"/>
-                      <a:r>
-                        <a:rPr sz="1000">
-                          <a:solidFill>
-                            <a:srgbClr val="3F3F3F"/>
-                          </a:solidFill>
-                          <a:latin typeface="Encode Sans"/>
-                        </a:rPr>
-                        <a:t>6.4%</a:t>
-                      </a:r>
-                    </a:p>
-                  </a:txBody>
-                  <a:tcPr marL="36576" marR="36576" marT="18288" marB="18288">
-                    <a:solidFill>
-                      <a:srgbClr val="F8F8F6"/>
-                    </a:solidFill>
-                  </a:tcPr>
-                </a:tc>
-                <a:tc>
-                  <a:txBody>
-                    <a:bodyPr/>
-                    <a:lstStyle/>
-                    <a:p>
-                      <a:pPr algn="r"/>
-                      <a:r>
-                        <a:rPr sz="1000">
-                          <a:solidFill>
-                            <a:srgbClr val="3F3F3F"/>
-                          </a:solidFill>
-                          <a:latin typeface="Encode Sans"/>
-                        </a:rPr>
-                        <a:t>48.8%</a:t>
-                      </a:r>
-                    </a:p>
-                  </a:txBody>
-                  <a:tcPr marL="36576" marR="36576" marT="18288" marB="18288">
-                    <a:solidFill>
-                      <a:srgbClr val="F8F8F6"/>
-                    </a:solidFill>
-                  </a:tcPr>
-                </a:tc>
-                <a:tc>
-                  <a:txBody>
-                    <a:bodyPr/>
-                    <a:lstStyle/>
-                    <a:p>
-                      <a:pPr algn="r"/>
-                      <a:r>
-                        <a:rPr sz="1000">
-                          <a:solidFill>
-                            <a:srgbClr val="3F3F3F"/>
-                          </a:solidFill>
-                          <a:latin typeface="Encode Sans"/>
-                        </a:rPr>
-                        <a:t>45.7%</a:t>
-                      </a:r>
-                    </a:p>
-                  </a:txBody>
-                  <a:tcPr marL="36576" marR="36576" marT="18288" marB="18288">
-                    <a:solidFill>
-                      <a:srgbClr val="F8F8F6"/>
-                    </a:solidFill>
-                  </a:tcPr>
-                </a:tc>
-              </a:tr>
-            </a:tbl>
-          </a:graphicData>
-        </a:graphic>
-      </p:graphicFrame>
-      <p:sp>
-        <p:nvSpPr>
-          <p:cNvPr id="9" name="TextBox 8"/>
-          <p:cNvSpPr txBox="1"/>
-          <p:nvPr/>
-        </p:nvSpPr>
-        <p:spPr>
-          <a:xfrm>
-            <a:off x="411480" y="6492240"/>
-            <a:ext cx="11368735" cy="274320"/>
-          </a:xfrm>
-          <a:prstGeom prst="rect">
-            <a:avLst/>
-          </a:prstGeom>
-          <a:noFill/>
-        </p:spPr>
-        <p:txBody>
-          <a:bodyPr wrap="none">
-            <a:spAutoFit/>
-          </a:bodyPr>
-          <a:lstStyle/>
-          <a:p>
-            <a:r>
-              <a:rPr sz="1000" b="0" i="1">
-                <a:solidFill>
-                  <a:srgbClr val="6A6760"/>
-                </a:solidFill>
-                <a:latin typeface="Encode Sans"/>
-              </a:rPr>
-              <a:t>Fuente: elaboración propia en base a INDEC EPH</a:t>
-            </a:r>
-          </a:p>
-        </p:txBody>
-      </p:sp>
-    </p:spTree>
-  </p:cSld>
-  <p:clrMapOvr>
-    <a:masterClrMapping/>
-  </p:clrMapOvr>
-</p:sld>
-</file>
-
-<file path=ppt/slides/slide3.xml><?xml version="1.0" encoding="utf-8"?>
-<p:sld xmlns:a="http://schemas.openxmlformats.org/drawingml/2006/main" xmlns:p="http://schemas.openxmlformats.org/presentationml/2006/main" xmlns:r="http://schemas.openxmlformats.org/officeDocument/2006/relationships">
-  <p:cSld>
-    <p:spTree>
-      <p:nvGrpSpPr>
-        <p:cNvPr id="1" name=""/>
-        <p:cNvGrpSpPr/>
-        <p:nvPr/>
-      </p:nvGrpSpPr>
-      <p:grpSpPr/>
-      <p:sp>
-        <p:nvSpPr>
-          <p:cNvPr id="2" name="Rectangle 1"/>
-          <p:cNvSpPr/>
-          <p:nvPr/>
-        </p:nvSpPr>
-        <p:spPr>
-          <a:xfrm>
-            <a:off x="0" y="0"/>
-            <a:ext cx="12191695" cy="274320"/>
-          </a:xfrm>
-          <a:prstGeom prst="rect">
-            <a:avLst/>
-          </a:prstGeom>
-          <a:solidFill>
-            <a:srgbClr val="00B2C9"/>
-          </a:solidFill>
-          <a:ln>
-            <a:noFill/>
-          </a:ln>
-        </p:spPr>
-        <p:style>
-          <a:lnRef idx="1">
-            <a:schemeClr val="accent1"/>
-          </a:lnRef>
-          <a:fillRef idx="3">
-            <a:schemeClr val="accent1"/>
-          </a:fillRef>
-          <a:effectRef idx="2">
-            <a:schemeClr val="accent1"/>
-          </a:effectRef>
-          <a:fontRef idx="minor">
-            <a:schemeClr val="lt1"/>
-          </a:fontRef>
-        </p:style>
-        <p:txBody>
-          <a:bodyPr rtlCol="0" anchor="ctr"/>
-          <a:lstStyle/>
-          <a:p>
-            <a:pPr algn="ctr"/>
-          </a:p>
-        </p:txBody>
-      </p:sp>
-      <p:sp>
-        <p:nvSpPr>
-          <p:cNvPr id="3" name="TextBox 2"/>
-          <p:cNvSpPr txBox="1"/>
-          <p:nvPr/>
-        </p:nvSpPr>
-        <p:spPr>
-          <a:xfrm>
-            <a:off x="411480" y="457200"/>
-            <a:ext cx="11368735" cy="914400"/>
-          </a:xfrm>
-          <a:prstGeom prst="rect">
-            <a:avLst/>
-          </a:prstGeom>
-          <a:noFill/>
-        </p:spPr>
-        <p:txBody>
-          <a:bodyPr wrap="square" lIns="0" rIns="0">
-            <a:spAutoFit/>
-          </a:bodyPr>
-          <a:lstStyle/>
-          <a:p>
-            <a:pPr algn="l"/>
-            <a:r>
-              <a:rPr sz="2600" b="1" i="0">
-                <a:solidFill>
-                  <a:srgbClr val="00B2C9"/>
-                </a:solidFill>
-                <a:latin typeface="Encode Sans"/>
-              </a:rPr>
-              <a:t>SALARIOS ABRIL 2026: ÍNDICE TOTAL REGISTRADO 8.629</a:t>
-            </a:r>
-          </a:p>
-        </p:txBody>
-      </p:sp>
-      <p:sp>
-        <p:nvSpPr>
-          <p:cNvPr id="4" name="TextBox 3"/>
-          <p:cNvSpPr txBox="1"/>
-          <p:nvPr/>
-        </p:nvSpPr>
-        <p:spPr>
-          <a:xfrm>
-            <a:off x="411480" y="1280160"/>
-            <a:ext cx="11368735" cy="274320"/>
-          </a:xfrm>
-          <a:prstGeom prst="rect">
-            <a:avLst/>
-          </a:prstGeom>
-          <a:noFill/>
-        </p:spPr>
-        <p:txBody>
-          <a:bodyPr wrap="none">
-            <a:spAutoFit/>
-          </a:bodyPr>
-          <a:lstStyle/>
-          <a:p>
-            <a:r>
-              <a:rPr sz="1100" b="0" i="1">
-                <a:solidFill>
-                  <a:srgbClr val="6A6760"/>
-                </a:solidFill>
-                <a:latin typeface="Encode Sans"/>
-              </a:rPr>
-              <a:t>INDEC · período 2026-04</a:t>
-            </a:r>
-          </a:p>
-        </p:txBody>
-      </p:sp>
-      <p:sp>
-        <p:nvSpPr>
-          <p:cNvPr id="5" name="TextBox 4"/>
-          <p:cNvSpPr txBox="1"/>
-          <p:nvPr/>
-        </p:nvSpPr>
-        <p:spPr>
-          <a:xfrm>
-            <a:off x="411480" y="1691640"/>
-            <a:ext cx="5486400" cy="1645920"/>
-          </a:xfrm>
-          <a:prstGeom prst="rect">
-            <a:avLst/>
-          </a:prstGeom>
-          <a:noFill/>
-        </p:spPr>
-        <p:txBody>
-          <a:bodyPr wrap="square" lIns="0" rIns="0">
-            <a:spAutoFit/>
-          </a:bodyPr>
-          <a:lstStyle/>
-          <a:p>
-            <a:pPr algn="just"/>
-            <a:r>
-              <a:rPr sz="1300" b="0" i="0">
-                <a:solidFill>
-                  <a:srgbClr val="3F3F3F"/>
-                </a:solidFill>
-                <a:latin typeface="Encode Sans"/>
-              </a:rPr>
-              <a:t>El Índice de Salarios INDEC alcanzó 8.629 para el sector registrado en abril 2026. Privado registrado: 9.293. Público: 7.515.</a:t>
-            </a:r>
-          </a:p>
-        </p:txBody>
-      </p:sp>
-      <p:sp>
-        <p:nvSpPr>
-          <p:cNvPr id="6" name="TextBox 5"/>
-          <p:cNvSpPr txBox="1"/>
-          <p:nvPr/>
-        </p:nvSpPr>
-        <p:spPr>
-          <a:xfrm>
-            <a:off x="411480" y="3520440"/>
-            <a:ext cx="5486400" cy="2743200"/>
-          </a:xfrm>
-          <a:prstGeom prst="rect">
-            <a:avLst/>
-          </a:prstGeom>
-          <a:noFill/>
-        </p:spPr>
-        <p:txBody>
-          <a:bodyPr wrap="square" lIns="0" rIns="0">
-            <a:spAutoFit/>
-          </a:bodyPr>
-          <a:lstStyle/>
-          <a:p>
-            <a:pPr algn="l">
-              <a:spcAft>
-                <a:spcPts val="800"/>
-              </a:spcAft>
-            </a:pPr>
-            <a:r>
-              <a:rPr sz="1300" b="1" i="0">
-                <a:solidFill>
-                  <a:srgbClr val="00B2C9"/>
-                </a:solidFill>
-                <a:latin typeface="Encode Sans"/>
-              </a:rPr>
-              <a:t>●  </a:t>
-            </a:r>
-            <a:r>
-              <a:rPr sz="1300" b="0" i="0">
-                <a:solidFill>
-                  <a:srgbClr val="3F3F3F"/>
-                </a:solidFill>
-                <a:latin typeface="Encode Sans"/>
-              </a:rPr>
-              <a:t>Total registrado: 8.629</a:t>
-            </a:r>
-          </a:p>
-          <a:p>
-            <a:pPr algn="l">
-              <a:spcAft>
-                <a:spcPts val="800"/>
-              </a:spcAft>
-            </a:pPr>
-            <a:r>
-              <a:rPr sz="1300" b="1" i="0">
-                <a:solidFill>
-                  <a:srgbClr val="00B2C9"/>
-                </a:solidFill>
-                <a:latin typeface="Encode Sans"/>
-              </a:rPr>
-              <a:t>●  </a:t>
-            </a:r>
-            <a:r>
-              <a:rPr sz="1300" b="0" i="0">
-                <a:solidFill>
-                  <a:srgbClr val="3F3F3F"/>
-                </a:solidFill>
-                <a:latin typeface="Encode Sans"/>
-              </a:rPr>
-              <a:t>Privado registrado: 9.293</a:t>
-            </a:r>
-          </a:p>
-          <a:p>
-            <a:pPr algn="l">
-              <a:spcAft>
-                <a:spcPts val="800"/>
-              </a:spcAft>
-            </a:pPr>
-            <a:r>
-              <a:rPr sz="1300" b="1" i="0">
-                <a:solidFill>
-                  <a:srgbClr val="00B2C9"/>
-                </a:solidFill>
-                <a:latin typeface="Encode Sans"/>
-              </a:rPr>
-              <a:t>●  </a:t>
-            </a:r>
-            <a:r>
-              <a:rPr sz="1300" b="0" i="0">
-                <a:solidFill>
-                  <a:srgbClr val="3F3F3F"/>
-                </a:solidFill>
-                <a:latin typeface="Encode Sans"/>
-              </a:rPr>
-              <a:t>Sector público: 7.515</a:t>
-            </a:r>
-          </a:p>
-          <a:p>
-            <a:pPr algn="l">
-              <a:spcAft>
-                <a:spcPts val="800"/>
-              </a:spcAft>
-            </a:pPr>
-            <a:r>
-              <a:rPr sz="1300" b="1" i="0">
-                <a:solidFill>
-                  <a:srgbClr val="00B2C9"/>
-                </a:solidFill>
-                <a:latin typeface="Encode Sans"/>
-              </a:rPr>
-              <a:t>●  </a:t>
-            </a:r>
-            <a:r>
-              <a:rPr sz="1300" b="0" i="0">
-                <a:solidFill>
-                  <a:srgbClr val="3F3F3F"/>
-                </a:solidFill>
-                <a:latin typeface="Encode Sans"/>
-              </a:rPr>
-              <a:t>No registrado: 10.381</a:t>
+              <a:t>Serie INDEC, base 2004=100. Mide el nivel general de actividad.</a:t>
             </a:r>
           </a:p>
         </p:txBody>
@@ -4686,7 +3625,7 @@
                           </a:solidFill>
                           <a:latin typeface="Encode Sans"/>
                         </a:rPr>
-                        <a:t>Total reg.</a:t>
+                        <a:t>Original</a:t>
                       </a:r>
                     </a:p>
                   </a:txBody>
@@ -4709,7 +3648,7 @@
                           </a:solidFill>
                           <a:latin typeface="Encode Sans"/>
                         </a:rPr>
-                        <a:t>Privado</a:t>
+                        <a:t>VIA %</a:t>
                       </a:r>
                     </a:p>
                   </a:txBody>
@@ -4732,7 +3671,7 @@
                           </a:solidFill>
                           <a:latin typeface="Encode Sans"/>
                         </a:rPr>
-                        <a:t>Público</a:t>
+                        <a:t>Desest.</a:t>
                       </a:r>
                     </a:p>
                   </a:txBody>
@@ -4780,7 +3719,7 @@
                           </a:solidFill>
                           <a:latin typeface="Encode Sans"/>
                         </a:rPr>
-                        <a:t>8.629</a:t>
+                        <a:t>161,5</a:t>
                       </a:r>
                     </a:p>
                   </a:txBody>
@@ -4803,7 +3742,7 @@
                           </a:solidFill>
                           <a:latin typeface="Encode Sans"/>
                         </a:rPr>
-                        <a:t>9.293</a:t>
+                        <a:t>+1.6%</a:t>
                       </a:r>
                     </a:p>
                   </a:txBody>
@@ -4826,7 +3765,7 @@
                           </a:solidFill>
                           <a:latin typeface="Encode Sans"/>
                         </a:rPr>
-                        <a:t>7.515</a:t>
+                        <a:t>154,5</a:t>
                       </a:r>
                     </a:p>
                   </a:txBody>
@@ -4874,7 +3813,7 @@
                           </a:solidFill>
                           <a:latin typeface="Encode Sans"/>
                         </a:rPr>
-                        <a:t>8.341</a:t>
+                        <a:t>160,0</a:t>
                       </a:r>
                     </a:p>
                   </a:txBody>
@@ -4897,7 +3836,7 @@
                           </a:solidFill>
                           <a:latin typeface="Encode Sans"/>
                         </a:rPr>
-                        <a:t>8.935</a:t>
+                        <a:t>+6.2%</a:t>
                       </a:r>
                     </a:p>
                   </a:txBody>
@@ -4920,7 +3859,7 @@
                           </a:solidFill>
                           <a:latin typeface="Encode Sans"/>
                         </a:rPr>
-                        <a:t>7.344</a:t>
+                        <a:t>156,9</a:t>
                       </a:r>
                     </a:p>
                   </a:txBody>
@@ -4968,7 +3907,7 @@
                           </a:solidFill>
                           <a:latin typeface="Encode Sans"/>
                         </a:rPr>
-                        <a:t>8.096</a:t>
+                        <a:t>139,3</a:t>
                       </a:r>
                     </a:p>
                   </a:txBody>
@@ -4991,7 +3930,7 @@
                           </a:solidFill>
                           <a:latin typeface="Encode Sans"/>
                         </a:rPr>
-                        <a:t>8.755</a:t>
+                        <a:t>-1.5%</a:t>
                       </a:r>
                     </a:p>
                   </a:txBody>
@@ -5014,7 +3953,7 @@
                           </a:solidFill>
                           <a:latin typeface="Encode Sans"/>
                         </a:rPr>
-                        <a:t>6.991</a:t>
+                        <a:t>152,2</a:t>
                       </a:r>
                     </a:p>
                   </a:txBody>
@@ -5062,7 +4001,7 @@
                           </a:solidFill>
                           <a:latin typeface="Encode Sans"/>
                         </a:rPr>
-                        <a:t>7.953</a:t>
+                        <a:t>149,5</a:t>
                       </a:r>
                     </a:p>
                   </a:txBody>
@@ -5085,7 +4024,7 @@
                           </a:solidFill>
                           <a:latin typeface="Encode Sans"/>
                         </a:rPr>
-                        <a:t>8.621</a:t>
+                        <a:t>+2.0%</a:t>
                       </a:r>
                     </a:p>
                   </a:txBody>
@@ -5108,7 +4047,7 @@
                           </a:solidFill>
                           <a:latin typeface="Encode Sans"/>
                         </a:rPr>
-                        <a:t>6.832</a:t>
+                        <a:t>156,4</a:t>
                       </a:r>
                     </a:p>
                   </a:txBody>
@@ -5156,7 +4095,7 @@
                           </a:solidFill>
                           <a:latin typeface="Encode Sans"/>
                         </a:rPr>
-                        <a:t>7.795</a:t>
+                        <a:t>153,8</a:t>
                       </a:r>
                     </a:p>
                   </a:txBody>
@@ -5179,7 +4118,7 @@
                           </a:solidFill>
                           <a:latin typeface="Encode Sans"/>
                         </a:rPr>
-                        <a:t>8.441</a:t>
+                        <a:t>+3.5%</a:t>
                       </a:r>
                     </a:p>
                   </a:txBody>
@@ -5202,7 +4141,7 @@
                           </a:solidFill>
                           <a:latin typeface="Encode Sans"/>
                         </a:rPr>
-                        <a:t>6.711</a:t>
+                        <a:t>156,0</a:t>
                       </a:r>
                     </a:p>
                   </a:txBody>
@@ -5250,7 +4189,7 @@
                           </a:solidFill>
                           <a:latin typeface="Encode Sans"/>
                         </a:rPr>
-                        <a:t>7.640</a:t>
+                        <a:t>148,0</a:t>
                       </a:r>
                     </a:p>
                   </a:txBody>
@@ -5273,7 +4212,7 @@
                           </a:solidFill>
                           <a:latin typeface="Encode Sans"/>
                         </a:rPr>
-                        <a:t>8.233</a:t>
+                        <a:t>-0.1%</a:t>
                       </a:r>
                     </a:p>
                   </a:txBody>
@@ -5296,1658 +4235,7 @@
                           </a:solidFill>
                           <a:latin typeface="Encode Sans"/>
                         </a:rPr>
-                        <a:t>6.645</a:t>
-                      </a:r>
-                    </a:p>
-                  </a:txBody>
-                  <a:tcPr marL="36576" marR="36576" marT="18288" marB="18288">
-                    <a:solidFill>
-                      <a:srgbClr val="F8F8F6"/>
-                    </a:solidFill>
-                  </a:tcPr>
-                </a:tc>
-              </a:tr>
-            </a:tbl>
-          </a:graphicData>
-        </a:graphic>
-      </p:graphicFrame>
-      <p:sp>
-        <p:nvSpPr>
-          <p:cNvPr id="9" name="TextBox 8"/>
-          <p:cNvSpPr txBox="1"/>
-          <p:nvPr/>
-        </p:nvSpPr>
-        <p:spPr>
-          <a:xfrm>
-            <a:off x="411480" y="6492240"/>
-            <a:ext cx="11368735" cy="274320"/>
-          </a:xfrm>
-          <a:prstGeom prst="rect">
-            <a:avLst/>
-          </a:prstGeom>
-          <a:noFill/>
-        </p:spPr>
-        <p:txBody>
-          <a:bodyPr wrap="none">
-            <a:spAutoFit/>
-          </a:bodyPr>
-          <a:lstStyle/>
-          <a:p>
-            <a:r>
-              <a:rPr sz="1000" b="0" i="1">
-                <a:solidFill>
-                  <a:srgbClr val="6A6760"/>
-                </a:solidFill>
-                <a:latin typeface="Encode Sans"/>
-              </a:rPr>
-              <a:t>Fuente: elaboración propia en base a INDEC</a:t>
-            </a:r>
-          </a:p>
-        </p:txBody>
-      </p:sp>
-    </p:spTree>
-  </p:cSld>
-  <p:clrMapOvr>
-    <a:masterClrMapping/>
-  </p:clrMapOvr>
-</p:sld>
-</file>
-
-<file path=ppt/slides/slide4.xml><?xml version="1.0" encoding="utf-8"?>
-<p:sld xmlns:a="http://schemas.openxmlformats.org/drawingml/2006/main" xmlns:p="http://schemas.openxmlformats.org/presentationml/2006/main" xmlns:r="http://schemas.openxmlformats.org/officeDocument/2006/relationships">
-  <p:cSld>
-    <p:spTree>
-      <p:nvGrpSpPr>
-        <p:cNvPr id="1" name=""/>
-        <p:cNvGrpSpPr/>
-        <p:nvPr/>
-      </p:nvGrpSpPr>
-      <p:grpSpPr/>
-      <p:sp>
-        <p:nvSpPr>
-          <p:cNvPr id="2" name="Rectangle 1"/>
-          <p:cNvSpPr/>
-          <p:nvPr/>
-        </p:nvSpPr>
-        <p:spPr>
-          <a:xfrm>
-            <a:off x="0" y="0"/>
-            <a:ext cx="12191695" cy="274320"/>
-          </a:xfrm>
-          <a:prstGeom prst="rect">
-            <a:avLst/>
-          </a:prstGeom>
-          <a:solidFill>
-            <a:srgbClr val="00B2C9"/>
-          </a:solidFill>
-          <a:ln>
-            <a:noFill/>
-          </a:ln>
-        </p:spPr>
-        <p:style>
-          <a:lnRef idx="1">
-            <a:schemeClr val="accent1"/>
-          </a:lnRef>
-          <a:fillRef idx="3">
-            <a:schemeClr val="accent1"/>
-          </a:fillRef>
-          <a:effectRef idx="2">
-            <a:schemeClr val="accent1"/>
-          </a:effectRef>
-          <a:fontRef idx="minor">
-            <a:schemeClr val="lt1"/>
-          </a:fontRef>
-        </p:style>
-        <p:txBody>
-          <a:bodyPr rtlCol="0" anchor="ctr"/>
-          <a:lstStyle/>
-          <a:p>
-            <a:pPr algn="ctr"/>
-          </a:p>
-        </p:txBody>
-      </p:sp>
-      <p:sp>
-        <p:nvSpPr>
-          <p:cNvPr id="3" name="TextBox 2"/>
-          <p:cNvSpPr txBox="1"/>
-          <p:nvPr/>
-        </p:nvSpPr>
-        <p:spPr>
-          <a:xfrm>
-            <a:off x="411480" y="457200"/>
-            <a:ext cx="11368735" cy="914400"/>
-          </a:xfrm>
-          <a:prstGeom prst="rect">
-            <a:avLst/>
-          </a:prstGeom>
-          <a:noFill/>
-        </p:spPr>
-        <p:txBody>
-          <a:bodyPr wrap="square" lIns="0" rIns="0">
-            <a:spAutoFit/>
-          </a:bodyPr>
-          <a:lstStyle/>
-          <a:p>
-            <a:pPr algn="l"/>
-            <a:r>
-              <a:rPr sz="2600" b="1" i="0">
-                <a:solidFill>
-                  <a:srgbClr val="00B2C9"/>
-                </a:solidFill>
-                <a:latin typeface="Encode Sans"/>
-              </a:rPr>
-              <a:t>PBI TRIMESTRAL 1ER TRIMESTRE 2026</a:t>
-            </a:r>
-          </a:p>
-        </p:txBody>
-      </p:sp>
-      <p:sp>
-        <p:nvSpPr>
-          <p:cNvPr id="4" name="TextBox 3"/>
-          <p:cNvSpPr txBox="1"/>
-          <p:nvPr/>
-        </p:nvSpPr>
-        <p:spPr>
-          <a:xfrm>
-            <a:off x="411480" y="1280160"/>
-            <a:ext cx="11368735" cy="274320"/>
-          </a:xfrm>
-          <a:prstGeom prst="rect">
-            <a:avLst/>
-          </a:prstGeom>
-          <a:noFill/>
-        </p:spPr>
-        <p:txBody>
-          <a:bodyPr wrap="none">
-            <a:spAutoFit/>
-          </a:bodyPr>
-          <a:lstStyle/>
-          <a:p>
-            <a:r>
-              <a:rPr sz="1100" b="0" i="1">
-                <a:solidFill>
-                  <a:srgbClr val="6A6760"/>
-                </a:solidFill>
-                <a:latin typeface="Encode Sans"/>
-              </a:rPr>
-              <a:t>INDEC CCNN · período 1er trimestre 2026</a:t>
-            </a:r>
-          </a:p>
-        </p:txBody>
-      </p:sp>
-      <p:sp>
-        <p:nvSpPr>
-          <p:cNvPr id="5" name="TextBox 4"/>
-          <p:cNvSpPr txBox="1"/>
-          <p:nvPr/>
-        </p:nvSpPr>
-        <p:spPr>
-          <a:xfrm>
-            <a:off x="411480" y="1691640"/>
-            <a:ext cx="5486400" cy="1645920"/>
-          </a:xfrm>
-          <a:prstGeom prst="rect">
-            <a:avLst/>
-          </a:prstGeom>
-          <a:noFill/>
-        </p:spPr>
-        <p:txBody>
-          <a:bodyPr wrap="square" lIns="0" rIns="0">
-            <a:spAutoFit/>
-          </a:bodyPr>
-          <a:lstStyle/>
-          <a:p>
-            <a:pPr algn="just"/>
-            <a:r>
-              <a:rPr sz="1300" b="0" i="0">
-                <a:solidFill>
-                  <a:srgbClr val="3F3F3F"/>
-                </a:solidFill>
-                <a:latin typeface="Encode Sans"/>
-              </a:rPr>
-              <a:t>Se publicó la actualización de PBI trimestral para 1er trimestre 2026. Fuente: INDEC CCNN.</a:t>
-            </a:r>
-          </a:p>
-        </p:txBody>
-      </p:sp>
-      <p:sp>
-        <p:nvSpPr>
-          <p:cNvPr id="6" name="TextBox 5"/>
-          <p:cNvSpPr txBox="1"/>
-          <p:nvPr/>
-        </p:nvSpPr>
-        <p:spPr>
-          <a:xfrm>
-            <a:off x="411480" y="3520440"/>
-            <a:ext cx="5486400" cy="2743200"/>
-          </a:xfrm>
-          <a:prstGeom prst="rect">
-            <a:avLst/>
-          </a:prstGeom>
-          <a:noFill/>
-        </p:spPr>
-        <p:txBody>
-          <a:bodyPr wrap="square" lIns="0" rIns="0">
-            <a:spAutoFit/>
-          </a:bodyPr>
-          <a:lstStyle/>
-          <a:p>
-            <a:pPr algn="l">
-              <a:spcAft>
-                <a:spcPts val="800"/>
-              </a:spcAft>
-            </a:pPr>
-            <a:r>
-              <a:rPr sz="1300" b="1" i="0">
-                <a:solidFill>
-                  <a:srgbClr val="00B2C9"/>
-                </a:solidFill>
-                <a:latin typeface="Encode Sans"/>
-              </a:rPr>
-              <a:t>●  </a:t>
-            </a:r>
-            <a:r>
-              <a:rPr sz="1300" b="0" i="0">
-                <a:solidFill>
-                  <a:srgbClr val="3F3F3F"/>
-                </a:solidFill>
-                <a:latin typeface="Encode Sans"/>
-              </a:rPr>
-              <a:t>pbi: 725.600,00</a:t>
-            </a:r>
-          </a:p>
-          <a:p>
-            <a:pPr algn="l">
-              <a:spcAft>
-                <a:spcPts val="800"/>
-              </a:spcAft>
-            </a:pPr>
-            <a:r>
-              <a:rPr sz="1300" b="1" i="0">
-                <a:solidFill>
-                  <a:srgbClr val="00B2C9"/>
-                </a:solidFill>
-                <a:latin typeface="Encode Sans"/>
-              </a:rPr>
-              <a:t>●  </a:t>
-            </a:r>
-            <a:r>
-              <a:rPr sz="1300" b="0" i="0">
-                <a:solidFill>
-                  <a:srgbClr val="3F3F3F"/>
-                </a:solidFill>
-                <a:latin typeface="Encode Sans"/>
-              </a:rPr>
-              <a:t>via: 2,30</a:t>
-            </a:r>
-          </a:p>
-        </p:txBody>
-      </p:sp>
-      <p:sp>
-        <p:nvSpPr>
-          <p:cNvPr id="7" name="TextBox 6"/>
-          <p:cNvSpPr txBox="1"/>
-          <p:nvPr/>
-        </p:nvSpPr>
-        <p:spPr>
-          <a:xfrm>
-            <a:off x="411480" y="6492240"/>
-            <a:ext cx="11368735" cy="274320"/>
-          </a:xfrm>
-          <a:prstGeom prst="rect">
-            <a:avLst/>
-          </a:prstGeom>
-          <a:noFill/>
-        </p:spPr>
-        <p:txBody>
-          <a:bodyPr wrap="none">
-            <a:spAutoFit/>
-          </a:bodyPr>
-          <a:lstStyle/>
-          <a:p>
-            <a:r>
-              <a:rPr sz="1000" b="0" i="1">
-                <a:solidFill>
-                  <a:srgbClr val="6A6760"/>
-                </a:solidFill>
-                <a:latin typeface="Encode Sans"/>
-              </a:rPr>
-              <a:t>Fuente: elaboración propia en base a INDEC CCNN</a:t>
-            </a:r>
-          </a:p>
-        </p:txBody>
-      </p:sp>
-    </p:spTree>
-  </p:cSld>
-  <p:clrMapOvr>
-    <a:masterClrMapping/>
-  </p:clrMapOvr>
-</p:sld>
-</file>
-
-<file path=ppt/slides/slide5.xml><?xml version="1.0" encoding="utf-8"?>
-<p:sld xmlns:a="http://schemas.openxmlformats.org/drawingml/2006/main" xmlns:p="http://schemas.openxmlformats.org/presentationml/2006/main" xmlns:r="http://schemas.openxmlformats.org/officeDocument/2006/relationships">
-  <p:cSld>
-    <p:spTree>
-      <p:nvGrpSpPr>
-        <p:cNvPr id="1" name=""/>
-        <p:cNvGrpSpPr/>
-        <p:nvPr/>
-      </p:nvGrpSpPr>
-      <p:grpSpPr/>
-      <p:sp>
-        <p:nvSpPr>
-          <p:cNvPr id="2" name="Rectangle 1"/>
-          <p:cNvSpPr/>
-          <p:nvPr/>
-        </p:nvSpPr>
-        <p:spPr>
-          <a:xfrm>
-            <a:off x="0" y="0"/>
-            <a:ext cx="12191695" cy="274320"/>
-          </a:xfrm>
-          <a:prstGeom prst="rect">
-            <a:avLst/>
-          </a:prstGeom>
-          <a:solidFill>
-            <a:srgbClr val="00B2C9"/>
-          </a:solidFill>
-          <a:ln>
-            <a:noFill/>
-          </a:ln>
-        </p:spPr>
-        <p:style>
-          <a:lnRef idx="1">
-            <a:schemeClr val="accent1"/>
-          </a:lnRef>
-          <a:fillRef idx="3">
-            <a:schemeClr val="accent1"/>
-          </a:fillRef>
-          <a:effectRef idx="2">
-            <a:schemeClr val="accent1"/>
-          </a:effectRef>
-          <a:fontRef idx="minor">
-            <a:schemeClr val="lt1"/>
-          </a:fontRef>
-        </p:style>
-        <p:txBody>
-          <a:bodyPr rtlCol="0" anchor="ctr"/>
-          <a:lstStyle/>
-          <a:p>
-            <a:pPr algn="ctr"/>
-          </a:p>
-        </p:txBody>
-      </p:sp>
-      <p:sp>
-        <p:nvSpPr>
-          <p:cNvPr id="3" name="TextBox 2"/>
-          <p:cNvSpPr txBox="1"/>
-          <p:nvPr/>
-        </p:nvSpPr>
-        <p:spPr>
-          <a:xfrm>
-            <a:off x="411480" y="457200"/>
-            <a:ext cx="11368735" cy="914400"/>
-          </a:xfrm>
-          <a:prstGeom prst="rect">
-            <a:avLst/>
-          </a:prstGeom>
-          <a:noFill/>
-        </p:spPr>
-        <p:txBody>
-          <a:bodyPr wrap="square" lIns="0" rIns="0">
-            <a:spAutoFit/>
-          </a:bodyPr>
-          <a:lstStyle/>
-          <a:p>
-            <a:pPr algn="l"/>
-            <a:r>
-              <a:rPr sz="2600" b="1" i="0">
-                <a:solidFill>
-                  <a:srgbClr val="00B2C9"/>
-                </a:solidFill>
-                <a:latin typeface="Encode Sans"/>
-              </a:rPr>
-              <a:t>BALANZA DE PAGOS 1ER TRIMESTRE 2026</a:t>
-            </a:r>
-          </a:p>
-        </p:txBody>
-      </p:sp>
-      <p:sp>
-        <p:nvSpPr>
-          <p:cNvPr id="4" name="TextBox 3"/>
-          <p:cNvSpPr txBox="1"/>
-          <p:nvPr/>
-        </p:nvSpPr>
-        <p:spPr>
-          <a:xfrm>
-            <a:off x="411480" y="1280160"/>
-            <a:ext cx="11368735" cy="274320"/>
-          </a:xfrm>
-          <a:prstGeom prst="rect">
-            <a:avLst/>
-          </a:prstGeom>
-          <a:noFill/>
-        </p:spPr>
-        <p:txBody>
-          <a:bodyPr wrap="none">
-            <a:spAutoFit/>
-          </a:bodyPr>
-          <a:lstStyle/>
-          <a:p>
-            <a:r>
-              <a:rPr sz="1100" b="0" i="1">
-                <a:solidFill>
-                  <a:srgbClr val="6A6760"/>
-                </a:solidFill>
-                <a:latin typeface="Encode Sans"/>
-              </a:rPr>
-              <a:t>INDEC · período 1er trimestre 2026</a:t>
-            </a:r>
-          </a:p>
-        </p:txBody>
-      </p:sp>
-      <p:sp>
-        <p:nvSpPr>
-          <p:cNvPr id="5" name="TextBox 4"/>
-          <p:cNvSpPr txBox="1"/>
-          <p:nvPr/>
-        </p:nvSpPr>
-        <p:spPr>
-          <a:xfrm>
-            <a:off x="411480" y="1691640"/>
-            <a:ext cx="5486400" cy="1645920"/>
-          </a:xfrm>
-          <a:prstGeom prst="rect">
-            <a:avLst/>
-          </a:prstGeom>
-          <a:noFill/>
-        </p:spPr>
-        <p:txBody>
-          <a:bodyPr wrap="square" lIns="0" rIns="0">
-            <a:spAutoFit/>
-          </a:bodyPr>
-          <a:lstStyle/>
-          <a:p>
-            <a:pPr algn="just"/>
-            <a:r>
-              <a:rPr sz="1300" b="0" i="0">
-                <a:solidFill>
-                  <a:srgbClr val="3F3F3F"/>
-                </a:solidFill>
-                <a:latin typeface="Encode Sans"/>
-              </a:rPr>
-              <a:t>Se publicó la actualización de Balanza de pagos para 1er trimestre 2026. Fuente: INDEC.</a:t>
-            </a:r>
-          </a:p>
-        </p:txBody>
-      </p:sp>
-      <p:sp>
-        <p:nvSpPr>
-          <p:cNvPr id="6" name="TextBox 5"/>
-          <p:cNvSpPr txBox="1"/>
-          <p:nvPr/>
-        </p:nvSpPr>
-        <p:spPr>
-          <a:xfrm>
-            <a:off x="411480" y="3520440"/>
-            <a:ext cx="5486400" cy="2743200"/>
-          </a:xfrm>
-          <a:prstGeom prst="rect">
-            <a:avLst/>
-          </a:prstGeom>
-          <a:noFill/>
-        </p:spPr>
-        <p:txBody>
-          <a:bodyPr wrap="square" lIns="0" rIns="0">
-            <a:spAutoFit/>
-          </a:bodyPr>
-          <a:lstStyle/>
-          <a:p>
-            <a:pPr algn="l">
-              <a:spcAft>
-                <a:spcPts val="800"/>
-              </a:spcAft>
-            </a:pPr>
-            <a:r>
-              <a:rPr sz="1300" b="1" i="0">
-                <a:solidFill>
-                  <a:srgbClr val="00B2C9"/>
-                </a:solidFill>
-                <a:latin typeface="Encode Sans"/>
-              </a:rPr>
-              <a:t>●  </a:t>
-            </a:r>
-            <a:r>
-              <a:rPr sz="1300" b="0" i="0">
-                <a:solidFill>
-                  <a:srgbClr val="3F3F3F"/>
-                </a:solidFill>
-                <a:latin typeface="Encode Sans"/>
-              </a:rPr>
-              <a:t>cta_cte: -1.651,00</a:t>
-            </a:r>
-          </a:p>
-          <a:p>
-            <a:pPr algn="l">
-              <a:spcAft>
-                <a:spcPts val="800"/>
-              </a:spcAft>
-            </a:pPr>
-            <a:r>
-              <a:rPr sz="1300" b="1" i="0">
-                <a:solidFill>
-                  <a:srgbClr val="00B2C9"/>
-                </a:solidFill>
-                <a:latin typeface="Encode Sans"/>
-              </a:rPr>
-              <a:t>●  </a:t>
-            </a:r>
-            <a:r>
-              <a:rPr sz="1300" b="0" i="0">
-                <a:solidFill>
-                  <a:srgbClr val="3F3F3F"/>
-                </a:solidFill>
-                <a:latin typeface="Encode Sans"/>
-              </a:rPr>
-              <a:t>bienes: 6.339,00</a:t>
-            </a:r>
-          </a:p>
-          <a:p>
-            <a:pPr algn="l">
-              <a:spcAft>
-                <a:spcPts val="800"/>
-              </a:spcAft>
-            </a:pPr>
-            <a:r>
-              <a:rPr sz="1300" b="1" i="0">
-                <a:solidFill>
-                  <a:srgbClr val="00B2C9"/>
-                </a:solidFill>
-                <a:latin typeface="Encode Sans"/>
-              </a:rPr>
-              <a:t>●  </a:t>
-            </a:r>
-            <a:r>
-              <a:rPr sz="1300" b="0" i="0">
-                <a:solidFill>
-                  <a:srgbClr val="3F3F3F"/>
-                </a:solidFill>
-                <a:latin typeface="Encode Sans"/>
-              </a:rPr>
-              <a:t>servicios: -4.028,00</a:t>
-            </a:r>
-          </a:p>
-          <a:p>
-            <a:pPr algn="l">
-              <a:spcAft>
-                <a:spcPts val="800"/>
-              </a:spcAft>
-            </a:pPr>
-            <a:r>
-              <a:rPr sz="1300" b="1" i="0">
-                <a:solidFill>
-                  <a:srgbClr val="00B2C9"/>
-                </a:solidFill>
-                <a:latin typeface="Encode Sans"/>
-              </a:rPr>
-              <a:t>●  </a:t>
-            </a:r>
-            <a:r>
-              <a:rPr sz="1300" b="0" i="0">
-                <a:solidFill>
-                  <a:srgbClr val="3F3F3F"/>
-                </a:solidFill>
-                <a:latin typeface="Encode Sans"/>
-              </a:rPr>
-              <a:t>ing_prim: -4.676,00</a:t>
-            </a:r>
-          </a:p>
-          <a:p>
-            <a:pPr algn="l">
-              <a:spcAft>
-                <a:spcPts val="800"/>
-              </a:spcAft>
-            </a:pPr>
-            <a:r>
-              <a:rPr sz="1300" b="1" i="0">
-                <a:solidFill>
-                  <a:srgbClr val="00B2C9"/>
-                </a:solidFill>
-                <a:latin typeface="Encode Sans"/>
-              </a:rPr>
-              <a:t>●  </a:t>
-            </a:r>
-            <a:r>
-              <a:rPr sz="1300" b="0" i="0">
-                <a:solidFill>
-                  <a:srgbClr val="3F3F3F"/>
-                </a:solidFill>
-                <a:latin typeface="Encode Sans"/>
-              </a:rPr>
-              <a:t>ing_sec: 714,00</a:t>
-            </a:r>
-          </a:p>
-        </p:txBody>
-      </p:sp>
-      <p:sp>
-        <p:nvSpPr>
-          <p:cNvPr id="7" name="TextBox 6"/>
-          <p:cNvSpPr txBox="1"/>
-          <p:nvPr/>
-        </p:nvSpPr>
-        <p:spPr>
-          <a:xfrm>
-            <a:off x="411480" y="6492240"/>
-            <a:ext cx="11368735" cy="274320"/>
-          </a:xfrm>
-          <a:prstGeom prst="rect">
-            <a:avLst/>
-          </a:prstGeom>
-          <a:noFill/>
-        </p:spPr>
-        <p:txBody>
-          <a:bodyPr wrap="none">
-            <a:spAutoFit/>
-          </a:bodyPr>
-          <a:lstStyle/>
-          <a:p>
-            <a:r>
-              <a:rPr sz="1000" b="0" i="1">
-                <a:solidFill>
-                  <a:srgbClr val="6A6760"/>
-                </a:solidFill>
-                <a:latin typeface="Encode Sans"/>
-              </a:rPr>
-              <a:t>Fuente: elaboración propia en base a INDEC</a:t>
-            </a:r>
-          </a:p>
-        </p:txBody>
-      </p:sp>
-    </p:spTree>
-  </p:cSld>
-  <p:clrMapOvr>
-    <a:masterClrMapping/>
-  </p:clrMapOvr>
-</p:sld>
-</file>
-
-<file path=ppt/slides/slide6.xml><?xml version="1.0" encoding="utf-8"?>
-<p:sld xmlns:a="http://schemas.openxmlformats.org/drawingml/2006/main" xmlns:p="http://schemas.openxmlformats.org/presentationml/2006/main" xmlns:r="http://schemas.openxmlformats.org/officeDocument/2006/relationships">
-  <p:cSld>
-    <p:spTree>
-      <p:nvGrpSpPr>
-        <p:cNvPr id="1" name=""/>
-        <p:cNvGrpSpPr/>
-        <p:nvPr/>
-      </p:nvGrpSpPr>
-      <p:grpSpPr/>
-      <p:sp>
-        <p:nvSpPr>
-          <p:cNvPr id="2" name="Rectangle 1"/>
-          <p:cNvSpPr/>
-          <p:nvPr/>
-        </p:nvSpPr>
-        <p:spPr>
-          <a:xfrm>
-            <a:off x="0" y="0"/>
-            <a:ext cx="12191695" cy="274320"/>
-          </a:xfrm>
-          <a:prstGeom prst="rect">
-            <a:avLst/>
-          </a:prstGeom>
-          <a:solidFill>
-            <a:srgbClr val="00B2C9"/>
-          </a:solidFill>
-          <a:ln>
-            <a:noFill/>
-          </a:ln>
-        </p:spPr>
-        <p:style>
-          <a:lnRef idx="1">
-            <a:schemeClr val="accent1"/>
-          </a:lnRef>
-          <a:fillRef idx="3">
-            <a:schemeClr val="accent1"/>
-          </a:fillRef>
-          <a:effectRef idx="2">
-            <a:schemeClr val="accent1"/>
-          </a:effectRef>
-          <a:fontRef idx="minor">
-            <a:schemeClr val="lt1"/>
-          </a:fontRef>
-        </p:style>
-        <p:txBody>
-          <a:bodyPr rtlCol="0" anchor="ctr"/>
-          <a:lstStyle/>
-          <a:p>
-            <a:pPr algn="ctr"/>
-          </a:p>
-        </p:txBody>
-      </p:sp>
-      <p:sp>
-        <p:nvSpPr>
-          <p:cNvPr id="3" name="TextBox 2"/>
-          <p:cNvSpPr txBox="1"/>
-          <p:nvPr/>
-        </p:nvSpPr>
-        <p:spPr>
-          <a:xfrm>
-            <a:off x="411480" y="457200"/>
-            <a:ext cx="11368735" cy="914400"/>
-          </a:xfrm>
-          <a:prstGeom prst="rect">
-            <a:avLst/>
-          </a:prstGeom>
-          <a:noFill/>
-        </p:spPr>
-        <p:txBody>
-          <a:bodyPr wrap="square" lIns="0" rIns="0">
-            <a:spAutoFit/>
-          </a:bodyPr>
-          <a:lstStyle/>
-          <a:p>
-            <a:pPr algn="l"/>
-            <a:r>
-              <a:rPr sz="2600" b="1" i="0">
-                <a:solidFill>
-                  <a:srgbClr val="00B2C9"/>
-                </a:solidFill>
-                <a:latin typeface="Encode Sans"/>
-              </a:rPr>
-              <a:t>TURISMO INTERNACIONAL MAYO 2026: SALDO -281.993 PERSONAS</a:t>
-            </a:r>
-          </a:p>
-        </p:txBody>
-      </p:sp>
-      <p:sp>
-        <p:nvSpPr>
-          <p:cNvPr id="4" name="TextBox 3"/>
-          <p:cNvSpPr txBox="1"/>
-          <p:nvPr/>
-        </p:nvSpPr>
-        <p:spPr>
-          <a:xfrm>
-            <a:off x="411480" y="1280160"/>
-            <a:ext cx="11368735" cy="274320"/>
-          </a:xfrm>
-          <a:prstGeom prst="rect">
-            <a:avLst/>
-          </a:prstGeom>
-          <a:noFill/>
-        </p:spPr>
-        <p:txBody>
-          <a:bodyPr wrap="none">
-            <a:spAutoFit/>
-          </a:bodyPr>
-          <a:lstStyle/>
-          <a:p>
-            <a:r>
-              <a:rPr sz="1100" b="0" i="1">
-                <a:solidFill>
-                  <a:srgbClr val="6A6760"/>
-                </a:solidFill>
-                <a:latin typeface="Encode Sans"/>
-              </a:rPr>
-              <a:t>INDEC · período 2026-05</a:t>
-            </a:r>
-          </a:p>
-        </p:txBody>
-      </p:sp>
-      <p:sp>
-        <p:nvSpPr>
-          <p:cNvPr id="5" name="TextBox 4"/>
-          <p:cNvSpPr txBox="1"/>
-          <p:nvPr/>
-        </p:nvSpPr>
-        <p:spPr>
-          <a:xfrm>
-            <a:off x="411480" y="1691640"/>
-            <a:ext cx="5486400" cy="1645920"/>
-          </a:xfrm>
-          <a:prstGeom prst="rect">
-            <a:avLst/>
-          </a:prstGeom>
-          <a:noFill/>
-        </p:spPr>
-        <p:txBody>
-          <a:bodyPr wrap="square" lIns="0" rIns="0">
-            <a:spAutoFit/>
-          </a:bodyPr>
-          <a:lstStyle/>
-          <a:p>
-            <a:pPr algn="just"/>
-            <a:r>
-              <a:rPr sz="1300" b="0" i="0">
-                <a:solidFill>
-                  <a:srgbClr val="3F3F3F"/>
-                </a:solidFill>
-                <a:latin typeface="Encode Sans"/>
-              </a:rPr>
-              <a:t>En mayo 2026 ingresaron 379.860 turistas no residentes y salieron 661.853 argentinos al exterior, con saldo de -281.993 personas. Receptivo +20.4% i.a., emisivo -12.1% i.a.</a:t>
-            </a:r>
-          </a:p>
-        </p:txBody>
-      </p:sp>
-      <p:sp>
-        <p:nvSpPr>
-          <p:cNvPr id="6" name="TextBox 5"/>
-          <p:cNvSpPr txBox="1"/>
-          <p:nvPr/>
-        </p:nvSpPr>
-        <p:spPr>
-          <a:xfrm>
-            <a:off x="411480" y="3520440"/>
-            <a:ext cx="5486400" cy="2743200"/>
-          </a:xfrm>
-          <a:prstGeom prst="rect">
-            <a:avLst/>
-          </a:prstGeom>
-          <a:noFill/>
-        </p:spPr>
-        <p:txBody>
-          <a:bodyPr wrap="square" lIns="0" rIns="0">
-            <a:spAutoFit/>
-          </a:bodyPr>
-          <a:lstStyle/>
-          <a:p>
-            <a:pPr algn="l">
-              <a:spcAft>
-                <a:spcPts val="800"/>
-              </a:spcAft>
-            </a:pPr>
-            <a:r>
-              <a:rPr sz="1300" b="1" i="0">
-                <a:solidFill>
-                  <a:srgbClr val="00B2C9"/>
-                </a:solidFill>
-                <a:latin typeface="Encode Sans"/>
-              </a:rPr>
-              <a:t>●  </a:t>
-            </a:r>
-            <a:r>
-              <a:rPr sz="1300" b="0" i="0">
-                <a:solidFill>
-                  <a:srgbClr val="3F3F3F"/>
-                </a:solidFill>
-                <a:latin typeface="Encode Sans"/>
-              </a:rPr>
-              <a:t>Receptivo: 379.860 personas</a:t>
-            </a:r>
-          </a:p>
-          <a:p>
-            <a:pPr algn="l">
-              <a:spcAft>
-                <a:spcPts val="800"/>
-              </a:spcAft>
-            </a:pPr>
-            <a:r>
-              <a:rPr sz="1300" b="1" i="0">
-                <a:solidFill>
-                  <a:srgbClr val="00B2C9"/>
-                </a:solidFill>
-                <a:latin typeface="Encode Sans"/>
-              </a:rPr>
-              <a:t>●  </a:t>
-            </a:r>
-            <a:r>
-              <a:rPr sz="1300" b="0" i="0">
-                <a:solidFill>
-                  <a:srgbClr val="3F3F3F"/>
-                </a:solidFill>
-                <a:latin typeface="Encode Sans"/>
-              </a:rPr>
-              <a:t>Emisivo: 661.853 personas</a:t>
-            </a:r>
-          </a:p>
-          <a:p>
-            <a:pPr algn="l">
-              <a:spcAft>
-                <a:spcPts val="800"/>
-              </a:spcAft>
-            </a:pPr>
-            <a:r>
-              <a:rPr sz="1300" b="1" i="0">
-                <a:solidFill>
-                  <a:srgbClr val="00B2C9"/>
-                </a:solidFill>
-                <a:latin typeface="Encode Sans"/>
-              </a:rPr>
-              <a:t>●  </a:t>
-            </a:r>
-            <a:r>
-              <a:rPr sz="1300" b="0" i="0">
-                <a:solidFill>
-                  <a:srgbClr val="3F3F3F"/>
-                </a:solidFill>
-                <a:latin typeface="Encode Sans"/>
-              </a:rPr>
-              <a:t>Saldo (receptivo − emisivo): -281.993 personas</a:t>
-            </a:r>
-          </a:p>
-          <a:p>
-            <a:pPr algn="l">
-              <a:spcAft>
-                <a:spcPts val="800"/>
-              </a:spcAft>
-            </a:pPr>
-            <a:r>
-              <a:rPr sz="1300" b="1" i="0">
-                <a:solidFill>
-                  <a:srgbClr val="00B2C9"/>
-                </a:solidFill>
-                <a:latin typeface="Encode Sans"/>
-              </a:rPr>
-              <a:t>●  </a:t>
-            </a:r>
-            <a:r>
-              <a:rPr sz="1300" b="0" i="0">
-                <a:solidFill>
-                  <a:srgbClr val="3F3F3F"/>
-                </a:solidFill>
-                <a:latin typeface="Encode Sans"/>
-              </a:rPr>
-              <a:t>Fuente: INDEC, Estadísticas de Turismo Internacional (todas las vías)</a:t>
-            </a:r>
-          </a:p>
-        </p:txBody>
-      </p:sp>
-      <p:pic>
-        <p:nvPicPr>
-          <p:cNvPr id="7" name="Picture 6" descr="image.png"/>
-          <p:cNvPicPr>
-            <a:picLocks noChangeAspect="1"/>
-          </p:cNvPicPr>
-          <p:nvPr/>
-        </p:nvPicPr>
-        <p:blipFill>
-          <a:blip r:embed="rId2"/>
-          <a:stretch>
-            <a:fillRect/>
-          </a:stretch>
-        </p:blipFill>
-        <p:spPr>
-          <a:xfrm>
-            <a:off x="6080760" y="1691640"/>
-            <a:ext cx="5669280" cy="2560320"/>
-          </a:xfrm>
-          <a:prstGeom prst="rect">
-            <a:avLst/>
-          </a:prstGeom>
-        </p:spPr>
-      </p:pic>
-      <p:graphicFrame>
-        <p:nvGraphicFramePr>
-          <p:cNvPr id="8" name="Table 7"/>
-          <p:cNvGraphicFramePr>
-            <a:graphicFrameLocks noGrp="1"/>
-          </p:cNvGraphicFramePr>
-          <p:nvPr/>
-        </p:nvGraphicFramePr>
-        <p:xfrm>
-          <a:off x="6080760" y="4434840"/>
-          <a:ext cx="5669280" cy="2048256"/>
-        </p:xfrm>
-        <a:graphic>
-          <a:graphicData uri="http://schemas.openxmlformats.org/drawingml/2006/table">
-            <a:tbl>
-              <a:tblPr firstRow="1" bandRow="1">
-                <a:tableStyleId>{5C22544A-7EE6-4342-B048-85BDC9FD1C3A}</a:tableStyleId>
-              </a:tblPr>
-              <a:tblGrid>
-                <a:gridCol w="1417320"/>
-                <a:gridCol w="1417320"/>
-                <a:gridCol w="1417320"/>
-                <a:gridCol w="1417320"/>
-              </a:tblGrid>
-              <a:tr h="292608">
-                <a:tc>
-                  <a:txBody>
-                    <a:bodyPr/>
-                    <a:lstStyle/>
-                    <a:p>
-                      <a:pPr algn="l"/>
-                      <a:r>
-                        <a:rPr sz="1000" b="1">
-                          <a:solidFill>
-                            <a:srgbClr val="FFFFFF"/>
-                          </a:solidFill>
-                          <a:latin typeface="Encode Sans"/>
-                        </a:rPr>
-                        <a:t>Mes</a:t>
-                      </a:r>
-                    </a:p>
-                  </a:txBody>
-                  <a:tcPr marL="36576" marR="36576" marT="18288" marB="18288">
-                    <a:solidFill>
-                      <a:srgbClr val="00B2C9"/>
-                    </a:solidFill>
-                  </a:tcPr>
-                </a:tc>
-                <a:tc>
-                  <a:txBody>
-                    <a:bodyPr/>
-                    <a:lstStyle/>
-                    <a:p>
-                      <a:pPr algn="r"/>
-                      <a:r>
-                        <a:rPr sz="1000" b="1">
-                          <a:solidFill>
-                            <a:srgbClr val="FFFFFF"/>
-                          </a:solidFill>
-                          <a:latin typeface="Encode Sans"/>
-                        </a:rPr>
-                        <a:t>Receptivo</a:t>
-                      </a:r>
-                    </a:p>
-                  </a:txBody>
-                  <a:tcPr marL="36576" marR="36576" marT="18288" marB="18288">
-                    <a:solidFill>
-                      <a:srgbClr val="00B2C9"/>
-                    </a:solidFill>
-                  </a:tcPr>
-                </a:tc>
-                <a:tc>
-                  <a:txBody>
-                    <a:bodyPr/>
-                    <a:lstStyle/>
-                    <a:p>
-                      <a:pPr algn="r"/>
-                      <a:r>
-                        <a:rPr sz="1000" b="1">
-                          <a:solidFill>
-                            <a:srgbClr val="FFFFFF"/>
-                          </a:solidFill>
-                          <a:latin typeface="Encode Sans"/>
-                        </a:rPr>
-                        <a:t>Emisivo</a:t>
-                      </a:r>
-                    </a:p>
-                  </a:txBody>
-                  <a:tcPr marL="36576" marR="36576" marT="18288" marB="18288">
-                    <a:solidFill>
-                      <a:srgbClr val="00B2C9"/>
-                    </a:solidFill>
-                  </a:tcPr>
-                </a:tc>
-                <a:tc>
-                  <a:txBody>
-                    <a:bodyPr/>
-                    <a:lstStyle/>
-                    <a:p>
-                      <a:pPr algn="r"/>
-                      <a:r>
-                        <a:rPr sz="1000" b="1">
-                          <a:solidFill>
-                            <a:srgbClr val="FFFFFF"/>
-                          </a:solidFill>
-                          <a:latin typeface="Encode Sans"/>
-                        </a:rPr>
-                        <a:t>Saldo</a:t>
-                      </a:r>
-                    </a:p>
-                  </a:txBody>
-                  <a:tcPr marL="36576" marR="36576" marT="18288" marB="18288">
-                    <a:solidFill>
-                      <a:srgbClr val="00B2C9"/>
-                    </a:solidFill>
-                  </a:tcPr>
-                </a:tc>
-              </a:tr>
-              <a:tr h="292608">
-                <a:tc>
-                  <a:txBody>
-                    <a:bodyPr/>
-                    <a:lstStyle/>
-                    <a:p>
-                      <a:pPr algn="l"/>
-                      <a:r>
-                        <a:rPr sz="1000">
-                          <a:solidFill>
-                            <a:srgbClr val="3F3F3F"/>
-                          </a:solidFill>
-                          <a:latin typeface="Encode Sans"/>
-                        </a:rPr>
-                        <a:t>Mayo 2026</a:t>
-                      </a:r>
-                    </a:p>
-                  </a:txBody>
-                  <a:tcPr marL="36576" marR="36576" marT="18288" marB="18288">
-                    <a:solidFill>
-                      <a:srgbClr val="FFFFFF"/>
-                    </a:solidFill>
-                  </a:tcPr>
-                </a:tc>
-                <a:tc>
-                  <a:txBody>
-                    <a:bodyPr/>
-                    <a:lstStyle/>
-                    <a:p>
-                      <a:pPr algn="r"/>
-                      <a:r>
-                        <a:rPr sz="1000">
-                          <a:solidFill>
-                            <a:srgbClr val="3F3F3F"/>
-                          </a:solidFill>
-                          <a:latin typeface="Encode Sans"/>
-                        </a:rPr>
-                        <a:t>379.860</a:t>
-                      </a:r>
-                    </a:p>
-                  </a:txBody>
-                  <a:tcPr marL="36576" marR="36576" marT="18288" marB="18288">
-                    <a:solidFill>
-                      <a:srgbClr val="FFFFFF"/>
-                    </a:solidFill>
-                  </a:tcPr>
-                </a:tc>
-                <a:tc>
-                  <a:txBody>
-                    <a:bodyPr/>
-                    <a:lstStyle/>
-                    <a:p>
-                      <a:pPr algn="r"/>
-                      <a:r>
-                        <a:rPr sz="1000">
-                          <a:solidFill>
-                            <a:srgbClr val="3F3F3F"/>
-                          </a:solidFill>
-                          <a:latin typeface="Encode Sans"/>
-                        </a:rPr>
-                        <a:t>661.853</a:t>
-                      </a:r>
-                    </a:p>
-                  </a:txBody>
-                  <a:tcPr marL="36576" marR="36576" marT="18288" marB="18288">
-                    <a:solidFill>
-                      <a:srgbClr val="FFFFFF"/>
-                    </a:solidFill>
-                  </a:tcPr>
-                </a:tc>
-                <a:tc>
-                  <a:txBody>
-                    <a:bodyPr/>
-                    <a:lstStyle/>
-                    <a:p>
-                      <a:pPr algn="r"/>
-                      <a:r>
-                        <a:rPr sz="1000">
-                          <a:solidFill>
-                            <a:srgbClr val="3F3F3F"/>
-                          </a:solidFill>
-                          <a:latin typeface="Encode Sans"/>
-                        </a:rPr>
-                        <a:t>-281.993</a:t>
-                      </a:r>
-                    </a:p>
-                  </a:txBody>
-                  <a:tcPr marL="36576" marR="36576" marT="18288" marB="18288">
-                    <a:solidFill>
-                      <a:srgbClr val="FFFFFF"/>
-                    </a:solidFill>
-                  </a:tcPr>
-                </a:tc>
-              </a:tr>
-              <a:tr h="292608">
-                <a:tc>
-                  <a:txBody>
-                    <a:bodyPr/>
-                    <a:lstStyle/>
-                    <a:p>
-                      <a:pPr algn="l"/>
-                      <a:r>
-                        <a:rPr sz="1000">
-                          <a:solidFill>
-                            <a:srgbClr val="3F3F3F"/>
-                          </a:solidFill>
-                          <a:latin typeface="Encode Sans"/>
-                        </a:rPr>
-                        <a:t>Abril 2026</a:t>
-                      </a:r>
-                    </a:p>
-                  </a:txBody>
-                  <a:tcPr marL="36576" marR="36576" marT="18288" marB="18288">
-                    <a:solidFill>
-                      <a:srgbClr val="F8F8F6"/>
-                    </a:solidFill>
-                  </a:tcPr>
-                </a:tc>
-                <a:tc>
-                  <a:txBody>
-                    <a:bodyPr/>
-                    <a:lstStyle/>
-                    <a:p>
-                      <a:pPr algn="r"/>
-                      <a:r>
-                        <a:rPr sz="1000">
-                          <a:solidFill>
-                            <a:srgbClr val="3F3F3F"/>
-                          </a:solidFill>
-                          <a:latin typeface="Encode Sans"/>
-                        </a:rPr>
-                        <a:t>463.072</a:t>
-                      </a:r>
-                    </a:p>
-                  </a:txBody>
-                  <a:tcPr marL="36576" marR="36576" marT="18288" marB="18288">
-                    <a:solidFill>
-                      <a:srgbClr val="F8F8F6"/>
-                    </a:solidFill>
-                  </a:tcPr>
-                </a:tc>
-                <a:tc>
-                  <a:txBody>
-                    <a:bodyPr/>
-                    <a:lstStyle/>
-                    <a:p>
-                      <a:pPr algn="r"/>
-                      <a:r>
-                        <a:rPr sz="1000">
-                          <a:solidFill>
-                            <a:srgbClr val="3F3F3F"/>
-                          </a:solidFill>
-                          <a:latin typeface="Encode Sans"/>
-                        </a:rPr>
-                        <a:t>764.757</a:t>
-                      </a:r>
-                    </a:p>
-                  </a:txBody>
-                  <a:tcPr marL="36576" marR="36576" marT="18288" marB="18288">
-                    <a:solidFill>
-                      <a:srgbClr val="F8F8F6"/>
-                    </a:solidFill>
-                  </a:tcPr>
-                </a:tc>
-                <a:tc>
-                  <a:txBody>
-                    <a:bodyPr/>
-                    <a:lstStyle/>
-                    <a:p>
-                      <a:pPr algn="r"/>
-                      <a:r>
-                        <a:rPr sz="1000">
-                          <a:solidFill>
-                            <a:srgbClr val="3F3F3F"/>
-                          </a:solidFill>
-                          <a:latin typeface="Encode Sans"/>
-                        </a:rPr>
-                        <a:t>-301.685</a:t>
-                      </a:r>
-                    </a:p>
-                  </a:txBody>
-                  <a:tcPr marL="36576" marR="36576" marT="18288" marB="18288">
-                    <a:solidFill>
-                      <a:srgbClr val="F8F8F6"/>
-                    </a:solidFill>
-                  </a:tcPr>
-                </a:tc>
-              </a:tr>
-              <a:tr h="292608">
-                <a:tc>
-                  <a:txBody>
-                    <a:bodyPr/>
-                    <a:lstStyle/>
-                    <a:p>
-                      <a:pPr algn="l"/>
-                      <a:r>
-                        <a:rPr sz="1000">
-                          <a:solidFill>
-                            <a:srgbClr val="3F3F3F"/>
-                          </a:solidFill>
-                          <a:latin typeface="Encode Sans"/>
-                        </a:rPr>
-                        <a:t>Marzo 2026</a:t>
-                      </a:r>
-                    </a:p>
-                  </a:txBody>
-                  <a:tcPr marL="36576" marR="36576" marT="18288" marB="18288">
-                    <a:solidFill>
-                      <a:srgbClr val="FFFFFF"/>
-                    </a:solidFill>
-                  </a:tcPr>
-                </a:tc>
-                <a:tc>
-                  <a:txBody>
-                    <a:bodyPr/>
-                    <a:lstStyle/>
-                    <a:p>
-                      <a:pPr algn="r"/>
-                      <a:r>
-                        <a:rPr sz="1000">
-                          <a:solidFill>
-                            <a:srgbClr val="3F3F3F"/>
-                          </a:solidFill>
-                          <a:latin typeface="Encode Sans"/>
-                        </a:rPr>
-                        <a:t>509.625</a:t>
-                      </a:r>
-                    </a:p>
-                  </a:txBody>
-                  <a:tcPr marL="36576" marR="36576" marT="18288" marB="18288">
-                    <a:solidFill>
-                      <a:srgbClr val="FFFFFF"/>
-                    </a:solidFill>
-                  </a:tcPr>
-                </a:tc>
-                <a:tc>
-                  <a:txBody>
-                    <a:bodyPr/>
-                    <a:lstStyle/>
-                    <a:p>
-                      <a:pPr algn="r"/>
-                      <a:r>
-                        <a:rPr sz="1000">
-                          <a:solidFill>
-                            <a:srgbClr val="3F3F3F"/>
-                          </a:solidFill>
-                          <a:latin typeface="Encode Sans"/>
-                        </a:rPr>
-                        <a:t>1.061.777</a:t>
-                      </a:r>
-                    </a:p>
-                  </a:txBody>
-                  <a:tcPr marL="36576" marR="36576" marT="18288" marB="18288">
-                    <a:solidFill>
-                      <a:srgbClr val="FFFFFF"/>
-                    </a:solidFill>
-                  </a:tcPr>
-                </a:tc>
-                <a:tc>
-                  <a:txBody>
-                    <a:bodyPr/>
-                    <a:lstStyle/>
-                    <a:p>
-                      <a:pPr algn="r"/>
-                      <a:r>
-                        <a:rPr sz="1000">
-                          <a:solidFill>
-                            <a:srgbClr val="3F3F3F"/>
-                          </a:solidFill>
-                          <a:latin typeface="Encode Sans"/>
-                        </a:rPr>
-                        <a:t>-552.152</a:t>
-                      </a:r>
-                    </a:p>
-                  </a:txBody>
-                  <a:tcPr marL="36576" marR="36576" marT="18288" marB="18288">
-                    <a:solidFill>
-                      <a:srgbClr val="FFFFFF"/>
-                    </a:solidFill>
-                  </a:tcPr>
-                </a:tc>
-              </a:tr>
-              <a:tr h="292608">
-                <a:tc>
-                  <a:txBody>
-                    <a:bodyPr/>
-                    <a:lstStyle/>
-                    <a:p>
-                      <a:pPr algn="l"/>
-                      <a:r>
-                        <a:rPr sz="1000">
-                          <a:solidFill>
-                            <a:srgbClr val="3F3F3F"/>
-                          </a:solidFill>
-                          <a:latin typeface="Encode Sans"/>
-                        </a:rPr>
-                        <a:t>Febrero 2026</a:t>
-                      </a:r>
-                    </a:p>
-                  </a:txBody>
-                  <a:tcPr marL="36576" marR="36576" marT="18288" marB="18288">
-                    <a:solidFill>
-                      <a:srgbClr val="F8F8F6"/>
-                    </a:solidFill>
-                  </a:tcPr>
-                </a:tc>
-                <a:tc>
-                  <a:txBody>
-                    <a:bodyPr/>
-                    <a:lstStyle/>
-                    <a:p>
-                      <a:pPr algn="r"/>
-                      <a:r>
-                        <a:rPr sz="1000">
-                          <a:solidFill>
-                            <a:srgbClr val="3F3F3F"/>
-                          </a:solidFill>
-                          <a:latin typeface="Encode Sans"/>
-                        </a:rPr>
-                        <a:t>534.223</a:t>
-                      </a:r>
-                    </a:p>
-                  </a:txBody>
-                  <a:tcPr marL="36576" marR="36576" marT="18288" marB="18288">
-                    <a:solidFill>
-                      <a:srgbClr val="F8F8F6"/>
-                    </a:solidFill>
-                  </a:tcPr>
-                </a:tc>
-                <a:tc>
-                  <a:txBody>
-                    <a:bodyPr/>
-                    <a:lstStyle/>
-                    <a:p>
-                      <a:pPr algn="r"/>
-                      <a:r>
-                        <a:rPr sz="1000">
-                          <a:solidFill>
-                            <a:srgbClr val="3F3F3F"/>
-                          </a:solidFill>
-                          <a:latin typeface="Encode Sans"/>
-                        </a:rPr>
-                        <a:t>1.629.180</a:t>
-                      </a:r>
-                    </a:p>
-                  </a:txBody>
-                  <a:tcPr marL="36576" marR="36576" marT="18288" marB="18288">
-                    <a:solidFill>
-                      <a:srgbClr val="F8F8F6"/>
-                    </a:solidFill>
-                  </a:tcPr>
-                </a:tc>
-                <a:tc>
-                  <a:txBody>
-                    <a:bodyPr/>
-                    <a:lstStyle/>
-                    <a:p>
-                      <a:pPr algn="r"/>
-                      <a:r>
-                        <a:rPr sz="1000">
-                          <a:solidFill>
-                            <a:srgbClr val="3F3F3F"/>
-                          </a:solidFill>
-                          <a:latin typeface="Encode Sans"/>
-                        </a:rPr>
-                        <a:t>-1.094.957</a:t>
-                      </a:r>
-                    </a:p>
-                  </a:txBody>
-                  <a:tcPr marL="36576" marR="36576" marT="18288" marB="18288">
-                    <a:solidFill>
-                      <a:srgbClr val="F8F8F6"/>
-                    </a:solidFill>
-                  </a:tcPr>
-                </a:tc>
-              </a:tr>
-              <a:tr h="292608">
-                <a:tc>
-                  <a:txBody>
-                    <a:bodyPr/>
-                    <a:lstStyle/>
-                    <a:p>
-                      <a:pPr algn="l"/>
-                      <a:r>
-                        <a:rPr sz="1000">
-                          <a:solidFill>
-                            <a:srgbClr val="3F3F3F"/>
-                          </a:solidFill>
-                          <a:latin typeface="Encode Sans"/>
-                        </a:rPr>
-                        <a:t>Enero 2026</a:t>
-                      </a:r>
-                    </a:p>
-                  </a:txBody>
-                  <a:tcPr marL="36576" marR="36576" marT="18288" marB="18288">
-                    <a:solidFill>
-                      <a:srgbClr val="FFFFFF"/>
-                    </a:solidFill>
-                  </a:tcPr>
-                </a:tc>
-                <a:tc>
-                  <a:txBody>
-                    <a:bodyPr/>
-                    <a:lstStyle/>
-                    <a:p>
-                      <a:pPr algn="r"/>
-                      <a:r>
-                        <a:rPr sz="1000">
-                          <a:solidFill>
-                            <a:srgbClr val="3F3F3F"/>
-                          </a:solidFill>
-                          <a:latin typeface="Encode Sans"/>
-                        </a:rPr>
-                        <a:t>681.956</a:t>
-                      </a:r>
-                    </a:p>
-                  </a:txBody>
-                  <a:tcPr marL="36576" marR="36576" marT="18288" marB="18288">
-                    <a:solidFill>
-                      <a:srgbClr val="FFFFFF"/>
-                    </a:solidFill>
-                  </a:tcPr>
-                </a:tc>
-                <a:tc>
-                  <a:txBody>
-                    <a:bodyPr/>
-                    <a:lstStyle/>
-                    <a:p>
-                      <a:pPr algn="r"/>
-                      <a:r>
-                        <a:rPr sz="1000">
-                          <a:solidFill>
-                            <a:srgbClr val="3F3F3F"/>
-                          </a:solidFill>
-                          <a:latin typeface="Encode Sans"/>
-                        </a:rPr>
-                        <a:t>1.764.091</a:t>
-                      </a:r>
-                    </a:p>
-                  </a:txBody>
-                  <a:tcPr marL="36576" marR="36576" marT="18288" marB="18288">
-                    <a:solidFill>
-                      <a:srgbClr val="FFFFFF"/>
-                    </a:solidFill>
-                  </a:tcPr>
-                </a:tc>
-                <a:tc>
-                  <a:txBody>
-                    <a:bodyPr/>
-                    <a:lstStyle/>
-                    <a:p>
-                      <a:pPr algn="r"/>
-                      <a:r>
-                        <a:rPr sz="1000">
-                          <a:solidFill>
-                            <a:srgbClr val="3F3F3F"/>
-                          </a:solidFill>
-                          <a:latin typeface="Encode Sans"/>
-                        </a:rPr>
-                        <a:t>-1.082.135</a:t>
-                      </a:r>
-                    </a:p>
-                  </a:txBody>
-                  <a:tcPr marL="36576" marR="36576" marT="18288" marB="18288">
-                    <a:solidFill>
-                      <a:srgbClr val="FFFFFF"/>
-                    </a:solidFill>
-                  </a:tcPr>
-                </a:tc>
-              </a:tr>
-              <a:tr h="292608">
-                <a:tc>
-                  <a:txBody>
-                    <a:bodyPr/>
-                    <a:lstStyle/>
-                    <a:p>
-                      <a:pPr algn="l"/>
-                      <a:r>
-                        <a:rPr sz="1000">
-                          <a:solidFill>
-                            <a:srgbClr val="3F3F3F"/>
-                          </a:solidFill>
-                          <a:latin typeface="Encode Sans"/>
-                        </a:rPr>
-                        <a:t>Diciembre 2025</a:t>
-                      </a:r>
-                    </a:p>
-                  </a:txBody>
-                  <a:tcPr marL="36576" marR="36576" marT="18288" marB="18288">
-                    <a:solidFill>
-                      <a:srgbClr val="F8F8F6"/>
-                    </a:solidFill>
-                  </a:tcPr>
-                </a:tc>
-                <a:tc>
-                  <a:txBody>
-                    <a:bodyPr/>
-                    <a:lstStyle/>
-                    <a:p>
-                      <a:pPr algn="r"/>
-                      <a:r>
-                        <a:rPr sz="1000">
-                          <a:solidFill>
-                            <a:srgbClr val="3F3F3F"/>
-                          </a:solidFill>
-                          <a:latin typeface="Encode Sans"/>
-                        </a:rPr>
-                        <a:t>535.845</a:t>
-                      </a:r>
-                    </a:p>
-                  </a:txBody>
-                  <a:tcPr marL="36576" marR="36576" marT="18288" marB="18288">
-                    <a:solidFill>
-                      <a:srgbClr val="F8F8F6"/>
-                    </a:solidFill>
-                  </a:tcPr>
-                </a:tc>
-                <a:tc>
-                  <a:txBody>
-                    <a:bodyPr/>
-                    <a:lstStyle/>
-                    <a:p>
-                      <a:pPr algn="r"/>
-                      <a:r>
-                        <a:rPr sz="1000">
-                          <a:solidFill>
-                            <a:srgbClr val="3F3F3F"/>
-                          </a:solidFill>
-                          <a:latin typeface="Encode Sans"/>
-                        </a:rPr>
-                        <a:t>705.141</a:t>
-                      </a:r>
-                    </a:p>
-                  </a:txBody>
-                  <a:tcPr marL="36576" marR="36576" marT="18288" marB="18288">
-                    <a:solidFill>
-                      <a:srgbClr val="F8F8F6"/>
-                    </a:solidFill>
-                  </a:tcPr>
-                </a:tc>
-                <a:tc>
-                  <a:txBody>
-                    <a:bodyPr/>
-                    <a:lstStyle/>
-                    <a:p>
-                      <a:pPr algn="r"/>
-                      <a:r>
-                        <a:rPr sz="1000">
-                          <a:solidFill>
-                            <a:srgbClr val="3F3F3F"/>
-                          </a:solidFill>
-                          <a:latin typeface="Encode Sans"/>
-                        </a:rPr>
-                        <a:t>-169.296</a:t>
+                        <a:t>153,0</a:t>
                       </a:r>
                     </a:p>
                   </a:txBody>

</xml_diff>

<commit_message>
data: update 2026-07-02 ( data.json despidos.json scraper/historical_despidos.json publicaciones_semana.pptx rrii_brutas.xlsx)
</commit_message>
<xml_diff>
--- a/publicaciones_semana.pptx
+++ b/publicaciones_semana.pptx
@@ -7,6 +7,7 @@
   <p:sldIdLst>
     <p:sldId id="256" r:id="rId7"/>
     <p:sldId id="257" r:id="rId8"/>
+    <p:sldId id="258" r:id="rId9"/>
   </p:sldIdLst>
   <p:sldSz cx="12191695" cy="6858000" type="screen4x3"/>
   <p:notesSz cx="6858000" cy="9144000"/>
@@ -3272,7 +3273,7 @@
                 </a:solidFill>
                 <a:latin typeface="Encode Sans"/>
               </a:rPr>
-              <a:t>1 publicaciones · datos oficiales INDEC / BCRA / Hacienda</a:t>
+              <a:t>2 publicaciones · datos oficiales INDEC / BCRA / Hacienda</a:t>
             </a:r>
           </a:p>
         </p:txBody>
@@ -4292,6 +4293,1038 @@
 </p:sld>
 </file>
 
+<file path=ppt/slides/slide3.xml><?xml version="1.0" encoding="utf-8"?>
+<p:sld xmlns:a="http://schemas.openxmlformats.org/drawingml/2006/main" xmlns:p="http://schemas.openxmlformats.org/presentationml/2006/main" xmlns:r="http://schemas.openxmlformats.org/officeDocument/2006/relationships">
+  <p:cSld>
+    <p:spTree>
+      <p:nvGrpSpPr>
+        <p:cNvPr id="1" name=""/>
+        <p:cNvGrpSpPr/>
+        <p:nvPr/>
+      </p:nvGrpSpPr>
+      <p:grpSpPr/>
+      <p:sp>
+        <p:nvSpPr>
+          <p:cNvPr id="2" name="Rectangle 1"/>
+          <p:cNvSpPr/>
+          <p:nvPr/>
+        </p:nvSpPr>
+        <p:spPr>
+          <a:xfrm>
+            <a:off x="0" y="0"/>
+            <a:ext cx="12191695" cy="274320"/>
+          </a:xfrm>
+          <a:prstGeom prst="rect">
+            <a:avLst/>
+          </a:prstGeom>
+          <a:solidFill>
+            <a:srgbClr val="00B2C9"/>
+          </a:solidFill>
+          <a:ln>
+            <a:noFill/>
+          </a:ln>
+        </p:spPr>
+        <p:style>
+          <a:lnRef idx="1">
+            <a:schemeClr val="accent1"/>
+          </a:lnRef>
+          <a:fillRef idx="3">
+            <a:schemeClr val="accent1"/>
+          </a:fillRef>
+          <a:effectRef idx="2">
+            <a:schemeClr val="accent1"/>
+          </a:effectRef>
+          <a:fontRef idx="minor">
+            <a:schemeClr val="lt1"/>
+          </a:fontRef>
+        </p:style>
+        <p:txBody>
+          <a:bodyPr rtlCol="0" anchor="ctr"/>
+          <a:lstStyle/>
+          <a:p>
+            <a:pPr algn="ctr"/>
+          </a:p>
+        </p:txBody>
+      </p:sp>
+      <p:sp>
+        <p:nvSpPr>
+          <p:cNvPr id="3" name="TextBox 2"/>
+          <p:cNvSpPr txBox="1"/>
+          <p:nvPr/>
+        </p:nvSpPr>
+        <p:spPr>
+          <a:xfrm>
+            <a:off x="411480" y="457200"/>
+            <a:ext cx="11368735" cy="914400"/>
+          </a:xfrm>
+          <a:prstGeom prst="rect">
+            <a:avLst/>
+          </a:prstGeom>
+          <a:noFill/>
+        </p:spPr>
+        <p:txBody>
+          <a:bodyPr wrap="square" lIns="0" rIns="0">
+            <a:spAutoFit/>
+          </a:bodyPr>
+          <a:lstStyle/>
+          <a:p>
+            <a:pPr algn="l"/>
+            <a:r>
+              <a:rPr sz="2600" b="1" i="0">
+                <a:solidFill>
+                  <a:srgbClr val="00B2C9"/>
+                </a:solidFill>
+                <a:latin typeface="Encode Sans"/>
+              </a:rPr>
+              <a:t>RECAUDACIÓN JUNIO 2026: CAYÓ -6.0% REAL I.A.</a:t>
+            </a:r>
+          </a:p>
+        </p:txBody>
+      </p:sp>
+      <p:sp>
+        <p:nvSpPr>
+          <p:cNvPr id="4" name="TextBox 3"/>
+          <p:cNvSpPr txBox="1"/>
+          <p:nvPr/>
+        </p:nvSpPr>
+        <p:spPr>
+          <a:xfrm>
+            <a:off x="411480" y="1280160"/>
+            <a:ext cx="11368735" cy="274320"/>
+          </a:xfrm>
+          <a:prstGeom prst="rect">
+            <a:avLst/>
+          </a:prstGeom>
+          <a:noFill/>
+        </p:spPr>
+        <p:txBody>
+          <a:bodyPr wrap="none">
+            <a:spAutoFit/>
+          </a:bodyPr>
+          <a:lstStyle/>
+          <a:p>
+            <a:r>
+              <a:rPr sz="1100" b="0" i="1">
+                <a:solidFill>
+                  <a:srgbClr val="6A6760"/>
+                </a:solidFill>
+                <a:latin typeface="Encode Sans"/>
+              </a:rPr>
+              <a:t>AFIP/ARCA · período 2026-06</a:t>
+            </a:r>
+          </a:p>
+        </p:txBody>
+      </p:sp>
+      <p:sp>
+        <p:nvSpPr>
+          <p:cNvPr id="5" name="TextBox 4"/>
+          <p:cNvSpPr txBox="1"/>
+          <p:nvPr/>
+        </p:nvSpPr>
+        <p:spPr>
+          <a:xfrm>
+            <a:off x="411480" y="1691640"/>
+            <a:ext cx="5486400" cy="1645920"/>
+          </a:xfrm>
+          <a:prstGeom prst="rect">
+            <a:avLst/>
+          </a:prstGeom>
+          <a:noFill/>
+        </p:spPr>
+        <p:txBody>
+          <a:bodyPr wrap="square" lIns="0" rIns="0">
+            <a:spAutoFit/>
+          </a:bodyPr>
+          <a:lstStyle/>
+          <a:p>
+            <a:pPr algn="just"/>
+            <a:r>
+              <a:rPr sz="1300" b="0" i="0">
+                <a:solidFill>
+                  <a:srgbClr val="3F3F3F"/>
+                </a:solidFill>
+                <a:latin typeface="Encode Sans"/>
+              </a:rPr>
+              <a:t>AFIP/ARCA recaudó $20.017K millones en junio 2026. Variación nominal interanual: +23.7%. En términos reales (deflactado por REM): -6.0% i.a.</a:t>
+            </a:r>
+          </a:p>
+        </p:txBody>
+      </p:sp>
+      <p:sp>
+        <p:nvSpPr>
+          <p:cNvPr id="6" name="TextBox 5"/>
+          <p:cNvSpPr txBox="1"/>
+          <p:nvPr/>
+        </p:nvSpPr>
+        <p:spPr>
+          <a:xfrm>
+            <a:off x="411480" y="3520440"/>
+            <a:ext cx="5486400" cy="2743200"/>
+          </a:xfrm>
+          <a:prstGeom prst="rect">
+            <a:avLst/>
+          </a:prstGeom>
+          <a:noFill/>
+        </p:spPr>
+        <p:txBody>
+          <a:bodyPr wrap="square" lIns="0" rIns="0">
+            <a:spAutoFit/>
+          </a:bodyPr>
+          <a:lstStyle/>
+          <a:p>
+            <a:pPr algn="l">
+              <a:spcAft>
+                <a:spcPts val="800"/>
+              </a:spcAft>
+            </a:pPr>
+            <a:r>
+              <a:rPr sz="1300" b="1" i="0">
+                <a:solidFill>
+                  <a:srgbClr val="00B2C9"/>
+                </a:solidFill>
+                <a:latin typeface="Encode Sans"/>
+              </a:rPr>
+              <a:t>●  </a:t>
+            </a:r>
+            <a:r>
+              <a:rPr sz="1300" b="0" i="0">
+                <a:solidFill>
+                  <a:srgbClr val="3F3F3F"/>
+                </a:solidFill>
+                <a:latin typeface="Encode Sans"/>
+              </a:rPr>
+              <a:t>Total: $20.017K M$</a:t>
+            </a:r>
+          </a:p>
+          <a:p>
+            <a:pPr algn="l">
+              <a:spcAft>
+                <a:spcPts val="800"/>
+              </a:spcAft>
+            </a:pPr>
+            <a:r>
+              <a:rPr sz="1300" b="1" i="0">
+                <a:solidFill>
+                  <a:srgbClr val="00B2C9"/>
+                </a:solidFill>
+                <a:latin typeface="Encode Sans"/>
+              </a:rPr>
+              <a:t>●  </a:t>
+            </a:r>
+            <a:r>
+              <a:rPr sz="1300" b="0" i="0">
+                <a:solidFill>
+                  <a:srgbClr val="3F3F3F"/>
+                </a:solidFill>
+                <a:latin typeface="Encode Sans"/>
+              </a:rPr>
+              <a:t>Variación nominal i.a.: +23.7%</a:t>
+            </a:r>
+          </a:p>
+          <a:p>
+            <a:pPr algn="l">
+              <a:spcAft>
+                <a:spcPts val="800"/>
+              </a:spcAft>
+            </a:pPr>
+            <a:r>
+              <a:rPr sz="1300" b="1" i="0">
+                <a:solidFill>
+                  <a:srgbClr val="00B2C9"/>
+                </a:solidFill>
+                <a:latin typeface="Encode Sans"/>
+              </a:rPr>
+              <a:t>●  </a:t>
+            </a:r>
+            <a:r>
+              <a:rPr sz="1300" b="0" i="0">
+                <a:solidFill>
+                  <a:srgbClr val="3F3F3F"/>
+                </a:solidFill>
+                <a:latin typeface="Encode Sans"/>
+              </a:rPr>
+              <a:t>Variación real i.a.: -6.0% (deflactor: REM)</a:t>
+            </a:r>
+          </a:p>
+          <a:p>
+            <a:pPr algn="l">
+              <a:spcAft>
+                <a:spcPts val="800"/>
+              </a:spcAft>
+            </a:pPr>
+            <a:r>
+              <a:rPr sz="1300" b="1" i="0">
+                <a:solidFill>
+                  <a:srgbClr val="00B2C9"/>
+                </a:solidFill>
+                <a:latin typeface="Encode Sans"/>
+              </a:rPr>
+              <a:t>●  </a:t>
+            </a:r>
+            <a:r>
+              <a:rPr sz="1300" b="0" i="0">
+                <a:solidFill>
+                  <a:srgbClr val="3F3F3F"/>
+                </a:solidFill>
+                <a:latin typeface="Encode Sans"/>
+              </a:rPr>
+              <a:t>Fuente: ARCA (ex AFIP) · indec.gob.ar series</a:t>
+            </a:r>
+          </a:p>
+        </p:txBody>
+      </p:sp>
+      <p:pic>
+        <p:nvPicPr>
+          <p:cNvPr id="7" name="Picture 6" descr="image.png"/>
+          <p:cNvPicPr>
+            <a:picLocks noChangeAspect="1"/>
+          </p:cNvPicPr>
+          <p:nvPr/>
+        </p:nvPicPr>
+        <p:blipFill>
+          <a:blip r:embed="rId2"/>
+          <a:stretch>
+            <a:fillRect/>
+          </a:stretch>
+        </p:blipFill>
+        <p:spPr>
+          <a:xfrm>
+            <a:off x="6080760" y="1691640"/>
+            <a:ext cx="5669280" cy="2560320"/>
+          </a:xfrm>
+          <a:prstGeom prst="rect">
+            <a:avLst/>
+          </a:prstGeom>
+        </p:spPr>
+      </p:pic>
+      <p:graphicFrame>
+        <p:nvGraphicFramePr>
+          <p:cNvPr id="8" name="Table 7"/>
+          <p:cNvGraphicFramePr>
+            <a:graphicFrameLocks noGrp="1"/>
+          </p:cNvGraphicFramePr>
+          <p:nvPr/>
+        </p:nvGraphicFramePr>
+        <p:xfrm>
+          <a:off x="6080760" y="4434840"/>
+          <a:ext cx="5669280" cy="2048256"/>
+        </p:xfrm>
+        <a:graphic>
+          <a:graphicData uri="http://schemas.openxmlformats.org/drawingml/2006/table">
+            <a:tbl>
+              <a:tblPr firstRow="1" bandRow="1">
+                <a:tableStyleId>{5C22544A-7EE6-4342-B048-85BDC9FD1C3A}</a:tableStyleId>
+              </a:tblPr>
+              <a:tblGrid>
+                <a:gridCol w="1417320"/>
+                <a:gridCol w="1417320"/>
+                <a:gridCol w="1417320"/>
+                <a:gridCol w="1417320"/>
+              </a:tblGrid>
+              <a:tr h="292608">
+                <a:tc>
+                  <a:txBody>
+                    <a:bodyPr/>
+                    <a:lstStyle/>
+                    <a:p>
+                      <a:pPr algn="l"/>
+                      <a:r>
+                        <a:rPr sz="1000" b="1">
+                          <a:solidFill>
+                            <a:srgbClr val="FFFFFF"/>
+                          </a:solidFill>
+                          <a:latin typeface="Encode Sans"/>
+                        </a:rPr>
+                        <a:t>Mes</a:t>
+                      </a:r>
+                    </a:p>
+                  </a:txBody>
+                  <a:tcPr marL="36576" marR="36576" marT="18288" marB="18288">
+                    <a:solidFill>
+                      <a:srgbClr val="00B2C9"/>
+                    </a:solidFill>
+                  </a:tcPr>
+                </a:tc>
+                <a:tc>
+                  <a:txBody>
+                    <a:bodyPr/>
+                    <a:lstStyle/>
+                    <a:p>
+                      <a:pPr algn="r"/>
+                      <a:r>
+                        <a:rPr sz="1000" b="1">
+                          <a:solidFill>
+                            <a:srgbClr val="FFFFFF"/>
+                          </a:solidFill>
+                          <a:latin typeface="Encode Sans"/>
+                        </a:rPr>
+                        <a:t>Total M$</a:t>
+                      </a:r>
+                    </a:p>
+                  </a:txBody>
+                  <a:tcPr marL="36576" marR="36576" marT="18288" marB="18288">
+                    <a:solidFill>
+                      <a:srgbClr val="00B2C9"/>
+                    </a:solidFill>
+                  </a:tcPr>
+                </a:tc>
+                <a:tc>
+                  <a:txBody>
+                    <a:bodyPr/>
+                    <a:lstStyle/>
+                    <a:p>
+                      <a:pPr algn="r"/>
+                      <a:r>
+                        <a:rPr sz="1000" b="1">
+                          <a:solidFill>
+                            <a:srgbClr val="FFFFFF"/>
+                          </a:solidFill>
+                          <a:latin typeface="Encode Sans"/>
+                        </a:rPr>
+                        <a:t>Var. nom. i.a.</a:t>
+                      </a:r>
+                    </a:p>
+                  </a:txBody>
+                  <a:tcPr marL="36576" marR="36576" marT="18288" marB="18288">
+                    <a:solidFill>
+                      <a:srgbClr val="00B2C9"/>
+                    </a:solidFill>
+                  </a:tcPr>
+                </a:tc>
+                <a:tc>
+                  <a:txBody>
+                    <a:bodyPr/>
+                    <a:lstStyle/>
+                    <a:p>
+                      <a:pPr algn="r"/>
+                      <a:r>
+                        <a:rPr sz="1000" b="1">
+                          <a:solidFill>
+                            <a:srgbClr val="FFFFFF"/>
+                          </a:solidFill>
+                          <a:latin typeface="Encode Sans"/>
+                        </a:rPr>
+                        <a:t>Var. real i.a.</a:t>
+                      </a:r>
+                    </a:p>
+                  </a:txBody>
+                  <a:tcPr marL="36576" marR="36576" marT="18288" marB="18288">
+                    <a:solidFill>
+                      <a:srgbClr val="00B2C9"/>
+                    </a:solidFill>
+                  </a:tcPr>
+                </a:tc>
+              </a:tr>
+              <a:tr h="292608">
+                <a:tc>
+                  <a:txBody>
+                    <a:bodyPr/>
+                    <a:lstStyle/>
+                    <a:p>
+                      <a:pPr algn="l"/>
+                      <a:r>
+                        <a:rPr sz="1000">
+                          <a:solidFill>
+                            <a:srgbClr val="3F3F3F"/>
+                          </a:solidFill>
+                          <a:latin typeface="Encode Sans"/>
+                        </a:rPr>
+                        <a:t>Junio 2026</a:t>
+                      </a:r>
+                    </a:p>
+                  </a:txBody>
+                  <a:tcPr marL="36576" marR="36576" marT="18288" marB="18288">
+                    <a:solidFill>
+                      <a:srgbClr val="FFFFFF"/>
+                    </a:solidFill>
+                  </a:tcPr>
+                </a:tc>
+                <a:tc>
+                  <a:txBody>
+                    <a:bodyPr/>
+                    <a:lstStyle/>
+                    <a:p>
+                      <a:pPr algn="r"/>
+                      <a:r>
+                        <a:rPr sz="1000">
+                          <a:solidFill>
+                            <a:srgbClr val="3F3F3F"/>
+                          </a:solidFill>
+                          <a:latin typeface="Encode Sans"/>
+                        </a:rPr>
+                        <a:t>20.017K</a:t>
+                      </a:r>
+                    </a:p>
+                  </a:txBody>
+                  <a:tcPr marL="36576" marR="36576" marT="18288" marB="18288">
+                    <a:solidFill>
+                      <a:srgbClr val="FFFFFF"/>
+                    </a:solidFill>
+                  </a:tcPr>
+                </a:tc>
+                <a:tc>
+                  <a:txBody>
+                    <a:bodyPr/>
+                    <a:lstStyle/>
+                    <a:p>
+                      <a:pPr algn="r"/>
+                      <a:r>
+                        <a:rPr sz="1000">
+                          <a:solidFill>
+                            <a:srgbClr val="3F3F3F"/>
+                          </a:solidFill>
+                          <a:latin typeface="Encode Sans"/>
+                        </a:rPr>
+                        <a:t>—</a:t>
+                      </a:r>
+                    </a:p>
+                  </a:txBody>
+                  <a:tcPr marL="36576" marR="36576" marT="18288" marB="18288">
+                    <a:solidFill>
+                      <a:srgbClr val="FFFFFF"/>
+                    </a:solidFill>
+                  </a:tcPr>
+                </a:tc>
+                <a:tc>
+                  <a:txBody>
+                    <a:bodyPr/>
+                    <a:lstStyle/>
+                    <a:p>
+                      <a:pPr algn="r"/>
+                      <a:r>
+                        <a:rPr sz="1000">
+                          <a:solidFill>
+                            <a:srgbClr val="3F3F3F"/>
+                          </a:solidFill>
+                          <a:latin typeface="Encode Sans"/>
+                        </a:rPr>
+                        <a:t>—</a:t>
+                      </a:r>
+                    </a:p>
+                  </a:txBody>
+                  <a:tcPr marL="36576" marR="36576" marT="18288" marB="18288">
+                    <a:solidFill>
+                      <a:srgbClr val="FFFFFF"/>
+                    </a:solidFill>
+                  </a:tcPr>
+                </a:tc>
+              </a:tr>
+              <a:tr h="292608">
+                <a:tc>
+                  <a:txBody>
+                    <a:bodyPr/>
+                    <a:lstStyle/>
+                    <a:p>
+                      <a:pPr algn="l"/>
+                      <a:r>
+                        <a:rPr sz="1000">
+                          <a:solidFill>
+                            <a:srgbClr val="3F3F3F"/>
+                          </a:solidFill>
+                          <a:latin typeface="Encode Sans"/>
+                        </a:rPr>
+                        <a:t>Mayo 2026</a:t>
+                      </a:r>
+                    </a:p>
+                  </a:txBody>
+                  <a:tcPr marL="36576" marR="36576" marT="18288" marB="18288">
+                    <a:solidFill>
+                      <a:srgbClr val="F8F8F6"/>
+                    </a:solidFill>
+                  </a:tcPr>
+                </a:tc>
+                <a:tc>
+                  <a:txBody>
+                    <a:bodyPr/>
+                    <a:lstStyle/>
+                    <a:p>
+                      <a:pPr algn="r"/>
+                      <a:r>
+                        <a:rPr sz="1000">
+                          <a:solidFill>
+                            <a:srgbClr val="3F3F3F"/>
+                          </a:solidFill>
+                          <a:latin typeface="Encode Sans"/>
+                        </a:rPr>
+                        <a:t>21.514K</a:t>
+                      </a:r>
+                    </a:p>
+                  </a:txBody>
+                  <a:tcPr marL="36576" marR="36576" marT="18288" marB="18288">
+                    <a:solidFill>
+                      <a:srgbClr val="F8F8F6"/>
+                    </a:solidFill>
+                  </a:tcPr>
+                </a:tc>
+                <a:tc>
+                  <a:txBody>
+                    <a:bodyPr/>
+                    <a:lstStyle/>
+                    <a:p>
+                      <a:pPr algn="r"/>
+                      <a:r>
+                        <a:rPr sz="1000">
+                          <a:solidFill>
+                            <a:srgbClr val="3F3F3F"/>
+                          </a:solidFill>
+                          <a:latin typeface="Encode Sans"/>
+                        </a:rPr>
+                        <a:t>—</a:t>
+                      </a:r>
+                    </a:p>
+                  </a:txBody>
+                  <a:tcPr marL="36576" marR="36576" marT="18288" marB="18288">
+                    <a:solidFill>
+                      <a:srgbClr val="F8F8F6"/>
+                    </a:solidFill>
+                  </a:tcPr>
+                </a:tc>
+                <a:tc>
+                  <a:txBody>
+                    <a:bodyPr/>
+                    <a:lstStyle/>
+                    <a:p>
+                      <a:pPr algn="r"/>
+                      <a:r>
+                        <a:rPr sz="1000">
+                          <a:solidFill>
+                            <a:srgbClr val="3F3F3F"/>
+                          </a:solidFill>
+                          <a:latin typeface="Encode Sans"/>
+                        </a:rPr>
+                        <a:t>—</a:t>
+                      </a:r>
+                    </a:p>
+                  </a:txBody>
+                  <a:tcPr marL="36576" marR="36576" marT="18288" marB="18288">
+                    <a:solidFill>
+                      <a:srgbClr val="F8F8F6"/>
+                    </a:solidFill>
+                  </a:tcPr>
+                </a:tc>
+              </a:tr>
+              <a:tr h="292608">
+                <a:tc>
+                  <a:txBody>
+                    <a:bodyPr/>
+                    <a:lstStyle/>
+                    <a:p>
+                      <a:pPr algn="l"/>
+                      <a:r>
+                        <a:rPr sz="1000">
+                          <a:solidFill>
+                            <a:srgbClr val="3F3F3F"/>
+                          </a:solidFill>
+                          <a:latin typeface="Encode Sans"/>
+                        </a:rPr>
+                        <a:t>Abril 2026</a:t>
+                      </a:r>
+                    </a:p>
+                  </a:txBody>
+                  <a:tcPr marL="36576" marR="36576" marT="18288" marB="18288">
+                    <a:solidFill>
+                      <a:srgbClr val="FFFFFF"/>
+                    </a:solidFill>
+                  </a:tcPr>
+                </a:tc>
+                <a:tc>
+                  <a:txBody>
+                    <a:bodyPr/>
+                    <a:lstStyle/>
+                    <a:p>
+                      <a:pPr algn="r"/>
+                      <a:r>
+                        <a:rPr sz="1000">
+                          <a:solidFill>
+                            <a:srgbClr val="3F3F3F"/>
+                          </a:solidFill>
+                          <a:latin typeface="Encode Sans"/>
+                        </a:rPr>
+                        <a:t>17.401K</a:t>
+                      </a:r>
+                    </a:p>
+                  </a:txBody>
+                  <a:tcPr marL="36576" marR="36576" marT="18288" marB="18288">
+                    <a:solidFill>
+                      <a:srgbClr val="FFFFFF"/>
+                    </a:solidFill>
+                  </a:tcPr>
+                </a:tc>
+                <a:tc>
+                  <a:txBody>
+                    <a:bodyPr/>
+                    <a:lstStyle/>
+                    <a:p>
+                      <a:pPr algn="r"/>
+                      <a:r>
+                        <a:rPr sz="1000">
+                          <a:solidFill>
+                            <a:srgbClr val="3F3F3F"/>
+                          </a:solidFill>
+                          <a:latin typeface="Encode Sans"/>
+                        </a:rPr>
+                        <a:t>—</a:t>
+                      </a:r>
+                    </a:p>
+                  </a:txBody>
+                  <a:tcPr marL="36576" marR="36576" marT="18288" marB="18288">
+                    <a:solidFill>
+                      <a:srgbClr val="FFFFFF"/>
+                    </a:solidFill>
+                  </a:tcPr>
+                </a:tc>
+                <a:tc>
+                  <a:txBody>
+                    <a:bodyPr/>
+                    <a:lstStyle/>
+                    <a:p>
+                      <a:pPr algn="r"/>
+                      <a:r>
+                        <a:rPr sz="1000">
+                          <a:solidFill>
+                            <a:srgbClr val="3F3F3F"/>
+                          </a:solidFill>
+                          <a:latin typeface="Encode Sans"/>
+                        </a:rPr>
+                        <a:t>—</a:t>
+                      </a:r>
+                    </a:p>
+                  </a:txBody>
+                  <a:tcPr marL="36576" marR="36576" marT="18288" marB="18288">
+                    <a:solidFill>
+                      <a:srgbClr val="FFFFFF"/>
+                    </a:solidFill>
+                  </a:tcPr>
+                </a:tc>
+              </a:tr>
+              <a:tr h="292608">
+                <a:tc>
+                  <a:txBody>
+                    <a:bodyPr/>
+                    <a:lstStyle/>
+                    <a:p>
+                      <a:pPr algn="l"/>
+                      <a:r>
+                        <a:rPr sz="1000">
+                          <a:solidFill>
+                            <a:srgbClr val="3F3F3F"/>
+                          </a:solidFill>
+                          <a:latin typeface="Encode Sans"/>
+                        </a:rPr>
+                        <a:t>Marzo 2026</a:t>
+                      </a:r>
+                    </a:p>
+                  </a:txBody>
+                  <a:tcPr marL="36576" marR="36576" marT="18288" marB="18288">
+                    <a:solidFill>
+                      <a:srgbClr val="F8F8F6"/>
+                    </a:solidFill>
+                  </a:tcPr>
+                </a:tc>
+                <a:tc>
+                  <a:txBody>
+                    <a:bodyPr/>
+                    <a:lstStyle/>
+                    <a:p>
+                      <a:pPr algn="r"/>
+                      <a:r>
+                        <a:rPr sz="1000">
+                          <a:solidFill>
+                            <a:srgbClr val="3F3F3F"/>
+                          </a:solidFill>
+                          <a:latin typeface="Encode Sans"/>
+                        </a:rPr>
+                        <a:t>16.071K</a:t>
+                      </a:r>
+                    </a:p>
+                  </a:txBody>
+                  <a:tcPr marL="36576" marR="36576" marT="18288" marB="18288">
+                    <a:solidFill>
+                      <a:srgbClr val="F8F8F6"/>
+                    </a:solidFill>
+                  </a:tcPr>
+                </a:tc>
+                <a:tc>
+                  <a:txBody>
+                    <a:bodyPr/>
+                    <a:lstStyle/>
+                    <a:p>
+                      <a:pPr algn="r"/>
+                      <a:r>
+                        <a:rPr sz="1000">
+                          <a:solidFill>
+                            <a:srgbClr val="3F3F3F"/>
+                          </a:solidFill>
+                          <a:latin typeface="Encode Sans"/>
+                        </a:rPr>
+                        <a:t>26.21%</a:t>
+                      </a:r>
+                    </a:p>
+                  </a:txBody>
+                  <a:tcPr marL="36576" marR="36576" marT="18288" marB="18288">
+                    <a:solidFill>
+                      <a:srgbClr val="F8F8F6"/>
+                    </a:solidFill>
+                  </a:tcPr>
+                </a:tc>
+                <a:tc>
+                  <a:txBody>
+                    <a:bodyPr/>
+                    <a:lstStyle/>
+                    <a:p>
+                      <a:pPr algn="r"/>
+                      <a:r>
+                        <a:rPr sz="1000">
+                          <a:solidFill>
+                            <a:srgbClr val="3F3F3F"/>
+                          </a:solidFill>
+                          <a:latin typeface="Encode Sans"/>
+                        </a:rPr>
+                        <a:t>—</a:t>
+                      </a:r>
+                    </a:p>
+                  </a:txBody>
+                  <a:tcPr marL="36576" marR="36576" marT="18288" marB="18288">
+                    <a:solidFill>
+                      <a:srgbClr val="F8F8F6"/>
+                    </a:solidFill>
+                  </a:tcPr>
+                </a:tc>
+              </a:tr>
+              <a:tr h="292608">
+                <a:tc>
+                  <a:txBody>
+                    <a:bodyPr/>
+                    <a:lstStyle/>
+                    <a:p>
+                      <a:pPr algn="l"/>
+                      <a:r>
+                        <a:rPr sz="1000">
+                          <a:solidFill>
+                            <a:srgbClr val="3F3F3F"/>
+                          </a:solidFill>
+                          <a:latin typeface="Encode Sans"/>
+                        </a:rPr>
+                        <a:t>Febrero 2026</a:t>
+                      </a:r>
+                    </a:p>
+                  </a:txBody>
+                  <a:tcPr marL="36576" marR="36576" marT="18288" marB="18288">
+                    <a:solidFill>
+                      <a:srgbClr val="FFFFFF"/>
+                    </a:solidFill>
+                  </a:tcPr>
+                </a:tc>
+                <a:tc>
+                  <a:txBody>
+                    <a:bodyPr/>
+                    <a:lstStyle/>
+                    <a:p>
+                      <a:pPr algn="r"/>
+                      <a:r>
+                        <a:rPr sz="1000">
+                          <a:solidFill>
+                            <a:srgbClr val="3F3F3F"/>
+                          </a:solidFill>
+                          <a:latin typeface="Encode Sans"/>
+                        </a:rPr>
+                        <a:t>16.232K</a:t>
+                      </a:r>
+                    </a:p>
+                  </a:txBody>
+                  <a:tcPr marL="36576" marR="36576" marT="18288" marB="18288">
+                    <a:solidFill>
+                      <a:srgbClr val="FFFFFF"/>
+                    </a:solidFill>
+                  </a:tcPr>
+                </a:tc>
+                <a:tc>
+                  <a:txBody>
+                    <a:bodyPr/>
+                    <a:lstStyle/>
+                    <a:p>
+                      <a:pPr algn="r"/>
+                      <a:r>
+                        <a:rPr sz="1000">
+                          <a:solidFill>
+                            <a:srgbClr val="3F3F3F"/>
+                          </a:solidFill>
+                          <a:latin typeface="Encode Sans"/>
+                        </a:rPr>
+                        <a:t>20.05%</a:t>
+                      </a:r>
+                    </a:p>
+                  </a:txBody>
+                  <a:tcPr marL="36576" marR="36576" marT="18288" marB="18288">
+                    <a:solidFill>
+                      <a:srgbClr val="FFFFFF"/>
+                    </a:solidFill>
+                  </a:tcPr>
+                </a:tc>
+                <a:tc>
+                  <a:txBody>
+                    <a:bodyPr/>
+                    <a:lstStyle/>
+                    <a:p>
+                      <a:pPr algn="r"/>
+                      <a:r>
+                        <a:rPr sz="1000">
+                          <a:solidFill>
+                            <a:srgbClr val="3F3F3F"/>
+                          </a:solidFill>
+                          <a:latin typeface="Encode Sans"/>
+                        </a:rPr>
+                        <a:t>-9.77%</a:t>
+                      </a:r>
+                    </a:p>
+                  </a:txBody>
+                  <a:tcPr marL="36576" marR="36576" marT="18288" marB="18288">
+                    <a:solidFill>
+                      <a:srgbClr val="FFFFFF"/>
+                    </a:solidFill>
+                  </a:tcPr>
+                </a:tc>
+              </a:tr>
+              <a:tr h="292608">
+                <a:tc>
+                  <a:txBody>
+                    <a:bodyPr/>
+                    <a:lstStyle/>
+                    <a:p>
+                      <a:pPr algn="l"/>
+                      <a:r>
+                        <a:rPr sz="1000">
+                          <a:solidFill>
+                            <a:srgbClr val="3F3F3F"/>
+                          </a:solidFill>
+                          <a:latin typeface="Encode Sans"/>
+                        </a:rPr>
+                        <a:t>Enero 2026</a:t>
+                      </a:r>
+                    </a:p>
+                  </a:txBody>
+                  <a:tcPr marL="36576" marR="36576" marT="18288" marB="18288">
+                    <a:solidFill>
+                      <a:srgbClr val="F8F8F6"/>
+                    </a:solidFill>
+                  </a:tcPr>
+                </a:tc>
+                <a:tc>
+                  <a:txBody>
+                    <a:bodyPr/>
+                    <a:lstStyle/>
+                    <a:p>
+                      <a:pPr algn="r"/>
+                      <a:r>
+                        <a:rPr sz="1000">
+                          <a:solidFill>
+                            <a:srgbClr val="3F3F3F"/>
+                          </a:solidFill>
+                          <a:latin typeface="Encode Sans"/>
+                        </a:rPr>
+                        <a:t>18.338K</a:t>
+                      </a:r>
+                    </a:p>
+                  </a:txBody>
+                  <a:tcPr marL="36576" marR="36576" marT="18288" marB="18288">
+                    <a:solidFill>
+                      <a:srgbClr val="F8F8F6"/>
+                    </a:solidFill>
+                  </a:tcPr>
+                </a:tc>
+                <a:tc>
+                  <a:txBody>
+                    <a:bodyPr/>
+                    <a:lstStyle/>
+                    <a:p>
+                      <a:pPr algn="r"/>
+                      <a:r>
+                        <a:rPr sz="1000">
+                          <a:solidFill>
+                            <a:srgbClr val="3F3F3F"/>
+                          </a:solidFill>
+                          <a:latin typeface="Encode Sans"/>
+                        </a:rPr>
+                        <a:t>21.99%</a:t>
+                      </a:r>
+                    </a:p>
+                  </a:txBody>
+                  <a:tcPr marL="36576" marR="36576" marT="18288" marB="18288">
+                    <a:solidFill>
+                      <a:srgbClr val="F8F8F6"/>
+                    </a:solidFill>
+                  </a:tcPr>
+                </a:tc>
+                <a:tc>
+                  <a:txBody>
+                    <a:bodyPr/>
+                    <a:lstStyle/>
+                    <a:p>
+                      <a:pPr algn="r"/>
+                      <a:r>
+                        <a:rPr sz="1000">
+                          <a:solidFill>
+                            <a:srgbClr val="3F3F3F"/>
+                          </a:solidFill>
+                          <a:latin typeface="Encode Sans"/>
+                        </a:rPr>
+                        <a:t>-7.87%</a:t>
+                      </a:r>
+                    </a:p>
+                  </a:txBody>
+                  <a:tcPr marL="36576" marR="36576" marT="18288" marB="18288">
+                    <a:solidFill>
+                      <a:srgbClr val="F8F8F6"/>
+                    </a:solidFill>
+                  </a:tcPr>
+                </a:tc>
+              </a:tr>
+            </a:tbl>
+          </a:graphicData>
+        </a:graphic>
+      </p:graphicFrame>
+      <p:sp>
+        <p:nvSpPr>
+          <p:cNvPr id="9" name="TextBox 8"/>
+          <p:cNvSpPr txBox="1"/>
+          <p:nvPr/>
+        </p:nvSpPr>
+        <p:spPr>
+          <a:xfrm>
+            <a:off x="411480" y="6492240"/>
+            <a:ext cx="11368735" cy="274320"/>
+          </a:xfrm>
+          <a:prstGeom prst="rect">
+            <a:avLst/>
+          </a:prstGeom>
+          <a:noFill/>
+        </p:spPr>
+        <p:txBody>
+          <a:bodyPr wrap="none">
+            <a:spAutoFit/>
+          </a:bodyPr>
+          <a:lstStyle/>
+          <a:p>
+            <a:r>
+              <a:rPr sz="1000" b="0" i="1">
+                <a:solidFill>
+                  <a:srgbClr val="6A6760"/>
+                </a:solidFill>
+                <a:latin typeface="Encode Sans"/>
+              </a:rPr>
+              <a:t>Fuente: elaboración propia en base a AFIP/ARCA</a:t>
+            </a:r>
+          </a:p>
+        </p:txBody>
+      </p:sp>
+    </p:spTree>
+  </p:cSld>
+  <p:clrMapOvr>
+    <a:masterClrMapping/>
+  </p:clrMapOvr>
+</p:sld>
+</file>
+
 <file path=ppt/theme/theme1.xml><?xml version="1.0" encoding="utf-8"?>
 <a:theme xmlns:a="http://schemas.openxmlformats.org/drawingml/2006/main" name="Office Theme">
   <a:themeElements>

</xml_diff>

<commit_message>
mora mayo 2026 + endeudamiento de personas (fintech vs bancos, por edad)
- Mora familias 12,7% / empresas 3,5% (mayo, preliminar 1816/CENDEU hasta Informe BCRA).
- Nuevo bloque D.endeu: ~6,9M excluidos del crédito, 32,2% mora en entidades no
  financieras (fintech/billeteras) vs 12,7% bancos, mora por tramo de edad.
- Dashboard: sección "Endeudamiento de las personas" en Financiero (buildEndeu,
  desacoplada de la API BCRA), con comparativa bancos vs no financieras y por edad.
- Fix _applyDataJson: ahora propaga objetos (no solo arrays) para D.endeu.

Co-Authored-By: Claude Opus 4.8 <noreply@anthropic.com>
</commit_message>
<xml_diff>
--- a/publicaciones_semana.pptx
+++ b/publicaciones_semana.pptx
@@ -8,6 +8,7 @@
     <p:sldId id="256" r:id="rId7"/>
     <p:sldId id="257" r:id="rId8"/>
     <p:sldId id="258" r:id="rId9"/>
+    <p:sldId id="259" r:id="rId10"/>
   </p:sldIdLst>
   <p:sldSz cx="12191695" cy="6858000" type="screen4x3"/>
   <p:notesSz cx="6858000" cy="9144000"/>
@@ -3273,7 +3274,7 @@
                 </a:solidFill>
                 <a:latin typeface="Encode Sans"/>
               </a:rPr>
-              <a:t>2 publicaciones · datos oficiales INDEC / BCRA / Hacienda</a:t>
+              <a:t>3 publicaciones · datos oficiales INDEC / BCRA / Hacienda</a:t>
             </a:r>
           </a:p>
         </p:txBody>
@@ -4294,6 +4295,876 @@
 </file>
 
 <file path=ppt/slides/slide3.xml><?xml version="1.0" encoding="utf-8"?>
+<p:sld xmlns:a="http://schemas.openxmlformats.org/drawingml/2006/main" xmlns:p="http://schemas.openxmlformats.org/presentationml/2006/main" xmlns:r="http://schemas.openxmlformats.org/officeDocument/2006/relationships">
+  <p:cSld>
+    <p:spTree>
+      <p:nvGrpSpPr>
+        <p:cNvPr id="1" name=""/>
+        <p:cNvGrpSpPr/>
+        <p:nvPr/>
+      </p:nvGrpSpPr>
+      <p:grpSpPr/>
+      <p:sp>
+        <p:nvSpPr>
+          <p:cNvPr id="2" name="Rectangle 1"/>
+          <p:cNvSpPr/>
+          <p:nvPr/>
+        </p:nvSpPr>
+        <p:spPr>
+          <a:xfrm>
+            <a:off x="0" y="0"/>
+            <a:ext cx="12191695" cy="274320"/>
+          </a:xfrm>
+          <a:prstGeom prst="rect">
+            <a:avLst/>
+          </a:prstGeom>
+          <a:solidFill>
+            <a:srgbClr val="00B2C9"/>
+          </a:solidFill>
+          <a:ln>
+            <a:noFill/>
+          </a:ln>
+        </p:spPr>
+        <p:style>
+          <a:lnRef idx="1">
+            <a:schemeClr val="accent1"/>
+          </a:lnRef>
+          <a:fillRef idx="3">
+            <a:schemeClr val="accent1"/>
+          </a:fillRef>
+          <a:effectRef idx="2">
+            <a:schemeClr val="accent1"/>
+          </a:effectRef>
+          <a:fontRef idx="minor">
+            <a:schemeClr val="lt1"/>
+          </a:fontRef>
+        </p:style>
+        <p:txBody>
+          <a:bodyPr rtlCol="0" anchor="ctr"/>
+          <a:lstStyle/>
+          <a:p>
+            <a:pPr algn="ctr"/>
+          </a:p>
+        </p:txBody>
+      </p:sp>
+      <p:sp>
+        <p:nvSpPr>
+          <p:cNvPr id="3" name="TextBox 2"/>
+          <p:cNvSpPr txBox="1"/>
+          <p:nvPr/>
+        </p:nvSpPr>
+        <p:spPr>
+          <a:xfrm>
+            <a:off x="411480" y="457200"/>
+            <a:ext cx="11368735" cy="914400"/>
+          </a:xfrm>
+          <a:prstGeom prst="rect">
+            <a:avLst/>
+          </a:prstGeom>
+          <a:noFill/>
+        </p:spPr>
+        <p:txBody>
+          <a:bodyPr wrap="square" lIns="0" rIns="0">
+            <a:spAutoFit/>
+          </a:bodyPr>
+          <a:lstStyle/>
+          <a:p>
+            <a:pPr algn="l"/>
+            <a:r>
+              <a:rPr sz="2600" b="1" i="0">
+                <a:solidFill>
+                  <a:srgbClr val="00B2C9"/>
+                </a:solidFill>
+                <a:latin typeface="Encode Sans"/>
+              </a:rPr>
+              <a:t>MORA BANCARIA MAYO 2026: FAMILIAS 12.7% · EMPRESAS 3.5% (PRELIMINAR)</a:t>
+            </a:r>
+          </a:p>
+        </p:txBody>
+      </p:sp>
+      <p:sp>
+        <p:nvSpPr>
+          <p:cNvPr id="4" name="TextBox 3"/>
+          <p:cNvSpPr txBox="1"/>
+          <p:nvPr/>
+        </p:nvSpPr>
+        <p:spPr>
+          <a:xfrm>
+            <a:off x="411480" y="1280160"/>
+            <a:ext cx="11368735" cy="274320"/>
+          </a:xfrm>
+          <a:prstGeom prst="rect">
+            <a:avLst/>
+          </a:prstGeom>
+          <a:noFill/>
+        </p:spPr>
+        <p:txBody>
+          <a:bodyPr wrap="none">
+            <a:spAutoFit/>
+          </a:bodyPr>
+          <a:lstStyle/>
+          <a:p>
+            <a:r>
+              <a:rPr sz="1100" b="0" i="1">
+                <a:solidFill>
+                  <a:srgbClr val="6A6760"/>
+                </a:solidFill>
+                <a:latin typeface="Encode Sans"/>
+              </a:rPr>
+              <a:t>BCRA Informe sobre Bancos · período 2026-05</a:t>
+            </a:r>
+          </a:p>
+        </p:txBody>
+      </p:sp>
+      <p:sp>
+        <p:nvSpPr>
+          <p:cNvPr id="5" name="TextBox 4"/>
+          <p:cNvSpPr txBox="1"/>
+          <p:nvPr/>
+        </p:nvSpPr>
+        <p:spPr>
+          <a:xfrm>
+            <a:off x="411480" y="1691640"/>
+            <a:ext cx="5486400" cy="1645920"/>
+          </a:xfrm>
+          <a:prstGeom prst="rect">
+            <a:avLst/>
+          </a:prstGeom>
+          <a:noFill/>
+        </p:spPr>
+        <p:txBody>
+          <a:bodyPr wrap="square" lIns="0" rIns="0">
+            <a:spAutoFit/>
+          </a:bodyPr>
+          <a:lstStyle/>
+          <a:p>
+            <a:pPr algn="just"/>
+            <a:r>
+              <a:rPr sz="1300" b="0" i="0">
+                <a:solidFill>
+                  <a:srgbClr val="3F3F3F"/>
+                </a:solidFill>
+                <a:latin typeface="Encode Sans"/>
+              </a:rPr>
+              <a:t>La irregularidad de cartera alcanzó 12.7% en familias y 3.5% en empresas en mayo 2026 (venía de 12.09% en abril 2026, +0.61 pp). Dato preliminar reportado por 1816/CENDEU (prelim · prev. Informe BCRA); el BCRA publicará el oficial en su próximo Informe sobre Bancos.</a:t>
+            </a:r>
+          </a:p>
+        </p:txBody>
+      </p:sp>
+      <p:sp>
+        <p:nvSpPr>
+          <p:cNvPr id="6" name="TextBox 5"/>
+          <p:cNvSpPr txBox="1"/>
+          <p:nvPr/>
+        </p:nvSpPr>
+        <p:spPr>
+          <a:xfrm>
+            <a:off x="411480" y="3520440"/>
+            <a:ext cx="5486400" cy="2743200"/>
+          </a:xfrm>
+          <a:prstGeom prst="rect">
+            <a:avLst/>
+          </a:prstGeom>
+          <a:noFill/>
+        </p:spPr>
+        <p:txBody>
+          <a:bodyPr wrap="square" lIns="0" rIns="0">
+            <a:spAutoFit/>
+          </a:bodyPr>
+          <a:lstStyle/>
+          <a:p>
+            <a:pPr algn="l">
+              <a:spcAft>
+                <a:spcPts val="800"/>
+              </a:spcAft>
+            </a:pPr>
+            <a:r>
+              <a:rPr sz="1300" b="1" i="0">
+                <a:solidFill>
+                  <a:srgbClr val="00B2C9"/>
+                </a:solidFill>
+                <a:latin typeface="Encode Sans"/>
+              </a:rPr>
+              <a:t>●  </a:t>
+            </a:r>
+            <a:r>
+              <a:rPr sz="1300" b="0" i="0">
+                <a:solidFill>
+                  <a:srgbClr val="3F3F3F"/>
+                </a:solidFill>
+                <a:latin typeface="Encode Sans"/>
+              </a:rPr>
+              <a:t>Familias: 12.7% del total de préstamos en situación irregular</a:t>
+            </a:r>
+          </a:p>
+          <a:p>
+            <a:pPr algn="l">
+              <a:spcAft>
+                <a:spcPts val="800"/>
+              </a:spcAft>
+            </a:pPr>
+            <a:r>
+              <a:rPr sz="1300" b="1" i="0">
+                <a:solidFill>
+                  <a:srgbClr val="00B2C9"/>
+                </a:solidFill>
+                <a:latin typeface="Encode Sans"/>
+              </a:rPr>
+              <a:t>●  </a:t>
+            </a:r>
+            <a:r>
+              <a:rPr sz="1300" b="0" i="0">
+                <a:solidFill>
+                  <a:srgbClr val="3F3F3F"/>
+                </a:solidFill>
+                <a:latin typeface="Encode Sans"/>
+              </a:rPr>
+              <a:t>Empresas: 3.5%</a:t>
+            </a:r>
+          </a:p>
+          <a:p>
+            <a:pPr algn="l">
+              <a:spcAft>
+                <a:spcPts val="800"/>
+              </a:spcAft>
+            </a:pPr>
+            <a:r>
+              <a:rPr sz="1300" b="1" i="0">
+                <a:solidFill>
+                  <a:srgbClr val="00B2C9"/>
+                </a:solidFill>
+                <a:latin typeface="Encode Sans"/>
+              </a:rPr>
+              <a:t>●  </a:t>
+            </a:r>
+            <a:r>
+              <a:rPr sz="1300" b="0" i="0">
+                <a:solidFill>
+                  <a:srgbClr val="3F3F3F"/>
+                </a:solidFill>
+                <a:latin typeface="Encode Sans"/>
+              </a:rPr>
+              <a:t>Fuente: 1816/CENDEU (prelim · prev. Informe BCRA)</a:t>
+            </a:r>
+          </a:p>
+          <a:p>
+            <a:pPr algn="l">
+              <a:spcAft>
+                <a:spcPts val="800"/>
+              </a:spcAft>
+            </a:pPr>
+            <a:r>
+              <a:rPr sz="1300" b="1" i="0">
+                <a:solidFill>
+                  <a:srgbClr val="00B2C9"/>
+                </a:solidFill>
+                <a:latin typeface="Encode Sans"/>
+              </a:rPr>
+              <a:t>●  </a:t>
+            </a:r>
+            <a:r>
+              <a:rPr sz="1300" b="0" i="0">
+                <a:solidFill>
+                  <a:srgbClr val="3F3F3F"/>
+                </a:solidFill>
+                <a:latin typeface="Encode Sans"/>
+              </a:rPr>
+              <a:t>⚠ Dato preliminar — sujeto a revisión cuando el BCRA publique el Informe oficial</a:t>
+            </a:r>
+          </a:p>
+        </p:txBody>
+      </p:sp>
+      <p:pic>
+        <p:nvPicPr>
+          <p:cNvPr id="7" name="Picture 6" descr="image.png"/>
+          <p:cNvPicPr>
+            <a:picLocks noChangeAspect="1"/>
+          </p:cNvPicPr>
+          <p:nvPr/>
+        </p:nvPicPr>
+        <p:blipFill>
+          <a:blip r:embed="rId2"/>
+          <a:stretch>
+            <a:fillRect/>
+          </a:stretch>
+        </p:blipFill>
+        <p:spPr>
+          <a:xfrm>
+            <a:off x="6080760" y="1691640"/>
+            <a:ext cx="5669280" cy="2560320"/>
+          </a:xfrm>
+          <a:prstGeom prst="rect">
+            <a:avLst/>
+          </a:prstGeom>
+        </p:spPr>
+      </p:pic>
+      <p:graphicFrame>
+        <p:nvGraphicFramePr>
+          <p:cNvPr id="8" name="Table 7"/>
+          <p:cNvGraphicFramePr>
+            <a:graphicFrameLocks noGrp="1"/>
+          </p:cNvGraphicFramePr>
+          <p:nvPr/>
+        </p:nvGraphicFramePr>
+        <p:xfrm>
+          <a:off x="6080760" y="4434840"/>
+          <a:ext cx="5669280" cy="2048256"/>
+        </p:xfrm>
+        <a:graphic>
+          <a:graphicData uri="http://schemas.openxmlformats.org/drawingml/2006/table">
+            <a:tbl>
+              <a:tblPr firstRow="1" bandRow="1">
+                <a:tableStyleId>{5C22544A-7EE6-4342-B048-85BDC9FD1C3A}</a:tableStyleId>
+              </a:tblPr>
+              <a:tblGrid>
+                <a:gridCol w="1889760"/>
+                <a:gridCol w="1889760"/>
+                <a:gridCol w="1889760"/>
+              </a:tblGrid>
+              <a:tr h="292608">
+                <a:tc>
+                  <a:txBody>
+                    <a:bodyPr/>
+                    <a:lstStyle/>
+                    <a:p>
+                      <a:pPr algn="l"/>
+                      <a:r>
+                        <a:rPr sz="1000" b="1">
+                          <a:solidFill>
+                            <a:srgbClr val="FFFFFF"/>
+                          </a:solidFill>
+                          <a:latin typeface="Encode Sans"/>
+                        </a:rPr>
+                        <a:t>Mes</a:t>
+                      </a:r>
+                    </a:p>
+                  </a:txBody>
+                  <a:tcPr marL="36576" marR="36576" marT="18288" marB="18288">
+                    <a:solidFill>
+                      <a:srgbClr val="00B2C9"/>
+                    </a:solidFill>
+                  </a:tcPr>
+                </a:tc>
+                <a:tc>
+                  <a:txBody>
+                    <a:bodyPr/>
+                    <a:lstStyle/>
+                    <a:p>
+                      <a:pPr algn="r"/>
+                      <a:r>
+                        <a:rPr sz="1000" b="1">
+                          <a:solidFill>
+                            <a:srgbClr val="FFFFFF"/>
+                          </a:solidFill>
+                          <a:latin typeface="Encode Sans"/>
+                        </a:rPr>
+                        <a:t>Familias %</a:t>
+                      </a:r>
+                    </a:p>
+                  </a:txBody>
+                  <a:tcPr marL="36576" marR="36576" marT="18288" marB="18288">
+                    <a:solidFill>
+                      <a:srgbClr val="00B2C9"/>
+                    </a:solidFill>
+                  </a:tcPr>
+                </a:tc>
+                <a:tc>
+                  <a:txBody>
+                    <a:bodyPr/>
+                    <a:lstStyle/>
+                    <a:p>
+                      <a:pPr algn="r"/>
+                      <a:r>
+                        <a:rPr sz="1000" b="1">
+                          <a:solidFill>
+                            <a:srgbClr val="FFFFFF"/>
+                          </a:solidFill>
+                          <a:latin typeface="Encode Sans"/>
+                        </a:rPr>
+                        <a:t>Empresas %</a:t>
+                      </a:r>
+                    </a:p>
+                  </a:txBody>
+                  <a:tcPr marL="36576" marR="36576" marT="18288" marB="18288">
+                    <a:solidFill>
+                      <a:srgbClr val="00B2C9"/>
+                    </a:solidFill>
+                  </a:tcPr>
+                </a:tc>
+              </a:tr>
+              <a:tr h="292608">
+                <a:tc>
+                  <a:txBody>
+                    <a:bodyPr/>
+                    <a:lstStyle/>
+                    <a:p>
+                      <a:pPr algn="l"/>
+                      <a:r>
+                        <a:rPr sz="1000">
+                          <a:solidFill>
+                            <a:srgbClr val="3F3F3F"/>
+                          </a:solidFill>
+                          <a:latin typeface="Encode Sans"/>
+                        </a:rPr>
+                        <a:t>Mayo 2026 *</a:t>
+                      </a:r>
+                    </a:p>
+                  </a:txBody>
+                  <a:tcPr marL="36576" marR="36576" marT="18288" marB="18288">
+                    <a:solidFill>
+                      <a:srgbClr val="FFFFFF"/>
+                    </a:solidFill>
+                  </a:tcPr>
+                </a:tc>
+                <a:tc>
+                  <a:txBody>
+                    <a:bodyPr/>
+                    <a:lstStyle/>
+                    <a:p>
+                      <a:pPr algn="r"/>
+                      <a:r>
+                        <a:rPr sz="1000">
+                          <a:solidFill>
+                            <a:srgbClr val="3F3F3F"/>
+                          </a:solidFill>
+                          <a:latin typeface="Encode Sans"/>
+                        </a:rPr>
+                        <a:t>12.7%</a:t>
+                      </a:r>
+                    </a:p>
+                  </a:txBody>
+                  <a:tcPr marL="36576" marR="36576" marT="18288" marB="18288">
+                    <a:solidFill>
+                      <a:srgbClr val="FFFFFF"/>
+                    </a:solidFill>
+                  </a:tcPr>
+                </a:tc>
+                <a:tc>
+                  <a:txBody>
+                    <a:bodyPr/>
+                    <a:lstStyle/>
+                    <a:p>
+                      <a:pPr algn="r"/>
+                      <a:r>
+                        <a:rPr sz="1000">
+                          <a:solidFill>
+                            <a:srgbClr val="3F3F3F"/>
+                          </a:solidFill>
+                          <a:latin typeface="Encode Sans"/>
+                        </a:rPr>
+                        <a:t>3.5%</a:t>
+                      </a:r>
+                    </a:p>
+                  </a:txBody>
+                  <a:tcPr marL="36576" marR="36576" marT="18288" marB="18288">
+                    <a:solidFill>
+                      <a:srgbClr val="FFFFFF"/>
+                    </a:solidFill>
+                  </a:tcPr>
+                </a:tc>
+              </a:tr>
+              <a:tr h="292608">
+                <a:tc>
+                  <a:txBody>
+                    <a:bodyPr/>
+                    <a:lstStyle/>
+                    <a:p>
+                      <a:pPr algn="l"/>
+                      <a:r>
+                        <a:rPr sz="1000">
+                          <a:solidFill>
+                            <a:srgbClr val="3F3F3F"/>
+                          </a:solidFill>
+                          <a:latin typeface="Encode Sans"/>
+                        </a:rPr>
+                        <a:t>Abril 2026</a:t>
+                      </a:r>
+                    </a:p>
+                  </a:txBody>
+                  <a:tcPr marL="36576" marR="36576" marT="18288" marB="18288">
+                    <a:solidFill>
+                      <a:srgbClr val="F8F8F6"/>
+                    </a:solidFill>
+                  </a:tcPr>
+                </a:tc>
+                <a:tc>
+                  <a:txBody>
+                    <a:bodyPr/>
+                    <a:lstStyle/>
+                    <a:p>
+                      <a:pPr algn="r"/>
+                      <a:r>
+                        <a:rPr sz="1000">
+                          <a:solidFill>
+                            <a:srgbClr val="3F3F3F"/>
+                          </a:solidFill>
+                          <a:latin typeface="Encode Sans"/>
+                        </a:rPr>
+                        <a:t>12.09%</a:t>
+                      </a:r>
+                    </a:p>
+                  </a:txBody>
+                  <a:tcPr marL="36576" marR="36576" marT="18288" marB="18288">
+                    <a:solidFill>
+                      <a:srgbClr val="F8F8F6"/>
+                    </a:solidFill>
+                  </a:tcPr>
+                </a:tc>
+                <a:tc>
+                  <a:txBody>
+                    <a:bodyPr/>
+                    <a:lstStyle/>
+                    <a:p>
+                      <a:pPr algn="r"/>
+                      <a:r>
+                        <a:rPr sz="1000">
+                          <a:solidFill>
+                            <a:srgbClr val="3F3F3F"/>
+                          </a:solidFill>
+                          <a:latin typeface="Encode Sans"/>
+                        </a:rPr>
+                        <a:t>3.34%</a:t>
+                      </a:r>
+                    </a:p>
+                  </a:txBody>
+                  <a:tcPr marL="36576" marR="36576" marT="18288" marB="18288">
+                    <a:solidFill>
+                      <a:srgbClr val="F8F8F6"/>
+                    </a:solidFill>
+                  </a:tcPr>
+                </a:tc>
+              </a:tr>
+              <a:tr h="292608">
+                <a:tc>
+                  <a:txBody>
+                    <a:bodyPr/>
+                    <a:lstStyle/>
+                    <a:p>
+                      <a:pPr algn="l"/>
+                      <a:r>
+                        <a:rPr sz="1000">
+                          <a:solidFill>
+                            <a:srgbClr val="3F3F3F"/>
+                          </a:solidFill>
+                          <a:latin typeface="Encode Sans"/>
+                        </a:rPr>
+                        <a:t>Marzo 2026</a:t>
+                      </a:r>
+                    </a:p>
+                  </a:txBody>
+                  <a:tcPr marL="36576" marR="36576" marT="18288" marB="18288">
+                    <a:solidFill>
+                      <a:srgbClr val="FFFFFF"/>
+                    </a:solidFill>
+                  </a:tcPr>
+                </a:tc>
+                <a:tc>
+                  <a:txBody>
+                    <a:bodyPr/>
+                    <a:lstStyle/>
+                    <a:p>
+                      <a:pPr algn="r"/>
+                      <a:r>
+                        <a:rPr sz="1000">
+                          <a:solidFill>
+                            <a:srgbClr val="3F3F3F"/>
+                          </a:solidFill>
+                          <a:latin typeface="Encode Sans"/>
+                        </a:rPr>
+                        <a:t>11.64%</a:t>
+                      </a:r>
+                    </a:p>
+                  </a:txBody>
+                  <a:tcPr marL="36576" marR="36576" marT="18288" marB="18288">
+                    <a:solidFill>
+                      <a:srgbClr val="FFFFFF"/>
+                    </a:solidFill>
+                  </a:tcPr>
+                </a:tc>
+                <a:tc>
+                  <a:txBody>
+                    <a:bodyPr/>
+                    <a:lstStyle/>
+                    <a:p>
+                      <a:pPr algn="r"/>
+                      <a:r>
+                        <a:rPr sz="1000">
+                          <a:solidFill>
+                            <a:srgbClr val="3F3F3F"/>
+                          </a:solidFill>
+                          <a:latin typeface="Encode Sans"/>
+                        </a:rPr>
+                        <a:t>3.18%</a:t>
+                      </a:r>
+                    </a:p>
+                  </a:txBody>
+                  <a:tcPr marL="36576" marR="36576" marT="18288" marB="18288">
+                    <a:solidFill>
+                      <a:srgbClr val="FFFFFF"/>
+                    </a:solidFill>
+                  </a:tcPr>
+                </a:tc>
+              </a:tr>
+              <a:tr h="292608">
+                <a:tc>
+                  <a:txBody>
+                    <a:bodyPr/>
+                    <a:lstStyle/>
+                    <a:p>
+                      <a:pPr algn="l"/>
+                      <a:r>
+                        <a:rPr sz="1000">
+                          <a:solidFill>
+                            <a:srgbClr val="3F3F3F"/>
+                          </a:solidFill>
+                          <a:latin typeface="Encode Sans"/>
+                        </a:rPr>
+                        <a:t>Febrero 2026</a:t>
+                      </a:r>
+                    </a:p>
+                  </a:txBody>
+                  <a:tcPr marL="36576" marR="36576" marT="18288" marB="18288">
+                    <a:solidFill>
+                      <a:srgbClr val="F8F8F6"/>
+                    </a:solidFill>
+                  </a:tcPr>
+                </a:tc>
+                <a:tc>
+                  <a:txBody>
+                    <a:bodyPr/>
+                    <a:lstStyle/>
+                    <a:p>
+                      <a:pPr algn="r"/>
+                      <a:r>
+                        <a:rPr sz="1000">
+                          <a:solidFill>
+                            <a:srgbClr val="3F3F3F"/>
+                          </a:solidFill>
+                          <a:latin typeface="Encode Sans"/>
+                        </a:rPr>
+                        <a:t>11.22%</a:t>
+                      </a:r>
+                    </a:p>
+                  </a:txBody>
+                  <a:tcPr marL="36576" marR="36576" marT="18288" marB="18288">
+                    <a:solidFill>
+                      <a:srgbClr val="F8F8F6"/>
+                    </a:solidFill>
+                  </a:tcPr>
+                </a:tc>
+                <a:tc>
+                  <a:txBody>
+                    <a:bodyPr/>
+                    <a:lstStyle/>
+                    <a:p>
+                      <a:pPr algn="r"/>
+                      <a:r>
+                        <a:rPr sz="1000">
+                          <a:solidFill>
+                            <a:srgbClr val="3F3F3F"/>
+                          </a:solidFill>
+                          <a:latin typeface="Encode Sans"/>
+                        </a:rPr>
+                        <a:t>2.92%</a:t>
+                      </a:r>
+                    </a:p>
+                  </a:txBody>
+                  <a:tcPr marL="36576" marR="36576" marT="18288" marB="18288">
+                    <a:solidFill>
+                      <a:srgbClr val="F8F8F6"/>
+                    </a:solidFill>
+                  </a:tcPr>
+                </a:tc>
+              </a:tr>
+              <a:tr h="292608">
+                <a:tc>
+                  <a:txBody>
+                    <a:bodyPr/>
+                    <a:lstStyle/>
+                    <a:p>
+                      <a:pPr algn="l"/>
+                      <a:r>
+                        <a:rPr sz="1000">
+                          <a:solidFill>
+                            <a:srgbClr val="3F3F3F"/>
+                          </a:solidFill>
+                          <a:latin typeface="Encode Sans"/>
+                        </a:rPr>
+                        <a:t>Enero 2026</a:t>
+                      </a:r>
+                    </a:p>
+                  </a:txBody>
+                  <a:tcPr marL="36576" marR="36576" marT="18288" marB="18288">
+                    <a:solidFill>
+                      <a:srgbClr val="FFFFFF"/>
+                    </a:solidFill>
+                  </a:tcPr>
+                </a:tc>
+                <a:tc>
+                  <a:txBody>
+                    <a:bodyPr/>
+                    <a:lstStyle/>
+                    <a:p>
+                      <a:pPr algn="r"/>
+                      <a:r>
+                        <a:rPr sz="1000">
+                          <a:solidFill>
+                            <a:srgbClr val="3F3F3F"/>
+                          </a:solidFill>
+                          <a:latin typeface="Encode Sans"/>
+                        </a:rPr>
+                        <a:t>10.61%</a:t>
+                      </a:r>
+                    </a:p>
+                  </a:txBody>
+                  <a:tcPr marL="36576" marR="36576" marT="18288" marB="18288">
+                    <a:solidFill>
+                      <a:srgbClr val="FFFFFF"/>
+                    </a:solidFill>
+                  </a:tcPr>
+                </a:tc>
+                <a:tc>
+                  <a:txBody>
+                    <a:bodyPr/>
+                    <a:lstStyle/>
+                    <a:p>
+                      <a:pPr algn="r"/>
+                      <a:r>
+                        <a:rPr sz="1000">
+                          <a:solidFill>
+                            <a:srgbClr val="3F3F3F"/>
+                          </a:solidFill>
+                          <a:latin typeface="Encode Sans"/>
+                        </a:rPr>
+                        <a:t>2.85%</a:t>
+                      </a:r>
+                    </a:p>
+                  </a:txBody>
+                  <a:tcPr marL="36576" marR="36576" marT="18288" marB="18288">
+                    <a:solidFill>
+                      <a:srgbClr val="FFFFFF"/>
+                    </a:solidFill>
+                  </a:tcPr>
+                </a:tc>
+              </a:tr>
+              <a:tr h="292608">
+                <a:tc>
+                  <a:txBody>
+                    <a:bodyPr/>
+                    <a:lstStyle/>
+                    <a:p>
+                      <a:pPr algn="l"/>
+                      <a:r>
+                        <a:rPr sz="1000">
+                          <a:solidFill>
+                            <a:srgbClr val="3F3F3F"/>
+                          </a:solidFill>
+                          <a:latin typeface="Encode Sans"/>
+                        </a:rPr>
+                        <a:t>Diciembre 2025</a:t>
+                      </a:r>
+                    </a:p>
+                  </a:txBody>
+                  <a:tcPr marL="36576" marR="36576" marT="18288" marB="18288">
+                    <a:solidFill>
+                      <a:srgbClr val="F8F8F6"/>
+                    </a:solidFill>
+                  </a:tcPr>
+                </a:tc>
+                <a:tc>
+                  <a:txBody>
+                    <a:bodyPr/>
+                    <a:lstStyle/>
+                    <a:p>
+                      <a:pPr algn="r"/>
+                      <a:r>
+                        <a:rPr sz="1000">
+                          <a:solidFill>
+                            <a:srgbClr val="3F3F3F"/>
+                          </a:solidFill>
+                          <a:latin typeface="Encode Sans"/>
+                        </a:rPr>
+                        <a:t>9.33%</a:t>
+                      </a:r>
+                    </a:p>
+                  </a:txBody>
+                  <a:tcPr marL="36576" marR="36576" marT="18288" marB="18288">
+                    <a:solidFill>
+                      <a:srgbClr val="F8F8F6"/>
+                    </a:solidFill>
+                  </a:tcPr>
+                </a:tc>
+                <a:tc>
+                  <a:txBody>
+                    <a:bodyPr/>
+                    <a:lstStyle/>
+                    <a:p>
+                      <a:pPr algn="r"/>
+                      <a:r>
+                        <a:rPr sz="1000">
+                          <a:solidFill>
+                            <a:srgbClr val="3F3F3F"/>
+                          </a:solidFill>
+                          <a:latin typeface="Encode Sans"/>
+                        </a:rPr>
+                        <a:t>2.53%</a:t>
+                      </a:r>
+                    </a:p>
+                  </a:txBody>
+                  <a:tcPr marL="36576" marR="36576" marT="18288" marB="18288">
+                    <a:solidFill>
+                      <a:srgbClr val="F8F8F6"/>
+                    </a:solidFill>
+                  </a:tcPr>
+                </a:tc>
+              </a:tr>
+            </a:tbl>
+          </a:graphicData>
+        </a:graphic>
+      </p:graphicFrame>
+      <p:sp>
+        <p:nvSpPr>
+          <p:cNvPr id="9" name="TextBox 8"/>
+          <p:cNvSpPr txBox="1"/>
+          <p:nvPr/>
+        </p:nvSpPr>
+        <p:spPr>
+          <a:xfrm>
+            <a:off x="411480" y="6492240"/>
+            <a:ext cx="11368735" cy="274320"/>
+          </a:xfrm>
+          <a:prstGeom prst="rect">
+            <a:avLst/>
+          </a:prstGeom>
+          <a:noFill/>
+        </p:spPr>
+        <p:txBody>
+          <a:bodyPr wrap="none">
+            <a:spAutoFit/>
+          </a:bodyPr>
+          <a:lstStyle/>
+          <a:p>
+            <a:r>
+              <a:rPr sz="1000" b="0" i="1">
+                <a:solidFill>
+                  <a:srgbClr val="6A6760"/>
+                </a:solidFill>
+                <a:latin typeface="Encode Sans"/>
+              </a:rPr>
+              <a:t>Fuente: elaboración propia en base a BCRA Informe sobre Bancos</a:t>
+            </a:r>
+          </a:p>
+        </p:txBody>
+      </p:sp>
+    </p:spTree>
+  </p:cSld>
+  <p:clrMapOvr>
+    <a:masterClrMapping/>
+  </p:clrMapOvr>
+</p:sld>
+</file>
+
+<file path=ppt/slides/slide4.xml><?xml version="1.0" encoding="utf-8"?>
 <p:sld xmlns:a="http://schemas.openxmlformats.org/drawingml/2006/main" xmlns:p="http://schemas.openxmlformats.org/presentationml/2006/main" xmlns:r="http://schemas.openxmlformats.org/officeDocument/2006/relationships">
   <p:cSld>
     <p:spTree>

</xml_diff>

<commit_message>
data: update 2026-07-08 ( data.json despidos.json scraper/historical_despidos.json publicaciones_semana.pptx rrii_brutas.xlsx)
</commit_message>
<xml_diff>
--- a/publicaciones_semana.pptx
+++ b/publicaciones_semana.pptx
@@ -7,8 +7,6 @@
   <p:sldIdLst>
     <p:sldId id="256" r:id="rId7"/>
     <p:sldId id="257" r:id="rId8"/>
-    <p:sldId id="258" r:id="rId9"/>
-    <p:sldId id="259" r:id="rId10"/>
   </p:sldIdLst>
   <p:sldSz cx="12191695" cy="6858000" type="screen4x3"/>
   <p:notesSz cx="6858000" cy="9144000"/>
@@ -3240,7 +3238,7 @@
                 </a:solidFill>
                 <a:latin typeface="Encode Sans"/>
               </a:rPr>
-              <a:t>Publicaciones de la semana del 29 de junio de 2026</a:t>
+              <a:t>Publicaciones de la semana del 06 de julio de 2026</a:t>
             </a:r>
           </a:p>
         </p:txBody>
@@ -3274,7 +3272,7 @@
                 </a:solidFill>
                 <a:latin typeface="Encode Sans"/>
               </a:rPr>
-              <a:t>3 publicaciones · datos oficiales INDEC / BCRA / Hacienda</a:t>
+              <a:t>1 publicaciones · datos oficiales INDEC / BCRA / Hacienda</a:t>
             </a:r>
           </a:p>
         </p:txBody>
@@ -3370,7 +3368,7 @@
                 </a:solidFill>
                 <a:latin typeface="Encode Sans"/>
               </a:rPr>
-              <a:t>EMAE ABRIL 2026: ACTIVIDAD CRECIÓ +1.6% I.A.</a:t>
+              <a:t>INDUSTRIA MAYO 2026: IPI CAYÓ -5.7% I.A.</a:t>
             </a:r>
           </a:p>
         </p:txBody>
@@ -3404,7 +3402,7 @@
                 </a:solidFill>
                 <a:latin typeface="Encode Sans"/>
               </a:rPr>
-              <a:t>INDEC · período 2026-04</a:t>
+              <a:t>INDEC · período 2026-05</a:t>
             </a:r>
           </a:p>
         </p:txBody>
@@ -3439,7 +3437,7 @@
                 </a:solidFill>
                 <a:latin typeface="Encode Sans"/>
               </a:rPr>
-              <a:t>El Estimador Mensual de Actividad Económica (EMAE) registró una variación interanual de +1.6% en abril 2026. En la medición desestacionalizada, el indicador se movió -1.5% respecto al mes anterior.</a:t>
+              <a:t>El Índice de Producción Industrial Manufacturero (IPI) registró una variación interanual de -5.7% en mayo 2026.</a:t>
             </a:r>
           </a:p>
         </p:txBody>
@@ -3487,7 +3485,7 @@
                 </a:solidFill>
                 <a:latin typeface="Encode Sans"/>
               </a:rPr>
-              <a:t>Variación interanual: +1.6%</a:t>
+              <a:t>Variación interanual: -5.7%</a:t>
             </a:r>
           </a:p>
           <a:p>
@@ -3512,1064 +3510,7 @@
                 </a:solidFill>
                 <a:latin typeface="Encode Sans"/>
               </a:rPr>
-              <a:t>Variación mensual desestacionalizada: -1.5%</a:t>
-            </a:r>
-          </a:p>
-          <a:p>
-            <a:pPr algn="l">
-              <a:spcAft>
-                <a:spcPts val="800"/>
-              </a:spcAft>
-            </a:pPr>
-            <a:r>
-              <a:rPr sz="1300" b="1" i="0">
-                <a:solidFill>
-                  <a:srgbClr val="00B2C9"/>
-                </a:solidFill>
-                <a:latin typeface="Encode Sans"/>
-              </a:rPr>
-              <a:t>●  </a:t>
-            </a:r>
-            <a:r>
-              <a:rPr sz="1300" b="0" i="0">
-                <a:solidFill>
-                  <a:srgbClr val="3F3F3F"/>
-                </a:solidFill>
-                <a:latin typeface="Encode Sans"/>
-              </a:rPr>
-              <a:t>Serie INDEC, base 2004=100. Mide el nivel general de actividad.</a:t>
-            </a:r>
-          </a:p>
-        </p:txBody>
-      </p:sp>
-      <p:pic>
-        <p:nvPicPr>
-          <p:cNvPr id="7" name="Picture 6" descr="image.png"/>
-          <p:cNvPicPr>
-            <a:picLocks noChangeAspect="1"/>
-          </p:cNvPicPr>
-          <p:nvPr/>
-        </p:nvPicPr>
-        <p:blipFill>
-          <a:blip r:embed="rId2"/>
-          <a:stretch>
-            <a:fillRect/>
-          </a:stretch>
-        </p:blipFill>
-        <p:spPr>
-          <a:xfrm>
-            <a:off x="6080760" y="1691640"/>
-            <a:ext cx="5669280" cy="2560320"/>
-          </a:xfrm>
-          <a:prstGeom prst="rect">
-            <a:avLst/>
-          </a:prstGeom>
-        </p:spPr>
-      </p:pic>
-      <p:graphicFrame>
-        <p:nvGraphicFramePr>
-          <p:cNvPr id="8" name="Table 7"/>
-          <p:cNvGraphicFramePr>
-            <a:graphicFrameLocks noGrp="1"/>
-          </p:cNvGraphicFramePr>
-          <p:nvPr/>
-        </p:nvGraphicFramePr>
-        <p:xfrm>
-          <a:off x="6080760" y="4434840"/>
-          <a:ext cx="5669280" cy="2048256"/>
-        </p:xfrm>
-        <a:graphic>
-          <a:graphicData uri="http://schemas.openxmlformats.org/drawingml/2006/table">
-            <a:tbl>
-              <a:tblPr firstRow="1" bandRow="1">
-                <a:tableStyleId>{5C22544A-7EE6-4342-B048-85BDC9FD1C3A}</a:tableStyleId>
-              </a:tblPr>
-              <a:tblGrid>
-                <a:gridCol w="1417320"/>
-                <a:gridCol w="1417320"/>
-                <a:gridCol w="1417320"/>
-                <a:gridCol w="1417320"/>
-              </a:tblGrid>
-              <a:tr h="292608">
-                <a:tc>
-                  <a:txBody>
-                    <a:bodyPr/>
-                    <a:lstStyle/>
-                    <a:p>
-                      <a:pPr algn="l"/>
-                      <a:r>
-                        <a:rPr sz="1000" b="1">
-                          <a:solidFill>
-                            <a:srgbClr val="FFFFFF"/>
-                          </a:solidFill>
-                          <a:latin typeface="Encode Sans"/>
-                        </a:rPr>
-                        <a:t>Mes</a:t>
-                      </a:r>
-                    </a:p>
-                  </a:txBody>
-                  <a:tcPr marL="36576" marR="36576" marT="18288" marB="18288">
-                    <a:solidFill>
-                      <a:srgbClr val="00B2C9"/>
-                    </a:solidFill>
-                  </a:tcPr>
-                </a:tc>
-                <a:tc>
-                  <a:txBody>
-                    <a:bodyPr/>
-                    <a:lstStyle/>
-                    <a:p>
-                      <a:pPr algn="r"/>
-                      <a:r>
-                        <a:rPr sz="1000" b="1">
-                          <a:solidFill>
-                            <a:srgbClr val="FFFFFF"/>
-                          </a:solidFill>
-                          <a:latin typeface="Encode Sans"/>
-                        </a:rPr>
-                        <a:t>Original</a:t>
-                      </a:r>
-                    </a:p>
-                  </a:txBody>
-                  <a:tcPr marL="36576" marR="36576" marT="18288" marB="18288">
-                    <a:solidFill>
-                      <a:srgbClr val="00B2C9"/>
-                    </a:solidFill>
-                  </a:tcPr>
-                </a:tc>
-                <a:tc>
-                  <a:txBody>
-                    <a:bodyPr/>
-                    <a:lstStyle/>
-                    <a:p>
-                      <a:pPr algn="r"/>
-                      <a:r>
-                        <a:rPr sz="1000" b="1">
-                          <a:solidFill>
-                            <a:srgbClr val="FFFFFF"/>
-                          </a:solidFill>
-                          <a:latin typeface="Encode Sans"/>
-                        </a:rPr>
-                        <a:t>VIA %</a:t>
-                      </a:r>
-                    </a:p>
-                  </a:txBody>
-                  <a:tcPr marL="36576" marR="36576" marT="18288" marB="18288">
-                    <a:solidFill>
-                      <a:srgbClr val="00B2C9"/>
-                    </a:solidFill>
-                  </a:tcPr>
-                </a:tc>
-                <a:tc>
-                  <a:txBody>
-                    <a:bodyPr/>
-                    <a:lstStyle/>
-                    <a:p>
-                      <a:pPr algn="r"/>
-                      <a:r>
-                        <a:rPr sz="1000" b="1">
-                          <a:solidFill>
-                            <a:srgbClr val="FFFFFF"/>
-                          </a:solidFill>
-                          <a:latin typeface="Encode Sans"/>
-                        </a:rPr>
-                        <a:t>Desest.</a:t>
-                      </a:r>
-                    </a:p>
-                  </a:txBody>
-                  <a:tcPr marL="36576" marR="36576" marT="18288" marB="18288">
-                    <a:solidFill>
-                      <a:srgbClr val="00B2C9"/>
-                    </a:solidFill>
-                  </a:tcPr>
-                </a:tc>
-              </a:tr>
-              <a:tr h="292608">
-                <a:tc>
-                  <a:txBody>
-                    <a:bodyPr/>
-                    <a:lstStyle/>
-                    <a:p>
-                      <a:pPr algn="l"/>
-                      <a:r>
-                        <a:rPr sz="1000">
-                          <a:solidFill>
-                            <a:srgbClr val="3F3F3F"/>
-                          </a:solidFill>
-                          <a:latin typeface="Encode Sans"/>
-                        </a:rPr>
-                        <a:t>Abril 2026</a:t>
-                      </a:r>
-                    </a:p>
-                  </a:txBody>
-                  <a:tcPr marL="36576" marR="36576" marT="18288" marB="18288">
-                    <a:solidFill>
-                      <a:srgbClr val="FFFFFF"/>
-                    </a:solidFill>
-                  </a:tcPr>
-                </a:tc>
-                <a:tc>
-                  <a:txBody>
-                    <a:bodyPr/>
-                    <a:lstStyle/>
-                    <a:p>
-                      <a:pPr algn="r"/>
-                      <a:r>
-                        <a:rPr sz="1000">
-                          <a:solidFill>
-                            <a:srgbClr val="3F3F3F"/>
-                          </a:solidFill>
-                          <a:latin typeface="Encode Sans"/>
-                        </a:rPr>
-                        <a:t>161,5</a:t>
-                      </a:r>
-                    </a:p>
-                  </a:txBody>
-                  <a:tcPr marL="36576" marR="36576" marT="18288" marB="18288">
-                    <a:solidFill>
-                      <a:srgbClr val="FFFFFF"/>
-                    </a:solidFill>
-                  </a:tcPr>
-                </a:tc>
-                <a:tc>
-                  <a:txBody>
-                    <a:bodyPr/>
-                    <a:lstStyle/>
-                    <a:p>
-                      <a:pPr algn="r"/>
-                      <a:r>
-                        <a:rPr sz="1000">
-                          <a:solidFill>
-                            <a:srgbClr val="3F3F3F"/>
-                          </a:solidFill>
-                          <a:latin typeface="Encode Sans"/>
-                        </a:rPr>
-                        <a:t>+1.6%</a:t>
-                      </a:r>
-                    </a:p>
-                  </a:txBody>
-                  <a:tcPr marL="36576" marR="36576" marT="18288" marB="18288">
-                    <a:solidFill>
-                      <a:srgbClr val="FFFFFF"/>
-                    </a:solidFill>
-                  </a:tcPr>
-                </a:tc>
-                <a:tc>
-                  <a:txBody>
-                    <a:bodyPr/>
-                    <a:lstStyle/>
-                    <a:p>
-                      <a:pPr algn="r"/>
-                      <a:r>
-                        <a:rPr sz="1000">
-                          <a:solidFill>
-                            <a:srgbClr val="3F3F3F"/>
-                          </a:solidFill>
-                          <a:latin typeface="Encode Sans"/>
-                        </a:rPr>
-                        <a:t>154,5</a:t>
-                      </a:r>
-                    </a:p>
-                  </a:txBody>
-                  <a:tcPr marL="36576" marR="36576" marT="18288" marB="18288">
-                    <a:solidFill>
-                      <a:srgbClr val="FFFFFF"/>
-                    </a:solidFill>
-                  </a:tcPr>
-                </a:tc>
-              </a:tr>
-              <a:tr h="292608">
-                <a:tc>
-                  <a:txBody>
-                    <a:bodyPr/>
-                    <a:lstStyle/>
-                    <a:p>
-                      <a:pPr algn="l"/>
-                      <a:r>
-                        <a:rPr sz="1000">
-                          <a:solidFill>
-                            <a:srgbClr val="3F3F3F"/>
-                          </a:solidFill>
-                          <a:latin typeface="Encode Sans"/>
-                        </a:rPr>
-                        <a:t>Marzo 2026</a:t>
-                      </a:r>
-                    </a:p>
-                  </a:txBody>
-                  <a:tcPr marL="36576" marR="36576" marT="18288" marB="18288">
-                    <a:solidFill>
-                      <a:srgbClr val="F8F8F6"/>
-                    </a:solidFill>
-                  </a:tcPr>
-                </a:tc>
-                <a:tc>
-                  <a:txBody>
-                    <a:bodyPr/>
-                    <a:lstStyle/>
-                    <a:p>
-                      <a:pPr algn="r"/>
-                      <a:r>
-                        <a:rPr sz="1000">
-                          <a:solidFill>
-                            <a:srgbClr val="3F3F3F"/>
-                          </a:solidFill>
-                          <a:latin typeface="Encode Sans"/>
-                        </a:rPr>
-                        <a:t>160,0</a:t>
-                      </a:r>
-                    </a:p>
-                  </a:txBody>
-                  <a:tcPr marL="36576" marR="36576" marT="18288" marB="18288">
-                    <a:solidFill>
-                      <a:srgbClr val="F8F8F6"/>
-                    </a:solidFill>
-                  </a:tcPr>
-                </a:tc>
-                <a:tc>
-                  <a:txBody>
-                    <a:bodyPr/>
-                    <a:lstStyle/>
-                    <a:p>
-                      <a:pPr algn="r"/>
-                      <a:r>
-                        <a:rPr sz="1000">
-                          <a:solidFill>
-                            <a:srgbClr val="3F3F3F"/>
-                          </a:solidFill>
-                          <a:latin typeface="Encode Sans"/>
-                        </a:rPr>
-                        <a:t>+6.2%</a:t>
-                      </a:r>
-                    </a:p>
-                  </a:txBody>
-                  <a:tcPr marL="36576" marR="36576" marT="18288" marB="18288">
-                    <a:solidFill>
-                      <a:srgbClr val="F8F8F6"/>
-                    </a:solidFill>
-                  </a:tcPr>
-                </a:tc>
-                <a:tc>
-                  <a:txBody>
-                    <a:bodyPr/>
-                    <a:lstStyle/>
-                    <a:p>
-                      <a:pPr algn="r"/>
-                      <a:r>
-                        <a:rPr sz="1000">
-                          <a:solidFill>
-                            <a:srgbClr val="3F3F3F"/>
-                          </a:solidFill>
-                          <a:latin typeface="Encode Sans"/>
-                        </a:rPr>
-                        <a:t>156,9</a:t>
-                      </a:r>
-                    </a:p>
-                  </a:txBody>
-                  <a:tcPr marL="36576" marR="36576" marT="18288" marB="18288">
-                    <a:solidFill>
-                      <a:srgbClr val="F8F8F6"/>
-                    </a:solidFill>
-                  </a:tcPr>
-                </a:tc>
-              </a:tr>
-              <a:tr h="292608">
-                <a:tc>
-                  <a:txBody>
-                    <a:bodyPr/>
-                    <a:lstStyle/>
-                    <a:p>
-                      <a:pPr algn="l"/>
-                      <a:r>
-                        <a:rPr sz="1000">
-                          <a:solidFill>
-                            <a:srgbClr val="3F3F3F"/>
-                          </a:solidFill>
-                          <a:latin typeface="Encode Sans"/>
-                        </a:rPr>
-                        <a:t>Febrero 2026</a:t>
-                      </a:r>
-                    </a:p>
-                  </a:txBody>
-                  <a:tcPr marL="36576" marR="36576" marT="18288" marB="18288">
-                    <a:solidFill>
-                      <a:srgbClr val="FFFFFF"/>
-                    </a:solidFill>
-                  </a:tcPr>
-                </a:tc>
-                <a:tc>
-                  <a:txBody>
-                    <a:bodyPr/>
-                    <a:lstStyle/>
-                    <a:p>
-                      <a:pPr algn="r"/>
-                      <a:r>
-                        <a:rPr sz="1000">
-                          <a:solidFill>
-                            <a:srgbClr val="3F3F3F"/>
-                          </a:solidFill>
-                          <a:latin typeface="Encode Sans"/>
-                        </a:rPr>
-                        <a:t>139,3</a:t>
-                      </a:r>
-                    </a:p>
-                  </a:txBody>
-                  <a:tcPr marL="36576" marR="36576" marT="18288" marB="18288">
-                    <a:solidFill>
-                      <a:srgbClr val="FFFFFF"/>
-                    </a:solidFill>
-                  </a:tcPr>
-                </a:tc>
-                <a:tc>
-                  <a:txBody>
-                    <a:bodyPr/>
-                    <a:lstStyle/>
-                    <a:p>
-                      <a:pPr algn="r"/>
-                      <a:r>
-                        <a:rPr sz="1000">
-                          <a:solidFill>
-                            <a:srgbClr val="3F3F3F"/>
-                          </a:solidFill>
-                          <a:latin typeface="Encode Sans"/>
-                        </a:rPr>
-                        <a:t>-1.5%</a:t>
-                      </a:r>
-                    </a:p>
-                  </a:txBody>
-                  <a:tcPr marL="36576" marR="36576" marT="18288" marB="18288">
-                    <a:solidFill>
-                      <a:srgbClr val="FFFFFF"/>
-                    </a:solidFill>
-                  </a:tcPr>
-                </a:tc>
-                <a:tc>
-                  <a:txBody>
-                    <a:bodyPr/>
-                    <a:lstStyle/>
-                    <a:p>
-                      <a:pPr algn="r"/>
-                      <a:r>
-                        <a:rPr sz="1000">
-                          <a:solidFill>
-                            <a:srgbClr val="3F3F3F"/>
-                          </a:solidFill>
-                          <a:latin typeface="Encode Sans"/>
-                        </a:rPr>
-                        <a:t>152,2</a:t>
-                      </a:r>
-                    </a:p>
-                  </a:txBody>
-                  <a:tcPr marL="36576" marR="36576" marT="18288" marB="18288">
-                    <a:solidFill>
-                      <a:srgbClr val="FFFFFF"/>
-                    </a:solidFill>
-                  </a:tcPr>
-                </a:tc>
-              </a:tr>
-              <a:tr h="292608">
-                <a:tc>
-                  <a:txBody>
-                    <a:bodyPr/>
-                    <a:lstStyle/>
-                    <a:p>
-                      <a:pPr algn="l"/>
-                      <a:r>
-                        <a:rPr sz="1000">
-                          <a:solidFill>
-                            <a:srgbClr val="3F3F3F"/>
-                          </a:solidFill>
-                          <a:latin typeface="Encode Sans"/>
-                        </a:rPr>
-                        <a:t>Enero 2026</a:t>
-                      </a:r>
-                    </a:p>
-                  </a:txBody>
-                  <a:tcPr marL="36576" marR="36576" marT="18288" marB="18288">
-                    <a:solidFill>
-                      <a:srgbClr val="F8F8F6"/>
-                    </a:solidFill>
-                  </a:tcPr>
-                </a:tc>
-                <a:tc>
-                  <a:txBody>
-                    <a:bodyPr/>
-                    <a:lstStyle/>
-                    <a:p>
-                      <a:pPr algn="r"/>
-                      <a:r>
-                        <a:rPr sz="1000">
-                          <a:solidFill>
-                            <a:srgbClr val="3F3F3F"/>
-                          </a:solidFill>
-                          <a:latin typeface="Encode Sans"/>
-                        </a:rPr>
-                        <a:t>149,5</a:t>
-                      </a:r>
-                    </a:p>
-                  </a:txBody>
-                  <a:tcPr marL="36576" marR="36576" marT="18288" marB="18288">
-                    <a:solidFill>
-                      <a:srgbClr val="F8F8F6"/>
-                    </a:solidFill>
-                  </a:tcPr>
-                </a:tc>
-                <a:tc>
-                  <a:txBody>
-                    <a:bodyPr/>
-                    <a:lstStyle/>
-                    <a:p>
-                      <a:pPr algn="r"/>
-                      <a:r>
-                        <a:rPr sz="1000">
-                          <a:solidFill>
-                            <a:srgbClr val="3F3F3F"/>
-                          </a:solidFill>
-                          <a:latin typeface="Encode Sans"/>
-                        </a:rPr>
-                        <a:t>+2.0%</a:t>
-                      </a:r>
-                    </a:p>
-                  </a:txBody>
-                  <a:tcPr marL="36576" marR="36576" marT="18288" marB="18288">
-                    <a:solidFill>
-                      <a:srgbClr val="F8F8F6"/>
-                    </a:solidFill>
-                  </a:tcPr>
-                </a:tc>
-                <a:tc>
-                  <a:txBody>
-                    <a:bodyPr/>
-                    <a:lstStyle/>
-                    <a:p>
-                      <a:pPr algn="r"/>
-                      <a:r>
-                        <a:rPr sz="1000">
-                          <a:solidFill>
-                            <a:srgbClr val="3F3F3F"/>
-                          </a:solidFill>
-                          <a:latin typeface="Encode Sans"/>
-                        </a:rPr>
-                        <a:t>156,4</a:t>
-                      </a:r>
-                    </a:p>
-                  </a:txBody>
-                  <a:tcPr marL="36576" marR="36576" marT="18288" marB="18288">
-                    <a:solidFill>
-                      <a:srgbClr val="F8F8F6"/>
-                    </a:solidFill>
-                  </a:tcPr>
-                </a:tc>
-              </a:tr>
-              <a:tr h="292608">
-                <a:tc>
-                  <a:txBody>
-                    <a:bodyPr/>
-                    <a:lstStyle/>
-                    <a:p>
-                      <a:pPr algn="l"/>
-                      <a:r>
-                        <a:rPr sz="1000">
-                          <a:solidFill>
-                            <a:srgbClr val="3F3F3F"/>
-                          </a:solidFill>
-                          <a:latin typeface="Encode Sans"/>
-                        </a:rPr>
-                        <a:t>Diciembre 2025</a:t>
-                      </a:r>
-                    </a:p>
-                  </a:txBody>
-                  <a:tcPr marL="36576" marR="36576" marT="18288" marB="18288">
-                    <a:solidFill>
-                      <a:srgbClr val="FFFFFF"/>
-                    </a:solidFill>
-                  </a:tcPr>
-                </a:tc>
-                <a:tc>
-                  <a:txBody>
-                    <a:bodyPr/>
-                    <a:lstStyle/>
-                    <a:p>
-                      <a:pPr algn="r"/>
-                      <a:r>
-                        <a:rPr sz="1000">
-                          <a:solidFill>
-                            <a:srgbClr val="3F3F3F"/>
-                          </a:solidFill>
-                          <a:latin typeface="Encode Sans"/>
-                        </a:rPr>
-                        <a:t>153,8</a:t>
-                      </a:r>
-                    </a:p>
-                  </a:txBody>
-                  <a:tcPr marL="36576" marR="36576" marT="18288" marB="18288">
-                    <a:solidFill>
-                      <a:srgbClr val="FFFFFF"/>
-                    </a:solidFill>
-                  </a:tcPr>
-                </a:tc>
-                <a:tc>
-                  <a:txBody>
-                    <a:bodyPr/>
-                    <a:lstStyle/>
-                    <a:p>
-                      <a:pPr algn="r"/>
-                      <a:r>
-                        <a:rPr sz="1000">
-                          <a:solidFill>
-                            <a:srgbClr val="3F3F3F"/>
-                          </a:solidFill>
-                          <a:latin typeface="Encode Sans"/>
-                        </a:rPr>
-                        <a:t>+3.5%</a:t>
-                      </a:r>
-                    </a:p>
-                  </a:txBody>
-                  <a:tcPr marL="36576" marR="36576" marT="18288" marB="18288">
-                    <a:solidFill>
-                      <a:srgbClr val="FFFFFF"/>
-                    </a:solidFill>
-                  </a:tcPr>
-                </a:tc>
-                <a:tc>
-                  <a:txBody>
-                    <a:bodyPr/>
-                    <a:lstStyle/>
-                    <a:p>
-                      <a:pPr algn="r"/>
-                      <a:r>
-                        <a:rPr sz="1000">
-                          <a:solidFill>
-                            <a:srgbClr val="3F3F3F"/>
-                          </a:solidFill>
-                          <a:latin typeface="Encode Sans"/>
-                        </a:rPr>
-                        <a:t>156,0</a:t>
-                      </a:r>
-                    </a:p>
-                  </a:txBody>
-                  <a:tcPr marL="36576" marR="36576" marT="18288" marB="18288">
-                    <a:solidFill>
-                      <a:srgbClr val="FFFFFF"/>
-                    </a:solidFill>
-                  </a:tcPr>
-                </a:tc>
-              </a:tr>
-              <a:tr h="292608">
-                <a:tc>
-                  <a:txBody>
-                    <a:bodyPr/>
-                    <a:lstStyle/>
-                    <a:p>
-                      <a:pPr algn="l"/>
-                      <a:r>
-                        <a:rPr sz="1000">
-                          <a:solidFill>
-                            <a:srgbClr val="3F3F3F"/>
-                          </a:solidFill>
-                          <a:latin typeface="Encode Sans"/>
-                        </a:rPr>
-                        <a:t>Noviembre 2025</a:t>
-                      </a:r>
-                    </a:p>
-                  </a:txBody>
-                  <a:tcPr marL="36576" marR="36576" marT="18288" marB="18288">
-                    <a:solidFill>
-                      <a:srgbClr val="F8F8F6"/>
-                    </a:solidFill>
-                  </a:tcPr>
-                </a:tc>
-                <a:tc>
-                  <a:txBody>
-                    <a:bodyPr/>
-                    <a:lstStyle/>
-                    <a:p>
-                      <a:pPr algn="r"/>
-                      <a:r>
-                        <a:rPr sz="1000">
-                          <a:solidFill>
-                            <a:srgbClr val="3F3F3F"/>
-                          </a:solidFill>
-                          <a:latin typeface="Encode Sans"/>
-                        </a:rPr>
-                        <a:t>148,0</a:t>
-                      </a:r>
-                    </a:p>
-                  </a:txBody>
-                  <a:tcPr marL="36576" marR="36576" marT="18288" marB="18288">
-                    <a:solidFill>
-                      <a:srgbClr val="F8F8F6"/>
-                    </a:solidFill>
-                  </a:tcPr>
-                </a:tc>
-                <a:tc>
-                  <a:txBody>
-                    <a:bodyPr/>
-                    <a:lstStyle/>
-                    <a:p>
-                      <a:pPr algn="r"/>
-                      <a:r>
-                        <a:rPr sz="1000">
-                          <a:solidFill>
-                            <a:srgbClr val="3F3F3F"/>
-                          </a:solidFill>
-                          <a:latin typeface="Encode Sans"/>
-                        </a:rPr>
-                        <a:t>-0.1%</a:t>
-                      </a:r>
-                    </a:p>
-                  </a:txBody>
-                  <a:tcPr marL="36576" marR="36576" marT="18288" marB="18288">
-                    <a:solidFill>
-                      <a:srgbClr val="F8F8F6"/>
-                    </a:solidFill>
-                  </a:tcPr>
-                </a:tc>
-                <a:tc>
-                  <a:txBody>
-                    <a:bodyPr/>
-                    <a:lstStyle/>
-                    <a:p>
-                      <a:pPr algn="r"/>
-                      <a:r>
-                        <a:rPr sz="1000">
-                          <a:solidFill>
-                            <a:srgbClr val="3F3F3F"/>
-                          </a:solidFill>
-                          <a:latin typeface="Encode Sans"/>
-                        </a:rPr>
-                        <a:t>153,0</a:t>
-                      </a:r>
-                    </a:p>
-                  </a:txBody>
-                  <a:tcPr marL="36576" marR="36576" marT="18288" marB="18288">
-                    <a:solidFill>
-                      <a:srgbClr val="F8F8F6"/>
-                    </a:solidFill>
-                  </a:tcPr>
-                </a:tc>
-              </a:tr>
-            </a:tbl>
-          </a:graphicData>
-        </a:graphic>
-      </p:graphicFrame>
-      <p:sp>
-        <p:nvSpPr>
-          <p:cNvPr id="9" name="TextBox 8"/>
-          <p:cNvSpPr txBox="1"/>
-          <p:nvPr/>
-        </p:nvSpPr>
-        <p:spPr>
-          <a:xfrm>
-            <a:off x="411480" y="6492240"/>
-            <a:ext cx="11368735" cy="274320"/>
-          </a:xfrm>
-          <a:prstGeom prst="rect">
-            <a:avLst/>
-          </a:prstGeom>
-          <a:noFill/>
-        </p:spPr>
-        <p:txBody>
-          <a:bodyPr wrap="none">
-            <a:spAutoFit/>
-          </a:bodyPr>
-          <a:lstStyle/>
-          <a:p>
-            <a:r>
-              <a:rPr sz="1000" b="0" i="1">
-                <a:solidFill>
-                  <a:srgbClr val="6A6760"/>
-                </a:solidFill>
-                <a:latin typeface="Encode Sans"/>
-              </a:rPr>
-              <a:t>Fuente: elaboración propia en base a INDEC</a:t>
-            </a:r>
-          </a:p>
-        </p:txBody>
-      </p:sp>
-    </p:spTree>
-  </p:cSld>
-  <p:clrMapOvr>
-    <a:masterClrMapping/>
-  </p:clrMapOvr>
-</p:sld>
-</file>
-
-<file path=ppt/slides/slide3.xml><?xml version="1.0" encoding="utf-8"?>
-<p:sld xmlns:a="http://schemas.openxmlformats.org/drawingml/2006/main" xmlns:p="http://schemas.openxmlformats.org/presentationml/2006/main" xmlns:r="http://schemas.openxmlformats.org/officeDocument/2006/relationships">
-  <p:cSld>
-    <p:spTree>
-      <p:nvGrpSpPr>
-        <p:cNvPr id="1" name=""/>
-        <p:cNvGrpSpPr/>
-        <p:nvPr/>
-      </p:nvGrpSpPr>
-      <p:grpSpPr/>
-      <p:sp>
-        <p:nvSpPr>
-          <p:cNvPr id="2" name="Rectangle 1"/>
-          <p:cNvSpPr/>
-          <p:nvPr/>
-        </p:nvSpPr>
-        <p:spPr>
-          <a:xfrm>
-            <a:off x="0" y="0"/>
-            <a:ext cx="12191695" cy="274320"/>
-          </a:xfrm>
-          <a:prstGeom prst="rect">
-            <a:avLst/>
-          </a:prstGeom>
-          <a:solidFill>
-            <a:srgbClr val="00B2C9"/>
-          </a:solidFill>
-          <a:ln>
-            <a:noFill/>
-          </a:ln>
-        </p:spPr>
-        <p:style>
-          <a:lnRef idx="1">
-            <a:schemeClr val="accent1"/>
-          </a:lnRef>
-          <a:fillRef idx="3">
-            <a:schemeClr val="accent1"/>
-          </a:fillRef>
-          <a:effectRef idx="2">
-            <a:schemeClr val="accent1"/>
-          </a:effectRef>
-          <a:fontRef idx="minor">
-            <a:schemeClr val="lt1"/>
-          </a:fontRef>
-        </p:style>
-        <p:txBody>
-          <a:bodyPr rtlCol="0" anchor="ctr"/>
-          <a:lstStyle/>
-          <a:p>
-            <a:pPr algn="ctr"/>
-          </a:p>
-        </p:txBody>
-      </p:sp>
-      <p:sp>
-        <p:nvSpPr>
-          <p:cNvPr id="3" name="TextBox 2"/>
-          <p:cNvSpPr txBox="1"/>
-          <p:nvPr/>
-        </p:nvSpPr>
-        <p:spPr>
-          <a:xfrm>
-            <a:off x="411480" y="457200"/>
-            <a:ext cx="11368735" cy="914400"/>
-          </a:xfrm>
-          <a:prstGeom prst="rect">
-            <a:avLst/>
-          </a:prstGeom>
-          <a:noFill/>
-        </p:spPr>
-        <p:txBody>
-          <a:bodyPr wrap="square" lIns="0" rIns="0">
-            <a:spAutoFit/>
-          </a:bodyPr>
-          <a:lstStyle/>
-          <a:p>
-            <a:pPr algn="l"/>
-            <a:r>
-              <a:rPr sz="2600" b="1" i="0">
-                <a:solidFill>
-                  <a:srgbClr val="00B2C9"/>
-                </a:solidFill>
-                <a:latin typeface="Encode Sans"/>
-              </a:rPr>
-              <a:t>MORA BANCARIA MAYO 2026: FAMILIAS 12.7% · EMPRESAS 3.5% (PRELIMINAR)</a:t>
-            </a:r>
-          </a:p>
-        </p:txBody>
-      </p:sp>
-      <p:sp>
-        <p:nvSpPr>
-          <p:cNvPr id="4" name="TextBox 3"/>
-          <p:cNvSpPr txBox="1"/>
-          <p:nvPr/>
-        </p:nvSpPr>
-        <p:spPr>
-          <a:xfrm>
-            <a:off x="411480" y="1280160"/>
-            <a:ext cx="11368735" cy="274320"/>
-          </a:xfrm>
-          <a:prstGeom prst="rect">
-            <a:avLst/>
-          </a:prstGeom>
-          <a:noFill/>
-        </p:spPr>
-        <p:txBody>
-          <a:bodyPr wrap="none">
-            <a:spAutoFit/>
-          </a:bodyPr>
-          <a:lstStyle/>
-          <a:p>
-            <a:r>
-              <a:rPr sz="1100" b="0" i="1">
-                <a:solidFill>
-                  <a:srgbClr val="6A6760"/>
-                </a:solidFill>
-                <a:latin typeface="Encode Sans"/>
-              </a:rPr>
-              <a:t>BCRA Informe sobre Bancos · período 2026-05</a:t>
-            </a:r>
-          </a:p>
-        </p:txBody>
-      </p:sp>
-      <p:sp>
-        <p:nvSpPr>
-          <p:cNvPr id="5" name="TextBox 4"/>
-          <p:cNvSpPr txBox="1"/>
-          <p:nvPr/>
-        </p:nvSpPr>
-        <p:spPr>
-          <a:xfrm>
-            <a:off x="411480" y="1691640"/>
-            <a:ext cx="5486400" cy="1645920"/>
-          </a:xfrm>
-          <a:prstGeom prst="rect">
-            <a:avLst/>
-          </a:prstGeom>
-          <a:noFill/>
-        </p:spPr>
-        <p:txBody>
-          <a:bodyPr wrap="square" lIns="0" rIns="0">
-            <a:spAutoFit/>
-          </a:bodyPr>
-          <a:lstStyle/>
-          <a:p>
-            <a:pPr algn="just"/>
-            <a:r>
-              <a:rPr sz="1300" b="0" i="0">
-                <a:solidFill>
-                  <a:srgbClr val="3F3F3F"/>
-                </a:solidFill>
-                <a:latin typeface="Encode Sans"/>
-              </a:rPr>
-              <a:t>La irregularidad de cartera alcanzó 12.7% en familias y 3.5% en empresas en mayo 2026 (venía de 12.09% en abril 2026, +0.61 pp). Dato preliminar reportado por 1816/CENDEU (prelim · prev. Informe BCRA); el BCRA publicará el oficial en su próximo Informe sobre Bancos.</a:t>
-            </a:r>
-          </a:p>
-        </p:txBody>
-      </p:sp>
-      <p:sp>
-        <p:nvSpPr>
-          <p:cNvPr id="6" name="TextBox 5"/>
-          <p:cNvSpPr txBox="1"/>
-          <p:nvPr/>
-        </p:nvSpPr>
-        <p:spPr>
-          <a:xfrm>
-            <a:off x="411480" y="3520440"/>
-            <a:ext cx="5486400" cy="2743200"/>
-          </a:xfrm>
-          <a:prstGeom prst="rect">
-            <a:avLst/>
-          </a:prstGeom>
-          <a:noFill/>
-        </p:spPr>
-        <p:txBody>
-          <a:bodyPr wrap="square" lIns="0" rIns="0">
-            <a:spAutoFit/>
-          </a:bodyPr>
-          <a:lstStyle/>
-          <a:p>
-            <a:pPr algn="l">
-              <a:spcAft>
-                <a:spcPts val="800"/>
-              </a:spcAft>
-            </a:pPr>
-            <a:r>
-              <a:rPr sz="1300" b="1" i="0">
-                <a:solidFill>
-                  <a:srgbClr val="00B2C9"/>
-                </a:solidFill>
-                <a:latin typeface="Encode Sans"/>
-              </a:rPr>
-              <a:t>●  </a:t>
-            </a:r>
-            <a:r>
-              <a:rPr sz="1300" b="0" i="0">
-                <a:solidFill>
-                  <a:srgbClr val="3F3F3F"/>
-                </a:solidFill>
-                <a:latin typeface="Encode Sans"/>
-              </a:rPr>
-              <a:t>Familias: 12.7% del total de préstamos en situación irregular</a:t>
-            </a:r>
-          </a:p>
-          <a:p>
-            <a:pPr algn="l">
-              <a:spcAft>
-                <a:spcPts val="800"/>
-              </a:spcAft>
-            </a:pPr>
-            <a:r>
-              <a:rPr sz="1300" b="1" i="0">
-                <a:solidFill>
-                  <a:srgbClr val="00B2C9"/>
-                </a:solidFill>
-                <a:latin typeface="Encode Sans"/>
-              </a:rPr>
-              <a:t>●  </a:t>
-            </a:r>
-            <a:r>
-              <a:rPr sz="1300" b="0" i="0">
-                <a:solidFill>
-                  <a:srgbClr val="3F3F3F"/>
-                </a:solidFill>
-                <a:latin typeface="Encode Sans"/>
-              </a:rPr>
-              <a:t>Empresas: 3.5%</a:t>
-            </a:r>
-          </a:p>
-          <a:p>
-            <a:pPr algn="l">
-              <a:spcAft>
-                <a:spcPts val="800"/>
-              </a:spcAft>
-            </a:pPr>
-            <a:r>
-              <a:rPr sz="1300" b="1" i="0">
-                <a:solidFill>
-                  <a:srgbClr val="00B2C9"/>
-                </a:solidFill>
-                <a:latin typeface="Encode Sans"/>
-              </a:rPr>
-              <a:t>●  </a:t>
-            </a:r>
-            <a:r>
-              <a:rPr sz="1300" b="0" i="0">
-                <a:solidFill>
-                  <a:srgbClr val="3F3F3F"/>
-                </a:solidFill>
-                <a:latin typeface="Encode Sans"/>
-              </a:rPr>
-              <a:t>Fuente: 1816/CENDEU (prelim · prev. Informe BCRA)</a:t>
-            </a:r>
-          </a:p>
-          <a:p>
-            <a:pPr algn="l">
-              <a:spcAft>
-                <a:spcPts val="800"/>
-              </a:spcAft>
-            </a:pPr>
-            <a:r>
-              <a:rPr sz="1300" b="1" i="0">
-                <a:solidFill>
-                  <a:srgbClr val="00B2C9"/>
-                </a:solidFill>
-                <a:latin typeface="Encode Sans"/>
-              </a:rPr>
-              <a:t>●  </a:t>
-            </a:r>
-            <a:r>
-              <a:rPr sz="1300" b="0" i="0">
-                <a:solidFill>
-                  <a:srgbClr val="3F3F3F"/>
-                </a:solidFill>
-                <a:latin typeface="Encode Sans"/>
-              </a:rPr>
-              <a:t>⚠ Dato preliminar — sujeto a revisión cuando el BCRA publique el Informe oficial</a:t>
+              <a:t>Serie INDEC, base 2004=100. Mide la producción manufacturera (16 ramas).</a:t>
             </a:r>
           </a:p>
         </p:txBody>
@@ -4658,7 +3599,7 @@
                           </a:solidFill>
                           <a:latin typeface="Encode Sans"/>
                         </a:rPr>
-                        <a:t>Familias %</a:t>
+                        <a:t>Original</a:t>
                       </a:r>
                     </a:p>
                   </a:txBody>
@@ -4681,7 +3622,7 @@
                           </a:solidFill>
                           <a:latin typeface="Encode Sans"/>
                         </a:rPr>
-                        <a:t>Empresas %</a:t>
+                        <a:t>VIA %</a:t>
                       </a:r>
                     </a:p>
                   </a:txBody>
@@ -4706,7 +3647,7 @@
                           </a:solidFill>
                           <a:latin typeface="Encode Sans"/>
                         </a:rPr>
-                        <a:t>Mayo 2026 *</a:t>
+                        <a:t>Mayo 2026</a:t>
                       </a:r>
                     </a:p>
                   </a:txBody>
@@ -4729,7 +3670,7 @@
                           </a:solidFill>
                           <a:latin typeface="Encode Sans"/>
                         </a:rPr>
-                        <a:t>12.7%</a:t>
+                        <a:t>117,0</a:t>
                       </a:r>
                     </a:p>
                   </a:txBody>
@@ -4752,7 +3693,7 @@
                           </a:solidFill>
                           <a:latin typeface="Encode Sans"/>
                         </a:rPr>
-                        <a:t>3.5%</a:t>
+                        <a:t>-5.7%</a:t>
                       </a:r>
                     </a:p>
                   </a:txBody>
@@ -4800,7 +3741,7 @@
                           </a:solidFill>
                           <a:latin typeface="Encode Sans"/>
                         </a:rPr>
-                        <a:t>12.09%</a:t>
+                        <a:t>118,4</a:t>
                       </a:r>
                     </a:p>
                   </a:txBody>
@@ -4823,7 +3764,7 @@
                           </a:solidFill>
                           <a:latin typeface="Encode Sans"/>
                         </a:rPr>
-                        <a:t>3.34%</a:t>
+                        <a:t>-2.5%</a:t>
                       </a:r>
                     </a:p>
                   </a:txBody>
@@ -4871,7 +3812,7 @@
                           </a:solidFill>
                           <a:latin typeface="Encode Sans"/>
                         </a:rPr>
-                        <a:t>11.64%</a:t>
+                        <a:t>122,1</a:t>
                       </a:r>
                     </a:p>
                   </a:txBody>
@@ -4894,7 +3835,7 @@
                           </a:solidFill>
                           <a:latin typeface="Encode Sans"/>
                         </a:rPr>
-                        <a:t>3.18%</a:t>
+                        <a:t>+5.0%</a:t>
                       </a:r>
                     </a:p>
                   </a:txBody>
@@ -4942,7 +3883,7 @@
                           </a:solidFill>
                           <a:latin typeface="Encode Sans"/>
                         </a:rPr>
-                        <a:t>11.22%</a:t>
+                        <a:t>100,2</a:t>
                       </a:r>
                     </a:p>
                   </a:txBody>
@@ -4965,7 +3906,7 @@
                           </a:solidFill>
                           <a:latin typeface="Encode Sans"/>
                         </a:rPr>
-                        <a:t>2.92%</a:t>
+                        <a:t>-8.9%</a:t>
                       </a:r>
                     </a:p>
                   </a:txBody>
@@ -5013,7 +3954,7 @@
                           </a:solidFill>
                           <a:latin typeface="Encode Sans"/>
                         </a:rPr>
-                        <a:t>10.61%</a:t>
+                        <a:t>106,5</a:t>
                       </a:r>
                     </a:p>
                   </a:txBody>
@@ -5036,7 +3977,7 @@
                           </a:solidFill>
                           <a:latin typeface="Encode Sans"/>
                         </a:rPr>
-                        <a:t>2.85%</a:t>
+                        <a:t>-3.8%</a:t>
                       </a:r>
                     </a:p>
                   </a:txBody>
@@ -5084,7 +4025,7 @@
                           </a:solidFill>
                           <a:latin typeface="Encode Sans"/>
                         </a:rPr>
-                        <a:t>9.33%</a:t>
+                        <a:t>112,0</a:t>
                       </a:r>
                     </a:p>
                   </a:txBody>
@@ -5107,7 +4048,7 @@
                           </a:solidFill>
                           <a:latin typeface="Encode Sans"/>
                         </a:rPr>
-                        <a:t>2.53%</a:t>
+                        <a:t>-4.0%</a:t>
                       </a:r>
                     </a:p>
                   </a:txBody>
@@ -5151,1039 +4092,7 @@
                 </a:solidFill>
                 <a:latin typeface="Encode Sans"/>
               </a:rPr>
-              <a:t>Fuente: elaboración propia en base a BCRA Informe sobre Bancos</a:t>
-            </a:r>
-          </a:p>
-        </p:txBody>
-      </p:sp>
-    </p:spTree>
-  </p:cSld>
-  <p:clrMapOvr>
-    <a:masterClrMapping/>
-  </p:clrMapOvr>
-</p:sld>
-</file>
-
-<file path=ppt/slides/slide4.xml><?xml version="1.0" encoding="utf-8"?>
-<p:sld xmlns:a="http://schemas.openxmlformats.org/drawingml/2006/main" xmlns:p="http://schemas.openxmlformats.org/presentationml/2006/main" xmlns:r="http://schemas.openxmlformats.org/officeDocument/2006/relationships">
-  <p:cSld>
-    <p:spTree>
-      <p:nvGrpSpPr>
-        <p:cNvPr id="1" name=""/>
-        <p:cNvGrpSpPr/>
-        <p:nvPr/>
-      </p:nvGrpSpPr>
-      <p:grpSpPr/>
-      <p:sp>
-        <p:nvSpPr>
-          <p:cNvPr id="2" name="Rectangle 1"/>
-          <p:cNvSpPr/>
-          <p:nvPr/>
-        </p:nvSpPr>
-        <p:spPr>
-          <a:xfrm>
-            <a:off x="0" y="0"/>
-            <a:ext cx="12191695" cy="274320"/>
-          </a:xfrm>
-          <a:prstGeom prst="rect">
-            <a:avLst/>
-          </a:prstGeom>
-          <a:solidFill>
-            <a:srgbClr val="00B2C9"/>
-          </a:solidFill>
-          <a:ln>
-            <a:noFill/>
-          </a:ln>
-        </p:spPr>
-        <p:style>
-          <a:lnRef idx="1">
-            <a:schemeClr val="accent1"/>
-          </a:lnRef>
-          <a:fillRef idx="3">
-            <a:schemeClr val="accent1"/>
-          </a:fillRef>
-          <a:effectRef idx="2">
-            <a:schemeClr val="accent1"/>
-          </a:effectRef>
-          <a:fontRef idx="minor">
-            <a:schemeClr val="lt1"/>
-          </a:fontRef>
-        </p:style>
-        <p:txBody>
-          <a:bodyPr rtlCol="0" anchor="ctr"/>
-          <a:lstStyle/>
-          <a:p>
-            <a:pPr algn="ctr"/>
-          </a:p>
-        </p:txBody>
-      </p:sp>
-      <p:sp>
-        <p:nvSpPr>
-          <p:cNvPr id="3" name="TextBox 2"/>
-          <p:cNvSpPr txBox="1"/>
-          <p:nvPr/>
-        </p:nvSpPr>
-        <p:spPr>
-          <a:xfrm>
-            <a:off x="411480" y="457200"/>
-            <a:ext cx="11368735" cy="914400"/>
-          </a:xfrm>
-          <a:prstGeom prst="rect">
-            <a:avLst/>
-          </a:prstGeom>
-          <a:noFill/>
-        </p:spPr>
-        <p:txBody>
-          <a:bodyPr wrap="square" lIns="0" rIns="0">
-            <a:spAutoFit/>
-          </a:bodyPr>
-          <a:lstStyle/>
-          <a:p>
-            <a:pPr algn="l"/>
-            <a:r>
-              <a:rPr sz="2600" b="1" i="0">
-                <a:solidFill>
-                  <a:srgbClr val="00B2C9"/>
-                </a:solidFill>
-                <a:latin typeface="Encode Sans"/>
-              </a:rPr>
-              <a:t>RECAUDACIÓN JUNIO 2026: CAYÓ -6.0% REAL I.A.</a:t>
-            </a:r>
-          </a:p>
-        </p:txBody>
-      </p:sp>
-      <p:sp>
-        <p:nvSpPr>
-          <p:cNvPr id="4" name="TextBox 3"/>
-          <p:cNvSpPr txBox="1"/>
-          <p:nvPr/>
-        </p:nvSpPr>
-        <p:spPr>
-          <a:xfrm>
-            <a:off x="411480" y="1280160"/>
-            <a:ext cx="11368735" cy="274320"/>
-          </a:xfrm>
-          <a:prstGeom prst="rect">
-            <a:avLst/>
-          </a:prstGeom>
-          <a:noFill/>
-        </p:spPr>
-        <p:txBody>
-          <a:bodyPr wrap="none">
-            <a:spAutoFit/>
-          </a:bodyPr>
-          <a:lstStyle/>
-          <a:p>
-            <a:r>
-              <a:rPr sz="1100" b="0" i="1">
-                <a:solidFill>
-                  <a:srgbClr val="6A6760"/>
-                </a:solidFill>
-                <a:latin typeface="Encode Sans"/>
-              </a:rPr>
-              <a:t>AFIP/ARCA · período 2026-06</a:t>
-            </a:r>
-          </a:p>
-        </p:txBody>
-      </p:sp>
-      <p:sp>
-        <p:nvSpPr>
-          <p:cNvPr id="5" name="TextBox 4"/>
-          <p:cNvSpPr txBox="1"/>
-          <p:nvPr/>
-        </p:nvSpPr>
-        <p:spPr>
-          <a:xfrm>
-            <a:off x="411480" y="1691640"/>
-            <a:ext cx="5486400" cy="1645920"/>
-          </a:xfrm>
-          <a:prstGeom prst="rect">
-            <a:avLst/>
-          </a:prstGeom>
-          <a:noFill/>
-        </p:spPr>
-        <p:txBody>
-          <a:bodyPr wrap="square" lIns="0" rIns="0">
-            <a:spAutoFit/>
-          </a:bodyPr>
-          <a:lstStyle/>
-          <a:p>
-            <a:pPr algn="just"/>
-            <a:r>
-              <a:rPr sz="1300" b="0" i="0">
-                <a:solidFill>
-                  <a:srgbClr val="3F3F3F"/>
-                </a:solidFill>
-                <a:latin typeface="Encode Sans"/>
-              </a:rPr>
-              <a:t>AFIP/ARCA recaudó $20.017K millones en junio 2026. Variación nominal interanual: +23.7%. En términos reales (deflactado por REM): -6.0% i.a.</a:t>
-            </a:r>
-          </a:p>
-        </p:txBody>
-      </p:sp>
-      <p:sp>
-        <p:nvSpPr>
-          <p:cNvPr id="6" name="TextBox 5"/>
-          <p:cNvSpPr txBox="1"/>
-          <p:nvPr/>
-        </p:nvSpPr>
-        <p:spPr>
-          <a:xfrm>
-            <a:off x="411480" y="3520440"/>
-            <a:ext cx="5486400" cy="2743200"/>
-          </a:xfrm>
-          <a:prstGeom prst="rect">
-            <a:avLst/>
-          </a:prstGeom>
-          <a:noFill/>
-        </p:spPr>
-        <p:txBody>
-          <a:bodyPr wrap="square" lIns="0" rIns="0">
-            <a:spAutoFit/>
-          </a:bodyPr>
-          <a:lstStyle/>
-          <a:p>
-            <a:pPr algn="l">
-              <a:spcAft>
-                <a:spcPts val="800"/>
-              </a:spcAft>
-            </a:pPr>
-            <a:r>
-              <a:rPr sz="1300" b="1" i="0">
-                <a:solidFill>
-                  <a:srgbClr val="00B2C9"/>
-                </a:solidFill>
-                <a:latin typeface="Encode Sans"/>
-              </a:rPr>
-              <a:t>●  </a:t>
-            </a:r>
-            <a:r>
-              <a:rPr sz="1300" b="0" i="0">
-                <a:solidFill>
-                  <a:srgbClr val="3F3F3F"/>
-                </a:solidFill>
-                <a:latin typeface="Encode Sans"/>
-              </a:rPr>
-              <a:t>Total: $20.017K M$</a:t>
-            </a:r>
-          </a:p>
-          <a:p>
-            <a:pPr algn="l">
-              <a:spcAft>
-                <a:spcPts val="800"/>
-              </a:spcAft>
-            </a:pPr>
-            <a:r>
-              <a:rPr sz="1300" b="1" i="0">
-                <a:solidFill>
-                  <a:srgbClr val="00B2C9"/>
-                </a:solidFill>
-                <a:latin typeface="Encode Sans"/>
-              </a:rPr>
-              <a:t>●  </a:t>
-            </a:r>
-            <a:r>
-              <a:rPr sz="1300" b="0" i="0">
-                <a:solidFill>
-                  <a:srgbClr val="3F3F3F"/>
-                </a:solidFill>
-                <a:latin typeface="Encode Sans"/>
-              </a:rPr>
-              <a:t>Variación nominal i.a.: +23.7%</a:t>
-            </a:r>
-          </a:p>
-          <a:p>
-            <a:pPr algn="l">
-              <a:spcAft>
-                <a:spcPts val="800"/>
-              </a:spcAft>
-            </a:pPr>
-            <a:r>
-              <a:rPr sz="1300" b="1" i="0">
-                <a:solidFill>
-                  <a:srgbClr val="00B2C9"/>
-                </a:solidFill>
-                <a:latin typeface="Encode Sans"/>
-              </a:rPr>
-              <a:t>●  </a:t>
-            </a:r>
-            <a:r>
-              <a:rPr sz="1300" b="0" i="0">
-                <a:solidFill>
-                  <a:srgbClr val="3F3F3F"/>
-                </a:solidFill>
-                <a:latin typeface="Encode Sans"/>
-              </a:rPr>
-              <a:t>Variación real i.a.: -6.0% (deflactor: REM)</a:t>
-            </a:r>
-          </a:p>
-          <a:p>
-            <a:pPr algn="l">
-              <a:spcAft>
-                <a:spcPts val="800"/>
-              </a:spcAft>
-            </a:pPr>
-            <a:r>
-              <a:rPr sz="1300" b="1" i="0">
-                <a:solidFill>
-                  <a:srgbClr val="00B2C9"/>
-                </a:solidFill>
-                <a:latin typeface="Encode Sans"/>
-              </a:rPr>
-              <a:t>●  </a:t>
-            </a:r>
-            <a:r>
-              <a:rPr sz="1300" b="0" i="0">
-                <a:solidFill>
-                  <a:srgbClr val="3F3F3F"/>
-                </a:solidFill>
-                <a:latin typeface="Encode Sans"/>
-              </a:rPr>
-              <a:t>Fuente: ARCA (ex AFIP) · indec.gob.ar series</a:t>
-            </a:r>
-          </a:p>
-        </p:txBody>
-      </p:sp>
-      <p:pic>
-        <p:nvPicPr>
-          <p:cNvPr id="7" name="Picture 6" descr="image.png"/>
-          <p:cNvPicPr>
-            <a:picLocks noChangeAspect="1"/>
-          </p:cNvPicPr>
-          <p:nvPr/>
-        </p:nvPicPr>
-        <p:blipFill>
-          <a:blip r:embed="rId2"/>
-          <a:stretch>
-            <a:fillRect/>
-          </a:stretch>
-        </p:blipFill>
-        <p:spPr>
-          <a:xfrm>
-            <a:off x="6080760" y="1691640"/>
-            <a:ext cx="5669280" cy="2560320"/>
-          </a:xfrm>
-          <a:prstGeom prst="rect">
-            <a:avLst/>
-          </a:prstGeom>
-        </p:spPr>
-      </p:pic>
-      <p:graphicFrame>
-        <p:nvGraphicFramePr>
-          <p:cNvPr id="8" name="Table 7"/>
-          <p:cNvGraphicFramePr>
-            <a:graphicFrameLocks noGrp="1"/>
-          </p:cNvGraphicFramePr>
-          <p:nvPr/>
-        </p:nvGraphicFramePr>
-        <p:xfrm>
-          <a:off x="6080760" y="4434840"/>
-          <a:ext cx="5669280" cy="2048256"/>
-        </p:xfrm>
-        <a:graphic>
-          <a:graphicData uri="http://schemas.openxmlformats.org/drawingml/2006/table">
-            <a:tbl>
-              <a:tblPr firstRow="1" bandRow="1">
-                <a:tableStyleId>{5C22544A-7EE6-4342-B048-85BDC9FD1C3A}</a:tableStyleId>
-              </a:tblPr>
-              <a:tblGrid>
-                <a:gridCol w="1417320"/>
-                <a:gridCol w="1417320"/>
-                <a:gridCol w="1417320"/>
-                <a:gridCol w="1417320"/>
-              </a:tblGrid>
-              <a:tr h="292608">
-                <a:tc>
-                  <a:txBody>
-                    <a:bodyPr/>
-                    <a:lstStyle/>
-                    <a:p>
-                      <a:pPr algn="l"/>
-                      <a:r>
-                        <a:rPr sz="1000" b="1">
-                          <a:solidFill>
-                            <a:srgbClr val="FFFFFF"/>
-                          </a:solidFill>
-                          <a:latin typeface="Encode Sans"/>
-                        </a:rPr>
-                        <a:t>Mes</a:t>
-                      </a:r>
-                    </a:p>
-                  </a:txBody>
-                  <a:tcPr marL="36576" marR="36576" marT="18288" marB="18288">
-                    <a:solidFill>
-                      <a:srgbClr val="00B2C9"/>
-                    </a:solidFill>
-                  </a:tcPr>
-                </a:tc>
-                <a:tc>
-                  <a:txBody>
-                    <a:bodyPr/>
-                    <a:lstStyle/>
-                    <a:p>
-                      <a:pPr algn="r"/>
-                      <a:r>
-                        <a:rPr sz="1000" b="1">
-                          <a:solidFill>
-                            <a:srgbClr val="FFFFFF"/>
-                          </a:solidFill>
-                          <a:latin typeface="Encode Sans"/>
-                        </a:rPr>
-                        <a:t>Total M$</a:t>
-                      </a:r>
-                    </a:p>
-                  </a:txBody>
-                  <a:tcPr marL="36576" marR="36576" marT="18288" marB="18288">
-                    <a:solidFill>
-                      <a:srgbClr val="00B2C9"/>
-                    </a:solidFill>
-                  </a:tcPr>
-                </a:tc>
-                <a:tc>
-                  <a:txBody>
-                    <a:bodyPr/>
-                    <a:lstStyle/>
-                    <a:p>
-                      <a:pPr algn="r"/>
-                      <a:r>
-                        <a:rPr sz="1000" b="1">
-                          <a:solidFill>
-                            <a:srgbClr val="FFFFFF"/>
-                          </a:solidFill>
-                          <a:latin typeface="Encode Sans"/>
-                        </a:rPr>
-                        <a:t>Var. nom. i.a.</a:t>
-                      </a:r>
-                    </a:p>
-                  </a:txBody>
-                  <a:tcPr marL="36576" marR="36576" marT="18288" marB="18288">
-                    <a:solidFill>
-                      <a:srgbClr val="00B2C9"/>
-                    </a:solidFill>
-                  </a:tcPr>
-                </a:tc>
-                <a:tc>
-                  <a:txBody>
-                    <a:bodyPr/>
-                    <a:lstStyle/>
-                    <a:p>
-                      <a:pPr algn="r"/>
-                      <a:r>
-                        <a:rPr sz="1000" b="1">
-                          <a:solidFill>
-                            <a:srgbClr val="FFFFFF"/>
-                          </a:solidFill>
-                          <a:latin typeface="Encode Sans"/>
-                        </a:rPr>
-                        <a:t>Var. real i.a.</a:t>
-                      </a:r>
-                    </a:p>
-                  </a:txBody>
-                  <a:tcPr marL="36576" marR="36576" marT="18288" marB="18288">
-                    <a:solidFill>
-                      <a:srgbClr val="00B2C9"/>
-                    </a:solidFill>
-                  </a:tcPr>
-                </a:tc>
-              </a:tr>
-              <a:tr h="292608">
-                <a:tc>
-                  <a:txBody>
-                    <a:bodyPr/>
-                    <a:lstStyle/>
-                    <a:p>
-                      <a:pPr algn="l"/>
-                      <a:r>
-                        <a:rPr sz="1000">
-                          <a:solidFill>
-                            <a:srgbClr val="3F3F3F"/>
-                          </a:solidFill>
-                          <a:latin typeface="Encode Sans"/>
-                        </a:rPr>
-                        <a:t>Junio 2026</a:t>
-                      </a:r>
-                    </a:p>
-                  </a:txBody>
-                  <a:tcPr marL="36576" marR="36576" marT="18288" marB="18288">
-                    <a:solidFill>
-                      <a:srgbClr val="FFFFFF"/>
-                    </a:solidFill>
-                  </a:tcPr>
-                </a:tc>
-                <a:tc>
-                  <a:txBody>
-                    <a:bodyPr/>
-                    <a:lstStyle/>
-                    <a:p>
-                      <a:pPr algn="r"/>
-                      <a:r>
-                        <a:rPr sz="1000">
-                          <a:solidFill>
-                            <a:srgbClr val="3F3F3F"/>
-                          </a:solidFill>
-                          <a:latin typeface="Encode Sans"/>
-                        </a:rPr>
-                        <a:t>20.017K</a:t>
-                      </a:r>
-                    </a:p>
-                  </a:txBody>
-                  <a:tcPr marL="36576" marR="36576" marT="18288" marB="18288">
-                    <a:solidFill>
-                      <a:srgbClr val="FFFFFF"/>
-                    </a:solidFill>
-                  </a:tcPr>
-                </a:tc>
-                <a:tc>
-                  <a:txBody>
-                    <a:bodyPr/>
-                    <a:lstStyle/>
-                    <a:p>
-                      <a:pPr algn="r"/>
-                      <a:r>
-                        <a:rPr sz="1000">
-                          <a:solidFill>
-                            <a:srgbClr val="3F3F3F"/>
-                          </a:solidFill>
-                          <a:latin typeface="Encode Sans"/>
-                        </a:rPr>
-                        <a:t>—</a:t>
-                      </a:r>
-                    </a:p>
-                  </a:txBody>
-                  <a:tcPr marL="36576" marR="36576" marT="18288" marB="18288">
-                    <a:solidFill>
-                      <a:srgbClr val="FFFFFF"/>
-                    </a:solidFill>
-                  </a:tcPr>
-                </a:tc>
-                <a:tc>
-                  <a:txBody>
-                    <a:bodyPr/>
-                    <a:lstStyle/>
-                    <a:p>
-                      <a:pPr algn="r"/>
-                      <a:r>
-                        <a:rPr sz="1000">
-                          <a:solidFill>
-                            <a:srgbClr val="3F3F3F"/>
-                          </a:solidFill>
-                          <a:latin typeface="Encode Sans"/>
-                        </a:rPr>
-                        <a:t>—</a:t>
-                      </a:r>
-                    </a:p>
-                  </a:txBody>
-                  <a:tcPr marL="36576" marR="36576" marT="18288" marB="18288">
-                    <a:solidFill>
-                      <a:srgbClr val="FFFFFF"/>
-                    </a:solidFill>
-                  </a:tcPr>
-                </a:tc>
-              </a:tr>
-              <a:tr h="292608">
-                <a:tc>
-                  <a:txBody>
-                    <a:bodyPr/>
-                    <a:lstStyle/>
-                    <a:p>
-                      <a:pPr algn="l"/>
-                      <a:r>
-                        <a:rPr sz="1000">
-                          <a:solidFill>
-                            <a:srgbClr val="3F3F3F"/>
-                          </a:solidFill>
-                          <a:latin typeface="Encode Sans"/>
-                        </a:rPr>
-                        <a:t>Mayo 2026</a:t>
-                      </a:r>
-                    </a:p>
-                  </a:txBody>
-                  <a:tcPr marL="36576" marR="36576" marT="18288" marB="18288">
-                    <a:solidFill>
-                      <a:srgbClr val="F8F8F6"/>
-                    </a:solidFill>
-                  </a:tcPr>
-                </a:tc>
-                <a:tc>
-                  <a:txBody>
-                    <a:bodyPr/>
-                    <a:lstStyle/>
-                    <a:p>
-                      <a:pPr algn="r"/>
-                      <a:r>
-                        <a:rPr sz="1000">
-                          <a:solidFill>
-                            <a:srgbClr val="3F3F3F"/>
-                          </a:solidFill>
-                          <a:latin typeface="Encode Sans"/>
-                        </a:rPr>
-                        <a:t>21.514K</a:t>
-                      </a:r>
-                    </a:p>
-                  </a:txBody>
-                  <a:tcPr marL="36576" marR="36576" marT="18288" marB="18288">
-                    <a:solidFill>
-                      <a:srgbClr val="F8F8F6"/>
-                    </a:solidFill>
-                  </a:tcPr>
-                </a:tc>
-                <a:tc>
-                  <a:txBody>
-                    <a:bodyPr/>
-                    <a:lstStyle/>
-                    <a:p>
-                      <a:pPr algn="r"/>
-                      <a:r>
-                        <a:rPr sz="1000">
-                          <a:solidFill>
-                            <a:srgbClr val="3F3F3F"/>
-                          </a:solidFill>
-                          <a:latin typeface="Encode Sans"/>
-                        </a:rPr>
-                        <a:t>—</a:t>
-                      </a:r>
-                    </a:p>
-                  </a:txBody>
-                  <a:tcPr marL="36576" marR="36576" marT="18288" marB="18288">
-                    <a:solidFill>
-                      <a:srgbClr val="F8F8F6"/>
-                    </a:solidFill>
-                  </a:tcPr>
-                </a:tc>
-                <a:tc>
-                  <a:txBody>
-                    <a:bodyPr/>
-                    <a:lstStyle/>
-                    <a:p>
-                      <a:pPr algn="r"/>
-                      <a:r>
-                        <a:rPr sz="1000">
-                          <a:solidFill>
-                            <a:srgbClr val="3F3F3F"/>
-                          </a:solidFill>
-                          <a:latin typeface="Encode Sans"/>
-                        </a:rPr>
-                        <a:t>—</a:t>
-                      </a:r>
-                    </a:p>
-                  </a:txBody>
-                  <a:tcPr marL="36576" marR="36576" marT="18288" marB="18288">
-                    <a:solidFill>
-                      <a:srgbClr val="F8F8F6"/>
-                    </a:solidFill>
-                  </a:tcPr>
-                </a:tc>
-              </a:tr>
-              <a:tr h="292608">
-                <a:tc>
-                  <a:txBody>
-                    <a:bodyPr/>
-                    <a:lstStyle/>
-                    <a:p>
-                      <a:pPr algn="l"/>
-                      <a:r>
-                        <a:rPr sz="1000">
-                          <a:solidFill>
-                            <a:srgbClr val="3F3F3F"/>
-                          </a:solidFill>
-                          <a:latin typeface="Encode Sans"/>
-                        </a:rPr>
-                        <a:t>Abril 2026</a:t>
-                      </a:r>
-                    </a:p>
-                  </a:txBody>
-                  <a:tcPr marL="36576" marR="36576" marT="18288" marB="18288">
-                    <a:solidFill>
-                      <a:srgbClr val="FFFFFF"/>
-                    </a:solidFill>
-                  </a:tcPr>
-                </a:tc>
-                <a:tc>
-                  <a:txBody>
-                    <a:bodyPr/>
-                    <a:lstStyle/>
-                    <a:p>
-                      <a:pPr algn="r"/>
-                      <a:r>
-                        <a:rPr sz="1000">
-                          <a:solidFill>
-                            <a:srgbClr val="3F3F3F"/>
-                          </a:solidFill>
-                          <a:latin typeface="Encode Sans"/>
-                        </a:rPr>
-                        <a:t>17.401K</a:t>
-                      </a:r>
-                    </a:p>
-                  </a:txBody>
-                  <a:tcPr marL="36576" marR="36576" marT="18288" marB="18288">
-                    <a:solidFill>
-                      <a:srgbClr val="FFFFFF"/>
-                    </a:solidFill>
-                  </a:tcPr>
-                </a:tc>
-                <a:tc>
-                  <a:txBody>
-                    <a:bodyPr/>
-                    <a:lstStyle/>
-                    <a:p>
-                      <a:pPr algn="r"/>
-                      <a:r>
-                        <a:rPr sz="1000">
-                          <a:solidFill>
-                            <a:srgbClr val="3F3F3F"/>
-                          </a:solidFill>
-                          <a:latin typeface="Encode Sans"/>
-                        </a:rPr>
-                        <a:t>—</a:t>
-                      </a:r>
-                    </a:p>
-                  </a:txBody>
-                  <a:tcPr marL="36576" marR="36576" marT="18288" marB="18288">
-                    <a:solidFill>
-                      <a:srgbClr val="FFFFFF"/>
-                    </a:solidFill>
-                  </a:tcPr>
-                </a:tc>
-                <a:tc>
-                  <a:txBody>
-                    <a:bodyPr/>
-                    <a:lstStyle/>
-                    <a:p>
-                      <a:pPr algn="r"/>
-                      <a:r>
-                        <a:rPr sz="1000">
-                          <a:solidFill>
-                            <a:srgbClr val="3F3F3F"/>
-                          </a:solidFill>
-                          <a:latin typeface="Encode Sans"/>
-                        </a:rPr>
-                        <a:t>—</a:t>
-                      </a:r>
-                    </a:p>
-                  </a:txBody>
-                  <a:tcPr marL="36576" marR="36576" marT="18288" marB="18288">
-                    <a:solidFill>
-                      <a:srgbClr val="FFFFFF"/>
-                    </a:solidFill>
-                  </a:tcPr>
-                </a:tc>
-              </a:tr>
-              <a:tr h="292608">
-                <a:tc>
-                  <a:txBody>
-                    <a:bodyPr/>
-                    <a:lstStyle/>
-                    <a:p>
-                      <a:pPr algn="l"/>
-                      <a:r>
-                        <a:rPr sz="1000">
-                          <a:solidFill>
-                            <a:srgbClr val="3F3F3F"/>
-                          </a:solidFill>
-                          <a:latin typeface="Encode Sans"/>
-                        </a:rPr>
-                        <a:t>Marzo 2026</a:t>
-                      </a:r>
-                    </a:p>
-                  </a:txBody>
-                  <a:tcPr marL="36576" marR="36576" marT="18288" marB="18288">
-                    <a:solidFill>
-                      <a:srgbClr val="F8F8F6"/>
-                    </a:solidFill>
-                  </a:tcPr>
-                </a:tc>
-                <a:tc>
-                  <a:txBody>
-                    <a:bodyPr/>
-                    <a:lstStyle/>
-                    <a:p>
-                      <a:pPr algn="r"/>
-                      <a:r>
-                        <a:rPr sz="1000">
-                          <a:solidFill>
-                            <a:srgbClr val="3F3F3F"/>
-                          </a:solidFill>
-                          <a:latin typeface="Encode Sans"/>
-                        </a:rPr>
-                        <a:t>16.071K</a:t>
-                      </a:r>
-                    </a:p>
-                  </a:txBody>
-                  <a:tcPr marL="36576" marR="36576" marT="18288" marB="18288">
-                    <a:solidFill>
-                      <a:srgbClr val="F8F8F6"/>
-                    </a:solidFill>
-                  </a:tcPr>
-                </a:tc>
-                <a:tc>
-                  <a:txBody>
-                    <a:bodyPr/>
-                    <a:lstStyle/>
-                    <a:p>
-                      <a:pPr algn="r"/>
-                      <a:r>
-                        <a:rPr sz="1000">
-                          <a:solidFill>
-                            <a:srgbClr val="3F3F3F"/>
-                          </a:solidFill>
-                          <a:latin typeface="Encode Sans"/>
-                        </a:rPr>
-                        <a:t>26.21%</a:t>
-                      </a:r>
-                    </a:p>
-                  </a:txBody>
-                  <a:tcPr marL="36576" marR="36576" marT="18288" marB="18288">
-                    <a:solidFill>
-                      <a:srgbClr val="F8F8F6"/>
-                    </a:solidFill>
-                  </a:tcPr>
-                </a:tc>
-                <a:tc>
-                  <a:txBody>
-                    <a:bodyPr/>
-                    <a:lstStyle/>
-                    <a:p>
-                      <a:pPr algn="r"/>
-                      <a:r>
-                        <a:rPr sz="1000">
-                          <a:solidFill>
-                            <a:srgbClr val="3F3F3F"/>
-                          </a:solidFill>
-                          <a:latin typeface="Encode Sans"/>
-                        </a:rPr>
-                        <a:t>—</a:t>
-                      </a:r>
-                    </a:p>
-                  </a:txBody>
-                  <a:tcPr marL="36576" marR="36576" marT="18288" marB="18288">
-                    <a:solidFill>
-                      <a:srgbClr val="F8F8F6"/>
-                    </a:solidFill>
-                  </a:tcPr>
-                </a:tc>
-              </a:tr>
-              <a:tr h="292608">
-                <a:tc>
-                  <a:txBody>
-                    <a:bodyPr/>
-                    <a:lstStyle/>
-                    <a:p>
-                      <a:pPr algn="l"/>
-                      <a:r>
-                        <a:rPr sz="1000">
-                          <a:solidFill>
-                            <a:srgbClr val="3F3F3F"/>
-                          </a:solidFill>
-                          <a:latin typeface="Encode Sans"/>
-                        </a:rPr>
-                        <a:t>Febrero 2026</a:t>
-                      </a:r>
-                    </a:p>
-                  </a:txBody>
-                  <a:tcPr marL="36576" marR="36576" marT="18288" marB="18288">
-                    <a:solidFill>
-                      <a:srgbClr val="FFFFFF"/>
-                    </a:solidFill>
-                  </a:tcPr>
-                </a:tc>
-                <a:tc>
-                  <a:txBody>
-                    <a:bodyPr/>
-                    <a:lstStyle/>
-                    <a:p>
-                      <a:pPr algn="r"/>
-                      <a:r>
-                        <a:rPr sz="1000">
-                          <a:solidFill>
-                            <a:srgbClr val="3F3F3F"/>
-                          </a:solidFill>
-                          <a:latin typeface="Encode Sans"/>
-                        </a:rPr>
-                        <a:t>16.232K</a:t>
-                      </a:r>
-                    </a:p>
-                  </a:txBody>
-                  <a:tcPr marL="36576" marR="36576" marT="18288" marB="18288">
-                    <a:solidFill>
-                      <a:srgbClr val="FFFFFF"/>
-                    </a:solidFill>
-                  </a:tcPr>
-                </a:tc>
-                <a:tc>
-                  <a:txBody>
-                    <a:bodyPr/>
-                    <a:lstStyle/>
-                    <a:p>
-                      <a:pPr algn="r"/>
-                      <a:r>
-                        <a:rPr sz="1000">
-                          <a:solidFill>
-                            <a:srgbClr val="3F3F3F"/>
-                          </a:solidFill>
-                          <a:latin typeface="Encode Sans"/>
-                        </a:rPr>
-                        <a:t>20.05%</a:t>
-                      </a:r>
-                    </a:p>
-                  </a:txBody>
-                  <a:tcPr marL="36576" marR="36576" marT="18288" marB="18288">
-                    <a:solidFill>
-                      <a:srgbClr val="FFFFFF"/>
-                    </a:solidFill>
-                  </a:tcPr>
-                </a:tc>
-                <a:tc>
-                  <a:txBody>
-                    <a:bodyPr/>
-                    <a:lstStyle/>
-                    <a:p>
-                      <a:pPr algn="r"/>
-                      <a:r>
-                        <a:rPr sz="1000">
-                          <a:solidFill>
-                            <a:srgbClr val="3F3F3F"/>
-                          </a:solidFill>
-                          <a:latin typeface="Encode Sans"/>
-                        </a:rPr>
-                        <a:t>-9.77%</a:t>
-                      </a:r>
-                    </a:p>
-                  </a:txBody>
-                  <a:tcPr marL="36576" marR="36576" marT="18288" marB="18288">
-                    <a:solidFill>
-                      <a:srgbClr val="FFFFFF"/>
-                    </a:solidFill>
-                  </a:tcPr>
-                </a:tc>
-              </a:tr>
-              <a:tr h="292608">
-                <a:tc>
-                  <a:txBody>
-                    <a:bodyPr/>
-                    <a:lstStyle/>
-                    <a:p>
-                      <a:pPr algn="l"/>
-                      <a:r>
-                        <a:rPr sz="1000">
-                          <a:solidFill>
-                            <a:srgbClr val="3F3F3F"/>
-                          </a:solidFill>
-                          <a:latin typeface="Encode Sans"/>
-                        </a:rPr>
-                        <a:t>Enero 2026</a:t>
-                      </a:r>
-                    </a:p>
-                  </a:txBody>
-                  <a:tcPr marL="36576" marR="36576" marT="18288" marB="18288">
-                    <a:solidFill>
-                      <a:srgbClr val="F8F8F6"/>
-                    </a:solidFill>
-                  </a:tcPr>
-                </a:tc>
-                <a:tc>
-                  <a:txBody>
-                    <a:bodyPr/>
-                    <a:lstStyle/>
-                    <a:p>
-                      <a:pPr algn="r"/>
-                      <a:r>
-                        <a:rPr sz="1000">
-                          <a:solidFill>
-                            <a:srgbClr val="3F3F3F"/>
-                          </a:solidFill>
-                          <a:latin typeface="Encode Sans"/>
-                        </a:rPr>
-                        <a:t>18.338K</a:t>
-                      </a:r>
-                    </a:p>
-                  </a:txBody>
-                  <a:tcPr marL="36576" marR="36576" marT="18288" marB="18288">
-                    <a:solidFill>
-                      <a:srgbClr val="F8F8F6"/>
-                    </a:solidFill>
-                  </a:tcPr>
-                </a:tc>
-                <a:tc>
-                  <a:txBody>
-                    <a:bodyPr/>
-                    <a:lstStyle/>
-                    <a:p>
-                      <a:pPr algn="r"/>
-                      <a:r>
-                        <a:rPr sz="1000">
-                          <a:solidFill>
-                            <a:srgbClr val="3F3F3F"/>
-                          </a:solidFill>
-                          <a:latin typeface="Encode Sans"/>
-                        </a:rPr>
-                        <a:t>21.99%</a:t>
-                      </a:r>
-                    </a:p>
-                  </a:txBody>
-                  <a:tcPr marL="36576" marR="36576" marT="18288" marB="18288">
-                    <a:solidFill>
-                      <a:srgbClr val="F8F8F6"/>
-                    </a:solidFill>
-                  </a:tcPr>
-                </a:tc>
-                <a:tc>
-                  <a:txBody>
-                    <a:bodyPr/>
-                    <a:lstStyle/>
-                    <a:p>
-                      <a:pPr algn="r"/>
-                      <a:r>
-                        <a:rPr sz="1000">
-                          <a:solidFill>
-                            <a:srgbClr val="3F3F3F"/>
-                          </a:solidFill>
-                          <a:latin typeface="Encode Sans"/>
-                        </a:rPr>
-                        <a:t>-7.87%</a:t>
-                      </a:r>
-                    </a:p>
-                  </a:txBody>
-                  <a:tcPr marL="36576" marR="36576" marT="18288" marB="18288">
-                    <a:solidFill>
-                      <a:srgbClr val="F8F8F6"/>
-                    </a:solidFill>
-                  </a:tcPr>
-                </a:tc>
-              </a:tr>
-            </a:tbl>
-          </a:graphicData>
-        </a:graphic>
-      </p:graphicFrame>
-      <p:sp>
-        <p:nvSpPr>
-          <p:cNvPr id="9" name="TextBox 8"/>
-          <p:cNvSpPr txBox="1"/>
-          <p:nvPr/>
-        </p:nvSpPr>
-        <p:spPr>
-          <a:xfrm>
-            <a:off x="411480" y="6492240"/>
-            <a:ext cx="11368735" cy="274320"/>
-          </a:xfrm>
-          <a:prstGeom prst="rect">
-            <a:avLst/>
-          </a:prstGeom>
-          <a:noFill/>
-        </p:spPr>
-        <p:txBody>
-          <a:bodyPr wrap="none">
-            <a:spAutoFit/>
-          </a:bodyPr>
-          <a:lstStyle/>
-          <a:p>
-            <a:r>
-              <a:rPr sz="1000" b="0" i="1">
-                <a:solidFill>
-                  <a:srgbClr val="6A6760"/>
-                </a:solidFill>
-                <a:latin typeface="Encode Sans"/>
-              </a:rPr>
-              <a:t>Fuente: elaboración propia en base a AFIP/ARCA</a:t>
+              <a:t>Fuente: elaboración propia en base a INDEC</a:t>
             </a:r>
           </a:p>
         </p:txBody>

</xml_diff>

<commit_message>
data: update 2026-07-14 ( data.json despidos.json scraper/historical_despidos.json publicaciones_semana.pptx rrii_brutas.xlsx)
</commit_message>
<xml_diff>
--- a/publicaciones_semana.pptx
+++ b/publicaciones_semana.pptx
@@ -7,7 +7,6 @@
   <p:sldIdLst>
     <p:sldId id="256" r:id="rId7"/>
     <p:sldId id="257" r:id="rId8"/>
-    <p:sldId id="258" r:id="rId9"/>
   </p:sldIdLst>
   <p:sldSz cx="12191695" cy="6858000" type="screen4x3"/>
   <p:notesSz cx="6858000" cy="9144000"/>
@@ -3239,7 +3238,7 @@
                 </a:solidFill>
                 <a:latin typeface="Encode Sans"/>
               </a:rPr>
-              <a:t>Publicaciones de la semana del 06 de julio de 2026</a:t>
+              <a:t>Publicaciones de la semana del 13 de julio de 2026</a:t>
             </a:r>
           </a:p>
         </p:txBody>
@@ -3273,7 +3272,7 @@
                 </a:solidFill>
                 <a:latin typeface="Encode Sans"/>
               </a:rPr>
-              <a:t>2 publicaciones · datos oficiales INDEC / BCRA / Hacienda</a:t>
+              <a:t>1 publicaciones · datos oficiales INDEC / BCRA / Hacienda</a:t>
             </a:r>
           </a:p>
         </p:txBody>
@@ -3369,7 +3368,7 @@
                 </a:solidFill>
                 <a:latin typeface="Encode Sans"/>
               </a:rPr>
-              <a:t>INDUSTRIA MAYO 2026: IPI CAYÓ -5.7% I.A.</a:t>
+              <a:t>INFLACIÓN JUNIO 2026: +1.9%</a:t>
             </a:r>
           </a:p>
         </p:txBody>
@@ -3403,7 +3402,7 @@
                 </a:solidFill>
                 <a:latin typeface="Encode Sans"/>
               </a:rPr>
-              <a:t>INDEC · período 2026-05</a:t>
+              <a:t>INDEC · período 2026-06</a:t>
             </a:r>
           </a:p>
         </p:txBody>
@@ -3438,7 +3437,7 @@
                 </a:solidFill>
                 <a:latin typeface="Encode Sans"/>
               </a:rPr>
-              <a:t>El Índice de Producción Industrial Manufacturero (IPI) registró una variación interanual de -5.7% en mayo 2026.</a:t>
+              <a:t>El IPC nivel general aumentó +1.9% mensual en junio 2026, acumulando 33.56% interanual. INDEC publicó el indicador con la metodología vigente.</a:t>
             </a:r>
           </a:p>
         </p:txBody>
@@ -3486,7 +3485,7 @@
                 </a:solidFill>
                 <a:latin typeface="Encode Sans"/>
               </a:rPr>
-              <a:t>Variación interanual: -5.7%</a:t>
+              <a:t>Variación mensual: +1.9%</a:t>
             </a:r>
           </a:p>
           <a:p>
@@ -3511,7 +3510,32 @@
                 </a:solidFill>
                 <a:latin typeface="Encode Sans"/>
               </a:rPr>
-              <a:t>Serie INDEC, base 2004=100. Mide la producción manufacturera (16 ramas).</a:t>
+              <a:t>Variación interanual: 33.56%</a:t>
+            </a:r>
+          </a:p>
+          <a:p>
+            <a:pPr algn="l">
+              <a:spcAft>
+                <a:spcPts val="800"/>
+              </a:spcAft>
+            </a:pPr>
+            <a:r>
+              <a:rPr sz="1300" b="1" i="0">
+                <a:solidFill>
+                  <a:srgbClr val="00B2C9"/>
+                </a:solidFill>
+                <a:latin typeface="Encode Sans"/>
+              </a:rPr>
+              <a:t>●  </a:t>
+            </a:r>
+            <a:r>
+              <a:rPr sz="1300" b="0" i="0">
+                <a:solidFill>
+                  <a:srgbClr val="3F3F3F"/>
+                </a:solidFill>
+                <a:latin typeface="Encode Sans"/>
+              </a:rPr>
+              <a:t>Acumulado últimos 6 meses: 15.8% (suma simple)</a:t>
             </a:r>
           </a:p>
         </p:txBody>
@@ -3600,7 +3624,7 @@
                           </a:solidFill>
                           <a:latin typeface="Encode Sans"/>
                         </a:rPr>
-                        <a:t>Original</a:t>
+                        <a:t>VM %</a:t>
                       </a:r>
                     </a:p>
                   </a:txBody>
@@ -3648,7 +3672,7 @@
                           </a:solidFill>
                           <a:latin typeface="Encode Sans"/>
                         </a:rPr>
-                        <a:t>Mayo 2026</a:t>
+                        <a:t>Junio 2026</a:t>
                       </a:r>
                     </a:p>
                   </a:txBody>
@@ -3671,7 +3695,7 @@
                           </a:solidFill>
                           <a:latin typeface="Encode Sans"/>
                         </a:rPr>
-                        <a:t>117,0</a:t>
+                        <a:t>+1.9%</a:t>
                       </a:r>
                     </a:p>
                   </a:txBody>
@@ -3694,7 +3718,7 @@
                           </a:solidFill>
                           <a:latin typeface="Encode Sans"/>
                         </a:rPr>
-                        <a:t>-5.7%</a:t>
+                        <a:t>+33.6%</a:t>
                       </a:r>
                     </a:p>
                   </a:txBody>
@@ -3719,7 +3743,7 @@
                           </a:solidFill>
                           <a:latin typeface="Encode Sans"/>
                         </a:rPr>
-                        <a:t>Abril 2026</a:t>
+                        <a:t>Mayo 2026</a:t>
                       </a:r>
                     </a:p>
                   </a:txBody>
@@ -3742,7 +3766,7 @@
                           </a:solidFill>
                           <a:latin typeface="Encode Sans"/>
                         </a:rPr>
-                        <a:t>118,4</a:t>
+                        <a:t>+2.1%</a:t>
                       </a:r>
                     </a:p>
                   </a:txBody>
@@ -3765,7 +3789,7 @@
                           </a:solidFill>
                           <a:latin typeface="Encode Sans"/>
                         </a:rPr>
-                        <a:t>-2.5%</a:t>
+                        <a:t>+33.2%</a:t>
                       </a:r>
                     </a:p>
                   </a:txBody>
@@ -3790,7 +3814,7 @@
                           </a:solidFill>
                           <a:latin typeface="Encode Sans"/>
                         </a:rPr>
-                        <a:t>Marzo 2026</a:t>
+                        <a:t>Abril 2026</a:t>
                       </a:r>
                     </a:p>
                   </a:txBody>
@@ -3813,7 +3837,7 @@
                           </a:solidFill>
                           <a:latin typeface="Encode Sans"/>
                         </a:rPr>
-                        <a:t>122,1</a:t>
+                        <a:t>+2.6%</a:t>
                       </a:r>
                     </a:p>
                   </a:txBody>
@@ -3836,7 +3860,7 @@
                           </a:solidFill>
                           <a:latin typeface="Encode Sans"/>
                         </a:rPr>
-                        <a:t>+5.0%</a:t>
+                        <a:t>+32.4%</a:t>
                       </a:r>
                     </a:p>
                   </a:txBody>
@@ -3861,7 +3885,7 @@
                           </a:solidFill>
                           <a:latin typeface="Encode Sans"/>
                         </a:rPr>
-                        <a:t>Febrero 2026</a:t>
+                        <a:t>Marzo 2026</a:t>
                       </a:r>
                     </a:p>
                   </a:txBody>
@@ -3884,7 +3908,7 @@
                           </a:solidFill>
                           <a:latin typeface="Encode Sans"/>
                         </a:rPr>
-                        <a:t>100,2</a:t>
+                        <a:t>+3.4%</a:t>
                       </a:r>
                     </a:p>
                   </a:txBody>
@@ -3907,7 +3931,7 @@
                           </a:solidFill>
                           <a:latin typeface="Encode Sans"/>
                         </a:rPr>
-                        <a:t>-8.9%</a:t>
+                        <a:t>+32.6%</a:t>
                       </a:r>
                     </a:p>
                   </a:txBody>
@@ -3932,7 +3956,7 @@
                           </a:solidFill>
                           <a:latin typeface="Encode Sans"/>
                         </a:rPr>
-                        <a:t>Enero 2026</a:t>
+                        <a:t>Febrero 2026</a:t>
                       </a:r>
                     </a:p>
                   </a:txBody>
@@ -3955,7 +3979,7 @@
                           </a:solidFill>
                           <a:latin typeface="Encode Sans"/>
                         </a:rPr>
-                        <a:t>106,5</a:t>
+                        <a:t>+2.9%</a:t>
                       </a:r>
                     </a:p>
                   </a:txBody>
@@ -3978,7 +4002,7 @@
                           </a:solidFill>
                           <a:latin typeface="Encode Sans"/>
                         </a:rPr>
-                        <a:t>-3.8%</a:t>
+                        <a:t>+33.0%</a:t>
                       </a:r>
                     </a:p>
                   </a:txBody>
@@ -4003,7 +4027,7 @@
                           </a:solidFill>
                           <a:latin typeface="Encode Sans"/>
                         </a:rPr>
-                        <a:t>Diciembre 2025</a:t>
+                        <a:t>Enero 2026</a:t>
                       </a:r>
                     </a:p>
                   </a:txBody>
@@ -4026,7 +4050,7 @@
                           </a:solidFill>
                           <a:latin typeface="Encode Sans"/>
                         </a:rPr>
-                        <a:t>112,0</a:t>
+                        <a:t>+2.9%</a:t>
                       </a:r>
                     </a:p>
                   </a:txBody>
@@ -4049,827 +4073,7 @@
                           </a:solidFill>
                           <a:latin typeface="Encode Sans"/>
                         </a:rPr>
-                        <a:t>-4.0%</a:t>
-                      </a:r>
-                    </a:p>
-                  </a:txBody>
-                  <a:tcPr marL="36576" marR="36576" marT="18288" marB="18288">
-                    <a:solidFill>
-                      <a:srgbClr val="F8F8F6"/>
-                    </a:solidFill>
-                  </a:tcPr>
-                </a:tc>
-              </a:tr>
-            </a:tbl>
-          </a:graphicData>
-        </a:graphic>
-      </p:graphicFrame>
-      <p:sp>
-        <p:nvSpPr>
-          <p:cNvPr id="9" name="TextBox 8"/>
-          <p:cNvSpPr txBox="1"/>
-          <p:nvPr/>
-        </p:nvSpPr>
-        <p:spPr>
-          <a:xfrm>
-            <a:off x="411480" y="6492240"/>
-            <a:ext cx="11368735" cy="274320"/>
-          </a:xfrm>
-          <a:prstGeom prst="rect">
-            <a:avLst/>
-          </a:prstGeom>
-          <a:noFill/>
-        </p:spPr>
-        <p:txBody>
-          <a:bodyPr wrap="none">
-            <a:spAutoFit/>
-          </a:bodyPr>
-          <a:lstStyle/>
-          <a:p>
-            <a:r>
-              <a:rPr sz="1000" b="0" i="1">
-                <a:solidFill>
-                  <a:srgbClr val="6A6760"/>
-                </a:solidFill>
-                <a:latin typeface="Encode Sans"/>
-              </a:rPr>
-              <a:t>Fuente: elaboración propia en base a INDEC</a:t>
-            </a:r>
-          </a:p>
-        </p:txBody>
-      </p:sp>
-    </p:spTree>
-  </p:cSld>
-  <p:clrMapOvr>
-    <a:masterClrMapping/>
-  </p:clrMapOvr>
-</p:sld>
-</file>
-
-<file path=ppt/slides/slide3.xml><?xml version="1.0" encoding="utf-8"?>
-<p:sld xmlns:a="http://schemas.openxmlformats.org/drawingml/2006/main" xmlns:p="http://schemas.openxmlformats.org/presentationml/2006/main" xmlns:r="http://schemas.openxmlformats.org/officeDocument/2006/relationships">
-  <p:cSld>
-    <p:spTree>
-      <p:nvGrpSpPr>
-        <p:cNvPr id="1" name=""/>
-        <p:cNvGrpSpPr/>
-        <p:nvPr/>
-      </p:nvGrpSpPr>
-      <p:grpSpPr/>
-      <p:sp>
-        <p:nvSpPr>
-          <p:cNvPr id="2" name="Rectangle 1"/>
-          <p:cNvSpPr/>
-          <p:nvPr/>
-        </p:nvSpPr>
-        <p:spPr>
-          <a:xfrm>
-            <a:off x="0" y="0"/>
-            <a:ext cx="12191695" cy="274320"/>
-          </a:xfrm>
-          <a:prstGeom prst="rect">
-            <a:avLst/>
-          </a:prstGeom>
-          <a:solidFill>
-            <a:srgbClr val="00B2C9"/>
-          </a:solidFill>
-          <a:ln>
-            <a:noFill/>
-          </a:ln>
-        </p:spPr>
-        <p:style>
-          <a:lnRef idx="1">
-            <a:schemeClr val="accent1"/>
-          </a:lnRef>
-          <a:fillRef idx="3">
-            <a:schemeClr val="accent1"/>
-          </a:fillRef>
-          <a:effectRef idx="2">
-            <a:schemeClr val="accent1"/>
-          </a:effectRef>
-          <a:fontRef idx="minor">
-            <a:schemeClr val="lt1"/>
-          </a:fontRef>
-        </p:style>
-        <p:txBody>
-          <a:bodyPr rtlCol="0" anchor="ctr"/>
-          <a:lstStyle/>
-          <a:p>
-            <a:pPr algn="ctr"/>
-          </a:p>
-        </p:txBody>
-      </p:sp>
-      <p:sp>
-        <p:nvSpPr>
-          <p:cNvPr id="3" name="TextBox 2"/>
-          <p:cNvSpPr txBox="1"/>
-          <p:nvPr/>
-        </p:nvSpPr>
-        <p:spPr>
-          <a:xfrm>
-            <a:off x="411480" y="457200"/>
-            <a:ext cx="11368735" cy="914400"/>
-          </a:xfrm>
-          <a:prstGeom prst="rect">
-            <a:avLst/>
-          </a:prstGeom>
-          <a:noFill/>
-        </p:spPr>
-        <p:txBody>
-          <a:bodyPr wrap="square" lIns="0" rIns="0">
-            <a:spAutoFit/>
-          </a:bodyPr>
-          <a:lstStyle/>
-          <a:p>
-            <a:pPr algn="l"/>
-            <a:r>
-              <a:rPr sz="2600" b="1" i="0">
-                <a:solidFill>
-                  <a:srgbClr val="00B2C9"/>
-                </a:solidFill>
-                <a:latin typeface="Encode Sans"/>
-              </a:rPr>
-              <a:t>INDUSTRIA MAYO 2026: IPI CRECIÓ +0.0% I.A.</a:t>
-            </a:r>
-          </a:p>
-        </p:txBody>
-      </p:sp>
-      <p:sp>
-        <p:nvSpPr>
-          <p:cNvPr id="4" name="TextBox 3"/>
-          <p:cNvSpPr txBox="1"/>
-          <p:nvPr/>
-        </p:nvSpPr>
-        <p:spPr>
-          <a:xfrm>
-            <a:off x="411480" y="1280160"/>
-            <a:ext cx="11368735" cy="274320"/>
-          </a:xfrm>
-          <a:prstGeom prst="rect">
-            <a:avLst/>
-          </a:prstGeom>
-          <a:noFill/>
-        </p:spPr>
-        <p:txBody>
-          <a:bodyPr wrap="none">
-            <a:spAutoFit/>
-          </a:bodyPr>
-          <a:lstStyle/>
-          <a:p>
-            <a:r>
-              <a:rPr sz="1100" b="0" i="1">
-                <a:solidFill>
-                  <a:srgbClr val="6A6760"/>
-                </a:solidFill>
-                <a:latin typeface="Encode Sans"/>
-              </a:rPr>
-              <a:t>INDEC · período 2026-05</a:t>
-            </a:r>
-          </a:p>
-        </p:txBody>
-      </p:sp>
-      <p:sp>
-        <p:nvSpPr>
-          <p:cNvPr id="5" name="TextBox 4"/>
-          <p:cNvSpPr txBox="1"/>
-          <p:nvPr/>
-        </p:nvSpPr>
-        <p:spPr>
-          <a:xfrm>
-            <a:off x="411480" y="1691640"/>
-            <a:ext cx="5486400" cy="1645920"/>
-          </a:xfrm>
-          <a:prstGeom prst="rect">
-            <a:avLst/>
-          </a:prstGeom>
-          <a:noFill/>
-        </p:spPr>
-        <p:txBody>
-          <a:bodyPr wrap="square" lIns="0" rIns="0">
-            <a:spAutoFit/>
-          </a:bodyPr>
-          <a:lstStyle/>
-          <a:p>
-            <a:pPr algn="just"/>
-            <a:r>
-              <a:rPr sz="1300" b="0" i="0">
-                <a:solidFill>
-                  <a:srgbClr val="3F3F3F"/>
-                </a:solidFill>
-                <a:latin typeface="Encode Sans"/>
-              </a:rPr>
-              <a:t>El Índice de Producción Industrial Manufacturero (IPI) registró una variación interanual de +0.0% en mayo 2026.</a:t>
-            </a:r>
-          </a:p>
-        </p:txBody>
-      </p:sp>
-      <p:sp>
-        <p:nvSpPr>
-          <p:cNvPr id="6" name="TextBox 5"/>
-          <p:cNvSpPr txBox="1"/>
-          <p:nvPr/>
-        </p:nvSpPr>
-        <p:spPr>
-          <a:xfrm>
-            <a:off x="411480" y="3520440"/>
-            <a:ext cx="5486400" cy="2743200"/>
-          </a:xfrm>
-          <a:prstGeom prst="rect">
-            <a:avLst/>
-          </a:prstGeom>
-          <a:noFill/>
-        </p:spPr>
-        <p:txBody>
-          <a:bodyPr wrap="square" lIns="0" rIns="0">
-            <a:spAutoFit/>
-          </a:bodyPr>
-          <a:lstStyle/>
-          <a:p>
-            <a:pPr algn="l">
-              <a:spcAft>
-                <a:spcPts val="800"/>
-              </a:spcAft>
-            </a:pPr>
-            <a:r>
-              <a:rPr sz="1300" b="1" i="0">
-                <a:solidFill>
-                  <a:srgbClr val="00B2C9"/>
-                </a:solidFill>
-                <a:latin typeface="Encode Sans"/>
-              </a:rPr>
-              <a:t>●  </a:t>
-            </a:r>
-            <a:r>
-              <a:rPr sz="1300" b="0" i="0">
-                <a:solidFill>
-                  <a:srgbClr val="3F3F3F"/>
-                </a:solidFill>
-                <a:latin typeface="Encode Sans"/>
-              </a:rPr>
-              <a:t>Variación interanual: +0.0%</a:t>
-            </a:r>
-          </a:p>
-          <a:p>
-            <a:pPr algn="l">
-              <a:spcAft>
-                <a:spcPts val="800"/>
-              </a:spcAft>
-            </a:pPr>
-            <a:r>
-              <a:rPr sz="1300" b="1" i="0">
-                <a:solidFill>
-                  <a:srgbClr val="00B2C9"/>
-                </a:solidFill>
-                <a:latin typeface="Encode Sans"/>
-              </a:rPr>
-              <a:t>●  </a:t>
-            </a:r>
-            <a:r>
-              <a:rPr sz="1300" b="0" i="0">
-                <a:solidFill>
-                  <a:srgbClr val="3F3F3F"/>
-                </a:solidFill>
-                <a:latin typeface="Encode Sans"/>
-              </a:rPr>
-              <a:t>Serie INDEC, base 2004=100. Mide la producción manufacturera (16 ramas).</a:t>
-            </a:r>
-          </a:p>
-        </p:txBody>
-      </p:sp>
-      <p:pic>
-        <p:nvPicPr>
-          <p:cNvPr id="7" name="Picture 6" descr="image.png"/>
-          <p:cNvPicPr>
-            <a:picLocks noChangeAspect="1"/>
-          </p:cNvPicPr>
-          <p:nvPr/>
-        </p:nvPicPr>
-        <p:blipFill>
-          <a:blip r:embed="rId2"/>
-          <a:stretch>
-            <a:fillRect/>
-          </a:stretch>
-        </p:blipFill>
-        <p:spPr>
-          <a:xfrm>
-            <a:off x="6080760" y="1691640"/>
-            <a:ext cx="5669280" cy="2560320"/>
-          </a:xfrm>
-          <a:prstGeom prst="rect">
-            <a:avLst/>
-          </a:prstGeom>
-        </p:spPr>
-      </p:pic>
-      <p:graphicFrame>
-        <p:nvGraphicFramePr>
-          <p:cNvPr id="8" name="Table 7"/>
-          <p:cNvGraphicFramePr>
-            <a:graphicFrameLocks noGrp="1"/>
-          </p:cNvGraphicFramePr>
-          <p:nvPr/>
-        </p:nvGraphicFramePr>
-        <p:xfrm>
-          <a:off x="6080760" y="4434840"/>
-          <a:ext cx="5669280" cy="2048256"/>
-        </p:xfrm>
-        <a:graphic>
-          <a:graphicData uri="http://schemas.openxmlformats.org/drawingml/2006/table">
-            <a:tbl>
-              <a:tblPr firstRow="1" bandRow="1">
-                <a:tableStyleId>{5C22544A-7EE6-4342-B048-85BDC9FD1C3A}</a:tableStyleId>
-              </a:tblPr>
-              <a:tblGrid>
-                <a:gridCol w="1889760"/>
-                <a:gridCol w="1889760"/>
-                <a:gridCol w="1889760"/>
-              </a:tblGrid>
-              <a:tr h="292608">
-                <a:tc>
-                  <a:txBody>
-                    <a:bodyPr/>
-                    <a:lstStyle/>
-                    <a:p>
-                      <a:pPr algn="l"/>
-                      <a:r>
-                        <a:rPr sz="1000" b="1">
-                          <a:solidFill>
-                            <a:srgbClr val="FFFFFF"/>
-                          </a:solidFill>
-                          <a:latin typeface="Encode Sans"/>
-                        </a:rPr>
-                        <a:t>Mes</a:t>
-                      </a:r>
-                    </a:p>
-                  </a:txBody>
-                  <a:tcPr marL="36576" marR="36576" marT="18288" marB="18288">
-                    <a:solidFill>
-                      <a:srgbClr val="00B2C9"/>
-                    </a:solidFill>
-                  </a:tcPr>
-                </a:tc>
-                <a:tc>
-                  <a:txBody>
-                    <a:bodyPr/>
-                    <a:lstStyle/>
-                    <a:p>
-                      <a:pPr algn="r"/>
-                      <a:r>
-                        <a:rPr sz="1000" b="1">
-                          <a:solidFill>
-                            <a:srgbClr val="FFFFFF"/>
-                          </a:solidFill>
-                          <a:latin typeface="Encode Sans"/>
-                        </a:rPr>
-                        <a:t>Original</a:t>
-                      </a:r>
-                    </a:p>
-                  </a:txBody>
-                  <a:tcPr marL="36576" marR="36576" marT="18288" marB="18288">
-                    <a:solidFill>
-                      <a:srgbClr val="00B2C9"/>
-                    </a:solidFill>
-                  </a:tcPr>
-                </a:tc>
-                <a:tc>
-                  <a:txBody>
-                    <a:bodyPr/>
-                    <a:lstStyle/>
-                    <a:p>
-                      <a:pPr algn="r"/>
-                      <a:r>
-                        <a:rPr sz="1000" b="1">
-                          <a:solidFill>
-                            <a:srgbClr val="FFFFFF"/>
-                          </a:solidFill>
-                          <a:latin typeface="Encode Sans"/>
-                        </a:rPr>
-                        <a:t>VIA %</a:t>
-                      </a:r>
-                    </a:p>
-                  </a:txBody>
-                  <a:tcPr marL="36576" marR="36576" marT="18288" marB="18288">
-                    <a:solidFill>
-                      <a:srgbClr val="00B2C9"/>
-                    </a:solidFill>
-                  </a:tcPr>
-                </a:tc>
-              </a:tr>
-              <a:tr h="292608">
-                <a:tc>
-                  <a:txBody>
-                    <a:bodyPr/>
-                    <a:lstStyle/>
-                    <a:p>
-                      <a:pPr algn="l"/>
-                      <a:r>
-                        <a:rPr sz="1000">
-                          <a:solidFill>
-                            <a:srgbClr val="3F3F3F"/>
-                          </a:solidFill>
-                          <a:latin typeface="Encode Sans"/>
-                        </a:rPr>
-                        <a:t>Mayo 2026</a:t>
-                      </a:r>
-                    </a:p>
-                  </a:txBody>
-                  <a:tcPr marL="36576" marR="36576" marT="18288" marB="18288">
-                    <a:solidFill>
-                      <a:srgbClr val="FFFFFF"/>
-                    </a:solidFill>
-                  </a:tcPr>
-                </a:tc>
-                <a:tc>
-                  <a:txBody>
-                    <a:bodyPr/>
-                    <a:lstStyle/>
-                    <a:p>
-                      <a:pPr algn="r"/>
-                      <a:r>
-                        <a:rPr sz="1000">
-                          <a:solidFill>
-                            <a:srgbClr val="3F3F3F"/>
-                          </a:solidFill>
-                          <a:latin typeface="Encode Sans"/>
-                        </a:rPr>
-                        <a:t>117,0</a:t>
-                      </a:r>
-                    </a:p>
-                  </a:txBody>
-                  <a:tcPr marL="36576" marR="36576" marT="18288" marB="18288">
-                    <a:solidFill>
-                      <a:srgbClr val="FFFFFF"/>
-                    </a:solidFill>
-                  </a:tcPr>
-                </a:tc>
-                <a:tc>
-                  <a:txBody>
-                    <a:bodyPr/>
-                    <a:lstStyle/>
-                    <a:p>
-                      <a:pPr algn="r"/>
-                      <a:r>
-                        <a:rPr sz="1000">
-                          <a:solidFill>
-                            <a:srgbClr val="3F3F3F"/>
-                          </a:solidFill>
-                          <a:latin typeface="Encode Sans"/>
-                        </a:rPr>
-                        <a:t>-5.7%</a:t>
-                      </a:r>
-                    </a:p>
-                  </a:txBody>
-                  <a:tcPr marL="36576" marR="36576" marT="18288" marB="18288">
-                    <a:solidFill>
-                      <a:srgbClr val="FFFFFF"/>
-                    </a:solidFill>
-                  </a:tcPr>
-                </a:tc>
-              </a:tr>
-              <a:tr h="292608">
-                <a:tc>
-                  <a:txBody>
-                    <a:bodyPr/>
-                    <a:lstStyle/>
-                    <a:p>
-                      <a:pPr algn="l"/>
-                      <a:r>
-                        <a:rPr sz="1000">
-                          <a:solidFill>
-                            <a:srgbClr val="3F3F3F"/>
-                          </a:solidFill>
-                          <a:latin typeface="Encode Sans"/>
-                        </a:rPr>
-                        <a:t>Abril 2026</a:t>
-                      </a:r>
-                    </a:p>
-                  </a:txBody>
-                  <a:tcPr marL="36576" marR="36576" marT="18288" marB="18288">
-                    <a:solidFill>
-                      <a:srgbClr val="F8F8F6"/>
-                    </a:solidFill>
-                  </a:tcPr>
-                </a:tc>
-                <a:tc>
-                  <a:txBody>
-                    <a:bodyPr/>
-                    <a:lstStyle/>
-                    <a:p>
-                      <a:pPr algn="r"/>
-                      <a:r>
-                        <a:rPr sz="1000">
-                          <a:solidFill>
-                            <a:srgbClr val="3F3F3F"/>
-                          </a:solidFill>
-                          <a:latin typeface="Encode Sans"/>
-                        </a:rPr>
-                        <a:t>118,4</a:t>
-                      </a:r>
-                    </a:p>
-                  </a:txBody>
-                  <a:tcPr marL="36576" marR="36576" marT="18288" marB="18288">
-                    <a:solidFill>
-                      <a:srgbClr val="F8F8F6"/>
-                    </a:solidFill>
-                  </a:tcPr>
-                </a:tc>
-                <a:tc>
-                  <a:txBody>
-                    <a:bodyPr/>
-                    <a:lstStyle/>
-                    <a:p>
-                      <a:pPr algn="r"/>
-                      <a:r>
-                        <a:rPr sz="1000">
-                          <a:solidFill>
-                            <a:srgbClr val="3F3F3F"/>
-                          </a:solidFill>
-                          <a:latin typeface="Encode Sans"/>
-                        </a:rPr>
-                        <a:t>-2.5%</a:t>
-                      </a:r>
-                    </a:p>
-                  </a:txBody>
-                  <a:tcPr marL="36576" marR="36576" marT="18288" marB="18288">
-                    <a:solidFill>
-                      <a:srgbClr val="F8F8F6"/>
-                    </a:solidFill>
-                  </a:tcPr>
-                </a:tc>
-              </a:tr>
-              <a:tr h="292608">
-                <a:tc>
-                  <a:txBody>
-                    <a:bodyPr/>
-                    <a:lstStyle/>
-                    <a:p>
-                      <a:pPr algn="l"/>
-                      <a:r>
-                        <a:rPr sz="1000">
-                          <a:solidFill>
-                            <a:srgbClr val="3F3F3F"/>
-                          </a:solidFill>
-                          <a:latin typeface="Encode Sans"/>
-                        </a:rPr>
-                        <a:t>Marzo 2026</a:t>
-                      </a:r>
-                    </a:p>
-                  </a:txBody>
-                  <a:tcPr marL="36576" marR="36576" marT="18288" marB="18288">
-                    <a:solidFill>
-                      <a:srgbClr val="FFFFFF"/>
-                    </a:solidFill>
-                  </a:tcPr>
-                </a:tc>
-                <a:tc>
-                  <a:txBody>
-                    <a:bodyPr/>
-                    <a:lstStyle/>
-                    <a:p>
-                      <a:pPr algn="r"/>
-                      <a:r>
-                        <a:rPr sz="1000">
-                          <a:solidFill>
-                            <a:srgbClr val="3F3F3F"/>
-                          </a:solidFill>
-                          <a:latin typeface="Encode Sans"/>
-                        </a:rPr>
-                        <a:t>122,1</a:t>
-                      </a:r>
-                    </a:p>
-                  </a:txBody>
-                  <a:tcPr marL="36576" marR="36576" marT="18288" marB="18288">
-                    <a:solidFill>
-                      <a:srgbClr val="FFFFFF"/>
-                    </a:solidFill>
-                  </a:tcPr>
-                </a:tc>
-                <a:tc>
-                  <a:txBody>
-                    <a:bodyPr/>
-                    <a:lstStyle/>
-                    <a:p>
-                      <a:pPr algn="r"/>
-                      <a:r>
-                        <a:rPr sz="1000">
-                          <a:solidFill>
-                            <a:srgbClr val="3F3F3F"/>
-                          </a:solidFill>
-                          <a:latin typeface="Encode Sans"/>
-                        </a:rPr>
-                        <a:t>+5.0%</a:t>
-                      </a:r>
-                    </a:p>
-                  </a:txBody>
-                  <a:tcPr marL="36576" marR="36576" marT="18288" marB="18288">
-                    <a:solidFill>
-                      <a:srgbClr val="FFFFFF"/>
-                    </a:solidFill>
-                  </a:tcPr>
-                </a:tc>
-              </a:tr>
-              <a:tr h="292608">
-                <a:tc>
-                  <a:txBody>
-                    <a:bodyPr/>
-                    <a:lstStyle/>
-                    <a:p>
-                      <a:pPr algn="l"/>
-                      <a:r>
-                        <a:rPr sz="1000">
-                          <a:solidFill>
-                            <a:srgbClr val="3F3F3F"/>
-                          </a:solidFill>
-                          <a:latin typeface="Encode Sans"/>
-                        </a:rPr>
-                        <a:t>Febrero 2026</a:t>
-                      </a:r>
-                    </a:p>
-                  </a:txBody>
-                  <a:tcPr marL="36576" marR="36576" marT="18288" marB="18288">
-                    <a:solidFill>
-                      <a:srgbClr val="F8F8F6"/>
-                    </a:solidFill>
-                  </a:tcPr>
-                </a:tc>
-                <a:tc>
-                  <a:txBody>
-                    <a:bodyPr/>
-                    <a:lstStyle/>
-                    <a:p>
-                      <a:pPr algn="r"/>
-                      <a:r>
-                        <a:rPr sz="1000">
-                          <a:solidFill>
-                            <a:srgbClr val="3F3F3F"/>
-                          </a:solidFill>
-                          <a:latin typeface="Encode Sans"/>
-                        </a:rPr>
-                        <a:t>100,2</a:t>
-                      </a:r>
-                    </a:p>
-                  </a:txBody>
-                  <a:tcPr marL="36576" marR="36576" marT="18288" marB="18288">
-                    <a:solidFill>
-                      <a:srgbClr val="F8F8F6"/>
-                    </a:solidFill>
-                  </a:tcPr>
-                </a:tc>
-                <a:tc>
-                  <a:txBody>
-                    <a:bodyPr/>
-                    <a:lstStyle/>
-                    <a:p>
-                      <a:pPr algn="r"/>
-                      <a:r>
-                        <a:rPr sz="1000">
-                          <a:solidFill>
-                            <a:srgbClr val="3F3F3F"/>
-                          </a:solidFill>
-                          <a:latin typeface="Encode Sans"/>
-                        </a:rPr>
-                        <a:t>-8.9%</a:t>
-                      </a:r>
-                    </a:p>
-                  </a:txBody>
-                  <a:tcPr marL="36576" marR="36576" marT="18288" marB="18288">
-                    <a:solidFill>
-                      <a:srgbClr val="F8F8F6"/>
-                    </a:solidFill>
-                  </a:tcPr>
-                </a:tc>
-              </a:tr>
-              <a:tr h="292608">
-                <a:tc>
-                  <a:txBody>
-                    <a:bodyPr/>
-                    <a:lstStyle/>
-                    <a:p>
-                      <a:pPr algn="l"/>
-                      <a:r>
-                        <a:rPr sz="1000">
-                          <a:solidFill>
-                            <a:srgbClr val="3F3F3F"/>
-                          </a:solidFill>
-                          <a:latin typeface="Encode Sans"/>
-                        </a:rPr>
-                        <a:t>Enero 2026</a:t>
-                      </a:r>
-                    </a:p>
-                  </a:txBody>
-                  <a:tcPr marL="36576" marR="36576" marT="18288" marB="18288">
-                    <a:solidFill>
-                      <a:srgbClr val="FFFFFF"/>
-                    </a:solidFill>
-                  </a:tcPr>
-                </a:tc>
-                <a:tc>
-                  <a:txBody>
-                    <a:bodyPr/>
-                    <a:lstStyle/>
-                    <a:p>
-                      <a:pPr algn="r"/>
-                      <a:r>
-                        <a:rPr sz="1000">
-                          <a:solidFill>
-                            <a:srgbClr val="3F3F3F"/>
-                          </a:solidFill>
-                          <a:latin typeface="Encode Sans"/>
-                        </a:rPr>
-                        <a:t>106,5</a:t>
-                      </a:r>
-                    </a:p>
-                  </a:txBody>
-                  <a:tcPr marL="36576" marR="36576" marT="18288" marB="18288">
-                    <a:solidFill>
-                      <a:srgbClr val="FFFFFF"/>
-                    </a:solidFill>
-                  </a:tcPr>
-                </a:tc>
-                <a:tc>
-                  <a:txBody>
-                    <a:bodyPr/>
-                    <a:lstStyle/>
-                    <a:p>
-                      <a:pPr algn="r"/>
-                      <a:r>
-                        <a:rPr sz="1000">
-                          <a:solidFill>
-                            <a:srgbClr val="3F3F3F"/>
-                          </a:solidFill>
-                          <a:latin typeface="Encode Sans"/>
-                        </a:rPr>
-                        <a:t>-3.8%</a:t>
-                      </a:r>
-                    </a:p>
-                  </a:txBody>
-                  <a:tcPr marL="36576" marR="36576" marT="18288" marB="18288">
-                    <a:solidFill>
-                      <a:srgbClr val="FFFFFF"/>
-                    </a:solidFill>
-                  </a:tcPr>
-                </a:tc>
-              </a:tr>
-              <a:tr h="292608">
-                <a:tc>
-                  <a:txBody>
-                    <a:bodyPr/>
-                    <a:lstStyle/>
-                    <a:p>
-                      <a:pPr algn="l"/>
-                      <a:r>
-                        <a:rPr sz="1000">
-                          <a:solidFill>
-                            <a:srgbClr val="3F3F3F"/>
-                          </a:solidFill>
-                          <a:latin typeface="Encode Sans"/>
-                        </a:rPr>
-                        <a:t>Diciembre 2025</a:t>
-                      </a:r>
-                    </a:p>
-                  </a:txBody>
-                  <a:tcPr marL="36576" marR="36576" marT="18288" marB="18288">
-                    <a:solidFill>
-                      <a:srgbClr val="F8F8F6"/>
-                    </a:solidFill>
-                  </a:tcPr>
-                </a:tc>
-                <a:tc>
-                  <a:txBody>
-                    <a:bodyPr/>
-                    <a:lstStyle/>
-                    <a:p>
-                      <a:pPr algn="r"/>
-                      <a:r>
-                        <a:rPr sz="1000">
-                          <a:solidFill>
-                            <a:srgbClr val="3F3F3F"/>
-                          </a:solidFill>
-                          <a:latin typeface="Encode Sans"/>
-                        </a:rPr>
-                        <a:t>112,0</a:t>
-                      </a:r>
-                    </a:p>
-                  </a:txBody>
-                  <a:tcPr marL="36576" marR="36576" marT="18288" marB="18288">
-                    <a:solidFill>
-                      <a:srgbClr val="F8F8F6"/>
-                    </a:solidFill>
-                  </a:tcPr>
-                </a:tc>
-                <a:tc>
-                  <a:txBody>
-                    <a:bodyPr/>
-                    <a:lstStyle/>
-                    <a:p>
-                      <a:pPr algn="r"/>
-                      <a:r>
-                        <a:rPr sz="1000">
-                          <a:solidFill>
-                            <a:srgbClr val="3F3F3F"/>
-                          </a:solidFill>
-                          <a:latin typeface="Encode Sans"/>
-                        </a:rPr>
-                        <a:t>-4.0%</a:t>
+                        <a:t>+32.4%</a:t>
                       </a:r>
                     </a:p>
                   </a:txBody>

</xml_diff>

<commit_message>
data: update 2026-07-15 ( data.json despidos.json scraper/historical_despidos.json publicaciones_semana.pptx rrii_brutas.xlsx)
</commit_message>
<xml_diff>
--- a/publicaciones_semana.pptx
+++ b/publicaciones_semana.pptx
@@ -7,6 +7,7 @@
   <p:sldIdLst>
     <p:sldId id="256" r:id="rId7"/>
     <p:sldId id="257" r:id="rId8"/>
+    <p:sldId id="258" r:id="rId9"/>
   </p:sldIdLst>
   <p:sldSz cx="12191695" cy="6858000" type="screen4x3"/>
   <p:notesSz cx="6858000" cy="9144000"/>
@@ -3272,7 +3273,7 @@
                 </a:solidFill>
                 <a:latin typeface="Encode Sans"/>
               </a:rPr>
-              <a:t>1 publicaciones · datos oficiales INDEC / BCRA / Hacienda</a:t>
+              <a:t>2 publicaciones · datos oficiales INDEC / BCRA / Hacienda</a:t>
             </a:r>
           </a:p>
         </p:txBody>
@@ -3437,7 +3438,7 @@
                 </a:solidFill>
                 <a:latin typeface="Encode Sans"/>
               </a:rPr>
-              <a:t>El IPC nivel general aumentó +1.9% mensual en junio 2026, acumulando 33.56% interanual. INDEC publicó el indicador con la metodología vigente.</a:t>
+              <a:t>El IPC nivel general aumentó +1.9% mensual en junio 2026, acumulando 33.55% interanual. INDEC publicó el indicador con la metodología vigente.</a:t>
             </a:r>
           </a:p>
         </p:txBody>
@@ -3510,7 +3511,7 @@
                 </a:solidFill>
                 <a:latin typeface="Encode Sans"/>
               </a:rPr>
-              <a:t>Variación interanual: 33.56%</a:t>
+              <a:t>Variación interanual: 33.55%</a:t>
             </a:r>
           </a:p>
           <a:p>
@@ -3718,7 +3719,7 @@
                           </a:solidFill>
                           <a:latin typeface="Encode Sans"/>
                         </a:rPr>
-                        <a:t>+33.6%</a:t>
+                        <a:t>+33.5%</a:t>
                       </a:r>
                     </a:p>
                   </a:txBody>
@@ -4130,6 +4131,826 @@
 </p:sld>
 </file>
 
+<file path=ppt/slides/slide3.xml><?xml version="1.0" encoding="utf-8"?>
+<p:sld xmlns:a="http://schemas.openxmlformats.org/drawingml/2006/main" xmlns:p="http://schemas.openxmlformats.org/presentationml/2006/main" xmlns:r="http://schemas.openxmlformats.org/officeDocument/2006/relationships">
+  <p:cSld>
+    <p:spTree>
+      <p:nvGrpSpPr>
+        <p:cNvPr id="1" name=""/>
+        <p:cNvGrpSpPr/>
+        <p:nvPr/>
+      </p:nvGrpSpPr>
+      <p:grpSpPr/>
+      <p:sp>
+        <p:nvSpPr>
+          <p:cNvPr id="2" name="Rectangle 1"/>
+          <p:cNvSpPr/>
+          <p:nvPr/>
+        </p:nvSpPr>
+        <p:spPr>
+          <a:xfrm>
+            <a:off x="0" y="0"/>
+            <a:ext cx="12191695" cy="274320"/>
+          </a:xfrm>
+          <a:prstGeom prst="rect">
+            <a:avLst/>
+          </a:prstGeom>
+          <a:solidFill>
+            <a:srgbClr val="00B2C9"/>
+          </a:solidFill>
+          <a:ln>
+            <a:noFill/>
+          </a:ln>
+        </p:spPr>
+        <p:style>
+          <a:lnRef idx="1">
+            <a:schemeClr val="accent1"/>
+          </a:lnRef>
+          <a:fillRef idx="3">
+            <a:schemeClr val="accent1"/>
+          </a:fillRef>
+          <a:effectRef idx="2">
+            <a:schemeClr val="accent1"/>
+          </a:effectRef>
+          <a:fontRef idx="minor">
+            <a:schemeClr val="lt1"/>
+          </a:fontRef>
+        </p:style>
+        <p:txBody>
+          <a:bodyPr rtlCol="0" anchor="ctr"/>
+          <a:lstStyle/>
+          <a:p>
+            <a:pPr algn="ctr"/>
+          </a:p>
+        </p:txBody>
+      </p:sp>
+      <p:sp>
+        <p:nvSpPr>
+          <p:cNvPr id="3" name="TextBox 2"/>
+          <p:cNvSpPr txBox="1"/>
+          <p:nvPr/>
+        </p:nvSpPr>
+        <p:spPr>
+          <a:xfrm>
+            <a:off x="411480" y="457200"/>
+            <a:ext cx="11368735" cy="914400"/>
+          </a:xfrm>
+          <a:prstGeom prst="rect">
+            <a:avLst/>
+          </a:prstGeom>
+          <a:noFill/>
+        </p:spPr>
+        <p:txBody>
+          <a:bodyPr wrap="square" lIns="0" rIns="0">
+            <a:spAutoFit/>
+          </a:bodyPr>
+          <a:lstStyle/>
+          <a:p>
+            <a:pPr algn="l"/>
+            <a:r>
+              <a:rPr sz="2600" b="1" i="0">
+                <a:solidFill>
+                  <a:srgbClr val="00B2C9"/>
+                </a:solidFill>
+                <a:latin typeface="Encode Sans"/>
+              </a:rPr>
+              <a:t>INDUSTRIA MAYO 2026: IPI CRECIÓ +0.0% I.A.</a:t>
+            </a:r>
+          </a:p>
+        </p:txBody>
+      </p:sp>
+      <p:sp>
+        <p:nvSpPr>
+          <p:cNvPr id="4" name="TextBox 3"/>
+          <p:cNvSpPr txBox="1"/>
+          <p:nvPr/>
+        </p:nvSpPr>
+        <p:spPr>
+          <a:xfrm>
+            <a:off x="411480" y="1280160"/>
+            <a:ext cx="11368735" cy="274320"/>
+          </a:xfrm>
+          <a:prstGeom prst="rect">
+            <a:avLst/>
+          </a:prstGeom>
+          <a:noFill/>
+        </p:spPr>
+        <p:txBody>
+          <a:bodyPr wrap="none">
+            <a:spAutoFit/>
+          </a:bodyPr>
+          <a:lstStyle/>
+          <a:p>
+            <a:r>
+              <a:rPr sz="1100" b="0" i="1">
+                <a:solidFill>
+                  <a:srgbClr val="6A6760"/>
+                </a:solidFill>
+                <a:latin typeface="Encode Sans"/>
+              </a:rPr>
+              <a:t>INDEC · período 2026-05</a:t>
+            </a:r>
+          </a:p>
+        </p:txBody>
+      </p:sp>
+      <p:sp>
+        <p:nvSpPr>
+          <p:cNvPr id="5" name="TextBox 4"/>
+          <p:cNvSpPr txBox="1"/>
+          <p:nvPr/>
+        </p:nvSpPr>
+        <p:spPr>
+          <a:xfrm>
+            <a:off x="411480" y="1691640"/>
+            <a:ext cx="5486400" cy="1645920"/>
+          </a:xfrm>
+          <a:prstGeom prst="rect">
+            <a:avLst/>
+          </a:prstGeom>
+          <a:noFill/>
+        </p:spPr>
+        <p:txBody>
+          <a:bodyPr wrap="square" lIns="0" rIns="0">
+            <a:spAutoFit/>
+          </a:bodyPr>
+          <a:lstStyle/>
+          <a:p>
+            <a:pPr algn="just"/>
+            <a:r>
+              <a:rPr sz="1300" b="0" i="0">
+                <a:solidFill>
+                  <a:srgbClr val="3F3F3F"/>
+                </a:solidFill>
+                <a:latin typeface="Encode Sans"/>
+              </a:rPr>
+              <a:t>El Índice de Producción Industrial Manufacturero (IPI) registró una variación interanual de +0.0% en mayo 2026.</a:t>
+            </a:r>
+          </a:p>
+        </p:txBody>
+      </p:sp>
+      <p:sp>
+        <p:nvSpPr>
+          <p:cNvPr id="6" name="TextBox 5"/>
+          <p:cNvSpPr txBox="1"/>
+          <p:nvPr/>
+        </p:nvSpPr>
+        <p:spPr>
+          <a:xfrm>
+            <a:off x="411480" y="3520440"/>
+            <a:ext cx="5486400" cy="2743200"/>
+          </a:xfrm>
+          <a:prstGeom prst="rect">
+            <a:avLst/>
+          </a:prstGeom>
+          <a:noFill/>
+        </p:spPr>
+        <p:txBody>
+          <a:bodyPr wrap="square" lIns="0" rIns="0">
+            <a:spAutoFit/>
+          </a:bodyPr>
+          <a:lstStyle/>
+          <a:p>
+            <a:pPr algn="l">
+              <a:spcAft>
+                <a:spcPts val="800"/>
+              </a:spcAft>
+            </a:pPr>
+            <a:r>
+              <a:rPr sz="1300" b="1" i="0">
+                <a:solidFill>
+                  <a:srgbClr val="00B2C9"/>
+                </a:solidFill>
+                <a:latin typeface="Encode Sans"/>
+              </a:rPr>
+              <a:t>●  </a:t>
+            </a:r>
+            <a:r>
+              <a:rPr sz="1300" b="0" i="0">
+                <a:solidFill>
+                  <a:srgbClr val="3F3F3F"/>
+                </a:solidFill>
+                <a:latin typeface="Encode Sans"/>
+              </a:rPr>
+              <a:t>Variación interanual: +0.0%</a:t>
+            </a:r>
+          </a:p>
+          <a:p>
+            <a:pPr algn="l">
+              <a:spcAft>
+                <a:spcPts val="800"/>
+              </a:spcAft>
+            </a:pPr>
+            <a:r>
+              <a:rPr sz="1300" b="1" i="0">
+                <a:solidFill>
+                  <a:srgbClr val="00B2C9"/>
+                </a:solidFill>
+                <a:latin typeface="Encode Sans"/>
+              </a:rPr>
+              <a:t>●  </a:t>
+            </a:r>
+            <a:r>
+              <a:rPr sz="1300" b="0" i="0">
+                <a:solidFill>
+                  <a:srgbClr val="3F3F3F"/>
+                </a:solidFill>
+                <a:latin typeface="Encode Sans"/>
+              </a:rPr>
+              <a:t>Serie INDEC, base 2004=100. Mide la producción manufacturera (16 ramas).</a:t>
+            </a:r>
+          </a:p>
+        </p:txBody>
+      </p:sp>
+      <p:pic>
+        <p:nvPicPr>
+          <p:cNvPr id="7" name="Picture 6" descr="image.png"/>
+          <p:cNvPicPr>
+            <a:picLocks noChangeAspect="1"/>
+          </p:cNvPicPr>
+          <p:nvPr/>
+        </p:nvPicPr>
+        <p:blipFill>
+          <a:blip r:embed="rId2"/>
+          <a:stretch>
+            <a:fillRect/>
+          </a:stretch>
+        </p:blipFill>
+        <p:spPr>
+          <a:xfrm>
+            <a:off x="6080760" y="1691640"/>
+            <a:ext cx="5669280" cy="2560320"/>
+          </a:xfrm>
+          <a:prstGeom prst="rect">
+            <a:avLst/>
+          </a:prstGeom>
+        </p:spPr>
+      </p:pic>
+      <p:graphicFrame>
+        <p:nvGraphicFramePr>
+          <p:cNvPr id="8" name="Table 7"/>
+          <p:cNvGraphicFramePr>
+            <a:graphicFrameLocks noGrp="1"/>
+          </p:cNvGraphicFramePr>
+          <p:nvPr/>
+        </p:nvGraphicFramePr>
+        <p:xfrm>
+          <a:off x="6080760" y="4434840"/>
+          <a:ext cx="5669280" cy="2048256"/>
+        </p:xfrm>
+        <a:graphic>
+          <a:graphicData uri="http://schemas.openxmlformats.org/drawingml/2006/table">
+            <a:tbl>
+              <a:tblPr firstRow="1" bandRow="1">
+                <a:tableStyleId>{5C22544A-7EE6-4342-B048-85BDC9FD1C3A}</a:tableStyleId>
+              </a:tblPr>
+              <a:tblGrid>
+                <a:gridCol w="1889760"/>
+                <a:gridCol w="1889760"/>
+                <a:gridCol w="1889760"/>
+              </a:tblGrid>
+              <a:tr h="292608">
+                <a:tc>
+                  <a:txBody>
+                    <a:bodyPr/>
+                    <a:lstStyle/>
+                    <a:p>
+                      <a:pPr algn="l"/>
+                      <a:r>
+                        <a:rPr sz="1000" b="1">
+                          <a:solidFill>
+                            <a:srgbClr val="FFFFFF"/>
+                          </a:solidFill>
+                          <a:latin typeface="Encode Sans"/>
+                        </a:rPr>
+                        <a:t>Mes</a:t>
+                      </a:r>
+                    </a:p>
+                  </a:txBody>
+                  <a:tcPr marL="36576" marR="36576" marT="18288" marB="18288">
+                    <a:solidFill>
+                      <a:srgbClr val="00B2C9"/>
+                    </a:solidFill>
+                  </a:tcPr>
+                </a:tc>
+                <a:tc>
+                  <a:txBody>
+                    <a:bodyPr/>
+                    <a:lstStyle/>
+                    <a:p>
+                      <a:pPr algn="r"/>
+                      <a:r>
+                        <a:rPr sz="1000" b="1">
+                          <a:solidFill>
+                            <a:srgbClr val="FFFFFF"/>
+                          </a:solidFill>
+                          <a:latin typeface="Encode Sans"/>
+                        </a:rPr>
+                        <a:t>Original</a:t>
+                      </a:r>
+                    </a:p>
+                  </a:txBody>
+                  <a:tcPr marL="36576" marR="36576" marT="18288" marB="18288">
+                    <a:solidFill>
+                      <a:srgbClr val="00B2C9"/>
+                    </a:solidFill>
+                  </a:tcPr>
+                </a:tc>
+                <a:tc>
+                  <a:txBody>
+                    <a:bodyPr/>
+                    <a:lstStyle/>
+                    <a:p>
+                      <a:pPr algn="r"/>
+                      <a:r>
+                        <a:rPr sz="1000" b="1">
+                          <a:solidFill>
+                            <a:srgbClr val="FFFFFF"/>
+                          </a:solidFill>
+                          <a:latin typeface="Encode Sans"/>
+                        </a:rPr>
+                        <a:t>VIA %</a:t>
+                      </a:r>
+                    </a:p>
+                  </a:txBody>
+                  <a:tcPr marL="36576" marR="36576" marT="18288" marB="18288">
+                    <a:solidFill>
+                      <a:srgbClr val="00B2C9"/>
+                    </a:solidFill>
+                  </a:tcPr>
+                </a:tc>
+              </a:tr>
+              <a:tr h="292608">
+                <a:tc>
+                  <a:txBody>
+                    <a:bodyPr/>
+                    <a:lstStyle/>
+                    <a:p>
+                      <a:pPr algn="l"/>
+                      <a:r>
+                        <a:rPr sz="1000">
+                          <a:solidFill>
+                            <a:srgbClr val="3F3F3F"/>
+                          </a:solidFill>
+                          <a:latin typeface="Encode Sans"/>
+                        </a:rPr>
+                        <a:t>Mayo 2026</a:t>
+                      </a:r>
+                    </a:p>
+                  </a:txBody>
+                  <a:tcPr marL="36576" marR="36576" marT="18288" marB="18288">
+                    <a:solidFill>
+                      <a:srgbClr val="FFFFFF"/>
+                    </a:solidFill>
+                  </a:tcPr>
+                </a:tc>
+                <a:tc>
+                  <a:txBody>
+                    <a:bodyPr/>
+                    <a:lstStyle/>
+                    <a:p>
+                      <a:pPr algn="r"/>
+                      <a:r>
+                        <a:rPr sz="1000">
+                          <a:solidFill>
+                            <a:srgbClr val="3F3F3F"/>
+                          </a:solidFill>
+                          <a:latin typeface="Encode Sans"/>
+                        </a:rPr>
+                        <a:t>117,0</a:t>
+                      </a:r>
+                    </a:p>
+                  </a:txBody>
+                  <a:tcPr marL="36576" marR="36576" marT="18288" marB="18288">
+                    <a:solidFill>
+                      <a:srgbClr val="FFFFFF"/>
+                    </a:solidFill>
+                  </a:tcPr>
+                </a:tc>
+                <a:tc>
+                  <a:txBody>
+                    <a:bodyPr/>
+                    <a:lstStyle/>
+                    <a:p>
+                      <a:pPr algn="r"/>
+                      <a:r>
+                        <a:rPr sz="1000">
+                          <a:solidFill>
+                            <a:srgbClr val="3F3F3F"/>
+                          </a:solidFill>
+                          <a:latin typeface="Encode Sans"/>
+                        </a:rPr>
+                        <a:t>-5.7%</a:t>
+                      </a:r>
+                    </a:p>
+                  </a:txBody>
+                  <a:tcPr marL="36576" marR="36576" marT="18288" marB="18288">
+                    <a:solidFill>
+                      <a:srgbClr val="FFFFFF"/>
+                    </a:solidFill>
+                  </a:tcPr>
+                </a:tc>
+              </a:tr>
+              <a:tr h="292608">
+                <a:tc>
+                  <a:txBody>
+                    <a:bodyPr/>
+                    <a:lstStyle/>
+                    <a:p>
+                      <a:pPr algn="l"/>
+                      <a:r>
+                        <a:rPr sz="1000">
+                          <a:solidFill>
+                            <a:srgbClr val="3F3F3F"/>
+                          </a:solidFill>
+                          <a:latin typeface="Encode Sans"/>
+                        </a:rPr>
+                        <a:t>Abril 2026</a:t>
+                      </a:r>
+                    </a:p>
+                  </a:txBody>
+                  <a:tcPr marL="36576" marR="36576" marT="18288" marB="18288">
+                    <a:solidFill>
+                      <a:srgbClr val="F8F8F6"/>
+                    </a:solidFill>
+                  </a:tcPr>
+                </a:tc>
+                <a:tc>
+                  <a:txBody>
+                    <a:bodyPr/>
+                    <a:lstStyle/>
+                    <a:p>
+                      <a:pPr algn="r"/>
+                      <a:r>
+                        <a:rPr sz="1000">
+                          <a:solidFill>
+                            <a:srgbClr val="3F3F3F"/>
+                          </a:solidFill>
+                          <a:latin typeface="Encode Sans"/>
+                        </a:rPr>
+                        <a:t>118,4</a:t>
+                      </a:r>
+                    </a:p>
+                  </a:txBody>
+                  <a:tcPr marL="36576" marR="36576" marT="18288" marB="18288">
+                    <a:solidFill>
+                      <a:srgbClr val="F8F8F6"/>
+                    </a:solidFill>
+                  </a:tcPr>
+                </a:tc>
+                <a:tc>
+                  <a:txBody>
+                    <a:bodyPr/>
+                    <a:lstStyle/>
+                    <a:p>
+                      <a:pPr algn="r"/>
+                      <a:r>
+                        <a:rPr sz="1000">
+                          <a:solidFill>
+                            <a:srgbClr val="3F3F3F"/>
+                          </a:solidFill>
+                          <a:latin typeface="Encode Sans"/>
+                        </a:rPr>
+                        <a:t>-2.5%</a:t>
+                      </a:r>
+                    </a:p>
+                  </a:txBody>
+                  <a:tcPr marL="36576" marR="36576" marT="18288" marB="18288">
+                    <a:solidFill>
+                      <a:srgbClr val="F8F8F6"/>
+                    </a:solidFill>
+                  </a:tcPr>
+                </a:tc>
+              </a:tr>
+              <a:tr h="292608">
+                <a:tc>
+                  <a:txBody>
+                    <a:bodyPr/>
+                    <a:lstStyle/>
+                    <a:p>
+                      <a:pPr algn="l"/>
+                      <a:r>
+                        <a:rPr sz="1000">
+                          <a:solidFill>
+                            <a:srgbClr val="3F3F3F"/>
+                          </a:solidFill>
+                          <a:latin typeface="Encode Sans"/>
+                        </a:rPr>
+                        <a:t>Marzo 2026</a:t>
+                      </a:r>
+                    </a:p>
+                  </a:txBody>
+                  <a:tcPr marL="36576" marR="36576" marT="18288" marB="18288">
+                    <a:solidFill>
+                      <a:srgbClr val="FFFFFF"/>
+                    </a:solidFill>
+                  </a:tcPr>
+                </a:tc>
+                <a:tc>
+                  <a:txBody>
+                    <a:bodyPr/>
+                    <a:lstStyle/>
+                    <a:p>
+                      <a:pPr algn="r"/>
+                      <a:r>
+                        <a:rPr sz="1000">
+                          <a:solidFill>
+                            <a:srgbClr val="3F3F3F"/>
+                          </a:solidFill>
+                          <a:latin typeface="Encode Sans"/>
+                        </a:rPr>
+                        <a:t>122,1</a:t>
+                      </a:r>
+                    </a:p>
+                  </a:txBody>
+                  <a:tcPr marL="36576" marR="36576" marT="18288" marB="18288">
+                    <a:solidFill>
+                      <a:srgbClr val="FFFFFF"/>
+                    </a:solidFill>
+                  </a:tcPr>
+                </a:tc>
+                <a:tc>
+                  <a:txBody>
+                    <a:bodyPr/>
+                    <a:lstStyle/>
+                    <a:p>
+                      <a:pPr algn="r"/>
+                      <a:r>
+                        <a:rPr sz="1000">
+                          <a:solidFill>
+                            <a:srgbClr val="3F3F3F"/>
+                          </a:solidFill>
+                          <a:latin typeface="Encode Sans"/>
+                        </a:rPr>
+                        <a:t>+5.0%</a:t>
+                      </a:r>
+                    </a:p>
+                  </a:txBody>
+                  <a:tcPr marL="36576" marR="36576" marT="18288" marB="18288">
+                    <a:solidFill>
+                      <a:srgbClr val="FFFFFF"/>
+                    </a:solidFill>
+                  </a:tcPr>
+                </a:tc>
+              </a:tr>
+              <a:tr h="292608">
+                <a:tc>
+                  <a:txBody>
+                    <a:bodyPr/>
+                    <a:lstStyle/>
+                    <a:p>
+                      <a:pPr algn="l"/>
+                      <a:r>
+                        <a:rPr sz="1000">
+                          <a:solidFill>
+                            <a:srgbClr val="3F3F3F"/>
+                          </a:solidFill>
+                          <a:latin typeface="Encode Sans"/>
+                        </a:rPr>
+                        <a:t>Febrero 2026</a:t>
+                      </a:r>
+                    </a:p>
+                  </a:txBody>
+                  <a:tcPr marL="36576" marR="36576" marT="18288" marB="18288">
+                    <a:solidFill>
+                      <a:srgbClr val="F8F8F6"/>
+                    </a:solidFill>
+                  </a:tcPr>
+                </a:tc>
+                <a:tc>
+                  <a:txBody>
+                    <a:bodyPr/>
+                    <a:lstStyle/>
+                    <a:p>
+                      <a:pPr algn="r"/>
+                      <a:r>
+                        <a:rPr sz="1000">
+                          <a:solidFill>
+                            <a:srgbClr val="3F3F3F"/>
+                          </a:solidFill>
+                          <a:latin typeface="Encode Sans"/>
+                        </a:rPr>
+                        <a:t>100,2</a:t>
+                      </a:r>
+                    </a:p>
+                  </a:txBody>
+                  <a:tcPr marL="36576" marR="36576" marT="18288" marB="18288">
+                    <a:solidFill>
+                      <a:srgbClr val="F8F8F6"/>
+                    </a:solidFill>
+                  </a:tcPr>
+                </a:tc>
+                <a:tc>
+                  <a:txBody>
+                    <a:bodyPr/>
+                    <a:lstStyle/>
+                    <a:p>
+                      <a:pPr algn="r"/>
+                      <a:r>
+                        <a:rPr sz="1000">
+                          <a:solidFill>
+                            <a:srgbClr val="3F3F3F"/>
+                          </a:solidFill>
+                          <a:latin typeface="Encode Sans"/>
+                        </a:rPr>
+                        <a:t>-8.9%</a:t>
+                      </a:r>
+                    </a:p>
+                  </a:txBody>
+                  <a:tcPr marL="36576" marR="36576" marT="18288" marB="18288">
+                    <a:solidFill>
+                      <a:srgbClr val="F8F8F6"/>
+                    </a:solidFill>
+                  </a:tcPr>
+                </a:tc>
+              </a:tr>
+              <a:tr h="292608">
+                <a:tc>
+                  <a:txBody>
+                    <a:bodyPr/>
+                    <a:lstStyle/>
+                    <a:p>
+                      <a:pPr algn="l"/>
+                      <a:r>
+                        <a:rPr sz="1000">
+                          <a:solidFill>
+                            <a:srgbClr val="3F3F3F"/>
+                          </a:solidFill>
+                          <a:latin typeface="Encode Sans"/>
+                        </a:rPr>
+                        <a:t>Enero 2026</a:t>
+                      </a:r>
+                    </a:p>
+                  </a:txBody>
+                  <a:tcPr marL="36576" marR="36576" marT="18288" marB="18288">
+                    <a:solidFill>
+                      <a:srgbClr val="FFFFFF"/>
+                    </a:solidFill>
+                  </a:tcPr>
+                </a:tc>
+                <a:tc>
+                  <a:txBody>
+                    <a:bodyPr/>
+                    <a:lstStyle/>
+                    <a:p>
+                      <a:pPr algn="r"/>
+                      <a:r>
+                        <a:rPr sz="1000">
+                          <a:solidFill>
+                            <a:srgbClr val="3F3F3F"/>
+                          </a:solidFill>
+                          <a:latin typeface="Encode Sans"/>
+                        </a:rPr>
+                        <a:t>106,5</a:t>
+                      </a:r>
+                    </a:p>
+                  </a:txBody>
+                  <a:tcPr marL="36576" marR="36576" marT="18288" marB="18288">
+                    <a:solidFill>
+                      <a:srgbClr val="FFFFFF"/>
+                    </a:solidFill>
+                  </a:tcPr>
+                </a:tc>
+                <a:tc>
+                  <a:txBody>
+                    <a:bodyPr/>
+                    <a:lstStyle/>
+                    <a:p>
+                      <a:pPr algn="r"/>
+                      <a:r>
+                        <a:rPr sz="1000">
+                          <a:solidFill>
+                            <a:srgbClr val="3F3F3F"/>
+                          </a:solidFill>
+                          <a:latin typeface="Encode Sans"/>
+                        </a:rPr>
+                        <a:t>-3.8%</a:t>
+                      </a:r>
+                    </a:p>
+                  </a:txBody>
+                  <a:tcPr marL="36576" marR="36576" marT="18288" marB="18288">
+                    <a:solidFill>
+                      <a:srgbClr val="FFFFFF"/>
+                    </a:solidFill>
+                  </a:tcPr>
+                </a:tc>
+              </a:tr>
+              <a:tr h="292608">
+                <a:tc>
+                  <a:txBody>
+                    <a:bodyPr/>
+                    <a:lstStyle/>
+                    <a:p>
+                      <a:pPr algn="l"/>
+                      <a:r>
+                        <a:rPr sz="1000">
+                          <a:solidFill>
+                            <a:srgbClr val="3F3F3F"/>
+                          </a:solidFill>
+                          <a:latin typeface="Encode Sans"/>
+                        </a:rPr>
+                        <a:t>Diciembre 2025</a:t>
+                      </a:r>
+                    </a:p>
+                  </a:txBody>
+                  <a:tcPr marL="36576" marR="36576" marT="18288" marB="18288">
+                    <a:solidFill>
+                      <a:srgbClr val="F8F8F6"/>
+                    </a:solidFill>
+                  </a:tcPr>
+                </a:tc>
+                <a:tc>
+                  <a:txBody>
+                    <a:bodyPr/>
+                    <a:lstStyle/>
+                    <a:p>
+                      <a:pPr algn="r"/>
+                      <a:r>
+                        <a:rPr sz="1000">
+                          <a:solidFill>
+                            <a:srgbClr val="3F3F3F"/>
+                          </a:solidFill>
+                          <a:latin typeface="Encode Sans"/>
+                        </a:rPr>
+                        <a:t>112,0</a:t>
+                      </a:r>
+                    </a:p>
+                  </a:txBody>
+                  <a:tcPr marL="36576" marR="36576" marT="18288" marB="18288">
+                    <a:solidFill>
+                      <a:srgbClr val="F8F8F6"/>
+                    </a:solidFill>
+                  </a:tcPr>
+                </a:tc>
+                <a:tc>
+                  <a:txBody>
+                    <a:bodyPr/>
+                    <a:lstStyle/>
+                    <a:p>
+                      <a:pPr algn="r"/>
+                      <a:r>
+                        <a:rPr sz="1000">
+                          <a:solidFill>
+                            <a:srgbClr val="3F3F3F"/>
+                          </a:solidFill>
+                          <a:latin typeface="Encode Sans"/>
+                        </a:rPr>
+                        <a:t>-4.0%</a:t>
+                      </a:r>
+                    </a:p>
+                  </a:txBody>
+                  <a:tcPr marL="36576" marR="36576" marT="18288" marB="18288">
+                    <a:solidFill>
+                      <a:srgbClr val="F8F8F6"/>
+                    </a:solidFill>
+                  </a:tcPr>
+                </a:tc>
+              </a:tr>
+            </a:tbl>
+          </a:graphicData>
+        </a:graphic>
+      </p:graphicFrame>
+      <p:sp>
+        <p:nvSpPr>
+          <p:cNvPr id="9" name="TextBox 8"/>
+          <p:cNvSpPr txBox="1"/>
+          <p:nvPr/>
+        </p:nvSpPr>
+        <p:spPr>
+          <a:xfrm>
+            <a:off x="411480" y="6492240"/>
+            <a:ext cx="11368735" cy="274320"/>
+          </a:xfrm>
+          <a:prstGeom prst="rect">
+            <a:avLst/>
+          </a:prstGeom>
+          <a:noFill/>
+        </p:spPr>
+        <p:txBody>
+          <a:bodyPr wrap="none">
+            <a:spAutoFit/>
+          </a:bodyPr>
+          <a:lstStyle/>
+          <a:p>
+            <a:r>
+              <a:rPr sz="1000" b="0" i="1">
+                <a:solidFill>
+                  <a:srgbClr val="6A6760"/>
+                </a:solidFill>
+                <a:latin typeface="Encode Sans"/>
+              </a:rPr>
+              <a:t>Fuente: elaboración propia en base a INDEC</a:t>
+            </a:r>
+          </a:p>
+        </p:txBody>
+      </p:sp>
+    </p:spTree>
+  </p:cSld>
+  <p:clrMapOvr>
+    <a:masterClrMapping/>
+  </p:clrMapOvr>
+</p:sld>
+</file>
+
 <file path=ppt/theme/theme1.xml><?xml version="1.0" encoding="utf-8"?>
 <a:theme xmlns:a="http://schemas.openxmlformats.org/drawingml/2006/main" name="Office Theme">
   <a:themeElements>

</xml_diff>

<commit_message>
data: update 2026-07-16 ( data.json despidos.json scraper/historical_despidos.json publicaciones_semana.pptx rrii_brutas.xlsx)
</commit_message>
<xml_diff>
--- a/publicaciones_semana.pptx
+++ b/publicaciones_semana.pptx
@@ -8,6 +8,8 @@
     <p:sldId id="256" r:id="rId7"/>
     <p:sldId id="257" r:id="rId8"/>
     <p:sldId id="258" r:id="rId9"/>
+    <p:sldId id="259" r:id="rId10"/>
+    <p:sldId id="260" r:id="rId11"/>
   </p:sldIdLst>
   <p:sldSz cx="12191695" cy="6858000" type="screen4x3"/>
   <p:notesSz cx="6858000" cy="9144000"/>
@@ -3273,7 +3275,7 @@
                 </a:solidFill>
                 <a:latin typeface="Encode Sans"/>
               </a:rPr>
-              <a:t>2 publicaciones · datos oficiales INDEC / BCRA / Hacienda</a:t>
+              <a:t>4 publicaciones · datos oficiales INDEC / BCRA / Hacienda</a:t>
             </a:r>
           </a:p>
         </p:txBody>
@@ -4939,6 +4941,1696 @@
                 <a:latin typeface="Encode Sans"/>
               </a:rPr>
               <a:t>Fuente: elaboración propia en base a INDEC</a:t>
+            </a:r>
+          </a:p>
+        </p:txBody>
+      </p:sp>
+    </p:spTree>
+  </p:cSld>
+  <p:clrMapOvr>
+    <a:masterClrMapping/>
+  </p:clrMapOvr>
+</p:sld>
+</file>
+
+<file path=ppt/slides/slide4.xml><?xml version="1.0" encoding="utf-8"?>
+<p:sld xmlns:a="http://schemas.openxmlformats.org/drawingml/2006/main" xmlns:p="http://schemas.openxmlformats.org/presentationml/2006/main" xmlns:r="http://schemas.openxmlformats.org/officeDocument/2006/relationships">
+  <p:cSld>
+    <p:spTree>
+      <p:nvGrpSpPr>
+        <p:cNvPr id="1" name=""/>
+        <p:cNvGrpSpPr/>
+        <p:nvPr/>
+      </p:nvGrpSpPr>
+      <p:grpSpPr/>
+      <p:sp>
+        <p:nvSpPr>
+          <p:cNvPr id="2" name="Rectangle 1"/>
+          <p:cNvSpPr/>
+          <p:nvPr/>
+        </p:nvSpPr>
+        <p:spPr>
+          <a:xfrm>
+            <a:off x="0" y="0"/>
+            <a:ext cx="12191695" cy="274320"/>
+          </a:xfrm>
+          <a:prstGeom prst="rect">
+            <a:avLst/>
+          </a:prstGeom>
+          <a:solidFill>
+            <a:srgbClr val="00B2C9"/>
+          </a:solidFill>
+          <a:ln>
+            <a:noFill/>
+          </a:ln>
+        </p:spPr>
+        <p:style>
+          <a:lnRef idx="1">
+            <a:schemeClr val="accent1"/>
+          </a:lnRef>
+          <a:fillRef idx="3">
+            <a:schemeClr val="accent1"/>
+          </a:fillRef>
+          <a:effectRef idx="2">
+            <a:schemeClr val="accent1"/>
+          </a:effectRef>
+          <a:fontRef idx="minor">
+            <a:schemeClr val="lt1"/>
+          </a:fontRef>
+        </p:style>
+        <p:txBody>
+          <a:bodyPr rtlCol="0" anchor="ctr"/>
+          <a:lstStyle/>
+          <a:p>
+            <a:pPr algn="ctr"/>
+          </a:p>
+        </p:txBody>
+      </p:sp>
+      <p:sp>
+        <p:nvSpPr>
+          <p:cNvPr id="3" name="TextBox 2"/>
+          <p:cNvSpPr txBox="1"/>
+          <p:nvPr/>
+        </p:nvSpPr>
+        <p:spPr>
+          <a:xfrm>
+            <a:off x="411480" y="457200"/>
+            <a:ext cx="11368735" cy="914400"/>
+          </a:xfrm>
+          <a:prstGeom prst="rect">
+            <a:avLst/>
+          </a:prstGeom>
+          <a:noFill/>
+        </p:spPr>
+        <p:txBody>
+          <a:bodyPr wrap="square" lIns="0" rIns="0">
+            <a:spAutoFit/>
+          </a:bodyPr>
+          <a:lstStyle/>
+          <a:p>
+            <a:pPr algn="l"/>
+            <a:r>
+              <a:rPr sz="2600" b="1" i="0">
+                <a:solidFill>
+                  <a:srgbClr val="00B2C9"/>
+                </a:solidFill>
+                <a:latin typeface="Encode Sans"/>
+              </a:rPr>
+              <a:t>FISCAL MAYO 2026: SUPERÁVIT PRIMARIO $1.924K M$</a:t>
+            </a:r>
+          </a:p>
+        </p:txBody>
+      </p:sp>
+      <p:sp>
+        <p:nvSpPr>
+          <p:cNvPr id="4" name="TextBox 3"/>
+          <p:cNvSpPr txBox="1"/>
+          <p:nvPr/>
+        </p:nvSpPr>
+        <p:spPr>
+          <a:xfrm>
+            <a:off x="411480" y="1280160"/>
+            <a:ext cx="11368735" cy="274320"/>
+          </a:xfrm>
+          <a:prstGeom prst="rect">
+            <a:avLst/>
+          </a:prstGeom>
+          <a:noFill/>
+        </p:spPr>
+        <p:txBody>
+          <a:bodyPr wrap="none">
+            <a:spAutoFit/>
+          </a:bodyPr>
+          <a:lstStyle/>
+          <a:p>
+            <a:r>
+              <a:rPr sz="1100" b="0" i="1">
+                <a:solidFill>
+                  <a:srgbClr val="6A6760"/>
+                </a:solidFill>
+                <a:latin typeface="Encode Sans"/>
+              </a:rPr>
+              <a:t>Hacienda (vía INDEC IMIG) · período 2026-05</a:t>
+            </a:r>
+          </a:p>
+        </p:txBody>
+      </p:sp>
+      <p:sp>
+        <p:nvSpPr>
+          <p:cNvPr id="5" name="TextBox 4"/>
+          <p:cNvSpPr txBox="1"/>
+          <p:nvPr/>
+        </p:nvSpPr>
+        <p:spPr>
+          <a:xfrm>
+            <a:off x="411480" y="1691640"/>
+            <a:ext cx="5486400" cy="1645920"/>
+          </a:xfrm>
+          <a:prstGeom prst="rect">
+            <a:avLst/>
+          </a:prstGeom>
+          <a:noFill/>
+        </p:spPr>
+        <p:txBody>
+          <a:bodyPr wrap="square" lIns="0" rIns="0">
+            <a:spAutoFit/>
+          </a:bodyPr>
+          <a:lstStyle/>
+          <a:p>
+            <a:pPr algn="just"/>
+            <a:r>
+              <a:rPr sz="1300" b="0" i="0">
+                <a:solidFill>
+                  <a:srgbClr val="3F3F3F"/>
+                </a:solidFill>
+                <a:latin typeface="Encode Sans"/>
+              </a:rPr>
+              <a:t>El Sector Público Nacional No Financiero registró un resultado primario de +1.924 mil millones de pesos en mayo 2026. El resultado financiero alcanzó +479K M$.</a:t>
+            </a:r>
+          </a:p>
+        </p:txBody>
+      </p:sp>
+      <p:sp>
+        <p:nvSpPr>
+          <p:cNvPr id="6" name="TextBox 5"/>
+          <p:cNvSpPr txBox="1"/>
+          <p:nvPr/>
+        </p:nvSpPr>
+        <p:spPr>
+          <a:xfrm>
+            <a:off x="411480" y="3520440"/>
+            <a:ext cx="5486400" cy="2743200"/>
+          </a:xfrm>
+          <a:prstGeom prst="rect">
+            <a:avLst/>
+          </a:prstGeom>
+          <a:noFill/>
+        </p:spPr>
+        <p:txBody>
+          <a:bodyPr wrap="square" lIns="0" rIns="0">
+            <a:spAutoFit/>
+          </a:bodyPr>
+          <a:lstStyle/>
+          <a:p>
+            <a:pPr algn="l">
+              <a:spcAft>
+                <a:spcPts val="800"/>
+              </a:spcAft>
+            </a:pPr>
+            <a:r>
+              <a:rPr sz="1300" b="1" i="0">
+                <a:solidFill>
+                  <a:srgbClr val="00B2C9"/>
+                </a:solidFill>
+                <a:latin typeface="Encode Sans"/>
+              </a:rPr>
+              <a:t>●  </a:t>
+            </a:r>
+            <a:r>
+              <a:rPr sz="1300" b="0" i="0">
+                <a:solidFill>
+                  <a:srgbClr val="3F3F3F"/>
+                </a:solidFill>
+                <a:latin typeface="Encode Sans"/>
+              </a:rPr>
+              <a:t>Resultado primario: +1.924 mil millones de pesos</a:t>
+            </a:r>
+          </a:p>
+          <a:p>
+            <a:pPr algn="l">
+              <a:spcAft>
+                <a:spcPts val="800"/>
+              </a:spcAft>
+            </a:pPr>
+            <a:r>
+              <a:rPr sz="1300" b="1" i="0">
+                <a:solidFill>
+                  <a:srgbClr val="00B2C9"/>
+                </a:solidFill>
+                <a:latin typeface="Encode Sans"/>
+              </a:rPr>
+              <a:t>●  </a:t>
+            </a:r>
+            <a:r>
+              <a:rPr sz="1300" b="0" i="0">
+                <a:solidFill>
+                  <a:srgbClr val="3F3F3F"/>
+                </a:solidFill>
+                <a:latin typeface="Encode Sans"/>
+              </a:rPr>
+              <a:t>Resultado financiero: +479 mil millones</a:t>
+            </a:r>
+          </a:p>
+          <a:p>
+            <a:pPr algn="l">
+              <a:spcAft>
+                <a:spcPts val="800"/>
+              </a:spcAft>
+            </a:pPr>
+            <a:r>
+              <a:rPr sz="1300" b="1" i="0">
+                <a:solidFill>
+                  <a:srgbClr val="00B2C9"/>
+                </a:solidFill>
+                <a:latin typeface="Encode Sans"/>
+              </a:rPr>
+              <a:t>●  </a:t>
+            </a:r>
+            <a:r>
+              <a:rPr sz="1300" b="0" i="0">
+                <a:solidFill>
+                  <a:srgbClr val="3F3F3F"/>
+                </a:solidFill>
+                <a:latin typeface="Encode Sans"/>
+              </a:rPr>
+              <a:t>Fuente: Secretaría de Hacienda, base caja (Metodología 2017)</a:t>
+            </a:r>
+          </a:p>
+        </p:txBody>
+      </p:sp>
+      <p:pic>
+        <p:nvPicPr>
+          <p:cNvPr id="7" name="Picture 6" descr="image.png"/>
+          <p:cNvPicPr>
+            <a:picLocks noChangeAspect="1"/>
+          </p:cNvPicPr>
+          <p:nvPr/>
+        </p:nvPicPr>
+        <p:blipFill>
+          <a:blip r:embed="rId2"/>
+          <a:stretch>
+            <a:fillRect/>
+          </a:stretch>
+        </p:blipFill>
+        <p:spPr>
+          <a:xfrm>
+            <a:off x="6080760" y="1691640"/>
+            <a:ext cx="5669280" cy="2560320"/>
+          </a:xfrm>
+          <a:prstGeom prst="rect">
+            <a:avLst/>
+          </a:prstGeom>
+        </p:spPr>
+      </p:pic>
+      <p:graphicFrame>
+        <p:nvGraphicFramePr>
+          <p:cNvPr id="8" name="Table 7"/>
+          <p:cNvGraphicFramePr>
+            <a:graphicFrameLocks noGrp="1"/>
+          </p:cNvGraphicFramePr>
+          <p:nvPr/>
+        </p:nvGraphicFramePr>
+        <p:xfrm>
+          <a:off x="6080760" y="4434840"/>
+          <a:ext cx="5669280" cy="2048256"/>
+        </p:xfrm>
+        <a:graphic>
+          <a:graphicData uri="http://schemas.openxmlformats.org/drawingml/2006/table">
+            <a:tbl>
+              <a:tblPr firstRow="1" bandRow="1">
+                <a:tableStyleId>{5C22544A-7EE6-4342-B048-85BDC9FD1C3A}</a:tableStyleId>
+              </a:tblPr>
+              <a:tblGrid>
+                <a:gridCol w="1889760"/>
+                <a:gridCol w="1889760"/>
+                <a:gridCol w="1889760"/>
+              </a:tblGrid>
+              <a:tr h="292608">
+                <a:tc>
+                  <a:txBody>
+                    <a:bodyPr/>
+                    <a:lstStyle/>
+                    <a:p>
+                      <a:pPr algn="l"/>
+                      <a:r>
+                        <a:rPr sz="1000" b="1">
+                          <a:solidFill>
+                            <a:srgbClr val="FFFFFF"/>
+                          </a:solidFill>
+                          <a:latin typeface="Encode Sans"/>
+                        </a:rPr>
+                        <a:t>Mes</a:t>
+                      </a:r>
+                    </a:p>
+                  </a:txBody>
+                  <a:tcPr marL="36576" marR="36576" marT="18288" marB="18288">
+                    <a:solidFill>
+                      <a:srgbClr val="00B2C9"/>
+                    </a:solidFill>
+                  </a:tcPr>
+                </a:tc>
+                <a:tc>
+                  <a:txBody>
+                    <a:bodyPr/>
+                    <a:lstStyle/>
+                    <a:p>
+                      <a:pPr algn="r"/>
+                      <a:r>
+                        <a:rPr sz="1000" b="1">
+                          <a:solidFill>
+                            <a:srgbClr val="FFFFFF"/>
+                          </a:solidFill>
+                          <a:latin typeface="Encode Sans"/>
+                        </a:rPr>
+                        <a:t>Primario M$</a:t>
+                      </a:r>
+                    </a:p>
+                  </a:txBody>
+                  <a:tcPr marL="36576" marR="36576" marT="18288" marB="18288">
+                    <a:solidFill>
+                      <a:srgbClr val="00B2C9"/>
+                    </a:solidFill>
+                  </a:tcPr>
+                </a:tc>
+                <a:tc>
+                  <a:txBody>
+                    <a:bodyPr/>
+                    <a:lstStyle/>
+                    <a:p>
+                      <a:pPr algn="r"/>
+                      <a:r>
+                        <a:rPr sz="1000" b="1">
+                          <a:solidFill>
+                            <a:srgbClr val="FFFFFF"/>
+                          </a:solidFill>
+                          <a:latin typeface="Encode Sans"/>
+                        </a:rPr>
+                        <a:t>Financiero M$</a:t>
+                      </a:r>
+                    </a:p>
+                  </a:txBody>
+                  <a:tcPr marL="36576" marR="36576" marT="18288" marB="18288">
+                    <a:solidFill>
+                      <a:srgbClr val="00B2C9"/>
+                    </a:solidFill>
+                  </a:tcPr>
+                </a:tc>
+              </a:tr>
+              <a:tr h="292608">
+                <a:tc>
+                  <a:txBody>
+                    <a:bodyPr/>
+                    <a:lstStyle/>
+                    <a:p>
+                      <a:pPr algn="l"/>
+                      <a:r>
+                        <a:rPr sz="1000">
+                          <a:solidFill>
+                            <a:srgbClr val="3F3F3F"/>
+                          </a:solidFill>
+                          <a:latin typeface="Encode Sans"/>
+                        </a:rPr>
+                        <a:t>Junio 2026</a:t>
+                      </a:r>
+                    </a:p>
+                  </a:txBody>
+                  <a:tcPr marL="36576" marR="36576" marT="18288" marB="18288">
+                    <a:solidFill>
+                      <a:srgbClr val="FFFFFF"/>
+                    </a:solidFill>
+                  </a:tcPr>
+                </a:tc>
+                <a:tc>
+                  <a:txBody>
+                    <a:bodyPr/>
+                    <a:lstStyle/>
+                    <a:p>
+                      <a:pPr algn="r"/>
+                      <a:r>
+                        <a:rPr sz="1000">
+                          <a:solidFill>
+                            <a:srgbClr val="3F3F3F"/>
+                          </a:solidFill>
+                          <a:latin typeface="Encode Sans"/>
+                        </a:rPr>
+                        <a:t>-696.843</a:t>
+                      </a:r>
+                    </a:p>
+                  </a:txBody>
+                  <a:tcPr marL="36576" marR="36576" marT="18288" marB="18288">
+                    <a:solidFill>
+                      <a:srgbClr val="FFFFFF"/>
+                    </a:solidFill>
+                  </a:tcPr>
+                </a:tc>
+                <a:tc>
+                  <a:txBody>
+                    <a:bodyPr/>
+                    <a:lstStyle/>
+                    <a:p>
+                      <a:pPr algn="r"/>
+                      <a:r>
+                        <a:rPr sz="1000">
+                          <a:solidFill>
+                            <a:srgbClr val="3F3F3F"/>
+                          </a:solidFill>
+                          <a:latin typeface="Encode Sans"/>
+                        </a:rPr>
+                        <a:t>-1.024.891</a:t>
+                      </a:r>
+                    </a:p>
+                  </a:txBody>
+                  <a:tcPr marL="36576" marR="36576" marT="18288" marB="18288">
+                    <a:solidFill>
+                      <a:srgbClr val="FFFFFF"/>
+                    </a:solidFill>
+                  </a:tcPr>
+                </a:tc>
+              </a:tr>
+              <a:tr h="292608">
+                <a:tc>
+                  <a:txBody>
+                    <a:bodyPr/>
+                    <a:lstStyle/>
+                    <a:p>
+                      <a:pPr algn="l"/>
+                      <a:r>
+                        <a:rPr sz="1000">
+                          <a:solidFill>
+                            <a:srgbClr val="3F3F3F"/>
+                          </a:solidFill>
+                          <a:latin typeface="Encode Sans"/>
+                        </a:rPr>
+                        <a:t>Mayo 2026</a:t>
+                      </a:r>
+                    </a:p>
+                  </a:txBody>
+                  <a:tcPr marL="36576" marR="36576" marT="18288" marB="18288">
+                    <a:solidFill>
+                      <a:srgbClr val="F8F8F6"/>
+                    </a:solidFill>
+                  </a:tcPr>
+                </a:tc>
+                <a:tc>
+                  <a:txBody>
+                    <a:bodyPr/>
+                    <a:lstStyle/>
+                    <a:p>
+                      <a:pPr algn="r"/>
+                      <a:r>
+                        <a:rPr sz="1000">
+                          <a:solidFill>
+                            <a:srgbClr val="3F3F3F"/>
+                          </a:solidFill>
+                          <a:latin typeface="Encode Sans"/>
+                        </a:rPr>
+                        <a:t>1.924.367</a:t>
+                      </a:r>
+                    </a:p>
+                  </a:txBody>
+                  <a:tcPr marL="36576" marR="36576" marT="18288" marB="18288">
+                    <a:solidFill>
+                      <a:srgbClr val="F8F8F6"/>
+                    </a:solidFill>
+                  </a:tcPr>
+                </a:tc>
+                <a:tc>
+                  <a:txBody>
+                    <a:bodyPr/>
+                    <a:lstStyle/>
+                    <a:p>
+                      <a:pPr algn="r"/>
+                      <a:r>
+                        <a:rPr sz="1000">
+                          <a:solidFill>
+                            <a:srgbClr val="3F3F3F"/>
+                          </a:solidFill>
+                          <a:latin typeface="Encode Sans"/>
+                        </a:rPr>
+                        <a:t>478.613</a:t>
+                      </a:r>
+                    </a:p>
+                  </a:txBody>
+                  <a:tcPr marL="36576" marR="36576" marT="18288" marB="18288">
+                    <a:solidFill>
+                      <a:srgbClr val="F8F8F6"/>
+                    </a:solidFill>
+                  </a:tcPr>
+                </a:tc>
+              </a:tr>
+              <a:tr h="292608">
+                <a:tc>
+                  <a:txBody>
+                    <a:bodyPr/>
+                    <a:lstStyle/>
+                    <a:p>
+                      <a:pPr algn="l"/>
+                      <a:r>
+                        <a:rPr sz="1000">
+                          <a:solidFill>
+                            <a:srgbClr val="3F3F3F"/>
+                          </a:solidFill>
+                          <a:latin typeface="Encode Sans"/>
+                        </a:rPr>
+                        <a:t>Abril 2026</a:t>
+                      </a:r>
+                    </a:p>
+                  </a:txBody>
+                  <a:tcPr marL="36576" marR="36576" marT="18288" marB="18288">
+                    <a:solidFill>
+                      <a:srgbClr val="FFFFFF"/>
+                    </a:solidFill>
+                  </a:tcPr>
+                </a:tc>
+                <a:tc>
+                  <a:txBody>
+                    <a:bodyPr/>
+                    <a:lstStyle/>
+                    <a:p>
+                      <a:pPr algn="r"/>
+                      <a:r>
+                        <a:rPr sz="1000">
+                          <a:solidFill>
+                            <a:srgbClr val="3F3F3F"/>
+                          </a:solidFill>
+                          <a:latin typeface="Encode Sans"/>
+                        </a:rPr>
+                        <a:t>632.844</a:t>
+                      </a:r>
+                    </a:p>
+                  </a:txBody>
+                  <a:tcPr marL="36576" marR="36576" marT="18288" marB="18288">
+                    <a:solidFill>
+                      <a:srgbClr val="FFFFFF"/>
+                    </a:solidFill>
+                  </a:tcPr>
+                </a:tc>
+                <a:tc>
+                  <a:txBody>
+                    <a:bodyPr/>
+                    <a:lstStyle/>
+                    <a:p>
+                      <a:pPr algn="r"/>
+                      <a:r>
+                        <a:rPr sz="1000">
+                          <a:solidFill>
+                            <a:srgbClr val="3F3F3F"/>
+                          </a:solidFill>
+                          <a:latin typeface="Encode Sans"/>
+                        </a:rPr>
+                        <a:t>268.103</a:t>
+                      </a:r>
+                    </a:p>
+                  </a:txBody>
+                  <a:tcPr marL="36576" marR="36576" marT="18288" marB="18288">
+                    <a:solidFill>
+                      <a:srgbClr val="FFFFFF"/>
+                    </a:solidFill>
+                  </a:tcPr>
+                </a:tc>
+              </a:tr>
+              <a:tr h="292608">
+                <a:tc>
+                  <a:txBody>
+                    <a:bodyPr/>
+                    <a:lstStyle/>
+                    <a:p>
+                      <a:pPr algn="l"/>
+                      <a:r>
+                        <a:rPr sz="1000">
+                          <a:solidFill>
+                            <a:srgbClr val="3F3F3F"/>
+                          </a:solidFill>
+                          <a:latin typeface="Encode Sans"/>
+                        </a:rPr>
+                        <a:t>Marzo 2026</a:t>
+                      </a:r>
+                    </a:p>
+                  </a:txBody>
+                  <a:tcPr marL="36576" marR="36576" marT="18288" marB="18288">
+                    <a:solidFill>
+                      <a:srgbClr val="F8F8F6"/>
+                    </a:solidFill>
+                  </a:tcPr>
+                </a:tc>
+                <a:tc>
+                  <a:txBody>
+                    <a:bodyPr/>
+                    <a:lstStyle/>
+                    <a:p>
+                      <a:pPr algn="r"/>
+                      <a:r>
+                        <a:rPr sz="1000">
+                          <a:solidFill>
+                            <a:srgbClr val="3F3F3F"/>
+                          </a:solidFill>
+                          <a:latin typeface="Encode Sans"/>
+                        </a:rPr>
+                        <a:t>930.284</a:t>
+                      </a:r>
+                    </a:p>
+                  </a:txBody>
+                  <a:tcPr marL="36576" marR="36576" marT="18288" marB="18288">
+                    <a:solidFill>
+                      <a:srgbClr val="F8F8F6"/>
+                    </a:solidFill>
+                  </a:tcPr>
+                </a:tc>
+                <a:tc>
+                  <a:txBody>
+                    <a:bodyPr/>
+                    <a:lstStyle/>
+                    <a:p>
+                      <a:pPr algn="r"/>
+                      <a:r>
+                        <a:rPr sz="1000">
+                          <a:solidFill>
+                            <a:srgbClr val="3F3F3F"/>
+                          </a:solidFill>
+                          <a:latin typeface="Encode Sans"/>
+                        </a:rPr>
+                        <a:t>246.434</a:t>
+                      </a:r>
+                    </a:p>
+                  </a:txBody>
+                  <a:tcPr marL="36576" marR="36576" marT="18288" marB="18288">
+                    <a:solidFill>
+                      <a:srgbClr val="F8F8F6"/>
+                    </a:solidFill>
+                  </a:tcPr>
+                </a:tc>
+              </a:tr>
+              <a:tr h="292608">
+                <a:tc>
+                  <a:txBody>
+                    <a:bodyPr/>
+                    <a:lstStyle/>
+                    <a:p>
+                      <a:pPr algn="l"/>
+                      <a:r>
+                        <a:rPr sz="1000">
+                          <a:solidFill>
+                            <a:srgbClr val="3F3F3F"/>
+                          </a:solidFill>
+                          <a:latin typeface="Encode Sans"/>
+                        </a:rPr>
+                        <a:t>Febrero 2026</a:t>
+                      </a:r>
+                    </a:p>
+                  </a:txBody>
+                  <a:tcPr marL="36576" marR="36576" marT="18288" marB="18288">
+                    <a:solidFill>
+                      <a:srgbClr val="FFFFFF"/>
+                    </a:solidFill>
+                  </a:tcPr>
+                </a:tc>
+                <a:tc>
+                  <a:txBody>
+                    <a:bodyPr/>
+                    <a:lstStyle/>
+                    <a:p>
+                      <a:pPr algn="r"/>
+                      <a:r>
+                        <a:rPr sz="1000">
+                          <a:solidFill>
+                            <a:srgbClr val="3F3F3F"/>
+                          </a:solidFill>
+                          <a:latin typeface="Encode Sans"/>
+                        </a:rPr>
+                        <a:t>1.410.640</a:t>
+                      </a:r>
+                    </a:p>
+                  </a:txBody>
+                  <a:tcPr marL="36576" marR="36576" marT="18288" marB="18288">
+                    <a:solidFill>
+                      <a:srgbClr val="FFFFFF"/>
+                    </a:solidFill>
+                  </a:tcPr>
+                </a:tc>
+                <a:tc>
+                  <a:txBody>
+                    <a:bodyPr/>
+                    <a:lstStyle/>
+                    <a:p>
+                      <a:pPr algn="r"/>
+                      <a:r>
+                        <a:rPr sz="1000">
+                          <a:solidFill>
+                            <a:srgbClr val="3F3F3F"/>
+                          </a:solidFill>
+                          <a:latin typeface="Encode Sans"/>
+                        </a:rPr>
+                        <a:t>297.224</a:t>
+                      </a:r>
+                    </a:p>
+                  </a:txBody>
+                  <a:tcPr marL="36576" marR="36576" marT="18288" marB="18288">
+                    <a:solidFill>
+                      <a:srgbClr val="FFFFFF"/>
+                    </a:solidFill>
+                  </a:tcPr>
+                </a:tc>
+              </a:tr>
+              <a:tr h="292608">
+                <a:tc>
+                  <a:txBody>
+                    <a:bodyPr/>
+                    <a:lstStyle/>
+                    <a:p>
+                      <a:pPr algn="l"/>
+                      <a:r>
+                        <a:rPr sz="1000">
+                          <a:solidFill>
+                            <a:srgbClr val="3F3F3F"/>
+                          </a:solidFill>
+                          <a:latin typeface="Encode Sans"/>
+                        </a:rPr>
+                        <a:t>Enero 2026</a:t>
+                      </a:r>
+                    </a:p>
+                  </a:txBody>
+                  <a:tcPr marL="36576" marR="36576" marT="18288" marB="18288">
+                    <a:solidFill>
+                      <a:srgbClr val="F8F8F6"/>
+                    </a:solidFill>
+                  </a:tcPr>
+                </a:tc>
+                <a:tc>
+                  <a:txBody>
+                    <a:bodyPr/>
+                    <a:lstStyle/>
+                    <a:p>
+                      <a:pPr algn="r"/>
+                      <a:r>
+                        <a:rPr sz="1000">
+                          <a:solidFill>
+                            <a:srgbClr val="3F3F3F"/>
+                          </a:solidFill>
+                          <a:latin typeface="Encode Sans"/>
+                        </a:rPr>
+                        <a:t>3.125.737</a:t>
+                      </a:r>
+                    </a:p>
+                  </a:txBody>
+                  <a:tcPr marL="36576" marR="36576" marT="18288" marB="18288">
+                    <a:solidFill>
+                      <a:srgbClr val="F8F8F6"/>
+                    </a:solidFill>
+                  </a:tcPr>
+                </a:tc>
+                <a:tc>
+                  <a:txBody>
+                    <a:bodyPr/>
+                    <a:lstStyle/>
+                    <a:p>
+                      <a:pPr algn="r"/>
+                      <a:r>
+                        <a:rPr sz="1000">
+                          <a:solidFill>
+                            <a:srgbClr val="3F3F3F"/>
+                          </a:solidFill>
+                          <a:latin typeface="Encode Sans"/>
+                        </a:rPr>
+                        <a:t>-166.961</a:t>
+                      </a:r>
+                    </a:p>
+                  </a:txBody>
+                  <a:tcPr marL="36576" marR="36576" marT="18288" marB="18288">
+                    <a:solidFill>
+                      <a:srgbClr val="F8F8F6"/>
+                    </a:solidFill>
+                  </a:tcPr>
+                </a:tc>
+              </a:tr>
+            </a:tbl>
+          </a:graphicData>
+        </a:graphic>
+      </p:graphicFrame>
+      <p:sp>
+        <p:nvSpPr>
+          <p:cNvPr id="9" name="TextBox 8"/>
+          <p:cNvSpPr txBox="1"/>
+          <p:nvPr/>
+        </p:nvSpPr>
+        <p:spPr>
+          <a:xfrm>
+            <a:off x="411480" y="6492240"/>
+            <a:ext cx="11368735" cy="274320"/>
+          </a:xfrm>
+          <a:prstGeom prst="rect">
+            <a:avLst/>
+          </a:prstGeom>
+          <a:noFill/>
+        </p:spPr>
+        <p:txBody>
+          <a:bodyPr wrap="none">
+            <a:spAutoFit/>
+          </a:bodyPr>
+          <a:lstStyle/>
+          <a:p>
+            <a:r>
+              <a:rPr sz="1000" b="0" i="1">
+                <a:solidFill>
+                  <a:srgbClr val="6A6760"/>
+                </a:solidFill>
+                <a:latin typeface="Encode Sans"/>
+              </a:rPr>
+              <a:t>Fuente: elaboración propia en base a Hacienda (vía INDEC IMIG)</a:t>
+            </a:r>
+          </a:p>
+        </p:txBody>
+      </p:sp>
+    </p:spTree>
+  </p:cSld>
+  <p:clrMapOvr>
+    <a:masterClrMapping/>
+  </p:clrMapOvr>
+</p:sld>
+</file>
+
+<file path=ppt/slides/slide5.xml><?xml version="1.0" encoding="utf-8"?>
+<p:sld xmlns:a="http://schemas.openxmlformats.org/drawingml/2006/main" xmlns:p="http://schemas.openxmlformats.org/presentationml/2006/main" xmlns:r="http://schemas.openxmlformats.org/officeDocument/2006/relationships">
+  <p:cSld>
+    <p:spTree>
+      <p:nvGrpSpPr>
+        <p:cNvPr id="1" name=""/>
+        <p:cNvGrpSpPr/>
+        <p:nvPr/>
+      </p:nvGrpSpPr>
+      <p:grpSpPr/>
+      <p:sp>
+        <p:nvSpPr>
+          <p:cNvPr id="2" name="Rectangle 1"/>
+          <p:cNvSpPr/>
+          <p:nvPr/>
+        </p:nvSpPr>
+        <p:spPr>
+          <a:xfrm>
+            <a:off x="0" y="0"/>
+            <a:ext cx="12191695" cy="274320"/>
+          </a:xfrm>
+          <a:prstGeom prst="rect">
+            <a:avLst/>
+          </a:prstGeom>
+          <a:solidFill>
+            <a:srgbClr val="00B2C9"/>
+          </a:solidFill>
+          <a:ln>
+            <a:noFill/>
+          </a:ln>
+        </p:spPr>
+        <p:style>
+          <a:lnRef idx="1">
+            <a:schemeClr val="accent1"/>
+          </a:lnRef>
+          <a:fillRef idx="3">
+            <a:schemeClr val="accent1"/>
+          </a:fillRef>
+          <a:effectRef idx="2">
+            <a:schemeClr val="accent1"/>
+          </a:effectRef>
+          <a:fontRef idx="minor">
+            <a:schemeClr val="lt1"/>
+          </a:fontRef>
+        </p:style>
+        <p:txBody>
+          <a:bodyPr rtlCol="0" anchor="ctr"/>
+          <a:lstStyle/>
+          <a:p>
+            <a:pPr algn="ctr"/>
+          </a:p>
+        </p:txBody>
+      </p:sp>
+      <p:sp>
+        <p:nvSpPr>
+          <p:cNvPr id="3" name="TextBox 2"/>
+          <p:cNvSpPr txBox="1"/>
+          <p:nvPr/>
+        </p:nvSpPr>
+        <p:spPr>
+          <a:xfrm>
+            <a:off x="411480" y="457200"/>
+            <a:ext cx="11368735" cy="914400"/>
+          </a:xfrm>
+          <a:prstGeom prst="rect">
+            <a:avLst/>
+          </a:prstGeom>
+          <a:noFill/>
+        </p:spPr>
+        <p:txBody>
+          <a:bodyPr wrap="square" lIns="0" rIns="0">
+            <a:spAutoFit/>
+          </a:bodyPr>
+          <a:lstStyle/>
+          <a:p>
+            <a:pPr algn="l"/>
+            <a:r>
+              <a:rPr sz="2600" b="1" i="0">
+                <a:solidFill>
+                  <a:srgbClr val="00B2C9"/>
+                </a:solidFill>
+                <a:latin typeface="Encode Sans"/>
+              </a:rPr>
+              <a:t>FISCAL JUNIO 2026: DÉFICIT PRIMARIO $697K M$</a:t>
+            </a:r>
+          </a:p>
+        </p:txBody>
+      </p:sp>
+      <p:sp>
+        <p:nvSpPr>
+          <p:cNvPr id="4" name="TextBox 3"/>
+          <p:cNvSpPr txBox="1"/>
+          <p:nvPr/>
+        </p:nvSpPr>
+        <p:spPr>
+          <a:xfrm>
+            <a:off x="411480" y="1280160"/>
+            <a:ext cx="11368735" cy="274320"/>
+          </a:xfrm>
+          <a:prstGeom prst="rect">
+            <a:avLst/>
+          </a:prstGeom>
+          <a:noFill/>
+        </p:spPr>
+        <p:txBody>
+          <a:bodyPr wrap="none">
+            <a:spAutoFit/>
+          </a:bodyPr>
+          <a:lstStyle/>
+          <a:p>
+            <a:r>
+              <a:rPr sz="1100" b="0" i="1">
+                <a:solidFill>
+                  <a:srgbClr val="6A6760"/>
+                </a:solidFill>
+                <a:latin typeface="Encode Sans"/>
+              </a:rPr>
+              <a:t>Hacienda (vía INDEC IMIG) · período 2026-06</a:t>
+            </a:r>
+          </a:p>
+        </p:txBody>
+      </p:sp>
+      <p:sp>
+        <p:nvSpPr>
+          <p:cNvPr id="5" name="TextBox 4"/>
+          <p:cNvSpPr txBox="1"/>
+          <p:nvPr/>
+        </p:nvSpPr>
+        <p:spPr>
+          <a:xfrm>
+            <a:off x="411480" y="1691640"/>
+            <a:ext cx="5486400" cy="1645920"/>
+          </a:xfrm>
+          <a:prstGeom prst="rect">
+            <a:avLst/>
+          </a:prstGeom>
+          <a:noFill/>
+        </p:spPr>
+        <p:txBody>
+          <a:bodyPr wrap="square" lIns="0" rIns="0">
+            <a:spAutoFit/>
+          </a:bodyPr>
+          <a:lstStyle/>
+          <a:p>
+            <a:pPr algn="just"/>
+            <a:r>
+              <a:rPr sz="1300" b="0" i="0">
+                <a:solidFill>
+                  <a:srgbClr val="3F3F3F"/>
+                </a:solidFill>
+                <a:latin typeface="Encode Sans"/>
+              </a:rPr>
+              <a:t>El Sector Público Nacional No Financiero registró un resultado primario de -697 mil millones de pesos en junio 2026. El resultado financiero alcanzó -1.025K M$.</a:t>
+            </a:r>
+          </a:p>
+        </p:txBody>
+      </p:sp>
+      <p:sp>
+        <p:nvSpPr>
+          <p:cNvPr id="6" name="TextBox 5"/>
+          <p:cNvSpPr txBox="1"/>
+          <p:nvPr/>
+        </p:nvSpPr>
+        <p:spPr>
+          <a:xfrm>
+            <a:off x="411480" y="3520440"/>
+            <a:ext cx="5486400" cy="2743200"/>
+          </a:xfrm>
+          <a:prstGeom prst="rect">
+            <a:avLst/>
+          </a:prstGeom>
+          <a:noFill/>
+        </p:spPr>
+        <p:txBody>
+          <a:bodyPr wrap="square" lIns="0" rIns="0">
+            <a:spAutoFit/>
+          </a:bodyPr>
+          <a:lstStyle/>
+          <a:p>
+            <a:pPr algn="l">
+              <a:spcAft>
+                <a:spcPts val="800"/>
+              </a:spcAft>
+            </a:pPr>
+            <a:r>
+              <a:rPr sz="1300" b="1" i="0">
+                <a:solidFill>
+                  <a:srgbClr val="00B2C9"/>
+                </a:solidFill>
+                <a:latin typeface="Encode Sans"/>
+              </a:rPr>
+              <a:t>●  </a:t>
+            </a:r>
+            <a:r>
+              <a:rPr sz="1300" b="0" i="0">
+                <a:solidFill>
+                  <a:srgbClr val="3F3F3F"/>
+                </a:solidFill>
+                <a:latin typeface="Encode Sans"/>
+              </a:rPr>
+              <a:t>Resultado primario: -697 mil millones de pesos</a:t>
+            </a:r>
+          </a:p>
+          <a:p>
+            <a:pPr algn="l">
+              <a:spcAft>
+                <a:spcPts val="800"/>
+              </a:spcAft>
+            </a:pPr>
+            <a:r>
+              <a:rPr sz="1300" b="1" i="0">
+                <a:solidFill>
+                  <a:srgbClr val="00B2C9"/>
+                </a:solidFill>
+                <a:latin typeface="Encode Sans"/>
+              </a:rPr>
+              <a:t>●  </a:t>
+            </a:r>
+            <a:r>
+              <a:rPr sz="1300" b="0" i="0">
+                <a:solidFill>
+                  <a:srgbClr val="3F3F3F"/>
+                </a:solidFill>
+                <a:latin typeface="Encode Sans"/>
+              </a:rPr>
+              <a:t>Resultado financiero: -1.025 mil millones</a:t>
+            </a:r>
+          </a:p>
+          <a:p>
+            <a:pPr algn="l">
+              <a:spcAft>
+                <a:spcPts val="800"/>
+              </a:spcAft>
+            </a:pPr>
+            <a:r>
+              <a:rPr sz="1300" b="1" i="0">
+                <a:solidFill>
+                  <a:srgbClr val="00B2C9"/>
+                </a:solidFill>
+                <a:latin typeface="Encode Sans"/>
+              </a:rPr>
+              <a:t>●  </a:t>
+            </a:r>
+            <a:r>
+              <a:rPr sz="1300" b="0" i="0">
+                <a:solidFill>
+                  <a:srgbClr val="3F3F3F"/>
+                </a:solidFill>
+                <a:latin typeface="Encode Sans"/>
+              </a:rPr>
+              <a:t>Fuente: Secretaría de Hacienda, base caja (Metodología 2017)</a:t>
+            </a:r>
+          </a:p>
+        </p:txBody>
+      </p:sp>
+      <p:pic>
+        <p:nvPicPr>
+          <p:cNvPr id="7" name="Picture 6" descr="image.png"/>
+          <p:cNvPicPr>
+            <a:picLocks noChangeAspect="1"/>
+          </p:cNvPicPr>
+          <p:nvPr/>
+        </p:nvPicPr>
+        <p:blipFill>
+          <a:blip r:embed="rId2"/>
+          <a:stretch>
+            <a:fillRect/>
+          </a:stretch>
+        </p:blipFill>
+        <p:spPr>
+          <a:xfrm>
+            <a:off x="6080760" y="1691640"/>
+            <a:ext cx="5669280" cy="2560320"/>
+          </a:xfrm>
+          <a:prstGeom prst="rect">
+            <a:avLst/>
+          </a:prstGeom>
+        </p:spPr>
+      </p:pic>
+      <p:graphicFrame>
+        <p:nvGraphicFramePr>
+          <p:cNvPr id="8" name="Table 7"/>
+          <p:cNvGraphicFramePr>
+            <a:graphicFrameLocks noGrp="1"/>
+          </p:cNvGraphicFramePr>
+          <p:nvPr/>
+        </p:nvGraphicFramePr>
+        <p:xfrm>
+          <a:off x="6080760" y="4434840"/>
+          <a:ext cx="5669280" cy="2048256"/>
+        </p:xfrm>
+        <a:graphic>
+          <a:graphicData uri="http://schemas.openxmlformats.org/drawingml/2006/table">
+            <a:tbl>
+              <a:tblPr firstRow="1" bandRow="1">
+                <a:tableStyleId>{5C22544A-7EE6-4342-B048-85BDC9FD1C3A}</a:tableStyleId>
+              </a:tblPr>
+              <a:tblGrid>
+                <a:gridCol w="1889760"/>
+                <a:gridCol w="1889760"/>
+                <a:gridCol w="1889760"/>
+              </a:tblGrid>
+              <a:tr h="292608">
+                <a:tc>
+                  <a:txBody>
+                    <a:bodyPr/>
+                    <a:lstStyle/>
+                    <a:p>
+                      <a:pPr algn="l"/>
+                      <a:r>
+                        <a:rPr sz="1000" b="1">
+                          <a:solidFill>
+                            <a:srgbClr val="FFFFFF"/>
+                          </a:solidFill>
+                          <a:latin typeface="Encode Sans"/>
+                        </a:rPr>
+                        <a:t>Mes</a:t>
+                      </a:r>
+                    </a:p>
+                  </a:txBody>
+                  <a:tcPr marL="36576" marR="36576" marT="18288" marB="18288">
+                    <a:solidFill>
+                      <a:srgbClr val="00B2C9"/>
+                    </a:solidFill>
+                  </a:tcPr>
+                </a:tc>
+                <a:tc>
+                  <a:txBody>
+                    <a:bodyPr/>
+                    <a:lstStyle/>
+                    <a:p>
+                      <a:pPr algn="r"/>
+                      <a:r>
+                        <a:rPr sz="1000" b="1">
+                          <a:solidFill>
+                            <a:srgbClr val="FFFFFF"/>
+                          </a:solidFill>
+                          <a:latin typeface="Encode Sans"/>
+                        </a:rPr>
+                        <a:t>Primario M$</a:t>
+                      </a:r>
+                    </a:p>
+                  </a:txBody>
+                  <a:tcPr marL="36576" marR="36576" marT="18288" marB="18288">
+                    <a:solidFill>
+                      <a:srgbClr val="00B2C9"/>
+                    </a:solidFill>
+                  </a:tcPr>
+                </a:tc>
+                <a:tc>
+                  <a:txBody>
+                    <a:bodyPr/>
+                    <a:lstStyle/>
+                    <a:p>
+                      <a:pPr algn="r"/>
+                      <a:r>
+                        <a:rPr sz="1000" b="1">
+                          <a:solidFill>
+                            <a:srgbClr val="FFFFFF"/>
+                          </a:solidFill>
+                          <a:latin typeface="Encode Sans"/>
+                        </a:rPr>
+                        <a:t>Financiero M$</a:t>
+                      </a:r>
+                    </a:p>
+                  </a:txBody>
+                  <a:tcPr marL="36576" marR="36576" marT="18288" marB="18288">
+                    <a:solidFill>
+                      <a:srgbClr val="00B2C9"/>
+                    </a:solidFill>
+                  </a:tcPr>
+                </a:tc>
+              </a:tr>
+              <a:tr h="292608">
+                <a:tc>
+                  <a:txBody>
+                    <a:bodyPr/>
+                    <a:lstStyle/>
+                    <a:p>
+                      <a:pPr algn="l"/>
+                      <a:r>
+                        <a:rPr sz="1000">
+                          <a:solidFill>
+                            <a:srgbClr val="3F3F3F"/>
+                          </a:solidFill>
+                          <a:latin typeface="Encode Sans"/>
+                        </a:rPr>
+                        <a:t>Junio 2026</a:t>
+                      </a:r>
+                    </a:p>
+                  </a:txBody>
+                  <a:tcPr marL="36576" marR="36576" marT="18288" marB="18288">
+                    <a:solidFill>
+                      <a:srgbClr val="FFFFFF"/>
+                    </a:solidFill>
+                  </a:tcPr>
+                </a:tc>
+                <a:tc>
+                  <a:txBody>
+                    <a:bodyPr/>
+                    <a:lstStyle/>
+                    <a:p>
+                      <a:pPr algn="r"/>
+                      <a:r>
+                        <a:rPr sz="1000">
+                          <a:solidFill>
+                            <a:srgbClr val="3F3F3F"/>
+                          </a:solidFill>
+                          <a:latin typeface="Encode Sans"/>
+                        </a:rPr>
+                        <a:t>-696.843</a:t>
+                      </a:r>
+                    </a:p>
+                  </a:txBody>
+                  <a:tcPr marL="36576" marR="36576" marT="18288" marB="18288">
+                    <a:solidFill>
+                      <a:srgbClr val="FFFFFF"/>
+                    </a:solidFill>
+                  </a:tcPr>
+                </a:tc>
+                <a:tc>
+                  <a:txBody>
+                    <a:bodyPr/>
+                    <a:lstStyle/>
+                    <a:p>
+                      <a:pPr algn="r"/>
+                      <a:r>
+                        <a:rPr sz="1000">
+                          <a:solidFill>
+                            <a:srgbClr val="3F3F3F"/>
+                          </a:solidFill>
+                          <a:latin typeface="Encode Sans"/>
+                        </a:rPr>
+                        <a:t>-1.024.891</a:t>
+                      </a:r>
+                    </a:p>
+                  </a:txBody>
+                  <a:tcPr marL="36576" marR="36576" marT="18288" marB="18288">
+                    <a:solidFill>
+                      <a:srgbClr val="FFFFFF"/>
+                    </a:solidFill>
+                  </a:tcPr>
+                </a:tc>
+              </a:tr>
+              <a:tr h="292608">
+                <a:tc>
+                  <a:txBody>
+                    <a:bodyPr/>
+                    <a:lstStyle/>
+                    <a:p>
+                      <a:pPr algn="l"/>
+                      <a:r>
+                        <a:rPr sz="1000">
+                          <a:solidFill>
+                            <a:srgbClr val="3F3F3F"/>
+                          </a:solidFill>
+                          <a:latin typeface="Encode Sans"/>
+                        </a:rPr>
+                        <a:t>Mayo 2026</a:t>
+                      </a:r>
+                    </a:p>
+                  </a:txBody>
+                  <a:tcPr marL="36576" marR="36576" marT="18288" marB="18288">
+                    <a:solidFill>
+                      <a:srgbClr val="F8F8F6"/>
+                    </a:solidFill>
+                  </a:tcPr>
+                </a:tc>
+                <a:tc>
+                  <a:txBody>
+                    <a:bodyPr/>
+                    <a:lstStyle/>
+                    <a:p>
+                      <a:pPr algn="r"/>
+                      <a:r>
+                        <a:rPr sz="1000">
+                          <a:solidFill>
+                            <a:srgbClr val="3F3F3F"/>
+                          </a:solidFill>
+                          <a:latin typeface="Encode Sans"/>
+                        </a:rPr>
+                        <a:t>1.924.367</a:t>
+                      </a:r>
+                    </a:p>
+                  </a:txBody>
+                  <a:tcPr marL="36576" marR="36576" marT="18288" marB="18288">
+                    <a:solidFill>
+                      <a:srgbClr val="F8F8F6"/>
+                    </a:solidFill>
+                  </a:tcPr>
+                </a:tc>
+                <a:tc>
+                  <a:txBody>
+                    <a:bodyPr/>
+                    <a:lstStyle/>
+                    <a:p>
+                      <a:pPr algn="r"/>
+                      <a:r>
+                        <a:rPr sz="1000">
+                          <a:solidFill>
+                            <a:srgbClr val="3F3F3F"/>
+                          </a:solidFill>
+                          <a:latin typeface="Encode Sans"/>
+                        </a:rPr>
+                        <a:t>478.613</a:t>
+                      </a:r>
+                    </a:p>
+                  </a:txBody>
+                  <a:tcPr marL="36576" marR="36576" marT="18288" marB="18288">
+                    <a:solidFill>
+                      <a:srgbClr val="F8F8F6"/>
+                    </a:solidFill>
+                  </a:tcPr>
+                </a:tc>
+              </a:tr>
+              <a:tr h="292608">
+                <a:tc>
+                  <a:txBody>
+                    <a:bodyPr/>
+                    <a:lstStyle/>
+                    <a:p>
+                      <a:pPr algn="l"/>
+                      <a:r>
+                        <a:rPr sz="1000">
+                          <a:solidFill>
+                            <a:srgbClr val="3F3F3F"/>
+                          </a:solidFill>
+                          <a:latin typeface="Encode Sans"/>
+                        </a:rPr>
+                        <a:t>Abril 2026</a:t>
+                      </a:r>
+                    </a:p>
+                  </a:txBody>
+                  <a:tcPr marL="36576" marR="36576" marT="18288" marB="18288">
+                    <a:solidFill>
+                      <a:srgbClr val="FFFFFF"/>
+                    </a:solidFill>
+                  </a:tcPr>
+                </a:tc>
+                <a:tc>
+                  <a:txBody>
+                    <a:bodyPr/>
+                    <a:lstStyle/>
+                    <a:p>
+                      <a:pPr algn="r"/>
+                      <a:r>
+                        <a:rPr sz="1000">
+                          <a:solidFill>
+                            <a:srgbClr val="3F3F3F"/>
+                          </a:solidFill>
+                          <a:latin typeface="Encode Sans"/>
+                        </a:rPr>
+                        <a:t>632.844</a:t>
+                      </a:r>
+                    </a:p>
+                  </a:txBody>
+                  <a:tcPr marL="36576" marR="36576" marT="18288" marB="18288">
+                    <a:solidFill>
+                      <a:srgbClr val="FFFFFF"/>
+                    </a:solidFill>
+                  </a:tcPr>
+                </a:tc>
+                <a:tc>
+                  <a:txBody>
+                    <a:bodyPr/>
+                    <a:lstStyle/>
+                    <a:p>
+                      <a:pPr algn="r"/>
+                      <a:r>
+                        <a:rPr sz="1000">
+                          <a:solidFill>
+                            <a:srgbClr val="3F3F3F"/>
+                          </a:solidFill>
+                          <a:latin typeface="Encode Sans"/>
+                        </a:rPr>
+                        <a:t>268.103</a:t>
+                      </a:r>
+                    </a:p>
+                  </a:txBody>
+                  <a:tcPr marL="36576" marR="36576" marT="18288" marB="18288">
+                    <a:solidFill>
+                      <a:srgbClr val="FFFFFF"/>
+                    </a:solidFill>
+                  </a:tcPr>
+                </a:tc>
+              </a:tr>
+              <a:tr h="292608">
+                <a:tc>
+                  <a:txBody>
+                    <a:bodyPr/>
+                    <a:lstStyle/>
+                    <a:p>
+                      <a:pPr algn="l"/>
+                      <a:r>
+                        <a:rPr sz="1000">
+                          <a:solidFill>
+                            <a:srgbClr val="3F3F3F"/>
+                          </a:solidFill>
+                          <a:latin typeface="Encode Sans"/>
+                        </a:rPr>
+                        <a:t>Marzo 2026</a:t>
+                      </a:r>
+                    </a:p>
+                  </a:txBody>
+                  <a:tcPr marL="36576" marR="36576" marT="18288" marB="18288">
+                    <a:solidFill>
+                      <a:srgbClr val="F8F8F6"/>
+                    </a:solidFill>
+                  </a:tcPr>
+                </a:tc>
+                <a:tc>
+                  <a:txBody>
+                    <a:bodyPr/>
+                    <a:lstStyle/>
+                    <a:p>
+                      <a:pPr algn="r"/>
+                      <a:r>
+                        <a:rPr sz="1000">
+                          <a:solidFill>
+                            <a:srgbClr val="3F3F3F"/>
+                          </a:solidFill>
+                          <a:latin typeface="Encode Sans"/>
+                        </a:rPr>
+                        <a:t>930.284</a:t>
+                      </a:r>
+                    </a:p>
+                  </a:txBody>
+                  <a:tcPr marL="36576" marR="36576" marT="18288" marB="18288">
+                    <a:solidFill>
+                      <a:srgbClr val="F8F8F6"/>
+                    </a:solidFill>
+                  </a:tcPr>
+                </a:tc>
+                <a:tc>
+                  <a:txBody>
+                    <a:bodyPr/>
+                    <a:lstStyle/>
+                    <a:p>
+                      <a:pPr algn="r"/>
+                      <a:r>
+                        <a:rPr sz="1000">
+                          <a:solidFill>
+                            <a:srgbClr val="3F3F3F"/>
+                          </a:solidFill>
+                          <a:latin typeface="Encode Sans"/>
+                        </a:rPr>
+                        <a:t>246.434</a:t>
+                      </a:r>
+                    </a:p>
+                  </a:txBody>
+                  <a:tcPr marL="36576" marR="36576" marT="18288" marB="18288">
+                    <a:solidFill>
+                      <a:srgbClr val="F8F8F6"/>
+                    </a:solidFill>
+                  </a:tcPr>
+                </a:tc>
+              </a:tr>
+              <a:tr h="292608">
+                <a:tc>
+                  <a:txBody>
+                    <a:bodyPr/>
+                    <a:lstStyle/>
+                    <a:p>
+                      <a:pPr algn="l"/>
+                      <a:r>
+                        <a:rPr sz="1000">
+                          <a:solidFill>
+                            <a:srgbClr val="3F3F3F"/>
+                          </a:solidFill>
+                          <a:latin typeface="Encode Sans"/>
+                        </a:rPr>
+                        <a:t>Febrero 2026</a:t>
+                      </a:r>
+                    </a:p>
+                  </a:txBody>
+                  <a:tcPr marL="36576" marR="36576" marT="18288" marB="18288">
+                    <a:solidFill>
+                      <a:srgbClr val="FFFFFF"/>
+                    </a:solidFill>
+                  </a:tcPr>
+                </a:tc>
+                <a:tc>
+                  <a:txBody>
+                    <a:bodyPr/>
+                    <a:lstStyle/>
+                    <a:p>
+                      <a:pPr algn="r"/>
+                      <a:r>
+                        <a:rPr sz="1000">
+                          <a:solidFill>
+                            <a:srgbClr val="3F3F3F"/>
+                          </a:solidFill>
+                          <a:latin typeface="Encode Sans"/>
+                        </a:rPr>
+                        <a:t>1.410.640</a:t>
+                      </a:r>
+                    </a:p>
+                  </a:txBody>
+                  <a:tcPr marL="36576" marR="36576" marT="18288" marB="18288">
+                    <a:solidFill>
+                      <a:srgbClr val="FFFFFF"/>
+                    </a:solidFill>
+                  </a:tcPr>
+                </a:tc>
+                <a:tc>
+                  <a:txBody>
+                    <a:bodyPr/>
+                    <a:lstStyle/>
+                    <a:p>
+                      <a:pPr algn="r"/>
+                      <a:r>
+                        <a:rPr sz="1000">
+                          <a:solidFill>
+                            <a:srgbClr val="3F3F3F"/>
+                          </a:solidFill>
+                          <a:latin typeface="Encode Sans"/>
+                        </a:rPr>
+                        <a:t>297.224</a:t>
+                      </a:r>
+                    </a:p>
+                  </a:txBody>
+                  <a:tcPr marL="36576" marR="36576" marT="18288" marB="18288">
+                    <a:solidFill>
+                      <a:srgbClr val="FFFFFF"/>
+                    </a:solidFill>
+                  </a:tcPr>
+                </a:tc>
+              </a:tr>
+              <a:tr h="292608">
+                <a:tc>
+                  <a:txBody>
+                    <a:bodyPr/>
+                    <a:lstStyle/>
+                    <a:p>
+                      <a:pPr algn="l"/>
+                      <a:r>
+                        <a:rPr sz="1000">
+                          <a:solidFill>
+                            <a:srgbClr val="3F3F3F"/>
+                          </a:solidFill>
+                          <a:latin typeface="Encode Sans"/>
+                        </a:rPr>
+                        <a:t>Enero 2026</a:t>
+                      </a:r>
+                    </a:p>
+                  </a:txBody>
+                  <a:tcPr marL="36576" marR="36576" marT="18288" marB="18288">
+                    <a:solidFill>
+                      <a:srgbClr val="F8F8F6"/>
+                    </a:solidFill>
+                  </a:tcPr>
+                </a:tc>
+                <a:tc>
+                  <a:txBody>
+                    <a:bodyPr/>
+                    <a:lstStyle/>
+                    <a:p>
+                      <a:pPr algn="r"/>
+                      <a:r>
+                        <a:rPr sz="1000">
+                          <a:solidFill>
+                            <a:srgbClr val="3F3F3F"/>
+                          </a:solidFill>
+                          <a:latin typeface="Encode Sans"/>
+                        </a:rPr>
+                        <a:t>3.125.737</a:t>
+                      </a:r>
+                    </a:p>
+                  </a:txBody>
+                  <a:tcPr marL="36576" marR="36576" marT="18288" marB="18288">
+                    <a:solidFill>
+                      <a:srgbClr val="F8F8F6"/>
+                    </a:solidFill>
+                  </a:tcPr>
+                </a:tc>
+                <a:tc>
+                  <a:txBody>
+                    <a:bodyPr/>
+                    <a:lstStyle/>
+                    <a:p>
+                      <a:pPr algn="r"/>
+                      <a:r>
+                        <a:rPr sz="1000">
+                          <a:solidFill>
+                            <a:srgbClr val="3F3F3F"/>
+                          </a:solidFill>
+                          <a:latin typeface="Encode Sans"/>
+                        </a:rPr>
+                        <a:t>-166.961</a:t>
+                      </a:r>
+                    </a:p>
+                  </a:txBody>
+                  <a:tcPr marL="36576" marR="36576" marT="18288" marB="18288">
+                    <a:solidFill>
+                      <a:srgbClr val="F8F8F6"/>
+                    </a:solidFill>
+                  </a:tcPr>
+                </a:tc>
+              </a:tr>
+            </a:tbl>
+          </a:graphicData>
+        </a:graphic>
+      </p:graphicFrame>
+      <p:sp>
+        <p:nvSpPr>
+          <p:cNvPr id="9" name="TextBox 8"/>
+          <p:cNvSpPr txBox="1"/>
+          <p:nvPr/>
+        </p:nvSpPr>
+        <p:spPr>
+          <a:xfrm>
+            <a:off x="411480" y="6492240"/>
+            <a:ext cx="11368735" cy="274320"/>
+          </a:xfrm>
+          <a:prstGeom prst="rect">
+            <a:avLst/>
+          </a:prstGeom>
+          <a:noFill/>
+        </p:spPr>
+        <p:txBody>
+          <a:bodyPr wrap="none">
+            <a:spAutoFit/>
+          </a:bodyPr>
+          <a:lstStyle/>
+          <a:p>
+            <a:r>
+              <a:rPr sz="1000" b="0" i="1">
+                <a:solidFill>
+                  <a:srgbClr val="6A6760"/>
+                </a:solidFill>
+                <a:latin typeface="Encode Sans"/>
+              </a:rPr>
+              <a:t>Fuente: elaboración propia en base a Hacienda (vía INDEC IMIG)</a:t>
             </a:r>
           </a:p>
         </p:txBody>

</xml_diff>

<commit_message>
data: update 2026-07-22 ( data.json despidos.json scraper/historical_despidos.json publicaciones_semana.pptx rrii_brutas.xlsx)
</commit_message>
<xml_diff>
--- a/publicaciones_semana.pptx
+++ b/publicaciones_semana.pptx
@@ -7,6 +7,7 @@
   <p:sldIdLst>
     <p:sldId id="256" r:id="rId7"/>
     <p:sldId id="257" r:id="rId8"/>
+    <p:sldId id="258" r:id="rId9"/>
   </p:sldIdLst>
   <p:sldSz cx="12191695" cy="6858000" type="screen4x3"/>
   <p:notesSz cx="6858000" cy="9144000"/>
@@ -3272,7 +3273,7 @@
                 </a:solidFill>
                 <a:latin typeface="Encode Sans"/>
               </a:rPr>
-              <a:t>1 publicaciones · datos oficiales INDEC / BCRA / Hacienda</a:t>
+              <a:t>2 publicaciones · datos oficiales INDEC / BCRA / Hacienda</a:t>
             </a:r>
           </a:p>
         </p:txBody>
@@ -4317,6 +4318,1013 @@
 </p:sld>
 </file>
 
+<file path=ppt/slides/slide3.xml><?xml version="1.0" encoding="utf-8"?>
+<p:sld xmlns:a="http://schemas.openxmlformats.org/drawingml/2006/main" xmlns:p="http://schemas.openxmlformats.org/presentationml/2006/main" xmlns:r="http://schemas.openxmlformats.org/officeDocument/2006/relationships">
+  <p:cSld>
+    <p:spTree>
+      <p:nvGrpSpPr>
+        <p:cNvPr id="1" name=""/>
+        <p:cNvGrpSpPr/>
+        <p:nvPr/>
+      </p:nvGrpSpPr>
+      <p:grpSpPr/>
+      <p:sp>
+        <p:nvSpPr>
+          <p:cNvPr id="2" name="Rectangle 1"/>
+          <p:cNvSpPr/>
+          <p:nvPr/>
+        </p:nvSpPr>
+        <p:spPr>
+          <a:xfrm>
+            <a:off x="0" y="0"/>
+            <a:ext cx="12191695" cy="274320"/>
+          </a:xfrm>
+          <a:prstGeom prst="rect">
+            <a:avLst/>
+          </a:prstGeom>
+          <a:solidFill>
+            <a:srgbClr val="00B2C9"/>
+          </a:solidFill>
+          <a:ln>
+            <a:noFill/>
+          </a:ln>
+        </p:spPr>
+        <p:style>
+          <a:lnRef idx="1">
+            <a:schemeClr val="accent1"/>
+          </a:lnRef>
+          <a:fillRef idx="3">
+            <a:schemeClr val="accent1"/>
+          </a:fillRef>
+          <a:effectRef idx="2">
+            <a:schemeClr val="accent1"/>
+          </a:effectRef>
+          <a:fontRef idx="minor">
+            <a:schemeClr val="lt1"/>
+          </a:fontRef>
+        </p:style>
+        <p:txBody>
+          <a:bodyPr rtlCol="0" anchor="ctr"/>
+          <a:lstStyle/>
+          <a:p>
+            <a:pPr algn="ctr"/>
+          </a:p>
+        </p:txBody>
+      </p:sp>
+      <p:sp>
+        <p:nvSpPr>
+          <p:cNvPr id="3" name="TextBox 2"/>
+          <p:cNvSpPr txBox="1"/>
+          <p:nvPr/>
+        </p:nvSpPr>
+        <p:spPr>
+          <a:xfrm>
+            <a:off x="411480" y="457200"/>
+            <a:ext cx="11368735" cy="914400"/>
+          </a:xfrm>
+          <a:prstGeom prst="rect">
+            <a:avLst/>
+          </a:prstGeom>
+          <a:noFill/>
+        </p:spPr>
+        <p:txBody>
+          <a:bodyPr wrap="square" lIns="0" rIns="0">
+            <a:spAutoFit/>
+          </a:bodyPr>
+          <a:lstStyle/>
+          <a:p>
+            <a:pPr algn="l"/>
+            <a:r>
+              <a:rPr sz="2600" b="1" i="0">
+                <a:solidFill>
+                  <a:srgbClr val="00B2C9"/>
+                </a:solidFill>
+                <a:latin typeface="Encode Sans"/>
+              </a:rPr>
+              <a:t>EMAE MAYO 2026: ACTIVIDAD CRECIÓ +0.2% I.A.</a:t>
+            </a:r>
+          </a:p>
+        </p:txBody>
+      </p:sp>
+      <p:sp>
+        <p:nvSpPr>
+          <p:cNvPr id="4" name="TextBox 3"/>
+          <p:cNvSpPr txBox="1"/>
+          <p:nvPr/>
+        </p:nvSpPr>
+        <p:spPr>
+          <a:xfrm>
+            <a:off x="411480" y="1280160"/>
+            <a:ext cx="11368735" cy="274320"/>
+          </a:xfrm>
+          <a:prstGeom prst="rect">
+            <a:avLst/>
+          </a:prstGeom>
+          <a:noFill/>
+        </p:spPr>
+        <p:txBody>
+          <a:bodyPr wrap="none">
+            <a:spAutoFit/>
+          </a:bodyPr>
+          <a:lstStyle/>
+          <a:p>
+            <a:r>
+              <a:rPr sz="1100" b="0" i="1">
+                <a:solidFill>
+                  <a:srgbClr val="6A6760"/>
+                </a:solidFill>
+                <a:latin typeface="Encode Sans"/>
+              </a:rPr>
+              <a:t>INDEC · período 2026-05</a:t>
+            </a:r>
+          </a:p>
+        </p:txBody>
+      </p:sp>
+      <p:sp>
+        <p:nvSpPr>
+          <p:cNvPr id="5" name="TextBox 4"/>
+          <p:cNvSpPr txBox="1"/>
+          <p:nvPr/>
+        </p:nvSpPr>
+        <p:spPr>
+          <a:xfrm>
+            <a:off x="411480" y="1691640"/>
+            <a:ext cx="5486400" cy="1645920"/>
+          </a:xfrm>
+          <a:prstGeom prst="rect">
+            <a:avLst/>
+          </a:prstGeom>
+          <a:noFill/>
+        </p:spPr>
+        <p:txBody>
+          <a:bodyPr wrap="square" lIns="0" rIns="0">
+            <a:spAutoFit/>
+          </a:bodyPr>
+          <a:lstStyle/>
+          <a:p>
+            <a:pPr algn="just"/>
+            <a:r>
+              <a:rPr sz="1300" b="0" i="0">
+                <a:solidFill>
+                  <a:srgbClr val="3F3F3F"/>
+                </a:solidFill>
+                <a:latin typeface="Encode Sans"/>
+              </a:rPr>
+              <a:t>El Estimador Mensual de Actividad Económica (EMAE) registró una variación interanual de +0.2% en mayo 2026. En la medición desestacionalizada, el indicador se movió -0.5% respecto al mes anterior.</a:t>
+            </a:r>
+          </a:p>
+        </p:txBody>
+      </p:sp>
+      <p:sp>
+        <p:nvSpPr>
+          <p:cNvPr id="6" name="TextBox 5"/>
+          <p:cNvSpPr txBox="1"/>
+          <p:nvPr/>
+        </p:nvSpPr>
+        <p:spPr>
+          <a:xfrm>
+            <a:off x="411480" y="3520440"/>
+            <a:ext cx="5486400" cy="2743200"/>
+          </a:xfrm>
+          <a:prstGeom prst="rect">
+            <a:avLst/>
+          </a:prstGeom>
+          <a:noFill/>
+        </p:spPr>
+        <p:txBody>
+          <a:bodyPr wrap="square" lIns="0" rIns="0">
+            <a:spAutoFit/>
+          </a:bodyPr>
+          <a:lstStyle/>
+          <a:p>
+            <a:pPr algn="l">
+              <a:spcAft>
+                <a:spcPts val="800"/>
+              </a:spcAft>
+            </a:pPr>
+            <a:r>
+              <a:rPr sz="1300" b="1" i="0">
+                <a:solidFill>
+                  <a:srgbClr val="00B2C9"/>
+                </a:solidFill>
+                <a:latin typeface="Encode Sans"/>
+              </a:rPr>
+              <a:t>●  </a:t>
+            </a:r>
+            <a:r>
+              <a:rPr sz="1300" b="0" i="0">
+                <a:solidFill>
+                  <a:srgbClr val="3F3F3F"/>
+                </a:solidFill>
+                <a:latin typeface="Encode Sans"/>
+              </a:rPr>
+              <a:t>Variación interanual: +0.2%</a:t>
+            </a:r>
+          </a:p>
+          <a:p>
+            <a:pPr algn="l">
+              <a:spcAft>
+                <a:spcPts val="800"/>
+              </a:spcAft>
+            </a:pPr>
+            <a:r>
+              <a:rPr sz="1300" b="1" i="0">
+                <a:solidFill>
+                  <a:srgbClr val="00B2C9"/>
+                </a:solidFill>
+                <a:latin typeface="Encode Sans"/>
+              </a:rPr>
+              <a:t>●  </a:t>
+            </a:r>
+            <a:r>
+              <a:rPr sz="1300" b="0" i="0">
+                <a:solidFill>
+                  <a:srgbClr val="3F3F3F"/>
+                </a:solidFill>
+                <a:latin typeface="Encode Sans"/>
+              </a:rPr>
+              <a:t>Variación mensual desestacionalizada: -0.5%</a:t>
+            </a:r>
+          </a:p>
+          <a:p>
+            <a:pPr algn="l">
+              <a:spcAft>
+                <a:spcPts val="800"/>
+              </a:spcAft>
+            </a:pPr>
+            <a:r>
+              <a:rPr sz="1300" b="1" i="0">
+                <a:solidFill>
+                  <a:srgbClr val="00B2C9"/>
+                </a:solidFill>
+                <a:latin typeface="Encode Sans"/>
+              </a:rPr>
+              <a:t>●  </a:t>
+            </a:r>
+            <a:r>
+              <a:rPr sz="1300" b="0" i="0">
+                <a:solidFill>
+                  <a:srgbClr val="3F3F3F"/>
+                </a:solidFill>
+                <a:latin typeface="Encode Sans"/>
+              </a:rPr>
+              <a:t>Serie INDEC, base 2004=100. Mide el nivel general de actividad.</a:t>
+            </a:r>
+          </a:p>
+        </p:txBody>
+      </p:sp>
+      <p:pic>
+        <p:nvPicPr>
+          <p:cNvPr id="7" name="Picture 6" descr="image.png"/>
+          <p:cNvPicPr>
+            <a:picLocks noChangeAspect="1"/>
+          </p:cNvPicPr>
+          <p:nvPr/>
+        </p:nvPicPr>
+        <p:blipFill>
+          <a:blip r:embed="rId2"/>
+          <a:stretch>
+            <a:fillRect/>
+          </a:stretch>
+        </p:blipFill>
+        <p:spPr>
+          <a:xfrm>
+            <a:off x="6080760" y="1691640"/>
+            <a:ext cx="5669280" cy="2560320"/>
+          </a:xfrm>
+          <a:prstGeom prst="rect">
+            <a:avLst/>
+          </a:prstGeom>
+        </p:spPr>
+      </p:pic>
+      <p:graphicFrame>
+        <p:nvGraphicFramePr>
+          <p:cNvPr id="8" name="Table 7"/>
+          <p:cNvGraphicFramePr>
+            <a:graphicFrameLocks noGrp="1"/>
+          </p:cNvGraphicFramePr>
+          <p:nvPr/>
+        </p:nvGraphicFramePr>
+        <p:xfrm>
+          <a:off x="6080760" y="4434840"/>
+          <a:ext cx="5669280" cy="2048256"/>
+        </p:xfrm>
+        <a:graphic>
+          <a:graphicData uri="http://schemas.openxmlformats.org/drawingml/2006/table">
+            <a:tbl>
+              <a:tblPr firstRow="1" bandRow="1">
+                <a:tableStyleId>{5C22544A-7EE6-4342-B048-85BDC9FD1C3A}</a:tableStyleId>
+              </a:tblPr>
+              <a:tblGrid>
+                <a:gridCol w="1417320"/>
+                <a:gridCol w="1417320"/>
+                <a:gridCol w="1417320"/>
+                <a:gridCol w="1417320"/>
+              </a:tblGrid>
+              <a:tr h="292608">
+                <a:tc>
+                  <a:txBody>
+                    <a:bodyPr/>
+                    <a:lstStyle/>
+                    <a:p>
+                      <a:pPr algn="l"/>
+                      <a:r>
+                        <a:rPr sz="1000" b="1">
+                          <a:solidFill>
+                            <a:srgbClr val="FFFFFF"/>
+                          </a:solidFill>
+                          <a:latin typeface="Encode Sans"/>
+                        </a:rPr>
+                        <a:t>Mes</a:t>
+                      </a:r>
+                    </a:p>
+                  </a:txBody>
+                  <a:tcPr marL="36576" marR="36576" marT="18288" marB="18288">
+                    <a:solidFill>
+                      <a:srgbClr val="00B2C9"/>
+                    </a:solidFill>
+                  </a:tcPr>
+                </a:tc>
+                <a:tc>
+                  <a:txBody>
+                    <a:bodyPr/>
+                    <a:lstStyle/>
+                    <a:p>
+                      <a:pPr algn="r"/>
+                      <a:r>
+                        <a:rPr sz="1000" b="1">
+                          <a:solidFill>
+                            <a:srgbClr val="FFFFFF"/>
+                          </a:solidFill>
+                          <a:latin typeface="Encode Sans"/>
+                        </a:rPr>
+                        <a:t>Original</a:t>
+                      </a:r>
+                    </a:p>
+                  </a:txBody>
+                  <a:tcPr marL="36576" marR="36576" marT="18288" marB="18288">
+                    <a:solidFill>
+                      <a:srgbClr val="00B2C9"/>
+                    </a:solidFill>
+                  </a:tcPr>
+                </a:tc>
+                <a:tc>
+                  <a:txBody>
+                    <a:bodyPr/>
+                    <a:lstStyle/>
+                    <a:p>
+                      <a:pPr algn="r"/>
+                      <a:r>
+                        <a:rPr sz="1000" b="1">
+                          <a:solidFill>
+                            <a:srgbClr val="FFFFFF"/>
+                          </a:solidFill>
+                          <a:latin typeface="Encode Sans"/>
+                        </a:rPr>
+                        <a:t>VIA %</a:t>
+                      </a:r>
+                    </a:p>
+                  </a:txBody>
+                  <a:tcPr marL="36576" marR="36576" marT="18288" marB="18288">
+                    <a:solidFill>
+                      <a:srgbClr val="00B2C9"/>
+                    </a:solidFill>
+                  </a:tcPr>
+                </a:tc>
+                <a:tc>
+                  <a:txBody>
+                    <a:bodyPr/>
+                    <a:lstStyle/>
+                    <a:p>
+                      <a:pPr algn="r"/>
+                      <a:r>
+                        <a:rPr sz="1000" b="1">
+                          <a:solidFill>
+                            <a:srgbClr val="FFFFFF"/>
+                          </a:solidFill>
+                          <a:latin typeface="Encode Sans"/>
+                        </a:rPr>
+                        <a:t>Desest.</a:t>
+                      </a:r>
+                    </a:p>
+                  </a:txBody>
+                  <a:tcPr marL="36576" marR="36576" marT="18288" marB="18288">
+                    <a:solidFill>
+                      <a:srgbClr val="00B2C9"/>
+                    </a:solidFill>
+                  </a:tcPr>
+                </a:tc>
+              </a:tr>
+              <a:tr h="292608">
+                <a:tc>
+                  <a:txBody>
+                    <a:bodyPr/>
+                    <a:lstStyle/>
+                    <a:p>
+                      <a:pPr algn="l"/>
+                      <a:r>
+                        <a:rPr sz="1000">
+                          <a:solidFill>
+                            <a:srgbClr val="3F3F3F"/>
+                          </a:solidFill>
+                          <a:latin typeface="Encode Sans"/>
+                        </a:rPr>
+                        <a:t>Mayo 2026</a:t>
+                      </a:r>
+                    </a:p>
+                  </a:txBody>
+                  <a:tcPr marL="36576" marR="36576" marT="18288" marB="18288">
+                    <a:solidFill>
+                      <a:srgbClr val="FFFFFF"/>
+                    </a:solidFill>
+                  </a:tcPr>
+                </a:tc>
+                <a:tc>
+                  <a:txBody>
+                    <a:bodyPr/>
+                    <a:lstStyle/>
+                    <a:p>
+                      <a:pPr algn="r"/>
+                      <a:r>
+                        <a:rPr sz="1000">
+                          <a:solidFill>
+                            <a:srgbClr val="3F3F3F"/>
+                          </a:solidFill>
+                          <a:latin typeface="Encode Sans"/>
+                        </a:rPr>
+                        <a:t>165,5</a:t>
+                      </a:r>
+                    </a:p>
+                  </a:txBody>
+                  <a:tcPr marL="36576" marR="36576" marT="18288" marB="18288">
+                    <a:solidFill>
+                      <a:srgbClr val="FFFFFF"/>
+                    </a:solidFill>
+                  </a:tcPr>
+                </a:tc>
+                <a:tc>
+                  <a:txBody>
+                    <a:bodyPr/>
+                    <a:lstStyle/>
+                    <a:p>
+                      <a:pPr algn="r"/>
+                      <a:r>
+                        <a:rPr sz="1000">
+                          <a:solidFill>
+                            <a:srgbClr val="3F3F3F"/>
+                          </a:solidFill>
+                          <a:latin typeface="Encode Sans"/>
+                        </a:rPr>
+                        <a:t>+0.2%</a:t>
+                      </a:r>
+                    </a:p>
+                  </a:txBody>
+                  <a:tcPr marL="36576" marR="36576" marT="18288" marB="18288">
+                    <a:solidFill>
+                      <a:srgbClr val="FFFFFF"/>
+                    </a:solidFill>
+                  </a:tcPr>
+                </a:tc>
+                <a:tc>
+                  <a:txBody>
+                    <a:bodyPr/>
+                    <a:lstStyle/>
+                    <a:p>
+                      <a:pPr algn="r"/>
+                      <a:r>
+                        <a:rPr sz="1000">
+                          <a:solidFill>
+                            <a:srgbClr val="3F3F3F"/>
+                          </a:solidFill>
+                          <a:latin typeface="Encode Sans"/>
+                        </a:rPr>
+                        <a:t>153,6</a:t>
+                      </a:r>
+                    </a:p>
+                  </a:txBody>
+                  <a:tcPr marL="36576" marR="36576" marT="18288" marB="18288">
+                    <a:solidFill>
+                      <a:srgbClr val="FFFFFF"/>
+                    </a:solidFill>
+                  </a:tcPr>
+                </a:tc>
+              </a:tr>
+              <a:tr h="292608">
+                <a:tc>
+                  <a:txBody>
+                    <a:bodyPr/>
+                    <a:lstStyle/>
+                    <a:p>
+                      <a:pPr algn="l"/>
+                      <a:r>
+                        <a:rPr sz="1000">
+                          <a:solidFill>
+                            <a:srgbClr val="3F3F3F"/>
+                          </a:solidFill>
+                          <a:latin typeface="Encode Sans"/>
+                        </a:rPr>
+                        <a:t>Abril 2026</a:t>
+                      </a:r>
+                    </a:p>
+                  </a:txBody>
+                  <a:tcPr marL="36576" marR="36576" marT="18288" marB="18288">
+                    <a:solidFill>
+                      <a:srgbClr val="F8F8F6"/>
+                    </a:solidFill>
+                  </a:tcPr>
+                </a:tc>
+                <a:tc>
+                  <a:txBody>
+                    <a:bodyPr/>
+                    <a:lstStyle/>
+                    <a:p>
+                      <a:pPr algn="r"/>
+                      <a:r>
+                        <a:rPr sz="1000">
+                          <a:solidFill>
+                            <a:srgbClr val="3F3F3F"/>
+                          </a:solidFill>
+                          <a:latin typeface="Encode Sans"/>
+                        </a:rPr>
+                        <a:t>161,6</a:t>
+                      </a:r>
+                    </a:p>
+                  </a:txBody>
+                  <a:tcPr marL="36576" marR="36576" marT="18288" marB="18288">
+                    <a:solidFill>
+                      <a:srgbClr val="F8F8F6"/>
+                    </a:solidFill>
+                  </a:tcPr>
+                </a:tc>
+                <a:tc>
+                  <a:txBody>
+                    <a:bodyPr/>
+                    <a:lstStyle/>
+                    <a:p>
+                      <a:pPr algn="r"/>
+                      <a:r>
+                        <a:rPr sz="1000">
+                          <a:solidFill>
+                            <a:srgbClr val="3F3F3F"/>
+                          </a:solidFill>
+                          <a:latin typeface="Encode Sans"/>
+                        </a:rPr>
+                        <a:t>+1.7%</a:t>
+                      </a:r>
+                    </a:p>
+                  </a:txBody>
+                  <a:tcPr marL="36576" marR="36576" marT="18288" marB="18288">
+                    <a:solidFill>
+                      <a:srgbClr val="F8F8F6"/>
+                    </a:solidFill>
+                  </a:tcPr>
+                </a:tc>
+                <a:tc>
+                  <a:txBody>
+                    <a:bodyPr/>
+                    <a:lstStyle/>
+                    <a:p>
+                      <a:pPr algn="r"/>
+                      <a:r>
+                        <a:rPr sz="1000">
+                          <a:solidFill>
+                            <a:srgbClr val="3F3F3F"/>
+                          </a:solidFill>
+                          <a:latin typeface="Encode Sans"/>
+                        </a:rPr>
+                        <a:t>154,3</a:t>
+                      </a:r>
+                    </a:p>
+                  </a:txBody>
+                  <a:tcPr marL="36576" marR="36576" marT="18288" marB="18288">
+                    <a:solidFill>
+                      <a:srgbClr val="F8F8F6"/>
+                    </a:solidFill>
+                  </a:tcPr>
+                </a:tc>
+              </a:tr>
+              <a:tr h="292608">
+                <a:tc>
+                  <a:txBody>
+                    <a:bodyPr/>
+                    <a:lstStyle/>
+                    <a:p>
+                      <a:pPr algn="l"/>
+                      <a:r>
+                        <a:rPr sz="1000">
+                          <a:solidFill>
+                            <a:srgbClr val="3F3F3F"/>
+                          </a:solidFill>
+                          <a:latin typeface="Encode Sans"/>
+                        </a:rPr>
+                        <a:t>Marzo 2026</a:t>
+                      </a:r>
+                    </a:p>
+                  </a:txBody>
+                  <a:tcPr marL="36576" marR="36576" marT="18288" marB="18288">
+                    <a:solidFill>
+                      <a:srgbClr val="FFFFFF"/>
+                    </a:solidFill>
+                  </a:tcPr>
+                </a:tc>
+                <a:tc>
+                  <a:txBody>
+                    <a:bodyPr/>
+                    <a:lstStyle/>
+                    <a:p>
+                      <a:pPr algn="r"/>
+                      <a:r>
+                        <a:rPr sz="1000">
+                          <a:solidFill>
+                            <a:srgbClr val="3F3F3F"/>
+                          </a:solidFill>
+                          <a:latin typeface="Encode Sans"/>
+                        </a:rPr>
+                        <a:t>160,0</a:t>
+                      </a:r>
+                    </a:p>
+                  </a:txBody>
+                  <a:tcPr marL="36576" marR="36576" marT="18288" marB="18288">
+                    <a:solidFill>
+                      <a:srgbClr val="FFFFFF"/>
+                    </a:solidFill>
+                  </a:tcPr>
+                </a:tc>
+                <a:tc>
+                  <a:txBody>
+                    <a:bodyPr/>
+                    <a:lstStyle/>
+                    <a:p>
+                      <a:pPr algn="r"/>
+                      <a:r>
+                        <a:rPr sz="1000">
+                          <a:solidFill>
+                            <a:srgbClr val="3F3F3F"/>
+                          </a:solidFill>
+                          <a:latin typeface="Encode Sans"/>
+                        </a:rPr>
+                        <a:t>+6.2%</a:t>
+                      </a:r>
+                    </a:p>
+                  </a:txBody>
+                  <a:tcPr marL="36576" marR="36576" marT="18288" marB="18288">
+                    <a:solidFill>
+                      <a:srgbClr val="FFFFFF"/>
+                    </a:solidFill>
+                  </a:tcPr>
+                </a:tc>
+                <a:tc>
+                  <a:txBody>
+                    <a:bodyPr/>
+                    <a:lstStyle/>
+                    <a:p>
+                      <a:pPr algn="r"/>
+                      <a:r>
+                        <a:rPr sz="1000">
+                          <a:solidFill>
+                            <a:srgbClr val="3F3F3F"/>
+                          </a:solidFill>
+                          <a:latin typeface="Encode Sans"/>
+                        </a:rPr>
+                        <a:t>156,7</a:t>
+                      </a:r>
+                    </a:p>
+                  </a:txBody>
+                  <a:tcPr marL="36576" marR="36576" marT="18288" marB="18288">
+                    <a:solidFill>
+                      <a:srgbClr val="FFFFFF"/>
+                    </a:solidFill>
+                  </a:tcPr>
+                </a:tc>
+              </a:tr>
+              <a:tr h="292608">
+                <a:tc>
+                  <a:txBody>
+                    <a:bodyPr/>
+                    <a:lstStyle/>
+                    <a:p>
+                      <a:pPr algn="l"/>
+                      <a:r>
+                        <a:rPr sz="1000">
+                          <a:solidFill>
+                            <a:srgbClr val="3F3F3F"/>
+                          </a:solidFill>
+                          <a:latin typeface="Encode Sans"/>
+                        </a:rPr>
+                        <a:t>Febrero 2026</a:t>
+                      </a:r>
+                    </a:p>
+                  </a:txBody>
+                  <a:tcPr marL="36576" marR="36576" marT="18288" marB="18288">
+                    <a:solidFill>
+                      <a:srgbClr val="F8F8F6"/>
+                    </a:solidFill>
+                  </a:tcPr>
+                </a:tc>
+                <a:tc>
+                  <a:txBody>
+                    <a:bodyPr/>
+                    <a:lstStyle/>
+                    <a:p>
+                      <a:pPr algn="r"/>
+                      <a:r>
+                        <a:rPr sz="1000">
+                          <a:solidFill>
+                            <a:srgbClr val="3F3F3F"/>
+                          </a:solidFill>
+                          <a:latin typeface="Encode Sans"/>
+                        </a:rPr>
+                        <a:t>139,3</a:t>
+                      </a:r>
+                    </a:p>
+                  </a:txBody>
+                  <a:tcPr marL="36576" marR="36576" marT="18288" marB="18288">
+                    <a:solidFill>
+                      <a:srgbClr val="F8F8F6"/>
+                    </a:solidFill>
+                  </a:tcPr>
+                </a:tc>
+                <a:tc>
+                  <a:txBody>
+                    <a:bodyPr/>
+                    <a:lstStyle/>
+                    <a:p>
+                      <a:pPr algn="r"/>
+                      <a:r>
+                        <a:rPr sz="1000">
+                          <a:solidFill>
+                            <a:srgbClr val="3F3F3F"/>
+                          </a:solidFill>
+                          <a:latin typeface="Encode Sans"/>
+                        </a:rPr>
+                        <a:t>-1.5%</a:t>
+                      </a:r>
+                    </a:p>
+                  </a:txBody>
+                  <a:tcPr marL="36576" marR="36576" marT="18288" marB="18288">
+                    <a:solidFill>
+                      <a:srgbClr val="F8F8F6"/>
+                    </a:solidFill>
+                  </a:tcPr>
+                </a:tc>
+                <a:tc>
+                  <a:txBody>
+                    <a:bodyPr/>
+                    <a:lstStyle/>
+                    <a:p>
+                      <a:pPr algn="r"/>
+                      <a:r>
+                        <a:rPr sz="1000">
+                          <a:solidFill>
+                            <a:srgbClr val="3F3F3F"/>
+                          </a:solidFill>
+                          <a:latin typeface="Encode Sans"/>
+                        </a:rPr>
+                        <a:t>152,5</a:t>
+                      </a:r>
+                    </a:p>
+                  </a:txBody>
+                  <a:tcPr marL="36576" marR="36576" marT="18288" marB="18288">
+                    <a:solidFill>
+                      <a:srgbClr val="F8F8F6"/>
+                    </a:solidFill>
+                  </a:tcPr>
+                </a:tc>
+              </a:tr>
+              <a:tr h="292608">
+                <a:tc>
+                  <a:txBody>
+                    <a:bodyPr/>
+                    <a:lstStyle/>
+                    <a:p>
+                      <a:pPr algn="l"/>
+                      <a:r>
+                        <a:rPr sz="1000">
+                          <a:solidFill>
+                            <a:srgbClr val="3F3F3F"/>
+                          </a:solidFill>
+                          <a:latin typeface="Encode Sans"/>
+                        </a:rPr>
+                        <a:t>Enero 2026</a:t>
+                      </a:r>
+                    </a:p>
+                  </a:txBody>
+                  <a:tcPr marL="36576" marR="36576" marT="18288" marB="18288">
+                    <a:solidFill>
+                      <a:srgbClr val="FFFFFF"/>
+                    </a:solidFill>
+                  </a:tcPr>
+                </a:tc>
+                <a:tc>
+                  <a:txBody>
+                    <a:bodyPr/>
+                    <a:lstStyle/>
+                    <a:p>
+                      <a:pPr algn="r"/>
+                      <a:r>
+                        <a:rPr sz="1000">
+                          <a:solidFill>
+                            <a:srgbClr val="3F3F3F"/>
+                          </a:solidFill>
+                          <a:latin typeface="Encode Sans"/>
+                        </a:rPr>
+                        <a:t>149,4</a:t>
+                      </a:r>
+                    </a:p>
+                  </a:txBody>
+                  <a:tcPr marL="36576" marR="36576" marT="18288" marB="18288">
+                    <a:solidFill>
+                      <a:srgbClr val="FFFFFF"/>
+                    </a:solidFill>
+                  </a:tcPr>
+                </a:tc>
+                <a:tc>
+                  <a:txBody>
+                    <a:bodyPr/>
+                    <a:lstStyle/>
+                    <a:p>
+                      <a:pPr algn="r"/>
+                      <a:r>
+                        <a:rPr sz="1000">
+                          <a:solidFill>
+                            <a:srgbClr val="3F3F3F"/>
+                          </a:solidFill>
+                          <a:latin typeface="Encode Sans"/>
+                        </a:rPr>
+                        <a:t>+2.0%</a:t>
+                      </a:r>
+                    </a:p>
+                  </a:txBody>
+                  <a:tcPr marL="36576" marR="36576" marT="18288" marB="18288">
+                    <a:solidFill>
+                      <a:srgbClr val="FFFFFF"/>
+                    </a:solidFill>
+                  </a:tcPr>
+                </a:tc>
+                <a:tc>
+                  <a:txBody>
+                    <a:bodyPr/>
+                    <a:lstStyle/>
+                    <a:p>
+                      <a:pPr algn="r"/>
+                      <a:r>
+                        <a:rPr sz="1000">
+                          <a:solidFill>
+                            <a:srgbClr val="3F3F3F"/>
+                          </a:solidFill>
+                          <a:latin typeface="Encode Sans"/>
+                        </a:rPr>
+                        <a:t>156,3</a:t>
+                      </a:r>
+                    </a:p>
+                  </a:txBody>
+                  <a:tcPr marL="36576" marR="36576" marT="18288" marB="18288">
+                    <a:solidFill>
+                      <a:srgbClr val="FFFFFF"/>
+                    </a:solidFill>
+                  </a:tcPr>
+                </a:tc>
+              </a:tr>
+              <a:tr h="292608">
+                <a:tc>
+                  <a:txBody>
+                    <a:bodyPr/>
+                    <a:lstStyle/>
+                    <a:p>
+                      <a:pPr algn="l"/>
+                      <a:r>
+                        <a:rPr sz="1000">
+                          <a:solidFill>
+                            <a:srgbClr val="3F3F3F"/>
+                          </a:solidFill>
+                          <a:latin typeface="Encode Sans"/>
+                        </a:rPr>
+                        <a:t>Diciembre 2025</a:t>
+                      </a:r>
+                    </a:p>
+                  </a:txBody>
+                  <a:tcPr marL="36576" marR="36576" marT="18288" marB="18288">
+                    <a:solidFill>
+                      <a:srgbClr val="F8F8F6"/>
+                    </a:solidFill>
+                  </a:tcPr>
+                </a:tc>
+                <a:tc>
+                  <a:txBody>
+                    <a:bodyPr/>
+                    <a:lstStyle/>
+                    <a:p>
+                      <a:pPr algn="r"/>
+                      <a:r>
+                        <a:rPr sz="1000">
+                          <a:solidFill>
+                            <a:srgbClr val="3F3F3F"/>
+                          </a:solidFill>
+                          <a:latin typeface="Encode Sans"/>
+                        </a:rPr>
+                        <a:t>153,8</a:t>
+                      </a:r>
+                    </a:p>
+                  </a:txBody>
+                  <a:tcPr marL="36576" marR="36576" marT="18288" marB="18288">
+                    <a:solidFill>
+                      <a:srgbClr val="F8F8F6"/>
+                    </a:solidFill>
+                  </a:tcPr>
+                </a:tc>
+                <a:tc>
+                  <a:txBody>
+                    <a:bodyPr/>
+                    <a:lstStyle/>
+                    <a:p>
+                      <a:pPr algn="r"/>
+                      <a:r>
+                        <a:rPr sz="1000">
+                          <a:solidFill>
+                            <a:srgbClr val="3F3F3F"/>
+                          </a:solidFill>
+                          <a:latin typeface="Encode Sans"/>
+                        </a:rPr>
+                        <a:t>+3.5%</a:t>
+                      </a:r>
+                    </a:p>
+                  </a:txBody>
+                  <a:tcPr marL="36576" marR="36576" marT="18288" marB="18288">
+                    <a:solidFill>
+                      <a:srgbClr val="F8F8F6"/>
+                    </a:solidFill>
+                  </a:tcPr>
+                </a:tc>
+                <a:tc>
+                  <a:txBody>
+                    <a:bodyPr/>
+                    <a:lstStyle/>
+                    <a:p>
+                      <a:pPr algn="r"/>
+                      <a:r>
+                        <a:rPr sz="1000">
+                          <a:solidFill>
+                            <a:srgbClr val="3F3F3F"/>
+                          </a:solidFill>
+                          <a:latin typeface="Encode Sans"/>
+                        </a:rPr>
+                        <a:t>155,9</a:t>
+                      </a:r>
+                    </a:p>
+                  </a:txBody>
+                  <a:tcPr marL="36576" marR="36576" marT="18288" marB="18288">
+                    <a:solidFill>
+                      <a:srgbClr val="F8F8F6"/>
+                    </a:solidFill>
+                  </a:tcPr>
+                </a:tc>
+              </a:tr>
+            </a:tbl>
+          </a:graphicData>
+        </a:graphic>
+      </p:graphicFrame>
+      <p:sp>
+        <p:nvSpPr>
+          <p:cNvPr id="9" name="TextBox 8"/>
+          <p:cNvSpPr txBox="1"/>
+          <p:nvPr/>
+        </p:nvSpPr>
+        <p:spPr>
+          <a:xfrm>
+            <a:off x="411480" y="6492240"/>
+            <a:ext cx="11368735" cy="274320"/>
+          </a:xfrm>
+          <a:prstGeom prst="rect">
+            <a:avLst/>
+          </a:prstGeom>
+          <a:noFill/>
+        </p:spPr>
+        <p:txBody>
+          <a:bodyPr wrap="none">
+            <a:spAutoFit/>
+          </a:bodyPr>
+          <a:lstStyle/>
+          <a:p>
+            <a:r>
+              <a:rPr sz="1000" b="0" i="1">
+                <a:solidFill>
+                  <a:srgbClr val="6A6760"/>
+                </a:solidFill>
+                <a:latin typeface="Encode Sans"/>
+              </a:rPr>
+              <a:t>Fuente: elaboración propia en base a INDEC</a:t>
+            </a:r>
+          </a:p>
+        </p:txBody>
+      </p:sp>
+    </p:spTree>
+  </p:cSld>
+  <p:clrMapOvr>
+    <a:masterClrMapping/>
+  </p:clrMapOvr>
+</p:sld>
+</file>
+
 <file path=ppt/theme/theme1.xml><?xml version="1.0" encoding="utf-8"?>
 <a:theme xmlns:a="http://schemas.openxmlformats.org/drawingml/2006/main" name="Office Theme">
   <a:themeElements>

</xml_diff>

<commit_message>
data: update 2026-07-23 ( data.json despidos.json scraper/historical_despidos.json scraper/calendar_oficial.json publicaciones_semana.pptx rrii_brutas.xlsx)
</commit_message>
<xml_diff>
--- a/publicaciones_semana.pptx
+++ b/publicaciones_semana.pptx
@@ -8,6 +8,7 @@
     <p:sldId id="256" r:id="rId7"/>
     <p:sldId id="257" r:id="rId8"/>
     <p:sldId id="258" r:id="rId9"/>
+    <p:sldId id="259" r:id="rId10"/>
   </p:sldIdLst>
   <p:sldSz cx="12191695" cy="6858000" type="screen4x3"/>
   <p:notesSz cx="6858000" cy="9144000"/>
@@ -3273,7 +3274,7 @@
                 </a:solidFill>
                 <a:latin typeface="Encode Sans"/>
               </a:rPr>
-              <a:t>2 publicaciones · datos oficiales INDEC / BCRA / Hacienda</a:t>
+              <a:t>3 publicaciones · datos oficiales INDEC / BCRA / Hacienda</a:t>
             </a:r>
           </a:p>
         </p:txBody>
@@ -5269,6 +5270,1013 @@
                           <a:latin typeface="Encode Sans"/>
                         </a:rPr>
                         <a:t>155,9</a:t>
+                      </a:r>
+                    </a:p>
+                  </a:txBody>
+                  <a:tcPr marL="36576" marR="36576" marT="18288" marB="18288">
+                    <a:solidFill>
+                      <a:srgbClr val="F8F8F6"/>
+                    </a:solidFill>
+                  </a:tcPr>
+                </a:tc>
+              </a:tr>
+            </a:tbl>
+          </a:graphicData>
+        </a:graphic>
+      </p:graphicFrame>
+      <p:sp>
+        <p:nvSpPr>
+          <p:cNvPr id="9" name="TextBox 8"/>
+          <p:cNvSpPr txBox="1"/>
+          <p:nvPr/>
+        </p:nvSpPr>
+        <p:spPr>
+          <a:xfrm>
+            <a:off x="411480" y="6492240"/>
+            <a:ext cx="11368735" cy="274320"/>
+          </a:xfrm>
+          <a:prstGeom prst="rect">
+            <a:avLst/>
+          </a:prstGeom>
+          <a:noFill/>
+        </p:spPr>
+        <p:txBody>
+          <a:bodyPr wrap="none">
+            <a:spAutoFit/>
+          </a:bodyPr>
+          <a:lstStyle/>
+          <a:p>
+            <a:r>
+              <a:rPr sz="1000" b="0" i="1">
+                <a:solidFill>
+                  <a:srgbClr val="6A6760"/>
+                </a:solidFill>
+                <a:latin typeface="Encode Sans"/>
+              </a:rPr>
+              <a:t>Fuente: elaboración propia en base a INDEC</a:t>
+            </a:r>
+          </a:p>
+        </p:txBody>
+      </p:sp>
+    </p:spTree>
+  </p:cSld>
+  <p:clrMapOvr>
+    <a:masterClrMapping/>
+  </p:clrMapOvr>
+</p:sld>
+</file>
+
+<file path=ppt/slides/slide4.xml><?xml version="1.0" encoding="utf-8"?>
+<p:sld xmlns:a="http://schemas.openxmlformats.org/drawingml/2006/main" xmlns:p="http://schemas.openxmlformats.org/presentationml/2006/main" xmlns:r="http://schemas.openxmlformats.org/officeDocument/2006/relationships">
+  <p:cSld>
+    <p:spTree>
+      <p:nvGrpSpPr>
+        <p:cNvPr id="1" name=""/>
+        <p:cNvGrpSpPr/>
+        <p:nvPr/>
+      </p:nvGrpSpPr>
+      <p:grpSpPr/>
+      <p:sp>
+        <p:nvSpPr>
+          <p:cNvPr id="2" name="Rectangle 1"/>
+          <p:cNvSpPr/>
+          <p:nvPr/>
+        </p:nvSpPr>
+        <p:spPr>
+          <a:xfrm>
+            <a:off x="0" y="0"/>
+            <a:ext cx="12191695" cy="274320"/>
+          </a:xfrm>
+          <a:prstGeom prst="rect">
+            <a:avLst/>
+          </a:prstGeom>
+          <a:solidFill>
+            <a:srgbClr val="00B2C9"/>
+          </a:solidFill>
+          <a:ln>
+            <a:noFill/>
+          </a:ln>
+        </p:spPr>
+        <p:style>
+          <a:lnRef idx="1">
+            <a:schemeClr val="accent1"/>
+          </a:lnRef>
+          <a:fillRef idx="3">
+            <a:schemeClr val="accent1"/>
+          </a:fillRef>
+          <a:effectRef idx="2">
+            <a:schemeClr val="accent1"/>
+          </a:effectRef>
+          <a:fontRef idx="minor">
+            <a:schemeClr val="lt1"/>
+          </a:fontRef>
+        </p:style>
+        <p:txBody>
+          <a:bodyPr rtlCol="0" anchor="ctr"/>
+          <a:lstStyle/>
+          <a:p>
+            <a:pPr algn="ctr"/>
+          </a:p>
+        </p:txBody>
+      </p:sp>
+      <p:sp>
+        <p:nvSpPr>
+          <p:cNvPr id="3" name="TextBox 2"/>
+          <p:cNvSpPr txBox="1"/>
+          <p:nvPr/>
+        </p:nvSpPr>
+        <p:spPr>
+          <a:xfrm>
+            <a:off x="411480" y="457200"/>
+            <a:ext cx="11368735" cy="914400"/>
+          </a:xfrm>
+          <a:prstGeom prst="rect">
+            <a:avLst/>
+          </a:prstGeom>
+          <a:noFill/>
+        </p:spPr>
+        <p:txBody>
+          <a:bodyPr wrap="square" lIns="0" rIns="0">
+            <a:spAutoFit/>
+          </a:bodyPr>
+          <a:lstStyle/>
+          <a:p>
+            <a:pPr algn="l"/>
+            <a:r>
+              <a:rPr sz="2600" b="1" i="0">
+                <a:solidFill>
+                  <a:srgbClr val="00B2C9"/>
+                </a:solidFill>
+                <a:latin typeface="Encode Sans"/>
+              </a:rPr>
+              <a:t>SUPERMERCADOS MAYO 2026: VENTAS REALES CAYERON -0.7%</a:t>
+            </a:r>
+          </a:p>
+        </p:txBody>
+      </p:sp>
+      <p:sp>
+        <p:nvSpPr>
+          <p:cNvPr id="4" name="TextBox 3"/>
+          <p:cNvSpPr txBox="1"/>
+          <p:nvPr/>
+        </p:nvSpPr>
+        <p:spPr>
+          <a:xfrm>
+            <a:off x="411480" y="1280160"/>
+            <a:ext cx="11368735" cy="274320"/>
+          </a:xfrm>
+          <a:prstGeom prst="rect">
+            <a:avLst/>
+          </a:prstGeom>
+          <a:noFill/>
+        </p:spPr>
+        <p:txBody>
+          <a:bodyPr wrap="none">
+            <a:spAutoFit/>
+          </a:bodyPr>
+          <a:lstStyle/>
+          <a:p>
+            <a:r>
+              <a:rPr sz="1100" b="0" i="1">
+                <a:solidFill>
+                  <a:srgbClr val="6A6760"/>
+                </a:solidFill>
+                <a:latin typeface="Encode Sans"/>
+              </a:rPr>
+              <a:t>INDEC · período 2026-05</a:t>
+            </a:r>
+          </a:p>
+        </p:txBody>
+      </p:sp>
+      <p:sp>
+        <p:nvSpPr>
+          <p:cNvPr id="5" name="TextBox 4"/>
+          <p:cNvSpPr txBox="1"/>
+          <p:nvPr/>
+        </p:nvSpPr>
+        <p:spPr>
+          <a:xfrm>
+            <a:off x="411480" y="1691640"/>
+            <a:ext cx="5486400" cy="1645920"/>
+          </a:xfrm>
+          <a:prstGeom prst="rect">
+            <a:avLst/>
+          </a:prstGeom>
+          <a:noFill/>
+        </p:spPr>
+        <p:txBody>
+          <a:bodyPr wrap="square" lIns="0" rIns="0">
+            <a:spAutoFit/>
+          </a:bodyPr>
+          <a:lstStyle/>
+          <a:p>
+            <a:pPr algn="just"/>
+            <a:r>
+              <a:rPr sz="1300" b="0" i="0">
+                <a:solidFill>
+                  <a:srgbClr val="3F3F3F"/>
+                </a:solidFill>
+                <a:latin typeface="Encode Sans"/>
+              </a:rPr>
+              <a:t>Las ventas de supermercados a precios constantes registraron una variación interanual real de -0.7% en mayo 2026. Desestacionalizada: +0.9% m/m.</a:t>
+            </a:r>
+          </a:p>
+        </p:txBody>
+      </p:sp>
+      <p:sp>
+        <p:nvSpPr>
+          <p:cNvPr id="6" name="TextBox 5"/>
+          <p:cNvSpPr txBox="1"/>
+          <p:nvPr/>
+        </p:nvSpPr>
+        <p:spPr>
+          <a:xfrm>
+            <a:off x="411480" y="3520440"/>
+            <a:ext cx="5486400" cy="2743200"/>
+          </a:xfrm>
+          <a:prstGeom prst="rect">
+            <a:avLst/>
+          </a:prstGeom>
+          <a:noFill/>
+        </p:spPr>
+        <p:txBody>
+          <a:bodyPr wrap="square" lIns="0" rIns="0">
+            <a:spAutoFit/>
+          </a:bodyPr>
+          <a:lstStyle/>
+          <a:p>
+            <a:pPr algn="l">
+              <a:spcAft>
+                <a:spcPts val="800"/>
+              </a:spcAft>
+            </a:pPr>
+            <a:r>
+              <a:rPr sz="1300" b="1" i="0">
+                <a:solidFill>
+                  <a:srgbClr val="00B2C9"/>
+                </a:solidFill>
+                <a:latin typeface="Encode Sans"/>
+              </a:rPr>
+              <a:t>●  </a:t>
+            </a:r>
+            <a:r>
+              <a:rPr sz="1300" b="0" i="0">
+                <a:solidFill>
+                  <a:srgbClr val="3F3F3F"/>
+                </a:solidFill>
+                <a:latin typeface="Encode Sans"/>
+              </a:rPr>
+              <a:t>Variación interanual real: -0.7%</a:t>
+            </a:r>
+          </a:p>
+          <a:p>
+            <a:pPr algn="l">
+              <a:spcAft>
+                <a:spcPts val="800"/>
+              </a:spcAft>
+            </a:pPr>
+            <a:r>
+              <a:rPr sz="1300" b="1" i="0">
+                <a:solidFill>
+                  <a:srgbClr val="00B2C9"/>
+                </a:solidFill>
+                <a:latin typeface="Encode Sans"/>
+              </a:rPr>
+              <a:t>●  </a:t>
+            </a:r>
+            <a:r>
+              <a:rPr sz="1300" b="0" i="0">
+                <a:solidFill>
+                  <a:srgbClr val="3F3F3F"/>
+                </a:solidFill>
+                <a:latin typeface="Encode Sans"/>
+              </a:rPr>
+              <a:t>Variación mensual desestacionalizada: +0.9%</a:t>
+            </a:r>
+          </a:p>
+          <a:p>
+            <a:pPr algn="l">
+              <a:spcAft>
+                <a:spcPts val="800"/>
+              </a:spcAft>
+            </a:pPr>
+            <a:r>
+              <a:rPr sz="1300" b="1" i="0">
+                <a:solidFill>
+                  <a:srgbClr val="00B2C9"/>
+                </a:solidFill>
+                <a:latin typeface="Encode Sans"/>
+              </a:rPr>
+              <a:t>●  </a:t>
+            </a:r>
+            <a:r>
+              <a:rPr sz="1300" b="0" i="0">
+                <a:solidFill>
+                  <a:srgbClr val="3F3F3F"/>
+                </a:solidFill>
+                <a:latin typeface="Encode Sans"/>
+              </a:rPr>
+              <a:t>Acumulado del año: -2.8%</a:t>
+            </a:r>
+          </a:p>
+        </p:txBody>
+      </p:sp>
+      <p:pic>
+        <p:nvPicPr>
+          <p:cNvPr id="7" name="Picture 6" descr="image.png"/>
+          <p:cNvPicPr>
+            <a:picLocks noChangeAspect="1"/>
+          </p:cNvPicPr>
+          <p:nvPr/>
+        </p:nvPicPr>
+        <p:blipFill>
+          <a:blip r:embed="rId2"/>
+          <a:stretch>
+            <a:fillRect/>
+          </a:stretch>
+        </p:blipFill>
+        <p:spPr>
+          <a:xfrm>
+            <a:off x="6080760" y="1691640"/>
+            <a:ext cx="5669280" cy="2560320"/>
+          </a:xfrm>
+          <a:prstGeom prst="rect">
+            <a:avLst/>
+          </a:prstGeom>
+        </p:spPr>
+      </p:pic>
+      <p:graphicFrame>
+        <p:nvGraphicFramePr>
+          <p:cNvPr id="8" name="Table 7"/>
+          <p:cNvGraphicFramePr>
+            <a:graphicFrameLocks noGrp="1"/>
+          </p:cNvGraphicFramePr>
+          <p:nvPr/>
+        </p:nvGraphicFramePr>
+        <p:xfrm>
+          <a:off x="6080760" y="4434840"/>
+          <a:ext cx="5669280" cy="2048256"/>
+        </p:xfrm>
+        <a:graphic>
+          <a:graphicData uri="http://schemas.openxmlformats.org/drawingml/2006/table">
+            <a:tbl>
+              <a:tblPr firstRow="1" bandRow="1">
+                <a:tableStyleId>{5C22544A-7EE6-4342-B048-85BDC9FD1C3A}</a:tableStyleId>
+              </a:tblPr>
+              <a:tblGrid>
+                <a:gridCol w="1417320"/>
+                <a:gridCol w="1417320"/>
+                <a:gridCol w="1417320"/>
+                <a:gridCol w="1417320"/>
+              </a:tblGrid>
+              <a:tr h="292608">
+                <a:tc>
+                  <a:txBody>
+                    <a:bodyPr/>
+                    <a:lstStyle/>
+                    <a:p>
+                      <a:pPr algn="l"/>
+                      <a:r>
+                        <a:rPr sz="1000" b="1">
+                          <a:solidFill>
+                            <a:srgbClr val="FFFFFF"/>
+                          </a:solidFill>
+                          <a:latin typeface="Encode Sans"/>
+                        </a:rPr>
+                        <a:t>Mes</a:t>
+                      </a:r>
+                    </a:p>
+                  </a:txBody>
+                  <a:tcPr marL="36576" marR="36576" marT="18288" marB="18288">
+                    <a:solidFill>
+                      <a:srgbClr val="00B2C9"/>
+                    </a:solidFill>
+                  </a:tcPr>
+                </a:tc>
+                <a:tc>
+                  <a:txBody>
+                    <a:bodyPr/>
+                    <a:lstStyle/>
+                    <a:p>
+                      <a:pPr algn="r"/>
+                      <a:r>
+                        <a:rPr sz="1000" b="1">
+                          <a:solidFill>
+                            <a:srgbClr val="FFFFFF"/>
+                          </a:solidFill>
+                          <a:latin typeface="Encode Sans"/>
+                        </a:rPr>
+                        <a:t>Índice real</a:t>
+                      </a:r>
+                    </a:p>
+                  </a:txBody>
+                  <a:tcPr marL="36576" marR="36576" marT="18288" marB="18288">
+                    <a:solidFill>
+                      <a:srgbClr val="00B2C9"/>
+                    </a:solidFill>
+                  </a:tcPr>
+                </a:tc>
+                <a:tc>
+                  <a:txBody>
+                    <a:bodyPr/>
+                    <a:lstStyle/>
+                    <a:p>
+                      <a:pPr algn="r"/>
+                      <a:r>
+                        <a:rPr sz="1000" b="1">
+                          <a:solidFill>
+                            <a:srgbClr val="FFFFFF"/>
+                          </a:solidFill>
+                          <a:latin typeface="Encode Sans"/>
+                        </a:rPr>
+                        <a:t>VIA real %</a:t>
+                      </a:r>
+                    </a:p>
+                  </a:txBody>
+                  <a:tcPr marL="36576" marR="36576" marT="18288" marB="18288">
+                    <a:solidFill>
+                      <a:srgbClr val="00B2C9"/>
+                    </a:solidFill>
+                  </a:tcPr>
+                </a:tc>
+                <a:tc>
+                  <a:txBody>
+                    <a:bodyPr/>
+                    <a:lstStyle/>
+                    <a:p>
+                      <a:pPr algn="r"/>
+                      <a:r>
+                        <a:rPr sz="1000" b="1">
+                          <a:solidFill>
+                            <a:srgbClr val="FFFFFF"/>
+                          </a:solidFill>
+                          <a:latin typeface="Encode Sans"/>
+                        </a:rPr>
+                        <a:t>Acumulado %</a:t>
+                      </a:r>
+                    </a:p>
+                  </a:txBody>
+                  <a:tcPr marL="36576" marR="36576" marT="18288" marB="18288">
+                    <a:solidFill>
+                      <a:srgbClr val="00B2C9"/>
+                    </a:solidFill>
+                  </a:tcPr>
+                </a:tc>
+              </a:tr>
+              <a:tr h="292608">
+                <a:tc>
+                  <a:txBody>
+                    <a:bodyPr/>
+                    <a:lstStyle/>
+                    <a:p>
+                      <a:pPr algn="l"/>
+                      <a:r>
+                        <a:rPr sz="1000">
+                          <a:solidFill>
+                            <a:srgbClr val="3F3F3F"/>
+                          </a:solidFill>
+                          <a:latin typeface="Encode Sans"/>
+                        </a:rPr>
+                        <a:t>Mayo 2026</a:t>
+                      </a:r>
+                    </a:p>
+                  </a:txBody>
+                  <a:tcPr marL="36576" marR="36576" marT="18288" marB="18288">
+                    <a:solidFill>
+                      <a:srgbClr val="FFFFFF"/>
+                    </a:solidFill>
+                  </a:tcPr>
+                </a:tc>
+                <a:tc>
+                  <a:txBody>
+                    <a:bodyPr/>
+                    <a:lstStyle/>
+                    <a:p>
+                      <a:pPr algn="r"/>
+                      <a:r>
+                        <a:rPr sz="1000">
+                          <a:solidFill>
+                            <a:srgbClr val="3F3F3F"/>
+                          </a:solidFill>
+                          <a:latin typeface="Encode Sans"/>
+                        </a:rPr>
+                        <a:t>80,5</a:t>
+                      </a:r>
+                    </a:p>
+                  </a:txBody>
+                  <a:tcPr marL="36576" marR="36576" marT="18288" marB="18288">
+                    <a:solidFill>
+                      <a:srgbClr val="FFFFFF"/>
+                    </a:solidFill>
+                  </a:tcPr>
+                </a:tc>
+                <a:tc>
+                  <a:txBody>
+                    <a:bodyPr/>
+                    <a:lstStyle/>
+                    <a:p>
+                      <a:pPr algn="r"/>
+                      <a:r>
+                        <a:rPr sz="1000">
+                          <a:solidFill>
+                            <a:srgbClr val="3F3F3F"/>
+                          </a:solidFill>
+                          <a:latin typeface="Encode Sans"/>
+                        </a:rPr>
+                        <a:t>-0.7%</a:t>
+                      </a:r>
+                    </a:p>
+                  </a:txBody>
+                  <a:tcPr marL="36576" marR="36576" marT="18288" marB="18288">
+                    <a:solidFill>
+                      <a:srgbClr val="FFFFFF"/>
+                    </a:solidFill>
+                  </a:tcPr>
+                </a:tc>
+                <a:tc>
+                  <a:txBody>
+                    <a:bodyPr/>
+                    <a:lstStyle/>
+                    <a:p>
+                      <a:pPr algn="r"/>
+                      <a:r>
+                        <a:rPr sz="1000">
+                          <a:solidFill>
+                            <a:srgbClr val="3F3F3F"/>
+                          </a:solidFill>
+                          <a:latin typeface="Encode Sans"/>
+                        </a:rPr>
+                        <a:t>-2.8%</a:t>
+                      </a:r>
+                    </a:p>
+                  </a:txBody>
+                  <a:tcPr marL="36576" marR="36576" marT="18288" marB="18288">
+                    <a:solidFill>
+                      <a:srgbClr val="FFFFFF"/>
+                    </a:solidFill>
+                  </a:tcPr>
+                </a:tc>
+              </a:tr>
+              <a:tr h="292608">
+                <a:tc>
+                  <a:txBody>
+                    <a:bodyPr/>
+                    <a:lstStyle/>
+                    <a:p>
+                      <a:pPr algn="l"/>
+                      <a:r>
+                        <a:rPr sz="1000">
+                          <a:solidFill>
+                            <a:srgbClr val="3F3F3F"/>
+                          </a:solidFill>
+                          <a:latin typeface="Encode Sans"/>
+                        </a:rPr>
+                        <a:t>Abril 2026</a:t>
+                      </a:r>
+                    </a:p>
+                  </a:txBody>
+                  <a:tcPr marL="36576" marR="36576" marT="18288" marB="18288">
+                    <a:solidFill>
+                      <a:srgbClr val="F8F8F6"/>
+                    </a:solidFill>
+                  </a:tcPr>
+                </a:tc>
+                <a:tc>
+                  <a:txBody>
+                    <a:bodyPr/>
+                    <a:lstStyle/>
+                    <a:p>
+                      <a:pPr algn="r"/>
+                      <a:r>
+                        <a:rPr sz="1000">
+                          <a:solidFill>
+                            <a:srgbClr val="3F3F3F"/>
+                          </a:solidFill>
+                          <a:latin typeface="Encode Sans"/>
+                        </a:rPr>
+                        <a:t>78,5</a:t>
+                      </a:r>
+                    </a:p>
+                  </a:txBody>
+                  <a:tcPr marL="36576" marR="36576" marT="18288" marB="18288">
+                    <a:solidFill>
+                      <a:srgbClr val="F8F8F6"/>
+                    </a:solidFill>
+                  </a:tcPr>
+                </a:tc>
+                <a:tc>
+                  <a:txBody>
+                    <a:bodyPr/>
+                    <a:lstStyle/>
+                    <a:p>
+                      <a:pPr algn="r"/>
+                      <a:r>
+                        <a:rPr sz="1000">
+                          <a:solidFill>
+                            <a:srgbClr val="3F3F3F"/>
+                          </a:solidFill>
+                          <a:latin typeface="Encode Sans"/>
+                        </a:rPr>
+                        <a:t>-3.7%</a:t>
+                      </a:r>
+                    </a:p>
+                  </a:txBody>
+                  <a:tcPr marL="36576" marR="36576" marT="18288" marB="18288">
+                    <a:solidFill>
+                      <a:srgbClr val="F8F8F6"/>
+                    </a:solidFill>
+                  </a:tcPr>
+                </a:tc>
+                <a:tc>
+                  <a:txBody>
+                    <a:bodyPr/>
+                    <a:lstStyle/>
+                    <a:p>
+                      <a:pPr algn="r"/>
+                      <a:r>
+                        <a:rPr sz="1000">
+                          <a:solidFill>
+                            <a:srgbClr val="3F3F3F"/>
+                          </a:solidFill>
+                          <a:latin typeface="Encode Sans"/>
+                        </a:rPr>
+                        <a:t>-3.3%</a:t>
+                      </a:r>
+                    </a:p>
+                  </a:txBody>
+                  <a:tcPr marL="36576" marR="36576" marT="18288" marB="18288">
+                    <a:solidFill>
+                      <a:srgbClr val="F8F8F6"/>
+                    </a:solidFill>
+                  </a:tcPr>
+                </a:tc>
+              </a:tr>
+              <a:tr h="292608">
+                <a:tc>
+                  <a:txBody>
+                    <a:bodyPr/>
+                    <a:lstStyle/>
+                    <a:p>
+                      <a:pPr algn="l"/>
+                      <a:r>
+                        <a:rPr sz="1000">
+                          <a:solidFill>
+                            <a:srgbClr val="3F3F3F"/>
+                          </a:solidFill>
+                          <a:latin typeface="Encode Sans"/>
+                        </a:rPr>
+                        <a:t>Marzo 2026</a:t>
+                      </a:r>
+                    </a:p>
+                  </a:txBody>
+                  <a:tcPr marL="36576" marR="36576" marT="18288" marB="18288">
+                    <a:solidFill>
+                      <a:srgbClr val="FFFFFF"/>
+                    </a:solidFill>
+                  </a:tcPr>
+                </a:tc>
+                <a:tc>
+                  <a:txBody>
+                    <a:bodyPr/>
+                    <a:lstStyle/>
+                    <a:p>
+                      <a:pPr algn="r"/>
+                      <a:r>
+                        <a:rPr sz="1000">
+                          <a:solidFill>
+                            <a:srgbClr val="3F3F3F"/>
+                          </a:solidFill>
+                          <a:latin typeface="Encode Sans"/>
+                        </a:rPr>
+                        <a:t>82,4</a:t>
+                      </a:r>
+                    </a:p>
+                  </a:txBody>
+                  <a:tcPr marL="36576" marR="36576" marT="18288" marB="18288">
+                    <a:solidFill>
+                      <a:srgbClr val="FFFFFF"/>
+                    </a:solidFill>
+                  </a:tcPr>
+                </a:tc>
+                <a:tc>
+                  <a:txBody>
+                    <a:bodyPr/>
+                    <a:lstStyle/>
+                    <a:p>
+                      <a:pPr algn="r"/>
+                      <a:r>
+                        <a:rPr sz="1000">
+                          <a:solidFill>
+                            <a:srgbClr val="3F3F3F"/>
+                          </a:solidFill>
+                          <a:latin typeface="Encode Sans"/>
+                        </a:rPr>
+                        <a:t>-5.1%</a:t>
+                      </a:r>
+                    </a:p>
+                  </a:txBody>
+                  <a:tcPr marL="36576" marR="36576" marT="18288" marB="18288">
+                    <a:solidFill>
+                      <a:srgbClr val="FFFFFF"/>
+                    </a:solidFill>
+                  </a:tcPr>
+                </a:tc>
+                <a:tc>
+                  <a:txBody>
+                    <a:bodyPr/>
+                    <a:lstStyle/>
+                    <a:p>
+                      <a:pPr algn="r"/>
+                      <a:r>
+                        <a:rPr sz="1000">
+                          <a:solidFill>
+                            <a:srgbClr val="3F3F3F"/>
+                          </a:solidFill>
+                          <a:latin typeface="Encode Sans"/>
+                        </a:rPr>
+                        <a:t>-3.1%</a:t>
+                      </a:r>
+                    </a:p>
+                  </a:txBody>
+                  <a:tcPr marL="36576" marR="36576" marT="18288" marB="18288">
+                    <a:solidFill>
+                      <a:srgbClr val="FFFFFF"/>
+                    </a:solidFill>
+                  </a:tcPr>
+                </a:tc>
+              </a:tr>
+              <a:tr h="292608">
+                <a:tc>
+                  <a:txBody>
+                    <a:bodyPr/>
+                    <a:lstStyle/>
+                    <a:p>
+                      <a:pPr algn="l"/>
+                      <a:r>
+                        <a:rPr sz="1000">
+                          <a:solidFill>
+                            <a:srgbClr val="3F3F3F"/>
+                          </a:solidFill>
+                          <a:latin typeface="Encode Sans"/>
+                        </a:rPr>
+                        <a:t>Febrero 2026</a:t>
+                      </a:r>
+                    </a:p>
+                  </a:txBody>
+                  <a:tcPr marL="36576" marR="36576" marT="18288" marB="18288">
+                    <a:solidFill>
+                      <a:srgbClr val="F8F8F6"/>
+                    </a:solidFill>
+                  </a:tcPr>
+                </a:tc>
+                <a:tc>
+                  <a:txBody>
+                    <a:bodyPr/>
+                    <a:lstStyle/>
+                    <a:p>
+                      <a:pPr algn="r"/>
+                      <a:r>
+                        <a:rPr sz="1000">
+                          <a:solidFill>
+                            <a:srgbClr val="3F3F3F"/>
+                          </a:solidFill>
+                          <a:latin typeface="Encode Sans"/>
+                        </a:rPr>
+                        <a:t>76,0</a:t>
+                      </a:r>
+                    </a:p>
+                  </a:txBody>
+                  <a:tcPr marL="36576" marR="36576" marT="18288" marB="18288">
+                    <a:solidFill>
+                      <a:srgbClr val="F8F8F6"/>
+                    </a:solidFill>
+                  </a:tcPr>
+                </a:tc>
+                <a:tc>
+                  <a:txBody>
+                    <a:bodyPr/>
+                    <a:lstStyle/>
+                    <a:p>
+                      <a:pPr algn="r"/>
+                      <a:r>
+                        <a:rPr sz="1000">
+                          <a:solidFill>
+                            <a:srgbClr val="3F3F3F"/>
+                          </a:solidFill>
+                          <a:latin typeface="Encode Sans"/>
+                        </a:rPr>
+                        <a:t>-3.1%</a:t>
+                      </a:r>
+                    </a:p>
+                  </a:txBody>
+                  <a:tcPr marL="36576" marR="36576" marT="18288" marB="18288">
+                    <a:solidFill>
+                      <a:srgbClr val="F8F8F6"/>
+                    </a:solidFill>
+                  </a:tcPr>
+                </a:tc>
+                <a:tc>
+                  <a:txBody>
+                    <a:bodyPr/>
+                    <a:lstStyle/>
+                    <a:p>
+                      <a:pPr algn="r"/>
+                      <a:r>
+                        <a:rPr sz="1000">
+                          <a:solidFill>
+                            <a:srgbClr val="3F3F3F"/>
+                          </a:solidFill>
+                          <a:latin typeface="Encode Sans"/>
+                        </a:rPr>
+                        <a:t>-2.1%</a:t>
+                      </a:r>
+                    </a:p>
+                  </a:txBody>
+                  <a:tcPr marL="36576" marR="36576" marT="18288" marB="18288">
+                    <a:solidFill>
+                      <a:srgbClr val="F8F8F6"/>
+                    </a:solidFill>
+                  </a:tcPr>
+                </a:tc>
+              </a:tr>
+              <a:tr h="292608">
+                <a:tc>
+                  <a:txBody>
+                    <a:bodyPr/>
+                    <a:lstStyle/>
+                    <a:p>
+                      <a:pPr algn="l"/>
+                      <a:r>
+                        <a:rPr sz="1000">
+                          <a:solidFill>
+                            <a:srgbClr val="3F3F3F"/>
+                          </a:solidFill>
+                          <a:latin typeface="Encode Sans"/>
+                        </a:rPr>
+                        <a:t>Enero 2026</a:t>
+                      </a:r>
+                    </a:p>
+                  </a:txBody>
+                  <a:tcPr marL="36576" marR="36576" marT="18288" marB="18288">
+                    <a:solidFill>
+                      <a:srgbClr val="FFFFFF"/>
+                    </a:solidFill>
+                  </a:tcPr>
+                </a:tc>
+                <a:tc>
+                  <a:txBody>
+                    <a:bodyPr/>
+                    <a:lstStyle/>
+                    <a:p>
+                      <a:pPr algn="r"/>
+                      <a:r>
+                        <a:rPr sz="1000">
+                          <a:solidFill>
+                            <a:srgbClr val="3F3F3F"/>
+                          </a:solidFill>
+                          <a:latin typeface="Encode Sans"/>
+                        </a:rPr>
+                        <a:t>82,8</a:t>
+                      </a:r>
+                    </a:p>
+                  </a:txBody>
+                  <a:tcPr marL="36576" marR="36576" marT="18288" marB="18288">
+                    <a:solidFill>
+                      <a:srgbClr val="FFFFFF"/>
+                    </a:solidFill>
+                  </a:tcPr>
+                </a:tc>
+                <a:tc>
+                  <a:txBody>
+                    <a:bodyPr/>
+                    <a:lstStyle/>
+                    <a:p>
+                      <a:pPr algn="r"/>
+                      <a:r>
+                        <a:rPr sz="1000">
+                          <a:solidFill>
+                            <a:srgbClr val="3F3F3F"/>
+                          </a:solidFill>
+                          <a:latin typeface="Encode Sans"/>
+                        </a:rPr>
+                        <a:t>-1.2%</a:t>
+                      </a:r>
+                    </a:p>
+                  </a:txBody>
+                  <a:tcPr marL="36576" marR="36576" marT="18288" marB="18288">
+                    <a:solidFill>
+                      <a:srgbClr val="FFFFFF"/>
+                    </a:solidFill>
+                  </a:tcPr>
+                </a:tc>
+                <a:tc>
+                  <a:txBody>
+                    <a:bodyPr/>
+                    <a:lstStyle/>
+                    <a:p>
+                      <a:pPr algn="r"/>
+                      <a:r>
+                        <a:rPr sz="1000">
+                          <a:solidFill>
+                            <a:srgbClr val="3F3F3F"/>
+                          </a:solidFill>
+                          <a:latin typeface="Encode Sans"/>
+                        </a:rPr>
+                        <a:t>-1.2%</a:t>
+                      </a:r>
+                    </a:p>
+                  </a:txBody>
+                  <a:tcPr marL="36576" marR="36576" marT="18288" marB="18288">
+                    <a:solidFill>
+                      <a:srgbClr val="FFFFFF"/>
+                    </a:solidFill>
+                  </a:tcPr>
+                </a:tc>
+              </a:tr>
+              <a:tr h="292608">
+                <a:tc>
+                  <a:txBody>
+                    <a:bodyPr/>
+                    <a:lstStyle/>
+                    <a:p>
+                      <a:pPr algn="l"/>
+                      <a:r>
+                        <a:rPr sz="1000">
+                          <a:solidFill>
+                            <a:srgbClr val="3F3F3F"/>
+                          </a:solidFill>
+                          <a:latin typeface="Encode Sans"/>
+                        </a:rPr>
+                        <a:t>Diciembre 2025</a:t>
+                      </a:r>
+                    </a:p>
+                  </a:txBody>
+                  <a:tcPr marL="36576" marR="36576" marT="18288" marB="18288">
+                    <a:solidFill>
+                      <a:srgbClr val="F8F8F6"/>
+                    </a:solidFill>
+                  </a:tcPr>
+                </a:tc>
+                <a:tc>
+                  <a:txBody>
+                    <a:bodyPr/>
+                    <a:lstStyle/>
+                    <a:p>
+                      <a:pPr algn="r"/>
+                      <a:r>
+                        <a:rPr sz="1000">
+                          <a:solidFill>
+                            <a:srgbClr val="3F3F3F"/>
+                          </a:solidFill>
+                          <a:latin typeface="Encode Sans"/>
+                        </a:rPr>
+                        <a:t>102,3</a:t>
+                      </a:r>
+                    </a:p>
+                  </a:txBody>
+                  <a:tcPr marL="36576" marR="36576" marT="18288" marB="18288">
+                    <a:solidFill>
+                      <a:srgbClr val="F8F8F6"/>
+                    </a:solidFill>
+                  </a:tcPr>
+                </a:tc>
+                <a:tc>
+                  <a:txBody>
+                    <a:bodyPr/>
+                    <a:lstStyle/>
+                    <a:p>
+                      <a:pPr algn="r"/>
+                      <a:r>
+                        <a:rPr sz="1000">
+                          <a:solidFill>
+                            <a:srgbClr val="3F3F3F"/>
+                          </a:solidFill>
+                          <a:latin typeface="Encode Sans"/>
+                        </a:rPr>
+                        <a:t>+0.5%</a:t>
+                      </a:r>
+                    </a:p>
+                  </a:txBody>
+                  <a:tcPr marL="36576" marR="36576" marT="18288" marB="18288">
+                    <a:solidFill>
+                      <a:srgbClr val="F8F8F6"/>
+                    </a:solidFill>
+                  </a:tcPr>
+                </a:tc>
+                <a:tc>
+                  <a:txBody>
+                    <a:bodyPr/>
+                    <a:lstStyle/>
+                    <a:p>
+                      <a:pPr algn="r"/>
+                      <a:r>
+                        <a:rPr sz="1000">
+                          <a:solidFill>
+                            <a:srgbClr val="3F3F3F"/>
+                          </a:solidFill>
+                          <a:latin typeface="Encode Sans"/>
+                        </a:rPr>
+                        <a:t>+2.0%</a:t>
                       </a:r>
                     </a:p>
                   </a:txBody>

</xml_diff>

<commit_message>
data: update 2026-07-27 ( data.json despidos.json scraper/historical_despidos.json publicaciones_semana.pptx rrii_brutas.xlsx)
</commit_message>
<xml_diff>
--- a/publicaciones_semana.pptx
+++ b/publicaciones_semana.pptx
@@ -7,8 +7,6 @@
   <p:sldIdLst>
     <p:sldId id="256" r:id="rId7"/>
     <p:sldId id="257" r:id="rId8"/>
-    <p:sldId id="258" r:id="rId9"/>
-    <p:sldId id="259" r:id="rId10"/>
   </p:sldIdLst>
   <p:sldSz cx="12191695" cy="6858000" type="screen4x3"/>
   <p:notesSz cx="6858000" cy="9144000"/>
@@ -3240,7 +3238,7 @@
                 </a:solidFill>
                 <a:latin typeface="Encode Sans"/>
               </a:rPr>
-              <a:t>Publicaciones de la semana del 20 de julio de 2026</a:t>
+              <a:t>Publicaciones de la semana del 27 de julio de 2026</a:t>
             </a:r>
           </a:p>
         </p:txBody>
@@ -3274,7 +3272,7 @@
                 </a:solidFill>
                 <a:latin typeface="Encode Sans"/>
               </a:rPr>
-              <a:t>3 publicaciones · datos oficiales INDEC / BCRA / Hacienda</a:t>
+              <a:t>1 publicaciones · datos oficiales INDEC / BCRA / Hacienda</a:t>
             </a:r>
           </a:p>
         </p:txBody>
@@ -3370,7 +3368,7 @@
                 </a:solidFill>
                 <a:latin typeface="Encode Sans"/>
               </a:rPr>
-              <a:t>SALARIOS MAYO 2026: ÍNDICE TOTAL REGISTRADO 8.788</a:t>
+              <a:t>TURISMO INTERNACIONAL JUNIO 2026: SALDO -172.741 PERSONAS</a:t>
             </a:r>
           </a:p>
         </p:txBody>
@@ -3404,7 +3402,7 @@
                 </a:solidFill>
                 <a:latin typeface="Encode Sans"/>
               </a:rPr>
-              <a:t>INDEC · período 2026-05</a:t>
+              <a:t>INDEC · período 2026-06</a:t>
             </a:r>
           </a:p>
         </p:txBody>
@@ -3439,7 +3437,7 @@
                 </a:solidFill>
                 <a:latin typeface="Encode Sans"/>
               </a:rPr>
-              <a:t>El Índice de Salarios INDEC alcanzó 8.788 para el sector registrado en mayo 2026. Privado registrado: 9.479. Público: 7.628.</a:t>
+              <a:t>En junio 2026 ingresaron 329.177 turistas no residentes y salieron 501.918 argentinos al exterior, con saldo de -172.741 personas. Receptivo +3.3% i.a., emisivo -22.0% i.a.</a:t>
             </a:r>
           </a:p>
         </p:txBody>
@@ -3487,7 +3485,7 @@
                 </a:solidFill>
                 <a:latin typeface="Encode Sans"/>
               </a:rPr>
-              <a:t>Total registrado: 8.788</a:t>
+              <a:t>Receptivo: 329.177 personas</a:t>
             </a:r>
           </a:p>
           <a:p>
@@ -3512,7 +3510,7 @@
                 </a:solidFill>
                 <a:latin typeface="Encode Sans"/>
               </a:rPr>
-              <a:t>Privado registrado: 9.479</a:t>
+              <a:t>Emisivo: 501.918 personas</a:t>
             </a:r>
           </a:p>
           <a:p>
@@ -3537,7 +3535,7 @@
                 </a:solidFill>
                 <a:latin typeface="Encode Sans"/>
               </a:rPr>
-              <a:t>Sector público: 7.628</a:t>
+              <a:t>Saldo (receptivo − emisivo): -172.741 personas</a:t>
             </a:r>
           </a:p>
           <a:p>
@@ -3562,7 +3560,7 @@
                 </a:solidFill>
                 <a:latin typeface="Encode Sans"/>
               </a:rPr>
-              <a:t>No registrado: 10.744</a:t>
+              <a:t>Fuente: INDEC, Estadísticas de Turismo Internacional (todas las vías)</a:t>
             </a:r>
           </a:p>
         </p:txBody>
@@ -3652,7 +3650,7 @@
                           </a:solidFill>
                           <a:latin typeface="Encode Sans"/>
                         </a:rPr>
-                        <a:t>Total reg.</a:t>
+                        <a:t>Receptivo</a:t>
                       </a:r>
                     </a:p>
                   </a:txBody>
@@ -3675,7 +3673,7 @@
                           </a:solidFill>
                           <a:latin typeface="Encode Sans"/>
                         </a:rPr>
-                        <a:t>Privado</a:t>
+                        <a:t>Emisivo</a:t>
                       </a:r>
                     </a:p>
                   </a:txBody>
@@ -3698,7 +3696,7 @@
                           </a:solidFill>
                           <a:latin typeface="Encode Sans"/>
                         </a:rPr>
-                        <a:t>Público</a:t>
+                        <a:t>Saldo</a:t>
                       </a:r>
                     </a:p>
                   </a:txBody>
@@ -3723,7 +3721,7 @@
                           </a:solidFill>
                           <a:latin typeface="Encode Sans"/>
                         </a:rPr>
-                        <a:t>Mayo 2026</a:t>
+                        <a:t>Junio 2026</a:t>
                       </a:r>
                     </a:p>
                   </a:txBody>
@@ -3746,7 +3744,7 @@
                           </a:solidFill>
                           <a:latin typeface="Encode Sans"/>
                         </a:rPr>
-                        <a:t>8.788</a:t>
+                        <a:t>329.177</a:t>
                       </a:r>
                     </a:p>
                   </a:txBody>
@@ -3769,7 +3767,7 @@
                           </a:solidFill>
                           <a:latin typeface="Encode Sans"/>
                         </a:rPr>
-                        <a:t>9.479</a:t>
+                        <a:t>501.918</a:t>
                       </a:r>
                     </a:p>
                   </a:txBody>
@@ -3792,7 +3790,7 @@
                           </a:solidFill>
                           <a:latin typeface="Encode Sans"/>
                         </a:rPr>
-                        <a:t>7.628</a:t>
+                        <a:t>-172.741</a:t>
                       </a:r>
                     </a:p>
                   </a:txBody>
@@ -3817,7 +3815,7 @@
                           </a:solidFill>
                           <a:latin typeface="Encode Sans"/>
                         </a:rPr>
-                        <a:t>Abril 2026</a:t>
+                        <a:t>Mayo 2026</a:t>
                       </a:r>
                     </a:p>
                   </a:txBody>
@@ -3840,7 +3838,7 @@
                           </a:solidFill>
                           <a:latin typeface="Encode Sans"/>
                         </a:rPr>
-                        <a:t>8.629</a:t>
+                        <a:t>379.860</a:t>
                       </a:r>
                     </a:p>
                   </a:txBody>
@@ -3863,7 +3861,7 @@
                           </a:solidFill>
                           <a:latin typeface="Encode Sans"/>
                         </a:rPr>
-                        <a:t>9.293</a:t>
+                        <a:t>661.853</a:t>
                       </a:r>
                     </a:p>
                   </a:txBody>
@@ -3886,7 +3884,7 @@
                           </a:solidFill>
                           <a:latin typeface="Encode Sans"/>
                         </a:rPr>
-                        <a:t>7.515</a:t>
+                        <a:t>-281.993</a:t>
                       </a:r>
                     </a:p>
                   </a:txBody>
@@ -3911,7 +3909,7 @@
                           </a:solidFill>
                           <a:latin typeface="Encode Sans"/>
                         </a:rPr>
-                        <a:t>Marzo 2026</a:t>
+                        <a:t>Abril 2026</a:t>
                       </a:r>
                     </a:p>
                   </a:txBody>
@@ -3934,7 +3932,7 @@
                           </a:solidFill>
                           <a:latin typeface="Encode Sans"/>
                         </a:rPr>
-                        <a:t>8.341</a:t>
+                        <a:t>463.072</a:t>
                       </a:r>
                     </a:p>
                   </a:txBody>
@@ -3957,7 +3955,7 @@
                           </a:solidFill>
                           <a:latin typeface="Encode Sans"/>
                         </a:rPr>
-                        <a:t>8.935</a:t>
+                        <a:t>764.757</a:t>
                       </a:r>
                     </a:p>
                   </a:txBody>
@@ -3980,7 +3978,7 @@
                           </a:solidFill>
                           <a:latin typeface="Encode Sans"/>
                         </a:rPr>
-                        <a:t>7.344</a:t>
+                        <a:t>-301.685</a:t>
                       </a:r>
                     </a:p>
                   </a:txBody>
@@ -4005,7 +4003,7 @@
                           </a:solidFill>
                           <a:latin typeface="Encode Sans"/>
                         </a:rPr>
-                        <a:t>Febrero 2026</a:t>
+                        <a:t>Marzo 2026</a:t>
                       </a:r>
                     </a:p>
                   </a:txBody>
@@ -4028,7 +4026,7 @@
                           </a:solidFill>
                           <a:latin typeface="Encode Sans"/>
                         </a:rPr>
-                        <a:t>8.096</a:t>
+                        <a:t>509.625</a:t>
                       </a:r>
                     </a:p>
                   </a:txBody>
@@ -4051,7 +4049,7 @@
                           </a:solidFill>
                           <a:latin typeface="Encode Sans"/>
                         </a:rPr>
-                        <a:t>8.755</a:t>
+                        <a:t>1.061.777</a:t>
                       </a:r>
                     </a:p>
                   </a:txBody>
@@ -4074,7 +4072,7 @@
                           </a:solidFill>
                           <a:latin typeface="Encode Sans"/>
                         </a:rPr>
-                        <a:t>6.991</a:t>
+                        <a:t>-552.152</a:t>
                       </a:r>
                     </a:p>
                   </a:txBody>
@@ -4099,7 +4097,7 @@
                           </a:solidFill>
                           <a:latin typeface="Encode Sans"/>
                         </a:rPr>
-                        <a:t>Enero 2026</a:t>
+                        <a:t>Febrero 2026</a:t>
                       </a:r>
                     </a:p>
                   </a:txBody>
@@ -4122,7 +4120,7 @@
                           </a:solidFill>
                           <a:latin typeface="Encode Sans"/>
                         </a:rPr>
-                        <a:t>7.953</a:t>
+                        <a:t>534.223</a:t>
                       </a:r>
                     </a:p>
                   </a:txBody>
@@ -4145,7 +4143,7 @@
                           </a:solidFill>
                           <a:latin typeface="Encode Sans"/>
                         </a:rPr>
-                        <a:t>8.621</a:t>
+                        <a:t>1.629.180</a:t>
                       </a:r>
                     </a:p>
                   </a:txBody>
@@ -4168,7 +4166,7 @@
                           </a:solidFill>
                           <a:latin typeface="Encode Sans"/>
                         </a:rPr>
-                        <a:t>6.832</a:t>
+                        <a:t>-1.094.957</a:t>
                       </a:r>
                     </a:p>
                   </a:txBody>
@@ -4193,7 +4191,7 @@
                           </a:solidFill>
                           <a:latin typeface="Encode Sans"/>
                         </a:rPr>
-                        <a:t>Diciembre 2025</a:t>
+                        <a:t>Enero 2026</a:t>
                       </a:r>
                     </a:p>
                   </a:txBody>
@@ -4216,7 +4214,7 @@
                           </a:solidFill>
                           <a:latin typeface="Encode Sans"/>
                         </a:rPr>
-                        <a:t>7.795</a:t>
+                        <a:t>681.956</a:t>
                       </a:r>
                     </a:p>
                   </a:txBody>
@@ -4239,7 +4237,7 @@
                           </a:solidFill>
                           <a:latin typeface="Encode Sans"/>
                         </a:rPr>
-                        <a:t>8.441</a:t>
+                        <a:t>1.764.091</a:t>
                       </a:r>
                     </a:p>
                   </a:txBody>
@@ -4262,2021 +4260,7 @@
                           </a:solidFill>
                           <a:latin typeface="Encode Sans"/>
                         </a:rPr>
-                        <a:t>6.711</a:t>
-                      </a:r>
-                    </a:p>
-                  </a:txBody>
-                  <a:tcPr marL="36576" marR="36576" marT="18288" marB="18288">
-                    <a:solidFill>
-                      <a:srgbClr val="F8F8F6"/>
-                    </a:solidFill>
-                  </a:tcPr>
-                </a:tc>
-              </a:tr>
-            </a:tbl>
-          </a:graphicData>
-        </a:graphic>
-      </p:graphicFrame>
-      <p:sp>
-        <p:nvSpPr>
-          <p:cNvPr id="9" name="TextBox 8"/>
-          <p:cNvSpPr txBox="1"/>
-          <p:nvPr/>
-        </p:nvSpPr>
-        <p:spPr>
-          <a:xfrm>
-            <a:off x="411480" y="6492240"/>
-            <a:ext cx="11368735" cy="274320"/>
-          </a:xfrm>
-          <a:prstGeom prst="rect">
-            <a:avLst/>
-          </a:prstGeom>
-          <a:noFill/>
-        </p:spPr>
-        <p:txBody>
-          <a:bodyPr wrap="none">
-            <a:spAutoFit/>
-          </a:bodyPr>
-          <a:lstStyle/>
-          <a:p>
-            <a:r>
-              <a:rPr sz="1000" b="0" i="1">
-                <a:solidFill>
-                  <a:srgbClr val="6A6760"/>
-                </a:solidFill>
-                <a:latin typeface="Encode Sans"/>
-              </a:rPr>
-              <a:t>Fuente: elaboración propia en base a INDEC</a:t>
-            </a:r>
-          </a:p>
-        </p:txBody>
-      </p:sp>
-    </p:spTree>
-  </p:cSld>
-  <p:clrMapOvr>
-    <a:masterClrMapping/>
-  </p:clrMapOvr>
-</p:sld>
-</file>
-
-<file path=ppt/slides/slide3.xml><?xml version="1.0" encoding="utf-8"?>
-<p:sld xmlns:a="http://schemas.openxmlformats.org/drawingml/2006/main" xmlns:p="http://schemas.openxmlformats.org/presentationml/2006/main" xmlns:r="http://schemas.openxmlformats.org/officeDocument/2006/relationships">
-  <p:cSld>
-    <p:spTree>
-      <p:nvGrpSpPr>
-        <p:cNvPr id="1" name=""/>
-        <p:cNvGrpSpPr/>
-        <p:nvPr/>
-      </p:nvGrpSpPr>
-      <p:grpSpPr/>
-      <p:sp>
-        <p:nvSpPr>
-          <p:cNvPr id="2" name="Rectangle 1"/>
-          <p:cNvSpPr/>
-          <p:nvPr/>
-        </p:nvSpPr>
-        <p:spPr>
-          <a:xfrm>
-            <a:off x="0" y="0"/>
-            <a:ext cx="12191695" cy="274320"/>
-          </a:xfrm>
-          <a:prstGeom prst="rect">
-            <a:avLst/>
-          </a:prstGeom>
-          <a:solidFill>
-            <a:srgbClr val="00B2C9"/>
-          </a:solidFill>
-          <a:ln>
-            <a:noFill/>
-          </a:ln>
-        </p:spPr>
-        <p:style>
-          <a:lnRef idx="1">
-            <a:schemeClr val="accent1"/>
-          </a:lnRef>
-          <a:fillRef idx="3">
-            <a:schemeClr val="accent1"/>
-          </a:fillRef>
-          <a:effectRef idx="2">
-            <a:schemeClr val="accent1"/>
-          </a:effectRef>
-          <a:fontRef idx="minor">
-            <a:schemeClr val="lt1"/>
-          </a:fontRef>
-        </p:style>
-        <p:txBody>
-          <a:bodyPr rtlCol="0" anchor="ctr"/>
-          <a:lstStyle/>
-          <a:p>
-            <a:pPr algn="ctr"/>
-          </a:p>
-        </p:txBody>
-      </p:sp>
-      <p:sp>
-        <p:nvSpPr>
-          <p:cNvPr id="3" name="TextBox 2"/>
-          <p:cNvSpPr txBox="1"/>
-          <p:nvPr/>
-        </p:nvSpPr>
-        <p:spPr>
-          <a:xfrm>
-            <a:off x="411480" y="457200"/>
-            <a:ext cx="11368735" cy="914400"/>
-          </a:xfrm>
-          <a:prstGeom prst="rect">
-            <a:avLst/>
-          </a:prstGeom>
-          <a:noFill/>
-        </p:spPr>
-        <p:txBody>
-          <a:bodyPr wrap="square" lIns="0" rIns="0">
-            <a:spAutoFit/>
-          </a:bodyPr>
-          <a:lstStyle/>
-          <a:p>
-            <a:pPr algn="l"/>
-            <a:r>
-              <a:rPr sz="2600" b="1" i="0">
-                <a:solidFill>
-                  <a:srgbClr val="00B2C9"/>
-                </a:solidFill>
-                <a:latin typeface="Encode Sans"/>
-              </a:rPr>
-              <a:t>EMAE MAYO 2026: ACTIVIDAD CRECIÓ +0.2% I.A.</a:t>
-            </a:r>
-          </a:p>
-        </p:txBody>
-      </p:sp>
-      <p:sp>
-        <p:nvSpPr>
-          <p:cNvPr id="4" name="TextBox 3"/>
-          <p:cNvSpPr txBox="1"/>
-          <p:nvPr/>
-        </p:nvSpPr>
-        <p:spPr>
-          <a:xfrm>
-            <a:off x="411480" y="1280160"/>
-            <a:ext cx="11368735" cy="274320"/>
-          </a:xfrm>
-          <a:prstGeom prst="rect">
-            <a:avLst/>
-          </a:prstGeom>
-          <a:noFill/>
-        </p:spPr>
-        <p:txBody>
-          <a:bodyPr wrap="none">
-            <a:spAutoFit/>
-          </a:bodyPr>
-          <a:lstStyle/>
-          <a:p>
-            <a:r>
-              <a:rPr sz="1100" b="0" i="1">
-                <a:solidFill>
-                  <a:srgbClr val="6A6760"/>
-                </a:solidFill>
-                <a:latin typeface="Encode Sans"/>
-              </a:rPr>
-              <a:t>INDEC · período 2026-05</a:t>
-            </a:r>
-          </a:p>
-        </p:txBody>
-      </p:sp>
-      <p:sp>
-        <p:nvSpPr>
-          <p:cNvPr id="5" name="TextBox 4"/>
-          <p:cNvSpPr txBox="1"/>
-          <p:nvPr/>
-        </p:nvSpPr>
-        <p:spPr>
-          <a:xfrm>
-            <a:off x="411480" y="1691640"/>
-            <a:ext cx="5486400" cy="1645920"/>
-          </a:xfrm>
-          <a:prstGeom prst="rect">
-            <a:avLst/>
-          </a:prstGeom>
-          <a:noFill/>
-        </p:spPr>
-        <p:txBody>
-          <a:bodyPr wrap="square" lIns="0" rIns="0">
-            <a:spAutoFit/>
-          </a:bodyPr>
-          <a:lstStyle/>
-          <a:p>
-            <a:pPr algn="just"/>
-            <a:r>
-              <a:rPr sz="1300" b="0" i="0">
-                <a:solidFill>
-                  <a:srgbClr val="3F3F3F"/>
-                </a:solidFill>
-                <a:latin typeface="Encode Sans"/>
-              </a:rPr>
-              <a:t>El Estimador Mensual de Actividad Económica (EMAE) registró una variación interanual de +0.2% en mayo 2026. En la medición desestacionalizada, el indicador se movió -0.5% respecto al mes anterior.</a:t>
-            </a:r>
-          </a:p>
-        </p:txBody>
-      </p:sp>
-      <p:sp>
-        <p:nvSpPr>
-          <p:cNvPr id="6" name="TextBox 5"/>
-          <p:cNvSpPr txBox="1"/>
-          <p:nvPr/>
-        </p:nvSpPr>
-        <p:spPr>
-          <a:xfrm>
-            <a:off x="411480" y="3520440"/>
-            <a:ext cx="5486400" cy="2743200"/>
-          </a:xfrm>
-          <a:prstGeom prst="rect">
-            <a:avLst/>
-          </a:prstGeom>
-          <a:noFill/>
-        </p:spPr>
-        <p:txBody>
-          <a:bodyPr wrap="square" lIns="0" rIns="0">
-            <a:spAutoFit/>
-          </a:bodyPr>
-          <a:lstStyle/>
-          <a:p>
-            <a:pPr algn="l">
-              <a:spcAft>
-                <a:spcPts val="800"/>
-              </a:spcAft>
-            </a:pPr>
-            <a:r>
-              <a:rPr sz="1300" b="1" i="0">
-                <a:solidFill>
-                  <a:srgbClr val="00B2C9"/>
-                </a:solidFill>
-                <a:latin typeface="Encode Sans"/>
-              </a:rPr>
-              <a:t>●  </a:t>
-            </a:r>
-            <a:r>
-              <a:rPr sz="1300" b="0" i="0">
-                <a:solidFill>
-                  <a:srgbClr val="3F3F3F"/>
-                </a:solidFill>
-                <a:latin typeface="Encode Sans"/>
-              </a:rPr>
-              <a:t>Variación interanual: +0.2%</a:t>
-            </a:r>
-          </a:p>
-          <a:p>
-            <a:pPr algn="l">
-              <a:spcAft>
-                <a:spcPts val="800"/>
-              </a:spcAft>
-            </a:pPr>
-            <a:r>
-              <a:rPr sz="1300" b="1" i="0">
-                <a:solidFill>
-                  <a:srgbClr val="00B2C9"/>
-                </a:solidFill>
-                <a:latin typeface="Encode Sans"/>
-              </a:rPr>
-              <a:t>●  </a:t>
-            </a:r>
-            <a:r>
-              <a:rPr sz="1300" b="0" i="0">
-                <a:solidFill>
-                  <a:srgbClr val="3F3F3F"/>
-                </a:solidFill>
-                <a:latin typeface="Encode Sans"/>
-              </a:rPr>
-              <a:t>Variación mensual desestacionalizada: -0.5%</a:t>
-            </a:r>
-          </a:p>
-          <a:p>
-            <a:pPr algn="l">
-              <a:spcAft>
-                <a:spcPts val="800"/>
-              </a:spcAft>
-            </a:pPr>
-            <a:r>
-              <a:rPr sz="1300" b="1" i="0">
-                <a:solidFill>
-                  <a:srgbClr val="00B2C9"/>
-                </a:solidFill>
-                <a:latin typeface="Encode Sans"/>
-              </a:rPr>
-              <a:t>●  </a:t>
-            </a:r>
-            <a:r>
-              <a:rPr sz="1300" b="0" i="0">
-                <a:solidFill>
-                  <a:srgbClr val="3F3F3F"/>
-                </a:solidFill>
-                <a:latin typeface="Encode Sans"/>
-              </a:rPr>
-              <a:t>Serie INDEC, base 2004=100. Mide el nivel general de actividad.</a:t>
-            </a:r>
-          </a:p>
-        </p:txBody>
-      </p:sp>
-      <p:pic>
-        <p:nvPicPr>
-          <p:cNvPr id="7" name="Picture 6" descr="image.png"/>
-          <p:cNvPicPr>
-            <a:picLocks noChangeAspect="1"/>
-          </p:cNvPicPr>
-          <p:nvPr/>
-        </p:nvPicPr>
-        <p:blipFill>
-          <a:blip r:embed="rId2"/>
-          <a:stretch>
-            <a:fillRect/>
-          </a:stretch>
-        </p:blipFill>
-        <p:spPr>
-          <a:xfrm>
-            <a:off x="6080760" y="1691640"/>
-            <a:ext cx="5669280" cy="2560320"/>
-          </a:xfrm>
-          <a:prstGeom prst="rect">
-            <a:avLst/>
-          </a:prstGeom>
-        </p:spPr>
-      </p:pic>
-      <p:graphicFrame>
-        <p:nvGraphicFramePr>
-          <p:cNvPr id="8" name="Table 7"/>
-          <p:cNvGraphicFramePr>
-            <a:graphicFrameLocks noGrp="1"/>
-          </p:cNvGraphicFramePr>
-          <p:nvPr/>
-        </p:nvGraphicFramePr>
-        <p:xfrm>
-          <a:off x="6080760" y="4434840"/>
-          <a:ext cx="5669280" cy="2048256"/>
-        </p:xfrm>
-        <a:graphic>
-          <a:graphicData uri="http://schemas.openxmlformats.org/drawingml/2006/table">
-            <a:tbl>
-              <a:tblPr firstRow="1" bandRow="1">
-                <a:tableStyleId>{5C22544A-7EE6-4342-B048-85BDC9FD1C3A}</a:tableStyleId>
-              </a:tblPr>
-              <a:tblGrid>
-                <a:gridCol w="1417320"/>
-                <a:gridCol w="1417320"/>
-                <a:gridCol w="1417320"/>
-                <a:gridCol w="1417320"/>
-              </a:tblGrid>
-              <a:tr h="292608">
-                <a:tc>
-                  <a:txBody>
-                    <a:bodyPr/>
-                    <a:lstStyle/>
-                    <a:p>
-                      <a:pPr algn="l"/>
-                      <a:r>
-                        <a:rPr sz="1000" b="1">
-                          <a:solidFill>
-                            <a:srgbClr val="FFFFFF"/>
-                          </a:solidFill>
-                          <a:latin typeface="Encode Sans"/>
-                        </a:rPr>
-                        <a:t>Mes</a:t>
-                      </a:r>
-                    </a:p>
-                  </a:txBody>
-                  <a:tcPr marL="36576" marR="36576" marT="18288" marB="18288">
-                    <a:solidFill>
-                      <a:srgbClr val="00B2C9"/>
-                    </a:solidFill>
-                  </a:tcPr>
-                </a:tc>
-                <a:tc>
-                  <a:txBody>
-                    <a:bodyPr/>
-                    <a:lstStyle/>
-                    <a:p>
-                      <a:pPr algn="r"/>
-                      <a:r>
-                        <a:rPr sz="1000" b="1">
-                          <a:solidFill>
-                            <a:srgbClr val="FFFFFF"/>
-                          </a:solidFill>
-                          <a:latin typeface="Encode Sans"/>
-                        </a:rPr>
-                        <a:t>Original</a:t>
-                      </a:r>
-                    </a:p>
-                  </a:txBody>
-                  <a:tcPr marL="36576" marR="36576" marT="18288" marB="18288">
-                    <a:solidFill>
-                      <a:srgbClr val="00B2C9"/>
-                    </a:solidFill>
-                  </a:tcPr>
-                </a:tc>
-                <a:tc>
-                  <a:txBody>
-                    <a:bodyPr/>
-                    <a:lstStyle/>
-                    <a:p>
-                      <a:pPr algn="r"/>
-                      <a:r>
-                        <a:rPr sz="1000" b="1">
-                          <a:solidFill>
-                            <a:srgbClr val="FFFFFF"/>
-                          </a:solidFill>
-                          <a:latin typeface="Encode Sans"/>
-                        </a:rPr>
-                        <a:t>VIA %</a:t>
-                      </a:r>
-                    </a:p>
-                  </a:txBody>
-                  <a:tcPr marL="36576" marR="36576" marT="18288" marB="18288">
-                    <a:solidFill>
-                      <a:srgbClr val="00B2C9"/>
-                    </a:solidFill>
-                  </a:tcPr>
-                </a:tc>
-                <a:tc>
-                  <a:txBody>
-                    <a:bodyPr/>
-                    <a:lstStyle/>
-                    <a:p>
-                      <a:pPr algn="r"/>
-                      <a:r>
-                        <a:rPr sz="1000" b="1">
-                          <a:solidFill>
-                            <a:srgbClr val="FFFFFF"/>
-                          </a:solidFill>
-                          <a:latin typeface="Encode Sans"/>
-                        </a:rPr>
-                        <a:t>Desest.</a:t>
-                      </a:r>
-                    </a:p>
-                  </a:txBody>
-                  <a:tcPr marL="36576" marR="36576" marT="18288" marB="18288">
-                    <a:solidFill>
-                      <a:srgbClr val="00B2C9"/>
-                    </a:solidFill>
-                  </a:tcPr>
-                </a:tc>
-              </a:tr>
-              <a:tr h="292608">
-                <a:tc>
-                  <a:txBody>
-                    <a:bodyPr/>
-                    <a:lstStyle/>
-                    <a:p>
-                      <a:pPr algn="l"/>
-                      <a:r>
-                        <a:rPr sz="1000">
-                          <a:solidFill>
-                            <a:srgbClr val="3F3F3F"/>
-                          </a:solidFill>
-                          <a:latin typeface="Encode Sans"/>
-                        </a:rPr>
-                        <a:t>Mayo 2026</a:t>
-                      </a:r>
-                    </a:p>
-                  </a:txBody>
-                  <a:tcPr marL="36576" marR="36576" marT="18288" marB="18288">
-                    <a:solidFill>
-                      <a:srgbClr val="FFFFFF"/>
-                    </a:solidFill>
-                  </a:tcPr>
-                </a:tc>
-                <a:tc>
-                  <a:txBody>
-                    <a:bodyPr/>
-                    <a:lstStyle/>
-                    <a:p>
-                      <a:pPr algn="r"/>
-                      <a:r>
-                        <a:rPr sz="1000">
-                          <a:solidFill>
-                            <a:srgbClr val="3F3F3F"/>
-                          </a:solidFill>
-                          <a:latin typeface="Encode Sans"/>
-                        </a:rPr>
-                        <a:t>165,5</a:t>
-                      </a:r>
-                    </a:p>
-                  </a:txBody>
-                  <a:tcPr marL="36576" marR="36576" marT="18288" marB="18288">
-                    <a:solidFill>
-                      <a:srgbClr val="FFFFFF"/>
-                    </a:solidFill>
-                  </a:tcPr>
-                </a:tc>
-                <a:tc>
-                  <a:txBody>
-                    <a:bodyPr/>
-                    <a:lstStyle/>
-                    <a:p>
-                      <a:pPr algn="r"/>
-                      <a:r>
-                        <a:rPr sz="1000">
-                          <a:solidFill>
-                            <a:srgbClr val="3F3F3F"/>
-                          </a:solidFill>
-                          <a:latin typeface="Encode Sans"/>
-                        </a:rPr>
-                        <a:t>+0.2%</a:t>
-                      </a:r>
-                    </a:p>
-                  </a:txBody>
-                  <a:tcPr marL="36576" marR="36576" marT="18288" marB="18288">
-                    <a:solidFill>
-                      <a:srgbClr val="FFFFFF"/>
-                    </a:solidFill>
-                  </a:tcPr>
-                </a:tc>
-                <a:tc>
-                  <a:txBody>
-                    <a:bodyPr/>
-                    <a:lstStyle/>
-                    <a:p>
-                      <a:pPr algn="r"/>
-                      <a:r>
-                        <a:rPr sz="1000">
-                          <a:solidFill>
-                            <a:srgbClr val="3F3F3F"/>
-                          </a:solidFill>
-                          <a:latin typeface="Encode Sans"/>
-                        </a:rPr>
-                        <a:t>153,6</a:t>
-                      </a:r>
-                    </a:p>
-                  </a:txBody>
-                  <a:tcPr marL="36576" marR="36576" marT="18288" marB="18288">
-                    <a:solidFill>
-                      <a:srgbClr val="FFFFFF"/>
-                    </a:solidFill>
-                  </a:tcPr>
-                </a:tc>
-              </a:tr>
-              <a:tr h="292608">
-                <a:tc>
-                  <a:txBody>
-                    <a:bodyPr/>
-                    <a:lstStyle/>
-                    <a:p>
-                      <a:pPr algn="l"/>
-                      <a:r>
-                        <a:rPr sz="1000">
-                          <a:solidFill>
-                            <a:srgbClr val="3F3F3F"/>
-                          </a:solidFill>
-                          <a:latin typeface="Encode Sans"/>
-                        </a:rPr>
-                        <a:t>Abril 2026</a:t>
-                      </a:r>
-                    </a:p>
-                  </a:txBody>
-                  <a:tcPr marL="36576" marR="36576" marT="18288" marB="18288">
-                    <a:solidFill>
-                      <a:srgbClr val="F8F8F6"/>
-                    </a:solidFill>
-                  </a:tcPr>
-                </a:tc>
-                <a:tc>
-                  <a:txBody>
-                    <a:bodyPr/>
-                    <a:lstStyle/>
-                    <a:p>
-                      <a:pPr algn="r"/>
-                      <a:r>
-                        <a:rPr sz="1000">
-                          <a:solidFill>
-                            <a:srgbClr val="3F3F3F"/>
-                          </a:solidFill>
-                          <a:latin typeface="Encode Sans"/>
-                        </a:rPr>
-                        <a:t>161,6</a:t>
-                      </a:r>
-                    </a:p>
-                  </a:txBody>
-                  <a:tcPr marL="36576" marR="36576" marT="18288" marB="18288">
-                    <a:solidFill>
-                      <a:srgbClr val="F8F8F6"/>
-                    </a:solidFill>
-                  </a:tcPr>
-                </a:tc>
-                <a:tc>
-                  <a:txBody>
-                    <a:bodyPr/>
-                    <a:lstStyle/>
-                    <a:p>
-                      <a:pPr algn="r"/>
-                      <a:r>
-                        <a:rPr sz="1000">
-                          <a:solidFill>
-                            <a:srgbClr val="3F3F3F"/>
-                          </a:solidFill>
-                          <a:latin typeface="Encode Sans"/>
-                        </a:rPr>
-                        <a:t>+1.7%</a:t>
-                      </a:r>
-                    </a:p>
-                  </a:txBody>
-                  <a:tcPr marL="36576" marR="36576" marT="18288" marB="18288">
-                    <a:solidFill>
-                      <a:srgbClr val="F8F8F6"/>
-                    </a:solidFill>
-                  </a:tcPr>
-                </a:tc>
-                <a:tc>
-                  <a:txBody>
-                    <a:bodyPr/>
-                    <a:lstStyle/>
-                    <a:p>
-                      <a:pPr algn="r"/>
-                      <a:r>
-                        <a:rPr sz="1000">
-                          <a:solidFill>
-                            <a:srgbClr val="3F3F3F"/>
-                          </a:solidFill>
-                          <a:latin typeface="Encode Sans"/>
-                        </a:rPr>
-                        <a:t>154,3</a:t>
-                      </a:r>
-                    </a:p>
-                  </a:txBody>
-                  <a:tcPr marL="36576" marR="36576" marT="18288" marB="18288">
-                    <a:solidFill>
-                      <a:srgbClr val="F8F8F6"/>
-                    </a:solidFill>
-                  </a:tcPr>
-                </a:tc>
-              </a:tr>
-              <a:tr h="292608">
-                <a:tc>
-                  <a:txBody>
-                    <a:bodyPr/>
-                    <a:lstStyle/>
-                    <a:p>
-                      <a:pPr algn="l"/>
-                      <a:r>
-                        <a:rPr sz="1000">
-                          <a:solidFill>
-                            <a:srgbClr val="3F3F3F"/>
-                          </a:solidFill>
-                          <a:latin typeface="Encode Sans"/>
-                        </a:rPr>
-                        <a:t>Marzo 2026</a:t>
-                      </a:r>
-                    </a:p>
-                  </a:txBody>
-                  <a:tcPr marL="36576" marR="36576" marT="18288" marB="18288">
-                    <a:solidFill>
-                      <a:srgbClr val="FFFFFF"/>
-                    </a:solidFill>
-                  </a:tcPr>
-                </a:tc>
-                <a:tc>
-                  <a:txBody>
-                    <a:bodyPr/>
-                    <a:lstStyle/>
-                    <a:p>
-                      <a:pPr algn="r"/>
-                      <a:r>
-                        <a:rPr sz="1000">
-                          <a:solidFill>
-                            <a:srgbClr val="3F3F3F"/>
-                          </a:solidFill>
-                          <a:latin typeface="Encode Sans"/>
-                        </a:rPr>
-                        <a:t>160,0</a:t>
-                      </a:r>
-                    </a:p>
-                  </a:txBody>
-                  <a:tcPr marL="36576" marR="36576" marT="18288" marB="18288">
-                    <a:solidFill>
-                      <a:srgbClr val="FFFFFF"/>
-                    </a:solidFill>
-                  </a:tcPr>
-                </a:tc>
-                <a:tc>
-                  <a:txBody>
-                    <a:bodyPr/>
-                    <a:lstStyle/>
-                    <a:p>
-                      <a:pPr algn="r"/>
-                      <a:r>
-                        <a:rPr sz="1000">
-                          <a:solidFill>
-                            <a:srgbClr val="3F3F3F"/>
-                          </a:solidFill>
-                          <a:latin typeface="Encode Sans"/>
-                        </a:rPr>
-                        <a:t>+6.2%</a:t>
-                      </a:r>
-                    </a:p>
-                  </a:txBody>
-                  <a:tcPr marL="36576" marR="36576" marT="18288" marB="18288">
-                    <a:solidFill>
-                      <a:srgbClr val="FFFFFF"/>
-                    </a:solidFill>
-                  </a:tcPr>
-                </a:tc>
-                <a:tc>
-                  <a:txBody>
-                    <a:bodyPr/>
-                    <a:lstStyle/>
-                    <a:p>
-                      <a:pPr algn="r"/>
-                      <a:r>
-                        <a:rPr sz="1000">
-                          <a:solidFill>
-                            <a:srgbClr val="3F3F3F"/>
-                          </a:solidFill>
-                          <a:latin typeface="Encode Sans"/>
-                        </a:rPr>
-                        <a:t>156,7</a:t>
-                      </a:r>
-                    </a:p>
-                  </a:txBody>
-                  <a:tcPr marL="36576" marR="36576" marT="18288" marB="18288">
-                    <a:solidFill>
-                      <a:srgbClr val="FFFFFF"/>
-                    </a:solidFill>
-                  </a:tcPr>
-                </a:tc>
-              </a:tr>
-              <a:tr h="292608">
-                <a:tc>
-                  <a:txBody>
-                    <a:bodyPr/>
-                    <a:lstStyle/>
-                    <a:p>
-                      <a:pPr algn="l"/>
-                      <a:r>
-                        <a:rPr sz="1000">
-                          <a:solidFill>
-                            <a:srgbClr val="3F3F3F"/>
-                          </a:solidFill>
-                          <a:latin typeface="Encode Sans"/>
-                        </a:rPr>
-                        <a:t>Febrero 2026</a:t>
-                      </a:r>
-                    </a:p>
-                  </a:txBody>
-                  <a:tcPr marL="36576" marR="36576" marT="18288" marB="18288">
-                    <a:solidFill>
-                      <a:srgbClr val="F8F8F6"/>
-                    </a:solidFill>
-                  </a:tcPr>
-                </a:tc>
-                <a:tc>
-                  <a:txBody>
-                    <a:bodyPr/>
-                    <a:lstStyle/>
-                    <a:p>
-                      <a:pPr algn="r"/>
-                      <a:r>
-                        <a:rPr sz="1000">
-                          <a:solidFill>
-                            <a:srgbClr val="3F3F3F"/>
-                          </a:solidFill>
-                          <a:latin typeface="Encode Sans"/>
-                        </a:rPr>
-                        <a:t>139,3</a:t>
-                      </a:r>
-                    </a:p>
-                  </a:txBody>
-                  <a:tcPr marL="36576" marR="36576" marT="18288" marB="18288">
-                    <a:solidFill>
-                      <a:srgbClr val="F8F8F6"/>
-                    </a:solidFill>
-                  </a:tcPr>
-                </a:tc>
-                <a:tc>
-                  <a:txBody>
-                    <a:bodyPr/>
-                    <a:lstStyle/>
-                    <a:p>
-                      <a:pPr algn="r"/>
-                      <a:r>
-                        <a:rPr sz="1000">
-                          <a:solidFill>
-                            <a:srgbClr val="3F3F3F"/>
-                          </a:solidFill>
-                          <a:latin typeface="Encode Sans"/>
-                        </a:rPr>
-                        <a:t>-1.5%</a:t>
-                      </a:r>
-                    </a:p>
-                  </a:txBody>
-                  <a:tcPr marL="36576" marR="36576" marT="18288" marB="18288">
-                    <a:solidFill>
-                      <a:srgbClr val="F8F8F6"/>
-                    </a:solidFill>
-                  </a:tcPr>
-                </a:tc>
-                <a:tc>
-                  <a:txBody>
-                    <a:bodyPr/>
-                    <a:lstStyle/>
-                    <a:p>
-                      <a:pPr algn="r"/>
-                      <a:r>
-                        <a:rPr sz="1000">
-                          <a:solidFill>
-                            <a:srgbClr val="3F3F3F"/>
-                          </a:solidFill>
-                          <a:latin typeface="Encode Sans"/>
-                        </a:rPr>
-                        <a:t>152,5</a:t>
-                      </a:r>
-                    </a:p>
-                  </a:txBody>
-                  <a:tcPr marL="36576" marR="36576" marT="18288" marB="18288">
-                    <a:solidFill>
-                      <a:srgbClr val="F8F8F6"/>
-                    </a:solidFill>
-                  </a:tcPr>
-                </a:tc>
-              </a:tr>
-              <a:tr h="292608">
-                <a:tc>
-                  <a:txBody>
-                    <a:bodyPr/>
-                    <a:lstStyle/>
-                    <a:p>
-                      <a:pPr algn="l"/>
-                      <a:r>
-                        <a:rPr sz="1000">
-                          <a:solidFill>
-                            <a:srgbClr val="3F3F3F"/>
-                          </a:solidFill>
-                          <a:latin typeface="Encode Sans"/>
-                        </a:rPr>
-                        <a:t>Enero 2026</a:t>
-                      </a:r>
-                    </a:p>
-                  </a:txBody>
-                  <a:tcPr marL="36576" marR="36576" marT="18288" marB="18288">
-                    <a:solidFill>
-                      <a:srgbClr val="FFFFFF"/>
-                    </a:solidFill>
-                  </a:tcPr>
-                </a:tc>
-                <a:tc>
-                  <a:txBody>
-                    <a:bodyPr/>
-                    <a:lstStyle/>
-                    <a:p>
-                      <a:pPr algn="r"/>
-                      <a:r>
-                        <a:rPr sz="1000">
-                          <a:solidFill>
-                            <a:srgbClr val="3F3F3F"/>
-                          </a:solidFill>
-                          <a:latin typeface="Encode Sans"/>
-                        </a:rPr>
-                        <a:t>149,4</a:t>
-                      </a:r>
-                    </a:p>
-                  </a:txBody>
-                  <a:tcPr marL="36576" marR="36576" marT="18288" marB="18288">
-                    <a:solidFill>
-                      <a:srgbClr val="FFFFFF"/>
-                    </a:solidFill>
-                  </a:tcPr>
-                </a:tc>
-                <a:tc>
-                  <a:txBody>
-                    <a:bodyPr/>
-                    <a:lstStyle/>
-                    <a:p>
-                      <a:pPr algn="r"/>
-                      <a:r>
-                        <a:rPr sz="1000">
-                          <a:solidFill>
-                            <a:srgbClr val="3F3F3F"/>
-                          </a:solidFill>
-                          <a:latin typeface="Encode Sans"/>
-                        </a:rPr>
-                        <a:t>+2.0%</a:t>
-                      </a:r>
-                    </a:p>
-                  </a:txBody>
-                  <a:tcPr marL="36576" marR="36576" marT="18288" marB="18288">
-                    <a:solidFill>
-                      <a:srgbClr val="FFFFFF"/>
-                    </a:solidFill>
-                  </a:tcPr>
-                </a:tc>
-                <a:tc>
-                  <a:txBody>
-                    <a:bodyPr/>
-                    <a:lstStyle/>
-                    <a:p>
-                      <a:pPr algn="r"/>
-                      <a:r>
-                        <a:rPr sz="1000">
-                          <a:solidFill>
-                            <a:srgbClr val="3F3F3F"/>
-                          </a:solidFill>
-                          <a:latin typeface="Encode Sans"/>
-                        </a:rPr>
-                        <a:t>156,3</a:t>
-                      </a:r>
-                    </a:p>
-                  </a:txBody>
-                  <a:tcPr marL="36576" marR="36576" marT="18288" marB="18288">
-                    <a:solidFill>
-                      <a:srgbClr val="FFFFFF"/>
-                    </a:solidFill>
-                  </a:tcPr>
-                </a:tc>
-              </a:tr>
-              <a:tr h="292608">
-                <a:tc>
-                  <a:txBody>
-                    <a:bodyPr/>
-                    <a:lstStyle/>
-                    <a:p>
-                      <a:pPr algn="l"/>
-                      <a:r>
-                        <a:rPr sz="1000">
-                          <a:solidFill>
-                            <a:srgbClr val="3F3F3F"/>
-                          </a:solidFill>
-                          <a:latin typeface="Encode Sans"/>
-                        </a:rPr>
-                        <a:t>Diciembre 2025</a:t>
-                      </a:r>
-                    </a:p>
-                  </a:txBody>
-                  <a:tcPr marL="36576" marR="36576" marT="18288" marB="18288">
-                    <a:solidFill>
-                      <a:srgbClr val="F8F8F6"/>
-                    </a:solidFill>
-                  </a:tcPr>
-                </a:tc>
-                <a:tc>
-                  <a:txBody>
-                    <a:bodyPr/>
-                    <a:lstStyle/>
-                    <a:p>
-                      <a:pPr algn="r"/>
-                      <a:r>
-                        <a:rPr sz="1000">
-                          <a:solidFill>
-                            <a:srgbClr val="3F3F3F"/>
-                          </a:solidFill>
-                          <a:latin typeface="Encode Sans"/>
-                        </a:rPr>
-                        <a:t>153,8</a:t>
-                      </a:r>
-                    </a:p>
-                  </a:txBody>
-                  <a:tcPr marL="36576" marR="36576" marT="18288" marB="18288">
-                    <a:solidFill>
-                      <a:srgbClr val="F8F8F6"/>
-                    </a:solidFill>
-                  </a:tcPr>
-                </a:tc>
-                <a:tc>
-                  <a:txBody>
-                    <a:bodyPr/>
-                    <a:lstStyle/>
-                    <a:p>
-                      <a:pPr algn="r"/>
-                      <a:r>
-                        <a:rPr sz="1000">
-                          <a:solidFill>
-                            <a:srgbClr val="3F3F3F"/>
-                          </a:solidFill>
-                          <a:latin typeface="Encode Sans"/>
-                        </a:rPr>
-                        <a:t>+3.5%</a:t>
-                      </a:r>
-                    </a:p>
-                  </a:txBody>
-                  <a:tcPr marL="36576" marR="36576" marT="18288" marB="18288">
-                    <a:solidFill>
-                      <a:srgbClr val="F8F8F6"/>
-                    </a:solidFill>
-                  </a:tcPr>
-                </a:tc>
-                <a:tc>
-                  <a:txBody>
-                    <a:bodyPr/>
-                    <a:lstStyle/>
-                    <a:p>
-                      <a:pPr algn="r"/>
-                      <a:r>
-                        <a:rPr sz="1000">
-                          <a:solidFill>
-                            <a:srgbClr val="3F3F3F"/>
-                          </a:solidFill>
-                          <a:latin typeface="Encode Sans"/>
-                        </a:rPr>
-                        <a:t>155,9</a:t>
-                      </a:r>
-                    </a:p>
-                  </a:txBody>
-                  <a:tcPr marL="36576" marR="36576" marT="18288" marB="18288">
-                    <a:solidFill>
-                      <a:srgbClr val="F8F8F6"/>
-                    </a:solidFill>
-                  </a:tcPr>
-                </a:tc>
-              </a:tr>
-            </a:tbl>
-          </a:graphicData>
-        </a:graphic>
-      </p:graphicFrame>
-      <p:sp>
-        <p:nvSpPr>
-          <p:cNvPr id="9" name="TextBox 8"/>
-          <p:cNvSpPr txBox="1"/>
-          <p:nvPr/>
-        </p:nvSpPr>
-        <p:spPr>
-          <a:xfrm>
-            <a:off x="411480" y="6492240"/>
-            <a:ext cx="11368735" cy="274320"/>
-          </a:xfrm>
-          <a:prstGeom prst="rect">
-            <a:avLst/>
-          </a:prstGeom>
-          <a:noFill/>
-        </p:spPr>
-        <p:txBody>
-          <a:bodyPr wrap="none">
-            <a:spAutoFit/>
-          </a:bodyPr>
-          <a:lstStyle/>
-          <a:p>
-            <a:r>
-              <a:rPr sz="1000" b="0" i="1">
-                <a:solidFill>
-                  <a:srgbClr val="6A6760"/>
-                </a:solidFill>
-                <a:latin typeface="Encode Sans"/>
-              </a:rPr>
-              <a:t>Fuente: elaboración propia en base a INDEC</a:t>
-            </a:r>
-          </a:p>
-        </p:txBody>
-      </p:sp>
-    </p:spTree>
-  </p:cSld>
-  <p:clrMapOvr>
-    <a:masterClrMapping/>
-  </p:clrMapOvr>
-</p:sld>
-</file>
-
-<file path=ppt/slides/slide4.xml><?xml version="1.0" encoding="utf-8"?>
-<p:sld xmlns:a="http://schemas.openxmlformats.org/drawingml/2006/main" xmlns:p="http://schemas.openxmlformats.org/presentationml/2006/main" xmlns:r="http://schemas.openxmlformats.org/officeDocument/2006/relationships">
-  <p:cSld>
-    <p:spTree>
-      <p:nvGrpSpPr>
-        <p:cNvPr id="1" name=""/>
-        <p:cNvGrpSpPr/>
-        <p:nvPr/>
-      </p:nvGrpSpPr>
-      <p:grpSpPr/>
-      <p:sp>
-        <p:nvSpPr>
-          <p:cNvPr id="2" name="Rectangle 1"/>
-          <p:cNvSpPr/>
-          <p:nvPr/>
-        </p:nvSpPr>
-        <p:spPr>
-          <a:xfrm>
-            <a:off x="0" y="0"/>
-            <a:ext cx="12191695" cy="274320"/>
-          </a:xfrm>
-          <a:prstGeom prst="rect">
-            <a:avLst/>
-          </a:prstGeom>
-          <a:solidFill>
-            <a:srgbClr val="00B2C9"/>
-          </a:solidFill>
-          <a:ln>
-            <a:noFill/>
-          </a:ln>
-        </p:spPr>
-        <p:style>
-          <a:lnRef idx="1">
-            <a:schemeClr val="accent1"/>
-          </a:lnRef>
-          <a:fillRef idx="3">
-            <a:schemeClr val="accent1"/>
-          </a:fillRef>
-          <a:effectRef idx="2">
-            <a:schemeClr val="accent1"/>
-          </a:effectRef>
-          <a:fontRef idx="minor">
-            <a:schemeClr val="lt1"/>
-          </a:fontRef>
-        </p:style>
-        <p:txBody>
-          <a:bodyPr rtlCol="0" anchor="ctr"/>
-          <a:lstStyle/>
-          <a:p>
-            <a:pPr algn="ctr"/>
-          </a:p>
-        </p:txBody>
-      </p:sp>
-      <p:sp>
-        <p:nvSpPr>
-          <p:cNvPr id="3" name="TextBox 2"/>
-          <p:cNvSpPr txBox="1"/>
-          <p:nvPr/>
-        </p:nvSpPr>
-        <p:spPr>
-          <a:xfrm>
-            <a:off x="411480" y="457200"/>
-            <a:ext cx="11368735" cy="914400"/>
-          </a:xfrm>
-          <a:prstGeom prst="rect">
-            <a:avLst/>
-          </a:prstGeom>
-          <a:noFill/>
-        </p:spPr>
-        <p:txBody>
-          <a:bodyPr wrap="square" lIns="0" rIns="0">
-            <a:spAutoFit/>
-          </a:bodyPr>
-          <a:lstStyle/>
-          <a:p>
-            <a:pPr algn="l"/>
-            <a:r>
-              <a:rPr sz="2600" b="1" i="0">
-                <a:solidFill>
-                  <a:srgbClr val="00B2C9"/>
-                </a:solidFill>
-                <a:latin typeface="Encode Sans"/>
-              </a:rPr>
-              <a:t>SUPERMERCADOS MAYO 2026: VENTAS REALES CAYERON -0.7%</a:t>
-            </a:r>
-          </a:p>
-        </p:txBody>
-      </p:sp>
-      <p:sp>
-        <p:nvSpPr>
-          <p:cNvPr id="4" name="TextBox 3"/>
-          <p:cNvSpPr txBox="1"/>
-          <p:nvPr/>
-        </p:nvSpPr>
-        <p:spPr>
-          <a:xfrm>
-            <a:off x="411480" y="1280160"/>
-            <a:ext cx="11368735" cy="274320"/>
-          </a:xfrm>
-          <a:prstGeom prst="rect">
-            <a:avLst/>
-          </a:prstGeom>
-          <a:noFill/>
-        </p:spPr>
-        <p:txBody>
-          <a:bodyPr wrap="none">
-            <a:spAutoFit/>
-          </a:bodyPr>
-          <a:lstStyle/>
-          <a:p>
-            <a:r>
-              <a:rPr sz="1100" b="0" i="1">
-                <a:solidFill>
-                  <a:srgbClr val="6A6760"/>
-                </a:solidFill>
-                <a:latin typeface="Encode Sans"/>
-              </a:rPr>
-              <a:t>INDEC · período 2026-05</a:t>
-            </a:r>
-          </a:p>
-        </p:txBody>
-      </p:sp>
-      <p:sp>
-        <p:nvSpPr>
-          <p:cNvPr id="5" name="TextBox 4"/>
-          <p:cNvSpPr txBox="1"/>
-          <p:nvPr/>
-        </p:nvSpPr>
-        <p:spPr>
-          <a:xfrm>
-            <a:off x="411480" y="1691640"/>
-            <a:ext cx="5486400" cy="1645920"/>
-          </a:xfrm>
-          <a:prstGeom prst="rect">
-            <a:avLst/>
-          </a:prstGeom>
-          <a:noFill/>
-        </p:spPr>
-        <p:txBody>
-          <a:bodyPr wrap="square" lIns="0" rIns="0">
-            <a:spAutoFit/>
-          </a:bodyPr>
-          <a:lstStyle/>
-          <a:p>
-            <a:pPr algn="just"/>
-            <a:r>
-              <a:rPr sz="1300" b="0" i="0">
-                <a:solidFill>
-                  <a:srgbClr val="3F3F3F"/>
-                </a:solidFill>
-                <a:latin typeface="Encode Sans"/>
-              </a:rPr>
-              <a:t>Las ventas de supermercados a precios constantes registraron una variación interanual real de -0.7% en mayo 2026. Desestacionalizada: +0.9% m/m.</a:t>
-            </a:r>
-          </a:p>
-        </p:txBody>
-      </p:sp>
-      <p:sp>
-        <p:nvSpPr>
-          <p:cNvPr id="6" name="TextBox 5"/>
-          <p:cNvSpPr txBox="1"/>
-          <p:nvPr/>
-        </p:nvSpPr>
-        <p:spPr>
-          <a:xfrm>
-            <a:off x="411480" y="3520440"/>
-            <a:ext cx="5486400" cy="2743200"/>
-          </a:xfrm>
-          <a:prstGeom prst="rect">
-            <a:avLst/>
-          </a:prstGeom>
-          <a:noFill/>
-        </p:spPr>
-        <p:txBody>
-          <a:bodyPr wrap="square" lIns="0" rIns="0">
-            <a:spAutoFit/>
-          </a:bodyPr>
-          <a:lstStyle/>
-          <a:p>
-            <a:pPr algn="l">
-              <a:spcAft>
-                <a:spcPts val="800"/>
-              </a:spcAft>
-            </a:pPr>
-            <a:r>
-              <a:rPr sz="1300" b="1" i="0">
-                <a:solidFill>
-                  <a:srgbClr val="00B2C9"/>
-                </a:solidFill>
-                <a:latin typeface="Encode Sans"/>
-              </a:rPr>
-              <a:t>●  </a:t>
-            </a:r>
-            <a:r>
-              <a:rPr sz="1300" b="0" i="0">
-                <a:solidFill>
-                  <a:srgbClr val="3F3F3F"/>
-                </a:solidFill>
-                <a:latin typeface="Encode Sans"/>
-              </a:rPr>
-              <a:t>Variación interanual real: -0.7%</a:t>
-            </a:r>
-          </a:p>
-          <a:p>
-            <a:pPr algn="l">
-              <a:spcAft>
-                <a:spcPts val="800"/>
-              </a:spcAft>
-            </a:pPr>
-            <a:r>
-              <a:rPr sz="1300" b="1" i="0">
-                <a:solidFill>
-                  <a:srgbClr val="00B2C9"/>
-                </a:solidFill>
-                <a:latin typeface="Encode Sans"/>
-              </a:rPr>
-              <a:t>●  </a:t>
-            </a:r>
-            <a:r>
-              <a:rPr sz="1300" b="0" i="0">
-                <a:solidFill>
-                  <a:srgbClr val="3F3F3F"/>
-                </a:solidFill>
-                <a:latin typeface="Encode Sans"/>
-              </a:rPr>
-              <a:t>Variación mensual desestacionalizada: +0.9%</a:t>
-            </a:r>
-          </a:p>
-          <a:p>
-            <a:pPr algn="l">
-              <a:spcAft>
-                <a:spcPts val="800"/>
-              </a:spcAft>
-            </a:pPr>
-            <a:r>
-              <a:rPr sz="1300" b="1" i="0">
-                <a:solidFill>
-                  <a:srgbClr val="00B2C9"/>
-                </a:solidFill>
-                <a:latin typeface="Encode Sans"/>
-              </a:rPr>
-              <a:t>●  </a:t>
-            </a:r>
-            <a:r>
-              <a:rPr sz="1300" b="0" i="0">
-                <a:solidFill>
-                  <a:srgbClr val="3F3F3F"/>
-                </a:solidFill>
-                <a:latin typeface="Encode Sans"/>
-              </a:rPr>
-              <a:t>Acumulado del año: -2.8%</a:t>
-            </a:r>
-          </a:p>
-        </p:txBody>
-      </p:sp>
-      <p:pic>
-        <p:nvPicPr>
-          <p:cNvPr id="7" name="Picture 6" descr="image.png"/>
-          <p:cNvPicPr>
-            <a:picLocks noChangeAspect="1"/>
-          </p:cNvPicPr>
-          <p:nvPr/>
-        </p:nvPicPr>
-        <p:blipFill>
-          <a:blip r:embed="rId2"/>
-          <a:stretch>
-            <a:fillRect/>
-          </a:stretch>
-        </p:blipFill>
-        <p:spPr>
-          <a:xfrm>
-            <a:off x="6080760" y="1691640"/>
-            <a:ext cx="5669280" cy="2560320"/>
-          </a:xfrm>
-          <a:prstGeom prst="rect">
-            <a:avLst/>
-          </a:prstGeom>
-        </p:spPr>
-      </p:pic>
-      <p:graphicFrame>
-        <p:nvGraphicFramePr>
-          <p:cNvPr id="8" name="Table 7"/>
-          <p:cNvGraphicFramePr>
-            <a:graphicFrameLocks noGrp="1"/>
-          </p:cNvGraphicFramePr>
-          <p:nvPr/>
-        </p:nvGraphicFramePr>
-        <p:xfrm>
-          <a:off x="6080760" y="4434840"/>
-          <a:ext cx="5669280" cy="2048256"/>
-        </p:xfrm>
-        <a:graphic>
-          <a:graphicData uri="http://schemas.openxmlformats.org/drawingml/2006/table">
-            <a:tbl>
-              <a:tblPr firstRow="1" bandRow="1">
-                <a:tableStyleId>{5C22544A-7EE6-4342-B048-85BDC9FD1C3A}</a:tableStyleId>
-              </a:tblPr>
-              <a:tblGrid>
-                <a:gridCol w="1417320"/>
-                <a:gridCol w="1417320"/>
-                <a:gridCol w="1417320"/>
-                <a:gridCol w="1417320"/>
-              </a:tblGrid>
-              <a:tr h="292608">
-                <a:tc>
-                  <a:txBody>
-                    <a:bodyPr/>
-                    <a:lstStyle/>
-                    <a:p>
-                      <a:pPr algn="l"/>
-                      <a:r>
-                        <a:rPr sz="1000" b="1">
-                          <a:solidFill>
-                            <a:srgbClr val="FFFFFF"/>
-                          </a:solidFill>
-                          <a:latin typeface="Encode Sans"/>
-                        </a:rPr>
-                        <a:t>Mes</a:t>
-                      </a:r>
-                    </a:p>
-                  </a:txBody>
-                  <a:tcPr marL="36576" marR="36576" marT="18288" marB="18288">
-                    <a:solidFill>
-                      <a:srgbClr val="00B2C9"/>
-                    </a:solidFill>
-                  </a:tcPr>
-                </a:tc>
-                <a:tc>
-                  <a:txBody>
-                    <a:bodyPr/>
-                    <a:lstStyle/>
-                    <a:p>
-                      <a:pPr algn="r"/>
-                      <a:r>
-                        <a:rPr sz="1000" b="1">
-                          <a:solidFill>
-                            <a:srgbClr val="FFFFFF"/>
-                          </a:solidFill>
-                          <a:latin typeface="Encode Sans"/>
-                        </a:rPr>
-                        <a:t>Índice real</a:t>
-                      </a:r>
-                    </a:p>
-                  </a:txBody>
-                  <a:tcPr marL="36576" marR="36576" marT="18288" marB="18288">
-                    <a:solidFill>
-                      <a:srgbClr val="00B2C9"/>
-                    </a:solidFill>
-                  </a:tcPr>
-                </a:tc>
-                <a:tc>
-                  <a:txBody>
-                    <a:bodyPr/>
-                    <a:lstStyle/>
-                    <a:p>
-                      <a:pPr algn="r"/>
-                      <a:r>
-                        <a:rPr sz="1000" b="1">
-                          <a:solidFill>
-                            <a:srgbClr val="FFFFFF"/>
-                          </a:solidFill>
-                          <a:latin typeface="Encode Sans"/>
-                        </a:rPr>
-                        <a:t>VIA real %</a:t>
-                      </a:r>
-                    </a:p>
-                  </a:txBody>
-                  <a:tcPr marL="36576" marR="36576" marT="18288" marB="18288">
-                    <a:solidFill>
-                      <a:srgbClr val="00B2C9"/>
-                    </a:solidFill>
-                  </a:tcPr>
-                </a:tc>
-                <a:tc>
-                  <a:txBody>
-                    <a:bodyPr/>
-                    <a:lstStyle/>
-                    <a:p>
-                      <a:pPr algn="r"/>
-                      <a:r>
-                        <a:rPr sz="1000" b="1">
-                          <a:solidFill>
-                            <a:srgbClr val="FFFFFF"/>
-                          </a:solidFill>
-                          <a:latin typeface="Encode Sans"/>
-                        </a:rPr>
-                        <a:t>Acumulado %</a:t>
-                      </a:r>
-                    </a:p>
-                  </a:txBody>
-                  <a:tcPr marL="36576" marR="36576" marT="18288" marB="18288">
-                    <a:solidFill>
-                      <a:srgbClr val="00B2C9"/>
-                    </a:solidFill>
-                  </a:tcPr>
-                </a:tc>
-              </a:tr>
-              <a:tr h="292608">
-                <a:tc>
-                  <a:txBody>
-                    <a:bodyPr/>
-                    <a:lstStyle/>
-                    <a:p>
-                      <a:pPr algn="l"/>
-                      <a:r>
-                        <a:rPr sz="1000">
-                          <a:solidFill>
-                            <a:srgbClr val="3F3F3F"/>
-                          </a:solidFill>
-                          <a:latin typeface="Encode Sans"/>
-                        </a:rPr>
-                        <a:t>Mayo 2026</a:t>
-                      </a:r>
-                    </a:p>
-                  </a:txBody>
-                  <a:tcPr marL="36576" marR="36576" marT="18288" marB="18288">
-                    <a:solidFill>
-                      <a:srgbClr val="FFFFFF"/>
-                    </a:solidFill>
-                  </a:tcPr>
-                </a:tc>
-                <a:tc>
-                  <a:txBody>
-                    <a:bodyPr/>
-                    <a:lstStyle/>
-                    <a:p>
-                      <a:pPr algn="r"/>
-                      <a:r>
-                        <a:rPr sz="1000">
-                          <a:solidFill>
-                            <a:srgbClr val="3F3F3F"/>
-                          </a:solidFill>
-                          <a:latin typeface="Encode Sans"/>
-                        </a:rPr>
-                        <a:t>80,5</a:t>
-                      </a:r>
-                    </a:p>
-                  </a:txBody>
-                  <a:tcPr marL="36576" marR="36576" marT="18288" marB="18288">
-                    <a:solidFill>
-                      <a:srgbClr val="FFFFFF"/>
-                    </a:solidFill>
-                  </a:tcPr>
-                </a:tc>
-                <a:tc>
-                  <a:txBody>
-                    <a:bodyPr/>
-                    <a:lstStyle/>
-                    <a:p>
-                      <a:pPr algn="r"/>
-                      <a:r>
-                        <a:rPr sz="1000">
-                          <a:solidFill>
-                            <a:srgbClr val="3F3F3F"/>
-                          </a:solidFill>
-                          <a:latin typeface="Encode Sans"/>
-                        </a:rPr>
-                        <a:t>-0.7%</a:t>
-                      </a:r>
-                    </a:p>
-                  </a:txBody>
-                  <a:tcPr marL="36576" marR="36576" marT="18288" marB="18288">
-                    <a:solidFill>
-                      <a:srgbClr val="FFFFFF"/>
-                    </a:solidFill>
-                  </a:tcPr>
-                </a:tc>
-                <a:tc>
-                  <a:txBody>
-                    <a:bodyPr/>
-                    <a:lstStyle/>
-                    <a:p>
-                      <a:pPr algn="r"/>
-                      <a:r>
-                        <a:rPr sz="1000">
-                          <a:solidFill>
-                            <a:srgbClr val="3F3F3F"/>
-                          </a:solidFill>
-                          <a:latin typeface="Encode Sans"/>
-                        </a:rPr>
-                        <a:t>-2.8%</a:t>
-                      </a:r>
-                    </a:p>
-                  </a:txBody>
-                  <a:tcPr marL="36576" marR="36576" marT="18288" marB="18288">
-                    <a:solidFill>
-                      <a:srgbClr val="FFFFFF"/>
-                    </a:solidFill>
-                  </a:tcPr>
-                </a:tc>
-              </a:tr>
-              <a:tr h="292608">
-                <a:tc>
-                  <a:txBody>
-                    <a:bodyPr/>
-                    <a:lstStyle/>
-                    <a:p>
-                      <a:pPr algn="l"/>
-                      <a:r>
-                        <a:rPr sz="1000">
-                          <a:solidFill>
-                            <a:srgbClr val="3F3F3F"/>
-                          </a:solidFill>
-                          <a:latin typeface="Encode Sans"/>
-                        </a:rPr>
-                        <a:t>Abril 2026</a:t>
-                      </a:r>
-                    </a:p>
-                  </a:txBody>
-                  <a:tcPr marL="36576" marR="36576" marT="18288" marB="18288">
-                    <a:solidFill>
-                      <a:srgbClr val="F8F8F6"/>
-                    </a:solidFill>
-                  </a:tcPr>
-                </a:tc>
-                <a:tc>
-                  <a:txBody>
-                    <a:bodyPr/>
-                    <a:lstStyle/>
-                    <a:p>
-                      <a:pPr algn="r"/>
-                      <a:r>
-                        <a:rPr sz="1000">
-                          <a:solidFill>
-                            <a:srgbClr val="3F3F3F"/>
-                          </a:solidFill>
-                          <a:latin typeface="Encode Sans"/>
-                        </a:rPr>
-                        <a:t>78,5</a:t>
-                      </a:r>
-                    </a:p>
-                  </a:txBody>
-                  <a:tcPr marL="36576" marR="36576" marT="18288" marB="18288">
-                    <a:solidFill>
-                      <a:srgbClr val="F8F8F6"/>
-                    </a:solidFill>
-                  </a:tcPr>
-                </a:tc>
-                <a:tc>
-                  <a:txBody>
-                    <a:bodyPr/>
-                    <a:lstStyle/>
-                    <a:p>
-                      <a:pPr algn="r"/>
-                      <a:r>
-                        <a:rPr sz="1000">
-                          <a:solidFill>
-                            <a:srgbClr val="3F3F3F"/>
-                          </a:solidFill>
-                          <a:latin typeface="Encode Sans"/>
-                        </a:rPr>
-                        <a:t>-3.7%</a:t>
-                      </a:r>
-                    </a:p>
-                  </a:txBody>
-                  <a:tcPr marL="36576" marR="36576" marT="18288" marB="18288">
-                    <a:solidFill>
-                      <a:srgbClr val="F8F8F6"/>
-                    </a:solidFill>
-                  </a:tcPr>
-                </a:tc>
-                <a:tc>
-                  <a:txBody>
-                    <a:bodyPr/>
-                    <a:lstStyle/>
-                    <a:p>
-                      <a:pPr algn="r"/>
-                      <a:r>
-                        <a:rPr sz="1000">
-                          <a:solidFill>
-                            <a:srgbClr val="3F3F3F"/>
-                          </a:solidFill>
-                          <a:latin typeface="Encode Sans"/>
-                        </a:rPr>
-                        <a:t>-3.3%</a:t>
-                      </a:r>
-                    </a:p>
-                  </a:txBody>
-                  <a:tcPr marL="36576" marR="36576" marT="18288" marB="18288">
-                    <a:solidFill>
-                      <a:srgbClr val="F8F8F6"/>
-                    </a:solidFill>
-                  </a:tcPr>
-                </a:tc>
-              </a:tr>
-              <a:tr h="292608">
-                <a:tc>
-                  <a:txBody>
-                    <a:bodyPr/>
-                    <a:lstStyle/>
-                    <a:p>
-                      <a:pPr algn="l"/>
-                      <a:r>
-                        <a:rPr sz="1000">
-                          <a:solidFill>
-                            <a:srgbClr val="3F3F3F"/>
-                          </a:solidFill>
-                          <a:latin typeface="Encode Sans"/>
-                        </a:rPr>
-                        <a:t>Marzo 2026</a:t>
-                      </a:r>
-                    </a:p>
-                  </a:txBody>
-                  <a:tcPr marL="36576" marR="36576" marT="18288" marB="18288">
-                    <a:solidFill>
-                      <a:srgbClr val="FFFFFF"/>
-                    </a:solidFill>
-                  </a:tcPr>
-                </a:tc>
-                <a:tc>
-                  <a:txBody>
-                    <a:bodyPr/>
-                    <a:lstStyle/>
-                    <a:p>
-                      <a:pPr algn="r"/>
-                      <a:r>
-                        <a:rPr sz="1000">
-                          <a:solidFill>
-                            <a:srgbClr val="3F3F3F"/>
-                          </a:solidFill>
-                          <a:latin typeface="Encode Sans"/>
-                        </a:rPr>
-                        <a:t>82,4</a:t>
-                      </a:r>
-                    </a:p>
-                  </a:txBody>
-                  <a:tcPr marL="36576" marR="36576" marT="18288" marB="18288">
-                    <a:solidFill>
-                      <a:srgbClr val="FFFFFF"/>
-                    </a:solidFill>
-                  </a:tcPr>
-                </a:tc>
-                <a:tc>
-                  <a:txBody>
-                    <a:bodyPr/>
-                    <a:lstStyle/>
-                    <a:p>
-                      <a:pPr algn="r"/>
-                      <a:r>
-                        <a:rPr sz="1000">
-                          <a:solidFill>
-                            <a:srgbClr val="3F3F3F"/>
-                          </a:solidFill>
-                          <a:latin typeface="Encode Sans"/>
-                        </a:rPr>
-                        <a:t>-5.1%</a:t>
-                      </a:r>
-                    </a:p>
-                  </a:txBody>
-                  <a:tcPr marL="36576" marR="36576" marT="18288" marB="18288">
-                    <a:solidFill>
-                      <a:srgbClr val="FFFFFF"/>
-                    </a:solidFill>
-                  </a:tcPr>
-                </a:tc>
-                <a:tc>
-                  <a:txBody>
-                    <a:bodyPr/>
-                    <a:lstStyle/>
-                    <a:p>
-                      <a:pPr algn="r"/>
-                      <a:r>
-                        <a:rPr sz="1000">
-                          <a:solidFill>
-                            <a:srgbClr val="3F3F3F"/>
-                          </a:solidFill>
-                          <a:latin typeface="Encode Sans"/>
-                        </a:rPr>
-                        <a:t>-3.1%</a:t>
-                      </a:r>
-                    </a:p>
-                  </a:txBody>
-                  <a:tcPr marL="36576" marR="36576" marT="18288" marB="18288">
-                    <a:solidFill>
-                      <a:srgbClr val="FFFFFF"/>
-                    </a:solidFill>
-                  </a:tcPr>
-                </a:tc>
-              </a:tr>
-              <a:tr h="292608">
-                <a:tc>
-                  <a:txBody>
-                    <a:bodyPr/>
-                    <a:lstStyle/>
-                    <a:p>
-                      <a:pPr algn="l"/>
-                      <a:r>
-                        <a:rPr sz="1000">
-                          <a:solidFill>
-                            <a:srgbClr val="3F3F3F"/>
-                          </a:solidFill>
-                          <a:latin typeface="Encode Sans"/>
-                        </a:rPr>
-                        <a:t>Febrero 2026</a:t>
-                      </a:r>
-                    </a:p>
-                  </a:txBody>
-                  <a:tcPr marL="36576" marR="36576" marT="18288" marB="18288">
-                    <a:solidFill>
-                      <a:srgbClr val="F8F8F6"/>
-                    </a:solidFill>
-                  </a:tcPr>
-                </a:tc>
-                <a:tc>
-                  <a:txBody>
-                    <a:bodyPr/>
-                    <a:lstStyle/>
-                    <a:p>
-                      <a:pPr algn="r"/>
-                      <a:r>
-                        <a:rPr sz="1000">
-                          <a:solidFill>
-                            <a:srgbClr val="3F3F3F"/>
-                          </a:solidFill>
-                          <a:latin typeface="Encode Sans"/>
-                        </a:rPr>
-                        <a:t>76,0</a:t>
-                      </a:r>
-                    </a:p>
-                  </a:txBody>
-                  <a:tcPr marL="36576" marR="36576" marT="18288" marB="18288">
-                    <a:solidFill>
-                      <a:srgbClr val="F8F8F6"/>
-                    </a:solidFill>
-                  </a:tcPr>
-                </a:tc>
-                <a:tc>
-                  <a:txBody>
-                    <a:bodyPr/>
-                    <a:lstStyle/>
-                    <a:p>
-                      <a:pPr algn="r"/>
-                      <a:r>
-                        <a:rPr sz="1000">
-                          <a:solidFill>
-                            <a:srgbClr val="3F3F3F"/>
-                          </a:solidFill>
-                          <a:latin typeface="Encode Sans"/>
-                        </a:rPr>
-                        <a:t>-3.1%</a:t>
-                      </a:r>
-                    </a:p>
-                  </a:txBody>
-                  <a:tcPr marL="36576" marR="36576" marT="18288" marB="18288">
-                    <a:solidFill>
-                      <a:srgbClr val="F8F8F6"/>
-                    </a:solidFill>
-                  </a:tcPr>
-                </a:tc>
-                <a:tc>
-                  <a:txBody>
-                    <a:bodyPr/>
-                    <a:lstStyle/>
-                    <a:p>
-                      <a:pPr algn="r"/>
-                      <a:r>
-                        <a:rPr sz="1000">
-                          <a:solidFill>
-                            <a:srgbClr val="3F3F3F"/>
-                          </a:solidFill>
-                          <a:latin typeface="Encode Sans"/>
-                        </a:rPr>
-                        <a:t>-2.1%</a:t>
-                      </a:r>
-                    </a:p>
-                  </a:txBody>
-                  <a:tcPr marL="36576" marR="36576" marT="18288" marB="18288">
-                    <a:solidFill>
-                      <a:srgbClr val="F8F8F6"/>
-                    </a:solidFill>
-                  </a:tcPr>
-                </a:tc>
-              </a:tr>
-              <a:tr h="292608">
-                <a:tc>
-                  <a:txBody>
-                    <a:bodyPr/>
-                    <a:lstStyle/>
-                    <a:p>
-                      <a:pPr algn="l"/>
-                      <a:r>
-                        <a:rPr sz="1000">
-                          <a:solidFill>
-                            <a:srgbClr val="3F3F3F"/>
-                          </a:solidFill>
-                          <a:latin typeface="Encode Sans"/>
-                        </a:rPr>
-                        <a:t>Enero 2026</a:t>
-                      </a:r>
-                    </a:p>
-                  </a:txBody>
-                  <a:tcPr marL="36576" marR="36576" marT="18288" marB="18288">
-                    <a:solidFill>
-                      <a:srgbClr val="FFFFFF"/>
-                    </a:solidFill>
-                  </a:tcPr>
-                </a:tc>
-                <a:tc>
-                  <a:txBody>
-                    <a:bodyPr/>
-                    <a:lstStyle/>
-                    <a:p>
-                      <a:pPr algn="r"/>
-                      <a:r>
-                        <a:rPr sz="1000">
-                          <a:solidFill>
-                            <a:srgbClr val="3F3F3F"/>
-                          </a:solidFill>
-                          <a:latin typeface="Encode Sans"/>
-                        </a:rPr>
-                        <a:t>82,8</a:t>
-                      </a:r>
-                    </a:p>
-                  </a:txBody>
-                  <a:tcPr marL="36576" marR="36576" marT="18288" marB="18288">
-                    <a:solidFill>
-                      <a:srgbClr val="FFFFFF"/>
-                    </a:solidFill>
-                  </a:tcPr>
-                </a:tc>
-                <a:tc>
-                  <a:txBody>
-                    <a:bodyPr/>
-                    <a:lstStyle/>
-                    <a:p>
-                      <a:pPr algn="r"/>
-                      <a:r>
-                        <a:rPr sz="1000">
-                          <a:solidFill>
-                            <a:srgbClr val="3F3F3F"/>
-                          </a:solidFill>
-                          <a:latin typeface="Encode Sans"/>
-                        </a:rPr>
-                        <a:t>-1.2%</a:t>
-                      </a:r>
-                    </a:p>
-                  </a:txBody>
-                  <a:tcPr marL="36576" marR="36576" marT="18288" marB="18288">
-                    <a:solidFill>
-                      <a:srgbClr val="FFFFFF"/>
-                    </a:solidFill>
-                  </a:tcPr>
-                </a:tc>
-                <a:tc>
-                  <a:txBody>
-                    <a:bodyPr/>
-                    <a:lstStyle/>
-                    <a:p>
-                      <a:pPr algn="r"/>
-                      <a:r>
-                        <a:rPr sz="1000">
-                          <a:solidFill>
-                            <a:srgbClr val="3F3F3F"/>
-                          </a:solidFill>
-                          <a:latin typeface="Encode Sans"/>
-                        </a:rPr>
-                        <a:t>-1.2%</a:t>
-                      </a:r>
-                    </a:p>
-                  </a:txBody>
-                  <a:tcPr marL="36576" marR="36576" marT="18288" marB="18288">
-                    <a:solidFill>
-                      <a:srgbClr val="FFFFFF"/>
-                    </a:solidFill>
-                  </a:tcPr>
-                </a:tc>
-              </a:tr>
-              <a:tr h="292608">
-                <a:tc>
-                  <a:txBody>
-                    <a:bodyPr/>
-                    <a:lstStyle/>
-                    <a:p>
-                      <a:pPr algn="l"/>
-                      <a:r>
-                        <a:rPr sz="1000">
-                          <a:solidFill>
-                            <a:srgbClr val="3F3F3F"/>
-                          </a:solidFill>
-                          <a:latin typeface="Encode Sans"/>
-                        </a:rPr>
-                        <a:t>Diciembre 2025</a:t>
-                      </a:r>
-                    </a:p>
-                  </a:txBody>
-                  <a:tcPr marL="36576" marR="36576" marT="18288" marB="18288">
-                    <a:solidFill>
-                      <a:srgbClr val="F8F8F6"/>
-                    </a:solidFill>
-                  </a:tcPr>
-                </a:tc>
-                <a:tc>
-                  <a:txBody>
-                    <a:bodyPr/>
-                    <a:lstStyle/>
-                    <a:p>
-                      <a:pPr algn="r"/>
-                      <a:r>
-                        <a:rPr sz="1000">
-                          <a:solidFill>
-                            <a:srgbClr val="3F3F3F"/>
-                          </a:solidFill>
-                          <a:latin typeface="Encode Sans"/>
-                        </a:rPr>
-                        <a:t>102,3</a:t>
-                      </a:r>
-                    </a:p>
-                  </a:txBody>
-                  <a:tcPr marL="36576" marR="36576" marT="18288" marB="18288">
-                    <a:solidFill>
-                      <a:srgbClr val="F8F8F6"/>
-                    </a:solidFill>
-                  </a:tcPr>
-                </a:tc>
-                <a:tc>
-                  <a:txBody>
-                    <a:bodyPr/>
-                    <a:lstStyle/>
-                    <a:p>
-                      <a:pPr algn="r"/>
-                      <a:r>
-                        <a:rPr sz="1000">
-                          <a:solidFill>
-                            <a:srgbClr val="3F3F3F"/>
-                          </a:solidFill>
-                          <a:latin typeface="Encode Sans"/>
-                        </a:rPr>
-                        <a:t>+0.5%</a:t>
-                      </a:r>
-                    </a:p>
-                  </a:txBody>
-                  <a:tcPr marL="36576" marR="36576" marT="18288" marB="18288">
-                    <a:solidFill>
-                      <a:srgbClr val="F8F8F6"/>
-                    </a:solidFill>
-                  </a:tcPr>
-                </a:tc>
-                <a:tc>
-                  <a:txBody>
-                    <a:bodyPr/>
-                    <a:lstStyle/>
-                    <a:p>
-                      <a:pPr algn="r"/>
-                      <a:r>
-                        <a:rPr sz="1000">
-                          <a:solidFill>
-                            <a:srgbClr val="3F3F3F"/>
-                          </a:solidFill>
-                          <a:latin typeface="Encode Sans"/>
-                        </a:rPr>
-                        <a:t>+2.0%</a:t>
+                        <a:t>-1.082.135</a:t>
                       </a:r>
                     </a:p>
                   </a:txBody>

</xml_diff>

<commit_message>
data: update 2026-08-07 ( data.json despidos.json scraper/historical_despidos.json publicaciones_semana.pptx rrii_brutas.xlsx)
</commit_message>
<xml_diff>
--- a/publicaciones_semana.pptx
+++ b/publicaciones_semana.pptx
@@ -3238,7 +3238,7 @@
                 </a:solidFill>
                 <a:latin typeface="Encode Sans"/>
               </a:rPr>
-              <a:t>Publicaciones de la semana del 27 de julio de 2026</a:t>
+              <a:t>Publicaciones de la semana del 03 de agosto de 2026</a:t>
             </a:r>
           </a:p>
         </p:txBody>
@@ -3368,7 +3368,7 @@
                 </a:solidFill>
                 <a:latin typeface="Encode Sans"/>
               </a:rPr>
-              <a:t>TURISMO INTERNACIONAL JUNIO 2026: SALDO -172.741 PERSONAS</a:t>
+              <a:t>INDUSTRIA JUNIO 2026: IPI CRECIÓ +2.0% I.A.</a:t>
             </a:r>
           </a:p>
         </p:txBody>
@@ -3437,7 +3437,7 @@
                 </a:solidFill>
                 <a:latin typeface="Encode Sans"/>
               </a:rPr>
-              <a:t>En junio 2026 ingresaron 329.177 turistas no residentes y salieron 501.918 argentinos al exterior, con saldo de -172.741 personas. Receptivo +3.3% i.a., emisivo -22.0% i.a.</a:t>
+              <a:t>El Índice de Producción Industrial Manufacturero (IPI) registró una variación interanual de +2.0% en junio 2026.</a:t>
             </a:r>
           </a:p>
         </p:txBody>
@@ -3485,7 +3485,7 @@
                 </a:solidFill>
                 <a:latin typeface="Encode Sans"/>
               </a:rPr>
-              <a:t>Receptivo: 329.177 personas</a:t>
+              <a:t>Variación interanual: +2.0%</a:t>
             </a:r>
           </a:p>
           <a:p>
@@ -3510,57 +3510,7 @@
                 </a:solidFill>
                 <a:latin typeface="Encode Sans"/>
               </a:rPr>
-              <a:t>Emisivo: 501.918 personas</a:t>
-            </a:r>
-          </a:p>
-          <a:p>
-            <a:pPr algn="l">
-              <a:spcAft>
-                <a:spcPts val="800"/>
-              </a:spcAft>
-            </a:pPr>
-            <a:r>
-              <a:rPr sz="1300" b="1" i="0">
-                <a:solidFill>
-                  <a:srgbClr val="00B2C9"/>
-                </a:solidFill>
-                <a:latin typeface="Encode Sans"/>
-              </a:rPr>
-              <a:t>●  </a:t>
-            </a:r>
-            <a:r>
-              <a:rPr sz="1300" b="0" i="0">
-                <a:solidFill>
-                  <a:srgbClr val="3F3F3F"/>
-                </a:solidFill>
-                <a:latin typeface="Encode Sans"/>
-              </a:rPr>
-              <a:t>Saldo (receptivo − emisivo): -172.741 personas</a:t>
-            </a:r>
-          </a:p>
-          <a:p>
-            <a:pPr algn="l">
-              <a:spcAft>
-                <a:spcPts val="800"/>
-              </a:spcAft>
-            </a:pPr>
-            <a:r>
-              <a:rPr sz="1300" b="1" i="0">
-                <a:solidFill>
-                  <a:srgbClr val="00B2C9"/>
-                </a:solidFill>
-                <a:latin typeface="Encode Sans"/>
-              </a:rPr>
-              <a:t>●  </a:t>
-            </a:r>
-            <a:r>
-              <a:rPr sz="1300" b="0" i="0">
-                <a:solidFill>
-                  <a:srgbClr val="3F3F3F"/>
-                </a:solidFill>
-                <a:latin typeface="Encode Sans"/>
-              </a:rPr>
-              <a:t>Fuente: INDEC, Estadísticas de Turismo Internacional (todas las vías)</a:t>
+              <a:t>Serie INDEC, base 2004=100. Mide la producción manufacturera (16 ramas).</a:t>
             </a:r>
           </a:p>
         </p:txBody>
@@ -3608,10 +3558,9 @@
                 <a:tableStyleId>{5C22544A-7EE6-4342-B048-85BDC9FD1C3A}</a:tableStyleId>
               </a:tblPr>
               <a:tblGrid>
-                <a:gridCol w="1417320"/>
-                <a:gridCol w="1417320"/>
-                <a:gridCol w="1417320"/>
-                <a:gridCol w="1417320"/>
+                <a:gridCol w="1889760"/>
+                <a:gridCol w="1889760"/>
+                <a:gridCol w="1889760"/>
               </a:tblGrid>
               <a:tr h="292608">
                 <a:tc>
@@ -3650,7 +3599,7 @@
                           </a:solidFill>
                           <a:latin typeface="Encode Sans"/>
                         </a:rPr>
-                        <a:t>Receptivo</a:t>
+                        <a:t>Original</a:t>
                       </a:r>
                     </a:p>
                   </a:txBody>
@@ -3673,30 +3622,7 @@
                           </a:solidFill>
                           <a:latin typeface="Encode Sans"/>
                         </a:rPr>
-                        <a:t>Emisivo</a:t>
-                      </a:r>
-                    </a:p>
-                  </a:txBody>
-                  <a:tcPr marL="36576" marR="36576" marT="18288" marB="18288">
-                    <a:solidFill>
-                      <a:srgbClr val="00B2C9"/>
-                    </a:solidFill>
-                  </a:tcPr>
-                </a:tc>
-                <a:tc>
-                  <a:txBody>
-                    <a:bodyPr/>
-                    <a:lstStyle/>
-                    <a:p>
-                      <a:pPr algn="r"/>
-                      <a:r>
-                        <a:rPr sz="1000" b="1">
-                          <a:solidFill>
-                            <a:srgbClr val="FFFFFF"/>
-                          </a:solidFill>
-                          <a:latin typeface="Encode Sans"/>
-                        </a:rPr>
-                        <a:t>Saldo</a:t>
+                        <a:t>VIA %</a:t>
                       </a:r>
                     </a:p>
                   </a:txBody>
@@ -3744,7 +3670,7 @@
                           </a:solidFill>
                           <a:latin typeface="Encode Sans"/>
                         </a:rPr>
-                        <a:t>329.177</a:t>
+                        <a:t>119,9</a:t>
                       </a:r>
                     </a:p>
                   </a:txBody>
@@ -3767,30 +3693,7 @@
                           </a:solidFill>
                           <a:latin typeface="Encode Sans"/>
                         </a:rPr>
-                        <a:t>501.918</a:t>
-                      </a:r>
-                    </a:p>
-                  </a:txBody>
-                  <a:tcPr marL="36576" marR="36576" marT="18288" marB="18288">
-                    <a:solidFill>
-                      <a:srgbClr val="FFFFFF"/>
-                    </a:solidFill>
-                  </a:tcPr>
-                </a:tc>
-                <a:tc>
-                  <a:txBody>
-                    <a:bodyPr/>
-                    <a:lstStyle/>
-                    <a:p>
-                      <a:pPr algn="r"/>
-                      <a:r>
-                        <a:rPr sz="1000">
-                          <a:solidFill>
-                            <a:srgbClr val="3F3F3F"/>
-                          </a:solidFill>
-                          <a:latin typeface="Encode Sans"/>
-                        </a:rPr>
-                        <a:t>-172.741</a:t>
+                        <a:t>+2.0%</a:t>
                       </a:r>
                     </a:p>
                   </a:txBody>
@@ -3838,7 +3741,7 @@
                           </a:solidFill>
                           <a:latin typeface="Encode Sans"/>
                         </a:rPr>
-                        <a:t>379.860</a:t>
+                        <a:t>117,0</a:t>
                       </a:r>
                     </a:p>
                   </a:txBody>
@@ -3861,30 +3764,7 @@
                           </a:solidFill>
                           <a:latin typeface="Encode Sans"/>
                         </a:rPr>
-                        <a:t>661.853</a:t>
-                      </a:r>
-                    </a:p>
-                  </a:txBody>
-                  <a:tcPr marL="36576" marR="36576" marT="18288" marB="18288">
-                    <a:solidFill>
-                      <a:srgbClr val="F8F8F6"/>
-                    </a:solidFill>
-                  </a:tcPr>
-                </a:tc>
-                <a:tc>
-                  <a:txBody>
-                    <a:bodyPr/>
-                    <a:lstStyle/>
-                    <a:p>
-                      <a:pPr algn="r"/>
-                      <a:r>
-                        <a:rPr sz="1000">
-                          <a:solidFill>
-                            <a:srgbClr val="3F3F3F"/>
-                          </a:solidFill>
-                          <a:latin typeface="Encode Sans"/>
-                        </a:rPr>
-                        <a:t>-281.993</a:t>
+                        <a:t>-5.6%</a:t>
                       </a:r>
                     </a:p>
                   </a:txBody>
@@ -3932,7 +3812,7 @@
                           </a:solidFill>
                           <a:latin typeface="Encode Sans"/>
                         </a:rPr>
-                        <a:t>463.072</a:t>
+                        <a:t>118,6</a:t>
                       </a:r>
                     </a:p>
                   </a:txBody>
@@ -3955,30 +3835,7 @@
                           </a:solidFill>
                           <a:latin typeface="Encode Sans"/>
                         </a:rPr>
-                        <a:t>764.757</a:t>
-                      </a:r>
-                    </a:p>
-                  </a:txBody>
-                  <a:tcPr marL="36576" marR="36576" marT="18288" marB="18288">
-                    <a:solidFill>
-                      <a:srgbClr val="FFFFFF"/>
-                    </a:solidFill>
-                  </a:tcPr>
-                </a:tc>
-                <a:tc>
-                  <a:txBody>
-                    <a:bodyPr/>
-                    <a:lstStyle/>
-                    <a:p>
-                      <a:pPr algn="r"/>
-                      <a:r>
-                        <a:rPr sz="1000">
-                          <a:solidFill>
-                            <a:srgbClr val="3F3F3F"/>
-                          </a:solidFill>
-                          <a:latin typeface="Encode Sans"/>
-                        </a:rPr>
-                        <a:t>-301.685</a:t>
+                        <a:t>-2.4%</a:t>
                       </a:r>
                     </a:p>
                   </a:txBody>
@@ -4026,7 +3883,7 @@
                           </a:solidFill>
                           <a:latin typeface="Encode Sans"/>
                         </a:rPr>
-                        <a:t>509.625</a:t>
+                        <a:t>122,2</a:t>
                       </a:r>
                     </a:p>
                   </a:txBody>
@@ -4049,30 +3906,7 @@
                           </a:solidFill>
                           <a:latin typeface="Encode Sans"/>
                         </a:rPr>
-                        <a:t>1.061.777</a:t>
-                      </a:r>
-                    </a:p>
-                  </a:txBody>
-                  <a:tcPr marL="36576" marR="36576" marT="18288" marB="18288">
-                    <a:solidFill>
-                      <a:srgbClr val="F8F8F6"/>
-                    </a:solidFill>
-                  </a:tcPr>
-                </a:tc>
-                <a:tc>
-                  <a:txBody>
-                    <a:bodyPr/>
-                    <a:lstStyle/>
-                    <a:p>
-                      <a:pPr algn="r"/>
-                      <a:r>
-                        <a:rPr sz="1000">
-                          <a:solidFill>
-                            <a:srgbClr val="3F3F3F"/>
-                          </a:solidFill>
-                          <a:latin typeface="Encode Sans"/>
-                        </a:rPr>
-                        <a:t>-552.152</a:t>
+                        <a:t>+5.1%</a:t>
                       </a:r>
                     </a:p>
                   </a:txBody>
@@ -4120,7 +3954,7 @@
                           </a:solidFill>
                           <a:latin typeface="Encode Sans"/>
                         </a:rPr>
-                        <a:t>534.223</a:t>
+                        <a:t>100,3</a:t>
                       </a:r>
                     </a:p>
                   </a:txBody>
@@ -4143,30 +3977,7 @@
                           </a:solidFill>
                           <a:latin typeface="Encode Sans"/>
                         </a:rPr>
-                        <a:t>1.629.180</a:t>
-                      </a:r>
-                    </a:p>
-                  </a:txBody>
-                  <a:tcPr marL="36576" marR="36576" marT="18288" marB="18288">
-                    <a:solidFill>
-                      <a:srgbClr val="FFFFFF"/>
-                    </a:solidFill>
-                  </a:tcPr>
-                </a:tc>
-                <a:tc>
-                  <a:txBody>
-                    <a:bodyPr/>
-                    <a:lstStyle/>
-                    <a:p>
-                      <a:pPr algn="r"/>
-                      <a:r>
-                        <a:rPr sz="1000">
-                          <a:solidFill>
-                            <a:srgbClr val="3F3F3F"/>
-                          </a:solidFill>
-                          <a:latin typeface="Encode Sans"/>
-                        </a:rPr>
-                        <a:t>-1.094.957</a:t>
+                        <a:t>-8.8%</a:t>
                       </a:r>
                     </a:p>
                   </a:txBody>
@@ -4214,7 +4025,7 @@
                           </a:solidFill>
                           <a:latin typeface="Encode Sans"/>
                         </a:rPr>
-                        <a:t>681.956</a:t>
+                        <a:t>106,5</a:t>
                       </a:r>
                     </a:p>
                   </a:txBody>
@@ -4237,30 +4048,7 @@
                           </a:solidFill>
                           <a:latin typeface="Encode Sans"/>
                         </a:rPr>
-                        <a:t>1.764.091</a:t>
-                      </a:r>
-                    </a:p>
-                  </a:txBody>
-                  <a:tcPr marL="36576" marR="36576" marT="18288" marB="18288">
-                    <a:solidFill>
-                      <a:srgbClr val="F8F8F6"/>
-                    </a:solidFill>
-                  </a:tcPr>
-                </a:tc>
-                <a:tc>
-                  <a:txBody>
-                    <a:bodyPr/>
-                    <a:lstStyle/>
-                    <a:p>
-                      <a:pPr algn="r"/>
-                      <a:r>
-                        <a:rPr sz="1000">
-                          <a:solidFill>
-                            <a:srgbClr val="3F3F3F"/>
-                          </a:solidFill>
-                          <a:latin typeface="Encode Sans"/>
-                        </a:rPr>
-                        <a:t>-1.082.135</a:t>
+                        <a:t>-3.8%</a:t>
                       </a:r>
                     </a:p>
                   </a:txBody>

</xml_diff>

<commit_message>
data: update 2026-08-08 ( data.json despidos.json scraper/historical_despidos.json publicaciones_semana.pptx rrii_brutas.xlsx)
</commit_message>
<xml_diff>
--- a/publicaciones_semana.pptx
+++ b/publicaciones_semana.pptx
@@ -7,6 +7,7 @@
   <p:sldIdLst>
     <p:sldId id="256" r:id="rId7"/>
     <p:sldId id="257" r:id="rId8"/>
+    <p:sldId id="258" r:id="rId9"/>
   </p:sldIdLst>
   <p:sldSz cx="12191695" cy="6858000" type="screen4x3"/>
   <p:notesSz cx="6858000" cy="9144000"/>
@@ -3272,7 +3273,7 @@
                 </a:solidFill>
                 <a:latin typeface="Encode Sans"/>
               </a:rPr>
-              <a:t>1 publicaciones · datos oficiales INDEC / BCRA / Hacienda</a:t>
+              <a:t>2 publicaciones · datos oficiales INDEC / BCRA / Hacienda</a:t>
             </a:r>
           </a:p>
         </p:txBody>
@@ -4105,6 +4106,826 @@
 </p:sld>
 </file>
 
+<file path=ppt/slides/slide3.xml><?xml version="1.0" encoding="utf-8"?>
+<p:sld xmlns:a="http://schemas.openxmlformats.org/drawingml/2006/main" xmlns:p="http://schemas.openxmlformats.org/presentationml/2006/main" xmlns:r="http://schemas.openxmlformats.org/officeDocument/2006/relationships">
+  <p:cSld>
+    <p:spTree>
+      <p:nvGrpSpPr>
+        <p:cNvPr id="1" name=""/>
+        <p:cNvGrpSpPr/>
+        <p:nvPr/>
+      </p:nvGrpSpPr>
+      <p:grpSpPr/>
+      <p:sp>
+        <p:nvSpPr>
+          <p:cNvPr id="2" name="Rectangle 1"/>
+          <p:cNvSpPr/>
+          <p:nvPr/>
+        </p:nvSpPr>
+        <p:spPr>
+          <a:xfrm>
+            <a:off x="0" y="0"/>
+            <a:ext cx="12191695" cy="274320"/>
+          </a:xfrm>
+          <a:prstGeom prst="rect">
+            <a:avLst/>
+          </a:prstGeom>
+          <a:solidFill>
+            <a:srgbClr val="00B2C9"/>
+          </a:solidFill>
+          <a:ln>
+            <a:noFill/>
+          </a:ln>
+        </p:spPr>
+        <p:style>
+          <a:lnRef idx="1">
+            <a:schemeClr val="accent1"/>
+          </a:lnRef>
+          <a:fillRef idx="3">
+            <a:schemeClr val="accent1"/>
+          </a:fillRef>
+          <a:effectRef idx="2">
+            <a:schemeClr val="accent1"/>
+          </a:effectRef>
+          <a:fontRef idx="minor">
+            <a:schemeClr val="lt1"/>
+          </a:fontRef>
+        </p:style>
+        <p:txBody>
+          <a:bodyPr rtlCol="0" anchor="ctr"/>
+          <a:lstStyle/>
+          <a:p>
+            <a:pPr algn="ctr"/>
+          </a:p>
+        </p:txBody>
+      </p:sp>
+      <p:sp>
+        <p:nvSpPr>
+          <p:cNvPr id="3" name="TextBox 2"/>
+          <p:cNvSpPr txBox="1"/>
+          <p:nvPr/>
+        </p:nvSpPr>
+        <p:spPr>
+          <a:xfrm>
+            <a:off x="411480" y="457200"/>
+            <a:ext cx="11368735" cy="914400"/>
+          </a:xfrm>
+          <a:prstGeom prst="rect">
+            <a:avLst/>
+          </a:prstGeom>
+          <a:noFill/>
+        </p:spPr>
+        <p:txBody>
+          <a:bodyPr wrap="square" lIns="0" rIns="0">
+            <a:spAutoFit/>
+          </a:bodyPr>
+          <a:lstStyle/>
+          <a:p>
+            <a:pPr algn="l"/>
+            <a:r>
+              <a:rPr sz="2600" b="1" i="0">
+                <a:solidFill>
+                  <a:srgbClr val="00B2C9"/>
+                </a:solidFill>
+                <a:latin typeface="Encode Sans"/>
+              </a:rPr>
+              <a:t>INDUSTRIA JUNIO 2026: IPI CRECIÓ +0.0% I.A.</a:t>
+            </a:r>
+          </a:p>
+        </p:txBody>
+      </p:sp>
+      <p:sp>
+        <p:nvSpPr>
+          <p:cNvPr id="4" name="TextBox 3"/>
+          <p:cNvSpPr txBox="1"/>
+          <p:nvPr/>
+        </p:nvSpPr>
+        <p:spPr>
+          <a:xfrm>
+            <a:off x="411480" y="1280160"/>
+            <a:ext cx="11368735" cy="274320"/>
+          </a:xfrm>
+          <a:prstGeom prst="rect">
+            <a:avLst/>
+          </a:prstGeom>
+          <a:noFill/>
+        </p:spPr>
+        <p:txBody>
+          <a:bodyPr wrap="none">
+            <a:spAutoFit/>
+          </a:bodyPr>
+          <a:lstStyle/>
+          <a:p>
+            <a:r>
+              <a:rPr sz="1100" b="0" i="1">
+                <a:solidFill>
+                  <a:srgbClr val="6A6760"/>
+                </a:solidFill>
+                <a:latin typeface="Encode Sans"/>
+              </a:rPr>
+              <a:t>INDEC · período 2026-06</a:t>
+            </a:r>
+          </a:p>
+        </p:txBody>
+      </p:sp>
+      <p:sp>
+        <p:nvSpPr>
+          <p:cNvPr id="5" name="TextBox 4"/>
+          <p:cNvSpPr txBox="1"/>
+          <p:nvPr/>
+        </p:nvSpPr>
+        <p:spPr>
+          <a:xfrm>
+            <a:off x="411480" y="1691640"/>
+            <a:ext cx="5486400" cy="1645920"/>
+          </a:xfrm>
+          <a:prstGeom prst="rect">
+            <a:avLst/>
+          </a:prstGeom>
+          <a:noFill/>
+        </p:spPr>
+        <p:txBody>
+          <a:bodyPr wrap="square" lIns="0" rIns="0">
+            <a:spAutoFit/>
+          </a:bodyPr>
+          <a:lstStyle/>
+          <a:p>
+            <a:pPr algn="just"/>
+            <a:r>
+              <a:rPr sz="1300" b="0" i="0">
+                <a:solidFill>
+                  <a:srgbClr val="3F3F3F"/>
+                </a:solidFill>
+                <a:latin typeface="Encode Sans"/>
+              </a:rPr>
+              <a:t>El Índice de Producción Industrial Manufacturero (IPI) registró una variación interanual de +0.0% en junio 2026.</a:t>
+            </a:r>
+          </a:p>
+        </p:txBody>
+      </p:sp>
+      <p:sp>
+        <p:nvSpPr>
+          <p:cNvPr id="6" name="TextBox 5"/>
+          <p:cNvSpPr txBox="1"/>
+          <p:nvPr/>
+        </p:nvSpPr>
+        <p:spPr>
+          <a:xfrm>
+            <a:off x="411480" y="3520440"/>
+            <a:ext cx="5486400" cy="2743200"/>
+          </a:xfrm>
+          <a:prstGeom prst="rect">
+            <a:avLst/>
+          </a:prstGeom>
+          <a:noFill/>
+        </p:spPr>
+        <p:txBody>
+          <a:bodyPr wrap="square" lIns="0" rIns="0">
+            <a:spAutoFit/>
+          </a:bodyPr>
+          <a:lstStyle/>
+          <a:p>
+            <a:pPr algn="l">
+              <a:spcAft>
+                <a:spcPts val="800"/>
+              </a:spcAft>
+            </a:pPr>
+            <a:r>
+              <a:rPr sz="1300" b="1" i="0">
+                <a:solidFill>
+                  <a:srgbClr val="00B2C9"/>
+                </a:solidFill>
+                <a:latin typeface="Encode Sans"/>
+              </a:rPr>
+              <a:t>●  </a:t>
+            </a:r>
+            <a:r>
+              <a:rPr sz="1300" b="0" i="0">
+                <a:solidFill>
+                  <a:srgbClr val="3F3F3F"/>
+                </a:solidFill>
+                <a:latin typeface="Encode Sans"/>
+              </a:rPr>
+              <a:t>Variación interanual: +0.0%</a:t>
+            </a:r>
+          </a:p>
+          <a:p>
+            <a:pPr algn="l">
+              <a:spcAft>
+                <a:spcPts val="800"/>
+              </a:spcAft>
+            </a:pPr>
+            <a:r>
+              <a:rPr sz="1300" b="1" i="0">
+                <a:solidFill>
+                  <a:srgbClr val="00B2C9"/>
+                </a:solidFill>
+                <a:latin typeface="Encode Sans"/>
+              </a:rPr>
+              <a:t>●  </a:t>
+            </a:r>
+            <a:r>
+              <a:rPr sz="1300" b="0" i="0">
+                <a:solidFill>
+                  <a:srgbClr val="3F3F3F"/>
+                </a:solidFill>
+                <a:latin typeface="Encode Sans"/>
+              </a:rPr>
+              <a:t>Serie INDEC, base 2004=100. Mide la producción manufacturera (16 ramas).</a:t>
+            </a:r>
+          </a:p>
+        </p:txBody>
+      </p:sp>
+      <p:pic>
+        <p:nvPicPr>
+          <p:cNvPr id="7" name="Picture 6" descr="image.png"/>
+          <p:cNvPicPr>
+            <a:picLocks noChangeAspect="1"/>
+          </p:cNvPicPr>
+          <p:nvPr/>
+        </p:nvPicPr>
+        <p:blipFill>
+          <a:blip r:embed="rId2"/>
+          <a:stretch>
+            <a:fillRect/>
+          </a:stretch>
+        </p:blipFill>
+        <p:spPr>
+          <a:xfrm>
+            <a:off x="6080760" y="1691640"/>
+            <a:ext cx="5669280" cy="2560320"/>
+          </a:xfrm>
+          <a:prstGeom prst="rect">
+            <a:avLst/>
+          </a:prstGeom>
+        </p:spPr>
+      </p:pic>
+      <p:graphicFrame>
+        <p:nvGraphicFramePr>
+          <p:cNvPr id="8" name="Table 7"/>
+          <p:cNvGraphicFramePr>
+            <a:graphicFrameLocks noGrp="1"/>
+          </p:cNvGraphicFramePr>
+          <p:nvPr/>
+        </p:nvGraphicFramePr>
+        <p:xfrm>
+          <a:off x="6080760" y="4434840"/>
+          <a:ext cx="5669280" cy="2048256"/>
+        </p:xfrm>
+        <a:graphic>
+          <a:graphicData uri="http://schemas.openxmlformats.org/drawingml/2006/table">
+            <a:tbl>
+              <a:tblPr firstRow="1" bandRow="1">
+                <a:tableStyleId>{5C22544A-7EE6-4342-B048-85BDC9FD1C3A}</a:tableStyleId>
+              </a:tblPr>
+              <a:tblGrid>
+                <a:gridCol w="1889760"/>
+                <a:gridCol w="1889760"/>
+                <a:gridCol w="1889760"/>
+              </a:tblGrid>
+              <a:tr h="292608">
+                <a:tc>
+                  <a:txBody>
+                    <a:bodyPr/>
+                    <a:lstStyle/>
+                    <a:p>
+                      <a:pPr algn="l"/>
+                      <a:r>
+                        <a:rPr sz="1000" b="1">
+                          <a:solidFill>
+                            <a:srgbClr val="FFFFFF"/>
+                          </a:solidFill>
+                          <a:latin typeface="Encode Sans"/>
+                        </a:rPr>
+                        <a:t>Mes</a:t>
+                      </a:r>
+                    </a:p>
+                  </a:txBody>
+                  <a:tcPr marL="36576" marR="36576" marT="18288" marB="18288">
+                    <a:solidFill>
+                      <a:srgbClr val="00B2C9"/>
+                    </a:solidFill>
+                  </a:tcPr>
+                </a:tc>
+                <a:tc>
+                  <a:txBody>
+                    <a:bodyPr/>
+                    <a:lstStyle/>
+                    <a:p>
+                      <a:pPr algn="r"/>
+                      <a:r>
+                        <a:rPr sz="1000" b="1">
+                          <a:solidFill>
+                            <a:srgbClr val="FFFFFF"/>
+                          </a:solidFill>
+                          <a:latin typeface="Encode Sans"/>
+                        </a:rPr>
+                        <a:t>Original</a:t>
+                      </a:r>
+                    </a:p>
+                  </a:txBody>
+                  <a:tcPr marL="36576" marR="36576" marT="18288" marB="18288">
+                    <a:solidFill>
+                      <a:srgbClr val="00B2C9"/>
+                    </a:solidFill>
+                  </a:tcPr>
+                </a:tc>
+                <a:tc>
+                  <a:txBody>
+                    <a:bodyPr/>
+                    <a:lstStyle/>
+                    <a:p>
+                      <a:pPr algn="r"/>
+                      <a:r>
+                        <a:rPr sz="1000" b="1">
+                          <a:solidFill>
+                            <a:srgbClr val="FFFFFF"/>
+                          </a:solidFill>
+                          <a:latin typeface="Encode Sans"/>
+                        </a:rPr>
+                        <a:t>VIA %</a:t>
+                      </a:r>
+                    </a:p>
+                  </a:txBody>
+                  <a:tcPr marL="36576" marR="36576" marT="18288" marB="18288">
+                    <a:solidFill>
+                      <a:srgbClr val="00B2C9"/>
+                    </a:solidFill>
+                  </a:tcPr>
+                </a:tc>
+              </a:tr>
+              <a:tr h="292608">
+                <a:tc>
+                  <a:txBody>
+                    <a:bodyPr/>
+                    <a:lstStyle/>
+                    <a:p>
+                      <a:pPr algn="l"/>
+                      <a:r>
+                        <a:rPr sz="1000">
+                          <a:solidFill>
+                            <a:srgbClr val="3F3F3F"/>
+                          </a:solidFill>
+                          <a:latin typeface="Encode Sans"/>
+                        </a:rPr>
+                        <a:t>Junio 2026</a:t>
+                      </a:r>
+                    </a:p>
+                  </a:txBody>
+                  <a:tcPr marL="36576" marR="36576" marT="18288" marB="18288">
+                    <a:solidFill>
+                      <a:srgbClr val="FFFFFF"/>
+                    </a:solidFill>
+                  </a:tcPr>
+                </a:tc>
+                <a:tc>
+                  <a:txBody>
+                    <a:bodyPr/>
+                    <a:lstStyle/>
+                    <a:p>
+                      <a:pPr algn="r"/>
+                      <a:r>
+                        <a:rPr sz="1000">
+                          <a:solidFill>
+                            <a:srgbClr val="3F3F3F"/>
+                          </a:solidFill>
+                          <a:latin typeface="Encode Sans"/>
+                        </a:rPr>
+                        <a:t>119,9</a:t>
+                      </a:r>
+                    </a:p>
+                  </a:txBody>
+                  <a:tcPr marL="36576" marR="36576" marT="18288" marB="18288">
+                    <a:solidFill>
+                      <a:srgbClr val="FFFFFF"/>
+                    </a:solidFill>
+                  </a:tcPr>
+                </a:tc>
+                <a:tc>
+                  <a:txBody>
+                    <a:bodyPr/>
+                    <a:lstStyle/>
+                    <a:p>
+                      <a:pPr algn="r"/>
+                      <a:r>
+                        <a:rPr sz="1000">
+                          <a:solidFill>
+                            <a:srgbClr val="3F3F3F"/>
+                          </a:solidFill>
+                          <a:latin typeface="Encode Sans"/>
+                        </a:rPr>
+                        <a:t>+2.0%</a:t>
+                      </a:r>
+                    </a:p>
+                  </a:txBody>
+                  <a:tcPr marL="36576" marR="36576" marT="18288" marB="18288">
+                    <a:solidFill>
+                      <a:srgbClr val="FFFFFF"/>
+                    </a:solidFill>
+                  </a:tcPr>
+                </a:tc>
+              </a:tr>
+              <a:tr h="292608">
+                <a:tc>
+                  <a:txBody>
+                    <a:bodyPr/>
+                    <a:lstStyle/>
+                    <a:p>
+                      <a:pPr algn="l"/>
+                      <a:r>
+                        <a:rPr sz="1000">
+                          <a:solidFill>
+                            <a:srgbClr val="3F3F3F"/>
+                          </a:solidFill>
+                          <a:latin typeface="Encode Sans"/>
+                        </a:rPr>
+                        <a:t>Mayo 2026</a:t>
+                      </a:r>
+                    </a:p>
+                  </a:txBody>
+                  <a:tcPr marL="36576" marR="36576" marT="18288" marB="18288">
+                    <a:solidFill>
+                      <a:srgbClr val="F8F8F6"/>
+                    </a:solidFill>
+                  </a:tcPr>
+                </a:tc>
+                <a:tc>
+                  <a:txBody>
+                    <a:bodyPr/>
+                    <a:lstStyle/>
+                    <a:p>
+                      <a:pPr algn="r"/>
+                      <a:r>
+                        <a:rPr sz="1000">
+                          <a:solidFill>
+                            <a:srgbClr val="3F3F3F"/>
+                          </a:solidFill>
+                          <a:latin typeface="Encode Sans"/>
+                        </a:rPr>
+                        <a:t>117,0</a:t>
+                      </a:r>
+                    </a:p>
+                  </a:txBody>
+                  <a:tcPr marL="36576" marR="36576" marT="18288" marB="18288">
+                    <a:solidFill>
+                      <a:srgbClr val="F8F8F6"/>
+                    </a:solidFill>
+                  </a:tcPr>
+                </a:tc>
+                <a:tc>
+                  <a:txBody>
+                    <a:bodyPr/>
+                    <a:lstStyle/>
+                    <a:p>
+                      <a:pPr algn="r"/>
+                      <a:r>
+                        <a:rPr sz="1000">
+                          <a:solidFill>
+                            <a:srgbClr val="3F3F3F"/>
+                          </a:solidFill>
+                          <a:latin typeface="Encode Sans"/>
+                        </a:rPr>
+                        <a:t>-5.6%</a:t>
+                      </a:r>
+                    </a:p>
+                  </a:txBody>
+                  <a:tcPr marL="36576" marR="36576" marT="18288" marB="18288">
+                    <a:solidFill>
+                      <a:srgbClr val="F8F8F6"/>
+                    </a:solidFill>
+                  </a:tcPr>
+                </a:tc>
+              </a:tr>
+              <a:tr h="292608">
+                <a:tc>
+                  <a:txBody>
+                    <a:bodyPr/>
+                    <a:lstStyle/>
+                    <a:p>
+                      <a:pPr algn="l"/>
+                      <a:r>
+                        <a:rPr sz="1000">
+                          <a:solidFill>
+                            <a:srgbClr val="3F3F3F"/>
+                          </a:solidFill>
+                          <a:latin typeface="Encode Sans"/>
+                        </a:rPr>
+                        <a:t>Abril 2026</a:t>
+                      </a:r>
+                    </a:p>
+                  </a:txBody>
+                  <a:tcPr marL="36576" marR="36576" marT="18288" marB="18288">
+                    <a:solidFill>
+                      <a:srgbClr val="FFFFFF"/>
+                    </a:solidFill>
+                  </a:tcPr>
+                </a:tc>
+                <a:tc>
+                  <a:txBody>
+                    <a:bodyPr/>
+                    <a:lstStyle/>
+                    <a:p>
+                      <a:pPr algn="r"/>
+                      <a:r>
+                        <a:rPr sz="1000">
+                          <a:solidFill>
+                            <a:srgbClr val="3F3F3F"/>
+                          </a:solidFill>
+                          <a:latin typeface="Encode Sans"/>
+                        </a:rPr>
+                        <a:t>118,6</a:t>
+                      </a:r>
+                    </a:p>
+                  </a:txBody>
+                  <a:tcPr marL="36576" marR="36576" marT="18288" marB="18288">
+                    <a:solidFill>
+                      <a:srgbClr val="FFFFFF"/>
+                    </a:solidFill>
+                  </a:tcPr>
+                </a:tc>
+                <a:tc>
+                  <a:txBody>
+                    <a:bodyPr/>
+                    <a:lstStyle/>
+                    <a:p>
+                      <a:pPr algn="r"/>
+                      <a:r>
+                        <a:rPr sz="1000">
+                          <a:solidFill>
+                            <a:srgbClr val="3F3F3F"/>
+                          </a:solidFill>
+                          <a:latin typeface="Encode Sans"/>
+                        </a:rPr>
+                        <a:t>-2.4%</a:t>
+                      </a:r>
+                    </a:p>
+                  </a:txBody>
+                  <a:tcPr marL="36576" marR="36576" marT="18288" marB="18288">
+                    <a:solidFill>
+                      <a:srgbClr val="FFFFFF"/>
+                    </a:solidFill>
+                  </a:tcPr>
+                </a:tc>
+              </a:tr>
+              <a:tr h="292608">
+                <a:tc>
+                  <a:txBody>
+                    <a:bodyPr/>
+                    <a:lstStyle/>
+                    <a:p>
+                      <a:pPr algn="l"/>
+                      <a:r>
+                        <a:rPr sz="1000">
+                          <a:solidFill>
+                            <a:srgbClr val="3F3F3F"/>
+                          </a:solidFill>
+                          <a:latin typeface="Encode Sans"/>
+                        </a:rPr>
+                        <a:t>Marzo 2026</a:t>
+                      </a:r>
+                    </a:p>
+                  </a:txBody>
+                  <a:tcPr marL="36576" marR="36576" marT="18288" marB="18288">
+                    <a:solidFill>
+                      <a:srgbClr val="F8F8F6"/>
+                    </a:solidFill>
+                  </a:tcPr>
+                </a:tc>
+                <a:tc>
+                  <a:txBody>
+                    <a:bodyPr/>
+                    <a:lstStyle/>
+                    <a:p>
+                      <a:pPr algn="r"/>
+                      <a:r>
+                        <a:rPr sz="1000">
+                          <a:solidFill>
+                            <a:srgbClr val="3F3F3F"/>
+                          </a:solidFill>
+                          <a:latin typeface="Encode Sans"/>
+                        </a:rPr>
+                        <a:t>122,2</a:t>
+                      </a:r>
+                    </a:p>
+                  </a:txBody>
+                  <a:tcPr marL="36576" marR="36576" marT="18288" marB="18288">
+                    <a:solidFill>
+                      <a:srgbClr val="F8F8F6"/>
+                    </a:solidFill>
+                  </a:tcPr>
+                </a:tc>
+                <a:tc>
+                  <a:txBody>
+                    <a:bodyPr/>
+                    <a:lstStyle/>
+                    <a:p>
+                      <a:pPr algn="r"/>
+                      <a:r>
+                        <a:rPr sz="1000">
+                          <a:solidFill>
+                            <a:srgbClr val="3F3F3F"/>
+                          </a:solidFill>
+                          <a:latin typeface="Encode Sans"/>
+                        </a:rPr>
+                        <a:t>+5.1%</a:t>
+                      </a:r>
+                    </a:p>
+                  </a:txBody>
+                  <a:tcPr marL="36576" marR="36576" marT="18288" marB="18288">
+                    <a:solidFill>
+                      <a:srgbClr val="F8F8F6"/>
+                    </a:solidFill>
+                  </a:tcPr>
+                </a:tc>
+              </a:tr>
+              <a:tr h="292608">
+                <a:tc>
+                  <a:txBody>
+                    <a:bodyPr/>
+                    <a:lstStyle/>
+                    <a:p>
+                      <a:pPr algn="l"/>
+                      <a:r>
+                        <a:rPr sz="1000">
+                          <a:solidFill>
+                            <a:srgbClr val="3F3F3F"/>
+                          </a:solidFill>
+                          <a:latin typeface="Encode Sans"/>
+                        </a:rPr>
+                        <a:t>Febrero 2026</a:t>
+                      </a:r>
+                    </a:p>
+                  </a:txBody>
+                  <a:tcPr marL="36576" marR="36576" marT="18288" marB="18288">
+                    <a:solidFill>
+                      <a:srgbClr val="FFFFFF"/>
+                    </a:solidFill>
+                  </a:tcPr>
+                </a:tc>
+                <a:tc>
+                  <a:txBody>
+                    <a:bodyPr/>
+                    <a:lstStyle/>
+                    <a:p>
+                      <a:pPr algn="r"/>
+                      <a:r>
+                        <a:rPr sz="1000">
+                          <a:solidFill>
+                            <a:srgbClr val="3F3F3F"/>
+                          </a:solidFill>
+                          <a:latin typeface="Encode Sans"/>
+                        </a:rPr>
+                        <a:t>100,3</a:t>
+                      </a:r>
+                    </a:p>
+                  </a:txBody>
+                  <a:tcPr marL="36576" marR="36576" marT="18288" marB="18288">
+                    <a:solidFill>
+                      <a:srgbClr val="FFFFFF"/>
+                    </a:solidFill>
+                  </a:tcPr>
+                </a:tc>
+                <a:tc>
+                  <a:txBody>
+                    <a:bodyPr/>
+                    <a:lstStyle/>
+                    <a:p>
+                      <a:pPr algn="r"/>
+                      <a:r>
+                        <a:rPr sz="1000">
+                          <a:solidFill>
+                            <a:srgbClr val="3F3F3F"/>
+                          </a:solidFill>
+                          <a:latin typeface="Encode Sans"/>
+                        </a:rPr>
+                        <a:t>-8.8%</a:t>
+                      </a:r>
+                    </a:p>
+                  </a:txBody>
+                  <a:tcPr marL="36576" marR="36576" marT="18288" marB="18288">
+                    <a:solidFill>
+                      <a:srgbClr val="FFFFFF"/>
+                    </a:solidFill>
+                  </a:tcPr>
+                </a:tc>
+              </a:tr>
+              <a:tr h="292608">
+                <a:tc>
+                  <a:txBody>
+                    <a:bodyPr/>
+                    <a:lstStyle/>
+                    <a:p>
+                      <a:pPr algn="l"/>
+                      <a:r>
+                        <a:rPr sz="1000">
+                          <a:solidFill>
+                            <a:srgbClr val="3F3F3F"/>
+                          </a:solidFill>
+                          <a:latin typeface="Encode Sans"/>
+                        </a:rPr>
+                        <a:t>Enero 2026</a:t>
+                      </a:r>
+                    </a:p>
+                  </a:txBody>
+                  <a:tcPr marL="36576" marR="36576" marT="18288" marB="18288">
+                    <a:solidFill>
+                      <a:srgbClr val="F8F8F6"/>
+                    </a:solidFill>
+                  </a:tcPr>
+                </a:tc>
+                <a:tc>
+                  <a:txBody>
+                    <a:bodyPr/>
+                    <a:lstStyle/>
+                    <a:p>
+                      <a:pPr algn="r"/>
+                      <a:r>
+                        <a:rPr sz="1000">
+                          <a:solidFill>
+                            <a:srgbClr val="3F3F3F"/>
+                          </a:solidFill>
+                          <a:latin typeface="Encode Sans"/>
+                        </a:rPr>
+                        <a:t>106,5</a:t>
+                      </a:r>
+                    </a:p>
+                  </a:txBody>
+                  <a:tcPr marL="36576" marR="36576" marT="18288" marB="18288">
+                    <a:solidFill>
+                      <a:srgbClr val="F8F8F6"/>
+                    </a:solidFill>
+                  </a:tcPr>
+                </a:tc>
+                <a:tc>
+                  <a:txBody>
+                    <a:bodyPr/>
+                    <a:lstStyle/>
+                    <a:p>
+                      <a:pPr algn="r"/>
+                      <a:r>
+                        <a:rPr sz="1000">
+                          <a:solidFill>
+                            <a:srgbClr val="3F3F3F"/>
+                          </a:solidFill>
+                          <a:latin typeface="Encode Sans"/>
+                        </a:rPr>
+                        <a:t>-3.8%</a:t>
+                      </a:r>
+                    </a:p>
+                  </a:txBody>
+                  <a:tcPr marL="36576" marR="36576" marT="18288" marB="18288">
+                    <a:solidFill>
+                      <a:srgbClr val="F8F8F6"/>
+                    </a:solidFill>
+                  </a:tcPr>
+                </a:tc>
+              </a:tr>
+            </a:tbl>
+          </a:graphicData>
+        </a:graphic>
+      </p:graphicFrame>
+      <p:sp>
+        <p:nvSpPr>
+          <p:cNvPr id="9" name="TextBox 8"/>
+          <p:cNvSpPr txBox="1"/>
+          <p:nvPr/>
+        </p:nvSpPr>
+        <p:spPr>
+          <a:xfrm>
+            <a:off x="411480" y="6492240"/>
+            <a:ext cx="11368735" cy="274320"/>
+          </a:xfrm>
+          <a:prstGeom prst="rect">
+            <a:avLst/>
+          </a:prstGeom>
+          <a:noFill/>
+        </p:spPr>
+        <p:txBody>
+          <a:bodyPr wrap="none">
+            <a:spAutoFit/>
+          </a:bodyPr>
+          <a:lstStyle/>
+          <a:p>
+            <a:r>
+              <a:rPr sz="1000" b="0" i="1">
+                <a:solidFill>
+                  <a:srgbClr val="6A6760"/>
+                </a:solidFill>
+                <a:latin typeface="Encode Sans"/>
+              </a:rPr>
+              <a:t>Fuente: elaboración propia en base a INDEC</a:t>
+            </a:r>
+          </a:p>
+        </p:txBody>
+      </p:sp>
+    </p:spTree>
+  </p:cSld>
+  <p:clrMapOvr>
+    <a:masterClrMapping/>
+  </p:clrMapOvr>
+</p:sld>
+</file>
+
 <file path=ppt/theme/theme1.xml><?xml version="1.0" encoding="utf-8"?>
 <a:theme xmlns:a="http://schemas.openxmlformats.org/drawingml/2006/main" name="Office Theme">
   <a:themeElements>

</xml_diff>

<commit_message>
data: update 2026-08-13 ( data.json despidos.json scraper/historical_despidos.json publicaciones_semana.pptx rrii_brutas.xlsx)
</commit_message>
<xml_diff>
--- a/publicaciones_semana.pptx
+++ b/publicaciones_semana.pptx
@@ -7,7 +7,6 @@
   <p:sldIdLst>
     <p:sldId id="256" r:id="rId7"/>
     <p:sldId id="257" r:id="rId8"/>
-    <p:sldId id="258" r:id="rId9"/>
   </p:sldIdLst>
   <p:sldSz cx="12191695" cy="6858000" type="screen4x3"/>
   <p:notesSz cx="6858000" cy="9144000"/>
@@ -3239,7 +3238,7 @@
                 </a:solidFill>
                 <a:latin typeface="Encode Sans"/>
               </a:rPr>
-              <a:t>Publicaciones de la semana del 03 de agosto de 2026</a:t>
+              <a:t>Publicaciones de la semana del 10 de agosto de 2026</a:t>
             </a:r>
           </a:p>
         </p:txBody>
@@ -3273,7 +3272,7 @@
                 </a:solidFill>
                 <a:latin typeface="Encode Sans"/>
               </a:rPr>
-              <a:t>2 publicaciones · datos oficiales INDEC / BCRA / Hacienda</a:t>
+              <a:t>1 publicaciones · datos oficiales INDEC / BCRA / Hacienda</a:t>
             </a:r>
           </a:p>
         </p:txBody>
@@ -3369,7 +3368,7 @@
                 </a:solidFill>
                 <a:latin typeface="Encode Sans"/>
               </a:rPr>
-              <a:t>INDUSTRIA JUNIO 2026: IPI CRECIÓ +2.0% I.A.</a:t>
+              <a:t>INFLACIÓN JULIO 2026: +2.1%</a:t>
             </a:r>
           </a:p>
         </p:txBody>
@@ -3403,7 +3402,7 @@
                 </a:solidFill>
                 <a:latin typeface="Encode Sans"/>
               </a:rPr>
-              <a:t>INDEC · período 2026-06</a:t>
+              <a:t>INDEC · período 2026-07</a:t>
             </a:r>
           </a:p>
         </p:txBody>
@@ -3438,7 +3437,7 @@
                 </a:solidFill>
                 <a:latin typeface="Encode Sans"/>
               </a:rPr>
-              <a:t>El Índice de Producción Industrial Manufacturero (IPI) registró una variación interanual de +2.0% en junio 2026.</a:t>
+              <a:t>El IPC nivel general aumentó +2.1% mensual en julio 2026, acumulando 33.81% interanual. INDEC publicó el indicador con la metodología vigente.</a:t>
             </a:r>
           </a:p>
         </p:txBody>
@@ -3486,7 +3485,7 @@
                 </a:solidFill>
                 <a:latin typeface="Encode Sans"/>
               </a:rPr>
-              <a:t>Variación interanual: +2.0%</a:t>
+              <a:t>Variación mensual: +2.1%</a:t>
             </a:r>
           </a:p>
           <a:p>
@@ -3511,7 +3510,32 @@
                 </a:solidFill>
                 <a:latin typeface="Encode Sans"/>
               </a:rPr>
-              <a:t>Serie INDEC, base 2004=100. Mide la producción manufacturera (16 ramas).</a:t>
+              <a:t>Variación interanual: 33.81%</a:t>
+            </a:r>
+          </a:p>
+          <a:p>
+            <a:pPr algn="l">
+              <a:spcAft>
+                <a:spcPts val="800"/>
+              </a:spcAft>
+            </a:pPr>
+            <a:r>
+              <a:rPr sz="1300" b="1" i="0">
+                <a:solidFill>
+                  <a:srgbClr val="00B2C9"/>
+                </a:solidFill>
+                <a:latin typeface="Encode Sans"/>
+              </a:rPr>
+              <a:t>●  </a:t>
+            </a:r>
+            <a:r>
+              <a:rPr sz="1300" b="0" i="0">
+                <a:solidFill>
+                  <a:srgbClr val="3F3F3F"/>
+                </a:solidFill>
+                <a:latin typeface="Encode Sans"/>
+              </a:rPr>
+              <a:t>Acumulado últimos 6 meses: 15.0% (suma simple)</a:t>
             </a:r>
           </a:p>
         </p:txBody>
@@ -3600,7 +3624,7 @@
                           </a:solidFill>
                           <a:latin typeface="Encode Sans"/>
                         </a:rPr>
-                        <a:t>Original</a:t>
+                        <a:t>VM %</a:t>
                       </a:r>
                     </a:p>
                   </a:txBody>
@@ -3648,7 +3672,7 @@
                           </a:solidFill>
                           <a:latin typeface="Encode Sans"/>
                         </a:rPr>
-                        <a:t>Junio 2026</a:t>
+                        <a:t>Julio 2026</a:t>
                       </a:r>
                     </a:p>
                   </a:txBody>
@@ -3671,7 +3695,7 @@
                           </a:solidFill>
                           <a:latin typeface="Encode Sans"/>
                         </a:rPr>
-                        <a:t>119,9</a:t>
+                        <a:t>+2.1%</a:t>
                       </a:r>
                     </a:p>
                   </a:txBody>
@@ -3694,7 +3718,7 @@
                           </a:solidFill>
                           <a:latin typeface="Encode Sans"/>
                         </a:rPr>
-                        <a:t>+2.0%</a:t>
+                        <a:t>+33.8%</a:t>
                       </a:r>
                     </a:p>
                   </a:txBody>
@@ -3719,7 +3743,7 @@
                           </a:solidFill>
                           <a:latin typeface="Encode Sans"/>
                         </a:rPr>
-                        <a:t>Mayo 2026</a:t>
+                        <a:t>Junio 2026</a:t>
                       </a:r>
                     </a:p>
                   </a:txBody>
@@ -3742,7 +3766,7 @@
                           </a:solidFill>
                           <a:latin typeface="Encode Sans"/>
                         </a:rPr>
-                        <a:t>117,0</a:t>
+                        <a:t>+1.9%</a:t>
                       </a:r>
                     </a:p>
                   </a:txBody>
@@ -3765,7 +3789,7 @@
                           </a:solidFill>
                           <a:latin typeface="Encode Sans"/>
                         </a:rPr>
-                        <a:t>-5.6%</a:t>
+                        <a:t>+33.5%</a:t>
                       </a:r>
                     </a:p>
                   </a:txBody>
@@ -3790,7 +3814,7 @@
                           </a:solidFill>
                           <a:latin typeface="Encode Sans"/>
                         </a:rPr>
-                        <a:t>Abril 2026</a:t>
+                        <a:t>Mayo 2026</a:t>
                       </a:r>
                     </a:p>
                   </a:txBody>
@@ -3813,7 +3837,7 @@
                           </a:solidFill>
                           <a:latin typeface="Encode Sans"/>
                         </a:rPr>
-                        <a:t>118,6</a:t>
+                        <a:t>+2.1%</a:t>
                       </a:r>
                     </a:p>
                   </a:txBody>
@@ -3836,7 +3860,7 @@
                           </a:solidFill>
                           <a:latin typeface="Encode Sans"/>
                         </a:rPr>
-                        <a:t>-2.4%</a:t>
+                        <a:t>+33.2%</a:t>
                       </a:r>
                     </a:p>
                   </a:txBody>
@@ -3861,7 +3885,7 @@
                           </a:solidFill>
                           <a:latin typeface="Encode Sans"/>
                         </a:rPr>
-                        <a:t>Marzo 2026</a:t>
+                        <a:t>Abril 2026</a:t>
                       </a:r>
                     </a:p>
                   </a:txBody>
@@ -3884,7 +3908,7 @@
                           </a:solidFill>
                           <a:latin typeface="Encode Sans"/>
                         </a:rPr>
-                        <a:t>122,2</a:t>
+                        <a:t>+2.6%</a:t>
                       </a:r>
                     </a:p>
                   </a:txBody>
@@ -3907,7 +3931,7 @@
                           </a:solidFill>
                           <a:latin typeface="Encode Sans"/>
                         </a:rPr>
-                        <a:t>+5.1%</a:t>
+                        <a:t>+32.4%</a:t>
                       </a:r>
                     </a:p>
                   </a:txBody>
@@ -3932,7 +3956,7 @@
                           </a:solidFill>
                           <a:latin typeface="Encode Sans"/>
                         </a:rPr>
-                        <a:t>Febrero 2026</a:t>
+                        <a:t>Marzo 2026</a:t>
                       </a:r>
                     </a:p>
                   </a:txBody>
@@ -3955,7 +3979,7 @@
                           </a:solidFill>
                           <a:latin typeface="Encode Sans"/>
                         </a:rPr>
-                        <a:t>100,3</a:t>
+                        <a:t>+3.4%</a:t>
                       </a:r>
                     </a:p>
                   </a:txBody>
@@ -3978,7 +4002,7 @@
                           </a:solidFill>
                           <a:latin typeface="Encode Sans"/>
                         </a:rPr>
-                        <a:t>-8.8%</a:t>
+                        <a:t>+32.6%</a:t>
                       </a:r>
                     </a:p>
                   </a:txBody>
@@ -4003,7 +4027,7 @@
                           </a:solidFill>
                           <a:latin typeface="Encode Sans"/>
                         </a:rPr>
-                        <a:t>Enero 2026</a:t>
+                        <a:t>Febrero 2026</a:t>
                       </a:r>
                     </a:p>
                   </a:txBody>
@@ -4026,7 +4050,7 @@
                           </a:solidFill>
                           <a:latin typeface="Encode Sans"/>
                         </a:rPr>
-                        <a:t>106,5</a:t>
+                        <a:t>+2.9%</a:t>
                       </a:r>
                     </a:p>
                   </a:txBody>
@@ -4049,827 +4073,7 @@
                           </a:solidFill>
                           <a:latin typeface="Encode Sans"/>
                         </a:rPr>
-                        <a:t>-3.8%</a:t>
-                      </a:r>
-                    </a:p>
-                  </a:txBody>
-                  <a:tcPr marL="36576" marR="36576" marT="18288" marB="18288">
-                    <a:solidFill>
-                      <a:srgbClr val="F8F8F6"/>
-                    </a:solidFill>
-                  </a:tcPr>
-                </a:tc>
-              </a:tr>
-            </a:tbl>
-          </a:graphicData>
-        </a:graphic>
-      </p:graphicFrame>
-      <p:sp>
-        <p:nvSpPr>
-          <p:cNvPr id="9" name="TextBox 8"/>
-          <p:cNvSpPr txBox="1"/>
-          <p:nvPr/>
-        </p:nvSpPr>
-        <p:spPr>
-          <a:xfrm>
-            <a:off x="411480" y="6492240"/>
-            <a:ext cx="11368735" cy="274320"/>
-          </a:xfrm>
-          <a:prstGeom prst="rect">
-            <a:avLst/>
-          </a:prstGeom>
-          <a:noFill/>
-        </p:spPr>
-        <p:txBody>
-          <a:bodyPr wrap="none">
-            <a:spAutoFit/>
-          </a:bodyPr>
-          <a:lstStyle/>
-          <a:p>
-            <a:r>
-              <a:rPr sz="1000" b="0" i="1">
-                <a:solidFill>
-                  <a:srgbClr val="6A6760"/>
-                </a:solidFill>
-                <a:latin typeface="Encode Sans"/>
-              </a:rPr>
-              <a:t>Fuente: elaboración propia en base a INDEC</a:t>
-            </a:r>
-          </a:p>
-        </p:txBody>
-      </p:sp>
-    </p:spTree>
-  </p:cSld>
-  <p:clrMapOvr>
-    <a:masterClrMapping/>
-  </p:clrMapOvr>
-</p:sld>
-</file>
-
-<file path=ppt/slides/slide3.xml><?xml version="1.0" encoding="utf-8"?>
-<p:sld xmlns:a="http://schemas.openxmlformats.org/drawingml/2006/main" xmlns:p="http://schemas.openxmlformats.org/presentationml/2006/main" xmlns:r="http://schemas.openxmlformats.org/officeDocument/2006/relationships">
-  <p:cSld>
-    <p:spTree>
-      <p:nvGrpSpPr>
-        <p:cNvPr id="1" name=""/>
-        <p:cNvGrpSpPr/>
-        <p:nvPr/>
-      </p:nvGrpSpPr>
-      <p:grpSpPr/>
-      <p:sp>
-        <p:nvSpPr>
-          <p:cNvPr id="2" name="Rectangle 1"/>
-          <p:cNvSpPr/>
-          <p:nvPr/>
-        </p:nvSpPr>
-        <p:spPr>
-          <a:xfrm>
-            <a:off x="0" y="0"/>
-            <a:ext cx="12191695" cy="274320"/>
-          </a:xfrm>
-          <a:prstGeom prst="rect">
-            <a:avLst/>
-          </a:prstGeom>
-          <a:solidFill>
-            <a:srgbClr val="00B2C9"/>
-          </a:solidFill>
-          <a:ln>
-            <a:noFill/>
-          </a:ln>
-        </p:spPr>
-        <p:style>
-          <a:lnRef idx="1">
-            <a:schemeClr val="accent1"/>
-          </a:lnRef>
-          <a:fillRef idx="3">
-            <a:schemeClr val="accent1"/>
-          </a:fillRef>
-          <a:effectRef idx="2">
-            <a:schemeClr val="accent1"/>
-          </a:effectRef>
-          <a:fontRef idx="minor">
-            <a:schemeClr val="lt1"/>
-          </a:fontRef>
-        </p:style>
-        <p:txBody>
-          <a:bodyPr rtlCol="0" anchor="ctr"/>
-          <a:lstStyle/>
-          <a:p>
-            <a:pPr algn="ctr"/>
-          </a:p>
-        </p:txBody>
-      </p:sp>
-      <p:sp>
-        <p:nvSpPr>
-          <p:cNvPr id="3" name="TextBox 2"/>
-          <p:cNvSpPr txBox="1"/>
-          <p:nvPr/>
-        </p:nvSpPr>
-        <p:spPr>
-          <a:xfrm>
-            <a:off x="411480" y="457200"/>
-            <a:ext cx="11368735" cy="914400"/>
-          </a:xfrm>
-          <a:prstGeom prst="rect">
-            <a:avLst/>
-          </a:prstGeom>
-          <a:noFill/>
-        </p:spPr>
-        <p:txBody>
-          <a:bodyPr wrap="square" lIns="0" rIns="0">
-            <a:spAutoFit/>
-          </a:bodyPr>
-          <a:lstStyle/>
-          <a:p>
-            <a:pPr algn="l"/>
-            <a:r>
-              <a:rPr sz="2600" b="1" i="0">
-                <a:solidFill>
-                  <a:srgbClr val="00B2C9"/>
-                </a:solidFill>
-                <a:latin typeface="Encode Sans"/>
-              </a:rPr>
-              <a:t>INDUSTRIA JUNIO 2026: IPI CRECIÓ +0.0% I.A.</a:t>
-            </a:r>
-          </a:p>
-        </p:txBody>
-      </p:sp>
-      <p:sp>
-        <p:nvSpPr>
-          <p:cNvPr id="4" name="TextBox 3"/>
-          <p:cNvSpPr txBox="1"/>
-          <p:nvPr/>
-        </p:nvSpPr>
-        <p:spPr>
-          <a:xfrm>
-            <a:off x="411480" y="1280160"/>
-            <a:ext cx="11368735" cy="274320"/>
-          </a:xfrm>
-          <a:prstGeom prst="rect">
-            <a:avLst/>
-          </a:prstGeom>
-          <a:noFill/>
-        </p:spPr>
-        <p:txBody>
-          <a:bodyPr wrap="none">
-            <a:spAutoFit/>
-          </a:bodyPr>
-          <a:lstStyle/>
-          <a:p>
-            <a:r>
-              <a:rPr sz="1100" b="0" i="1">
-                <a:solidFill>
-                  <a:srgbClr val="6A6760"/>
-                </a:solidFill>
-                <a:latin typeface="Encode Sans"/>
-              </a:rPr>
-              <a:t>INDEC · período 2026-06</a:t>
-            </a:r>
-          </a:p>
-        </p:txBody>
-      </p:sp>
-      <p:sp>
-        <p:nvSpPr>
-          <p:cNvPr id="5" name="TextBox 4"/>
-          <p:cNvSpPr txBox="1"/>
-          <p:nvPr/>
-        </p:nvSpPr>
-        <p:spPr>
-          <a:xfrm>
-            <a:off x="411480" y="1691640"/>
-            <a:ext cx="5486400" cy="1645920"/>
-          </a:xfrm>
-          <a:prstGeom prst="rect">
-            <a:avLst/>
-          </a:prstGeom>
-          <a:noFill/>
-        </p:spPr>
-        <p:txBody>
-          <a:bodyPr wrap="square" lIns="0" rIns="0">
-            <a:spAutoFit/>
-          </a:bodyPr>
-          <a:lstStyle/>
-          <a:p>
-            <a:pPr algn="just"/>
-            <a:r>
-              <a:rPr sz="1300" b="0" i="0">
-                <a:solidFill>
-                  <a:srgbClr val="3F3F3F"/>
-                </a:solidFill>
-                <a:latin typeface="Encode Sans"/>
-              </a:rPr>
-              <a:t>El Índice de Producción Industrial Manufacturero (IPI) registró una variación interanual de +0.0% en junio 2026.</a:t>
-            </a:r>
-          </a:p>
-        </p:txBody>
-      </p:sp>
-      <p:sp>
-        <p:nvSpPr>
-          <p:cNvPr id="6" name="TextBox 5"/>
-          <p:cNvSpPr txBox="1"/>
-          <p:nvPr/>
-        </p:nvSpPr>
-        <p:spPr>
-          <a:xfrm>
-            <a:off x="411480" y="3520440"/>
-            <a:ext cx="5486400" cy="2743200"/>
-          </a:xfrm>
-          <a:prstGeom prst="rect">
-            <a:avLst/>
-          </a:prstGeom>
-          <a:noFill/>
-        </p:spPr>
-        <p:txBody>
-          <a:bodyPr wrap="square" lIns="0" rIns="0">
-            <a:spAutoFit/>
-          </a:bodyPr>
-          <a:lstStyle/>
-          <a:p>
-            <a:pPr algn="l">
-              <a:spcAft>
-                <a:spcPts val="800"/>
-              </a:spcAft>
-            </a:pPr>
-            <a:r>
-              <a:rPr sz="1300" b="1" i="0">
-                <a:solidFill>
-                  <a:srgbClr val="00B2C9"/>
-                </a:solidFill>
-                <a:latin typeface="Encode Sans"/>
-              </a:rPr>
-              <a:t>●  </a:t>
-            </a:r>
-            <a:r>
-              <a:rPr sz="1300" b="0" i="0">
-                <a:solidFill>
-                  <a:srgbClr val="3F3F3F"/>
-                </a:solidFill>
-                <a:latin typeface="Encode Sans"/>
-              </a:rPr>
-              <a:t>Variación interanual: +0.0%</a:t>
-            </a:r>
-          </a:p>
-          <a:p>
-            <a:pPr algn="l">
-              <a:spcAft>
-                <a:spcPts val="800"/>
-              </a:spcAft>
-            </a:pPr>
-            <a:r>
-              <a:rPr sz="1300" b="1" i="0">
-                <a:solidFill>
-                  <a:srgbClr val="00B2C9"/>
-                </a:solidFill>
-                <a:latin typeface="Encode Sans"/>
-              </a:rPr>
-              <a:t>●  </a:t>
-            </a:r>
-            <a:r>
-              <a:rPr sz="1300" b="0" i="0">
-                <a:solidFill>
-                  <a:srgbClr val="3F3F3F"/>
-                </a:solidFill>
-                <a:latin typeface="Encode Sans"/>
-              </a:rPr>
-              <a:t>Serie INDEC, base 2004=100. Mide la producción manufacturera (16 ramas).</a:t>
-            </a:r>
-          </a:p>
-        </p:txBody>
-      </p:sp>
-      <p:pic>
-        <p:nvPicPr>
-          <p:cNvPr id="7" name="Picture 6" descr="image.png"/>
-          <p:cNvPicPr>
-            <a:picLocks noChangeAspect="1"/>
-          </p:cNvPicPr>
-          <p:nvPr/>
-        </p:nvPicPr>
-        <p:blipFill>
-          <a:blip r:embed="rId2"/>
-          <a:stretch>
-            <a:fillRect/>
-          </a:stretch>
-        </p:blipFill>
-        <p:spPr>
-          <a:xfrm>
-            <a:off x="6080760" y="1691640"/>
-            <a:ext cx="5669280" cy="2560320"/>
-          </a:xfrm>
-          <a:prstGeom prst="rect">
-            <a:avLst/>
-          </a:prstGeom>
-        </p:spPr>
-      </p:pic>
-      <p:graphicFrame>
-        <p:nvGraphicFramePr>
-          <p:cNvPr id="8" name="Table 7"/>
-          <p:cNvGraphicFramePr>
-            <a:graphicFrameLocks noGrp="1"/>
-          </p:cNvGraphicFramePr>
-          <p:nvPr/>
-        </p:nvGraphicFramePr>
-        <p:xfrm>
-          <a:off x="6080760" y="4434840"/>
-          <a:ext cx="5669280" cy="2048256"/>
-        </p:xfrm>
-        <a:graphic>
-          <a:graphicData uri="http://schemas.openxmlformats.org/drawingml/2006/table">
-            <a:tbl>
-              <a:tblPr firstRow="1" bandRow="1">
-                <a:tableStyleId>{5C22544A-7EE6-4342-B048-85BDC9FD1C3A}</a:tableStyleId>
-              </a:tblPr>
-              <a:tblGrid>
-                <a:gridCol w="1889760"/>
-                <a:gridCol w="1889760"/>
-                <a:gridCol w="1889760"/>
-              </a:tblGrid>
-              <a:tr h="292608">
-                <a:tc>
-                  <a:txBody>
-                    <a:bodyPr/>
-                    <a:lstStyle/>
-                    <a:p>
-                      <a:pPr algn="l"/>
-                      <a:r>
-                        <a:rPr sz="1000" b="1">
-                          <a:solidFill>
-                            <a:srgbClr val="FFFFFF"/>
-                          </a:solidFill>
-                          <a:latin typeface="Encode Sans"/>
-                        </a:rPr>
-                        <a:t>Mes</a:t>
-                      </a:r>
-                    </a:p>
-                  </a:txBody>
-                  <a:tcPr marL="36576" marR="36576" marT="18288" marB="18288">
-                    <a:solidFill>
-                      <a:srgbClr val="00B2C9"/>
-                    </a:solidFill>
-                  </a:tcPr>
-                </a:tc>
-                <a:tc>
-                  <a:txBody>
-                    <a:bodyPr/>
-                    <a:lstStyle/>
-                    <a:p>
-                      <a:pPr algn="r"/>
-                      <a:r>
-                        <a:rPr sz="1000" b="1">
-                          <a:solidFill>
-                            <a:srgbClr val="FFFFFF"/>
-                          </a:solidFill>
-                          <a:latin typeface="Encode Sans"/>
-                        </a:rPr>
-                        <a:t>Original</a:t>
-                      </a:r>
-                    </a:p>
-                  </a:txBody>
-                  <a:tcPr marL="36576" marR="36576" marT="18288" marB="18288">
-                    <a:solidFill>
-                      <a:srgbClr val="00B2C9"/>
-                    </a:solidFill>
-                  </a:tcPr>
-                </a:tc>
-                <a:tc>
-                  <a:txBody>
-                    <a:bodyPr/>
-                    <a:lstStyle/>
-                    <a:p>
-                      <a:pPr algn="r"/>
-                      <a:r>
-                        <a:rPr sz="1000" b="1">
-                          <a:solidFill>
-                            <a:srgbClr val="FFFFFF"/>
-                          </a:solidFill>
-                          <a:latin typeface="Encode Sans"/>
-                        </a:rPr>
-                        <a:t>VIA %</a:t>
-                      </a:r>
-                    </a:p>
-                  </a:txBody>
-                  <a:tcPr marL="36576" marR="36576" marT="18288" marB="18288">
-                    <a:solidFill>
-                      <a:srgbClr val="00B2C9"/>
-                    </a:solidFill>
-                  </a:tcPr>
-                </a:tc>
-              </a:tr>
-              <a:tr h="292608">
-                <a:tc>
-                  <a:txBody>
-                    <a:bodyPr/>
-                    <a:lstStyle/>
-                    <a:p>
-                      <a:pPr algn="l"/>
-                      <a:r>
-                        <a:rPr sz="1000">
-                          <a:solidFill>
-                            <a:srgbClr val="3F3F3F"/>
-                          </a:solidFill>
-                          <a:latin typeface="Encode Sans"/>
-                        </a:rPr>
-                        <a:t>Junio 2026</a:t>
-                      </a:r>
-                    </a:p>
-                  </a:txBody>
-                  <a:tcPr marL="36576" marR="36576" marT="18288" marB="18288">
-                    <a:solidFill>
-                      <a:srgbClr val="FFFFFF"/>
-                    </a:solidFill>
-                  </a:tcPr>
-                </a:tc>
-                <a:tc>
-                  <a:txBody>
-                    <a:bodyPr/>
-                    <a:lstStyle/>
-                    <a:p>
-                      <a:pPr algn="r"/>
-                      <a:r>
-                        <a:rPr sz="1000">
-                          <a:solidFill>
-                            <a:srgbClr val="3F3F3F"/>
-                          </a:solidFill>
-                          <a:latin typeface="Encode Sans"/>
-                        </a:rPr>
-                        <a:t>119,9</a:t>
-                      </a:r>
-                    </a:p>
-                  </a:txBody>
-                  <a:tcPr marL="36576" marR="36576" marT="18288" marB="18288">
-                    <a:solidFill>
-                      <a:srgbClr val="FFFFFF"/>
-                    </a:solidFill>
-                  </a:tcPr>
-                </a:tc>
-                <a:tc>
-                  <a:txBody>
-                    <a:bodyPr/>
-                    <a:lstStyle/>
-                    <a:p>
-                      <a:pPr algn="r"/>
-                      <a:r>
-                        <a:rPr sz="1000">
-                          <a:solidFill>
-                            <a:srgbClr val="3F3F3F"/>
-                          </a:solidFill>
-                          <a:latin typeface="Encode Sans"/>
-                        </a:rPr>
-                        <a:t>+2.0%</a:t>
-                      </a:r>
-                    </a:p>
-                  </a:txBody>
-                  <a:tcPr marL="36576" marR="36576" marT="18288" marB="18288">
-                    <a:solidFill>
-                      <a:srgbClr val="FFFFFF"/>
-                    </a:solidFill>
-                  </a:tcPr>
-                </a:tc>
-              </a:tr>
-              <a:tr h="292608">
-                <a:tc>
-                  <a:txBody>
-                    <a:bodyPr/>
-                    <a:lstStyle/>
-                    <a:p>
-                      <a:pPr algn="l"/>
-                      <a:r>
-                        <a:rPr sz="1000">
-                          <a:solidFill>
-                            <a:srgbClr val="3F3F3F"/>
-                          </a:solidFill>
-                          <a:latin typeface="Encode Sans"/>
-                        </a:rPr>
-                        <a:t>Mayo 2026</a:t>
-                      </a:r>
-                    </a:p>
-                  </a:txBody>
-                  <a:tcPr marL="36576" marR="36576" marT="18288" marB="18288">
-                    <a:solidFill>
-                      <a:srgbClr val="F8F8F6"/>
-                    </a:solidFill>
-                  </a:tcPr>
-                </a:tc>
-                <a:tc>
-                  <a:txBody>
-                    <a:bodyPr/>
-                    <a:lstStyle/>
-                    <a:p>
-                      <a:pPr algn="r"/>
-                      <a:r>
-                        <a:rPr sz="1000">
-                          <a:solidFill>
-                            <a:srgbClr val="3F3F3F"/>
-                          </a:solidFill>
-                          <a:latin typeface="Encode Sans"/>
-                        </a:rPr>
-                        <a:t>117,0</a:t>
-                      </a:r>
-                    </a:p>
-                  </a:txBody>
-                  <a:tcPr marL="36576" marR="36576" marT="18288" marB="18288">
-                    <a:solidFill>
-                      <a:srgbClr val="F8F8F6"/>
-                    </a:solidFill>
-                  </a:tcPr>
-                </a:tc>
-                <a:tc>
-                  <a:txBody>
-                    <a:bodyPr/>
-                    <a:lstStyle/>
-                    <a:p>
-                      <a:pPr algn="r"/>
-                      <a:r>
-                        <a:rPr sz="1000">
-                          <a:solidFill>
-                            <a:srgbClr val="3F3F3F"/>
-                          </a:solidFill>
-                          <a:latin typeface="Encode Sans"/>
-                        </a:rPr>
-                        <a:t>-5.6%</a:t>
-                      </a:r>
-                    </a:p>
-                  </a:txBody>
-                  <a:tcPr marL="36576" marR="36576" marT="18288" marB="18288">
-                    <a:solidFill>
-                      <a:srgbClr val="F8F8F6"/>
-                    </a:solidFill>
-                  </a:tcPr>
-                </a:tc>
-              </a:tr>
-              <a:tr h="292608">
-                <a:tc>
-                  <a:txBody>
-                    <a:bodyPr/>
-                    <a:lstStyle/>
-                    <a:p>
-                      <a:pPr algn="l"/>
-                      <a:r>
-                        <a:rPr sz="1000">
-                          <a:solidFill>
-                            <a:srgbClr val="3F3F3F"/>
-                          </a:solidFill>
-                          <a:latin typeface="Encode Sans"/>
-                        </a:rPr>
-                        <a:t>Abril 2026</a:t>
-                      </a:r>
-                    </a:p>
-                  </a:txBody>
-                  <a:tcPr marL="36576" marR="36576" marT="18288" marB="18288">
-                    <a:solidFill>
-                      <a:srgbClr val="FFFFFF"/>
-                    </a:solidFill>
-                  </a:tcPr>
-                </a:tc>
-                <a:tc>
-                  <a:txBody>
-                    <a:bodyPr/>
-                    <a:lstStyle/>
-                    <a:p>
-                      <a:pPr algn="r"/>
-                      <a:r>
-                        <a:rPr sz="1000">
-                          <a:solidFill>
-                            <a:srgbClr val="3F3F3F"/>
-                          </a:solidFill>
-                          <a:latin typeface="Encode Sans"/>
-                        </a:rPr>
-                        <a:t>118,6</a:t>
-                      </a:r>
-                    </a:p>
-                  </a:txBody>
-                  <a:tcPr marL="36576" marR="36576" marT="18288" marB="18288">
-                    <a:solidFill>
-                      <a:srgbClr val="FFFFFF"/>
-                    </a:solidFill>
-                  </a:tcPr>
-                </a:tc>
-                <a:tc>
-                  <a:txBody>
-                    <a:bodyPr/>
-                    <a:lstStyle/>
-                    <a:p>
-                      <a:pPr algn="r"/>
-                      <a:r>
-                        <a:rPr sz="1000">
-                          <a:solidFill>
-                            <a:srgbClr val="3F3F3F"/>
-                          </a:solidFill>
-                          <a:latin typeface="Encode Sans"/>
-                        </a:rPr>
-                        <a:t>-2.4%</a:t>
-                      </a:r>
-                    </a:p>
-                  </a:txBody>
-                  <a:tcPr marL="36576" marR="36576" marT="18288" marB="18288">
-                    <a:solidFill>
-                      <a:srgbClr val="FFFFFF"/>
-                    </a:solidFill>
-                  </a:tcPr>
-                </a:tc>
-              </a:tr>
-              <a:tr h="292608">
-                <a:tc>
-                  <a:txBody>
-                    <a:bodyPr/>
-                    <a:lstStyle/>
-                    <a:p>
-                      <a:pPr algn="l"/>
-                      <a:r>
-                        <a:rPr sz="1000">
-                          <a:solidFill>
-                            <a:srgbClr val="3F3F3F"/>
-                          </a:solidFill>
-                          <a:latin typeface="Encode Sans"/>
-                        </a:rPr>
-                        <a:t>Marzo 2026</a:t>
-                      </a:r>
-                    </a:p>
-                  </a:txBody>
-                  <a:tcPr marL="36576" marR="36576" marT="18288" marB="18288">
-                    <a:solidFill>
-                      <a:srgbClr val="F8F8F6"/>
-                    </a:solidFill>
-                  </a:tcPr>
-                </a:tc>
-                <a:tc>
-                  <a:txBody>
-                    <a:bodyPr/>
-                    <a:lstStyle/>
-                    <a:p>
-                      <a:pPr algn="r"/>
-                      <a:r>
-                        <a:rPr sz="1000">
-                          <a:solidFill>
-                            <a:srgbClr val="3F3F3F"/>
-                          </a:solidFill>
-                          <a:latin typeface="Encode Sans"/>
-                        </a:rPr>
-                        <a:t>122,2</a:t>
-                      </a:r>
-                    </a:p>
-                  </a:txBody>
-                  <a:tcPr marL="36576" marR="36576" marT="18288" marB="18288">
-                    <a:solidFill>
-                      <a:srgbClr val="F8F8F6"/>
-                    </a:solidFill>
-                  </a:tcPr>
-                </a:tc>
-                <a:tc>
-                  <a:txBody>
-                    <a:bodyPr/>
-                    <a:lstStyle/>
-                    <a:p>
-                      <a:pPr algn="r"/>
-                      <a:r>
-                        <a:rPr sz="1000">
-                          <a:solidFill>
-                            <a:srgbClr val="3F3F3F"/>
-                          </a:solidFill>
-                          <a:latin typeface="Encode Sans"/>
-                        </a:rPr>
-                        <a:t>+5.1%</a:t>
-                      </a:r>
-                    </a:p>
-                  </a:txBody>
-                  <a:tcPr marL="36576" marR="36576" marT="18288" marB="18288">
-                    <a:solidFill>
-                      <a:srgbClr val="F8F8F6"/>
-                    </a:solidFill>
-                  </a:tcPr>
-                </a:tc>
-              </a:tr>
-              <a:tr h="292608">
-                <a:tc>
-                  <a:txBody>
-                    <a:bodyPr/>
-                    <a:lstStyle/>
-                    <a:p>
-                      <a:pPr algn="l"/>
-                      <a:r>
-                        <a:rPr sz="1000">
-                          <a:solidFill>
-                            <a:srgbClr val="3F3F3F"/>
-                          </a:solidFill>
-                          <a:latin typeface="Encode Sans"/>
-                        </a:rPr>
-                        <a:t>Febrero 2026</a:t>
-                      </a:r>
-                    </a:p>
-                  </a:txBody>
-                  <a:tcPr marL="36576" marR="36576" marT="18288" marB="18288">
-                    <a:solidFill>
-                      <a:srgbClr val="FFFFFF"/>
-                    </a:solidFill>
-                  </a:tcPr>
-                </a:tc>
-                <a:tc>
-                  <a:txBody>
-                    <a:bodyPr/>
-                    <a:lstStyle/>
-                    <a:p>
-                      <a:pPr algn="r"/>
-                      <a:r>
-                        <a:rPr sz="1000">
-                          <a:solidFill>
-                            <a:srgbClr val="3F3F3F"/>
-                          </a:solidFill>
-                          <a:latin typeface="Encode Sans"/>
-                        </a:rPr>
-                        <a:t>100,3</a:t>
-                      </a:r>
-                    </a:p>
-                  </a:txBody>
-                  <a:tcPr marL="36576" marR="36576" marT="18288" marB="18288">
-                    <a:solidFill>
-                      <a:srgbClr val="FFFFFF"/>
-                    </a:solidFill>
-                  </a:tcPr>
-                </a:tc>
-                <a:tc>
-                  <a:txBody>
-                    <a:bodyPr/>
-                    <a:lstStyle/>
-                    <a:p>
-                      <a:pPr algn="r"/>
-                      <a:r>
-                        <a:rPr sz="1000">
-                          <a:solidFill>
-                            <a:srgbClr val="3F3F3F"/>
-                          </a:solidFill>
-                          <a:latin typeface="Encode Sans"/>
-                        </a:rPr>
-                        <a:t>-8.8%</a:t>
-                      </a:r>
-                    </a:p>
-                  </a:txBody>
-                  <a:tcPr marL="36576" marR="36576" marT="18288" marB="18288">
-                    <a:solidFill>
-                      <a:srgbClr val="FFFFFF"/>
-                    </a:solidFill>
-                  </a:tcPr>
-                </a:tc>
-              </a:tr>
-              <a:tr h="292608">
-                <a:tc>
-                  <a:txBody>
-                    <a:bodyPr/>
-                    <a:lstStyle/>
-                    <a:p>
-                      <a:pPr algn="l"/>
-                      <a:r>
-                        <a:rPr sz="1000">
-                          <a:solidFill>
-                            <a:srgbClr val="3F3F3F"/>
-                          </a:solidFill>
-                          <a:latin typeface="Encode Sans"/>
-                        </a:rPr>
-                        <a:t>Enero 2026</a:t>
-                      </a:r>
-                    </a:p>
-                  </a:txBody>
-                  <a:tcPr marL="36576" marR="36576" marT="18288" marB="18288">
-                    <a:solidFill>
-                      <a:srgbClr val="F8F8F6"/>
-                    </a:solidFill>
-                  </a:tcPr>
-                </a:tc>
-                <a:tc>
-                  <a:txBody>
-                    <a:bodyPr/>
-                    <a:lstStyle/>
-                    <a:p>
-                      <a:pPr algn="r"/>
-                      <a:r>
-                        <a:rPr sz="1000">
-                          <a:solidFill>
-                            <a:srgbClr val="3F3F3F"/>
-                          </a:solidFill>
-                          <a:latin typeface="Encode Sans"/>
-                        </a:rPr>
-                        <a:t>106,5</a:t>
-                      </a:r>
-                    </a:p>
-                  </a:txBody>
-                  <a:tcPr marL="36576" marR="36576" marT="18288" marB="18288">
-                    <a:solidFill>
-                      <a:srgbClr val="F8F8F6"/>
-                    </a:solidFill>
-                  </a:tcPr>
-                </a:tc>
-                <a:tc>
-                  <a:txBody>
-                    <a:bodyPr/>
-                    <a:lstStyle/>
-                    <a:p>
-                      <a:pPr algn="r"/>
-                      <a:r>
-                        <a:rPr sz="1000">
-                          <a:solidFill>
-                            <a:srgbClr val="3F3F3F"/>
-                          </a:solidFill>
-                          <a:latin typeface="Encode Sans"/>
-                        </a:rPr>
-                        <a:t>-3.8%</a:t>
+                        <a:t>+33.0%</a:t>
                       </a:r>
                     </a:p>
                   </a:txBody>

</xml_diff>

<commit_message>
data: update 2026-08-14 ( data.json despidos.json scraper/historical_despidos.json publicaciones_semana.pptx rrii_brutas.xlsx)
</commit_message>
<xml_diff>
--- a/publicaciones_semana.pptx
+++ b/publicaciones_semana.pptx
@@ -7,6 +7,7 @@
   <p:sldIdLst>
     <p:sldId id="256" r:id="rId7"/>
     <p:sldId id="257" r:id="rId8"/>
+    <p:sldId id="258" r:id="rId9"/>
   </p:sldIdLst>
   <p:sldSz cx="12191695" cy="6858000" type="screen4x3"/>
   <p:notesSz cx="6858000" cy="9144000"/>
@@ -3272,7 +3273,7 @@
                 </a:solidFill>
                 <a:latin typeface="Encode Sans"/>
               </a:rPr>
-              <a:t>1 publicaciones · datos oficiales INDEC / BCRA / Hacienda</a:t>
+              <a:t>2 publicaciones · datos oficiales INDEC / BCRA / Hacienda</a:t>
             </a:r>
           </a:p>
         </p:txBody>
@@ -3437,7 +3438,7 @@
                 </a:solidFill>
                 <a:latin typeface="Encode Sans"/>
               </a:rPr>
-              <a:t>El IPC nivel general aumentó +2.1% mensual en julio 2026, acumulando 33.81% interanual. INDEC publicó el indicador con la metodología vigente.</a:t>
+              <a:t>El IPC nivel general aumentó +2.1% mensual en julio 2026, acumulando 33.83% interanual. INDEC publicó el indicador con la metodología vigente.</a:t>
             </a:r>
           </a:p>
         </p:txBody>
@@ -3510,7 +3511,7 @@
                 </a:solidFill>
                 <a:latin typeface="Encode Sans"/>
               </a:rPr>
-              <a:t>Variación interanual: 33.81%</a:t>
+              <a:t>Variación interanual: 33.83%</a:t>
             </a:r>
           </a:p>
           <a:p>
@@ -4130,6 +4131,826 @@
 </p:sld>
 </file>
 
+<file path=ppt/slides/slide3.xml><?xml version="1.0" encoding="utf-8"?>
+<p:sld xmlns:a="http://schemas.openxmlformats.org/drawingml/2006/main" xmlns:p="http://schemas.openxmlformats.org/presentationml/2006/main" xmlns:r="http://schemas.openxmlformats.org/officeDocument/2006/relationships">
+  <p:cSld>
+    <p:spTree>
+      <p:nvGrpSpPr>
+        <p:cNvPr id="1" name=""/>
+        <p:cNvGrpSpPr/>
+        <p:nvPr/>
+      </p:nvGrpSpPr>
+      <p:grpSpPr/>
+      <p:sp>
+        <p:nvSpPr>
+          <p:cNvPr id="2" name="Rectangle 1"/>
+          <p:cNvSpPr/>
+          <p:nvPr/>
+        </p:nvSpPr>
+        <p:spPr>
+          <a:xfrm>
+            <a:off x="0" y="0"/>
+            <a:ext cx="12191695" cy="274320"/>
+          </a:xfrm>
+          <a:prstGeom prst="rect">
+            <a:avLst/>
+          </a:prstGeom>
+          <a:solidFill>
+            <a:srgbClr val="00B2C9"/>
+          </a:solidFill>
+          <a:ln>
+            <a:noFill/>
+          </a:ln>
+        </p:spPr>
+        <p:style>
+          <a:lnRef idx="1">
+            <a:schemeClr val="accent1"/>
+          </a:lnRef>
+          <a:fillRef idx="3">
+            <a:schemeClr val="accent1"/>
+          </a:fillRef>
+          <a:effectRef idx="2">
+            <a:schemeClr val="accent1"/>
+          </a:effectRef>
+          <a:fontRef idx="minor">
+            <a:schemeClr val="lt1"/>
+          </a:fontRef>
+        </p:style>
+        <p:txBody>
+          <a:bodyPr rtlCol="0" anchor="ctr"/>
+          <a:lstStyle/>
+          <a:p>
+            <a:pPr algn="ctr"/>
+          </a:p>
+        </p:txBody>
+      </p:sp>
+      <p:sp>
+        <p:nvSpPr>
+          <p:cNvPr id="3" name="TextBox 2"/>
+          <p:cNvSpPr txBox="1"/>
+          <p:nvPr/>
+        </p:nvSpPr>
+        <p:spPr>
+          <a:xfrm>
+            <a:off x="411480" y="457200"/>
+            <a:ext cx="11368735" cy="914400"/>
+          </a:xfrm>
+          <a:prstGeom prst="rect">
+            <a:avLst/>
+          </a:prstGeom>
+          <a:noFill/>
+        </p:spPr>
+        <p:txBody>
+          <a:bodyPr wrap="square" lIns="0" rIns="0">
+            <a:spAutoFit/>
+          </a:bodyPr>
+          <a:lstStyle/>
+          <a:p>
+            <a:pPr algn="l"/>
+            <a:r>
+              <a:rPr sz="2600" b="1" i="0">
+                <a:solidFill>
+                  <a:srgbClr val="00B2C9"/>
+                </a:solidFill>
+                <a:latin typeface="Encode Sans"/>
+              </a:rPr>
+              <a:t>INDUSTRIA JUNIO 2026: IPI CRECIÓ +0.0% I.A.</a:t>
+            </a:r>
+          </a:p>
+        </p:txBody>
+      </p:sp>
+      <p:sp>
+        <p:nvSpPr>
+          <p:cNvPr id="4" name="TextBox 3"/>
+          <p:cNvSpPr txBox="1"/>
+          <p:nvPr/>
+        </p:nvSpPr>
+        <p:spPr>
+          <a:xfrm>
+            <a:off x="411480" y="1280160"/>
+            <a:ext cx="11368735" cy="274320"/>
+          </a:xfrm>
+          <a:prstGeom prst="rect">
+            <a:avLst/>
+          </a:prstGeom>
+          <a:noFill/>
+        </p:spPr>
+        <p:txBody>
+          <a:bodyPr wrap="none">
+            <a:spAutoFit/>
+          </a:bodyPr>
+          <a:lstStyle/>
+          <a:p>
+            <a:r>
+              <a:rPr sz="1100" b="0" i="1">
+                <a:solidFill>
+                  <a:srgbClr val="6A6760"/>
+                </a:solidFill>
+                <a:latin typeface="Encode Sans"/>
+              </a:rPr>
+              <a:t>INDEC · período 2026-06</a:t>
+            </a:r>
+          </a:p>
+        </p:txBody>
+      </p:sp>
+      <p:sp>
+        <p:nvSpPr>
+          <p:cNvPr id="5" name="TextBox 4"/>
+          <p:cNvSpPr txBox="1"/>
+          <p:nvPr/>
+        </p:nvSpPr>
+        <p:spPr>
+          <a:xfrm>
+            <a:off x="411480" y="1691640"/>
+            <a:ext cx="5486400" cy="1645920"/>
+          </a:xfrm>
+          <a:prstGeom prst="rect">
+            <a:avLst/>
+          </a:prstGeom>
+          <a:noFill/>
+        </p:spPr>
+        <p:txBody>
+          <a:bodyPr wrap="square" lIns="0" rIns="0">
+            <a:spAutoFit/>
+          </a:bodyPr>
+          <a:lstStyle/>
+          <a:p>
+            <a:pPr algn="just"/>
+            <a:r>
+              <a:rPr sz="1300" b="0" i="0">
+                <a:solidFill>
+                  <a:srgbClr val="3F3F3F"/>
+                </a:solidFill>
+                <a:latin typeface="Encode Sans"/>
+              </a:rPr>
+              <a:t>El Índice de Producción Industrial Manufacturero (IPI) registró una variación interanual de +0.0% en junio 2026.</a:t>
+            </a:r>
+          </a:p>
+        </p:txBody>
+      </p:sp>
+      <p:sp>
+        <p:nvSpPr>
+          <p:cNvPr id="6" name="TextBox 5"/>
+          <p:cNvSpPr txBox="1"/>
+          <p:nvPr/>
+        </p:nvSpPr>
+        <p:spPr>
+          <a:xfrm>
+            <a:off x="411480" y="3520440"/>
+            <a:ext cx="5486400" cy="2743200"/>
+          </a:xfrm>
+          <a:prstGeom prst="rect">
+            <a:avLst/>
+          </a:prstGeom>
+          <a:noFill/>
+        </p:spPr>
+        <p:txBody>
+          <a:bodyPr wrap="square" lIns="0" rIns="0">
+            <a:spAutoFit/>
+          </a:bodyPr>
+          <a:lstStyle/>
+          <a:p>
+            <a:pPr algn="l">
+              <a:spcAft>
+                <a:spcPts val="800"/>
+              </a:spcAft>
+            </a:pPr>
+            <a:r>
+              <a:rPr sz="1300" b="1" i="0">
+                <a:solidFill>
+                  <a:srgbClr val="00B2C9"/>
+                </a:solidFill>
+                <a:latin typeface="Encode Sans"/>
+              </a:rPr>
+              <a:t>●  </a:t>
+            </a:r>
+            <a:r>
+              <a:rPr sz="1300" b="0" i="0">
+                <a:solidFill>
+                  <a:srgbClr val="3F3F3F"/>
+                </a:solidFill>
+                <a:latin typeface="Encode Sans"/>
+              </a:rPr>
+              <a:t>Variación interanual: +0.0%</a:t>
+            </a:r>
+          </a:p>
+          <a:p>
+            <a:pPr algn="l">
+              <a:spcAft>
+                <a:spcPts val="800"/>
+              </a:spcAft>
+            </a:pPr>
+            <a:r>
+              <a:rPr sz="1300" b="1" i="0">
+                <a:solidFill>
+                  <a:srgbClr val="00B2C9"/>
+                </a:solidFill>
+                <a:latin typeface="Encode Sans"/>
+              </a:rPr>
+              <a:t>●  </a:t>
+            </a:r>
+            <a:r>
+              <a:rPr sz="1300" b="0" i="0">
+                <a:solidFill>
+                  <a:srgbClr val="3F3F3F"/>
+                </a:solidFill>
+                <a:latin typeface="Encode Sans"/>
+              </a:rPr>
+              <a:t>Serie INDEC, base 2004=100. Mide la producción manufacturera (16 ramas).</a:t>
+            </a:r>
+          </a:p>
+        </p:txBody>
+      </p:sp>
+      <p:pic>
+        <p:nvPicPr>
+          <p:cNvPr id="7" name="Picture 6" descr="image.png"/>
+          <p:cNvPicPr>
+            <a:picLocks noChangeAspect="1"/>
+          </p:cNvPicPr>
+          <p:nvPr/>
+        </p:nvPicPr>
+        <p:blipFill>
+          <a:blip r:embed="rId2"/>
+          <a:stretch>
+            <a:fillRect/>
+          </a:stretch>
+        </p:blipFill>
+        <p:spPr>
+          <a:xfrm>
+            <a:off x="6080760" y="1691640"/>
+            <a:ext cx="5669280" cy="2560320"/>
+          </a:xfrm>
+          <a:prstGeom prst="rect">
+            <a:avLst/>
+          </a:prstGeom>
+        </p:spPr>
+      </p:pic>
+      <p:graphicFrame>
+        <p:nvGraphicFramePr>
+          <p:cNvPr id="8" name="Table 7"/>
+          <p:cNvGraphicFramePr>
+            <a:graphicFrameLocks noGrp="1"/>
+          </p:cNvGraphicFramePr>
+          <p:nvPr/>
+        </p:nvGraphicFramePr>
+        <p:xfrm>
+          <a:off x="6080760" y="4434840"/>
+          <a:ext cx="5669280" cy="2048256"/>
+        </p:xfrm>
+        <a:graphic>
+          <a:graphicData uri="http://schemas.openxmlformats.org/drawingml/2006/table">
+            <a:tbl>
+              <a:tblPr firstRow="1" bandRow="1">
+                <a:tableStyleId>{5C22544A-7EE6-4342-B048-85BDC9FD1C3A}</a:tableStyleId>
+              </a:tblPr>
+              <a:tblGrid>
+                <a:gridCol w="1889760"/>
+                <a:gridCol w="1889760"/>
+                <a:gridCol w="1889760"/>
+              </a:tblGrid>
+              <a:tr h="292608">
+                <a:tc>
+                  <a:txBody>
+                    <a:bodyPr/>
+                    <a:lstStyle/>
+                    <a:p>
+                      <a:pPr algn="l"/>
+                      <a:r>
+                        <a:rPr sz="1000" b="1">
+                          <a:solidFill>
+                            <a:srgbClr val="FFFFFF"/>
+                          </a:solidFill>
+                          <a:latin typeface="Encode Sans"/>
+                        </a:rPr>
+                        <a:t>Mes</a:t>
+                      </a:r>
+                    </a:p>
+                  </a:txBody>
+                  <a:tcPr marL="36576" marR="36576" marT="18288" marB="18288">
+                    <a:solidFill>
+                      <a:srgbClr val="00B2C9"/>
+                    </a:solidFill>
+                  </a:tcPr>
+                </a:tc>
+                <a:tc>
+                  <a:txBody>
+                    <a:bodyPr/>
+                    <a:lstStyle/>
+                    <a:p>
+                      <a:pPr algn="r"/>
+                      <a:r>
+                        <a:rPr sz="1000" b="1">
+                          <a:solidFill>
+                            <a:srgbClr val="FFFFFF"/>
+                          </a:solidFill>
+                          <a:latin typeface="Encode Sans"/>
+                        </a:rPr>
+                        <a:t>Original</a:t>
+                      </a:r>
+                    </a:p>
+                  </a:txBody>
+                  <a:tcPr marL="36576" marR="36576" marT="18288" marB="18288">
+                    <a:solidFill>
+                      <a:srgbClr val="00B2C9"/>
+                    </a:solidFill>
+                  </a:tcPr>
+                </a:tc>
+                <a:tc>
+                  <a:txBody>
+                    <a:bodyPr/>
+                    <a:lstStyle/>
+                    <a:p>
+                      <a:pPr algn="r"/>
+                      <a:r>
+                        <a:rPr sz="1000" b="1">
+                          <a:solidFill>
+                            <a:srgbClr val="FFFFFF"/>
+                          </a:solidFill>
+                          <a:latin typeface="Encode Sans"/>
+                        </a:rPr>
+                        <a:t>VIA %</a:t>
+                      </a:r>
+                    </a:p>
+                  </a:txBody>
+                  <a:tcPr marL="36576" marR="36576" marT="18288" marB="18288">
+                    <a:solidFill>
+                      <a:srgbClr val="00B2C9"/>
+                    </a:solidFill>
+                  </a:tcPr>
+                </a:tc>
+              </a:tr>
+              <a:tr h="292608">
+                <a:tc>
+                  <a:txBody>
+                    <a:bodyPr/>
+                    <a:lstStyle/>
+                    <a:p>
+                      <a:pPr algn="l"/>
+                      <a:r>
+                        <a:rPr sz="1000">
+                          <a:solidFill>
+                            <a:srgbClr val="3F3F3F"/>
+                          </a:solidFill>
+                          <a:latin typeface="Encode Sans"/>
+                        </a:rPr>
+                        <a:t>Junio 2026</a:t>
+                      </a:r>
+                    </a:p>
+                  </a:txBody>
+                  <a:tcPr marL="36576" marR="36576" marT="18288" marB="18288">
+                    <a:solidFill>
+                      <a:srgbClr val="FFFFFF"/>
+                    </a:solidFill>
+                  </a:tcPr>
+                </a:tc>
+                <a:tc>
+                  <a:txBody>
+                    <a:bodyPr/>
+                    <a:lstStyle/>
+                    <a:p>
+                      <a:pPr algn="r"/>
+                      <a:r>
+                        <a:rPr sz="1000">
+                          <a:solidFill>
+                            <a:srgbClr val="3F3F3F"/>
+                          </a:solidFill>
+                          <a:latin typeface="Encode Sans"/>
+                        </a:rPr>
+                        <a:t>119,9</a:t>
+                      </a:r>
+                    </a:p>
+                  </a:txBody>
+                  <a:tcPr marL="36576" marR="36576" marT="18288" marB="18288">
+                    <a:solidFill>
+                      <a:srgbClr val="FFFFFF"/>
+                    </a:solidFill>
+                  </a:tcPr>
+                </a:tc>
+                <a:tc>
+                  <a:txBody>
+                    <a:bodyPr/>
+                    <a:lstStyle/>
+                    <a:p>
+                      <a:pPr algn="r"/>
+                      <a:r>
+                        <a:rPr sz="1000">
+                          <a:solidFill>
+                            <a:srgbClr val="3F3F3F"/>
+                          </a:solidFill>
+                          <a:latin typeface="Encode Sans"/>
+                        </a:rPr>
+                        <a:t>+2.0%</a:t>
+                      </a:r>
+                    </a:p>
+                  </a:txBody>
+                  <a:tcPr marL="36576" marR="36576" marT="18288" marB="18288">
+                    <a:solidFill>
+                      <a:srgbClr val="FFFFFF"/>
+                    </a:solidFill>
+                  </a:tcPr>
+                </a:tc>
+              </a:tr>
+              <a:tr h="292608">
+                <a:tc>
+                  <a:txBody>
+                    <a:bodyPr/>
+                    <a:lstStyle/>
+                    <a:p>
+                      <a:pPr algn="l"/>
+                      <a:r>
+                        <a:rPr sz="1000">
+                          <a:solidFill>
+                            <a:srgbClr val="3F3F3F"/>
+                          </a:solidFill>
+                          <a:latin typeface="Encode Sans"/>
+                        </a:rPr>
+                        <a:t>Mayo 2026</a:t>
+                      </a:r>
+                    </a:p>
+                  </a:txBody>
+                  <a:tcPr marL="36576" marR="36576" marT="18288" marB="18288">
+                    <a:solidFill>
+                      <a:srgbClr val="F8F8F6"/>
+                    </a:solidFill>
+                  </a:tcPr>
+                </a:tc>
+                <a:tc>
+                  <a:txBody>
+                    <a:bodyPr/>
+                    <a:lstStyle/>
+                    <a:p>
+                      <a:pPr algn="r"/>
+                      <a:r>
+                        <a:rPr sz="1000">
+                          <a:solidFill>
+                            <a:srgbClr val="3F3F3F"/>
+                          </a:solidFill>
+                          <a:latin typeface="Encode Sans"/>
+                        </a:rPr>
+                        <a:t>117,0</a:t>
+                      </a:r>
+                    </a:p>
+                  </a:txBody>
+                  <a:tcPr marL="36576" marR="36576" marT="18288" marB="18288">
+                    <a:solidFill>
+                      <a:srgbClr val="F8F8F6"/>
+                    </a:solidFill>
+                  </a:tcPr>
+                </a:tc>
+                <a:tc>
+                  <a:txBody>
+                    <a:bodyPr/>
+                    <a:lstStyle/>
+                    <a:p>
+                      <a:pPr algn="r"/>
+                      <a:r>
+                        <a:rPr sz="1000">
+                          <a:solidFill>
+                            <a:srgbClr val="3F3F3F"/>
+                          </a:solidFill>
+                          <a:latin typeface="Encode Sans"/>
+                        </a:rPr>
+                        <a:t>-5.6%</a:t>
+                      </a:r>
+                    </a:p>
+                  </a:txBody>
+                  <a:tcPr marL="36576" marR="36576" marT="18288" marB="18288">
+                    <a:solidFill>
+                      <a:srgbClr val="F8F8F6"/>
+                    </a:solidFill>
+                  </a:tcPr>
+                </a:tc>
+              </a:tr>
+              <a:tr h="292608">
+                <a:tc>
+                  <a:txBody>
+                    <a:bodyPr/>
+                    <a:lstStyle/>
+                    <a:p>
+                      <a:pPr algn="l"/>
+                      <a:r>
+                        <a:rPr sz="1000">
+                          <a:solidFill>
+                            <a:srgbClr val="3F3F3F"/>
+                          </a:solidFill>
+                          <a:latin typeface="Encode Sans"/>
+                        </a:rPr>
+                        <a:t>Abril 2026</a:t>
+                      </a:r>
+                    </a:p>
+                  </a:txBody>
+                  <a:tcPr marL="36576" marR="36576" marT="18288" marB="18288">
+                    <a:solidFill>
+                      <a:srgbClr val="FFFFFF"/>
+                    </a:solidFill>
+                  </a:tcPr>
+                </a:tc>
+                <a:tc>
+                  <a:txBody>
+                    <a:bodyPr/>
+                    <a:lstStyle/>
+                    <a:p>
+                      <a:pPr algn="r"/>
+                      <a:r>
+                        <a:rPr sz="1000">
+                          <a:solidFill>
+                            <a:srgbClr val="3F3F3F"/>
+                          </a:solidFill>
+                          <a:latin typeface="Encode Sans"/>
+                        </a:rPr>
+                        <a:t>118,6</a:t>
+                      </a:r>
+                    </a:p>
+                  </a:txBody>
+                  <a:tcPr marL="36576" marR="36576" marT="18288" marB="18288">
+                    <a:solidFill>
+                      <a:srgbClr val="FFFFFF"/>
+                    </a:solidFill>
+                  </a:tcPr>
+                </a:tc>
+                <a:tc>
+                  <a:txBody>
+                    <a:bodyPr/>
+                    <a:lstStyle/>
+                    <a:p>
+                      <a:pPr algn="r"/>
+                      <a:r>
+                        <a:rPr sz="1000">
+                          <a:solidFill>
+                            <a:srgbClr val="3F3F3F"/>
+                          </a:solidFill>
+                          <a:latin typeface="Encode Sans"/>
+                        </a:rPr>
+                        <a:t>-2.4%</a:t>
+                      </a:r>
+                    </a:p>
+                  </a:txBody>
+                  <a:tcPr marL="36576" marR="36576" marT="18288" marB="18288">
+                    <a:solidFill>
+                      <a:srgbClr val="FFFFFF"/>
+                    </a:solidFill>
+                  </a:tcPr>
+                </a:tc>
+              </a:tr>
+              <a:tr h="292608">
+                <a:tc>
+                  <a:txBody>
+                    <a:bodyPr/>
+                    <a:lstStyle/>
+                    <a:p>
+                      <a:pPr algn="l"/>
+                      <a:r>
+                        <a:rPr sz="1000">
+                          <a:solidFill>
+                            <a:srgbClr val="3F3F3F"/>
+                          </a:solidFill>
+                          <a:latin typeface="Encode Sans"/>
+                        </a:rPr>
+                        <a:t>Marzo 2026</a:t>
+                      </a:r>
+                    </a:p>
+                  </a:txBody>
+                  <a:tcPr marL="36576" marR="36576" marT="18288" marB="18288">
+                    <a:solidFill>
+                      <a:srgbClr val="F8F8F6"/>
+                    </a:solidFill>
+                  </a:tcPr>
+                </a:tc>
+                <a:tc>
+                  <a:txBody>
+                    <a:bodyPr/>
+                    <a:lstStyle/>
+                    <a:p>
+                      <a:pPr algn="r"/>
+                      <a:r>
+                        <a:rPr sz="1000">
+                          <a:solidFill>
+                            <a:srgbClr val="3F3F3F"/>
+                          </a:solidFill>
+                          <a:latin typeface="Encode Sans"/>
+                        </a:rPr>
+                        <a:t>122,2</a:t>
+                      </a:r>
+                    </a:p>
+                  </a:txBody>
+                  <a:tcPr marL="36576" marR="36576" marT="18288" marB="18288">
+                    <a:solidFill>
+                      <a:srgbClr val="F8F8F6"/>
+                    </a:solidFill>
+                  </a:tcPr>
+                </a:tc>
+                <a:tc>
+                  <a:txBody>
+                    <a:bodyPr/>
+                    <a:lstStyle/>
+                    <a:p>
+                      <a:pPr algn="r"/>
+                      <a:r>
+                        <a:rPr sz="1000">
+                          <a:solidFill>
+                            <a:srgbClr val="3F3F3F"/>
+                          </a:solidFill>
+                          <a:latin typeface="Encode Sans"/>
+                        </a:rPr>
+                        <a:t>+5.1%</a:t>
+                      </a:r>
+                    </a:p>
+                  </a:txBody>
+                  <a:tcPr marL="36576" marR="36576" marT="18288" marB="18288">
+                    <a:solidFill>
+                      <a:srgbClr val="F8F8F6"/>
+                    </a:solidFill>
+                  </a:tcPr>
+                </a:tc>
+              </a:tr>
+              <a:tr h="292608">
+                <a:tc>
+                  <a:txBody>
+                    <a:bodyPr/>
+                    <a:lstStyle/>
+                    <a:p>
+                      <a:pPr algn="l"/>
+                      <a:r>
+                        <a:rPr sz="1000">
+                          <a:solidFill>
+                            <a:srgbClr val="3F3F3F"/>
+                          </a:solidFill>
+                          <a:latin typeface="Encode Sans"/>
+                        </a:rPr>
+                        <a:t>Febrero 2026</a:t>
+                      </a:r>
+                    </a:p>
+                  </a:txBody>
+                  <a:tcPr marL="36576" marR="36576" marT="18288" marB="18288">
+                    <a:solidFill>
+                      <a:srgbClr val="FFFFFF"/>
+                    </a:solidFill>
+                  </a:tcPr>
+                </a:tc>
+                <a:tc>
+                  <a:txBody>
+                    <a:bodyPr/>
+                    <a:lstStyle/>
+                    <a:p>
+                      <a:pPr algn="r"/>
+                      <a:r>
+                        <a:rPr sz="1000">
+                          <a:solidFill>
+                            <a:srgbClr val="3F3F3F"/>
+                          </a:solidFill>
+                          <a:latin typeface="Encode Sans"/>
+                        </a:rPr>
+                        <a:t>100,3</a:t>
+                      </a:r>
+                    </a:p>
+                  </a:txBody>
+                  <a:tcPr marL="36576" marR="36576" marT="18288" marB="18288">
+                    <a:solidFill>
+                      <a:srgbClr val="FFFFFF"/>
+                    </a:solidFill>
+                  </a:tcPr>
+                </a:tc>
+                <a:tc>
+                  <a:txBody>
+                    <a:bodyPr/>
+                    <a:lstStyle/>
+                    <a:p>
+                      <a:pPr algn="r"/>
+                      <a:r>
+                        <a:rPr sz="1000">
+                          <a:solidFill>
+                            <a:srgbClr val="3F3F3F"/>
+                          </a:solidFill>
+                          <a:latin typeface="Encode Sans"/>
+                        </a:rPr>
+                        <a:t>-8.8%</a:t>
+                      </a:r>
+                    </a:p>
+                  </a:txBody>
+                  <a:tcPr marL="36576" marR="36576" marT="18288" marB="18288">
+                    <a:solidFill>
+                      <a:srgbClr val="FFFFFF"/>
+                    </a:solidFill>
+                  </a:tcPr>
+                </a:tc>
+              </a:tr>
+              <a:tr h="292608">
+                <a:tc>
+                  <a:txBody>
+                    <a:bodyPr/>
+                    <a:lstStyle/>
+                    <a:p>
+                      <a:pPr algn="l"/>
+                      <a:r>
+                        <a:rPr sz="1000">
+                          <a:solidFill>
+                            <a:srgbClr val="3F3F3F"/>
+                          </a:solidFill>
+                          <a:latin typeface="Encode Sans"/>
+                        </a:rPr>
+                        <a:t>Enero 2026</a:t>
+                      </a:r>
+                    </a:p>
+                  </a:txBody>
+                  <a:tcPr marL="36576" marR="36576" marT="18288" marB="18288">
+                    <a:solidFill>
+                      <a:srgbClr val="F8F8F6"/>
+                    </a:solidFill>
+                  </a:tcPr>
+                </a:tc>
+                <a:tc>
+                  <a:txBody>
+                    <a:bodyPr/>
+                    <a:lstStyle/>
+                    <a:p>
+                      <a:pPr algn="r"/>
+                      <a:r>
+                        <a:rPr sz="1000">
+                          <a:solidFill>
+                            <a:srgbClr val="3F3F3F"/>
+                          </a:solidFill>
+                          <a:latin typeface="Encode Sans"/>
+                        </a:rPr>
+                        <a:t>106,5</a:t>
+                      </a:r>
+                    </a:p>
+                  </a:txBody>
+                  <a:tcPr marL="36576" marR="36576" marT="18288" marB="18288">
+                    <a:solidFill>
+                      <a:srgbClr val="F8F8F6"/>
+                    </a:solidFill>
+                  </a:tcPr>
+                </a:tc>
+                <a:tc>
+                  <a:txBody>
+                    <a:bodyPr/>
+                    <a:lstStyle/>
+                    <a:p>
+                      <a:pPr algn="r"/>
+                      <a:r>
+                        <a:rPr sz="1000">
+                          <a:solidFill>
+                            <a:srgbClr val="3F3F3F"/>
+                          </a:solidFill>
+                          <a:latin typeface="Encode Sans"/>
+                        </a:rPr>
+                        <a:t>-3.8%</a:t>
+                      </a:r>
+                    </a:p>
+                  </a:txBody>
+                  <a:tcPr marL="36576" marR="36576" marT="18288" marB="18288">
+                    <a:solidFill>
+                      <a:srgbClr val="F8F8F6"/>
+                    </a:solidFill>
+                  </a:tcPr>
+                </a:tc>
+              </a:tr>
+            </a:tbl>
+          </a:graphicData>
+        </a:graphic>
+      </p:graphicFrame>
+      <p:sp>
+        <p:nvSpPr>
+          <p:cNvPr id="9" name="TextBox 8"/>
+          <p:cNvSpPr txBox="1"/>
+          <p:nvPr/>
+        </p:nvSpPr>
+        <p:spPr>
+          <a:xfrm>
+            <a:off x="411480" y="6492240"/>
+            <a:ext cx="11368735" cy="274320"/>
+          </a:xfrm>
+          <a:prstGeom prst="rect">
+            <a:avLst/>
+          </a:prstGeom>
+          <a:noFill/>
+        </p:spPr>
+        <p:txBody>
+          <a:bodyPr wrap="none">
+            <a:spAutoFit/>
+          </a:bodyPr>
+          <a:lstStyle/>
+          <a:p>
+            <a:r>
+              <a:rPr sz="1000" b="0" i="1">
+                <a:solidFill>
+                  <a:srgbClr val="6A6760"/>
+                </a:solidFill>
+                <a:latin typeface="Encode Sans"/>
+              </a:rPr>
+              <a:t>Fuente: elaboración propia en base a INDEC</a:t>
+            </a:r>
+          </a:p>
+        </p:txBody>
+      </p:sp>
+    </p:spTree>
+  </p:cSld>
+  <p:clrMapOvr>
+    <a:masterClrMapping/>
+  </p:clrMapOvr>
+</p:sld>
+</file>
+
 <file path=ppt/theme/theme1.xml><?xml version="1.0" encoding="utf-8"?>
 <a:theme xmlns:a="http://schemas.openxmlformats.org/drawingml/2006/main" name="Office Theme">
   <a:themeElements>

</xml_diff>

<commit_message>
data: update 2026-08-18 ( data.json despidos.json scraper/historical_despidos.json publicaciones_semana.pptx rrii_brutas.xlsx)
</commit_message>
<xml_diff>
--- a/publicaciones_semana.pptx
+++ b/publicaciones_semana.pptx
@@ -8,6 +8,8 @@
     <p:sldId id="256" r:id="rId7"/>
     <p:sldId id="257" r:id="rId8"/>
     <p:sldId id="258" r:id="rId9"/>
+    <p:sldId id="259" r:id="rId10"/>
+    <p:sldId id="260" r:id="rId11"/>
   </p:sldIdLst>
   <p:sldSz cx="12191695" cy="6858000" type="screen4x3"/>
   <p:notesSz cx="6858000" cy="9144000"/>
@@ -3239,7 +3241,7 @@
                 </a:solidFill>
                 <a:latin typeface="Encode Sans"/>
               </a:rPr>
-              <a:t>Publicaciones de la semana del 10 de agosto de 2026</a:t>
+              <a:t>Publicaciones de la semana del 17 de agosto de 2026</a:t>
             </a:r>
           </a:p>
         </p:txBody>
@@ -3273,7 +3275,7 @@
                 </a:solidFill>
                 <a:latin typeface="Encode Sans"/>
               </a:rPr>
-              <a:t>2 publicaciones · datos oficiales INDEC / BCRA / Hacienda</a:t>
+              <a:t>4 publicaciones · datos oficiales INDEC / BCRA / Hacienda</a:t>
             </a:r>
           </a:p>
         </p:txBody>
@@ -3369,7 +3371,7 @@
                 </a:solidFill>
                 <a:latin typeface="Encode Sans"/>
               </a:rPr>
-              <a:t>INFLACIÓN JULIO 2026: +2.1%</a:t>
+              <a:t>IPIM MAYORISTA JULIO 2026: +0.8%</a:t>
             </a:r>
           </a:p>
         </p:txBody>
@@ -3438,7 +3440,7 @@
                 </a:solidFill>
                 <a:latin typeface="Encode Sans"/>
               </a:rPr>
-              <a:t>El IPC nivel general aumentó +2.1% mensual en julio 2026, acumulando 33.83% interanual. INDEC publicó el indicador con la metodología vigente.</a:t>
+              <a:t>El IPIM mayorista registró un aumento de +0.8% mensual en julio 2026, acumulando 31.05% interanual. Suele anticipar el IPC minorista.</a:t>
             </a:r>
           </a:p>
         </p:txBody>
@@ -3486,7 +3488,7 @@
                 </a:solidFill>
                 <a:latin typeface="Encode Sans"/>
               </a:rPr>
-              <a:t>Variación mensual: +2.1%</a:t>
+              <a:t>Nivel general: +0.8% mensual</a:t>
             </a:r>
           </a:p>
           <a:p>
@@ -3511,7 +3513,7 @@
                 </a:solidFill>
                 <a:latin typeface="Encode Sans"/>
               </a:rPr>
-              <a:t>Variación interanual: 33.83%</a:t>
+              <a:t>Interanual: 31.05%</a:t>
             </a:r>
           </a:p>
           <a:p>
@@ -3536,7 +3538,7 @@
                 </a:solidFill>
                 <a:latin typeface="Encode Sans"/>
               </a:rPr>
-              <a:t>Acumulado últimos 6 meses: 15.0% (suma simple)</a:t>
+              <a:t>Brecha vs IPC minorista: -1.3% pp (IPC +2.1%)</a:t>
             </a:r>
           </a:p>
         </p:txBody>
@@ -3696,7 +3698,7 @@
                           </a:solidFill>
                           <a:latin typeface="Encode Sans"/>
                         </a:rPr>
-                        <a:t>+2.1%</a:t>
+                        <a:t>+0.80%</a:t>
                       </a:r>
                     </a:p>
                   </a:txBody>
@@ -3719,7 +3721,7 @@
                           </a:solidFill>
                           <a:latin typeface="Encode Sans"/>
                         </a:rPr>
-                        <a:t>+33.8%</a:t>
+                        <a:t>+31.1%</a:t>
                       </a:r>
                     </a:p>
                   </a:txBody>
@@ -3767,7 +3769,7 @@
                           </a:solidFill>
                           <a:latin typeface="Encode Sans"/>
                         </a:rPr>
-                        <a:t>+1.9%</a:t>
+                        <a:t>+1.08%</a:t>
                       </a:r>
                     </a:p>
                   </a:txBody>
@@ -3790,7 +3792,7 @@
                           </a:solidFill>
                           <a:latin typeface="Encode Sans"/>
                         </a:rPr>
-                        <a:t>+33.5%</a:t>
+                        <a:t>+33.7%</a:t>
                       </a:r>
                     </a:p>
                   </a:txBody>
@@ -3838,7 +3840,7 @@
                           </a:solidFill>
                           <a:latin typeface="Encode Sans"/>
                         </a:rPr>
-                        <a:t>+2.1%</a:t>
+                        <a:t>+2.51%</a:t>
                       </a:r>
                     </a:p>
                   </a:txBody>
@@ -3861,7 +3863,7 @@
                           </a:solidFill>
                           <a:latin typeface="Encode Sans"/>
                         </a:rPr>
-                        <a:t>+33.2%</a:t>
+                        <a:t>+34.5%</a:t>
                       </a:r>
                     </a:p>
                   </a:txBody>
@@ -3909,7 +3911,7 @@
                           </a:solidFill>
                           <a:latin typeface="Encode Sans"/>
                         </a:rPr>
-                        <a:t>+2.6%</a:t>
+                        <a:t>+5.16%</a:t>
                       </a:r>
                     </a:p>
                   </a:txBody>
@@ -3932,7 +3934,7 @@
                           </a:solidFill>
                           <a:latin typeface="Encode Sans"/>
                         </a:rPr>
-                        <a:t>+32.4%</a:t>
+                        <a:t>+30.8%</a:t>
                       </a:r>
                     </a:p>
                   </a:txBody>
@@ -3980,7 +3982,7 @@
                           </a:solidFill>
                           <a:latin typeface="Encode Sans"/>
                         </a:rPr>
-                        <a:t>+3.4%</a:t>
+                        <a:t>+3.38%</a:t>
                       </a:r>
                     </a:p>
                   </a:txBody>
@@ -4003,7 +4005,7 @@
                           </a:solidFill>
                           <a:latin typeface="Encode Sans"/>
                         </a:rPr>
-                        <a:t>+32.6%</a:t>
+                        <a:t>+27.9%</a:t>
                       </a:r>
                     </a:p>
                   </a:txBody>
@@ -4051,7 +4053,7 @@
                           </a:solidFill>
                           <a:latin typeface="Encode Sans"/>
                         </a:rPr>
-                        <a:t>+2.9%</a:t>
+                        <a:t>+0.98%</a:t>
                       </a:r>
                     </a:p>
                   </a:txBody>
@@ -4074,7 +4076,7 @@
                           </a:solidFill>
                           <a:latin typeface="Encode Sans"/>
                         </a:rPr>
-                        <a:t>+33.0%</a:t>
+                        <a:t>+25.6%</a:t>
                       </a:r>
                     </a:p>
                   </a:txBody>
@@ -4214,7 +4216,7 @@
                 </a:solidFill>
                 <a:latin typeface="Encode Sans"/>
               </a:rPr>
-              <a:t>INDUSTRIA JUNIO 2026: IPI CRECIÓ +0.0% I.A.</a:t>
+              <a:t>FISCAL JULIO 2026: SUPERÁVIT PRIMARIO $2.960K M$</a:t>
             </a:r>
           </a:p>
         </p:txBody>
@@ -4248,7 +4250,7 @@
                 </a:solidFill>
                 <a:latin typeface="Encode Sans"/>
               </a:rPr>
-              <a:t>INDEC · período 2026-06</a:t>
+              <a:t>Hacienda (vía INDEC IMIG) · período 2026-07</a:t>
             </a:r>
           </a:p>
         </p:txBody>
@@ -4283,7 +4285,7 @@
                 </a:solidFill>
                 <a:latin typeface="Encode Sans"/>
               </a:rPr>
-              <a:t>El Índice de Producción Industrial Manufacturero (IPI) registró una variación interanual de +0.0% en junio 2026.</a:t>
+              <a:t>El Sector Público Nacional No Financiero registró un resultado primario de +2.960 mil millones de pesos en julio 2026. El resultado financiero alcanzó +245K M$.</a:t>
             </a:r>
           </a:p>
         </p:txBody>
@@ -4331,7 +4333,7 @@
                 </a:solidFill>
                 <a:latin typeface="Encode Sans"/>
               </a:rPr>
-              <a:t>Variación interanual: +0.0%</a:t>
+              <a:t>Resultado primario: +2.960 mil millones de pesos</a:t>
             </a:r>
           </a:p>
           <a:p>
@@ -4356,7 +4358,32 @@
                 </a:solidFill>
                 <a:latin typeface="Encode Sans"/>
               </a:rPr>
-              <a:t>Serie INDEC, base 2004=100. Mide la producción manufacturera (16 ramas).</a:t>
+              <a:t>Resultado financiero: +245 mil millones</a:t>
+            </a:r>
+          </a:p>
+          <a:p>
+            <a:pPr algn="l">
+              <a:spcAft>
+                <a:spcPts val="800"/>
+              </a:spcAft>
+            </a:pPr>
+            <a:r>
+              <a:rPr sz="1300" b="1" i="0">
+                <a:solidFill>
+                  <a:srgbClr val="00B2C9"/>
+                </a:solidFill>
+                <a:latin typeface="Encode Sans"/>
+              </a:rPr>
+              <a:t>●  </a:t>
+            </a:r>
+            <a:r>
+              <a:rPr sz="1300" b="0" i="0">
+                <a:solidFill>
+                  <a:srgbClr val="3F3F3F"/>
+                </a:solidFill>
+                <a:latin typeface="Encode Sans"/>
+              </a:rPr>
+              <a:t>Fuente: Secretaría de Hacienda, base caja (Metodología 2017)</a:t>
             </a:r>
           </a:p>
         </p:txBody>
@@ -4445,7 +4472,7 @@
                           </a:solidFill>
                           <a:latin typeface="Encode Sans"/>
                         </a:rPr>
-                        <a:t>Original</a:t>
+                        <a:t>Primario M$</a:t>
                       </a:r>
                     </a:p>
                   </a:txBody>
@@ -4468,7 +4495,7 @@
                           </a:solidFill>
                           <a:latin typeface="Encode Sans"/>
                         </a:rPr>
-                        <a:t>VIA %</a:t>
+                        <a:t>Financiero M$</a:t>
                       </a:r>
                     </a:p>
                   </a:txBody>
@@ -4493,7 +4520,7 @@
                           </a:solidFill>
                           <a:latin typeface="Encode Sans"/>
                         </a:rPr>
-                        <a:t>Junio 2026</a:t>
+                        <a:t>Julio 2026</a:t>
                       </a:r>
                     </a:p>
                   </a:txBody>
@@ -4516,7 +4543,7 @@
                           </a:solidFill>
                           <a:latin typeface="Encode Sans"/>
                         </a:rPr>
-                        <a:t>119,9</a:t>
+                        <a:t>2.960.333</a:t>
                       </a:r>
                     </a:p>
                   </a:txBody>
@@ -4539,7 +4566,7 @@
                           </a:solidFill>
                           <a:latin typeface="Encode Sans"/>
                         </a:rPr>
-                        <a:t>+2.0%</a:t>
+                        <a:t>244.897</a:t>
                       </a:r>
                     </a:p>
                   </a:txBody>
@@ -4564,7 +4591,7 @@
                           </a:solidFill>
                           <a:latin typeface="Encode Sans"/>
                         </a:rPr>
-                        <a:t>Mayo 2026</a:t>
+                        <a:t>Junio 2026</a:t>
                       </a:r>
                     </a:p>
                   </a:txBody>
@@ -4587,7 +4614,7 @@
                           </a:solidFill>
                           <a:latin typeface="Encode Sans"/>
                         </a:rPr>
-                        <a:t>117,0</a:t>
+                        <a:t>-696.843</a:t>
                       </a:r>
                     </a:p>
                   </a:txBody>
@@ -4610,7 +4637,7 @@
                           </a:solidFill>
                           <a:latin typeface="Encode Sans"/>
                         </a:rPr>
-                        <a:t>-5.6%</a:t>
+                        <a:t>-1.024.891</a:t>
                       </a:r>
                     </a:p>
                   </a:txBody>
@@ -4635,7 +4662,7 @@
                           </a:solidFill>
                           <a:latin typeface="Encode Sans"/>
                         </a:rPr>
-                        <a:t>Abril 2026</a:t>
+                        <a:t>Mayo 2026</a:t>
                       </a:r>
                     </a:p>
                   </a:txBody>
@@ -4658,7 +4685,7 @@
                           </a:solidFill>
                           <a:latin typeface="Encode Sans"/>
                         </a:rPr>
-                        <a:t>118,6</a:t>
+                        <a:t>1.924.367</a:t>
                       </a:r>
                     </a:p>
                   </a:txBody>
@@ -4681,7 +4708,7 @@
                           </a:solidFill>
                           <a:latin typeface="Encode Sans"/>
                         </a:rPr>
-                        <a:t>-2.4%</a:t>
+                        <a:t>478.613</a:t>
                       </a:r>
                     </a:p>
                   </a:txBody>
@@ -4706,7 +4733,7 @@
                           </a:solidFill>
                           <a:latin typeface="Encode Sans"/>
                         </a:rPr>
-                        <a:t>Marzo 2026</a:t>
+                        <a:t>Abril 2026</a:t>
                       </a:r>
                     </a:p>
                   </a:txBody>
@@ -4729,7 +4756,7 @@
                           </a:solidFill>
                           <a:latin typeface="Encode Sans"/>
                         </a:rPr>
-                        <a:t>122,2</a:t>
+                        <a:t>632.844</a:t>
                       </a:r>
                     </a:p>
                   </a:txBody>
@@ -4752,7 +4779,7 @@
                           </a:solidFill>
                           <a:latin typeface="Encode Sans"/>
                         </a:rPr>
-                        <a:t>+5.1%</a:t>
+                        <a:t>356.292</a:t>
                       </a:r>
                     </a:p>
                   </a:txBody>
@@ -4777,7 +4804,7 @@
                           </a:solidFill>
                           <a:latin typeface="Encode Sans"/>
                         </a:rPr>
-                        <a:t>Febrero 2026</a:t>
+                        <a:t>Marzo 2026</a:t>
                       </a:r>
                     </a:p>
                   </a:txBody>
@@ -4800,7 +4827,7 @@
                           </a:solidFill>
                           <a:latin typeface="Encode Sans"/>
                         </a:rPr>
-                        <a:t>100,3</a:t>
+                        <a:t>930.284</a:t>
                       </a:r>
                     </a:p>
                   </a:txBody>
@@ -4823,7 +4850,7 @@
                           </a:solidFill>
                           <a:latin typeface="Encode Sans"/>
                         </a:rPr>
-                        <a:t>-8.8%</a:t>
+                        <a:t>246.434</a:t>
                       </a:r>
                     </a:p>
                   </a:txBody>
@@ -4848,7 +4875,7 @@
                           </a:solidFill>
                           <a:latin typeface="Encode Sans"/>
                         </a:rPr>
-                        <a:t>Enero 2026</a:t>
+                        <a:t>Febrero 2026</a:t>
                       </a:r>
                     </a:p>
                   </a:txBody>
@@ -4871,7 +4898,7 @@
                           </a:solidFill>
                           <a:latin typeface="Encode Sans"/>
                         </a:rPr>
-                        <a:t>106,5</a:t>
+                        <a:t>1.410.640</a:t>
                       </a:r>
                     </a:p>
                   </a:txBody>
@@ -4894,7 +4921,1697 @@
                           </a:solidFill>
                           <a:latin typeface="Encode Sans"/>
                         </a:rPr>
-                        <a:t>-3.8%</a:t>
+                        <a:t>297.224</a:t>
+                      </a:r>
+                    </a:p>
+                  </a:txBody>
+                  <a:tcPr marL="36576" marR="36576" marT="18288" marB="18288">
+                    <a:solidFill>
+                      <a:srgbClr val="F8F8F6"/>
+                    </a:solidFill>
+                  </a:tcPr>
+                </a:tc>
+              </a:tr>
+            </a:tbl>
+          </a:graphicData>
+        </a:graphic>
+      </p:graphicFrame>
+      <p:sp>
+        <p:nvSpPr>
+          <p:cNvPr id="9" name="TextBox 8"/>
+          <p:cNvSpPr txBox="1"/>
+          <p:nvPr/>
+        </p:nvSpPr>
+        <p:spPr>
+          <a:xfrm>
+            <a:off x="411480" y="6492240"/>
+            <a:ext cx="11368735" cy="274320"/>
+          </a:xfrm>
+          <a:prstGeom prst="rect">
+            <a:avLst/>
+          </a:prstGeom>
+          <a:noFill/>
+        </p:spPr>
+        <p:txBody>
+          <a:bodyPr wrap="none">
+            <a:spAutoFit/>
+          </a:bodyPr>
+          <a:lstStyle/>
+          <a:p>
+            <a:r>
+              <a:rPr sz="1000" b="0" i="1">
+                <a:solidFill>
+                  <a:srgbClr val="6A6760"/>
+                </a:solidFill>
+                <a:latin typeface="Encode Sans"/>
+              </a:rPr>
+              <a:t>Fuente: elaboración propia en base a Hacienda (vía INDEC IMIG)</a:t>
+            </a:r>
+          </a:p>
+        </p:txBody>
+      </p:sp>
+    </p:spTree>
+  </p:cSld>
+  <p:clrMapOvr>
+    <a:masterClrMapping/>
+  </p:clrMapOvr>
+</p:sld>
+</file>
+
+<file path=ppt/slides/slide4.xml><?xml version="1.0" encoding="utf-8"?>
+<p:sld xmlns:a="http://schemas.openxmlformats.org/drawingml/2006/main" xmlns:p="http://schemas.openxmlformats.org/presentationml/2006/main" xmlns:r="http://schemas.openxmlformats.org/officeDocument/2006/relationships">
+  <p:cSld>
+    <p:spTree>
+      <p:nvGrpSpPr>
+        <p:cNvPr id="1" name=""/>
+        <p:cNvGrpSpPr/>
+        <p:nvPr/>
+      </p:nvGrpSpPr>
+      <p:grpSpPr/>
+      <p:sp>
+        <p:nvSpPr>
+          <p:cNvPr id="2" name="Rectangle 1"/>
+          <p:cNvSpPr/>
+          <p:nvPr/>
+        </p:nvSpPr>
+        <p:spPr>
+          <a:xfrm>
+            <a:off x="0" y="0"/>
+            <a:ext cx="12191695" cy="274320"/>
+          </a:xfrm>
+          <a:prstGeom prst="rect">
+            <a:avLst/>
+          </a:prstGeom>
+          <a:solidFill>
+            <a:srgbClr val="00B2C9"/>
+          </a:solidFill>
+          <a:ln>
+            <a:noFill/>
+          </a:ln>
+        </p:spPr>
+        <p:style>
+          <a:lnRef idx="1">
+            <a:schemeClr val="accent1"/>
+          </a:lnRef>
+          <a:fillRef idx="3">
+            <a:schemeClr val="accent1"/>
+          </a:fillRef>
+          <a:effectRef idx="2">
+            <a:schemeClr val="accent1"/>
+          </a:effectRef>
+          <a:fontRef idx="minor">
+            <a:schemeClr val="lt1"/>
+          </a:fontRef>
+        </p:style>
+        <p:txBody>
+          <a:bodyPr rtlCol="0" anchor="ctr"/>
+          <a:lstStyle/>
+          <a:p>
+            <a:pPr algn="ctr"/>
+          </a:p>
+        </p:txBody>
+      </p:sp>
+      <p:sp>
+        <p:nvSpPr>
+          <p:cNvPr id="3" name="TextBox 2"/>
+          <p:cNvSpPr txBox="1"/>
+          <p:nvPr/>
+        </p:nvSpPr>
+        <p:spPr>
+          <a:xfrm>
+            <a:off x="411480" y="457200"/>
+            <a:ext cx="11368735" cy="914400"/>
+          </a:xfrm>
+          <a:prstGeom prst="rect">
+            <a:avLst/>
+          </a:prstGeom>
+          <a:noFill/>
+        </p:spPr>
+        <p:txBody>
+          <a:bodyPr wrap="square" lIns="0" rIns="0">
+            <a:spAutoFit/>
+          </a:bodyPr>
+          <a:lstStyle/>
+          <a:p>
+            <a:pPr algn="l"/>
+            <a:r>
+              <a:rPr sz="2600" b="1" i="0">
+                <a:solidFill>
+                  <a:srgbClr val="00B2C9"/>
+                </a:solidFill>
+                <a:latin typeface="Encode Sans"/>
+              </a:rPr>
+              <a:t>IPIB BÁSICOS JULIO 2026: +0.85%</a:t>
+            </a:r>
+          </a:p>
+        </p:txBody>
+      </p:sp>
+      <p:sp>
+        <p:nvSpPr>
+          <p:cNvPr id="4" name="TextBox 3"/>
+          <p:cNvSpPr txBox="1"/>
+          <p:nvPr/>
+        </p:nvSpPr>
+        <p:spPr>
+          <a:xfrm>
+            <a:off x="411480" y="1280160"/>
+            <a:ext cx="11368735" cy="274320"/>
+          </a:xfrm>
+          <a:prstGeom prst="rect">
+            <a:avLst/>
+          </a:prstGeom>
+          <a:noFill/>
+        </p:spPr>
+        <p:txBody>
+          <a:bodyPr wrap="none">
+            <a:spAutoFit/>
+          </a:bodyPr>
+          <a:lstStyle/>
+          <a:p>
+            <a:r>
+              <a:rPr sz="1100" b="0" i="1">
+                <a:solidFill>
+                  <a:srgbClr val="6A6760"/>
+                </a:solidFill>
+                <a:latin typeface="Encode Sans"/>
+              </a:rPr>
+              <a:t>INDEC · período 2026-07</a:t>
+            </a:r>
+          </a:p>
+        </p:txBody>
+      </p:sp>
+      <p:sp>
+        <p:nvSpPr>
+          <p:cNvPr id="5" name="TextBox 4"/>
+          <p:cNvSpPr txBox="1"/>
+          <p:nvPr/>
+        </p:nvSpPr>
+        <p:spPr>
+          <a:xfrm>
+            <a:off x="411480" y="1691640"/>
+            <a:ext cx="5486400" cy="1645920"/>
+          </a:xfrm>
+          <a:prstGeom prst="rect">
+            <a:avLst/>
+          </a:prstGeom>
+          <a:noFill/>
+        </p:spPr>
+        <p:txBody>
+          <a:bodyPr wrap="square" lIns="0" rIns="0">
+            <a:spAutoFit/>
+          </a:bodyPr>
+          <a:lstStyle/>
+          <a:p>
+            <a:pPr algn="just"/>
+            <a:r>
+              <a:rPr sz="1300" b="0" i="0">
+                <a:solidFill>
+                  <a:srgbClr val="3F3F3F"/>
+                </a:solidFill>
+                <a:latin typeface="Encode Sans"/>
+              </a:rPr>
+              <a:t>El IPIB básicos registró un aumento de +0.85% mensual en julio 2026, acumulando 30.18% interanual. Suele anticipar el IPC minorista.</a:t>
+            </a:r>
+          </a:p>
+        </p:txBody>
+      </p:sp>
+      <p:sp>
+        <p:nvSpPr>
+          <p:cNvPr id="6" name="TextBox 5"/>
+          <p:cNvSpPr txBox="1"/>
+          <p:nvPr/>
+        </p:nvSpPr>
+        <p:spPr>
+          <a:xfrm>
+            <a:off x="411480" y="3520440"/>
+            <a:ext cx="5486400" cy="2743200"/>
+          </a:xfrm>
+          <a:prstGeom prst="rect">
+            <a:avLst/>
+          </a:prstGeom>
+          <a:noFill/>
+        </p:spPr>
+        <p:txBody>
+          <a:bodyPr wrap="square" lIns="0" rIns="0">
+            <a:spAutoFit/>
+          </a:bodyPr>
+          <a:lstStyle/>
+          <a:p>
+            <a:pPr algn="l">
+              <a:spcAft>
+                <a:spcPts val="800"/>
+              </a:spcAft>
+            </a:pPr>
+            <a:r>
+              <a:rPr sz="1300" b="1" i="0">
+                <a:solidFill>
+                  <a:srgbClr val="00B2C9"/>
+                </a:solidFill>
+                <a:latin typeface="Encode Sans"/>
+              </a:rPr>
+              <a:t>●  </a:t>
+            </a:r>
+            <a:r>
+              <a:rPr sz="1300" b="0" i="0">
+                <a:solidFill>
+                  <a:srgbClr val="3F3F3F"/>
+                </a:solidFill>
+                <a:latin typeface="Encode Sans"/>
+              </a:rPr>
+              <a:t>Nivel general: +0.85% mensual</a:t>
+            </a:r>
+          </a:p>
+          <a:p>
+            <a:pPr algn="l">
+              <a:spcAft>
+                <a:spcPts val="800"/>
+              </a:spcAft>
+            </a:pPr>
+            <a:r>
+              <a:rPr sz="1300" b="1" i="0">
+                <a:solidFill>
+                  <a:srgbClr val="00B2C9"/>
+                </a:solidFill>
+                <a:latin typeface="Encode Sans"/>
+              </a:rPr>
+              <a:t>●  </a:t>
+            </a:r>
+            <a:r>
+              <a:rPr sz="1300" b="0" i="0">
+                <a:solidFill>
+                  <a:srgbClr val="3F3F3F"/>
+                </a:solidFill>
+                <a:latin typeface="Encode Sans"/>
+              </a:rPr>
+              <a:t>Interanual: 30.18%</a:t>
+            </a:r>
+          </a:p>
+          <a:p>
+            <a:pPr algn="l">
+              <a:spcAft>
+                <a:spcPts val="800"/>
+              </a:spcAft>
+            </a:pPr>
+            <a:r>
+              <a:rPr sz="1300" b="1" i="0">
+                <a:solidFill>
+                  <a:srgbClr val="00B2C9"/>
+                </a:solidFill>
+                <a:latin typeface="Encode Sans"/>
+              </a:rPr>
+              <a:t>●  </a:t>
+            </a:r>
+            <a:r>
+              <a:rPr sz="1300" b="0" i="0">
+                <a:solidFill>
+                  <a:srgbClr val="3F3F3F"/>
+                </a:solidFill>
+                <a:latin typeface="Encode Sans"/>
+              </a:rPr>
+              <a:t>Brecha vs IPC minorista: -1.3% pp (IPC +2.1%)</a:t>
+            </a:r>
+          </a:p>
+        </p:txBody>
+      </p:sp>
+      <p:pic>
+        <p:nvPicPr>
+          <p:cNvPr id="7" name="Picture 6" descr="image.png"/>
+          <p:cNvPicPr>
+            <a:picLocks noChangeAspect="1"/>
+          </p:cNvPicPr>
+          <p:nvPr/>
+        </p:nvPicPr>
+        <p:blipFill>
+          <a:blip r:embed="rId2"/>
+          <a:stretch>
+            <a:fillRect/>
+          </a:stretch>
+        </p:blipFill>
+        <p:spPr>
+          <a:xfrm>
+            <a:off x="6080760" y="1691640"/>
+            <a:ext cx="5669280" cy="2560320"/>
+          </a:xfrm>
+          <a:prstGeom prst="rect">
+            <a:avLst/>
+          </a:prstGeom>
+        </p:spPr>
+      </p:pic>
+      <p:graphicFrame>
+        <p:nvGraphicFramePr>
+          <p:cNvPr id="8" name="Table 7"/>
+          <p:cNvGraphicFramePr>
+            <a:graphicFrameLocks noGrp="1"/>
+          </p:cNvGraphicFramePr>
+          <p:nvPr/>
+        </p:nvGraphicFramePr>
+        <p:xfrm>
+          <a:off x="6080760" y="4434840"/>
+          <a:ext cx="5669280" cy="2048256"/>
+        </p:xfrm>
+        <a:graphic>
+          <a:graphicData uri="http://schemas.openxmlformats.org/drawingml/2006/table">
+            <a:tbl>
+              <a:tblPr firstRow="1" bandRow="1">
+                <a:tableStyleId>{5C22544A-7EE6-4342-B048-85BDC9FD1C3A}</a:tableStyleId>
+              </a:tblPr>
+              <a:tblGrid>
+                <a:gridCol w="1889760"/>
+                <a:gridCol w="1889760"/>
+                <a:gridCol w="1889760"/>
+              </a:tblGrid>
+              <a:tr h="292608">
+                <a:tc>
+                  <a:txBody>
+                    <a:bodyPr/>
+                    <a:lstStyle/>
+                    <a:p>
+                      <a:pPr algn="l"/>
+                      <a:r>
+                        <a:rPr sz="1000" b="1">
+                          <a:solidFill>
+                            <a:srgbClr val="FFFFFF"/>
+                          </a:solidFill>
+                          <a:latin typeface="Encode Sans"/>
+                        </a:rPr>
+                        <a:t>Mes</a:t>
+                      </a:r>
+                    </a:p>
+                  </a:txBody>
+                  <a:tcPr marL="36576" marR="36576" marT="18288" marB="18288">
+                    <a:solidFill>
+                      <a:srgbClr val="00B2C9"/>
+                    </a:solidFill>
+                  </a:tcPr>
+                </a:tc>
+                <a:tc>
+                  <a:txBody>
+                    <a:bodyPr/>
+                    <a:lstStyle/>
+                    <a:p>
+                      <a:pPr algn="r"/>
+                      <a:r>
+                        <a:rPr sz="1000" b="1">
+                          <a:solidFill>
+                            <a:srgbClr val="FFFFFF"/>
+                          </a:solidFill>
+                          <a:latin typeface="Encode Sans"/>
+                        </a:rPr>
+                        <a:t>VM %</a:t>
+                      </a:r>
+                    </a:p>
+                  </a:txBody>
+                  <a:tcPr marL="36576" marR="36576" marT="18288" marB="18288">
+                    <a:solidFill>
+                      <a:srgbClr val="00B2C9"/>
+                    </a:solidFill>
+                  </a:tcPr>
+                </a:tc>
+                <a:tc>
+                  <a:txBody>
+                    <a:bodyPr/>
+                    <a:lstStyle/>
+                    <a:p>
+                      <a:pPr algn="r"/>
+                      <a:r>
+                        <a:rPr sz="1000" b="1">
+                          <a:solidFill>
+                            <a:srgbClr val="FFFFFF"/>
+                          </a:solidFill>
+                          <a:latin typeface="Encode Sans"/>
+                        </a:rPr>
+                        <a:t>VIA %</a:t>
+                      </a:r>
+                    </a:p>
+                  </a:txBody>
+                  <a:tcPr marL="36576" marR="36576" marT="18288" marB="18288">
+                    <a:solidFill>
+                      <a:srgbClr val="00B2C9"/>
+                    </a:solidFill>
+                  </a:tcPr>
+                </a:tc>
+              </a:tr>
+              <a:tr h="292608">
+                <a:tc>
+                  <a:txBody>
+                    <a:bodyPr/>
+                    <a:lstStyle/>
+                    <a:p>
+                      <a:pPr algn="l"/>
+                      <a:r>
+                        <a:rPr sz="1000">
+                          <a:solidFill>
+                            <a:srgbClr val="3F3F3F"/>
+                          </a:solidFill>
+                          <a:latin typeface="Encode Sans"/>
+                        </a:rPr>
+                        <a:t>Julio 2026</a:t>
+                      </a:r>
+                    </a:p>
+                  </a:txBody>
+                  <a:tcPr marL="36576" marR="36576" marT="18288" marB="18288">
+                    <a:solidFill>
+                      <a:srgbClr val="FFFFFF"/>
+                    </a:solidFill>
+                  </a:tcPr>
+                </a:tc>
+                <a:tc>
+                  <a:txBody>
+                    <a:bodyPr/>
+                    <a:lstStyle/>
+                    <a:p>
+                      <a:pPr algn="r"/>
+                      <a:r>
+                        <a:rPr sz="1000">
+                          <a:solidFill>
+                            <a:srgbClr val="3F3F3F"/>
+                          </a:solidFill>
+                          <a:latin typeface="Encode Sans"/>
+                        </a:rPr>
+                        <a:t>+0.85%</a:t>
+                      </a:r>
+                    </a:p>
+                  </a:txBody>
+                  <a:tcPr marL="36576" marR="36576" marT="18288" marB="18288">
+                    <a:solidFill>
+                      <a:srgbClr val="FFFFFF"/>
+                    </a:solidFill>
+                  </a:tcPr>
+                </a:tc>
+                <a:tc>
+                  <a:txBody>
+                    <a:bodyPr/>
+                    <a:lstStyle/>
+                    <a:p>
+                      <a:pPr algn="r"/>
+                      <a:r>
+                        <a:rPr sz="1000">
+                          <a:solidFill>
+                            <a:srgbClr val="3F3F3F"/>
+                          </a:solidFill>
+                          <a:latin typeface="Encode Sans"/>
+                        </a:rPr>
+                        <a:t>+30.2%</a:t>
+                      </a:r>
+                    </a:p>
+                  </a:txBody>
+                  <a:tcPr marL="36576" marR="36576" marT="18288" marB="18288">
+                    <a:solidFill>
+                      <a:srgbClr val="FFFFFF"/>
+                    </a:solidFill>
+                  </a:tcPr>
+                </a:tc>
+              </a:tr>
+              <a:tr h="292608">
+                <a:tc>
+                  <a:txBody>
+                    <a:bodyPr/>
+                    <a:lstStyle/>
+                    <a:p>
+                      <a:pPr algn="l"/>
+                      <a:r>
+                        <a:rPr sz="1000">
+                          <a:solidFill>
+                            <a:srgbClr val="3F3F3F"/>
+                          </a:solidFill>
+                          <a:latin typeface="Encode Sans"/>
+                        </a:rPr>
+                        <a:t>Junio 2026</a:t>
+                      </a:r>
+                    </a:p>
+                  </a:txBody>
+                  <a:tcPr marL="36576" marR="36576" marT="18288" marB="18288">
+                    <a:solidFill>
+                      <a:srgbClr val="F8F8F6"/>
+                    </a:solidFill>
+                  </a:tcPr>
+                </a:tc>
+                <a:tc>
+                  <a:txBody>
+                    <a:bodyPr/>
+                    <a:lstStyle/>
+                    <a:p>
+                      <a:pPr algn="r"/>
+                      <a:r>
+                        <a:rPr sz="1000">
+                          <a:solidFill>
+                            <a:srgbClr val="3F3F3F"/>
+                          </a:solidFill>
+                          <a:latin typeface="Encode Sans"/>
+                        </a:rPr>
+                        <a:t>+1.15%</a:t>
+                      </a:r>
+                    </a:p>
+                  </a:txBody>
+                  <a:tcPr marL="36576" marR="36576" marT="18288" marB="18288">
+                    <a:solidFill>
+                      <a:srgbClr val="F8F8F6"/>
+                    </a:solidFill>
+                  </a:tcPr>
+                </a:tc>
+                <a:tc>
+                  <a:txBody>
+                    <a:bodyPr/>
+                    <a:lstStyle/>
+                    <a:p>
+                      <a:pPr algn="r"/>
+                      <a:r>
+                        <a:rPr sz="1000">
+                          <a:solidFill>
+                            <a:srgbClr val="3F3F3F"/>
+                          </a:solidFill>
+                          <a:latin typeface="Encode Sans"/>
+                        </a:rPr>
+                        <a:t>+33.0%</a:t>
+                      </a:r>
+                    </a:p>
+                  </a:txBody>
+                  <a:tcPr marL="36576" marR="36576" marT="18288" marB="18288">
+                    <a:solidFill>
+                      <a:srgbClr val="F8F8F6"/>
+                    </a:solidFill>
+                  </a:tcPr>
+                </a:tc>
+              </a:tr>
+              <a:tr h="292608">
+                <a:tc>
+                  <a:txBody>
+                    <a:bodyPr/>
+                    <a:lstStyle/>
+                    <a:p>
+                      <a:pPr algn="l"/>
+                      <a:r>
+                        <a:rPr sz="1000">
+                          <a:solidFill>
+                            <a:srgbClr val="3F3F3F"/>
+                          </a:solidFill>
+                          <a:latin typeface="Encode Sans"/>
+                        </a:rPr>
+                        <a:t>Mayo 2026</a:t>
+                      </a:r>
+                    </a:p>
+                  </a:txBody>
+                  <a:tcPr marL="36576" marR="36576" marT="18288" marB="18288">
+                    <a:solidFill>
+                      <a:srgbClr val="FFFFFF"/>
+                    </a:solidFill>
+                  </a:tcPr>
+                </a:tc>
+                <a:tc>
+                  <a:txBody>
+                    <a:bodyPr/>
+                    <a:lstStyle/>
+                    <a:p>
+                      <a:pPr algn="r"/>
+                      <a:r>
+                        <a:rPr sz="1000">
+                          <a:solidFill>
+                            <a:srgbClr val="3F3F3F"/>
+                          </a:solidFill>
+                          <a:latin typeface="Encode Sans"/>
+                        </a:rPr>
+                        <a:t>+2.68%</a:t>
+                      </a:r>
+                    </a:p>
+                  </a:txBody>
+                  <a:tcPr marL="36576" marR="36576" marT="18288" marB="18288">
+                    <a:solidFill>
+                      <a:srgbClr val="FFFFFF"/>
+                    </a:solidFill>
+                  </a:tcPr>
+                </a:tc>
+                <a:tc>
+                  <a:txBody>
+                    <a:bodyPr/>
+                    <a:lstStyle/>
+                    <a:p>
+                      <a:pPr algn="r"/>
+                      <a:r>
+                        <a:rPr sz="1000">
+                          <a:solidFill>
+                            <a:srgbClr val="3F3F3F"/>
+                          </a:solidFill>
+                          <a:latin typeface="Encode Sans"/>
+                        </a:rPr>
+                        <a:t>+33.5%</a:t>
+                      </a:r>
+                    </a:p>
+                  </a:txBody>
+                  <a:tcPr marL="36576" marR="36576" marT="18288" marB="18288">
+                    <a:solidFill>
+                      <a:srgbClr val="FFFFFF"/>
+                    </a:solidFill>
+                  </a:tcPr>
+                </a:tc>
+              </a:tr>
+              <a:tr h="292608">
+                <a:tc>
+                  <a:txBody>
+                    <a:bodyPr/>
+                    <a:lstStyle/>
+                    <a:p>
+                      <a:pPr algn="l"/>
+                      <a:r>
+                        <a:rPr sz="1000">
+                          <a:solidFill>
+                            <a:srgbClr val="3F3F3F"/>
+                          </a:solidFill>
+                          <a:latin typeface="Encode Sans"/>
+                        </a:rPr>
+                        <a:t>Abril 2026</a:t>
+                      </a:r>
+                    </a:p>
+                  </a:txBody>
+                  <a:tcPr marL="36576" marR="36576" marT="18288" marB="18288">
+                    <a:solidFill>
+                      <a:srgbClr val="F8F8F6"/>
+                    </a:solidFill>
+                  </a:tcPr>
+                </a:tc>
+                <a:tc>
+                  <a:txBody>
+                    <a:bodyPr/>
+                    <a:lstStyle/>
+                    <a:p>
+                      <a:pPr algn="r"/>
+                      <a:r>
+                        <a:rPr sz="1000">
+                          <a:solidFill>
+                            <a:srgbClr val="3F3F3F"/>
+                          </a:solidFill>
+                          <a:latin typeface="Encode Sans"/>
+                        </a:rPr>
+                        <a:t>+4.76%</a:t>
+                      </a:r>
+                    </a:p>
+                  </a:txBody>
+                  <a:tcPr marL="36576" marR="36576" marT="18288" marB="18288">
+                    <a:solidFill>
+                      <a:srgbClr val="F8F8F6"/>
+                    </a:solidFill>
+                  </a:tcPr>
+                </a:tc>
+                <a:tc>
+                  <a:txBody>
+                    <a:bodyPr/>
+                    <a:lstStyle/>
+                    <a:p>
+                      <a:pPr algn="r"/>
+                      <a:r>
+                        <a:rPr sz="1000">
+                          <a:solidFill>
+                            <a:srgbClr val="3F3F3F"/>
+                          </a:solidFill>
+                          <a:latin typeface="Encode Sans"/>
+                        </a:rPr>
+                        <a:t>+29.6%</a:t>
+                      </a:r>
+                    </a:p>
+                  </a:txBody>
+                  <a:tcPr marL="36576" marR="36576" marT="18288" marB="18288">
+                    <a:solidFill>
+                      <a:srgbClr val="F8F8F6"/>
+                    </a:solidFill>
+                  </a:tcPr>
+                </a:tc>
+              </a:tr>
+              <a:tr h="292608">
+                <a:tc>
+                  <a:txBody>
+                    <a:bodyPr/>
+                    <a:lstStyle/>
+                    <a:p>
+                      <a:pPr algn="l"/>
+                      <a:r>
+                        <a:rPr sz="1000">
+                          <a:solidFill>
+                            <a:srgbClr val="3F3F3F"/>
+                          </a:solidFill>
+                          <a:latin typeface="Encode Sans"/>
+                        </a:rPr>
+                        <a:t>Marzo 2026</a:t>
+                      </a:r>
+                    </a:p>
+                  </a:txBody>
+                  <a:tcPr marL="36576" marR="36576" marT="18288" marB="18288">
+                    <a:solidFill>
+                      <a:srgbClr val="FFFFFF"/>
+                    </a:solidFill>
+                  </a:tcPr>
+                </a:tc>
+                <a:tc>
+                  <a:txBody>
+                    <a:bodyPr/>
+                    <a:lstStyle/>
+                    <a:p>
+                      <a:pPr algn="r"/>
+                      <a:r>
+                        <a:rPr sz="1000">
+                          <a:solidFill>
+                            <a:srgbClr val="3F3F3F"/>
+                          </a:solidFill>
+                          <a:latin typeface="Encode Sans"/>
+                        </a:rPr>
+                        <a:t>+3.00%</a:t>
+                      </a:r>
+                    </a:p>
+                  </a:txBody>
+                  <a:tcPr marL="36576" marR="36576" marT="18288" marB="18288">
+                    <a:solidFill>
+                      <a:srgbClr val="FFFFFF"/>
+                    </a:solidFill>
+                  </a:tcPr>
+                </a:tc>
+                <a:tc>
+                  <a:txBody>
+                    <a:bodyPr/>
+                    <a:lstStyle/>
+                    <a:p>
+                      <a:pPr algn="r"/>
+                      <a:r>
+                        <a:rPr sz="1000">
+                          <a:solidFill>
+                            <a:srgbClr val="3F3F3F"/>
+                          </a:solidFill>
+                          <a:latin typeface="Encode Sans"/>
+                        </a:rPr>
+                        <a:t>+27.1%</a:t>
+                      </a:r>
+                    </a:p>
+                  </a:txBody>
+                  <a:tcPr marL="36576" marR="36576" marT="18288" marB="18288">
+                    <a:solidFill>
+                      <a:srgbClr val="FFFFFF"/>
+                    </a:solidFill>
+                  </a:tcPr>
+                </a:tc>
+              </a:tr>
+              <a:tr h="292608">
+                <a:tc>
+                  <a:txBody>
+                    <a:bodyPr/>
+                    <a:lstStyle/>
+                    <a:p>
+                      <a:pPr algn="l"/>
+                      <a:r>
+                        <a:rPr sz="1000">
+                          <a:solidFill>
+                            <a:srgbClr val="3F3F3F"/>
+                          </a:solidFill>
+                          <a:latin typeface="Encode Sans"/>
+                        </a:rPr>
+                        <a:t>Febrero 2026</a:t>
+                      </a:r>
+                    </a:p>
+                  </a:txBody>
+                  <a:tcPr marL="36576" marR="36576" marT="18288" marB="18288">
+                    <a:solidFill>
+                      <a:srgbClr val="F8F8F6"/>
+                    </a:solidFill>
+                  </a:tcPr>
+                </a:tc>
+                <a:tc>
+                  <a:txBody>
+                    <a:bodyPr/>
+                    <a:lstStyle/>
+                    <a:p>
+                      <a:pPr algn="r"/>
+                      <a:r>
+                        <a:rPr sz="1000">
+                          <a:solidFill>
+                            <a:srgbClr val="3F3F3F"/>
+                          </a:solidFill>
+                          <a:latin typeface="Encode Sans"/>
+                        </a:rPr>
+                        <a:t>+0.67%</a:t>
+                      </a:r>
+                    </a:p>
+                  </a:txBody>
+                  <a:tcPr marL="36576" marR="36576" marT="18288" marB="18288">
+                    <a:solidFill>
+                      <a:srgbClr val="F8F8F6"/>
+                    </a:solidFill>
+                  </a:tcPr>
+                </a:tc>
+                <a:tc>
+                  <a:txBody>
+                    <a:bodyPr/>
+                    <a:lstStyle/>
+                    <a:p>
+                      <a:pPr algn="r"/>
+                      <a:r>
+                        <a:rPr sz="1000">
+                          <a:solidFill>
+                            <a:srgbClr val="3F3F3F"/>
+                          </a:solidFill>
+                          <a:latin typeface="Encode Sans"/>
+                        </a:rPr>
+                        <a:t>+25.1%</a:t>
+                      </a:r>
+                    </a:p>
+                  </a:txBody>
+                  <a:tcPr marL="36576" marR="36576" marT="18288" marB="18288">
+                    <a:solidFill>
+                      <a:srgbClr val="F8F8F6"/>
+                    </a:solidFill>
+                  </a:tcPr>
+                </a:tc>
+              </a:tr>
+            </a:tbl>
+          </a:graphicData>
+        </a:graphic>
+      </p:graphicFrame>
+      <p:sp>
+        <p:nvSpPr>
+          <p:cNvPr id="9" name="TextBox 8"/>
+          <p:cNvSpPr txBox="1"/>
+          <p:nvPr/>
+        </p:nvSpPr>
+        <p:spPr>
+          <a:xfrm>
+            <a:off x="411480" y="6492240"/>
+            <a:ext cx="11368735" cy="274320"/>
+          </a:xfrm>
+          <a:prstGeom prst="rect">
+            <a:avLst/>
+          </a:prstGeom>
+          <a:noFill/>
+        </p:spPr>
+        <p:txBody>
+          <a:bodyPr wrap="none">
+            <a:spAutoFit/>
+          </a:bodyPr>
+          <a:lstStyle/>
+          <a:p>
+            <a:r>
+              <a:rPr sz="1000" b="0" i="1">
+                <a:solidFill>
+                  <a:srgbClr val="6A6760"/>
+                </a:solidFill>
+                <a:latin typeface="Encode Sans"/>
+              </a:rPr>
+              <a:t>Fuente: elaboración propia en base a INDEC</a:t>
+            </a:r>
+          </a:p>
+        </p:txBody>
+      </p:sp>
+    </p:spTree>
+  </p:cSld>
+  <p:clrMapOvr>
+    <a:masterClrMapping/>
+  </p:clrMapOvr>
+</p:sld>
+</file>
+
+<file path=ppt/slides/slide5.xml><?xml version="1.0" encoding="utf-8"?>
+<p:sld xmlns:a="http://schemas.openxmlformats.org/drawingml/2006/main" xmlns:p="http://schemas.openxmlformats.org/presentationml/2006/main" xmlns:r="http://schemas.openxmlformats.org/officeDocument/2006/relationships">
+  <p:cSld>
+    <p:spTree>
+      <p:nvGrpSpPr>
+        <p:cNvPr id="1" name=""/>
+        <p:cNvGrpSpPr/>
+        <p:nvPr/>
+      </p:nvGrpSpPr>
+      <p:grpSpPr/>
+      <p:sp>
+        <p:nvSpPr>
+          <p:cNvPr id="2" name="Rectangle 1"/>
+          <p:cNvSpPr/>
+          <p:nvPr/>
+        </p:nvSpPr>
+        <p:spPr>
+          <a:xfrm>
+            <a:off x="0" y="0"/>
+            <a:ext cx="12191695" cy="274320"/>
+          </a:xfrm>
+          <a:prstGeom prst="rect">
+            <a:avLst/>
+          </a:prstGeom>
+          <a:solidFill>
+            <a:srgbClr val="00B2C9"/>
+          </a:solidFill>
+          <a:ln>
+            <a:noFill/>
+          </a:ln>
+        </p:spPr>
+        <p:style>
+          <a:lnRef idx="1">
+            <a:schemeClr val="accent1"/>
+          </a:lnRef>
+          <a:fillRef idx="3">
+            <a:schemeClr val="accent1"/>
+          </a:fillRef>
+          <a:effectRef idx="2">
+            <a:schemeClr val="accent1"/>
+          </a:effectRef>
+          <a:fontRef idx="minor">
+            <a:schemeClr val="lt1"/>
+          </a:fontRef>
+        </p:style>
+        <p:txBody>
+          <a:bodyPr rtlCol="0" anchor="ctr"/>
+          <a:lstStyle/>
+          <a:p>
+            <a:pPr algn="ctr"/>
+          </a:p>
+        </p:txBody>
+      </p:sp>
+      <p:sp>
+        <p:nvSpPr>
+          <p:cNvPr id="3" name="TextBox 2"/>
+          <p:cNvSpPr txBox="1"/>
+          <p:nvPr/>
+        </p:nvSpPr>
+        <p:spPr>
+          <a:xfrm>
+            <a:off x="411480" y="457200"/>
+            <a:ext cx="11368735" cy="914400"/>
+          </a:xfrm>
+          <a:prstGeom prst="rect">
+            <a:avLst/>
+          </a:prstGeom>
+          <a:noFill/>
+        </p:spPr>
+        <p:txBody>
+          <a:bodyPr wrap="square" lIns="0" rIns="0">
+            <a:spAutoFit/>
+          </a:bodyPr>
+          <a:lstStyle/>
+          <a:p>
+            <a:pPr algn="l"/>
+            <a:r>
+              <a:rPr sz="2600" b="1" i="0">
+                <a:solidFill>
+                  <a:srgbClr val="00B2C9"/>
+                </a:solidFill>
+                <a:latin typeface="Encode Sans"/>
+              </a:rPr>
+              <a:t>IPP PRODUCTOR JULIO 2026: +0.89%</a:t>
+            </a:r>
+          </a:p>
+        </p:txBody>
+      </p:sp>
+      <p:sp>
+        <p:nvSpPr>
+          <p:cNvPr id="4" name="TextBox 3"/>
+          <p:cNvSpPr txBox="1"/>
+          <p:nvPr/>
+        </p:nvSpPr>
+        <p:spPr>
+          <a:xfrm>
+            <a:off x="411480" y="1280160"/>
+            <a:ext cx="11368735" cy="274320"/>
+          </a:xfrm>
+          <a:prstGeom prst="rect">
+            <a:avLst/>
+          </a:prstGeom>
+          <a:noFill/>
+        </p:spPr>
+        <p:txBody>
+          <a:bodyPr wrap="none">
+            <a:spAutoFit/>
+          </a:bodyPr>
+          <a:lstStyle/>
+          <a:p>
+            <a:r>
+              <a:rPr sz="1100" b="0" i="1">
+                <a:solidFill>
+                  <a:srgbClr val="6A6760"/>
+                </a:solidFill>
+                <a:latin typeface="Encode Sans"/>
+              </a:rPr>
+              <a:t>INDEC · período 2026-07</a:t>
+            </a:r>
+          </a:p>
+        </p:txBody>
+      </p:sp>
+      <p:sp>
+        <p:nvSpPr>
+          <p:cNvPr id="5" name="TextBox 4"/>
+          <p:cNvSpPr txBox="1"/>
+          <p:nvPr/>
+        </p:nvSpPr>
+        <p:spPr>
+          <a:xfrm>
+            <a:off x="411480" y="1691640"/>
+            <a:ext cx="5486400" cy="1645920"/>
+          </a:xfrm>
+          <a:prstGeom prst="rect">
+            <a:avLst/>
+          </a:prstGeom>
+          <a:noFill/>
+        </p:spPr>
+        <p:txBody>
+          <a:bodyPr wrap="square" lIns="0" rIns="0">
+            <a:spAutoFit/>
+          </a:bodyPr>
+          <a:lstStyle/>
+          <a:p>
+            <a:pPr algn="just"/>
+            <a:r>
+              <a:rPr sz="1300" b="0" i="0">
+                <a:solidFill>
+                  <a:srgbClr val="3F3F3F"/>
+                </a:solidFill>
+                <a:latin typeface="Encode Sans"/>
+              </a:rPr>
+              <a:t>El IPP productor registró un aumento de +0.89% mensual en julio 2026, acumulando 31.31% interanual. Suele anticipar el IPC minorista.</a:t>
+            </a:r>
+          </a:p>
+        </p:txBody>
+      </p:sp>
+      <p:sp>
+        <p:nvSpPr>
+          <p:cNvPr id="6" name="TextBox 5"/>
+          <p:cNvSpPr txBox="1"/>
+          <p:nvPr/>
+        </p:nvSpPr>
+        <p:spPr>
+          <a:xfrm>
+            <a:off x="411480" y="3520440"/>
+            <a:ext cx="5486400" cy="2743200"/>
+          </a:xfrm>
+          <a:prstGeom prst="rect">
+            <a:avLst/>
+          </a:prstGeom>
+          <a:noFill/>
+        </p:spPr>
+        <p:txBody>
+          <a:bodyPr wrap="square" lIns="0" rIns="0">
+            <a:spAutoFit/>
+          </a:bodyPr>
+          <a:lstStyle/>
+          <a:p>
+            <a:pPr algn="l">
+              <a:spcAft>
+                <a:spcPts val="800"/>
+              </a:spcAft>
+            </a:pPr>
+            <a:r>
+              <a:rPr sz="1300" b="1" i="0">
+                <a:solidFill>
+                  <a:srgbClr val="00B2C9"/>
+                </a:solidFill>
+                <a:latin typeface="Encode Sans"/>
+              </a:rPr>
+              <a:t>●  </a:t>
+            </a:r>
+            <a:r>
+              <a:rPr sz="1300" b="0" i="0">
+                <a:solidFill>
+                  <a:srgbClr val="3F3F3F"/>
+                </a:solidFill>
+                <a:latin typeface="Encode Sans"/>
+              </a:rPr>
+              <a:t>Nivel general: +0.89% mensual</a:t>
+            </a:r>
+          </a:p>
+          <a:p>
+            <a:pPr algn="l">
+              <a:spcAft>
+                <a:spcPts val="800"/>
+              </a:spcAft>
+            </a:pPr>
+            <a:r>
+              <a:rPr sz="1300" b="1" i="0">
+                <a:solidFill>
+                  <a:srgbClr val="00B2C9"/>
+                </a:solidFill>
+                <a:latin typeface="Encode Sans"/>
+              </a:rPr>
+              <a:t>●  </a:t>
+            </a:r>
+            <a:r>
+              <a:rPr sz="1300" b="0" i="0">
+                <a:solidFill>
+                  <a:srgbClr val="3F3F3F"/>
+                </a:solidFill>
+                <a:latin typeface="Encode Sans"/>
+              </a:rPr>
+              <a:t>Interanual: 31.31%</a:t>
+            </a:r>
+          </a:p>
+          <a:p>
+            <a:pPr algn="l">
+              <a:spcAft>
+                <a:spcPts val="800"/>
+              </a:spcAft>
+            </a:pPr>
+            <a:r>
+              <a:rPr sz="1300" b="1" i="0">
+                <a:solidFill>
+                  <a:srgbClr val="00B2C9"/>
+                </a:solidFill>
+                <a:latin typeface="Encode Sans"/>
+              </a:rPr>
+              <a:t>●  </a:t>
+            </a:r>
+            <a:r>
+              <a:rPr sz="1300" b="0" i="0">
+                <a:solidFill>
+                  <a:srgbClr val="3F3F3F"/>
+                </a:solidFill>
+                <a:latin typeface="Encode Sans"/>
+              </a:rPr>
+              <a:t>Brecha vs IPC minorista: -1.2% pp (IPC +2.1%)</a:t>
+            </a:r>
+          </a:p>
+        </p:txBody>
+      </p:sp>
+      <p:pic>
+        <p:nvPicPr>
+          <p:cNvPr id="7" name="Picture 6" descr="image.png"/>
+          <p:cNvPicPr>
+            <a:picLocks noChangeAspect="1"/>
+          </p:cNvPicPr>
+          <p:nvPr/>
+        </p:nvPicPr>
+        <p:blipFill>
+          <a:blip r:embed="rId2"/>
+          <a:stretch>
+            <a:fillRect/>
+          </a:stretch>
+        </p:blipFill>
+        <p:spPr>
+          <a:xfrm>
+            <a:off x="6080760" y="1691640"/>
+            <a:ext cx="5669280" cy="2560320"/>
+          </a:xfrm>
+          <a:prstGeom prst="rect">
+            <a:avLst/>
+          </a:prstGeom>
+        </p:spPr>
+      </p:pic>
+      <p:graphicFrame>
+        <p:nvGraphicFramePr>
+          <p:cNvPr id="8" name="Table 7"/>
+          <p:cNvGraphicFramePr>
+            <a:graphicFrameLocks noGrp="1"/>
+          </p:cNvGraphicFramePr>
+          <p:nvPr/>
+        </p:nvGraphicFramePr>
+        <p:xfrm>
+          <a:off x="6080760" y="4434840"/>
+          <a:ext cx="5669280" cy="2048256"/>
+        </p:xfrm>
+        <a:graphic>
+          <a:graphicData uri="http://schemas.openxmlformats.org/drawingml/2006/table">
+            <a:tbl>
+              <a:tblPr firstRow="1" bandRow="1">
+                <a:tableStyleId>{5C22544A-7EE6-4342-B048-85BDC9FD1C3A}</a:tableStyleId>
+              </a:tblPr>
+              <a:tblGrid>
+                <a:gridCol w="1889760"/>
+                <a:gridCol w="1889760"/>
+                <a:gridCol w="1889760"/>
+              </a:tblGrid>
+              <a:tr h="292608">
+                <a:tc>
+                  <a:txBody>
+                    <a:bodyPr/>
+                    <a:lstStyle/>
+                    <a:p>
+                      <a:pPr algn="l"/>
+                      <a:r>
+                        <a:rPr sz="1000" b="1">
+                          <a:solidFill>
+                            <a:srgbClr val="FFFFFF"/>
+                          </a:solidFill>
+                          <a:latin typeface="Encode Sans"/>
+                        </a:rPr>
+                        <a:t>Mes</a:t>
+                      </a:r>
+                    </a:p>
+                  </a:txBody>
+                  <a:tcPr marL="36576" marR="36576" marT="18288" marB="18288">
+                    <a:solidFill>
+                      <a:srgbClr val="00B2C9"/>
+                    </a:solidFill>
+                  </a:tcPr>
+                </a:tc>
+                <a:tc>
+                  <a:txBody>
+                    <a:bodyPr/>
+                    <a:lstStyle/>
+                    <a:p>
+                      <a:pPr algn="r"/>
+                      <a:r>
+                        <a:rPr sz="1000" b="1">
+                          <a:solidFill>
+                            <a:srgbClr val="FFFFFF"/>
+                          </a:solidFill>
+                          <a:latin typeface="Encode Sans"/>
+                        </a:rPr>
+                        <a:t>VM %</a:t>
+                      </a:r>
+                    </a:p>
+                  </a:txBody>
+                  <a:tcPr marL="36576" marR="36576" marT="18288" marB="18288">
+                    <a:solidFill>
+                      <a:srgbClr val="00B2C9"/>
+                    </a:solidFill>
+                  </a:tcPr>
+                </a:tc>
+                <a:tc>
+                  <a:txBody>
+                    <a:bodyPr/>
+                    <a:lstStyle/>
+                    <a:p>
+                      <a:pPr algn="r"/>
+                      <a:r>
+                        <a:rPr sz="1000" b="1">
+                          <a:solidFill>
+                            <a:srgbClr val="FFFFFF"/>
+                          </a:solidFill>
+                          <a:latin typeface="Encode Sans"/>
+                        </a:rPr>
+                        <a:t>VIA %</a:t>
+                      </a:r>
+                    </a:p>
+                  </a:txBody>
+                  <a:tcPr marL="36576" marR="36576" marT="18288" marB="18288">
+                    <a:solidFill>
+                      <a:srgbClr val="00B2C9"/>
+                    </a:solidFill>
+                  </a:tcPr>
+                </a:tc>
+              </a:tr>
+              <a:tr h="292608">
+                <a:tc>
+                  <a:txBody>
+                    <a:bodyPr/>
+                    <a:lstStyle/>
+                    <a:p>
+                      <a:pPr algn="l"/>
+                      <a:r>
+                        <a:rPr sz="1000">
+                          <a:solidFill>
+                            <a:srgbClr val="3F3F3F"/>
+                          </a:solidFill>
+                          <a:latin typeface="Encode Sans"/>
+                        </a:rPr>
+                        <a:t>Julio 2026</a:t>
+                      </a:r>
+                    </a:p>
+                  </a:txBody>
+                  <a:tcPr marL="36576" marR="36576" marT="18288" marB="18288">
+                    <a:solidFill>
+                      <a:srgbClr val="FFFFFF"/>
+                    </a:solidFill>
+                  </a:tcPr>
+                </a:tc>
+                <a:tc>
+                  <a:txBody>
+                    <a:bodyPr/>
+                    <a:lstStyle/>
+                    <a:p>
+                      <a:pPr algn="r"/>
+                      <a:r>
+                        <a:rPr sz="1000">
+                          <a:solidFill>
+                            <a:srgbClr val="3F3F3F"/>
+                          </a:solidFill>
+                          <a:latin typeface="Encode Sans"/>
+                        </a:rPr>
+                        <a:t>+0.89%</a:t>
+                      </a:r>
+                    </a:p>
+                  </a:txBody>
+                  <a:tcPr marL="36576" marR="36576" marT="18288" marB="18288">
+                    <a:solidFill>
+                      <a:srgbClr val="FFFFFF"/>
+                    </a:solidFill>
+                  </a:tcPr>
+                </a:tc>
+                <a:tc>
+                  <a:txBody>
+                    <a:bodyPr/>
+                    <a:lstStyle/>
+                    <a:p>
+                      <a:pPr algn="r"/>
+                      <a:r>
+                        <a:rPr sz="1000">
+                          <a:solidFill>
+                            <a:srgbClr val="3F3F3F"/>
+                          </a:solidFill>
+                          <a:latin typeface="Encode Sans"/>
+                        </a:rPr>
+                        <a:t>+31.3%</a:t>
+                      </a:r>
+                    </a:p>
+                  </a:txBody>
+                  <a:tcPr marL="36576" marR="36576" marT="18288" marB="18288">
+                    <a:solidFill>
+                      <a:srgbClr val="FFFFFF"/>
+                    </a:solidFill>
+                  </a:tcPr>
+                </a:tc>
+              </a:tr>
+              <a:tr h="292608">
+                <a:tc>
+                  <a:txBody>
+                    <a:bodyPr/>
+                    <a:lstStyle/>
+                    <a:p>
+                      <a:pPr algn="l"/>
+                      <a:r>
+                        <a:rPr sz="1000">
+                          <a:solidFill>
+                            <a:srgbClr val="3F3F3F"/>
+                          </a:solidFill>
+                          <a:latin typeface="Encode Sans"/>
+                        </a:rPr>
+                        <a:t>Junio 2026</a:t>
+                      </a:r>
+                    </a:p>
+                  </a:txBody>
+                  <a:tcPr marL="36576" marR="36576" marT="18288" marB="18288">
+                    <a:solidFill>
+                      <a:srgbClr val="F8F8F6"/>
+                    </a:solidFill>
+                  </a:tcPr>
+                </a:tc>
+                <a:tc>
+                  <a:txBody>
+                    <a:bodyPr/>
+                    <a:lstStyle/>
+                    <a:p>
+                      <a:pPr algn="r"/>
+                      <a:r>
+                        <a:rPr sz="1000">
+                          <a:solidFill>
+                            <a:srgbClr val="3F3F3F"/>
+                          </a:solidFill>
+                          <a:latin typeface="Encode Sans"/>
+                        </a:rPr>
+                        <a:t>+1.06%</a:t>
+                      </a:r>
+                    </a:p>
+                  </a:txBody>
+                  <a:tcPr marL="36576" marR="36576" marT="18288" marB="18288">
+                    <a:solidFill>
+                      <a:srgbClr val="F8F8F6"/>
+                    </a:solidFill>
+                  </a:tcPr>
+                </a:tc>
+                <a:tc>
+                  <a:txBody>
+                    <a:bodyPr/>
+                    <a:lstStyle/>
+                    <a:p>
+                      <a:pPr algn="r"/>
+                      <a:r>
+                        <a:rPr sz="1000">
+                          <a:solidFill>
+                            <a:srgbClr val="3F3F3F"/>
+                          </a:solidFill>
+                          <a:latin typeface="Encode Sans"/>
+                        </a:rPr>
+                        <a:t>+34.0%</a:t>
+                      </a:r>
+                    </a:p>
+                  </a:txBody>
+                  <a:tcPr marL="36576" marR="36576" marT="18288" marB="18288">
+                    <a:solidFill>
+                      <a:srgbClr val="F8F8F6"/>
+                    </a:solidFill>
+                  </a:tcPr>
+                </a:tc>
+              </a:tr>
+              <a:tr h="292608">
+                <a:tc>
+                  <a:txBody>
+                    <a:bodyPr/>
+                    <a:lstStyle/>
+                    <a:p>
+                      <a:pPr algn="l"/>
+                      <a:r>
+                        <a:rPr sz="1000">
+                          <a:solidFill>
+                            <a:srgbClr val="3F3F3F"/>
+                          </a:solidFill>
+                          <a:latin typeface="Encode Sans"/>
+                        </a:rPr>
+                        <a:t>Mayo 2026</a:t>
+                      </a:r>
+                    </a:p>
+                  </a:txBody>
+                  <a:tcPr marL="36576" marR="36576" marT="18288" marB="18288">
+                    <a:solidFill>
+                      <a:srgbClr val="FFFFFF"/>
+                    </a:solidFill>
+                  </a:tcPr>
+                </a:tc>
+                <a:tc>
+                  <a:txBody>
+                    <a:bodyPr/>
+                    <a:lstStyle/>
+                    <a:p>
+                      <a:pPr algn="r"/>
+                      <a:r>
+                        <a:rPr sz="1000">
+                          <a:solidFill>
+                            <a:srgbClr val="3F3F3F"/>
+                          </a:solidFill>
+                          <a:latin typeface="Encode Sans"/>
+                        </a:rPr>
+                        <a:t>+2.67%</a:t>
+                      </a:r>
+                    </a:p>
+                  </a:txBody>
+                  <a:tcPr marL="36576" marR="36576" marT="18288" marB="18288">
+                    <a:solidFill>
+                      <a:srgbClr val="FFFFFF"/>
+                    </a:solidFill>
+                  </a:tcPr>
+                </a:tc>
+                <a:tc>
+                  <a:txBody>
+                    <a:bodyPr/>
+                    <a:lstStyle/>
+                    <a:p>
+                      <a:pPr algn="r"/>
+                      <a:r>
+                        <a:rPr sz="1000">
+                          <a:solidFill>
+                            <a:srgbClr val="3F3F3F"/>
+                          </a:solidFill>
+                          <a:latin typeface="Encode Sans"/>
+                        </a:rPr>
+                        <a:t>+34.6%</a:t>
+                      </a:r>
+                    </a:p>
+                  </a:txBody>
+                  <a:tcPr marL="36576" marR="36576" marT="18288" marB="18288">
+                    <a:solidFill>
+                      <a:srgbClr val="FFFFFF"/>
+                    </a:solidFill>
+                  </a:tcPr>
+                </a:tc>
+              </a:tr>
+              <a:tr h="292608">
+                <a:tc>
+                  <a:txBody>
+                    <a:bodyPr/>
+                    <a:lstStyle/>
+                    <a:p>
+                      <a:pPr algn="l"/>
+                      <a:r>
+                        <a:rPr sz="1000">
+                          <a:solidFill>
+                            <a:srgbClr val="3F3F3F"/>
+                          </a:solidFill>
+                          <a:latin typeface="Encode Sans"/>
+                        </a:rPr>
+                        <a:t>Abril 2026</a:t>
+                      </a:r>
+                    </a:p>
+                  </a:txBody>
+                  <a:tcPr marL="36576" marR="36576" marT="18288" marB="18288">
+                    <a:solidFill>
+                      <a:srgbClr val="F8F8F6"/>
+                    </a:solidFill>
+                  </a:tcPr>
+                </a:tc>
+                <a:tc>
+                  <a:txBody>
+                    <a:bodyPr/>
+                    <a:lstStyle/>
+                    <a:p>
+                      <a:pPr algn="r"/>
+                      <a:r>
+                        <a:rPr sz="1000">
+                          <a:solidFill>
+                            <a:srgbClr val="3F3F3F"/>
+                          </a:solidFill>
+                          <a:latin typeface="Encode Sans"/>
+                        </a:rPr>
+                        <a:t>+4.79%</a:t>
+                      </a:r>
+                    </a:p>
+                  </a:txBody>
+                  <a:tcPr marL="36576" marR="36576" marT="18288" marB="18288">
+                    <a:solidFill>
+                      <a:srgbClr val="F8F8F6"/>
+                    </a:solidFill>
+                  </a:tcPr>
+                </a:tc>
+                <a:tc>
+                  <a:txBody>
+                    <a:bodyPr/>
+                    <a:lstStyle/>
+                    <a:p>
+                      <a:pPr algn="r"/>
+                      <a:r>
+                        <a:rPr sz="1000">
+                          <a:solidFill>
+                            <a:srgbClr val="3F3F3F"/>
+                          </a:solidFill>
+                          <a:latin typeface="Encode Sans"/>
+                        </a:rPr>
+                        <a:t>+30.9%</a:t>
+                      </a:r>
+                    </a:p>
+                  </a:txBody>
+                  <a:tcPr marL="36576" marR="36576" marT="18288" marB="18288">
+                    <a:solidFill>
+                      <a:srgbClr val="F8F8F6"/>
+                    </a:solidFill>
+                  </a:tcPr>
+                </a:tc>
+              </a:tr>
+              <a:tr h="292608">
+                <a:tc>
+                  <a:txBody>
+                    <a:bodyPr/>
+                    <a:lstStyle/>
+                    <a:p>
+                      <a:pPr algn="l"/>
+                      <a:r>
+                        <a:rPr sz="1000">
+                          <a:solidFill>
+                            <a:srgbClr val="3F3F3F"/>
+                          </a:solidFill>
+                          <a:latin typeface="Encode Sans"/>
+                        </a:rPr>
+                        <a:t>Marzo 2026</a:t>
+                      </a:r>
+                    </a:p>
+                  </a:txBody>
+                  <a:tcPr marL="36576" marR="36576" marT="18288" marB="18288">
+                    <a:solidFill>
+                      <a:srgbClr val="FFFFFF"/>
+                    </a:solidFill>
+                  </a:tcPr>
+                </a:tc>
+                <a:tc>
+                  <a:txBody>
+                    <a:bodyPr/>
+                    <a:lstStyle/>
+                    <a:p>
+                      <a:pPr algn="r"/>
+                      <a:r>
+                        <a:rPr sz="1000">
+                          <a:solidFill>
+                            <a:srgbClr val="3F3F3F"/>
+                          </a:solidFill>
+                          <a:latin typeface="Encode Sans"/>
+                        </a:rPr>
+                        <a:t>+2.95%</a:t>
+                      </a:r>
+                    </a:p>
+                  </a:txBody>
+                  <a:tcPr marL="36576" marR="36576" marT="18288" marB="18288">
+                    <a:solidFill>
+                      <a:srgbClr val="FFFFFF"/>
+                    </a:solidFill>
+                  </a:tcPr>
+                </a:tc>
+                <a:tc>
+                  <a:txBody>
+                    <a:bodyPr/>
+                    <a:lstStyle/>
+                    <a:p>
+                      <a:pPr algn="r"/>
+                      <a:r>
+                        <a:rPr sz="1000">
+                          <a:solidFill>
+                            <a:srgbClr val="3F3F3F"/>
+                          </a:solidFill>
+                          <a:latin typeface="Encode Sans"/>
+                        </a:rPr>
+                        <a:t>+28.1%</a:t>
+                      </a:r>
+                    </a:p>
+                  </a:txBody>
+                  <a:tcPr marL="36576" marR="36576" marT="18288" marB="18288">
+                    <a:solidFill>
+                      <a:srgbClr val="FFFFFF"/>
+                    </a:solidFill>
+                  </a:tcPr>
+                </a:tc>
+              </a:tr>
+              <a:tr h="292608">
+                <a:tc>
+                  <a:txBody>
+                    <a:bodyPr/>
+                    <a:lstStyle/>
+                    <a:p>
+                      <a:pPr algn="l"/>
+                      <a:r>
+                        <a:rPr sz="1000">
+                          <a:solidFill>
+                            <a:srgbClr val="3F3F3F"/>
+                          </a:solidFill>
+                          <a:latin typeface="Encode Sans"/>
+                        </a:rPr>
+                        <a:t>Febrero 2026</a:t>
+                      </a:r>
+                    </a:p>
+                  </a:txBody>
+                  <a:tcPr marL="36576" marR="36576" marT="18288" marB="18288">
+                    <a:solidFill>
+                      <a:srgbClr val="F8F8F6"/>
+                    </a:solidFill>
+                  </a:tcPr>
+                </a:tc>
+                <a:tc>
+                  <a:txBody>
+                    <a:bodyPr/>
+                    <a:lstStyle/>
+                    <a:p>
+                      <a:pPr algn="r"/>
+                      <a:r>
+                        <a:rPr sz="1000">
+                          <a:solidFill>
+                            <a:srgbClr val="3F3F3F"/>
+                          </a:solidFill>
+                          <a:latin typeface="Encode Sans"/>
+                        </a:rPr>
+                        <a:t>+0.69%</a:t>
+                      </a:r>
+                    </a:p>
+                  </a:txBody>
+                  <a:tcPr marL="36576" marR="36576" marT="18288" marB="18288">
+                    <a:solidFill>
+                      <a:srgbClr val="F8F8F6"/>
+                    </a:solidFill>
+                  </a:tcPr>
+                </a:tc>
+                <a:tc>
+                  <a:txBody>
+                    <a:bodyPr/>
+                    <a:lstStyle/>
+                    <a:p>
+                      <a:pPr algn="r"/>
+                      <a:r>
+                        <a:rPr sz="1000">
+                          <a:solidFill>
+                            <a:srgbClr val="3F3F3F"/>
+                          </a:solidFill>
+                          <a:latin typeface="Encode Sans"/>
+                        </a:rPr>
+                        <a:t>+26.0%</a:t>
                       </a:r>
                     </a:p>
                   </a:txBody>

</xml_diff>

<commit_message>
data: update 2026-08-20 ( data.json despidos.json scraper/historical_despidos.json publicaciones_semana.pptx rrii_brutas.xlsx)
</commit_message>
<xml_diff>
--- a/publicaciones_semana.pptx
+++ b/publicaciones_semana.pptx
@@ -10,6 +10,8 @@
     <p:sldId id="258" r:id="rId9"/>
     <p:sldId id="259" r:id="rId10"/>
     <p:sldId id="260" r:id="rId11"/>
+    <p:sldId id="261" r:id="rId12"/>
+    <p:sldId id="262" r:id="rId13"/>
   </p:sldIdLst>
   <p:sldSz cx="12191695" cy="6858000" type="screen4x3"/>
   <p:notesSz cx="6858000" cy="9144000"/>
@@ -3275,7 +3277,7 @@
                 </a:solidFill>
                 <a:latin typeface="Encode Sans"/>
               </a:rPr>
-              <a:t>4 publicaciones · datos oficiales INDEC / BCRA / Hacienda</a:t>
+              <a:t>6 publicaciones · datos oficiales INDEC / BCRA / Hacienda</a:t>
             </a:r>
           </a:p>
         </p:txBody>
@@ -6612,6 +6614,2045 @@
                           <a:latin typeface="Encode Sans"/>
                         </a:rPr>
                         <a:t>+26.0%</a:t>
+                      </a:r>
+                    </a:p>
+                  </a:txBody>
+                  <a:tcPr marL="36576" marR="36576" marT="18288" marB="18288">
+                    <a:solidFill>
+                      <a:srgbClr val="F8F8F6"/>
+                    </a:solidFill>
+                  </a:tcPr>
+                </a:tc>
+              </a:tr>
+            </a:tbl>
+          </a:graphicData>
+        </a:graphic>
+      </p:graphicFrame>
+      <p:sp>
+        <p:nvSpPr>
+          <p:cNvPr id="9" name="TextBox 8"/>
+          <p:cNvSpPr txBox="1"/>
+          <p:nvPr/>
+        </p:nvSpPr>
+        <p:spPr>
+          <a:xfrm>
+            <a:off x="411480" y="6492240"/>
+            <a:ext cx="11368735" cy="274320"/>
+          </a:xfrm>
+          <a:prstGeom prst="rect">
+            <a:avLst/>
+          </a:prstGeom>
+          <a:noFill/>
+        </p:spPr>
+        <p:txBody>
+          <a:bodyPr wrap="none">
+            <a:spAutoFit/>
+          </a:bodyPr>
+          <a:lstStyle/>
+          <a:p>
+            <a:r>
+              <a:rPr sz="1000" b="0" i="1">
+                <a:solidFill>
+                  <a:srgbClr val="6A6760"/>
+                </a:solidFill>
+                <a:latin typeface="Encode Sans"/>
+              </a:rPr>
+              <a:t>Fuente: elaboración propia en base a INDEC</a:t>
+            </a:r>
+          </a:p>
+        </p:txBody>
+      </p:sp>
+    </p:spTree>
+  </p:cSld>
+  <p:clrMapOvr>
+    <a:masterClrMapping/>
+  </p:clrMapOvr>
+</p:sld>
+</file>
+
+<file path=ppt/slides/slide6.xml><?xml version="1.0" encoding="utf-8"?>
+<p:sld xmlns:a="http://schemas.openxmlformats.org/drawingml/2006/main" xmlns:p="http://schemas.openxmlformats.org/presentationml/2006/main" xmlns:r="http://schemas.openxmlformats.org/officeDocument/2006/relationships">
+  <p:cSld>
+    <p:spTree>
+      <p:nvGrpSpPr>
+        <p:cNvPr id="1" name=""/>
+        <p:cNvGrpSpPr/>
+        <p:nvPr/>
+      </p:nvGrpSpPr>
+      <p:grpSpPr/>
+      <p:sp>
+        <p:nvSpPr>
+          <p:cNvPr id="2" name="Rectangle 1"/>
+          <p:cNvSpPr/>
+          <p:nvPr/>
+        </p:nvSpPr>
+        <p:spPr>
+          <a:xfrm>
+            <a:off x="0" y="0"/>
+            <a:ext cx="12191695" cy="274320"/>
+          </a:xfrm>
+          <a:prstGeom prst="rect">
+            <a:avLst/>
+          </a:prstGeom>
+          <a:solidFill>
+            <a:srgbClr val="00B2C9"/>
+          </a:solidFill>
+          <a:ln>
+            <a:noFill/>
+          </a:ln>
+        </p:spPr>
+        <p:style>
+          <a:lnRef idx="1">
+            <a:schemeClr val="accent1"/>
+          </a:lnRef>
+          <a:fillRef idx="3">
+            <a:schemeClr val="accent1"/>
+          </a:fillRef>
+          <a:effectRef idx="2">
+            <a:schemeClr val="accent1"/>
+          </a:effectRef>
+          <a:fontRef idx="minor">
+            <a:schemeClr val="lt1"/>
+          </a:fontRef>
+        </p:style>
+        <p:txBody>
+          <a:bodyPr rtlCol="0" anchor="ctr"/>
+          <a:lstStyle/>
+          <a:p>
+            <a:pPr algn="ctr"/>
+          </a:p>
+        </p:txBody>
+      </p:sp>
+      <p:sp>
+        <p:nvSpPr>
+          <p:cNvPr id="3" name="TextBox 2"/>
+          <p:cNvSpPr txBox="1"/>
+          <p:nvPr/>
+        </p:nvSpPr>
+        <p:spPr>
+          <a:xfrm>
+            <a:off x="411480" y="457200"/>
+            <a:ext cx="11368735" cy="914400"/>
+          </a:xfrm>
+          <a:prstGeom prst="rect">
+            <a:avLst/>
+          </a:prstGeom>
+          <a:noFill/>
+        </p:spPr>
+        <p:txBody>
+          <a:bodyPr wrap="square" lIns="0" rIns="0">
+            <a:spAutoFit/>
+          </a:bodyPr>
+          <a:lstStyle/>
+          <a:p>
+            <a:pPr algn="l"/>
+            <a:r>
+              <a:rPr sz="2600" b="1" i="0">
+                <a:solidFill>
+                  <a:srgbClr val="00B2C9"/>
+                </a:solidFill>
+                <a:latin typeface="Encode Sans"/>
+              </a:rPr>
+              <a:t>EMAE JUNIO 2026: ACTIVIDAD CRECIÓ +2.7% I.A.</a:t>
+            </a:r>
+          </a:p>
+        </p:txBody>
+      </p:sp>
+      <p:sp>
+        <p:nvSpPr>
+          <p:cNvPr id="4" name="TextBox 3"/>
+          <p:cNvSpPr txBox="1"/>
+          <p:nvPr/>
+        </p:nvSpPr>
+        <p:spPr>
+          <a:xfrm>
+            <a:off x="411480" y="1280160"/>
+            <a:ext cx="11368735" cy="274320"/>
+          </a:xfrm>
+          <a:prstGeom prst="rect">
+            <a:avLst/>
+          </a:prstGeom>
+          <a:noFill/>
+        </p:spPr>
+        <p:txBody>
+          <a:bodyPr wrap="none">
+            <a:spAutoFit/>
+          </a:bodyPr>
+          <a:lstStyle/>
+          <a:p>
+            <a:r>
+              <a:rPr sz="1100" b="0" i="1">
+                <a:solidFill>
+                  <a:srgbClr val="6A6760"/>
+                </a:solidFill>
+                <a:latin typeface="Encode Sans"/>
+              </a:rPr>
+              <a:t>INDEC · período 2026-06</a:t>
+            </a:r>
+          </a:p>
+        </p:txBody>
+      </p:sp>
+      <p:sp>
+        <p:nvSpPr>
+          <p:cNvPr id="5" name="TextBox 4"/>
+          <p:cNvSpPr txBox="1"/>
+          <p:nvPr/>
+        </p:nvSpPr>
+        <p:spPr>
+          <a:xfrm>
+            <a:off x="411480" y="1691640"/>
+            <a:ext cx="5486400" cy="1645920"/>
+          </a:xfrm>
+          <a:prstGeom prst="rect">
+            <a:avLst/>
+          </a:prstGeom>
+          <a:noFill/>
+        </p:spPr>
+        <p:txBody>
+          <a:bodyPr wrap="square" lIns="0" rIns="0">
+            <a:spAutoFit/>
+          </a:bodyPr>
+          <a:lstStyle/>
+          <a:p>
+            <a:pPr algn="just"/>
+            <a:r>
+              <a:rPr sz="1300" b="0" i="0">
+                <a:solidFill>
+                  <a:srgbClr val="3F3F3F"/>
+                </a:solidFill>
+                <a:latin typeface="Encode Sans"/>
+              </a:rPr>
+              <a:t>El Estimador Mensual de Actividad Económica (EMAE) registró una variación interanual de +2.7% en junio 2026. En la medición desestacionalizada, el indicador se movió +0.8% respecto al mes anterior.</a:t>
+            </a:r>
+          </a:p>
+        </p:txBody>
+      </p:sp>
+      <p:sp>
+        <p:nvSpPr>
+          <p:cNvPr id="6" name="TextBox 5"/>
+          <p:cNvSpPr txBox="1"/>
+          <p:nvPr/>
+        </p:nvSpPr>
+        <p:spPr>
+          <a:xfrm>
+            <a:off x="411480" y="3520440"/>
+            <a:ext cx="5486400" cy="2743200"/>
+          </a:xfrm>
+          <a:prstGeom prst="rect">
+            <a:avLst/>
+          </a:prstGeom>
+          <a:noFill/>
+        </p:spPr>
+        <p:txBody>
+          <a:bodyPr wrap="square" lIns="0" rIns="0">
+            <a:spAutoFit/>
+          </a:bodyPr>
+          <a:lstStyle/>
+          <a:p>
+            <a:pPr algn="l">
+              <a:spcAft>
+                <a:spcPts val="800"/>
+              </a:spcAft>
+            </a:pPr>
+            <a:r>
+              <a:rPr sz="1300" b="1" i="0">
+                <a:solidFill>
+                  <a:srgbClr val="00B2C9"/>
+                </a:solidFill>
+                <a:latin typeface="Encode Sans"/>
+              </a:rPr>
+              <a:t>●  </a:t>
+            </a:r>
+            <a:r>
+              <a:rPr sz="1300" b="0" i="0">
+                <a:solidFill>
+                  <a:srgbClr val="3F3F3F"/>
+                </a:solidFill>
+                <a:latin typeface="Encode Sans"/>
+              </a:rPr>
+              <a:t>Variación interanual: +2.7%</a:t>
+            </a:r>
+          </a:p>
+          <a:p>
+            <a:pPr algn="l">
+              <a:spcAft>
+                <a:spcPts val="800"/>
+              </a:spcAft>
+            </a:pPr>
+            <a:r>
+              <a:rPr sz="1300" b="1" i="0">
+                <a:solidFill>
+                  <a:srgbClr val="00B2C9"/>
+                </a:solidFill>
+                <a:latin typeface="Encode Sans"/>
+              </a:rPr>
+              <a:t>●  </a:t>
+            </a:r>
+            <a:r>
+              <a:rPr sz="1300" b="0" i="0">
+                <a:solidFill>
+                  <a:srgbClr val="3F3F3F"/>
+                </a:solidFill>
+                <a:latin typeface="Encode Sans"/>
+              </a:rPr>
+              <a:t>Variación mensual desestacionalizada: +0.8%</a:t>
+            </a:r>
+          </a:p>
+          <a:p>
+            <a:pPr algn="l">
+              <a:spcAft>
+                <a:spcPts val="800"/>
+              </a:spcAft>
+            </a:pPr>
+            <a:r>
+              <a:rPr sz="1300" b="1" i="0">
+                <a:solidFill>
+                  <a:srgbClr val="00B2C9"/>
+                </a:solidFill>
+                <a:latin typeface="Encode Sans"/>
+              </a:rPr>
+              <a:t>●  </a:t>
+            </a:r>
+            <a:r>
+              <a:rPr sz="1300" b="0" i="0">
+                <a:solidFill>
+                  <a:srgbClr val="3F3F3F"/>
+                </a:solidFill>
+                <a:latin typeface="Encode Sans"/>
+              </a:rPr>
+              <a:t>Serie INDEC, base 2004=100. Mide el nivel general de actividad.</a:t>
+            </a:r>
+          </a:p>
+        </p:txBody>
+      </p:sp>
+      <p:pic>
+        <p:nvPicPr>
+          <p:cNvPr id="7" name="Picture 6" descr="image.png"/>
+          <p:cNvPicPr>
+            <a:picLocks noChangeAspect="1"/>
+          </p:cNvPicPr>
+          <p:nvPr/>
+        </p:nvPicPr>
+        <p:blipFill>
+          <a:blip r:embed="rId2"/>
+          <a:stretch>
+            <a:fillRect/>
+          </a:stretch>
+        </p:blipFill>
+        <p:spPr>
+          <a:xfrm>
+            <a:off x="6080760" y="1691640"/>
+            <a:ext cx="5669280" cy="2560320"/>
+          </a:xfrm>
+          <a:prstGeom prst="rect">
+            <a:avLst/>
+          </a:prstGeom>
+        </p:spPr>
+      </p:pic>
+      <p:graphicFrame>
+        <p:nvGraphicFramePr>
+          <p:cNvPr id="8" name="Table 7"/>
+          <p:cNvGraphicFramePr>
+            <a:graphicFrameLocks noGrp="1"/>
+          </p:cNvGraphicFramePr>
+          <p:nvPr/>
+        </p:nvGraphicFramePr>
+        <p:xfrm>
+          <a:off x="6080760" y="4434840"/>
+          <a:ext cx="5669280" cy="2048256"/>
+        </p:xfrm>
+        <a:graphic>
+          <a:graphicData uri="http://schemas.openxmlformats.org/drawingml/2006/table">
+            <a:tbl>
+              <a:tblPr firstRow="1" bandRow="1">
+                <a:tableStyleId>{5C22544A-7EE6-4342-B048-85BDC9FD1C3A}</a:tableStyleId>
+              </a:tblPr>
+              <a:tblGrid>
+                <a:gridCol w="1417320"/>
+                <a:gridCol w="1417320"/>
+                <a:gridCol w="1417320"/>
+                <a:gridCol w="1417320"/>
+              </a:tblGrid>
+              <a:tr h="292608">
+                <a:tc>
+                  <a:txBody>
+                    <a:bodyPr/>
+                    <a:lstStyle/>
+                    <a:p>
+                      <a:pPr algn="l"/>
+                      <a:r>
+                        <a:rPr sz="1000" b="1">
+                          <a:solidFill>
+                            <a:srgbClr val="FFFFFF"/>
+                          </a:solidFill>
+                          <a:latin typeface="Encode Sans"/>
+                        </a:rPr>
+                        <a:t>Mes</a:t>
+                      </a:r>
+                    </a:p>
+                  </a:txBody>
+                  <a:tcPr marL="36576" marR="36576" marT="18288" marB="18288">
+                    <a:solidFill>
+                      <a:srgbClr val="00B2C9"/>
+                    </a:solidFill>
+                  </a:tcPr>
+                </a:tc>
+                <a:tc>
+                  <a:txBody>
+                    <a:bodyPr/>
+                    <a:lstStyle/>
+                    <a:p>
+                      <a:pPr algn="r"/>
+                      <a:r>
+                        <a:rPr sz="1000" b="1">
+                          <a:solidFill>
+                            <a:srgbClr val="FFFFFF"/>
+                          </a:solidFill>
+                          <a:latin typeface="Encode Sans"/>
+                        </a:rPr>
+                        <a:t>Original</a:t>
+                      </a:r>
+                    </a:p>
+                  </a:txBody>
+                  <a:tcPr marL="36576" marR="36576" marT="18288" marB="18288">
+                    <a:solidFill>
+                      <a:srgbClr val="00B2C9"/>
+                    </a:solidFill>
+                  </a:tcPr>
+                </a:tc>
+                <a:tc>
+                  <a:txBody>
+                    <a:bodyPr/>
+                    <a:lstStyle/>
+                    <a:p>
+                      <a:pPr algn="r"/>
+                      <a:r>
+                        <a:rPr sz="1000" b="1">
+                          <a:solidFill>
+                            <a:srgbClr val="FFFFFF"/>
+                          </a:solidFill>
+                          <a:latin typeface="Encode Sans"/>
+                        </a:rPr>
+                        <a:t>VIA %</a:t>
+                      </a:r>
+                    </a:p>
+                  </a:txBody>
+                  <a:tcPr marL="36576" marR="36576" marT="18288" marB="18288">
+                    <a:solidFill>
+                      <a:srgbClr val="00B2C9"/>
+                    </a:solidFill>
+                  </a:tcPr>
+                </a:tc>
+                <a:tc>
+                  <a:txBody>
+                    <a:bodyPr/>
+                    <a:lstStyle/>
+                    <a:p>
+                      <a:pPr algn="r"/>
+                      <a:r>
+                        <a:rPr sz="1000" b="1">
+                          <a:solidFill>
+                            <a:srgbClr val="FFFFFF"/>
+                          </a:solidFill>
+                          <a:latin typeface="Encode Sans"/>
+                        </a:rPr>
+                        <a:t>Desest.</a:t>
+                      </a:r>
+                    </a:p>
+                  </a:txBody>
+                  <a:tcPr marL="36576" marR="36576" marT="18288" marB="18288">
+                    <a:solidFill>
+                      <a:srgbClr val="00B2C9"/>
+                    </a:solidFill>
+                  </a:tcPr>
+                </a:tc>
+              </a:tr>
+              <a:tr h="292608">
+                <a:tc>
+                  <a:txBody>
+                    <a:bodyPr/>
+                    <a:lstStyle/>
+                    <a:p>
+                      <a:pPr algn="l"/>
+                      <a:r>
+                        <a:rPr sz="1000">
+                          <a:solidFill>
+                            <a:srgbClr val="3F3F3F"/>
+                          </a:solidFill>
+                          <a:latin typeface="Encode Sans"/>
+                        </a:rPr>
+                        <a:t>Junio 2026</a:t>
+                      </a:r>
+                    </a:p>
+                  </a:txBody>
+                  <a:tcPr marL="36576" marR="36576" marT="18288" marB="18288">
+                    <a:solidFill>
+                      <a:srgbClr val="FFFFFF"/>
+                    </a:solidFill>
+                  </a:tcPr>
+                </a:tc>
+                <a:tc>
+                  <a:txBody>
+                    <a:bodyPr/>
+                    <a:lstStyle/>
+                    <a:p>
+                      <a:pPr algn="r"/>
+                      <a:r>
+                        <a:rPr sz="1000">
+                          <a:solidFill>
+                            <a:srgbClr val="3F3F3F"/>
+                          </a:solidFill>
+                          <a:latin typeface="Encode Sans"/>
+                        </a:rPr>
+                        <a:t>161,0</a:t>
+                      </a:r>
+                    </a:p>
+                  </a:txBody>
+                  <a:tcPr marL="36576" marR="36576" marT="18288" marB="18288">
+                    <a:solidFill>
+                      <a:srgbClr val="FFFFFF"/>
+                    </a:solidFill>
+                  </a:tcPr>
+                </a:tc>
+                <a:tc>
+                  <a:txBody>
+                    <a:bodyPr/>
+                    <a:lstStyle/>
+                    <a:p>
+                      <a:pPr algn="r"/>
+                      <a:r>
+                        <a:rPr sz="1000">
+                          <a:solidFill>
+                            <a:srgbClr val="3F3F3F"/>
+                          </a:solidFill>
+                          <a:latin typeface="Encode Sans"/>
+                        </a:rPr>
+                        <a:t>+2.7%</a:t>
+                      </a:r>
+                    </a:p>
+                  </a:txBody>
+                  <a:tcPr marL="36576" marR="36576" marT="18288" marB="18288">
+                    <a:solidFill>
+                      <a:srgbClr val="FFFFFF"/>
+                    </a:solidFill>
+                  </a:tcPr>
+                </a:tc>
+                <a:tc>
+                  <a:txBody>
+                    <a:bodyPr/>
+                    <a:lstStyle/>
+                    <a:p>
+                      <a:pPr algn="r"/>
+                      <a:r>
+                        <a:rPr sz="1000">
+                          <a:solidFill>
+                            <a:srgbClr val="3F3F3F"/>
+                          </a:solidFill>
+                          <a:latin typeface="Encode Sans"/>
+                        </a:rPr>
+                        <a:t>154,1</a:t>
+                      </a:r>
+                    </a:p>
+                  </a:txBody>
+                  <a:tcPr marL="36576" marR="36576" marT="18288" marB="18288">
+                    <a:solidFill>
+                      <a:srgbClr val="FFFFFF"/>
+                    </a:solidFill>
+                  </a:tcPr>
+                </a:tc>
+              </a:tr>
+              <a:tr h="292608">
+                <a:tc>
+                  <a:txBody>
+                    <a:bodyPr/>
+                    <a:lstStyle/>
+                    <a:p>
+                      <a:pPr algn="l"/>
+                      <a:r>
+                        <a:rPr sz="1000">
+                          <a:solidFill>
+                            <a:srgbClr val="3F3F3F"/>
+                          </a:solidFill>
+                          <a:latin typeface="Encode Sans"/>
+                        </a:rPr>
+                        <a:t>Mayo 2026</a:t>
+                      </a:r>
+                    </a:p>
+                  </a:txBody>
+                  <a:tcPr marL="36576" marR="36576" marT="18288" marB="18288">
+                    <a:solidFill>
+                      <a:srgbClr val="F8F8F6"/>
+                    </a:solidFill>
+                  </a:tcPr>
+                </a:tc>
+                <a:tc>
+                  <a:txBody>
+                    <a:bodyPr/>
+                    <a:lstStyle/>
+                    <a:p>
+                      <a:pPr algn="r"/>
+                      <a:r>
+                        <a:rPr sz="1000">
+                          <a:solidFill>
+                            <a:srgbClr val="3F3F3F"/>
+                          </a:solidFill>
+                          <a:latin typeface="Encode Sans"/>
+                        </a:rPr>
+                        <a:t>165,7</a:t>
+                      </a:r>
+                    </a:p>
+                  </a:txBody>
+                  <a:tcPr marL="36576" marR="36576" marT="18288" marB="18288">
+                    <a:solidFill>
+                      <a:srgbClr val="F8F8F6"/>
+                    </a:solidFill>
+                  </a:tcPr>
+                </a:tc>
+                <a:tc>
+                  <a:txBody>
+                    <a:bodyPr/>
+                    <a:lstStyle/>
+                    <a:p>
+                      <a:pPr algn="r"/>
+                      <a:r>
+                        <a:rPr sz="1000">
+                          <a:solidFill>
+                            <a:srgbClr val="3F3F3F"/>
+                          </a:solidFill>
+                          <a:latin typeface="Encode Sans"/>
+                        </a:rPr>
+                        <a:t>+0.4%</a:t>
+                      </a:r>
+                    </a:p>
+                  </a:txBody>
+                  <a:tcPr marL="36576" marR="36576" marT="18288" marB="18288">
+                    <a:solidFill>
+                      <a:srgbClr val="F8F8F6"/>
+                    </a:solidFill>
+                  </a:tcPr>
+                </a:tc>
+                <a:tc>
+                  <a:txBody>
+                    <a:bodyPr/>
+                    <a:lstStyle/>
+                    <a:p>
+                      <a:pPr algn="r"/>
+                      <a:r>
+                        <a:rPr sz="1000">
+                          <a:solidFill>
+                            <a:srgbClr val="3F3F3F"/>
+                          </a:solidFill>
+                          <a:latin typeface="Encode Sans"/>
+                        </a:rPr>
+                        <a:t>153,0</a:t>
+                      </a:r>
+                    </a:p>
+                  </a:txBody>
+                  <a:tcPr marL="36576" marR="36576" marT="18288" marB="18288">
+                    <a:solidFill>
+                      <a:srgbClr val="F8F8F6"/>
+                    </a:solidFill>
+                  </a:tcPr>
+                </a:tc>
+              </a:tr>
+              <a:tr h="292608">
+                <a:tc>
+                  <a:txBody>
+                    <a:bodyPr/>
+                    <a:lstStyle/>
+                    <a:p>
+                      <a:pPr algn="l"/>
+                      <a:r>
+                        <a:rPr sz="1000">
+                          <a:solidFill>
+                            <a:srgbClr val="3F3F3F"/>
+                          </a:solidFill>
+                          <a:latin typeface="Encode Sans"/>
+                        </a:rPr>
+                        <a:t>Abril 2026</a:t>
+                      </a:r>
+                    </a:p>
+                  </a:txBody>
+                  <a:tcPr marL="36576" marR="36576" marT="18288" marB="18288">
+                    <a:solidFill>
+                      <a:srgbClr val="FFFFFF"/>
+                    </a:solidFill>
+                  </a:tcPr>
+                </a:tc>
+                <a:tc>
+                  <a:txBody>
+                    <a:bodyPr/>
+                    <a:lstStyle/>
+                    <a:p>
+                      <a:pPr algn="r"/>
+                      <a:r>
+                        <a:rPr sz="1000">
+                          <a:solidFill>
+                            <a:srgbClr val="3F3F3F"/>
+                          </a:solidFill>
+                          <a:latin typeface="Encode Sans"/>
+                        </a:rPr>
+                        <a:t>161,7</a:t>
+                      </a:r>
+                    </a:p>
+                  </a:txBody>
+                  <a:tcPr marL="36576" marR="36576" marT="18288" marB="18288">
+                    <a:solidFill>
+                      <a:srgbClr val="FFFFFF"/>
+                    </a:solidFill>
+                  </a:tcPr>
+                </a:tc>
+                <a:tc>
+                  <a:txBody>
+                    <a:bodyPr/>
+                    <a:lstStyle/>
+                    <a:p>
+                      <a:pPr algn="r"/>
+                      <a:r>
+                        <a:rPr sz="1000">
+                          <a:solidFill>
+                            <a:srgbClr val="3F3F3F"/>
+                          </a:solidFill>
+                          <a:latin typeface="Encode Sans"/>
+                        </a:rPr>
+                        <a:t>+1.8%</a:t>
+                      </a:r>
+                    </a:p>
+                  </a:txBody>
+                  <a:tcPr marL="36576" marR="36576" marT="18288" marB="18288">
+                    <a:solidFill>
+                      <a:srgbClr val="FFFFFF"/>
+                    </a:solidFill>
+                  </a:tcPr>
+                </a:tc>
+                <a:tc>
+                  <a:txBody>
+                    <a:bodyPr/>
+                    <a:lstStyle/>
+                    <a:p>
+                      <a:pPr algn="r"/>
+                      <a:r>
+                        <a:rPr sz="1000">
+                          <a:solidFill>
+                            <a:srgbClr val="3F3F3F"/>
+                          </a:solidFill>
+                          <a:latin typeface="Encode Sans"/>
+                        </a:rPr>
+                        <a:t>153,9</a:t>
+                      </a:r>
+                    </a:p>
+                  </a:txBody>
+                  <a:tcPr marL="36576" marR="36576" marT="18288" marB="18288">
+                    <a:solidFill>
+                      <a:srgbClr val="FFFFFF"/>
+                    </a:solidFill>
+                  </a:tcPr>
+                </a:tc>
+              </a:tr>
+              <a:tr h="292608">
+                <a:tc>
+                  <a:txBody>
+                    <a:bodyPr/>
+                    <a:lstStyle/>
+                    <a:p>
+                      <a:pPr algn="l"/>
+                      <a:r>
+                        <a:rPr sz="1000">
+                          <a:solidFill>
+                            <a:srgbClr val="3F3F3F"/>
+                          </a:solidFill>
+                          <a:latin typeface="Encode Sans"/>
+                        </a:rPr>
+                        <a:t>Marzo 2026</a:t>
+                      </a:r>
+                    </a:p>
+                  </a:txBody>
+                  <a:tcPr marL="36576" marR="36576" marT="18288" marB="18288">
+                    <a:solidFill>
+                      <a:srgbClr val="F8F8F6"/>
+                    </a:solidFill>
+                  </a:tcPr>
+                </a:tc>
+                <a:tc>
+                  <a:txBody>
+                    <a:bodyPr/>
+                    <a:lstStyle/>
+                    <a:p>
+                      <a:pPr algn="r"/>
+                      <a:r>
+                        <a:rPr sz="1000">
+                          <a:solidFill>
+                            <a:srgbClr val="3F3F3F"/>
+                          </a:solidFill>
+                          <a:latin typeface="Encode Sans"/>
+                        </a:rPr>
+                        <a:t>159,9</a:t>
+                      </a:r>
+                    </a:p>
+                  </a:txBody>
+                  <a:tcPr marL="36576" marR="36576" marT="18288" marB="18288">
+                    <a:solidFill>
+                      <a:srgbClr val="F8F8F6"/>
+                    </a:solidFill>
+                  </a:tcPr>
+                </a:tc>
+                <a:tc>
+                  <a:txBody>
+                    <a:bodyPr/>
+                    <a:lstStyle/>
+                    <a:p>
+                      <a:pPr algn="r"/>
+                      <a:r>
+                        <a:rPr sz="1000">
+                          <a:solidFill>
+                            <a:srgbClr val="3F3F3F"/>
+                          </a:solidFill>
+                          <a:latin typeface="Encode Sans"/>
+                        </a:rPr>
+                        <a:t>+6.2%</a:t>
+                      </a:r>
+                    </a:p>
+                  </a:txBody>
+                  <a:tcPr marL="36576" marR="36576" marT="18288" marB="18288">
+                    <a:solidFill>
+                      <a:srgbClr val="F8F8F6"/>
+                    </a:solidFill>
+                  </a:tcPr>
+                </a:tc>
+                <a:tc>
+                  <a:txBody>
+                    <a:bodyPr/>
+                    <a:lstStyle/>
+                    <a:p>
+                      <a:pPr algn="r"/>
+                      <a:r>
+                        <a:rPr sz="1000">
+                          <a:solidFill>
+                            <a:srgbClr val="3F3F3F"/>
+                          </a:solidFill>
+                          <a:latin typeface="Encode Sans"/>
+                        </a:rPr>
+                        <a:t>156,5</a:t>
+                      </a:r>
+                    </a:p>
+                  </a:txBody>
+                  <a:tcPr marL="36576" marR="36576" marT="18288" marB="18288">
+                    <a:solidFill>
+                      <a:srgbClr val="F8F8F6"/>
+                    </a:solidFill>
+                  </a:tcPr>
+                </a:tc>
+              </a:tr>
+              <a:tr h="292608">
+                <a:tc>
+                  <a:txBody>
+                    <a:bodyPr/>
+                    <a:lstStyle/>
+                    <a:p>
+                      <a:pPr algn="l"/>
+                      <a:r>
+                        <a:rPr sz="1000">
+                          <a:solidFill>
+                            <a:srgbClr val="3F3F3F"/>
+                          </a:solidFill>
+                          <a:latin typeface="Encode Sans"/>
+                        </a:rPr>
+                        <a:t>Febrero 2026</a:t>
+                      </a:r>
+                    </a:p>
+                  </a:txBody>
+                  <a:tcPr marL="36576" marR="36576" marT="18288" marB="18288">
+                    <a:solidFill>
+                      <a:srgbClr val="FFFFFF"/>
+                    </a:solidFill>
+                  </a:tcPr>
+                </a:tc>
+                <a:tc>
+                  <a:txBody>
+                    <a:bodyPr/>
+                    <a:lstStyle/>
+                    <a:p>
+                      <a:pPr algn="r"/>
+                      <a:r>
+                        <a:rPr sz="1000">
+                          <a:solidFill>
+                            <a:srgbClr val="3F3F3F"/>
+                          </a:solidFill>
+                          <a:latin typeface="Encode Sans"/>
+                        </a:rPr>
+                        <a:t>139,3</a:t>
+                      </a:r>
+                    </a:p>
+                  </a:txBody>
+                  <a:tcPr marL="36576" marR="36576" marT="18288" marB="18288">
+                    <a:solidFill>
+                      <a:srgbClr val="FFFFFF"/>
+                    </a:solidFill>
+                  </a:tcPr>
+                </a:tc>
+                <a:tc>
+                  <a:txBody>
+                    <a:bodyPr/>
+                    <a:lstStyle/>
+                    <a:p>
+                      <a:pPr algn="r"/>
+                      <a:r>
+                        <a:rPr sz="1000">
+                          <a:solidFill>
+                            <a:srgbClr val="3F3F3F"/>
+                          </a:solidFill>
+                          <a:latin typeface="Encode Sans"/>
+                        </a:rPr>
+                        <a:t>-1.5%</a:t>
+                      </a:r>
+                    </a:p>
+                  </a:txBody>
+                  <a:tcPr marL="36576" marR="36576" marT="18288" marB="18288">
+                    <a:solidFill>
+                      <a:srgbClr val="FFFFFF"/>
+                    </a:solidFill>
+                  </a:tcPr>
+                </a:tc>
+                <a:tc>
+                  <a:txBody>
+                    <a:bodyPr/>
+                    <a:lstStyle/>
+                    <a:p>
+                      <a:pPr algn="r"/>
+                      <a:r>
+                        <a:rPr sz="1000">
+                          <a:solidFill>
+                            <a:srgbClr val="3F3F3F"/>
+                          </a:solidFill>
+                          <a:latin typeface="Encode Sans"/>
+                        </a:rPr>
+                        <a:t>152,5</a:t>
+                      </a:r>
+                    </a:p>
+                  </a:txBody>
+                  <a:tcPr marL="36576" marR="36576" marT="18288" marB="18288">
+                    <a:solidFill>
+                      <a:srgbClr val="FFFFFF"/>
+                    </a:solidFill>
+                  </a:tcPr>
+                </a:tc>
+              </a:tr>
+              <a:tr h="292608">
+                <a:tc>
+                  <a:txBody>
+                    <a:bodyPr/>
+                    <a:lstStyle/>
+                    <a:p>
+                      <a:pPr algn="l"/>
+                      <a:r>
+                        <a:rPr sz="1000">
+                          <a:solidFill>
+                            <a:srgbClr val="3F3F3F"/>
+                          </a:solidFill>
+                          <a:latin typeface="Encode Sans"/>
+                        </a:rPr>
+                        <a:t>Enero 2026</a:t>
+                      </a:r>
+                    </a:p>
+                  </a:txBody>
+                  <a:tcPr marL="36576" marR="36576" marT="18288" marB="18288">
+                    <a:solidFill>
+                      <a:srgbClr val="F8F8F6"/>
+                    </a:solidFill>
+                  </a:tcPr>
+                </a:tc>
+                <a:tc>
+                  <a:txBody>
+                    <a:bodyPr/>
+                    <a:lstStyle/>
+                    <a:p>
+                      <a:pPr algn="r"/>
+                      <a:r>
+                        <a:rPr sz="1000">
+                          <a:solidFill>
+                            <a:srgbClr val="3F3F3F"/>
+                          </a:solidFill>
+                          <a:latin typeface="Encode Sans"/>
+                        </a:rPr>
+                        <a:t>149,4</a:t>
+                      </a:r>
+                    </a:p>
+                  </a:txBody>
+                  <a:tcPr marL="36576" marR="36576" marT="18288" marB="18288">
+                    <a:solidFill>
+                      <a:srgbClr val="F8F8F6"/>
+                    </a:solidFill>
+                  </a:tcPr>
+                </a:tc>
+                <a:tc>
+                  <a:txBody>
+                    <a:bodyPr/>
+                    <a:lstStyle/>
+                    <a:p>
+                      <a:pPr algn="r"/>
+                      <a:r>
+                        <a:rPr sz="1000">
+                          <a:solidFill>
+                            <a:srgbClr val="3F3F3F"/>
+                          </a:solidFill>
+                          <a:latin typeface="Encode Sans"/>
+                        </a:rPr>
+                        <a:t>+2.0%</a:t>
+                      </a:r>
+                    </a:p>
+                  </a:txBody>
+                  <a:tcPr marL="36576" marR="36576" marT="18288" marB="18288">
+                    <a:solidFill>
+                      <a:srgbClr val="F8F8F6"/>
+                    </a:solidFill>
+                  </a:tcPr>
+                </a:tc>
+                <a:tc>
+                  <a:txBody>
+                    <a:bodyPr/>
+                    <a:lstStyle/>
+                    <a:p>
+                      <a:pPr algn="r"/>
+                      <a:r>
+                        <a:rPr sz="1000">
+                          <a:solidFill>
+                            <a:srgbClr val="3F3F3F"/>
+                          </a:solidFill>
+                          <a:latin typeface="Encode Sans"/>
+                        </a:rPr>
+                        <a:t>156,4</a:t>
+                      </a:r>
+                    </a:p>
+                  </a:txBody>
+                  <a:tcPr marL="36576" marR="36576" marT="18288" marB="18288">
+                    <a:solidFill>
+                      <a:srgbClr val="F8F8F6"/>
+                    </a:solidFill>
+                  </a:tcPr>
+                </a:tc>
+              </a:tr>
+            </a:tbl>
+          </a:graphicData>
+        </a:graphic>
+      </p:graphicFrame>
+      <p:sp>
+        <p:nvSpPr>
+          <p:cNvPr id="9" name="TextBox 8"/>
+          <p:cNvSpPr txBox="1"/>
+          <p:nvPr/>
+        </p:nvSpPr>
+        <p:spPr>
+          <a:xfrm>
+            <a:off x="411480" y="6492240"/>
+            <a:ext cx="11368735" cy="274320"/>
+          </a:xfrm>
+          <a:prstGeom prst="rect">
+            <a:avLst/>
+          </a:prstGeom>
+          <a:noFill/>
+        </p:spPr>
+        <p:txBody>
+          <a:bodyPr wrap="none">
+            <a:spAutoFit/>
+          </a:bodyPr>
+          <a:lstStyle/>
+          <a:p>
+            <a:r>
+              <a:rPr sz="1000" b="0" i="1">
+                <a:solidFill>
+                  <a:srgbClr val="6A6760"/>
+                </a:solidFill>
+                <a:latin typeface="Encode Sans"/>
+              </a:rPr>
+              <a:t>Fuente: elaboración propia en base a INDEC</a:t>
+            </a:r>
+          </a:p>
+        </p:txBody>
+      </p:sp>
+    </p:spTree>
+  </p:cSld>
+  <p:clrMapOvr>
+    <a:masterClrMapping/>
+  </p:clrMapOvr>
+</p:sld>
+</file>
+
+<file path=ppt/slides/slide7.xml><?xml version="1.0" encoding="utf-8"?>
+<p:sld xmlns:a="http://schemas.openxmlformats.org/drawingml/2006/main" xmlns:p="http://schemas.openxmlformats.org/presentationml/2006/main" xmlns:r="http://schemas.openxmlformats.org/officeDocument/2006/relationships">
+  <p:cSld>
+    <p:spTree>
+      <p:nvGrpSpPr>
+        <p:cNvPr id="1" name=""/>
+        <p:cNvGrpSpPr/>
+        <p:nvPr/>
+      </p:nvGrpSpPr>
+      <p:grpSpPr/>
+      <p:sp>
+        <p:nvSpPr>
+          <p:cNvPr id="2" name="Rectangle 1"/>
+          <p:cNvSpPr/>
+          <p:nvPr/>
+        </p:nvSpPr>
+        <p:spPr>
+          <a:xfrm>
+            <a:off x="0" y="0"/>
+            <a:ext cx="12191695" cy="274320"/>
+          </a:xfrm>
+          <a:prstGeom prst="rect">
+            <a:avLst/>
+          </a:prstGeom>
+          <a:solidFill>
+            <a:srgbClr val="00B2C9"/>
+          </a:solidFill>
+          <a:ln>
+            <a:noFill/>
+          </a:ln>
+        </p:spPr>
+        <p:style>
+          <a:lnRef idx="1">
+            <a:schemeClr val="accent1"/>
+          </a:lnRef>
+          <a:fillRef idx="3">
+            <a:schemeClr val="accent1"/>
+          </a:fillRef>
+          <a:effectRef idx="2">
+            <a:schemeClr val="accent1"/>
+          </a:effectRef>
+          <a:fontRef idx="minor">
+            <a:schemeClr val="lt1"/>
+          </a:fontRef>
+        </p:style>
+        <p:txBody>
+          <a:bodyPr rtlCol="0" anchor="ctr"/>
+          <a:lstStyle/>
+          <a:p>
+            <a:pPr algn="ctr"/>
+          </a:p>
+        </p:txBody>
+      </p:sp>
+      <p:sp>
+        <p:nvSpPr>
+          <p:cNvPr id="3" name="TextBox 2"/>
+          <p:cNvSpPr txBox="1"/>
+          <p:nvPr/>
+        </p:nvSpPr>
+        <p:spPr>
+          <a:xfrm>
+            <a:off x="411480" y="457200"/>
+            <a:ext cx="11368735" cy="914400"/>
+          </a:xfrm>
+          <a:prstGeom prst="rect">
+            <a:avLst/>
+          </a:prstGeom>
+          <a:noFill/>
+        </p:spPr>
+        <p:txBody>
+          <a:bodyPr wrap="square" lIns="0" rIns="0">
+            <a:spAutoFit/>
+          </a:bodyPr>
+          <a:lstStyle/>
+          <a:p>
+            <a:pPr algn="l"/>
+            <a:r>
+              <a:rPr sz="2600" b="1" i="0">
+                <a:solidFill>
+                  <a:srgbClr val="00B2C9"/>
+                </a:solidFill>
+                <a:latin typeface="Encode Sans"/>
+              </a:rPr>
+              <a:t>SALARIOS JUNIO 2026: ÍNDICE TOTAL REGISTRADO 9.000</a:t>
+            </a:r>
+          </a:p>
+        </p:txBody>
+      </p:sp>
+      <p:sp>
+        <p:nvSpPr>
+          <p:cNvPr id="4" name="TextBox 3"/>
+          <p:cNvSpPr txBox="1"/>
+          <p:nvPr/>
+        </p:nvSpPr>
+        <p:spPr>
+          <a:xfrm>
+            <a:off x="411480" y="1280160"/>
+            <a:ext cx="11368735" cy="274320"/>
+          </a:xfrm>
+          <a:prstGeom prst="rect">
+            <a:avLst/>
+          </a:prstGeom>
+          <a:noFill/>
+        </p:spPr>
+        <p:txBody>
+          <a:bodyPr wrap="none">
+            <a:spAutoFit/>
+          </a:bodyPr>
+          <a:lstStyle/>
+          <a:p>
+            <a:r>
+              <a:rPr sz="1100" b="0" i="1">
+                <a:solidFill>
+                  <a:srgbClr val="6A6760"/>
+                </a:solidFill>
+                <a:latin typeface="Encode Sans"/>
+              </a:rPr>
+              <a:t>INDEC · período 2026-06</a:t>
+            </a:r>
+          </a:p>
+        </p:txBody>
+      </p:sp>
+      <p:sp>
+        <p:nvSpPr>
+          <p:cNvPr id="5" name="TextBox 4"/>
+          <p:cNvSpPr txBox="1"/>
+          <p:nvPr/>
+        </p:nvSpPr>
+        <p:spPr>
+          <a:xfrm>
+            <a:off x="411480" y="1691640"/>
+            <a:ext cx="5486400" cy="1645920"/>
+          </a:xfrm>
+          <a:prstGeom prst="rect">
+            <a:avLst/>
+          </a:prstGeom>
+          <a:noFill/>
+        </p:spPr>
+        <p:txBody>
+          <a:bodyPr wrap="square" lIns="0" rIns="0">
+            <a:spAutoFit/>
+          </a:bodyPr>
+          <a:lstStyle/>
+          <a:p>
+            <a:pPr algn="just"/>
+            <a:r>
+              <a:rPr sz="1300" b="0" i="0">
+                <a:solidFill>
+                  <a:srgbClr val="3F3F3F"/>
+                </a:solidFill>
+                <a:latin typeface="Encode Sans"/>
+              </a:rPr>
+              <a:t>El Índice de Salarios INDEC alcanzó 9.000 para el sector registrado en junio 2026. Privado registrado: 9.662. Público: 7.889.</a:t>
+            </a:r>
+          </a:p>
+        </p:txBody>
+      </p:sp>
+      <p:sp>
+        <p:nvSpPr>
+          <p:cNvPr id="6" name="TextBox 5"/>
+          <p:cNvSpPr txBox="1"/>
+          <p:nvPr/>
+        </p:nvSpPr>
+        <p:spPr>
+          <a:xfrm>
+            <a:off x="411480" y="3520440"/>
+            <a:ext cx="5486400" cy="2743200"/>
+          </a:xfrm>
+          <a:prstGeom prst="rect">
+            <a:avLst/>
+          </a:prstGeom>
+          <a:noFill/>
+        </p:spPr>
+        <p:txBody>
+          <a:bodyPr wrap="square" lIns="0" rIns="0">
+            <a:spAutoFit/>
+          </a:bodyPr>
+          <a:lstStyle/>
+          <a:p>
+            <a:pPr algn="l">
+              <a:spcAft>
+                <a:spcPts val="800"/>
+              </a:spcAft>
+            </a:pPr>
+            <a:r>
+              <a:rPr sz="1300" b="1" i="0">
+                <a:solidFill>
+                  <a:srgbClr val="00B2C9"/>
+                </a:solidFill>
+                <a:latin typeface="Encode Sans"/>
+              </a:rPr>
+              <a:t>●  </a:t>
+            </a:r>
+            <a:r>
+              <a:rPr sz="1300" b="0" i="0">
+                <a:solidFill>
+                  <a:srgbClr val="3F3F3F"/>
+                </a:solidFill>
+                <a:latin typeface="Encode Sans"/>
+              </a:rPr>
+              <a:t>Total registrado: 9.000</a:t>
+            </a:r>
+          </a:p>
+          <a:p>
+            <a:pPr algn="l">
+              <a:spcAft>
+                <a:spcPts val="800"/>
+              </a:spcAft>
+            </a:pPr>
+            <a:r>
+              <a:rPr sz="1300" b="1" i="0">
+                <a:solidFill>
+                  <a:srgbClr val="00B2C9"/>
+                </a:solidFill>
+                <a:latin typeface="Encode Sans"/>
+              </a:rPr>
+              <a:t>●  </a:t>
+            </a:r>
+            <a:r>
+              <a:rPr sz="1300" b="0" i="0">
+                <a:solidFill>
+                  <a:srgbClr val="3F3F3F"/>
+                </a:solidFill>
+                <a:latin typeface="Encode Sans"/>
+              </a:rPr>
+              <a:t>Privado registrado: 9.662</a:t>
+            </a:r>
+          </a:p>
+          <a:p>
+            <a:pPr algn="l">
+              <a:spcAft>
+                <a:spcPts val="800"/>
+              </a:spcAft>
+            </a:pPr>
+            <a:r>
+              <a:rPr sz="1300" b="1" i="0">
+                <a:solidFill>
+                  <a:srgbClr val="00B2C9"/>
+                </a:solidFill>
+                <a:latin typeface="Encode Sans"/>
+              </a:rPr>
+              <a:t>●  </a:t>
+            </a:r>
+            <a:r>
+              <a:rPr sz="1300" b="0" i="0">
+                <a:solidFill>
+                  <a:srgbClr val="3F3F3F"/>
+                </a:solidFill>
+                <a:latin typeface="Encode Sans"/>
+              </a:rPr>
+              <a:t>Sector público: 7.889</a:t>
+            </a:r>
+          </a:p>
+          <a:p>
+            <a:pPr algn="l">
+              <a:spcAft>
+                <a:spcPts val="800"/>
+              </a:spcAft>
+            </a:pPr>
+            <a:r>
+              <a:rPr sz="1300" b="1" i="0">
+                <a:solidFill>
+                  <a:srgbClr val="00B2C9"/>
+                </a:solidFill>
+                <a:latin typeface="Encode Sans"/>
+              </a:rPr>
+              <a:t>●  </a:t>
+            </a:r>
+            <a:r>
+              <a:rPr sz="1300" b="0" i="0">
+                <a:solidFill>
+                  <a:srgbClr val="3F3F3F"/>
+                </a:solidFill>
+                <a:latin typeface="Encode Sans"/>
+              </a:rPr>
+              <a:t>No registrado: 11.220</a:t>
+            </a:r>
+          </a:p>
+        </p:txBody>
+      </p:sp>
+      <p:pic>
+        <p:nvPicPr>
+          <p:cNvPr id="7" name="Picture 6" descr="image.png"/>
+          <p:cNvPicPr>
+            <a:picLocks noChangeAspect="1"/>
+          </p:cNvPicPr>
+          <p:nvPr/>
+        </p:nvPicPr>
+        <p:blipFill>
+          <a:blip r:embed="rId2"/>
+          <a:stretch>
+            <a:fillRect/>
+          </a:stretch>
+        </p:blipFill>
+        <p:spPr>
+          <a:xfrm>
+            <a:off x="6080760" y="1691640"/>
+            <a:ext cx="5669280" cy="2560320"/>
+          </a:xfrm>
+          <a:prstGeom prst="rect">
+            <a:avLst/>
+          </a:prstGeom>
+        </p:spPr>
+      </p:pic>
+      <p:graphicFrame>
+        <p:nvGraphicFramePr>
+          <p:cNvPr id="8" name="Table 7"/>
+          <p:cNvGraphicFramePr>
+            <a:graphicFrameLocks noGrp="1"/>
+          </p:cNvGraphicFramePr>
+          <p:nvPr/>
+        </p:nvGraphicFramePr>
+        <p:xfrm>
+          <a:off x="6080760" y="4434840"/>
+          <a:ext cx="5669280" cy="2048256"/>
+        </p:xfrm>
+        <a:graphic>
+          <a:graphicData uri="http://schemas.openxmlformats.org/drawingml/2006/table">
+            <a:tbl>
+              <a:tblPr firstRow="1" bandRow="1">
+                <a:tableStyleId>{5C22544A-7EE6-4342-B048-85BDC9FD1C3A}</a:tableStyleId>
+              </a:tblPr>
+              <a:tblGrid>
+                <a:gridCol w="1417320"/>
+                <a:gridCol w="1417320"/>
+                <a:gridCol w="1417320"/>
+                <a:gridCol w="1417320"/>
+              </a:tblGrid>
+              <a:tr h="292608">
+                <a:tc>
+                  <a:txBody>
+                    <a:bodyPr/>
+                    <a:lstStyle/>
+                    <a:p>
+                      <a:pPr algn="l"/>
+                      <a:r>
+                        <a:rPr sz="1000" b="1">
+                          <a:solidFill>
+                            <a:srgbClr val="FFFFFF"/>
+                          </a:solidFill>
+                          <a:latin typeface="Encode Sans"/>
+                        </a:rPr>
+                        <a:t>Mes</a:t>
+                      </a:r>
+                    </a:p>
+                  </a:txBody>
+                  <a:tcPr marL="36576" marR="36576" marT="18288" marB="18288">
+                    <a:solidFill>
+                      <a:srgbClr val="00B2C9"/>
+                    </a:solidFill>
+                  </a:tcPr>
+                </a:tc>
+                <a:tc>
+                  <a:txBody>
+                    <a:bodyPr/>
+                    <a:lstStyle/>
+                    <a:p>
+                      <a:pPr algn="r"/>
+                      <a:r>
+                        <a:rPr sz="1000" b="1">
+                          <a:solidFill>
+                            <a:srgbClr val="FFFFFF"/>
+                          </a:solidFill>
+                          <a:latin typeface="Encode Sans"/>
+                        </a:rPr>
+                        <a:t>Total reg.</a:t>
+                      </a:r>
+                    </a:p>
+                  </a:txBody>
+                  <a:tcPr marL="36576" marR="36576" marT="18288" marB="18288">
+                    <a:solidFill>
+                      <a:srgbClr val="00B2C9"/>
+                    </a:solidFill>
+                  </a:tcPr>
+                </a:tc>
+                <a:tc>
+                  <a:txBody>
+                    <a:bodyPr/>
+                    <a:lstStyle/>
+                    <a:p>
+                      <a:pPr algn="r"/>
+                      <a:r>
+                        <a:rPr sz="1000" b="1">
+                          <a:solidFill>
+                            <a:srgbClr val="FFFFFF"/>
+                          </a:solidFill>
+                          <a:latin typeface="Encode Sans"/>
+                        </a:rPr>
+                        <a:t>Privado</a:t>
+                      </a:r>
+                    </a:p>
+                  </a:txBody>
+                  <a:tcPr marL="36576" marR="36576" marT="18288" marB="18288">
+                    <a:solidFill>
+                      <a:srgbClr val="00B2C9"/>
+                    </a:solidFill>
+                  </a:tcPr>
+                </a:tc>
+                <a:tc>
+                  <a:txBody>
+                    <a:bodyPr/>
+                    <a:lstStyle/>
+                    <a:p>
+                      <a:pPr algn="r"/>
+                      <a:r>
+                        <a:rPr sz="1000" b="1">
+                          <a:solidFill>
+                            <a:srgbClr val="FFFFFF"/>
+                          </a:solidFill>
+                          <a:latin typeface="Encode Sans"/>
+                        </a:rPr>
+                        <a:t>Público</a:t>
+                      </a:r>
+                    </a:p>
+                  </a:txBody>
+                  <a:tcPr marL="36576" marR="36576" marT="18288" marB="18288">
+                    <a:solidFill>
+                      <a:srgbClr val="00B2C9"/>
+                    </a:solidFill>
+                  </a:tcPr>
+                </a:tc>
+              </a:tr>
+              <a:tr h="292608">
+                <a:tc>
+                  <a:txBody>
+                    <a:bodyPr/>
+                    <a:lstStyle/>
+                    <a:p>
+                      <a:pPr algn="l"/>
+                      <a:r>
+                        <a:rPr sz="1000">
+                          <a:solidFill>
+                            <a:srgbClr val="3F3F3F"/>
+                          </a:solidFill>
+                          <a:latin typeface="Encode Sans"/>
+                        </a:rPr>
+                        <a:t>Junio 2026</a:t>
+                      </a:r>
+                    </a:p>
+                  </a:txBody>
+                  <a:tcPr marL="36576" marR="36576" marT="18288" marB="18288">
+                    <a:solidFill>
+                      <a:srgbClr val="FFFFFF"/>
+                    </a:solidFill>
+                  </a:tcPr>
+                </a:tc>
+                <a:tc>
+                  <a:txBody>
+                    <a:bodyPr/>
+                    <a:lstStyle/>
+                    <a:p>
+                      <a:pPr algn="r"/>
+                      <a:r>
+                        <a:rPr sz="1000">
+                          <a:solidFill>
+                            <a:srgbClr val="3F3F3F"/>
+                          </a:solidFill>
+                          <a:latin typeface="Encode Sans"/>
+                        </a:rPr>
+                        <a:t>9.000</a:t>
+                      </a:r>
+                    </a:p>
+                  </a:txBody>
+                  <a:tcPr marL="36576" marR="36576" marT="18288" marB="18288">
+                    <a:solidFill>
+                      <a:srgbClr val="FFFFFF"/>
+                    </a:solidFill>
+                  </a:tcPr>
+                </a:tc>
+                <a:tc>
+                  <a:txBody>
+                    <a:bodyPr/>
+                    <a:lstStyle/>
+                    <a:p>
+                      <a:pPr algn="r"/>
+                      <a:r>
+                        <a:rPr sz="1000">
+                          <a:solidFill>
+                            <a:srgbClr val="3F3F3F"/>
+                          </a:solidFill>
+                          <a:latin typeface="Encode Sans"/>
+                        </a:rPr>
+                        <a:t>9.662</a:t>
+                      </a:r>
+                    </a:p>
+                  </a:txBody>
+                  <a:tcPr marL="36576" marR="36576" marT="18288" marB="18288">
+                    <a:solidFill>
+                      <a:srgbClr val="FFFFFF"/>
+                    </a:solidFill>
+                  </a:tcPr>
+                </a:tc>
+                <a:tc>
+                  <a:txBody>
+                    <a:bodyPr/>
+                    <a:lstStyle/>
+                    <a:p>
+                      <a:pPr algn="r"/>
+                      <a:r>
+                        <a:rPr sz="1000">
+                          <a:solidFill>
+                            <a:srgbClr val="3F3F3F"/>
+                          </a:solidFill>
+                          <a:latin typeface="Encode Sans"/>
+                        </a:rPr>
+                        <a:t>7.889</a:t>
+                      </a:r>
+                    </a:p>
+                  </a:txBody>
+                  <a:tcPr marL="36576" marR="36576" marT="18288" marB="18288">
+                    <a:solidFill>
+                      <a:srgbClr val="FFFFFF"/>
+                    </a:solidFill>
+                  </a:tcPr>
+                </a:tc>
+              </a:tr>
+              <a:tr h="292608">
+                <a:tc>
+                  <a:txBody>
+                    <a:bodyPr/>
+                    <a:lstStyle/>
+                    <a:p>
+                      <a:pPr algn="l"/>
+                      <a:r>
+                        <a:rPr sz="1000">
+                          <a:solidFill>
+                            <a:srgbClr val="3F3F3F"/>
+                          </a:solidFill>
+                          <a:latin typeface="Encode Sans"/>
+                        </a:rPr>
+                        <a:t>Mayo 2026</a:t>
+                      </a:r>
+                    </a:p>
+                  </a:txBody>
+                  <a:tcPr marL="36576" marR="36576" marT="18288" marB="18288">
+                    <a:solidFill>
+                      <a:srgbClr val="F8F8F6"/>
+                    </a:solidFill>
+                  </a:tcPr>
+                </a:tc>
+                <a:tc>
+                  <a:txBody>
+                    <a:bodyPr/>
+                    <a:lstStyle/>
+                    <a:p>
+                      <a:pPr algn="r"/>
+                      <a:r>
+                        <a:rPr sz="1000">
+                          <a:solidFill>
+                            <a:srgbClr val="3F3F3F"/>
+                          </a:solidFill>
+                          <a:latin typeface="Encode Sans"/>
+                        </a:rPr>
+                        <a:t>8.788</a:t>
+                      </a:r>
+                    </a:p>
+                  </a:txBody>
+                  <a:tcPr marL="36576" marR="36576" marT="18288" marB="18288">
+                    <a:solidFill>
+                      <a:srgbClr val="F8F8F6"/>
+                    </a:solidFill>
+                  </a:tcPr>
+                </a:tc>
+                <a:tc>
+                  <a:txBody>
+                    <a:bodyPr/>
+                    <a:lstStyle/>
+                    <a:p>
+                      <a:pPr algn="r"/>
+                      <a:r>
+                        <a:rPr sz="1000">
+                          <a:solidFill>
+                            <a:srgbClr val="3F3F3F"/>
+                          </a:solidFill>
+                          <a:latin typeface="Encode Sans"/>
+                        </a:rPr>
+                        <a:t>9.479</a:t>
+                      </a:r>
+                    </a:p>
+                  </a:txBody>
+                  <a:tcPr marL="36576" marR="36576" marT="18288" marB="18288">
+                    <a:solidFill>
+                      <a:srgbClr val="F8F8F6"/>
+                    </a:solidFill>
+                  </a:tcPr>
+                </a:tc>
+                <a:tc>
+                  <a:txBody>
+                    <a:bodyPr/>
+                    <a:lstStyle/>
+                    <a:p>
+                      <a:pPr algn="r"/>
+                      <a:r>
+                        <a:rPr sz="1000">
+                          <a:solidFill>
+                            <a:srgbClr val="3F3F3F"/>
+                          </a:solidFill>
+                          <a:latin typeface="Encode Sans"/>
+                        </a:rPr>
+                        <a:t>7.628</a:t>
+                      </a:r>
+                    </a:p>
+                  </a:txBody>
+                  <a:tcPr marL="36576" marR="36576" marT="18288" marB="18288">
+                    <a:solidFill>
+                      <a:srgbClr val="F8F8F6"/>
+                    </a:solidFill>
+                  </a:tcPr>
+                </a:tc>
+              </a:tr>
+              <a:tr h="292608">
+                <a:tc>
+                  <a:txBody>
+                    <a:bodyPr/>
+                    <a:lstStyle/>
+                    <a:p>
+                      <a:pPr algn="l"/>
+                      <a:r>
+                        <a:rPr sz="1000">
+                          <a:solidFill>
+                            <a:srgbClr val="3F3F3F"/>
+                          </a:solidFill>
+                          <a:latin typeface="Encode Sans"/>
+                        </a:rPr>
+                        <a:t>Abril 2026</a:t>
+                      </a:r>
+                    </a:p>
+                  </a:txBody>
+                  <a:tcPr marL="36576" marR="36576" marT="18288" marB="18288">
+                    <a:solidFill>
+                      <a:srgbClr val="FFFFFF"/>
+                    </a:solidFill>
+                  </a:tcPr>
+                </a:tc>
+                <a:tc>
+                  <a:txBody>
+                    <a:bodyPr/>
+                    <a:lstStyle/>
+                    <a:p>
+                      <a:pPr algn="r"/>
+                      <a:r>
+                        <a:rPr sz="1000">
+                          <a:solidFill>
+                            <a:srgbClr val="3F3F3F"/>
+                          </a:solidFill>
+                          <a:latin typeface="Encode Sans"/>
+                        </a:rPr>
+                        <a:t>8.629</a:t>
+                      </a:r>
+                    </a:p>
+                  </a:txBody>
+                  <a:tcPr marL="36576" marR="36576" marT="18288" marB="18288">
+                    <a:solidFill>
+                      <a:srgbClr val="FFFFFF"/>
+                    </a:solidFill>
+                  </a:tcPr>
+                </a:tc>
+                <a:tc>
+                  <a:txBody>
+                    <a:bodyPr/>
+                    <a:lstStyle/>
+                    <a:p>
+                      <a:pPr algn="r"/>
+                      <a:r>
+                        <a:rPr sz="1000">
+                          <a:solidFill>
+                            <a:srgbClr val="3F3F3F"/>
+                          </a:solidFill>
+                          <a:latin typeface="Encode Sans"/>
+                        </a:rPr>
+                        <a:t>9.293</a:t>
+                      </a:r>
+                    </a:p>
+                  </a:txBody>
+                  <a:tcPr marL="36576" marR="36576" marT="18288" marB="18288">
+                    <a:solidFill>
+                      <a:srgbClr val="FFFFFF"/>
+                    </a:solidFill>
+                  </a:tcPr>
+                </a:tc>
+                <a:tc>
+                  <a:txBody>
+                    <a:bodyPr/>
+                    <a:lstStyle/>
+                    <a:p>
+                      <a:pPr algn="r"/>
+                      <a:r>
+                        <a:rPr sz="1000">
+                          <a:solidFill>
+                            <a:srgbClr val="3F3F3F"/>
+                          </a:solidFill>
+                          <a:latin typeface="Encode Sans"/>
+                        </a:rPr>
+                        <a:t>7.515</a:t>
+                      </a:r>
+                    </a:p>
+                  </a:txBody>
+                  <a:tcPr marL="36576" marR="36576" marT="18288" marB="18288">
+                    <a:solidFill>
+                      <a:srgbClr val="FFFFFF"/>
+                    </a:solidFill>
+                  </a:tcPr>
+                </a:tc>
+              </a:tr>
+              <a:tr h="292608">
+                <a:tc>
+                  <a:txBody>
+                    <a:bodyPr/>
+                    <a:lstStyle/>
+                    <a:p>
+                      <a:pPr algn="l"/>
+                      <a:r>
+                        <a:rPr sz="1000">
+                          <a:solidFill>
+                            <a:srgbClr val="3F3F3F"/>
+                          </a:solidFill>
+                          <a:latin typeface="Encode Sans"/>
+                        </a:rPr>
+                        <a:t>Marzo 2026</a:t>
+                      </a:r>
+                    </a:p>
+                  </a:txBody>
+                  <a:tcPr marL="36576" marR="36576" marT="18288" marB="18288">
+                    <a:solidFill>
+                      <a:srgbClr val="F8F8F6"/>
+                    </a:solidFill>
+                  </a:tcPr>
+                </a:tc>
+                <a:tc>
+                  <a:txBody>
+                    <a:bodyPr/>
+                    <a:lstStyle/>
+                    <a:p>
+                      <a:pPr algn="r"/>
+                      <a:r>
+                        <a:rPr sz="1000">
+                          <a:solidFill>
+                            <a:srgbClr val="3F3F3F"/>
+                          </a:solidFill>
+                          <a:latin typeface="Encode Sans"/>
+                        </a:rPr>
+                        <a:t>8.341</a:t>
+                      </a:r>
+                    </a:p>
+                  </a:txBody>
+                  <a:tcPr marL="36576" marR="36576" marT="18288" marB="18288">
+                    <a:solidFill>
+                      <a:srgbClr val="F8F8F6"/>
+                    </a:solidFill>
+                  </a:tcPr>
+                </a:tc>
+                <a:tc>
+                  <a:txBody>
+                    <a:bodyPr/>
+                    <a:lstStyle/>
+                    <a:p>
+                      <a:pPr algn="r"/>
+                      <a:r>
+                        <a:rPr sz="1000">
+                          <a:solidFill>
+                            <a:srgbClr val="3F3F3F"/>
+                          </a:solidFill>
+                          <a:latin typeface="Encode Sans"/>
+                        </a:rPr>
+                        <a:t>8.935</a:t>
+                      </a:r>
+                    </a:p>
+                  </a:txBody>
+                  <a:tcPr marL="36576" marR="36576" marT="18288" marB="18288">
+                    <a:solidFill>
+                      <a:srgbClr val="F8F8F6"/>
+                    </a:solidFill>
+                  </a:tcPr>
+                </a:tc>
+                <a:tc>
+                  <a:txBody>
+                    <a:bodyPr/>
+                    <a:lstStyle/>
+                    <a:p>
+                      <a:pPr algn="r"/>
+                      <a:r>
+                        <a:rPr sz="1000">
+                          <a:solidFill>
+                            <a:srgbClr val="3F3F3F"/>
+                          </a:solidFill>
+                          <a:latin typeface="Encode Sans"/>
+                        </a:rPr>
+                        <a:t>7.344</a:t>
+                      </a:r>
+                    </a:p>
+                  </a:txBody>
+                  <a:tcPr marL="36576" marR="36576" marT="18288" marB="18288">
+                    <a:solidFill>
+                      <a:srgbClr val="F8F8F6"/>
+                    </a:solidFill>
+                  </a:tcPr>
+                </a:tc>
+              </a:tr>
+              <a:tr h="292608">
+                <a:tc>
+                  <a:txBody>
+                    <a:bodyPr/>
+                    <a:lstStyle/>
+                    <a:p>
+                      <a:pPr algn="l"/>
+                      <a:r>
+                        <a:rPr sz="1000">
+                          <a:solidFill>
+                            <a:srgbClr val="3F3F3F"/>
+                          </a:solidFill>
+                          <a:latin typeface="Encode Sans"/>
+                        </a:rPr>
+                        <a:t>Febrero 2026</a:t>
+                      </a:r>
+                    </a:p>
+                  </a:txBody>
+                  <a:tcPr marL="36576" marR="36576" marT="18288" marB="18288">
+                    <a:solidFill>
+                      <a:srgbClr val="FFFFFF"/>
+                    </a:solidFill>
+                  </a:tcPr>
+                </a:tc>
+                <a:tc>
+                  <a:txBody>
+                    <a:bodyPr/>
+                    <a:lstStyle/>
+                    <a:p>
+                      <a:pPr algn="r"/>
+                      <a:r>
+                        <a:rPr sz="1000">
+                          <a:solidFill>
+                            <a:srgbClr val="3F3F3F"/>
+                          </a:solidFill>
+                          <a:latin typeface="Encode Sans"/>
+                        </a:rPr>
+                        <a:t>8.096</a:t>
+                      </a:r>
+                    </a:p>
+                  </a:txBody>
+                  <a:tcPr marL="36576" marR="36576" marT="18288" marB="18288">
+                    <a:solidFill>
+                      <a:srgbClr val="FFFFFF"/>
+                    </a:solidFill>
+                  </a:tcPr>
+                </a:tc>
+                <a:tc>
+                  <a:txBody>
+                    <a:bodyPr/>
+                    <a:lstStyle/>
+                    <a:p>
+                      <a:pPr algn="r"/>
+                      <a:r>
+                        <a:rPr sz="1000">
+                          <a:solidFill>
+                            <a:srgbClr val="3F3F3F"/>
+                          </a:solidFill>
+                          <a:latin typeface="Encode Sans"/>
+                        </a:rPr>
+                        <a:t>8.755</a:t>
+                      </a:r>
+                    </a:p>
+                  </a:txBody>
+                  <a:tcPr marL="36576" marR="36576" marT="18288" marB="18288">
+                    <a:solidFill>
+                      <a:srgbClr val="FFFFFF"/>
+                    </a:solidFill>
+                  </a:tcPr>
+                </a:tc>
+                <a:tc>
+                  <a:txBody>
+                    <a:bodyPr/>
+                    <a:lstStyle/>
+                    <a:p>
+                      <a:pPr algn="r"/>
+                      <a:r>
+                        <a:rPr sz="1000">
+                          <a:solidFill>
+                            <a:srgbClr val="3F3F3F"/>
+                          </a:solidFill>
+                          <a:latin typeface="Encode Sans"/>
+                        </a:rPr>
+                        <a:t>6.991</a:t>
+                      </a:r>
+                    </a:p>
+                  </a:txBody>
+                  <a:tcPr marL="36576" marR="36576" marT="18288" marB="18288">
+                    <a:solidFill>
+                      <a:srgbClr val="FFFFFF"/>
+                    </a:solidFill>
+                  </a:tcPr>
+                </a:tc>
+              </a:tr>
+              <a:tr h="292608">
+                <a:tc>
+                  <a:txBody>
+                    <a:bodyPr/>
+                    <a:lstStyle/>
+                    <a:p>
+                      <a:pPr algn="l"/>
+                      <a:r>
+                        <a:rPr sz="1000">
+                          <a:solidFill>
+                            <a:srgbClr val="3F3F3F"/>
+                          </a:solidFill>
+                          <a:latin typeface="Encode Sans"/>
+                        </a:rPr>
+                        <a:t>Enero 2026</a:t>
+                      </a:r>
+                    </a:p>
+                  </a:txBody>
+                  <a:tcPr marL="36576" marR="36576" marT="18288" marB="18288">
+                    <a:solidFill>
+                      <a:srgbClr val="F8F8F6"/>
+                    </a:solidFill>
+                  </a:tcPr>
+                </a:tc>
+                <a:tc>
+                  <a:txBody>
+                    <a:bodyPr/>
+                    <a:lstStyle/>
+                    <a:p>
+                      <a:pPr algn="r"/>
+                      <a:r>
+                        <a:rPr sz="1000">
+                          <a:solidFill>
+                            <a:srgbClr val="3F3F3F"/>
+                          </a:solidFill>
+                          <a:latin typeface="Encode Sans"/>
+                        </a:rPr>
+                        <a:t>7.953</a:t>
+                      </a:r>
+                    </a:p>
+                  </a:txBody>
+                  <a:tcPr marL="36576" marR="36576" marT="18288" marB="18288">
+                    <a:solidFill>
+                      <a:srgbClr val="F8F8F6"/>
+                    </a:solidFill>
+                  </a:tcPr>
+                </a:tc>
+                <a:tc>
+                  <a:txBody>
+                    <a:bodyPr/>
+                    <a:lstStyle/>
+                    <a:p>
+                      <a:pPr algn="r"/>
+                      <a:r>
+                        <a:rPr sz="1000">
+                          <a:solidFill>
+                            <a:srgbClr val="3F3F3F"/>
+                          </a:solidFill>
+                          <a:latin typeface="Encode Sans"/>
+                        </a:rPr>
+                        <a:t>8.621</a:t>
+                      </a:r>
+                    </a:p>
+                  </a:txBody>
+                  <a:tcPr marL="36576" marR="36576" marT="18288" marB="18288">
+                    <a:solidFill>
+                      <a:srgbClr val="F8F8F6"/>
+                    </a:solidFill>
+                  </a:tcPr>
+                </a:tc>
+                <a:tc>
+                  <a:txBody>
+                    <a:bodyPr/>
+                    <a:lstStyle/>
+                    <a:p>
+                      <a:pPr algn="r"/>
+                      <a:r>
+                        <a:rPr sz="1000">
+                          <a:solidFill>
+                            <a:srgbClr val="3F3F3F"/>
+                          </a:solidFill>
+                          <a:latin typeface="Encode Sans"/>
+                        </a:rPr>
+                        <a:t>6.832</a:t>
                       </a:r>
                     </a:p>
                   </a:txBody>

</xml_diff>

<commit_message>
data: update 2026-08-21 ( data.json despidos.json scraper/historical_despidos.json publicaciones_semana.pptx rrii_brutas.xlsx)
</commit_message>
<xml_diff>
--- a/publicaciones_semana.pptx
+++ b/publicaciones_semana.pptx
@@ -12,6 +12,7 @@
     <p:sldId id="260" r:id="rId11"/>
     <p:sldId id="261" r:id="rId12"/>
     <p:sldId id="262" r:id="rId13"/>
+    <p:sldId id="263" r:id="rId14"/>
   </p:sldIdLst>
   <p:sldSz cx="12191695" cy="6858000" type="screen4x3"/>
   <p:notesSz cx="6858000" cy="9144000"/>
@@ -3277,7 +3278,7 @@
                 </a:solidFill>
                 <a:latin typeface="Encode Sans"/>
               </a:rPr>
-              <a:t>6 publicaciones · datos oficiales INDEC / BCRA / Hacienda</a:t>
+              <a:t>7 publicaciones · datos oficiales INDEC / BCRA / Hacienda</a:t>
             </a:r>
           </a:p>
         </p:txBody>
@@ -8653,6 +8654,1013 @@
                           <a:latin typeface="Encode Sans"/>
                         </a:rPr>
                         <a:t>6.832</a:t>
+                      </a:r>
+                    </a:p>
+                  </a:txBody>
+                  <a:tcPr marL="36576" marR="36576" marT="18288" marB="18288">
+                    <a:solidFill>
+                      <a:srgbClr val="F8F8F6"/>
+                    </a:solidFill>
+                  </a:tcPr>
+                </a:tc>
+              </a:tr>
+            </a:tbl>
+          </a:graphicData>
+        </a:graphic>
+      </p:graphicFrame>
+      <p:sp>
+        <p:nvSpPr>
+          <p:cNvPr id="9" name="TextBox 8"/>
+          <p:cNvSpPr txBox="1"/>
+          <p:nvPr/>
+        </p:nvSpPr>
+        <p:spPr>
+          <a:xfrm>
+            <a:off x="411480" y="6492240"/>
+            <a:ext cx="11368735" cy="274320"/>
+          </a:xfrm>
+          <a:prstGeom prst="rect">
+            <a:avLst/>
+          </a:prstGeom>
+          <a:noFill/>
+        </p:spPr>
+        <p:txBody>
+          <a:bodyPr wrap="none">
+            <a:spAutoFit/>
+          </a:bodyPr>
+          <a:lstStyle/>
+          <a:p>
+            <a:r>
+              <a:rPr sz="1000" b="0" i="1">
+                <a:solidFill>
+                  <a:srgbClr val="6A6760"/>
+                </a:solidFill>
+                <a:latin typeface="Encode Sans"/>
+              </a:rPr>
+              <a:t>Fuente: elaboración propia en base a INDEC</a:t>
+            </a:r>
+          </a:p>
+        </p:txBody>
+      </p:sp>
+    </p:spTree>
+  </p:cSld>
+  <p:clrMapOvr>
+    <a:masterClrMapping/>
+  </p:clrMapOvr>
+</p:sld>
+</file>
+
+<file path=ppt/slides/slide8.xml><?xml version="1.0" encoding="utf-8"?>
+<p:sld xmlns:a="http://schemas.openxmlformats.org/drawingml/2006/main" xmlns:p="http://schemas.openxmlformats.org/presentationml/2006/main" xmlns:r="http://schemas.openxmlformats.org/officeDocument/2006/relationships">
+  <p:cSld>
+    <p:spTree>
+      <p:nvGrpSpPr>
+        <p:cNvPr id="1" name=""/>
+        <p:cNvGrpSpPr/>
+        <p:nvPr/>
+      </p:nvGrpSpPr>
+      <p:grpSpPr/>
+      <p:sp>
+        <p:nvSpPr>
+          <p:cNvPr id="2" name="Rectangle 1"/>
+          <p:cNvSpPr/>
+          <p:nvPr/>
+        </p:nvSpPr>
+        <p:spPr>
+          <a:xfrm>
+            <a:off x="0" y="0"/>
+            <a:ext cx="12191695" cy="274320"/>
+          </a:xfrm>
+          <a:prstGeom prst="rect">
+            <a:avLst/>
+          </a:prstGeom>
+          <a:solidFill>
+            <a:srgbClr val="00B2C9"/>
+          </a:solidFill>
+          <a:ln>
+            <a:noFill/>
+          </a:ln>
+        </p:spPr>
+        <p:style>
+          <a:lnRef idx="1">
+            <a:schemeClr val="accent1"/>
+          </a:lnRef>
+          <a:fillRef idx="3">
+            <a:schemeClr val="accent1"/>
+          </a:fillRef>
+          <a:effectRef idx="2">
+            <a:schemeClr val="accent1"/>
+          </a:effectRef>
+          <a:fontRef idx="minor">
+            <a:schemeClr val="lt1"/>
+          </a:fontRef>
+        </p:style>
+        <p:txBody>
+          <a:bodyPr rtlCol="0" anchor="ctr"/>
+          <a:lstStyle/>
+          <a:p>
+            <a:pPr algn="ctr"/>
+          </a:p>
+        </p:txBody>
+      </p:sp>
+      <p:sp>
+        <p:nvSpPr>
+          <p:cNvPr id="3" name="TextBox 2"/>
+          <p:cNvSpPr txBox="1"/>
+          <p:nvPr/>
+        </p:nvSpPr>
+        <p:spPr>
+          <a:xfrm>
+            <a:off x="411480" y="457200"/>
+            <a:ext cx="11368735" cy="914400"/>
+          </a:xfrm>
+          <a:prstGeom prst="rect">
+            <a:avLst/>
+          </a:prstGeom>
+          <a:noFill/>
+        </p:spPr>
+        <p:txBody>
+          <a:bodyPr wrap="square" lIns="0" rIns="0">
+            <a:spAutoFit/>
+          </a:bodyPr>
+          <a:lstStyle/>
+          <a:p>
+            <a:pPr algn="l"/>
+            <a:r>
+              <a:rPr sz="2600" b="1" i="0">
+                <a:solidFill>
+                  <a:srgbClr val="00B2C9"/>
+                </a:solidFill>
+                <a:latin typeface="Encode Sans"/>
+              </a:rPr>
+              <a:t>SUPERMERCADOS JUNIO 2026: VENTAS REALES CAYERON -3.1%</a:t>
+            </a:r>
+          </a:p>
+        </p:txBody>
+      </p:sp>
+      <p:sp>
+        <p:nvSpPr>
+          <p:cNvPr id="4" name="TextBox 3"/>
+          <p:cNvSpPr txBox="1"/>
+          <p:nvPr/>
+        </p:nvSpPr>
+        <p:spPr>
+          <a:xfrm>
+            <a:off x="411480" y="1280160"/>
+            <a:ext cx="11368735" cy="274320"/>
+          </a:xfrm>
+          <a:prstGeom prst="rect">
+            <a:avLst/>
+          </a:prstGeom>
+          <a:noFill/>
+        </p:spPr>
+        <p:txBody>
+          <a:bodyPr wrap="none">
+            <a:spAutoFit/>
+          </a:bodyPr>
+          <a:lstStyle/>
+          <a:p>
+            <a:r>
+              <a:rPr sz="1100" b="0" i="1">
+                <a:solidFill>
+                  <a:srgbClr val="6A6760"/>
+                </a:solidFill>
+                <a:latin typeface="Encode Sans"/>
+              </a:rPr>
+              <a:t>INDEC · período 2026-06</a:t>
+            </a:r>
+          </a:p>
+        </p:txBody>
+      </p:sp>
+      <p:sp>
+        <p:nvSpPr>
+          <p:cNvPr id="5" name="TextBox 4"/>
+          <p:cNvSpPr txBox="1"/>
+          <p:nvPr/>
+        </p:nvSpPr>
+        <p:spPr>
+          <a:xfrm>
+            <a:off x="411480" y="1691640"/>
+            <a:ext cx="5486400" cy="1645920"/>
+          </a:xfrm>
+          <a:prstGeom prst="rect">
+            <a:avLst/>
+          </a:prstGeom>
+          <a:noFill/>
+        </p:spPr>
+        <p:txBody>
+          <a:bodyPr wrap="square" lIns="0" rIns="0">
+            <a:spAutoFit/>
+          </a:bodyPr>
+          <a:lstStyle/>
+          <a:p>
+            <a:pPr algn="just"/>
+            <a:r>
+              <a:rPr sz="1300" b="0" i="0">
+                <a:solidFill>
+                  <a:srgbClr val="3F3F3F"/>
+                </a:solidFill>
+                <a:latin typeface="Encode Sans"/>
+              </a:rPr>
+              <a:t>Las ventas de supermercados a precios constantes registraron una variación interanual real de -3.1% en junio 2026. Desestacionalizada: -1.0% m/m.</a:t>
+            </a:r>
+          </a:p>
+        </p:txBody>
+      </p:sp>
+      <p:sp>
+        <p:nvSpPr>
+          <p:cNvPr id="6" name="TextBox 5"/>
+          <p:cNvSpPr txBox="1"/>
+          <p:nvPr/>
+        </p:nvSpPr>
+        <p:spPr>
+          <a:xfrm>
+            <a:off x="411480" y="3520440"/>
+            <a:ext cx="5486400" cy="2743200"/>
+          </a:xfrm>
+          <a:prstGeom prst="rect">
+            <a:avLst/>
+          </a:prstGeom>
+          <a:noFill/>
+        </p:spPr>
+        <p:txBody>
+          <a:bodyPr wrap="square" lIns="0" rIns="0">
+            <a:spAutoFit/>
+          </a:bodyPr>
+          <a:lstStyle/>
+          <a:p>
+            <a:pPr algn="l">
+              <a:spcAft>
+                <a:spcPts val="800"/>
+              </a:spcAft>
+            </a:pPr>
+            <a:r>
+              <a:rPr sz="1300" b="1" i="0">
+                <a:solidFill>
+                  <a:srgbClr val="00B2C9"/>
+                </a:solidFill>
+                <a:latin typeface="Encode Sans"/>
+              </a:rPr>
+              <a:t>●  </a:t>
+            </a:r>
+            <a:r>
+              <a:rPr sz="1300" b="0" i="0">
+                <a:solidFill>
+                  <a:srgbClr val="3F3F3F"/>
+                </a:solidFill>
+                <a:latin typeface="Encode Sans"/>
+              </a:rPr>
+              <a:t>Variación interanual real: -3.1%</a:t>
+            </a:r>
+          </a:p>
+          <a:p>
+            <a:pPr algn="l">
+              <a:spcAft>
+                <a:spcPts val="800"/>
+              </a:spcAft>
+            </a:pPr>
+            <a:r>
+              <a:rPr sz="1300" b="1" i="0">
+                <a:solidFill>
+                  <a:srgbClr val="00B2C9"/>
+                </a:solidFill>
+                <a:latin typeface="Encode Sans"/>
+              </a:rPr>
+              <a:t>●  </a:t>
+            </a:r>
+            <a:r>
+              <a:rPr sz="1300" b="0" i="0">
+                <a:solidFill>
+                  <a:srgbClr val="3F3F3F"/>
+                </a:solidFill>
+                <a:latin typeface="Encode Sans"/>
+              </a:rPr>
+              <a:t>Variación mensual desestacionalizada: -1.0%</a:t>
+            </a:r>
+          </a:p>
+          <a:p>
+            <a:pPr algn="l">
+              <a:spcAft>
+                <a:spcPts val="800"/>
+              </a:spcAft>
+            </a:pPr>
+            <a:r>
+              <a:rPr sz="1300" b="1" i="0">
+                <a:solidFill>
+                  <a:srgbClr val="00B2C9"/>
+                </a:solidFill>
+                <a:latin typeface="Encode Sans"/>
+              </a:rPr>
+              <a:t>●  </a:t>
+            </a:r>
+            <a:r>
+              <a:rPr sz="1300" b="0" i="0">
+                <a:solidFill>
+                  <a:srgbClr val="3F3F3F"/>
+                </a:solidFill>
+                <a:latin typeface="Encode Sans"/>
+              </a:rPr>
+              <a:t>Acumulado del año: -2.8%</a:t>
+            </a:r>
+          </a:p>
+        </p:txBody>
+      </p:sp>
+      <p:pic>
+        <p:nvPicPr>
+          <p:cNvPr id="7" name="Picture 6" descr="image.png"/>
+          <p:cNvPicPr>
+            <a:picLocks noChangeAspect="1"/>
+          </p:cNvPicPr>
+          <p:nvPr/>
+        </p:nvPicPr>
+        <p:blipFill>
+          <a:blip r:embed="rId2"/>
+          <a:stretch>
+            <a:fillRect/>
+          </a:stretch>
+        </p:blipFill>
+        <p:spPr>
+          <a:xfrm>
+            <a:off x="6080760" y="1691640"/>
+            <a:ext cx="5669280" cy="2560320"/>
+          </a:xfrm>
+          <a:prstGeom prst="rect">
+            <a:avLst/>
+          </a:prstGeom>
+        </p:spPr>
+      </p:pic>
+      <p:graphicFrame>
+        <p:nvGraphicFramePr>
+          <p:cNvPr id="8" name="Table 7"/>
+          <p:cNvGraphicFramePr>
+            <a:graphicFrameLocks noGrp="1"/>
+          </p:cNvGraphicFramePr>
+          <p:nvPr/>
+        </p:nvGraphicFramePr>
+        <p:xfrm>
+          <a:off x="6080760" y="4434840"/>
+          <a:ext cx="5669280" cy="2048256"/>
+        </p:xfrm>
+        <a:graphic>
+          <a:graphicData uri="http://schemas.openxmlformats.org/drawingml/2006/table">
+            <a:tbl>
+              <a:tblPr firstRow="1" bandRow="1">
+                <a:tableStyleId>{5C22544A-7EE6-4342-B048-85BDC9FD1C3A}</a:tableStyleId>
+              </a:tblPr>
+              <a:tblGrid>
+                <a:gridCol w="1417320"/>
+                <a:gridCol w="1417320"/>
+                <a:gridCol w="1417320"/>
+                <a:gridCol w="1417320"/>
+              </a:tblGrid>
+              <a:tr h="292608">
+                <a:tc>
+                  <a:txBody>
+                    <a:bodyPr/>
+                    <a:lstStyle/>
+                    <a:p>
+                      <a:pPr algn="l"/>
+                      <a:r>
+                        <a:rPr sz="1000" b="1">
+                          <a:solidFill>
+                            <a:srgbClr val="FFFFFF"/>
+                          </a:solidFill>
+                          <a:latin typeface="Encode Sans"/>
+                        </a:rPr>
+                        <a:t>Mes</a:t>
+                      </a:r>
+                    </a:p>
+                  </a:txBody>
+                  <a:tcPr marL="36576" marR="36576" marT="18288" marB="18288">
+                    <a:solidFill>
+                      <a:srgbClr val="00B2C9"/>
+                    </a:solidFill>
+                  </a:tcPr>
+                </a:tc>
+                <a:tc>
+                  <a:txBody>
+                    <a:bodyPr/>
+                    <a:lstStyle/>
+                    <a:p>
+                      <a:pPr algn="r"/>
+                      <a:r>
+                        <a:rPr sz="1000" b="1">
+                          <a:solidFill>
+                            <a:srgbClr val="FFFFFF"/>
+                          </a:solidFill>
+                          <a:latin typeface="Encode Sans"/>
+                        </a:rPr>
+                        <a:t>Índice real</a:t>
+                      </a:r>
+                    </a:p>
+                  </a:txBody>
+                  <a:tcPr marL="36576" marR="36576" marT="18288" marB="18288">
+                    <a:solidFill>
+                      <a:srgbClr val="00B2C9"/>
+                    </a:solidFill>
+                  </a:tcPr>
+                </a:tc>
+                <a:tc>
+                  <a:txBody>
+                    <a:bodyPr/>
+                    <a:lstStyle/>
+                    <a:p>
+                      <a:pPr algn="r"/>
+                      <a:r>
+                        <a:rPr sz="1000" b="1">
+                          <a:solidFill>
+                            <a:srgbClr val="FFFFFF"/>
+                          </a:solidFill>
+                          <a:latin typeface="Encode Sans"/>
+                        </a:rPr>
+                        <a:t>VIA real %</a:t>
+                      </a:r>
+                    </a:p>
+                  </a:txBody>
+                  <a:tcPr marL="36576" marR="36576" marT="18288" marB="18288">
+                    <a:solidFill>
+                      <a:srgbClr val="00B2C9"/>
+                    </a:solidFill>
+                  </a:tcPr>
+                </a:tc>
+                <a:tc>
+                  <a:txBody>
+                    <a:bodyPr/>
+                    <a:lstStyle/>
+                    <a:p>
+                      <a:pPr algn="r"/>
+                      <a:r>
+                        <a:rPr sz="1000" b="1">
+                          <a:solidFill>
+                            <a:srgbClr val="FFFFFF"/>
+                          </a:solidFill>
+                          <a:latin typeface="Encode Sans"/>
+                        </a:rPr>
+                        <a:t>Acumulado %</a:t>
+                      </a:r>
+                    </a:p>
+                  </a:txBody>
+                  <a:tcPr marL="36576" marR="36576" marT="18288" marB="18288">
+                    <a:solidFill>
+                      <a:srgbClr val="00B2C9"/>
+                    </a:solidFill>
+                  </a:tcPr>
+                </a:tc>
+              </a:tr>
+              <a:tr h="292608">
+                <a:tc>
+                  <a:txBody>
+                    <a:bodyPr/>
+                    <a:lstStyle/>
+                    <a:p>
+                      <a:pPr algn="l"/>
+                      <a:r>
+                        <a:rPr sz="1000">
+                          <a:solidFill>
+                            <a:srgbClr val="3F3F3F"/>
+                          </a:solidFill>
+                          <a:latin typeface="Encode Sans"/>
+                        </a:rPr>
+                        <a:t>Junio 2026</a:t>
+                      </a:r>
+                    </a:p>
+                  </a:txBody>
+                  <a:tcPr marL="36576" marR="36576" marT="18288" marB="18288">
+                    <a:solidFill>
+                      <a:srgbClr val="FFFFFF"/>
+                    </a:solidFill>
+                  </a:tcPr>
+                </a:tc>
+                <a:tc>
+                  <a:txBody>
+                    <a:bodyPr/>
+                    <a:lstStyle/>
+                    <a:p>
+                      <a:pPr algn="r"/>
+                      <a:r>
+                        <a:rPr sz="1000">
+                          <a:solidFill>
+                            <a:srgbClr val="3F3F3F"/>
+                          </a:solidFill>
+                          <a:latin typeface="Encode Sans"/>
+                        </a:rPr>
+                        <a:t>78,7</a:t>
+                      </a:r>
+                    </a:p>
+                  </a:txBody>
+                  <a:tcPr marL="36576" marR="36576" marT="18288" marB="18288">
+                    <a:solidFill>
+                      <a:srgbClr val="FFFFFF"/>
+                    </a:solidFill>
+                  </a:tcPr>
+                </a:tc>
+                <a:tc>
+                  <a:txBody>
+                    <a:bodyPr/>
+                    <a:lstStyle/>
+                    <a:p>
+                      <a:pPr algn="r"/>
+                      <a:r>
+                        <a:rPr sz="1000">
+                          <a:solidFill>
+                            <a:srgbClr val="3F3F3F"/>
+                          </a:solidFill>
+                          <a:latin typeface="Encode Sans"/>
+                        </a:rPr>
+                        <a:t>-3.1%</a:t>
+                      </a:r>
+                    </a:p>
+                  </a:txBody>
+                  <a:tcPr marL="36576" marR="36576" marT="18288" marB="18288">
+                    <a:solidFill>
+                      <a:srgbClr val="FFFFFF"/>
+                    </a:solidFill>
+                  </a:tcPr>
+                </a:tc>
+                <a:tc>
+                  <a:txBody>
+                    <a:bodyPr/>
+                    <a:lstStyle/>
+                    <a:p>
+                      <a:pPr algn="r"/>
+                      <a:r>
+                        <a:rPr sz="1000">
+                          <a:solidFill>
+                            <a:srgbClr val="3F3F3F"/>
+                          </a:solidFill>
+                          <a:latin typeface="Encode Sans"/>
+                        </a:rPr>
+                        <a:t>-2.8%</a:t>
+                      </a:r>
+                    </a:p>
+                  </a:txBody>
+                  <a:tcPr marL="36576" marR="36576" marT="18288" marB="18288">
+                    <a:solidFill>
+                      <a:srgbClr val="FFFFFF"/>
+                    </a:solidFill>
+                  </a:tcPr>
+                </a:tc>
+              </a:tr>
+              <a:tr h="292608">
+                <a:tc>
+                  <a:txBody>
+                    <a:bodyPr/>
+                    <a:lstStyle/>
+                    <a:p>
+                      <a:pPr algn="l"/>
+                      <a:r>
+                        <a:rPr sz="1000">
+                          <a:solidFill>
+                            <a:srgbClr val="3F3F3F"/>
+                          </a:solidFill>
+                          <a:latin typeface="Encode Sans"/>
+                        </a:rPr>
+                        <a:t>Mayo 2026</a:t>
+                      </a:r>
+                    </a:p>
+                  </a:txBody>
+                  <a:tcPr marL="36576" marR="36576" marT="18288" marB="18288">
+                    <a:solidFill>
+                      <a:srgbClr val="F8F8F6"/>
+                    </a:solidFill>
+                  </a:tcPr>
+                </a:tc>
+                <a:tc>
+                  <a:txBody>
+                    <a:bodyPr/>
+                    <a:lstStyle/>
+                    <a:p>
+                      <a:pPr algn="r"/>
+                      <a:r>
+                        <a:rPr sz="1000">
+                          <a:solidFill>
+                            <a:srgbClr val="3F3F3F"/>
+                          </a:solidFill>
+                          <a:latin typeface="Encode Sans"/>
+                        </a:rPr>
+                        <a:t>80,5</a:t>
+                      </a:r>
+                    </a:p>
+                  </a:txBody>
+                  <a:tcPr marL="36576" marR="36576" marT="18288" marB="18288">
+                    <a:solidFill>
+                      <a:srgbClr val="F8F8F6"/>
+                    </a:solidFill>
+                  </a:tcPr>
+                </a:tc>
+                <a:tc>
+                  <a:txBody>
+                    <a:bodyPr/>
+                    <a:lstStyle/>
+                    <a:p>
+                      <a:pPr algn="r"/>
+                      <a:r>
+                        <a:rPr sz="1000">
+                          <a:solidFill>
+                            <a:srgbClr val="3F3F3F"/>
+                          </a:solidFill>
+                          <a:latin typeface="Encode Sans"/>
+                        </a:rPr>
+                        <a:t>-0.7%</a:t>
+                      </a:r>
+                    </a:p>
+                  </a:txBody>
+                  <a:tcPr marL="36576" marR="36576" marT="18288" marB="18288">
+                    <a:solidFill>
+                      <a:srgbClr val="F8F8F6"/>
+                    </a:solidFill>
+                  </a:tcPr>
+                </a:tc>
+                <a:tc>
+                  <a:txBody>
+                    <a:bodyPr/>
+                    <a:lstStyle/>
+                    <a:p>
+                      <a:pPr algn="r"/>
+                      <a:r>
+                        <a:rPr sz="1000">
+                          <a:solidFill>
+                            <a:srgbClr val="3F3F3F"/>
+                          </a:solidFill>
+                          <a:latin typeface="Encode Sans"/>
+                        </a:rPr>
+                        <a:t>-2.8%</a:t>
+                      </a:r>
+                    </a:p>
+                  </a:txBody>
+                  <a:tcPr marL="36576" marR="36576" marT="18288" marB="18288">
+                    <a:solidFill>
+                      <a:srgbClr val="F8F8F6"/>
+                    </a:solidFill>
+                  </a:tcPr>
+                </a:tc>
+              </a:tr>
+              <a:tr h="292608">
+                <a:tc>
+                  <a:txBody>
+                    <a:bodyPr/>
+                    <a:lstStyle/>
+                    <a:p>
+                      <a:pPr algn="l"/>
+                      <a:r>
+                        <a:rPr sz="1000">
+                          <a:solidFill>
+                            <a:srgbClr val="3F3F3F"/>
+                          </a:solidFill>
+                          <a:latin typeface="Encode Sans"/>
+                        </a:rPr>
+                        <a:t>Abril 2026</a:t>
+                      </a:r>
+                    </a:p>
+                  </a:txBody>
+                  <a:tcPr marL="36576" marR="36576" marT="18288" marB="18288">
+                    <a:solidFill>
+                      <a:srgbClr val="FFFFFF"/>
+                    </a:solidFill>
+                  </a:tcPr>
+                </a:tc>
+                <a:tc>
+                  <a:txBody>
+                    <a:bodyPr/>
+                    <a:lstStyle/>
+                    <a:p>
+                      <a:pPr algn="r"/>
+                      <a:r>
+                        <a:rPr sz="1000">
+                          <a:solidFill>
+                            <a:srgbClr val="3F3F3F"/>
+                          </a:solidFill>
+                          <a:latin typeface="Encode Sans"/>
+                        </a:rPr>
+                        <a:t>78,5</a:t>
+                      </a:r>
+                    </a:p>
+                  </a:txBody>
+                  <a:tcPr marL="36576" marR="36576" marT="18288" marB="18288">
+                    <a:solidFill>
+                      <a:srgbClr val="FFFFFF"/>
+                    </a:solidFill>
+                  </a:tcPr>
+                </a:tc>
+                <a:tc>
+                  <a:txBody>
+                    <a:bodyPr/>
+                    <a:lstStyle/>
+                    <a:p>
+                      <a:pPr algn="r"/>
+                      <a:r>
+                        <a:rPr sz="1000">
+                          <a:solidFill>
+                            <a:srgbClr val="3F3F3F"/>
+                          </a:solidFill>
+                          <a:latin typeface="Encode Sans"/>
+                        </a:rPr>
+                        <a:t>-3.7%</a:t>
+                      </a:r>
+                    </a:p>
+                  </a:txBody>
+                  <a:tcPr marL="36576" marR="36576" marT="18288" marB="18288">
+                    <a:solidFill>
+                      <a:srgbClr val="FFFFFF"/>
+                    </a:solidFill>
+                  </a:tcPr>
+                </a:tc>
+                <a:tc>
+                  <a:txBody>
+                    <a:bodyPr/>
+                    <a:lstStyle/>
+                    <a:p>
+                      <a:pPr algn="r"/>
+                      <a:r>
+                        <a:rPr sz="1000">
+                          <a:solidFill>
+                            <a:srgbClr val="3F3F3F"/>
+                          </a:solidFill>
+                          <a:latin typeface="Encode Sans"/>
+                        </a:rPr>
+                        <a:t>-3.3%</a:t>
+                      </a:r>
+                    </a:p>
+                  </a:txBody>
+                  <a:tcPr marL="36576" marR="36576" marT="18288" marB="18288">
+                    <a:solidFill>
+                      <a:srgbClr val="FFFFFF"/>
+                    </a:solidFill>
+                  </a:tcPr>
+                </a:tc>
+              </a:tr>
+              <a:tr h="292608">
+                <a:tc>
+                  <a:txBody>
+                    <a:bodyPr/>
+                    <a:lstStyle/>
+                    <a:p>
+                      <a:pPr algn="l"/>
+                      <a:r>
+                        <a:rPr sz="1000">
+                          <a:solidFill>
+                            <a:srgbClr val="3F3F3F"/>
+                          </a:solidFill>
+                          <a:latin typeface="Encode Sans"/>
+                        </a:rPr>
+                        <a:t>Marzo 2026</a:t>
+                      </a:r>
+                    </a:p>
+                  </a:txBody>
+                  <a:tcPr marL="36576" marR="36576" marT="18288" marB="18288">
+                    <a:solidFill>
+                      <a:srgbClr val="F8F8F6"/>
+                    </a:solidFill>
+                  </a:tcPr>
+                </a:tc>
+                <a:tc>
+                  <a:txBody>
+                    <a:bodyPr/>
+                    <a:lstStyle/>
+                    <a:p>
+                      <a:pPr algn="r"/>
+                      <a:r>
+                        <a:rPr sz="1000">
+                          <a:solidFill>
+                            <a:srgbClr val="3F3F3F"/>
+                          </a:solidFill>
+                          <a:latin typeface="Encode Sans"/>
+                        </a:rPr>
+                        <a:t>82,4</a:t>
+                      </a:r>
+                    </a:p>
+                  </a:txBody>
+                  <a:tcPr marL="36576" marR="36576" marT="18288" marB="18288">
+                    <a:solidFill>
+                      <a:srgbClr val="F8F8F6"/>
+                    </a:solidFill>
+                  </a:tcPr>
+                </a:tc>
+                <a:tc>
+                  <a:txBody>
+                    <a:bodyPr/>
+                    <a:lstStyle/>
+                    <a:p>
+                      <a:pPr algn="r"/>
+                      <a:r>
+                        <a:rPr sz="1000">
+                          <a:solidFill>
+                            <a:srgbClr val="3F3F3F"/>
+                          </a:solidFill>
+                          <a:latin typeface="Encode Sans"/>
+                        </a:rPr>
+                        <a:t>-5.1%</a:t>
+                      </a:r>
+                    </a:p>
+                  </a:txBody>
+                  <a:tcPr marL="36576" marR="36576" marT="18288" marB="18288">
+                    <a:solidFill>
+                      <a:srgbClr val="F8F8F6"/>
+                    </a:solidFill>
+                  </a:tcPr>
+                </a:tc>
+                <a:tc>
+                  <a:txBody>
+                    <a:bodyPr/>
+                    <a:lstStyle/>
+                    <a:p>
+                      <a:pPr algn="r"/>
+                      <a:r>
+                        <a:rPr sz="1000">
+                          <a:solidFill>
+                            <a:srgbClr val="3F3F3F"/>
+                          </a:solidFill>
+                          <a:latin typeface="Encode Sans"/>
+                        </a:rPr>
+                        <a:t>-3.1%</a:t>
+                      </a:r>
+                    </a:p>
+                  </a:txBody>
+                  <a:tcPr marL="36576" marR="36576" marT="18288" marB="18288">
+                    <a:solidFill>
+                      <a:srgbClr val="F8F8F6"/>
+                    </a:solidFill>
+                  </a:tcPr>
+                </a:tc>
+              </a:tr>
+              <a:tr h="292608">
+                <a:tc>
+                  <a:txBody>
+                    <a:bodyPr/>
+                    <a:lstStyle/>
+                    <a:p>
+                      <a:pPr algn="l"/>
+                      <a:r>
+                        <a:rPr sz="1000">
+                          <a:solidFill>
+                            <a:srgbClr val="3F3F3F"/>
+                          </a:solidFill>
+                          <a:latin typeface="Encode Sans"/>
+                        </a:rPr>
+                        <a:t>Febrero 2026</a:t>
+                      </a:r>
+                    </a:p>
+                  </a:txBody>
+                  <a:tcPr marL="36576" marR="36576" marT="18288" marB="18288">
+                    <a:solidFill>
+                      <a:srgbClr val="FFFFFF"/>
+                    </a:solidFill>
+                  </a:tcPr>
+                </a:tc>
+                <a:tc>
+                  <a:txBody>
+                    <a:bodyPr/>
+                    <a:lstStyle/>
+                    <a:p>
+                      <a:pPr algn="r"/>
+                      <a:r>
+                        <a:rPr sz="1000">
+                          <a:solidFill>
+                            <a:srgbClr val="3F3F3F"/>
+                          </a:solidFill>
+                          <a:latin typeface="Encode Sans"/>
+                        </a:rPr>
+                        <a:t>76,0</a:t>
+                      </a:r>
+                    </a:p>
+                  </a:txBody>
+                  <a:tcPr marL="36576" marR="36576" marT="18288" marB="18288">
+                    <a:solidFill>
+                      <a:srgbClr val="FFFFFF"/>
+                    </a:solidFill>
+                  </a:tcPr>
+                </a:tc>
+                <a:tc>
+                  <a:txBody>
+                    <a:bodyPr/>
+                    <a:lstStyle/>
+                    <a:p>
+                      <a:pPr algn="r"/>
+                      <a:r>
+                        <a:rPr sz="1000">
+                          <a:solidFill>
+                            <a:srgbClr val="3F3F3F"/>
+                          </a:solidFill>
+                          <a:latin typeface="Encode Sans"/>
+                        </a:rPr>
+                        <a:t>-3.1%</a:t>
+                      </a:r>
+                    </a:p>
+                  </a:txBody>
+                  <a:tcPr marL="36576" marR="36576" marT="18288" marB="18288">
+                    <a:solidFill>
+                      <a:srgbClr val="FFFFFF"/>
+                    </a:solidFill>
+                  </a:tcPr>
+                </a:tc>
+                <a:tc>
+                  <a:txBody>
+                    <a:bodyPr/>
+                    <a:lstStyle/>
+                    <a:p>
+                      <a:pPr algn="r"/>
+                      <a:r>
+                        <a:rPr sz="1000">
+                          <a:solidFill>
+                            <a:srgbClr val="3F3F3F"/>
+                          </a:solidFill>
+                          <a:latin typeface="Encode Sans"/>
+                        </a:rPr>
+                        <a:t>-2.1%</a:t>
+                      </a:r>
+                    </a:p>
+                  </a:txBody>
+                  <a:tcPr marL="36576" marR="36576" marT="18288" marB="18288">
+                    <a:solidFill>
+                      <a:srgbClr val="FFFFFF"/>
+                    </a:solidFill>
+                  </a:tcPr>
+                </a:tc>
+              </a:tr>
+              <a:tr h="292608">
+                <a:tc>
+                  <a:txBody>
+                    <a:bodyPr/>
+                    <a:lstStyle/>
+                    <a:p>
+                      <a:pPr algn="l"/>
+                      <a:r>
+                        <a:rPr sz="1000">
+                          <a:solidFill>
+                            <a:srgbClr val="3F3F3F"/>
+                          </a:solidFill>
+                          <a:latin typeface="Encode Sans"/>
+                        </a:rPr>
+                        <a:t>Enero 2026</a:t>
+                      </a:r>
+                    </a:p>
+                  </a:txBody>
+                  <a:tcPr marL="36576" marR="36576" marT="18288" marB="18288">
+                    <a:solidFill>
+                      <a:srgbClr val="F8F8F6"/>
+                    </a:solidFill>
+                  </a:tcPr>
+                </a:tc>
+                <a:tc>
+                  <a:txBody>
+                    <a:bodyPr/>
+                    <a:lstStyle/>
+                    <a:p>
+                      <a:pPr algn="r"/>
+                      <a:r>
+                        <a:rPr sz="1000">
+                          <a:solidFill>
+                            <a:srgbClr val="3F3F3F"/>
+                          </a:solidFill>
+                          <a:latin typeface="Encode Sans"/>
+                        </a:rPr>
+                        <a:t>82,8</a:t>
+                      </a:r>
+                    </a:p>
+                  </a:txBody>
+                  <a:tcPr marL="36576" marR="36576" marT="18288" marB="18288">
+                    <a:solidFill>
+                      <a:srgbClr val="F8F8F6"/>
+                    </a:solidFill>
+                  </a:tcPr>
+                </a:tc>
+                <a:tc>
+                  <a:txBody>
+                    <a:bodyPr/>
+                    <a:lstStyle/>
+                    <a:p>
+                      <a:pPr algn="r"/>
+                      <a:r>
+                        <a:rPr sz="1000">
+                          <a:solidFill>
+                            <a:srgbClr val="3F3F3F"/>
+                          </a:solidFill>
+                          <a:latin typeface="Encode Sans"/>
+                        </a:rPr>
+                        <a:t>-1.2%</a:t>
+                      </a:r>
+                    </a:p>
+                  </a:txBody>
+                  <a:tcPr marL="36576" marR="36576" marT="18288" marB="18288">
+                    <a:solidFill>
+                      <a:srgbClr val="F8F8F6"/>
+                    </a:solidFill>
+                  </a:tcPr>
+                </a:tc>
+                <a:tc>
+                  <a:txBody>
+                    <a:bodyPr/>
+                    <a:lstStyle/>
+                    <a:p>
+                      <a:pPr algn="r"/>
+                      <a:r>
+                        <a:rPr sz="1000">
+                          <a:solidFill>
+                            <a:srgbClr val="3F3F3F"/>
+                          </a:solidFill>
+                          <a:latin typeface="Encode Sans"/>
+                        </a:rPr>
+                        <a:t>-1.2%</a:t>
                       </a:r>
                     </a:p>
                   </a:txBody>

</xml_diff>

<commit_message>
data: update 2026-09-03 ( data.json despidos.json scraper/historical_despidos.json publicaciones_semana.pptx rrii_brutas.xlsx)
</commit_message>
<xml_diff>
--- a/publicaciones_semana.pptx
+++ b/publicaciones_semana.pptx
@@ -7,7 +7,6 @@
   <p:sldIdLst>
     <p:sldId id="256" r:id="rId7"/>
     <p:sldId id="257" r:id="rId8"/>
-    <p:sldId id="258" r:id="rId9"/>
   </p:sldIdLst>
   <p:sldSz cx="12191695" cy="6858000" type="screen4x3"/>
   <p:notesSz cx="6858000" cy="9144000"/>
@@ -3239,7 +3238,7 @@
                 </a:solidFill>
                 <a:latin typeface="Encode Sans"/>
               </a:rPr>
-              <a:t>Publicaciones de la semana del 24 de agosto de 2026</a:t>
+              <a:t>Publicaciones de la semana del 31 de agosto de 2026</a:t>
             </a:r>
           </a:p>
         </p:txBody>
@@ -3273,7 +3272,7 @@
                 </a:solidFill>
                 <a:latin typeface="Encode Sans"/>
               </a:rPr>
-              <a:t>2 publicaciones · datos oficiales INDEC / BCRA / Hacienda</a:t>
+              <a:t>1 publicaciones · datos oficiales INDEC / BCRA / Hacienda</a:t>
             </a:r>
           </a:p>
         </p:txBody>
@@ -3369,7 +3368,7 @@
                 </a:solidFill>
                 <a:latin typeface="Encode Sans"/>
               </a:rPr>
-              <a:t>TURISMO INTERNACIONAL JULIO 2026: SALDO -230.916 PERSONAS</a:t>
+              <a:t>RECAUDACIÓN AGOSTO 2026: CRECIÓ +3.8% REAL I.A.</a:t>
             </a:r>
           </a:p>
         </p:txBody>
@@ -3403,7 +3402,7 @@
                 </a:solidFill>
                 <a:latin typeface="Encode Sans"/>
               </a:rPr>
-              <a:t>INDEC · período 2026-07</a:t>
+              <a:t>AFIP/ARCA · período 2026-08</a:t>
             </a:r>
           </a:p>
         </p:txBody>
@@ -3438,7 +3437,7 @@
                 </a:solidFill>
                 <a:latin typeface="Encode Sans"/>
               </a:rPr>
-              <a:t>En julio 2026 ingresaron 466.234 turistas no residentes y salieron 697.150 argentinos al exterior, con saldo de -230.916 personas. Receptivo +9.1% i.a., emisivo -17.3% i.a.</a:t>
+              <a:t>AFIP/ARCA recaudó $20.509K millones en agosto 2026. Variación nominal interanual: +33.5%. En términos reales (deflactado por REM): +3.8% i.a. Quiebre de tendencia: venía con 6 meses de caída real interanual.</a:t>
             </a:r>
           </a:p>
         </p:txBody>
@@ -3486,7 +3485,7 @@
                 </a:solidFill>
                 <a:latin typeface="Encode Sans"/>
               </a:rPr>
-              <a:t>Receptivo: 466.234 personas</a:t>
+              <a:t>Total: $20.509K M$</a:t>
             </a:r>
           </a:p>
           <a:p>
@@ -3511,7 +3510,7 @@
                 </a:solidFill>
                 <a:latin typeface="Encode Sans"/>
               </a:rPr>
-              <a:t>Emisivo: 697.150 personas</a:t>
+              <a:t>Variación nominal i.a.: +33.5%</a:t>
             </a:r>
           </a:p>
           <a:p>
@@ -3536,7 +3535,7 @@
                 </a:solidFill>
                 <a:latin typeface="Encode Sans"/>
               </a:rPr>
-              <a:t>Saldo (receptivo − emisivo): -230.916 personas</a:t>
+              <a:t>Variación real i.a.: +3.8% (deflactor: REM)</a:t>
             </a:r>
           </a:p>
           <a:p>
@@ -3561,7 +3560,7 @@
                 </a:solidFill>
                 <a:latin typeface="Encode Sans"/>
               </a:rPr>
-              <a:t>Fuente: INDEC, Estadísticas de Turismo Internacional (todas las vías)</a:t>
+              <a:t>Fuente: ARCA (ex AFIP) · indec.gob.ar series</a:t>
             </a:r>
           </a:p>
         </p:txBody>
@@ -3651,7 +3650,7 @@
                           </a:solidFill>
                           <a:latin typeface="Encode Sans"/>
                         </a:rPr>
-                        <a:t>Receptivo</a:t>
+                        <a:t>Total M$</a:t>
                       </a:r>
                     </a:p>
                   </a:txBody>
@@ -3674,7 +3673,7 @@
                           </a:solidFill>
                           <a:latin typeface="Encode Sans"/>
                         </a:rPr>
-                        <a:t>Emisivo</a:t>
+                        <a:t>Var. nom. i.a.</a:t>
                       </a:r>
                     </a:p>
                   </a:txBody>
@@ -3697,7 +3696,7 @@
                           </a:solidFill>
                           <a:latin typeface="Encode Sans"/>
                         </a:rPr>
-                        <a:t>Saldo</a:t>
+                        <a:t>Var. real i.a.</a:t>
                       </a:r>
                     </a:p>
                   </a:txBody>
@@ -3722,7 +3721,7 @@
                           </a:solidFill>
                           <a:latin typeface="Encode Sans"/>
                         </a:rPr>
-                        <a:t>Julio 2026</a:t>
+                        <a:t>Agosto 2026</a:t>
                       </a:r>
                     </a:p>
                   </a:txBody>
@@ -3745,7 +3744,7 @@
                           </a:solidFill>
                           <a:latin typeface="Encode Sans"/>
                         </a:rPr>
-                        <a:t>466.234</a:t>
+                        <a:t>20.509K</a:t>
                       </a:r>
                     </a:p>
                   </a:txBody>
@@ -3768,7 +3767,7 @@
                           </a:solidFill>
                           <a:latin typeface="Encode Sans"/>
                         </a:rPr>
-                        <a:t>697.150</a:t>
+                        <a:t>—</a:t>
                       </a:r>
                     </a:p>
                   </a:txBody>
@@ -3791,7 +3790,7 @@
                           </a:solidFill>
                           <a:latin typeface="Encode Sans"/>
                         </a:rPr>
-                        <a:t>-230.916</a:t>
+                        <a:t>—</a:t>
                       </a:r>
                     </a:p>
                   </a:txBody>
@@ -3816,7 +3815,7 @@
                           </a:solidFill>
                           <a:latin typeface="Encode Sans"/>
                         </a:rPr>
-                        <a:t>Junio 2026</a:t>
+                        <a:t>Julio 2026</a:t>
                       </a:r>
                     </a:p>
                   </a:txBody>
@@ -3839,7 +3838,7 @@
                           </a:solidFill>
                           <a:latin typeface="Encode Sans"/>
                         </a:rPr>
-                        <a:t>329.177</a:t>
+                        <a:t>22.965K</a:t>
                       </a:r>
                     </a:p>
                   </a:txBody>
@@ -3862,7 +3861,7 @@
                           </a:solidFill>
                           <a:latin typeface="Encode Sans"/>
                         </a:rPr>
-                        <a:t>501.918</a:t>
+                        <a:t>—</a:t>
                       </a:r>
                     </a:p>
                   </a:txBody>
@@ -3885,7 +3884,7 @@
                           </a:solidFill>
                           <a:latin typeface="Encode Sans"/>
                         </a:rPr>
-                        <a:t>-172.741</a:t>
+                        <a:t>—</a:t>
                       </a:r>
                     </a:p>
                   </a:txBody>
@@ -3910,7 +3909,7 @@
                           </a:solidFill>
                           <a:latin typeface="Encode Sans"/>
                         </a:rPr>
-                        <a:t>Mayo 2026</a:t>
+                        <a:t>Junio 2026</a:t>
                       </a:r>
                     </a:p>
                   </a:txBody>
@@ -3933,7 +3932,7 @@
                           </a:solidFill>
                           <a:latin typeface="Encode Sans"/>
                         </a:rPr>
-                        <a:t>379.860</a:t>
+                        <a:t>20.017K</a:t>
                       </a:r>
                     </a:p>
                   </a:txBody>
@@ -3956,7 +3955,7 @@
                           </a:solidFill>
                           <a:latin typeface="Encode Sans"/>
                         </a:rPr>
-                        <a:t>661.853</a:t>
+                        <a:t>—</a:t>
                       </a:r>
                     </a:p>
                   </a:txBody>
@@ -3979,7 +3978,7 @@
                           </a:solidFill>
                           <a:latin typeface="Encode Sans"/>
                         </a:rPr>
-                        <a:t>-281.993</a:t>
+                        <a:t>—</a:t>
                       </a:r>
                     </a:p>
                   </a:txBody>
@@ -4004,7 +4003,7 @@
                           </a:solidFill>
                           <a:latin typeface="Encode Sans"/>
                         </a:rPr>
-                        <a:t>Abril 2026</a:t>
+                        <a:t>Mayo 2026</a:t>
                       </a:r>
                     </a:p>
                   </a:txBody>
@@ -4027,7 +4026,7 @@
                           </a:solidFill>
                           <a:latin typeface="Encode Sans"/>
                         </a:rPr>
-                        <a:t>463.072</a:t>
+                        <a:t>21.514K</a:t>
                       </a:r>
                     </a:p>
                   </a:txBody>
@@ -4050,7 +4049,7 @@
                           </a:solidFill>
                           <a:latin typeface="Encode Sans"/>
                         </a:rPr>
-                        <a:t>764.757</a:t>
+                        <a:t>—</a:t>
                       </a:r>
                     </a:p>
                   </a:txBody>
@@ -4073,7 +4072,7 @@
                           </a:solidFill>
                           <a:latin typeface="Encode Sans"/>
                         </a:rPr>
-                        <a:t>-301.685</a:t>
+                        <a:t>—</a:t>
                       </a:r>
                     </a:p>
                   </a:txBody>
@@ -4098,7 +4097,7 @@
                           </a:solidFill>
                           <a:latin typeface="Encode Sans"/>
                         </a:rPr>
-                        <a:t>Marzo 2026</a:t>
+                        <a:t>Abril 2026</a:t>
                       </a:r>
                     </a:p>
                   </a:txBody>
@@ -4121,7 +4120,7 @@
                           </a:solidFill>
                           <a:latin typeface="Encode Sans"/>
                         </a:rPr>
-                        <a:t>509.625</a:t>
+                        <a:t>17.401K</a:t>
                       </a:r>
                     </a:p>
                   </a:txBody>
@@ -4144,7 +4143,7 @@
                           </a:solidFill>
                           <a:latin typeface="Encode Sans"/>
                         </a:rPr>
-                        <a:t>1.061.777</a:t>
+                        <a:t>—</a:t>
                       </a:r>
                     </a:p>
                   </a:txBody>
@@ -4167,7 +4166,7 @@
                           </a:solidFill>
                           <a:latin typeface="Encode Sans"/>
                         </a:rPr>
-                        <a:t>-552.152</a:t>
+                        <a:t>—</a:t>
                       </a:r>
                     </a:p>
                   </a:txBody>
@@ -4192,7 +4191,7 @@
                           </a:solidFill>
                           <a:latin typeface="Encode Sans"/>
                         </a:rPr>
-                        <a:t>Febrero 2026</a:t>
+                        <a:t>Marzo 2026</a:t>
                       </a:r>
                     </a:p>
                   </a:txBody>
@@ -4215,7 +4214,7 @@
                           </a:solidFill>
                           <a:latin typeface="Encode Sans"/>
                         </a:rPr>
-                        <a:t>534.223</a:t>
+                        <a:t>16.071K</a:t>
                       </a:r>
                     </a:p>
                   </a:txBody>
@@ -4238,7 +4237,7 @@
                           </a:solidFill>
                           <a:latin typeface="Encode Sans"/>
                         </a:rPr>
-                        <a:t>1.629.180</a:t>
+                        <a:t>26.21%</a:t>
                       </a:r>
                     </a:p>
                   </a:txBody>
@@ -4261,7 +4260,7 @@
                           </a:solidFill>
                           <a:latin typeface="Encode Sans"/>
                         </a:rPr>
-                        <a:t>-1.094.957</a:t>
+                        <a:t>—</a:t>
                       </a:r>
                     </a:p>
                   </a:txBody>
@@ -4305,1039 +4304,7 @@
                 </a:solidFill>
                 <a:latin typeface="Encode Sans"/>
               </a:rPr>
-              <a:t>Fuente: elaboración propia en base a INDEC</a:t>
-            </a:r>
-          </a:p>
-        </p:txBody>
-      </p:sp>
-    </p:spTree>
-  </p:cSld>
-  <p:clrMapOvr>
-    <a:masterClrMapping/>
-  </p:clrMapOvr>
-</p:sld>
-</file>
-
-<file path=ppt/slides/slide3.xml><?xml version="1.0" encoding="utf-8"?>
-<p:sld xmlns:a="http://schemas.openxmlformats.org/drawingml/2006/main" xmlns:p="http://schemas.openxmlformats.org/presentationml/2006/main" xmlns:r="http://schemas.openxmlformats.org/officeDocument/2006/relationships">
-  <p:cSld>
-    <p:spTree>
-      <p:nvGrpSpPr>
-        <p:cNvPr id="1" name=""/>
-        <p:cNvGrpSpPr/>
-        <p:nvPr/>
-      </p:nvGrpSpPr>
-      <p:grpSpPr/>
-      <p:sp>
-        <p:nvSpPr>
-          <p:cNvPr id="2" name="Rectangle 1"/>
-          <p:cNvSpPr/>
-          <p:nvPr/>
-        </p:nvSpPr>
-        <p:spPr>
-          <a:xfrm>
-            <a:off x="0" y="0"/>
-            <a:ext cx="12191695" cy="274320"/>
-          </a:xfrm>
-          <a:prstGeom prst="rect">
-            <a:avLst/>
-          </a:prstGeom>
-          <a:solidFill>
-            <a:srgbClr val="00B2C9"/>
-          </a:solidFill>
-          <a:ln>
-            <a:noFill/>
-          </a:ln>
-        </p:spPr>
-        <p:style>
-          <a:lnRef idx="1">
-            <a:schemeClr val="accent1"/>
-          </a:lnRef>
-          <a:fillRef idx="3">
-            <a:schemeClr val="accent1"/>
-          </a:fillRef>
-          <a:effectRef idx="2">
-            <a:schemeClr val="accent1"/>
-          </a:effectRef>
-          <a:fontRef idx="minor">
-            <a:schemeClr val="lt1"/>
-          </a:fontRef>
-        </p:style>
-        <p:txBody>
-          <a:bodyPr rtlCol="0" anchor="ctr"/>
-          <a:lstStyle/>
-          <a:p>
-            <a:pPr algn="ctr"/>
-          </a:p>
-        </p:txBody>
-      </p:sp>
-      <p:sp>
-        <p:nvSpPr>
-          <p:cNvPr id="3" name="TextBox 2"/>
-          <p:cNvSpPr txBox="1"/>
-          <p:nvPr/>
-        </p:nvSpPr>
-        <p:spPr>
-          <a:xfrm>
-            <a:off x="411480" y="457200"/>
-            <a:ext cx="11368735" cy="914400"/>
-          </a:xfrm>
-          <a:prstGeom prst="rect">
-            <a:avLst/>
-          </a:prstGeom>
-          <a:noFill/>
-        </p:spPr>
-        <p:txBody>
-          <a:bodyPr wrap="square" lIns="0" rIns="0">
-            <a:spAutoFit/>
-          </a:bodyPr>
-          <a:lstStyle/>
-          <a:p>
-            <a:pPr algn="l"/>
-            <a:r>
-              <a:rPr sz="2600" b="1" i="0">
-                <a:solidFill>
-                  <a:srgbClr val="00B2C9"/>
-                </a:solidFill>
-                <a:latin typeface="Encode Sans"/>
-              </a:rPr>
-              <a:t>TURISMO INTERNACIONAL JUNIO 2026: SALDO -172.741 PERSONAS</a:t>
-            </a:r>
-          </a:p>
-        </p:txBody>
-      </p:sp>
-      <p:sp>
-        <p:nvSpPr>
-          <p:cNvPr id="4" name="TextBox 3"/>
-          <p:cNvSpPr txBox="1"/>
-          <p:nvPr/>
-        </p:nvSpPr>
-        <p:spPr>
-          <a:xfrm>
-            <a:off x="411480" y="1280160"/>
-            <a:ext cx="11368735" cy="274320"/>
-          </a:xfrm>
-          <a:prstGeom prst="rect">
-            <a:avLst/>
-          </a:prstGeom>
-          <a:noFill/>
-        </p:spPr>
-        <p:txBody>
-          <a:bodyPr wrap="none">
-            <a:spAutoFit/>
-          </a:bodyPr>
-          <a:lstStyle/>
-          <a:p>
-            <a:r>
-              <a:rPr sz="1100" b="0" i="1">
-                <a:solidFill>
-                  <a:srgbClr val="6A6760"/>
-                </a:solidFill>
-                <a:latin typeface="Encode Sans"/>
-              </a:rPr>
-              <a:t>INDEC · período 2026-06</a:t>
-            </a:r>
-          </a:p>
-        </p:txBody>
-      </p:sp>
-      <p:sp>
-        <p:nvSpPr>
-          <p:cNvPr id="5" name="TextBox 4"/>
-          <p:cNvSpPr txBox="1"/>
-          <p:nvPr/>
-        </p:nvSpPr>
-        <p:spPr>
-          <a:xfrm>
-            <a:off x="411480" y="1691640"/>
-            <a:ext cx="5486400" cy="1645920"/>
-          </a:xfrm>
-          <a:prstGeom prst="rect">
-            <a:avLst/>
-          </a:prstGeom>
-          <a:noFill/>
-        </p:spPr>
-        <p:txBody>
-          <a:bodyPr wrap="square" lIns="0" rIns="0">
-            <a:spAutoFit/>
-          </a:bodyPr>
-          <a:lstStyle/>
-          <a:p>
-            <a:pPr algn="just"/>
-            <a:r>
-              <a:rPr sz="1300" b="0" i="0">
-                <a:solidFill>
-                  <a:srgbClr val="3F3F3F"/>
-                </a:solidFill>
-                <a:latin typeface="Encode Sans"/>
-              </a:rPr>
-              <a:t>En junio 2026 ingresaron 329.177 turistas no residentes y salieron 501.918 argentinos al exterior, con saldo de -172.741 personas. Receptivo +3.3% i.a., emisivo -22.0% i.a.</a:t>
-            </a:r>
-          </a:p>
-        </p:txBody>
-      </p:sp>
-      <p:sp>
-        <p:nvSpPr>
-          <p:cNvPr id="6" name="TextBox 5"/>
-          <p:cNvSpPr txBox="1"/>
-          <p:nvPr/>
-        </p:nvSpPr>
-        <p:spPr>
-          <a:xfrm>
-            <a:off x="411480" y="3520440"/>
-            <a:ext cx="5486400" cy="2743200"/>
-          </a:xfrm>
-          <a:prstGeom prst="rect">
-            <a:avLst/>
-          </a:prstGeom>
-          <a:noFill/>
-        </p:spPr>
-        <p:txBody>
-          <a:bodyPr wrap="square" lIns="0" rIns="0">
-            <a:spAutoFit/>
-          </a:bodyPr>
-          <a:lstStyle/>
-          <a:p>
-            <a:pPr algn="l">
-              <a:spcAft>
-                <a:spcPts val="800"/>
-              </a:spcAft>
-            </a:pPr>
-            <a:r>
-              <a:rPr sz="1300" b="1" i="0">
-                <a:solidFill>
-                  <a:srgbClr val="00B2C9"/>
-                </a:solidFill>
-                <a:latin typeface="Encode Sans"/>
-              </a:rPr>
-              <a:t>●  </a:t>
-            </a:r>
-            <a:r>
-              <a:rPr sz="1300" b="0" i="0">
-                <a:solidFill>
-                  <a:srgbClr val="3F3F3F"/>
-                </a:solidFill>
-                <a:latin typeface="Encode Sans"/>
-              </a:rPr>
-              <a:t>Receptivo: 329.177 personas</a:t>
-            </a:r>
-          </a:p>
-          <a:p>
-            <a:pPr algn="l">
-              <a:spcAft>
-                <a:spcPts val="800"/>
-              </a:spcAft>
-            </a:pPr>
-            <a:r>
-              <a:rPr sz="1300" b="1" i="0">
-                <a:solidFill>
-                  <a:srgbClr val="00B2C9"/>
-                </a:solidFill>
-                <a:latin typeface="Encode Sans"/>
-              </a:rPr>
-              <a:t>●  </a:t>
-            </a:r>
-            <a:r>
-              <a:rPr sz="1300" b="0" i="0">
-                <a:solidFill>
-                  <a:srgbClr val="3F3F3F"/>
-                </a:solidFill>
-                <a:latin typeface="Encode Sans"/>
-              </a:rPr>
-              <a:t>Emisivo: 501.918 personas</a:t>
-            </a:r>
-          </a:p>
-          <a:p>
-            <a:pPr algn="l">
-              <a:spcAft>
-                <a:spcPts val="800"/>
-              </a:spcAft>
-            </a:pPr>
-            <a:r>
-              <a:rPr sz="1300" b="1" i="0">
-                <a:solidFill>
-                  <a:srgbClr val="00B2C9"/>
-                </a:solidFill>
-                <a:latin typeface="Encode Sans"/>
-              </a:rPr>
-              <a:t>●  </a:t>
-            </a:r>
-            <a:r>
-              <a:rPr sz="1300" b="0" i="0">
-                <a:solidFill>
-                  <a:srgbClr val="3F3F3F"/>
-                </a:solidFill>
-                <a:latin typeface="Encode Sans"/>
-              </a:rPr>
-              <a:t>Saldo (receptivo − emisivo): -172.741 personas</a:t>
-            </a:r>
-          </a:p>
-          <a:p>
-            <a:pPr algn="l">
-              <a:spcAft>
-                <a:spcPts val="800"/>
-              </a:spcAft>
-            </a:pPr>
-            <a:r>
-              <a:rPr sz="1300" b="1" i="0">
-                <a:solidFill>
-                  <a:srgbClr val="00B2C9"/>
-                </a:solidFill>
-                <a:latin typeface="Encode Sans"/>
-              </a:rPr>
-              <a:t>●  </a:t>
-            </a:r>
-            <a:r>
-              <a:rPr sz="1300" b="0" i="0">
-                <a:solidFill>
-                  <a:srgbClr val="3F3F3F"/>
-                </a:solidFill>
-                <a:latin typeface="Encode Sans"/>
-              </a:rPr>
-              <a:t>Fuente: INDEC, Estadísticas de Turismo Internacional (todas las vías)</a:t>
-            </a:r>
-          </a:p>
-        </p:txBody>
-      </p:sp>
-      <p:pic>
-        <p:nvPicPr>
-          <p:cNvPr id="7" name="Picture 6" descr="image.png"/>
-          <p:cNvPicPr>
-            <a:picLocks noChangeAspect="1"/>
-          </p:cNvPicPr>
-          <p:nvPr/>
-        </p:nvPicPr>
-        <p:blipFill>
-          <a:blip r:embed="rId2"/>
-          <a:stretch>
-            <a:fillRect/>
-          </a:stretch>
-        </p:blipFill>
-        <p:spPr>
-          <a:xfrm>
-            <a:off x="6080760" y="1691640"/>
-            <a:ext cx="5669280" cy="2560320"/>
-          </a:xfrm>
-          <a:prstGeom prst="rect">
-            <a:avLst/>
-          </a:prstGeom>
-        </p:spPr>
-      </p:pic>
-      <p:graphicFrame>
-        <p:nvGraphicFramePr>
-          <p:cNvPr id="8" name="Table 7"/>
-          <p:cNvGraphicFramePr>
-            <a:graphicFrameLocks noGrp="1"/>
-          </p:cNvGraphicFramePr>
-          <p:nvPr/>
-        </p:nvGraphicFramePr>
-        <p:xfrm>
-          <a:off x="6080760" y="4434840"/>
-          <a:ext cx="5669280" cy="2048256"/>
-        </p:xfrm>
-        <a:graphic>
-          <a:graphicData uri="http://schemas.openxmlformats.org/drawingml/2006/table">
-            <a:tbl>
-              <a:tblPr firstRow="1" bandRow="1">
-                <a:tableStyleId>{5C22544A-7EE6-4342-B048-85BDC9FD1C3A}</a:tableStyleId>
-              </a:tblPr>
-              <a:tblGrid>
-                <a:gridCol w="1417320"/>
-                <a:gridCol w="1417320"/>
-                <a:gridCol w="1417320"/>
-                <a:gridCol w="1417320"/>
-              </a:tblGrid>
-              <a:tr h="292608">
-                <a:tc>
-                  <a:txBody>
-                    <a:bodyPr/>
-                    <a:lstStyle/>
-                    <a:p>
-                      <a:pPr algn="l"/>
-                      <a:r>
-                        <a:rPr sz="1000" b="1">
-                          <a:solidFill>
-                            <a:srgbClr val="FFFFFF"/>
-                          </a:solidFill>
-                          <a:latin typeface="Encode Sans"/>
-                        </a:rPr>
-                        <a:t>Mes</a:t>
-                      </a:r>
-                    </a:p>
-                  </a:txBody>
-                  <a:tcPr marL="36576" marR="36576" marT="18288" marB="18288">
-                    <a:solidFill>
-                      <a:srgbClr val="00B2C9"/>
-                    </a:solidFill>
-                  </a:tcPr>
-                </a:tc>
-                <a:tc>
-                  <a:txBody>
-                    <a:bodyPr/>
-                    <a:lstStyle/>
-                    <a:p>
-                      <a:pPr algn="r"/>
-                      <a:r>
-                        <a:rPr sz="1000" b="1">
-                          <a:solidFill>
-                            <a:srgbClr val="FFFFFF"/>
-                          </a:solidFill>
-                          <a:latin typeface="Encode Sans"/>
-                        </a:rPr>
-                        <a:t>Receptivo</a:t>
-                      </a:r>
-                    </a:p>
-                  </a:txBody>
-                  <a:tcPr marL="36576" marR="36576" marT="18288" marB="18288">
-                    <a:solidFill>
-                      <a:srgbClr val="00B2C9"/>
-                    </a:solidFill>
-                  </a:tcPr>
-                </a:tc>
-                <a:tc>
-                  <a:txBody>
-                    <a:bodyPr/>
-                    <a:lstStyle/>
-                    <a:p>
-                      <a:pPr algn="r"/>
-                      <a:r>
-                        <a:rPr sz="1000" b="1">
-                          <a:solidFill>
-                            <a:srgbClr val="FFFFFF"/>
-                          </a:solidFill>
-                          <a:latin typeface="Encode Sans"/>
-                        </a:rPr>
-                        <a:t>Emisivo</a:t>
-                      </a:r>
-                    </a:p>
-                  </a:txBody>
-                  <a:tcPr marL="36576" marR="36576" marT="18288" marB="18288">
-                    <a:solidFill>
-                      <a:srgbClr val="00B2C9"/>
-                    </a:solidFill>
-                  </a:tcPr>
-                </a:tc>
-                <a:tc>
-                  <a:txBody>
-                    <a:bodyPr/>
-                    <a:lstStyle/>
-                    <a:p>
-                      <a:pPr algn="r"/>
-                      <a:r>
-                        <a:rPr sz="1000" b="1">
-                          <a:solidFill>
-                            <a:srgbClr val="FFFFFF"/>
-                          </a:solidFill>
-                          <a:latin typeface="Encode Sans"/>
-                        </a:rPr>
-                        <a:t>Saldo</a:t>
-                      </a:r>
-                    </a:p>
-                  </a:txBody>
-                  <a:tcPr marL="36576" marR="36576" marT="18288" marB="18288">
-                    <a:solidFill>
-                      <a:srgbClr val="00B2C9"/>
-                    </a:solidFill>
-                  </a:tcPr>
-                </a:tc>
-              </a:tr>
-              <a:tr h="292608">
-                <a:tc>
-                  <a:txBody>
-                    <a:bodyPr/>
-                    <a:lstStyle/>
-                    <a:p>
-                      <a:pPr algn="l"/>
-                      <a:r>
-                        <a:rPr sz="1000">
-                          <a:solidFill>
-                            <a:srgbClr val="3F3F3F"/>
-                          </a:solidFill>
-                          <a:latin typeface="Encode Sans"/>
-                        </a:rPr>
-                        <a:t>Julio 2026</a:t>
-                      </a:r>
-                    </a:p>
-                  </a:txBody>
-                  <a:tcPr marL="36576" marR="36576" marT="18288" marB="18288">
-                    <a:solidFill>
-                      <a:srgbClr val="FFFFFF"/>
-                    </a:solidFill>
-                  </a:tcPr>
-                </a:tc>
-                <a:tc>
-                  <a:txBody>
-                    <a:bodyPr/>
-                    <a:lstStyle/>
-                    <a:p>
-                      <a:pPr algn="r"/>
-                      <a:r>
-                        <a:rPr sz="1000">
-                          <a:solidFill>
-                            <a:srgbClr val="3F3F3F"/>
-                          </a:solidFill>
-                          <a:latin typeface="Encode Sans"/>
-                        </a:rPr>
-                        <a:t>466.234</a:t>
-                      </a:r>
-                    </a:p>
-                  </a:txBody>
-                  <a:tcPr marL="36576" marR="36576" marT="18288" marB="18288">
-                    <a:solidFill>
-                      <a:srgbClr val="FFFFFF"/>
-                    </a:solidFill>
-                  </a:tcPr>
-                </a:tc>
-                <a:tc>
-                  <a:txBody>
-                    <a:bodyPr/>
-                    <a:lstStyle/>
-                    <a:p>
-                      <a:pPr algn="r"/>
-                      <a:r>
-                        <a:rPr sz="1000">
-                          <a:solidFill>
-                            <a:srgbClr val="3F3F3F"/>
-                          </a:solidFill>
-                          <a:latin typeface="Encode Sans"/>
-                        </a:rPr>
-                        <a:t>697.150</a:t>
-                      </a:r>
-                    </a:p>
-                  </a:txBody>
-                  <a:tcPr marL="36576" marR="36576" marT="18288" marB="18288">
-                    <a:solidFill>
-                      <a:srgbClr val="FFFFFF"/>
-                    </a:solidFill>
-                  </a:tcPr>
-                </a:tc>
-                <a:tc>
-                  <a:txBody>
-                    <a:bodyPr/>
-                    <a:lstStyle/>
-                    <a:p>
-                      <a:pPr algn="r"/>
-                      <a:r>
-                        <a:rPr sz="1000">
-                          <a:solidFill>
-                            <a:srgbClr val="3F3F3F"/>
-                          </a:solidFill>
-                          <a:latin typeface="Encode Sans"/>
-                        </a:rPr>
-                        <a:t>-230.916</a:t>
-                      </a:r>
-                    </a:p>
-                  </a:txBody>
-                  <a:tcPr marL="36576" marR="36576" marT="18288" marB="18288">
-                    <a:solidFill>
-                      <a:srgbClr val="FFFFFF"/>
-                    </a:solidFill>
-                  </a:tcPr>
-                </a:tc>
-              </a:tr>
-              <a:tr h="292608">
-                <a:tc>
-                  <a:txBody>
-                    <a:bodyPr/>
-                    <a:lstStyle/>
-                    <a:p>
-                      <a:pPr algn="l"/>
-                      <a:r>
-                        <a:rPr sz="1000">
-                          <a:solidFill>
-                            <a:srgbClr val="3F3F3F"/>
-                          </a:solidFill>
-                          <a:latin typeface="Encode Sans"/>
-                        </a:rPr>
-                        <a:t>Junio 2026</a:t>
-                      </a:r>
-                    </a:p>
-                  </a:txBody>
-                  <a:tcPr marL="36576" marR="36576" marT="18288" marB="18288">
-                    <a:solidFill>
-                      <a:srgbClr val="F8F8F6"/>
-                    </a:solidFill>
-                  </a:tcPr>
-                </a:tc>
-                <a:tc>
-                  <a:txBody>
-                    <a:bodyPr/>
-                    <a:lstStyle/>
-                    <a:p>
-                      <a:pPr algn="r"/>
-                      <a:r>
-                        <a:rPr sz="1000">
-                          <a:solidFill>
-                            <a:srgbClr val="3F3F3F"/>
-                          </a:solidFill>
-                          <a:latin typeface="Encode Sans"/>
-                        </a:rPr>
-                        <a:t>329.177</a:t>
-                      </a:r>
-                    </a:p>
-                  </a:txBody>
-                  <a:tcPr marL="36576" marR="36576" marT="18288" marB="18288">
-                    <a:solidFill>
-                      <a:srgbClr val="F8F8F6"/>
-                    </a:solidFill>
-                  </a:tcPr>
-                </a:tc>
-                <a:tc>
-                  <a:txBody>
-                    <a:bodyPr/>
-                    <a:lstStyle/>
-                    <a:p>
-                      <a:pPr algn="r"/>
-                      <a:r>
-                        <a:rPr sz="1000">
-                          <a:solidFill>
-                            <a:srgbClr val="3F3F3F"/>
-                          </a:solidFill>
-                          <a:latin typeface="Encode Sans"/>
-                        </a:rPr>
-                        <a:t>501.918</a:t>
-                      </a:r>
-                    </a:p>
-                  </a:txBody>
-                  <a:tcPr marL="36576" marR="36576" marT="18288" marB="18288">
-                    <a:solidFill>
-                      <a:srgbClr val="F8F8F6"/>
-                    </a:solidFill>
-                  </a:tcPr>
-                </a:tc>
-                <a:tc>
-                  <a:txBody>
-                    <a:bodyPr/>
-                    <a:lstStyle/>
-                    <a:p>
-                      <a:pPr algn="r"/>
-                      <a:r>
-                        <a:rPr sz="1000">
-                          <a:solidFill>
-                            <a:srgbClr val="3F3F3F"/>
-                          </a:solidFill>
-                          <a:latin typeface="Encode Sans"/>
-                        </a:rPr>
-                        <a:t>-172.741</a:t>
-                      </a:r>
-                    </a:p>
-                  </a:txBody>
-                  <a:tcPr marL="36576" marR="36576" marT="18288" marB="18288">
-                    <a:solidFill>
-                      <a:srgbClr val="F8F8F6"/>
-                    </a:solidFill>
-                  </a:tcPr>
-                </a:tc>
-              </a:tr>
-              <a:tr h="292608">
-                <a:tc>
-                  <a:txBody>
-                    <a:bodyPr/>
-                    <a:lstStyle/>
-                    <a:p>
-                      <a:pPr algn="l"/>
-                      <a:r>
-                        <a:rPr sz="1000">
-                          <a:solidFill>
-                            <a:srgbClr val="3F3F3F"/>
-                          </a:solidFill>
-                          <a:latin typeface="Encode Sans"/>
-                        </a:rPr>
-                        <a:t>Mayo 2026</a:t>
-                      </a:r>
-                    </a:p>
-                  </a:txBody>
-                  <a:tcPr marL="36576" marR="36576" marT="18288" marB="18288">
-                    <a:solidFill>
-                      <a:srgbClr val="FFFFFF"/>
-                    </a:solidFill>
-                  </a:tcPr>
-                </a:tc>
-                <a:tc>
-                  <a:txBody>
-                    <a:bodyPr/>
-                    <a:lstStyle/>
-                    <a:p>
-                      <a:pPr algn="r"/>
-                      <a:r>
-                        <a:rPr sz="1000">
-                          <a:solidFill>
-                            <a:srgbClr val="3F3F3F"/>
-                          </a:solidFill>
-                          <a:latin typeface="Encode Sans"/>
-                        </a:rPr>
-                        <a:t>379.860</a:t>
-                      </a:r>
-                    </a:p>
-                  </a:txBody>
-                  <a:tcPr marL="36576" marR="36576" marT="18288" marB="18288">
-                    <a:solidFill>
-                      <a:srgbClr val="FFFFFF"/>
-                    </a:solidFill>
-                  </a:tcPr>
-                </a:tc>
-                <a:tc>
-                  <a:txBody>
-                    <a:bodyPr/>
-                    <a:lstStyle/>
-                    <a:p>
-                      <a:pPr algn="r"/>
-                      <a:r>
-                        <a:rPr sz="1000">
-                          <a:solidFill>
-                            <a:srgbClr val="3F3F3F"/>
-                          </a:solidFill>
-                          <a:latin typeface="Encode Sans"/>
-                        </a:rPr>
-                        <a:t>661.853</a:t>
-                      </a:r>
-                    </a:p>
-                  </a:txBody>
-                  <a:tcPr marL="36576" marR="36576" marT="18288" marB="18288">
-                    <a:solidFill>
-                      <a:srgbClr val="FFFFFF"/>
-                    </a:solidFill>
-                  </a:tcPr>
-                </a:tc>
-                <a:tc>
-                  <a:txBody>
-                    <a:bodyPr/>
-                    <a:lstStyle/>
-                    <a:p>
-                      <a:pPr algn="r"/>
-                      <a:r>
-                        <a:rPr sz="1000">
-                          <a:solidFill>
-                            <a:srgbClr val="3F3F3F"/>
-                          </a:solidFill>
-                          <a:latin typeface="Encode Sans"/>
-                        </a:rPr>
-                        <a:t>-281.993</a:t>
-                      </a:r>
-                    </a:p>
-                  </a:txBody>
-                  <a:tcPr marL="36576" marR="36576" marT="18288" marB="18288">
-                    <a:solidFill>
-                      <a:srgbClr val="FFFFFF"/>
-                    </a:solidFill>
-                  </a:tcPr>
-                </a:tc>
-              </a:tr>
-              <a:tr h="292608">
-                <a:tc>
-                  <a:txBody>
-                    <a:bodyPr/>
-                    <a:lstStyle/>
-                    <a:p>
-                      <a:pPr algn="l"/>
-                      <a:r>
-                        <a:rPr sz="1000">
-                          <a:solidFill>
-                            <a:srgbClr val="3F3F3F"/>
-                          </a:solidFill>
-                          <a:latin typeface="Encode Sans"/>
-                        </a:rPr>
-                        <a:t>Abril 2026</a:t>
-                      </a:r>
-                    </a:p>
-                  </a:txBody>
-                  <a:tcPr marL="36576" marR="36576" marT="18288" marB="18288">
-                    <a:solidFill>
-                      <a:srgbClr val="F8F8F6"/>
-                    </a:solidFill>
-                  </a:tcPr>
-                </a:tc>
-                <a:tc>
-                  <a:txBody>
-                    <a:bodyPr/>
-                    <a:lstStyle/>
-                    <a:p>
-                      <a:pPr algn="r"/>
-                      <a:r>
-                        <a:rPr sz="1000">
-                          <a:solidFill>
-                            <a:srgbClr val="3F3F3F"/>
-                          </a:solidFill>
-                          <a:latin typeface="Encode Sans"/>
-                        </a:rPr>
-                        <a:t>463.072</a:t>
-                      </a:r>
-                    </a:p>
-                  </a:txBody>
-                  <a:tcPr marL="36576" marR="36576" marT="18288" marB="18288">
-                    <a:solidFill>
-                      <a:srgbClr val="F8F8F6"/>
-                    </a:solidFill>
-                  </a:tcPr>
-                </a:tc>
-                <a:tc>
-                  <a:txBody>
-                    <a:bodyPr/>
-                    <a:lstStyle/>
-                    <a:p>
-                      <a:pPr algn="r"/>
-                      <a:r>
-                        <a:rPr sz="1000">
-                          <a:solidFill>
-                            <a:srgbClr val="3F3F3F"/>
-                          </a:solidFill>
-                          <a:latin typeface="Encode Sans"/>
-                        </a:rPr>
-                        <a:t>764.757</a:t>
-                      </a:r>
-                    </a:p>
-                  </a:txBody>
-                  <a:tcPr marL="36576" marR="36576" marT="18288" marB="18288">
-                    <a:solidFill>
-                      <a:srgbClr val="F8F8F6"/>
-                    </a:solidFill>
-                  </a:tcPr>
-                </a:tc>
-                <a:tc>
-                  <a:txBody>
-                    <a:bodyPr/>
-                    <a:lstStyle/>
-                    <a:p>
-                      <a:pPr algn="r"/>
-                      <a:r>
-                        <a:rPr sz="1000">
-                          <a:solidFill>
-                            <a:srgbClr val="3F3F3F"/>
-                          </a:solidFill>
-                          <a:latin typeface="Encode Sans"/>
-                        </a:rPr>
-                        <a:t>-301.685</a:t>
-                      </a:r>
-                    </a:p>
-                  </a:txBody>
-                  <a:tcPr marL="36576" marR="36576" marT="18288" marB="18288">
-                    <a:solidFill>
-                      <a:srgbClr val="F8F8F6"/>
-                    </a:solidFill>
-                  </a:tcPr>
-                </a:tc>
-              </a:tr>
-              <a:tr h="292608">
-                <a:tc>
-                  <a:txBody>
-                    <a:bodyPr/>
-                    <a:lstStyle/>
-                    <a:p>
-                      <a:pPr algn="l"/>
-                      <a:r>
-                        <a:rPr sz="1000">
-                          <a:solidFill>
-                            <a:srgbClr val="3F3F3F"/>
-                          </a:solidFill>
-                          <a:latin typeface="Encode Sans"/>
-                        </a:rPr>
-                        <a:t>Marzo 2026</a:t>
-                      </a:r>
-                    </a:p>
-                  </a:txBody>
-                  <a:tcPr marL="36576" marR="36576" marT="18288" marB="18288">
-                    <a:solidFill>
-                      <a:srgbClr val="FFFFFF"/>
-                    </a:solidFill>
-                  </a:tcPr>
-                </a:tc>
-                <a:tc>
-                  <a:txBody>
-                    <a:bodyPr/>
-                    <a:lstStyle/>
-                    <a:p>
-                      <a:pPr algn="r"/>
-                      <a:r>
-                        <a:rPr sz="1000">
-                          <a:solidFill>
-                            <a:srgbClr val="3F3F3F"/>
-                          </a:solidFill>
-                          <a:latin typeface="Encode Sans"/>
-                        </a:rPr>
-                        <a:t>509.625</a:t>
-                      </a:r>
-                    </a:p>
-                  </a:txBody>
-                  <a:tcPr marL="36576" marR="36576" marT="18288" marB="18288">
-                    <a:solidFill>
-                      <a:srgbClr val="FFFFFF"/>
-                    </a:solidFill>
-                  </a:tcPr>
-                </a:tc>
-                <a:tc>
-                  <a:txBody>
-                    <a:bodyPr/>
-                    <a:lstStyle/>
-                    <a:p>
-                      <a:pPr algn="r"/>
-                      <a:r>
-                        <a:rPr sz="1000">
-                          <a:solidFill>
-                            <a:srgbClr val="3F3F3F"/>
-                          </a:solidFill>
-                          <a:latin typeface="Encode Sans"/>
-                        </a:rPr>
-                        <a:t>1.061.777</a:t>
-                      </a:r>
-                    </a:p>
-                  </a:txBody>
-                  <a:tcPr marL="36576" marR="36576" marT="18288" marB="18288">
-                    <a:solidFill>
-                      <a:srgbClr val="FFFFFF"/>
-                    </a:solidFill>
-                  </a:tcPr>
-                </a:tc>
-                <a:tc>
-                  <a:txBody>
-                    <a:bodyPr/>
-                    <a:lstStyle/>
-                    <a:p>
-                      <a:pPr algn="r"/>
-                      <a:r>
-                        <a:rPr sz="1000">
-                          <a:solidFill>
-                            <a:srgbClr val="3F3F3F"/>
-                          </a:solidFill>
-                          <a:latin typeface="Encode Sans"/>
-                        </a:rPr>
-                        <a:t>-552.152</a:t>
-                      </a:r>
-                    </a:p>
-                  </a:txBody>
-                  <a:tcPr marL="36576" marR="36576" marT="18288" marB="18288">
-                    <a:solidFill>
-                      <a:srgbClr val="FFFFFF"/>
-                    </a:solidFill>
-                  </a:tcPr>
-                </a:tc>
-              </a:tr>
-              <a:tr h="292608">
-                <a:tc>
-                  <a:txBody>
-                    <a:bodyPr/>
-                    <a:lstStyle/>
-                    <a:p>
-                      <a:pPr algn="l"/>
-                      <a:r>
-                        <a:rPr sz="1000">
-                          <a:solidFill>
-                            <a:srgbClr val="3F3F3F"/>
-                          </a:solidFill>
-                          <a:latin typeface="Encode Sans"/>
-                        </a:rPr>
-                        <a:t>Febrero 2026</a:t>
-                      </a:r>
-                    </a:p>
-                  </a:txBody>
-                  <a:tcPr marL="36576" marR="36576" marT="18288" marB="18288">
-                    <a:solidFill>
-                      <a:srgbClr val="F8F8F6"/>
-                    </a:solidFill>
-                  </a:tcPr>
-                </a:tc>
-                <a:tc>
-                  <a:txBody>
-                    <a:bodyPr/>
-                    <a:lstStyle/>
-                    <a:p>
-                      <a:pPr algn="r"/>
-                      <a:r>
-                        <a:rPr sz="1000">
-                          <a:solidFill>
-                            <a:srgbClr val="3F3F3F"/>
-                          </a:solidFill>
-                          <a:latin typeface="Encode Sans"/>
-                        </a:rPr>
-                        <a:t>534.223</a:t>
-                      </a:r>
-                    </a:p>
-                  </a:txBody>
-                  <a:tcPr marL="36576" marR="36576" marT="18288" marB="18288">
-                    <a:solidFill>
-                      <a:srgbClr val="F8F8F6"/>
-                    </a:solidFill>
-                  </a:tcPr>
-                </a:tc>
-                <a:tc>
-                  <a:txBody>
-                    <a:bodyPr/>
-                    <a:lstStyle/>
-                    <a:p>
-                      <a:pPr algn="r"/>
-                      <a:r>
-                        <a:rPr sz="1000">
-                          <a:solidFill>
-                            <a:srgbClr val="3F3F3F"/>
-                          </a:solidFill>
-                          <a:latin typeface="Encode Sans"/>
-                        </a:rPr>
-                        <a:t>1.629.180</a:t>
-                      </a:r>
-                    </a:p>
-                  </a:txBody>
-                  <a:tcPr marL="36576" marR="36576" marT="18288" marB="18288">
-                    <a:solidFill>
-                      <a:srgbClr val="F8F8F6"/>
-                    </a:solidFill>
-                  </a:tcPr>
-                </a:tc>
-                <a:tc>
-                  <a:txBody>
-                    <a:bodyPr/>
-                    <a:lstStyle/>
-                    <a:p>
-                      <a:pPr algn="r"/>
-                      <a:r>
-                        <a:rPr sz="1000">
-                          <a:solidFill>
-                            <a:srgbClr val="3F3F3F"/>
-                          </a:solidFill>
-                          <a:latin typeface="Encode Sans"/>
-                        </a:rPr>
-                        <a:t>-1.094.957</a:t>
-                      </a:r>
-                    </a:p>
-                  </a:txBody>
-                  <a:tcPr marL="36576" marR="36576" marT="18288" marB="18288">
-                    <a:solidFill>
-                      <a:srgbClr val="F8F8F6"/>
-                    </a:solidFill>
-                  </a:tcPr>
-                </a:tc>
-              </a:tr>
-            </a:tbl>
-          </a:graphicData>
-        </a:graphic>
-      </p:graphicFrame>
-      <p:sp>
-        <p:nvSpPr>
-          <p:cNvPr id="9" name="TextBox 8"/>
-          <p:cNvSpPr txBox="1"/>
-          <p:nvPr/>
-        </p:nvSpPr>
-        <p:spPr>
-          <a:xfrm>
-            <a:off x="411480" y="6492240"/>
-            <a:ext cx="11368735" cy="274320"/>
-          </a:xfrm>
-          <a:prstGeom prst="rect">
-            <a:avLst/>
-          </a:prstGeom>
-          <a:noFill/>
-        </p:spPr>
-        <p:txBody>
-          <a:bodyPr wrap="none">
-            <a:spAutoFit/>
-          </a:bodyPr>
-          <a:lstStyle/>
-          <a:p>
-            <a:r>
-              <a:rPr sz="1000" b="0" i="1">
-                <a:solidFill>
-                  <a:srgbClr val="6A6760"/>
-                </a:solidFill>
-                <a:latin typeface="Encode Sans"/>
-              </a:rPr>
-              <a:t>Fuente: elaboración propia en base a INDEC</a:t>
+              <a:t>Fuente: elaboración propia en base a AFIP/ARCA</a:t>
             </a:r>
           </a:p>
         </p:txBody>

</xml_diff>

<commit_message>
data: update 2026-09-08 ( data.json despidos.json scraper/historical_despidos.json publicaciones_semana.pptx rrii_brutas.xlsx)
</commit_message>
<xml_diff>
--- a/publicaciones_semana.pptx
+++ b/publicaciones_semana.pptx
@@ -3238,7 +3238,7 @@
                 </a:solidFill>
                 <a:latin typeface="Encode Sans"/>
               </a:rPr>
-              <a:t>Publicaciones de la semana del 31 de agosto de 2026</a:t>
+              <a:t>Publicaciones de la semana del 07 de septiembre de 2026</a:t>
             </a:r>
           </a:p>
         </p:txBody>
@@ -3368,7 +3368,7 @@
                 </a:solidFill>
                 <a:latin typeface="Encode Sans"/>
               </a:rPr>
-              <a:t>RECAUDACIÓN AGOSTO 2026: CRECIÓ +3.8% REAL I.A.</a:t>
+              <a:t>INDUSTRIA JULIO 2026: IPI CAYÓ -4.9% I.A.</a:t>
             </a:r>
           </a:p>
         </p:txBody>
@@ -3402,7 +3402,7 @@
                 </a:solidFill>
                 <a:latin typeface="Encode Sans"/>
               </a:rPr>
-              <a:t>AFIP/ARCA · período 2026-08</a:t>
+              <a:t>INDEC · período 2026-07</a:t>
             </a:r>
           </a:p>
         </p:txBody>
@@ -3437,7 +3437,7 @@
                 </a:solidFill>
                 <a:latin typeface="Encode Sans"/>
               </a:rPr>
-              <a:t>AFIP/ARCA recaudó $20.509K millones en agosto 2026. Variación nominal interanual: +33.5%. En términos reales (deflactado por REM): +3.8% i.a. Quiebre de tendencia: venía con 6 meses de caída real interanual.</a:t>
+              <a:t>El Índice de Producción Industrial Manufacturero (IPI) registró una variación interanual de -4.9% en julio 2026.</a:t>
             </a:r>
           </a:p>
         </p:txBody>
@@ -3485,7 +3485,7 @@
                 </a:solidFill>
                 <a:latin typeface="Encode Sans"/>
               </a:rPr>
-              <a:t>Total: $20.509K M$</a:t>
+              <a:t>Variación interanual: -4.9%</a:t>
             </a:r>
           </a:p>
           <a:p>
@@ -3510,57 +3510,7 @@
                 </a:solidFill>
                 <a:latin typeface="Encode Sans"/>
               </a:rPr>
-              <a:t>Variación nominal i.a.: +33.5%</a:t>
-            </a:r>
-          </a:p>
-          <a:p>
-            <a:pPr algn="l">
-              <a:spcAft>
-                <a:spcPts val="800"/>
-              </a:spcAft>
-            </a:pPr>
-            <a:r>
-              <a:rPr sz="1300" b="1" i="0">
-                <a:solidFill>
-                  <a:srgbClr val="00B2C9"/>
-                </a:solidFill>
-                <a:latin typeface="Encode Sans"/>
-              </a:rPr>
-              <a:t>●  </a:t>
-            </a:r>
-            <a:r>
-              <a:rPr sz="1300" b="0" i="0">
-                <a:solidFill>
-                  <a:srgbClr val="3F3F3F"/>
-                </a:solidFill>
-                <a:latin typeface="Encode Sans"/>
-              </a:rPr>
-              <a:t>Variación real i.a.: +3.8% (deflactor: REM)</a:t>
-            </a:r>
-          </a:p>
-          <a:p>
-            <a:pPr algn="l">
-              <a:spcAft>
-                <a:spcPts val="800"/>
-              </a:spcAft>
-            </a:pPr>
-            <a:r>
-              <a:rPr sz="1300" b="1" i="0">
-                <a:solidFill>
-                  <a:srgbClr val="00B2C9"/>
-                </a:solidFill>
-                <a:latin typeface="Encode Sans"/>
-              </a:rPr>
-              <a:t>●  </a:t>
-            </a:r>
-            <a:r>
-              <a:rPr sz="1300" b="0" i="0">
-                <a:solidFill>
-                  <a:srgbClr val="3F3F3F"/>
-                </a:solidFill>
-                <a:latin typeface="Encode Sans"/>
-              </a:rPr>
-              <a:t>Fuente: ARCA (ex AFIP) · indec.gob.ar series</a:t>
+              <a:t>Serie INDEC, base 2004=100. Mide la producción manufacturera (16 ramas).</a:t>
             </a:r>
           </a:p>
         </p:txBody>
@@ -3608,10 +3558,9 @@
                 <a:tableStyleId>{5C22544A-7EE6-4342-B048-85BDC9FD1C3A}</a:tableStyleId>
               </a:tblPr>
               <a:tblGrid>
-                <a:gridCol w="1417320"/>
-                <a:gridCol w="1417320"/>
-                <a:gridCol w="1417320"/>
-                <a:gridCol w="1417320"/>
+                <a:gridCol w="1889760"/>
+                <a:gridCol w="1889760"/>
+                <a:gridCol w="1889760"/>
               </a:tblGrid>
               <a:tr h="292608">
                 <a:tc>
@@ -3650,7 +3599,7 @@
                           </a:solidFill>
                           <a:latin typeface="Encode Sans"/>
                         </a:rPr>
-                        <a:t>Total M$</a:t>
+                        <a:t>Original</a:t>
                       </a:r>
                     </a:p>
                   </a:txBody>
@@ -3673,30 +3622,7 @@
                           </a:solidFill>
                           <a:latin typeface="Encode Sans"/>
                         </a:rPr>
-                        <a:t>Var. nom. i.a.</a:t>
-                      </a:r>
-                    </a:p>
-                  </a:txBody>
-                  <a:tcPr marL="36576" marR="36576" marT="18288" marB="18288">
-                    <a:solidFill>
-                      <a:srgbClr val="00B2C9"/>
-                    </a:solidFill>
-                  </a:tcPr>
-                </a:tc>
-                <a:tc>
-                  <a:txBody>
-                    <a:bodyPr/>
-                    <a:lstStyle/>
-                    <a:p>
-                      <a:pPr algn="r"/>
-                      <a:r>
-                        <a:rPr sz="1000" b="1">
-                          <a:solidFill>
-                            <a:srgbClr val="FFFFFF"/>
-                          </a:solidFill>
-                          <a:latin typeface="Encode Sans"/>
-                        </a:rPr>
-                        <a:t>Var. real i.a.</a:t>
+                        <a:t>VIA %</a:t>
                       </a:r>
                     </a:p>
                   </a:txBody>
@@ -3721,7 +3647,7 @@
                           </a:solidFill>
                           <a:latin typeface="Encode Sans"/>
                         </a:rPr>
-                        <a:t>Agosto 2026</a:t>
+                        <a:t>Julio 2026</a:t>
                       </a:r>
                     </a:p>
                   </a:txBody>
@@ -3744,7 +3670,7 @@
                           </a:solidFill>
                           <a:latin typeface="Encode Sans"/>
                         </a:rPr>
-                        <a:t>20.509K</a:t>
+                        <a:t>118,2</a:t>
                       </a:r>
                     </a:p>
                   </a:txBody>
@@ -3767,30 +3693,7 @@
                           </a:solidFill>
                           <a:latin typeface="Encode Sans"/>
                         </a:rPr>
-                        <a:t>—</a:t>
-                      </a:r>
-                    </a:p>
-                  </a:txBody>
-                  <a:tcPr marL="36576" marR="36576" marT="18288" marB="18288">
-                    <a:solidFill>
-                      <a:srgbClr val="FFFFFF"/>
-                    </a:solidFill>
-                  </a:tcPr>
-                </a:tc>
-                <a:tc>
-                  <a:txBody>
-                    <a:bodyPr/>
-                    <a:lstStyle/>
-                    <a:p>
-                      <a:pPr algn="r"/>
-                      <a:r>
-                        <a:rPr sz="1000">
-                          <a:solidFill>
-                            <a:srgbClr val="3F3F3F"/>
-                          </a:solidFill>
-                          <a:latin typeface="Encode Sans"/>
-                        </a:rPr>
-                        <a:t>—</a:t>
+                        <a:t>-4.9%</a:t>
                       </a:r>
                     </a:p>
                   </a:txBody>
@@ -3815,7 +3718,7 @@
                           </a:solidFill>
                           <a:latin typeface="Encode Sans"/>
                         </a:rPr>
-                        <a:t>Julio 2026</a:t>
+                        <a:t>Junio 2026</a:t>
                       </a:r>
                     </a:p>
                   </a:txBody>
@@ -3838,7 +3741,7 @@
                           </a:solidFill>
                           <a:latin typeface="Encode Sans"/>
                         </a:rPr>
-                        <a:t>22.965K</a:t>
+                        <a:t>120,0</a:t>
                       </a:r>
                     </a:p>
                   </a:txBody>
@@ -3861,30 +3764,7 @@
                           </a:solidFill>
                           <a:latin typeface="Encode Sans"/>
                         </a:rPr>
-                        <a:t>—</a:t>
-                      </a:r>
-                    </a:p>
-                  </a:txBody>
-                  <a:tcPr marL="36576" marR="36576" marT="18288" marB="18288">
-                    <a:solidFill>
-                      <a:srgbClr val="F8F8F6"/>
-                    </a:solidFill>
-                  </a:tcPr>
-                </a:tc>
-                <a:tc>
-                  <a:txBody>
-                    <a:bodyPr/>
-                    <a:lstStyle/>
-                    <a:p>
-                      <a:pPr algn="r"/>
-                      <a:r>
-                        <a:rPr sz="1000">
-                          <a:solidFill>
-                            <a:srgbClr val="3F3F3F"/>
-                          </a:solidFill>
-                          <a:latin typeface="Encode Sans"/>
-                        </a:rPr>
-                        <a:t>—</a:t>
+                        <a:t>+2.1%</a:t>
                       </a:r>
                     </a:p>
                   </a:txBody>
@@ -3909,7 +3789,7 @@
                           </a:solidFill>
                           <a:latin typeface="Encode Sans"/>
                         </a:rPr>
-                        <a:t>Junio 2026</a:t>
+                        <a:t>Mayo 2026</a:t>
                       </a:r>
                     </a:p>
                   </a:txBody>
@@ -3932,7 +3812,7 @@
                           </a:solidFill>
                           <a:latin typeface="Encode Sans"/>
                         </a:rPr>
-                        <a:t>20.017K</a:t>
+                        <a:t>117,0</a:t>
                       </a:r>
                     </a:p>
                   </a:txBody>
@@ -3955,30 +3835,7 @@
                           </a:solidFill>
                           <a:latin typeface="Encode Sans"/>
                         </a:rPr>
-                        <a:t>—</a:t>
-                      </a:r>
-                    </a:p>
-                  </a:txBody>
-                  <a:tcPr marL="36576" marR="36576" marT="18288" marB="18288">
-                    <a:solidFill>
-                      <a:srgbClr val="FFFFFF"/>
-                    </a:solidFill>
-                  </a:tcPr>
-                </a:tc>
-                <a:tc>
-                  <a:txBody>
-                    <a:bodyPr/>
-                    <a:lstStyle/>
-                    <a:p>
-                      <a:pPr algn="r"/>
-                      <a:r>
-                        <a:rPr sz="1000">
-                          <a:solidFill>
-                            <a:srgbClr val="3F3F3F"/>
-                          </a:solidFill>
-                          <a:latin typeface="Encode Sans"/>
-                        </a:rPr>
-                        <a:t>—</a:t>
+                        <a:t>-5.7%</a:t>
                       </a:r>
                     </a:p>
                   </a:txBody>
@@ -4003,7 +3860,7 @@
                           </a:solidFill>
                           <a:latin typeface="Encode Sans"/>
                         </a:rPr>
-                        <a:t>Mayo 2026</a:t>
+                        <a:t>Abril 2026</a:t>
                       </a:r>
                     </a:p>
                   </a:txBody>
@@ -4026,7 +3883,7 @@
                           </a:solidFill>
                           <a:latin typeface="Encode Sans"/>
                         </a:rPr>
-                        <a:t>21.514K</a:t>
+                        <a:t>118,6</a:t>
                       </a:r>
                     </a:p>
                   </a:txBody>
@@ -4049,30 +3906,7 @@
                           </a:solidFill>
                           <a:latin typeface="Encode Sans"/>
                         </a:rPr>
-                        <a:t>—</a:t>
-                      </a:r>
-                    </a:p>
-                  </a:txBody>
-                  <a:tcPr marL="36576" marR="36576" marT="18288" marB="18288">
-                    <a:solidFill>
-                      <a:srgbClr val="F8F8F6"/>
-                    </a:solidFill>
-                  </a:tcPr>
-                </a:tc>
-                <a:tc>
-                  <a:txBody>
-                    <a:bodyPr/>
-                    <a:lstStyle/>
-                    <a:p>
-                      <a:pPr algn="r"/>
-                      <a:r>
-                        <a:rPr sz="1000">
-                          <a:solidFill>
-                            <a:srgbClr val="3F3F3F"/>
-                          </a:solidFill>
-                          <a:latin typeface="Encode Sans"/>
-                        </a:rPr>
-                        <a:t>—</a:t>
+                        <a:t>-2.4%</a:t>
                       </a:r>
                     </a:p>
                   </a:txBody>
@@ -4097,7 +3931,7 @@
                           </a:solidFill>
                           <a:latin typeface="Encode Sans"/>
                         </a:rPr>
-                        <a:t>Abril 2026</a:t>
+                        <a:t>Marzo 2026</a:t>
                       </a:r>
                     </a:p>
                   </a:txBody>
@@ -4120,7 +3954,7 @@
                           </a:solidFill>
                           <a:latin typeface="Encode Sans"/>
                         </a:rPr>
-                        <a:t>17.401K</a:t>
+                        <a:t>122,2</a:t>
                       </a:r>
                     </a:p>
                   </a:txBody>
@@ -4143,30 +3977,7 @@
                           </a:solidFill>
                           <a:latin typeface="Encode Sans"/>
                         </a:rPr>
-                        <a:t>—</a:t>
-                      </a:r>
-                    </a:p>
-                  </a:txBody>
-                  <a:tcPr marL="36576" marR="36576" marT="18288" marB="18288">
-                    <a:solidFill>
-                      <a:srgbClr val="FFFFFF"/>
-                    </a:solidFill>
-                  </a:tcPr>
-                </a:tc>
-                <a:tc>
-                  <a:txBody>
-                    <a:bodyPr/>
-                    <a:lstStyle/>
-                    <a:p>
-                      <a:pPr algn="r"/>
-                      <a:r>
-                        <a:rPr sz="1000">
-                          <a:solidFill>
-                            <a:srgbClr val="3F3F3F"/>
-                          </a:solidFill>
-                          <a:latin typeface="Encode Sans"/>
-                        </a:rPr>
-                        <a:t>—</a:t>
+                        <a:t>+5.1%</a:t>
                       </a:r>
                     </a:p>
                   </a:txBody>
@@ -4191,7 +4002,7 @@
                           </a:solidFill>
                           <a:latin typeface="Encode Sans"/>
                         </a:rPr>
-                        <a:t>Marzo 2026</a:t>
+                        <a:t>Febrero 2026</a:t>
                       </a:r>
                     </a:p>
                   </a:txBody>
@@ -4214,7 +4025,7 @@
                           </a:solidFill>
                           <a:latin typeface="Encode Sans"/>
                         </a:rPr>
-                        <a:t>16.071K</a:t>
+                        <a:t>100,3</a:t>
                       </a:r>
                     </a:p>
                   </a:txBody>
@@ -4237,30 +4048,7 @@
                           </a:solidFill>
                           <a:latin typeface="Encode Sans"/>
                         </a:rPr>
-                        <a:t>26.21%</a:t>
-                      </a:r>
-                    </a:p>
-                  </a:txBody>
-                  <a:tcPr marL="36576" marR="36576" marT="18288" marB="18288">
-                    <a:solidFill>
-                      <a:srgbClr val="F8F8F6"/>
-                    </a:solidFill>
-                  </a:tcPr>
-                </a:tc>
-                <a:tc>
-                  <a:txBody>
-                    <a:bodyPr/>
-                    <a:lstStyle/>
-                    <a:p>
-                      <a:pPr algn="r"/>
-                      <a:r>
-                        <a:rPr sz="1000">
-                          <a:solidFill>
-                            <a:srgbClr val="3F3F3F"/>
-                          </a:solidFill>
-                          <a:latin typeface="Encode Sans"/>
-                        </a:rPr>
-                        <a:t>—</a:t>
+                        <a:t>-8.8%</a:t>
                       </a:r>
                     </a:p>
                   </a:txBody>
@@ -4304,7 +4092,7 @@
                 </a:solidFill>
                 <a:latin typeface="Encode Sans"/>
               </a:rPr>
-              <a:t>Fuente: elaboración propia en base a AFIP/ARCA</a:t>
+              <a:t>Fuente: elaboración propia en base a INDEC</a:t>
             </a:r>
           </a:p>
         </p:txBody>

</xml_diff>

<commit_message>
data: update 2026-09-09 ( data.json despidos.json scraper/historical_despidos.json publicaciones_semana.pptx rrii_brutas.xlsx)
</commit_message>
<xml_diff>
--- a/publicaciones_semana.pptx
+++ b/publicaciones_semana.pptx
@@ -7,6 +7,7 @@
   <p:sldIdLst>
     <p:sldId id="256" r:id="rId7"/>
     <p:sldId id="257" r:id="rId8"/>
+    <p:sldId id="258" r:id="rId9"/>
   </p:sldIdLst>
   <p:sldSz cx="12191695" cy="6858000" type="screen4x3"/>
   <p:notesSz cx="6858000" cy="9144000"/>
@@ -3272,7 +3273,7 @@
                 </a:solidFill>
                 <a:latin typeface="Encode Sans"/>
               </a:rPr>
-              <a:t>1 publicaciones · datos oficiales INDEC / BCRA / Hacienda</a:t>
+              <a:t>2 publicaciones · datos oficiales INDEC / BCRA / Hacienda</a:t>
             </a:r>
           </a:p>
         </p:txBody>
@@ -4105,6 +4106,826 @@
 </p:sld>
 </file>
 
+<file path=ppt/slides/slide3.xml><?xml version="1.0" encoding="utf-8"?>
+<p:sld xmlns:a="http://schemas.openxmlformats.org/drawingml/2006/main" xmlns:p="http://schemas.openxmlformats.org/presentationml/2006/main" xmlns:r="http://schemas.openxmlformats.org/officeDocument/2006/relationships">
+  <p:cSld>
+    <p:spTree>
+      <p:nvGrpSpPr>
+        <p:cNvPr id="1" name=""/>
+        <p:cNvGrpSpPr/>
+        <p:nvPr/>
+      </p:nvGrpSpPr>
+      <p:grpSpPr/>
+      <p:sp>
+        <p:nvSpPr>
+          <p:cNvPr id="2" name="Rectangle 1"/>
+          <p:cNvSpPr/>
+          <p:nvPr/>
+        </p:nvSpPr>
+        <p:spPr>
+          <a:xfrm>
+            <a:off x="0" y="0"/>
+            <a:ext cx="12191695" cy="274320"/>
+          </a:xfrm>
+          <a:prstGeom prst="rect">
+            <a:avLst/>
+          </a:prstGeom>
+          <a:solidFill>
+            <a:srgbClr val="00B2C9"/>
+          </a:solidFill>
+          <a:ln>
+            <a:noFill/>
+          </a:ln>
+        </p:spPr>
+        <p:style>
+          <a:lnRef idx="1">
+            <a:schemeClr val="accent1"/>
+          </a:lnRef>
+          <a:fillRef idx="3">
+            <a:schemeClr val="accent1"/>
+          </a:fillRef>
+          <a:effectRef idx="2">
+            <a:schemeClr val="accent1"/>
+          </a:effectRef>
+          <a:fontRef idx="minor">
+            <a:schemeClr val="lt1"/>
+          </a:fontRef>
+        </p:style>
+        <p:txBody>
+          <a:bodyPr rtlCol="0" anchor="ctr"/>
+          <a:lstStyle/>
+          <a:p>
+            <a:pPr algn="ctr"/>
+          </a:p>
+        </p:txBody>
+      </p:sp>
+      <p:sp>
+        <p:nvSpPr>
+          <p:cNvPr id="3" name="TextBox 2"/>
+          <p:cNvSpPr txBox="1"/>
+          <p:nvPr/>
+        </p:nvSpPr>
+        <p:spPr>
+          <a:xfrm>
+            <a:off x="411480" y="457200"/>
+            <a:ext cx="11368735" cy="914400"/>
+          </a:xfrm>
+          <a:prstGeom prst="rect">
+            <a:avLst/>
+          </a:prstGeom>
+          <a:noFill/>
+        </p:spPr>
+        <p:txBody>
+          <a:bodyPr wrap="square" lIns="0" rIns="0">
+            <a:spAutoFit/>
+          </a:bodyPr>
+          <a:lstStyle/>
+          <a:p>
+            <a:pPr algn="l"/>
+            <a:r>
+              <a:rPr sz="2600" b="1" i="0">
+                <a:solidFill>
+                  <a:srgbClr val="00B2C9"/>
+                </a:solidFill>
+                <a:latin typeface="Encode Sans"/>
+              </a:rPr>
+              <a:t>INDUSTRIA JULIO 2026: IPI CRECIÓ +0.0% I.A.</a:t>
+            </a:r>
+          </a:p>
+        </p:txBody>
+      </p:sp>
+      <p:sp>
+        <p:nvSpPr>
+          <p:cNvPr id="4" name="TextBox 3"/>
+          <p:cNvSpPr txBox="1"/>
+          <p:nvPr/>
+        </p:nvSpPr>
+        <p:spPr>
+          <a:xfrm>
+            <a:off x="411480" y="1280160"/>
+            <a:ext cx="11368735" cy="274320"/>
+          </a:xfrm>
+          <a:prstGeom prst="rect">
+            <a:avLst/>
+          </a:prstGeom>
+          <a:noFill/>
+        </p:spPr>
+        <p:txBody>
+          <a:bodyPr wrap="none">
+            <a:spAutoFit/>
+          </a:bodyPr>
+          <a:lstStyle/>
+          <a:p>
+            <a:r>
+              <a:rPr sz="1100" b="0" i="1">
+                <a:solidFill>
+                  <a:srgbClr val="6A6760"/>
+                </a:solidFill>
+                <a:latin typeface="Encode Sans"/>
+              </a:rPr>
+              <a:t>INDEC · período 2026-07</a:t>
+            </a:r>
+          </a:p>
+        </p:txBody>
+      </p:sp>
+      <p:sp>
+        <p:nvSpPr>
+          <p:cNvPr id="5" name="TextBox 4"/>
+          <p:cNvSpPr txBox="1"/>
+          <p:nvPr/>
+        </p:nvSpPr>
+        <p:spPr>
+          <a:xfrm>
+            <a:off x="411480" y="1691640"/>
+            <a:ext cx="5486400" cy="1645920"/>
+          </a:xfrm>
+          <a:prstGeom prst="rect">
+            <a:avLst/>
+          </a:prstGeom>
+          <a:noFill/>
+        </p:spPr>
+        <p:txBody>
+          <a:bodyPr wrap="square" lIns="0" rIns="0">
+            <a:spAutoFit/>
+          </a:bodyPr>
+          <a:lstStyle/>
+          <a:p>
+            <a:pPr algn="just"/>
+            <a:r>
+              <a:rPr sz="1300" b="0" i="0">
+                <a:solidFill>
+                  <a:srgbClr val="3F3F3F"/>
+                </a:solidFill>
+                <a:latin typeface="Encode Sans"/>
+              </a:rPr>
+              <a:t>El Índice de Producción Industrial Manufacturero (IPI) registró una variación interanual de +0.0% en julio 2026.</a:t>
+            </a:r>
+          </a:p>
+        </p:txBody>
+      </p:sp>
+      <p:sp>
+        <p:nvSpPr>
+          <p:cNvPr id="6" name="TextBox 5"/>
+          <p:cNvSpPr txBox="1"/>
+          <p:nvPr/>
+        </p:nvSpPr>
+        <p:spPr>
+          <a:xfrm>
+            <a:off x="411480" y="3520440"/>
+            <a:ext cx="5486400" cy="2743200"/>
+          </a:xfrm>
+          <a:prstGeom prst="rect">
+            <a:avLst/>
+          </a:prstGeom>
+          <a:noFill/>
+        </p:spPr>
+        <p:txBody>
+          <a:bodyPr wrap="square" lIns="0" rIns="0">
+            <a:spAutoFit/>
+          </a:bodyPr>
+          <a:lstStyle/>
+          <a:p>
+            <a:pPr algn="l">
+              <a:spcAft>
+                <a:spcPts val="800"/>
+              </a:spcAft>
+            </a:pPr>
+            <a:r>
+              <a:rPr sz="1300" b="1" i="0">
+                <a:solidFill>
+                  <a:srgbClr val="00B2C9"/>
+                </a:solidFill>
+                <a:latin typeface="Encode Sans"/>
+              </a:rPr>
+              <a:t>●  </a:t>
+            </a:r>
+            <a:r>
+              <a:rPr sz="1300" b="0" i="0">
+                <a:solidFill>
+                  <a:srgbClr val="3F3F3F"/>
+                </a:solidFill>
+                <a:latin typeface="Encode Sans"/>
+              </a:rPr>
+              <a:t>Variación interanual: +0.0%</a:t>
+            </a:r>
+          </a:p>
+          <a:p>
+            <a:pPr algn="l">
+              <a:spcAft>
+                <a:spcPts val="800"/>
+              </a:spcAft>
+            </a:pPr>
+            <a:r>
+              <a:rPr sz="1300" b="1" i="0">
+                <a:solidFill>
+                  <a:srgbClr val="00B2C9"/>
+                </a:solidFill>
+                <a:latin typeface="Encode Sans"/>
+              </a:rPr>
+              <a:t>●  </a:t>
+            </a:r>
+            <a:r>
+              <a:rPr sz="1300" b="0" i="0">
+                <a:solidFill>
+                  <a:srgbClr val="3F3F3F"/>
+                </a:solidFill>
+                <a:latin typeface="Encode Sans"/>
+              </a:rPr>
+              <a:t>Serie INDEC, base 2004=100. Mide la producción manufacturera (16 ramas).</a:t>
+            </a:r>
+          </a:p>
+        </p:txBody>
+      </p:sp>
+      <p:pic>
+        <p:nvPicPr>
+          <p:cNvPr id="7" name="Picture 6" descr="image.png"/>
+          <p:cNvPicPr>
+            <a:picLocks noChangeAspect="1"/>
+          </p:cNvPicPr>
+          <p:nvPr/>
+        </p:nvPicPr>
+        <p:blipFill>
+          <a:blip r:embed="rId2"/>
+          <a:stretch>
+            <a:fillRect/>
+          </a:stretch>
+        </p:blipFill>
+        <p:spPr>
+          <a:xfrm>
+            <a:off x="6080760" y="1691640"/>
+            <a:ext cx="5669280" cy="2560320"/>
+          </a:xfrm>
+          <a:prstGeom prst="rect">
+            <a:avLst/>
+          </a:prstGeom>
+        </p:spPr>
+      </p:pic>
+      <p:graphicFrame>
+        <p:nvGraphicFramePr>
+          <p:cNvPr id="8" name="Table 7"/>
+          <p:cNvGraphicFramePr>
+            <a:graphicFrameLocks noGrp="1"/>
+          </p:cNvGraphicFramePr>
+          <p:nvPr/>
+        </p:nvGraphicFramePr>
+        <p:xfrm>
+          <a:off x="6080760" y="4434840"/>
+          <a:ext cx="5669280" cy="2048256"/>
+        </p:xfrm>
+        <a:graphic>
+          <a:graphicData uri="http://schemas.openxmlformats.org/drawingml/2006/table">
+            <a:tbl>
+              <a:tblPr firstRow="1" bandRow="1">
+                <a:tableStyleId>{5C22544A-7EE6-4342-B048-85BDC9FD1C3A}</a:tableStyleId>
+              </a:tblPr>
+              <a:tblGrid>
+                <a:gridCol w="1889760"/>
+                <a:gridCol w="1889760"/>
+                <a:gridCol w="1889760"/>
+              </a:tblGrid>
+              <a:tr h="292608">
+                <a:tc>
+                  <a:txBody>
+                    <a:bodyPr/>
+                    <a:lstStyle/>
+                    <a:p>
+                      <a:pPr algn="l"/>
+                      <a:r>
+                        <a:rPr sz="1000" b="1">
+                          <a:solidFill>
+                            <a:srgbClr val="FFFFFF"/>
+                          </a:solidFill>
+                          <a:latin typeface="Encode Sans"/>
+                        </a:rPr>
+                        <a:t>Mes</a:t>
+                      </a:r>
+                    </a:p>
+                  </a:txBody>
+                  <a:tcPr marL="36576" marR="36576" marT="18288" marB="18288">
+                    <a:solidFill>
+                      <a:srgbClr val="00B2C9"/>
+                    </a:solidFill>
+                  </a:tcPr>
+                </a:tc>
+                <a:tc>
+                  <a:txBody>
+                    <a:bodyPr/>
+                    <a:lstStyle/>
+                    <a:p>
+                      <a:pPr algn="r"/>
+                      <a:r>
+                        <a:rPr sz="1000" b="1">
+                          <a:solidFill>
+                            <a:srgbClr val="FFFFFF"/>
+                          </a:solidFill>
+                          <a:latin typeface="Encode Sans"/>
+                        </a:rPr>
+                        <a:t>Original</a:t>
+                      </a:r>
+                    </a:p>
+                  </a:txBody>
+                  <a:tcPr marL="36576" marR="36576" marT="18288" marB="18288">
+                    <a:solidFill>
+                      <a:srgbClr val="00B2C9"/>
+                    </a:solidFill>
+                  </a:tcPr>
+                </a:tc>
+                <a:tc>
+                  <a:txBody>
+                    <a:bodyPr/>
+                    <a:lstStyle/>
+                    <a:p>
+                      <a:pPr algn="r"/>
+                      <a:r>
+                        <a:rPr sz="1000" b="1">
+                          <a:solidFill>
+                            <a:srgbClr val="FFFFFF"/>
+                          </a:solidFill>
+                          <a:latin typeface="Encode Sans"/>
+                        </a:rPr>
+                        <a:t>VIA %</a:t>
+                      </a:r>
+                    </a:p>
+                  </a:txBody>
+                  <a:tcPr marL="36576" marR="36576" marT="18288" marB="18288">
+                    <a:solidFill>
+                      <a:srgbClr val="00B2C9"/>
+                    </a:solidFill>
+                  </a:tcPr>
+                </a:tc>
+              </a:tr>
+              <a:tr h="292608">
+                <a:tc>
+                  <a:txBody>
+                    <a:bodyPr/>
+                    <a:lstStyle/>
+                    <a:p>
+                      <a:pPr algn="l"/>
+                      <a:r>
+                        <a:rPr sz="1000">
+                          <a:solidFill>
+                            <a:srgbClr val="3F3F3F"/>
+                          </a:solidFill>
+                          <a:latin typeface="Encode Sans"/>
+                        </a:rPr>
+                        <a:t>Julio 2026</a:t>
+                      </a:r>
+                    </a:p>
+                  </a:txBody>
+                  <a:tcPr marL="36576" marR="36576" marT="18288" marB="18288">
+                    <a:solidFill>
+                      <a:srgbClr val="FFFFFF"/>
+                    </a:solidFill>
+                  </a:tcPr>
+                </a:tc>
+                <a:tc>
+                  <a:txBody>
+                    <a:bodyPr/>
+                    <a:lstStyle/>
+                    <a:p>
+                      <a:pPr algn="r"/>
+                      <a:r>
+                        <a:rPr sz="1000">
+                          <a:solidFill>
+                            <a:srgbClr val="3F3F3F"/>
+                          </a:solidFill>
+                          <a:latin typeface="Encode Sans"/>
+                        </a:rPr>
+                        <a:t>118,2</a:t>
+                      </a:r>
+                    </a:p>
+                  </a:txBody>
+                  <a:tcPr marL="36576" marR="36576" marT="18288" marB="18288">
+                    <a:solidFill>
+                      <a:srgbClr val="FFFFFF"/>
+                    </a:solidFill>
+                  </a:tcPr>
+                </a:tc>
+                <a:tc>
+                  <a:txBody>
+                    <a:bodyPr/>
+                    <a:lstStyle/>
+                    <a:p>
+                      <a:pPr algn="r"/>
+                      <a:r>
+                        <a:rPr sz="1000">
+                          <a:solidFill>
+                            <a:srgbClr val="3F3F3F"/>
+                          </a:solidFill>
+                          <a:latin typeface="Encode Sans"/>
+                        </a:rPr>
+                        <a:t>-4.9%</a:t>
+                      </a:r>
+                    </a:p>
+                  </a:txBody>
+                  <a:tcPr marL="36576" marR="36576" marT="18288" marB="18288">
+                    <a:solidFill>
+                      <a:srgbClr val="FFFFFF"/>
+                    </a:solidFill>
+                  </a:tcPr>
+                </a:tc>
+              </a:tr>
+              <a:tr h="292608">
+                <a:tc>
+                  <a:txBody>
+                    <a:bodyPr/>
+                    <a:lstStyle/>
+                    <a:p>
+                      <a:pPr algn="l"/>
+                      <a:r>
+                        <a:rPr sz="1000">
+                          <a:solidFill>
+                            <a:srgbClr val="3F3F3F"/>
+                          </a:solidFill>
+                          <a:latin typeface="Encode Sans"/>
+                        </a:rPr>
+                        <a:t>Junio 2026</a:t>
+                      </a:r>
+                    </a:p>
+                  </a:txBody>
+                  <a:tcPr marL="36576" marR="36576" marT="18288" marB="18288">
+                    <a:solidFill>
+                      <a:srgbClr val="F8F8F6"/>
+                    </a:solidFill>
+                  </a:tcPr>
+                </a:tc>
+                <a:tc>
+                  <a:txBody>
+                    <a:bodyPr/>
+                    <a:lstStyle/>
+                    <a:p>
+                      <a:pPr algn="r"/>
+                      <a:r>
+                        <a:rPr sz="1000">
+                          <a:solidFill>
+                            <a:srgbClr val="3F3F3F"/>
+                          </a:solidFill>
+                          <a:latin typeface="Encode Sans"/>
+                        </a:rPr>
+                        <a:t>120,0</a:t>
+                      </a:r>
+                    </a:p>
+                  </a:txBody>
+                  <a:tcPr marL="36576" marR="36576" marT="18288" marB="18288">
+                    <a:solidFill>
+                      <a:srgbClr val="F8F8F6"/>
+                    </a:solidFill>
+                  </a:tcPr>
+                </a:tc>
+                <a:tc>
+                  <a:txBody>
+                    <a:bodyPr/>
+                    <a:lstStyle/>
+                    <a:p>
+                      <a:pPr algn="r"/>
+                      <a:r>
+                        <a:rPr sz="1000">
+                          <a:solidFill>
+                            <a:srgbClr val="3F3F3F"/>
+                          </a:solidFill>
+                          <a:latin typeface="Encode Sans"/>
+                        </a:rPr>
+                        <a:t>+2.1%</a:t>
+                      </a:r>
+                    </a:p>
+                  </a:txBody>
+                  <a:tcPr marL="36576" marR="36576" marT="18288" marB="18288">
+                    <a:solidFill>
+                      <a:srgbClr val="F8F8F6"/>
+                    </a:solidFill>
+                  </a:tcPr>
+                </a:tc>
+              </a:tr>
+              <a:tr h="292608">
+                <a:tc>
+                  <a:txBody>
+                    <a:bodyPr/>
+                    <a:lstStyle/>
+                    <a:p>
+                      <a:pPr algn="l"/>
+                      <a:r>
+                        <a:rPr sz="1000">
+                          <a:solidFill>
+                            <a:srgbClr val="3F3F3F"/>
+                          </a:solidFill>
+                          <a:latin typeface="Encode Sans"/>
+                        </a:rPr>
+                        <a:t>Mayo 2026</a:t>
+                      </a:r>
+                    </a:p>
+                  </a:txBody>
+                  <a:tcPr marL="36576" marR="36576" marT="18288" marB="18288">
+                    <a:solidFill>
+                      <a:srgbClr val="FFFFFF"/>
+                    </a:solidFill>
+                  </a:tcPr>
+                </a:tc>
+                <a:tc>
+                  <a:txBody>
+                    <a:bodyPr/>
+                    <a:lstStyle/>
+                    <a:p>
+                      <a:pPr algn="r"/>
+                      <a:r>
+                        <a:rPr sz="1000">
+                          <a:solidFill>
+                            <a:srgbClr val="3F3F3F"/>
+                          </a:solidFill>
+                          <a:latin typeface="Encode Sans"/>
+                        </a:rPr>
+                        <a:t>117,0</a:t>
+                      </a:r>
+                    </a:p>
+                  </a:txBody>
+                  <a:tcPr marL="36576" marR="36576" marT="18288" marB="18288">
+                    <a:solidFill>
+                      <a:srgbClr val="FFFFFF"/>
+                    </a:solidFill>
+                  </a:tcPr>
+                </a:tc>
+                <a:tc>
+                  <a:txBody>
+                    <a:bodyPr/>
+                    <a:lstStyle/>
+                    <a:p>
+                      <a:pPr algn="r"/>
+                      <a:r>
+                        <a:rPr sz="1000">
+                          <a:solidFill>
+                            <a:srgbClr val="3F3F3F"/>
+                          </a:solidFill>
+                          <a:latin typeface="Encode Sans"/>
+                        </a:rPr>
+                        <a:t>-5.7%</a:t>
+                      </a:r>
+                    </a:p>
+                  </a:txBody>
+                  <a:tcPr marL="36576" marR="36576" marT="18288" marB="18288">
+                    <a:solidFill>
+                      <a:srgbClr val="FFFFFF"/>
+                    </a:solidFill>
+                  </a:tcPr>
+                </a:tc>
+              </a:tr>
+              <a:tr h="292608">
+                <a:tc>
+                  <a:txBody>
+                    <a:bodyPr/>
+                    <a:lstStyle/>
+                    <a:p>
+                      <a:pPr algn="l"/>
+                      <a:r>
+                        <a:rPr sz="1000">
+                          <a:solidFill>
+                            <a:srgbClr val="3F3F3F"/>
+                          </a:solidFill>
+                          <a:latin typeface="Encode Sans"/>
+                        </a:rPr>
+                        <a:t>Abril 2026</a:t>
+                      </a:r>
+                    </a:p>
+                  </a:txBody>
+                  <a:tcPr marL="36576" marR="36576" marT="18288" marB="18288">
+                    <a:solidFill>
+                      <a:srgbClr val="F8F8F6"/>
+                    </a:solidFill>
+                  </a:tcPr>
+                </a:tc>
+                <a:tc>
+                  <a:txBody>
+                    <a:bodyPr/>
+                    <a:lstStyle/>
+                    <a:p>
+                      <a:pPr algn="r"/>
+                      <a:r>
+                        <a:rPr sz="1000">
+                          <a:solidFill>
+                            <a:srgbClr val="3F3F3F"/>
+                          </a:solidFill>
+                          <a:latin typeface="Encode Sans"/>
+                        </a:rPr>
+                        <a:t>118,6</a:t>
+                      </a:r>
+                    </a:p>
+                  </a:txBody>
+                  <a:tcPr marL="36576" marR="36576" marT="18288" marB="18288">
+                    <a:solidFill>
+                      <a:srgbClr val="F8F8F6"/>
+                    </a:solidFill>
+                  </a:tcPr>
+                </a:tc>
+                <a:tc>
+                  <a:txBody>
+                    <a:bodyPr/>
+                    <a:lstStyle/>
+                    <a:p>
+                      <a:pPr algn="r"/>
+                      <a:r>
+                        <a:rPr sz="1000">
+                          <a:solidFill>
+                            <a:srgbClr val="3F3F3F"/>
+                          </a:solidFill>
+                          <a:latin typeface="Encode Sans"/>
+                        </a:rPr>
+                        <a:t>-2.4%</a:t>
+                      </a:r>
+                    </a:p>
+                  </a:txBody>
+                  <a:tcPr marL="36576" marR="36576" marT="18288" marB="18288">
+                    <a:solidFill>
+                      <a:srgbClr val="F8F8F6"/>
+                    </a:solidFill>
+                  </a:tcPr>
+                </a:tc>
+              </a:tr>
+              <a:tr h="292608">
+                <a:tc>
+                  <a:txBody>
+                    <a:bodyPr/>
+                    <a:lstStyle/>
+                    <a:p>
+                      <a:pPr algn="l"/>
+                      <a:r>
+                        <a:rPr sz="1000">
+                          <a:solidFill>
+                            <a:srgbClr val="3F3F3F"/>
+                          </a:solidFill>
+                          <a:latin typeface="Encode Sans"/>
+                        </a:rPr>
+                        <a:t>Marzo 2026</a:t>
+                      </a:r>
+                    </a:p>
+                  </a:txBody>
+                  <a:tcPr marL="36576" marR="36576" marT="18288" marB="18288">
+                    <a:solidFill>
+                      <a:srgbClr val="FFFFFF"/>
+                    </a:solidFill>
+                  </a:tcPr>
+                </a:tc>
+                <a:tc>
+                  <a:txBody>
+                    <a:bodyPr/>
+                    <a:lstStyle/>
+                    <a:p>
+                      <a:pPr algn="r"/>
+                      <a:r>
+                        <a:rPr sz="1000">
+                          <a:solidFill>
+                            <a:srgbClr val="3F3F3F"/>
+                          </a:solidFill>
+                          <a:latin typeface="Encode Sans"/>
+                        </a:rPr>
+                        <a:t>122,2</a:t>
+                      </a:r>
+                    </a:p>
+                  </a:txBody>
+                  <a:tcPr marL="36576" marR="36576" marT="18288" marB="18288">
+                    <a:solidFill>
+                      <a:srgbClr val="FFFFFF"/>
+                    </a:solidFill>
+                  </a:tcPr>
+                </a:tc>
+                <a:tc>
+                  <a:txBody>
+                    <a:bodyPr/>
+                    <a:lstStyle/>
+                    <a:p>
+                      <a:pPr algn="r"/>
+                      <a:r>
+                        <a:rPr sz="1000">
+                          <a:solidFill>
+                            <a:srgbClr val="3F3F3F"/>
+                          </a:solidFill>
+                          <a:latin typeface="Encode Sans"/>
+                        </a:rPr>
+                        <a:t>+5.1%</a:t>
+                      </a:r>
+                    </a:p>
+                  </a:txBody>
+                  <a:tcPr marL="36576" marR="36576" marT="18288" marB="18288">
+                    <a:solidFill>
+                      <a:srgbClr val="FFFFFF"/>
+                    </a:solidFill>
+                  </a:tcPr>
+                </a:tc>
+              </a:tr>
+              <a:tr h="292608">
+                <a:tc>
+                  <a:txBody>
+                    <a:bodyPr/>
+                    <a:lstStyle/>
+                    <a:p>
+                      <a:pPr algn="l"/>
+                      <a:r>
+                        <a:rPr sz="1000">
+                          <a:solidFill>
+                            <a:srgbClr val="3F3F3F"/>
+                          </a:solidFill>
+                          <a:latin typeface="Encode Sans"/>
+                        </a:rPr>
+                        <a:t>Febrero 2026</a:t>
+                      </a:r>
+                    </a:p>
+                  </a:txBody>
+                  <a:tcPr marL="36576" marR="36576" marT="18288" marB="18288">
+                    <a:solidFill>
+                      <a:srgbClr val="F8F8F6"/>
+                    </a:solidFill>
+                  </a:tcPr>
+                </a:tc>
+                <a:tc>
+                  <a:txBody>
+                    <a:bodyPr/>
+                    <a:lstStyle/>
+                    <a:p>
+                      <a:pPr algn="r"/>
+                      <a:r>
+                        <a:rPr sz="1000">
+                          <a:solidFill>
+                            <a:srgbClr val="3F3F3F"/>
+                          </a:solidFill>
+                          <a:latin typeface="Encode Sans"/>
+                        </a:rPr>
+                        <a:t>100,3</a:t>
+                      </a:r>
+                    </a:p>
+                  </a:txBody>
+                  <a:tcPr marL="36576" marR="36576" marT="18288" marB="18288">
+                    <a:solidFill>
+                      <a:srgbClr val="F8F8F6"/>
+                    </a:solidFill>
+                  </a:tcPr>
+                </a:tc>
+                <a:tc>
+                  <a:txBody>
+                    <a:bodyPr/>
+                    <a:lstStyle/>
+                    <a:p>
+                      <a:pPr algn="r"/>
+                      <a:r>
+                        <a:rPr sz="1000">
+                          <a:solidFill>
+                            <a:srgbClr val="3F3F3F"/>
+                          </a:solidFill>
+                          <a:latin typeface="Encode Sans"/>
+                        </a:rPr>
+                        <a:t>-8.8%</a:t>
+                      </a:r>
+                    </a:p>
+                  </a:txBody>
+                  <a:tcPr marL="36576" marR="36576" marT="18288" marB="18288">
+                    <a:solidFill>
+                      <a:srgbClr val="F8F8F6"/>
+                    </a:solidFill>
+                  </a:tcPr>
+                </a:tc>
+              </a:tr>
+            </a:tbl>
+          </a:graphicData>
+        </a:graphic>
+      </p:graphicFrame>
+      <p:sp>
+        <p:nvSpPr>
+          <p:cNvPr id="9" name="TextBox 8"/>
+          <p:cNvSpPr txBox="1"/>
+          <p:nvPr/>
+        </p:nvSpPr>
+        <p:spPr>
+          <a:xfrm>
+            <a:off x="411480" y="6492240"/>
+            <a:ext cx="11368735" cy="274320"/>
+          </a:xfrm>
+          <a:prstGeom prst="rect">
+            <a:avLst/>
+          </a:prstGeom>
+          <a:noFill/>
+        </p:spPr>
+        <p:txBody>
+          <a:bodyPr wrap="none">
+            <a:spAutoFit/>
+          </a:bodyPr>
+          <a:lstStyle/>
+          <a:p>
+            <a:r>
+              <a:rPr sz="1000" b="0" i="1">
+                <a:solidFill>
+                  <a:srgbClr val="6A6760"/>
+                </a:solidFill>
+                <a:latin typeface="Encode Sans"/>
+              </a:rPr>
+              <a:t>Fuente: elaboración propia en base a INDEC</a:t>
+            </a:r>
+          </a:p>
+        </p:txBody>
+      </p:sp>
+    </p:spTree>
+  </p:cSld>
+  <p:clrMapOvr>
+    <a:masterClrMapping/>
+  </p:clrMapOvr>
+</p:sld>
+</file>
+
 <file path=ppt/theme/theme1.xml><?xml version="1.0" encoding="utf-8"?>
 <a:theme xmlns:a="http://schemas.openxmlformats.org/drawingml/2006/main" name="Office Theme">
   <a:themeElements>

</xml_diff>

<commit_message>
data: update 2026-09-10 ( data.json despidos.json scraper/historical_despidos.json scraper/calendar_oficial.json publicaciones_semana.pptx rrii_brutas.xlsx)
</commit_message>
<xml_diff>
--- a/publicaciones_semana.pptx
+++ b/publicaciones_semana.pptx
@@ -8,6 +8,7 @@
     <p:sldId id="256" r:id="rId7"/>
     <p:sldId id="257" r:id="rId8"/>
     <p:sldId id="258" r:id="rId9"/>
+    <p:sldId id="259" r:id="rId10"/>
   </p:sldIdLst>
   <p:sldSz cx="12191695" cy="6858000" type="screen4x3"/>
   <p:notesSz cx="6858000" cy="9144000"/>
@@ -3273,7 +3274,7 @@
                 </a:solidFill>
                 <a:latin typeface="Encode Sans"/>
               </a:rPr>
-              <a:t>2 publicaciones · datos oficiales INDEC / BCRA / Hacienda</a:t>
+              <a:t>3 publicaciones · datos oficiales INDEC / BCRA / Hacienda</a:t>
             </a:r>
           </a:p>
         </p:txBody>
@@ -4870,6 +4871,851 @@
                           <a:latin typeface="Encode Sans"/>
                         </a:rPr>
                         <a:t>-8.8%</a:t>
+                      </a:r>
+                    </a:p>
+                  </a:txBody>
+                  <a:tcPr marL="36576" marR="36576" marT="18288" marB="18288">
+                    <a:solidFill>
+                      <a:srgbClr val="F8F8F6"/>
+                    </a:solidFill>
+                  </a:tcPr>
+                </a:tc>
+              </a:tr>
+            </a:tbl>
+          </a:graphicData>
+        </a:graphic>
+      </p:graphicFrame>
+      <p:sp>
+        <p:nvSpPr>
+          <p:cNvPr id="9" name="TextBox 8"/>
+          <p:cNvSpPr txBox="1"/>
+          <p:nvPr/>
+        </p:nvSpPr>
+        <p:spPr>
+          <a:xfrm>
+            <a:off x="411480" y="6492240"/>
+            <a:ext cx="11368735" cy="274320"/>
+          </a:xfrm>
+          <a:prstGeom prst="rect">
+            <a:avLst/>
+          </a:prstGeom>
+          <a:noFill/>
+        </p:spPr>
+        <p:txBody>
+          <a:bodyPr wrap="none">
+            <a:spAutoFit/>
+          </a:bodyPr>
+          <a:lstStyle/>
+          <a:p>
+            <a:r>
+              <a:rPr sz="1000" b="0" i="1">
+                <a:solidFill>
+                  <a:srgbClr val="6A6760"/>
+                </a:solidFill>
+                <a:latin typeface="Encode Sans"/>
+              </a:rPr>
+              <a:t>Fuente: elaboración propia en base a INDEC</a:t>
+            </a:r>
+          </a:p>
+        </p:txBody>
+      </p:sp>
+    </p:spTree>
+  </p:cSld>
+  <p:clrMapOvr>
+    <a:masterClrMapping/>
+  </p:clrMapOvr>
+</p:sld>
+</file>
+
+<file path=ppt/slides/slide4.xml><?xml version="1.0" encoding="utf-8"?>
+<p:sld xmlns:a="http://schemas.openxmlformats.org/drawingml/2006/main" xmlns:p="http://schemas.openxmlformats.org/presentationml/2006/main" xmlns:r="http://schemas.openxmlformats.org/officeDocument/2006/relationships">
+  <p:cSld>
+    <p:spTree>
+      <p:nvGrpSpPr>
+        <p:cNvPr id="1" name=""/>
+        <p:cNvGrpSpPr/>
+        <p:nvPr/>
+      </p:nvGrpSpPr>
+      <p:grpSpPr/>
+      <p:sp>
+        <p:nvSpPr>
+          <p:cNvPr id="2" name="Rectangle 1"/>
+          <p:cNvSpPr/>
+          <p:nvPr/>
+        </p:nvSpPr>
+        <p:spPr>
+          <a:xfrm>
+            <a:off x="0" y="0"/>
+            <a:ext cx="12191695" cy="274320"/>
+          </a:xfrm>
+          <a:prstGeom prst="rect">
+            <a:avLst/>
+          </a:prstGeom>
+          <a:solidFill>
+            <a:srgbClr val="00B2C9"/>
+          </a:solidFill>
+          <a:ln>
+            <a:noFill/>
+          </a:ln>
+        </p:spPr>
+        <p:style>
+          <a:lnRef idx="1">
+            <a:schemeClr val="accent1"/>
+          </a:lnRef>
+          <a:fillRef idx="3">
+            <a:schemeClr val="accent1"/>
+          </a:fillRef>
+          <a:effectRef idx="2">
+            <a:schemeClr val="accent1"/>
+          </a:effectRef>
+          <a:fontRef idx="minor">
+            <a:schemeClr val="lt1"/>
+          </a:fontRef>
+        </p:style>
+        <p:txBody>
+          <a:bodyPr rtlCol="0" anchor="ctr"/>
+          <a:lstStyle/>
+          <a:p>
+            <a:pPr algn="ctr"/>
+          </a:p>
+        </p:txBody>
+      </p:sp>
+      <p:sp>
+        <p:nvSpPr>
+          <p:cNvPr id="3" name="TextBox 2"/>
+          <p:cNvSpPr txBox="1"/>
+          <p:nvPr/>
+        </p:nvSpPr>
+        <p:spPr>
+          <a:xfrm>
+            <a:off x="411480" y="457200"/>
+            <a:ext cx="11368735" cy="914400"/>
+          </a:xfrm>
+          <a:prstGeom prst="rect">
+            <a:avLst/>
+          </a:prstGeom>
+          <a:noFill/>
+        </p:spPr>
+        <p:txBody>
+          <a:bodyPr wrap="square" lIns="0" rIns="0">
+            <a:spAutoFit/>
+          </a:bodyPr>
+          <a:lstStyle/>
+          <a:p>
+            <a:pPr algn="l"/>
+            <a:r>
+              <a:rPr sz="2600" b="1" i="0">
+                <a:solidFill>
+                  <a:srgbClr val="00B2C9"/>
+                </a:solidFill>
+                <a:latin typeface="Encode Sans"/>
+              </a:rPr>
+              <a:t>INFLACIÓN AGOSTO 2026: +1.7%</a:t>
+            </a:r>
+          </a:p>
+        </p:txBody>
+      </p:sp>
+      <p:sp>
+        <p:nvSpPr>
+          <p:cNvPr id="4" name="TextBox 3"/>
+          <p:cNvSpPr txBox="1"/>
+          <p:nvPr/>
+        </p:nvSpPr>
+        <p:spPr>
+          <a:xfrm>
+            <a:off x="411480" y="1280160"/>
+            <a:ext cx="11368735" cy="274320"/>
+          </a:xfrm>
+          <a:prstGeom prst="rect">
+            <a:avLst/>
+          </a:prstGeom>
+          <a:noFill/>
+        </p:spPr>
+        <p:txBody>
+          <a:bodyPr wrap="none">
+            <a:spAutoFit/>
+          </a:bodyPr>
+          <a:lstStyle/>
+          <a:p>
+            <a:r>
+              <a:rPr sz="1100" b="0" i="1">
+                <a:solidFill>
+                  <a:srgbClr val="6A6760"/>
+                </a:solidFill>
+                <a:latin typeface="Encode Sans"/>
+              </a:rPr>
+              <a:t>INDEC · período 2026-08</a:t>
+            </a:r>
+          </a:p>
+        </p:txBody>
+      </p:sp>
+      <p:sp>
+        <p:nvSpPr>
+          <p:cNvPr id="5" name="TextBox 4"/>
+          <p:cNvSpPr txBox="1"/>
+          <p:nvPr/>
+        </p:nvSpPr>
+        <p:spPr>
+          <a:xfrm>
+            <a:off x="411480" y="1691640"/>
+            <a:ext cx="5486400" cy="1645920"/>
+          </a:xfrm>
+          <a:prstGeom prst="rect">
+            <a:avLst/>
+          </a:prstGeom>
+          <a:noFill/>
+        </p:spPr>
+        <p:txBody>
+          <a:bodyPr wrap="square" lIns="0" rIns="0">
+            <a:spAutoFit/>
+          </a:bodyPr>
+          <a:lstStyle/>
+          <a:p>
+            <a:pPr algn="just"/>
+            <a:r>
+              <a:rPr sz="1300" b="0" i="0">
+                <a:solidFill>
+                  <a:srgbClr val="3F3F3F"/>
+                </a:solidFill>
+                <a:latin typeface="Encode Sans"/>
+              </a:rPr>
+              <a:t>El IPC nivel general aumentó +1.7% mensual en agosto 2026, acumulando 33.59% interanual. INDEC publicó el indicador con la metodología vigente.</a:t>
+            </a:r>
+          </a:p>
+        </p:txBody>
+      </p:sp>
+      <p:sp>
+        <p:nvSpPr>
+          <p:cNvPr id="6" name="TextBox 5"/>
+          <p:cNvSpPr txBox="1"/>
+          <p:nvPr/>
+        </p:nvSpPr>
+        <p:spPr>
+          <a:xfrm>
+            <a:off x="411480" y="3520440"/>
+            <a:ext cx="5486400" cy="2743200"/>
+          </a:xfrm>
+          <a:prstGeom prst="rect">
+            <a:avLst/>
+          </a:prstGeom>
+          <a:noFill/>
+        </p:spPr>
+        <p:txBody>
+          <a:bodyPr wrap="square" lIns="0" rIns="0">
+            <a:spAutoFit/>
+          </a:bodyPr>
+          <a:lstStyle/>
+          <a:p>
+            <a:pPr algn="l">
+              <a:spcAft>
+                <a:spcPts val="800"/>
+              </a:spcAft>
+            </a:pPr>
+            <a:r>
+              <a:rPr sz="1300" b="1" i="0">
+                <a:solidFill>
+                  <a:srgbClr val="00B2C9"/>
+                </a:solidFill>
+                <a:latin typeface="Encode Sans"/>
+              </a:rPr>
+              <a:t>●  </a:t>
+            </a:r>
+            <a:r>
+              <a:rPr sz="1300" b="0" i="0">
+                <a:solidFill>
+                  <a:srgbClr val="3F3F3F"/>
+                </a:solidFill>
+                <a:latin typeface="Encode Sans"/>
+              </a:rPr>
+              <a:t>Variación mensual: +1.7%</a:t>
+            </a:r>
+          </a:p>
+          <a:p>
+            <a:pPr algn="l">
+              <a:spcAft>
+                <a:spcPts val="800"/>
+              </a:spcAft>
+            </a:pPr>
+            <a:r>
+              <a:rPr sz="1300" b="1" i="0">
+                <a:solidFill>
+                  <a:srgbClr val="00B2C9"/>
+                </a:solidFill>
+                <a:latin typeface="Encode Sans"/>
+              </a:rPr>
+              <a:t>●  </a:t>
+            </a:r>
+            <a:r>
+              <a:rPr sz="1300" b="0" i="0">
+                <a:solidFill>
+                  <a:srgbClr val="3F3F3F"/>
+                </a:solidFill>
+                <a:latin typeface="Encode Sans"/>
+              </a:rPr>
+              <a:t>Variación interanual: 33.59%</a:t>
+            </a:r>
+          </a:p>
+          <a:p>
+            <a:pPr algn="l">
+              <a:spcAft>
+                <a:spcPts val="800"/>
+              </a:spcAft>
+            </a:pPr>
+            <a:r>
+              <a:rPr sz="1300" b="1" i="0">
+                <a:solidFill>
+                  <a:srgbClr val="00B2C9"/>
+                </a:solidFill>
+                <a:latin typeface="Encode Sans"/>
+              </a:rPr>
+              <a:t>●  </a:t>
+            </a:r>
+            <a:r>
+              <a:rPr sz="1300" b="0" i="0">
+                <a:solidFill>
+                  <a:srgbClr val="3F3F3F"/>
+                </a:solidFill>
+                <a:latin typeface="Encode Sans"/>
+              </a:rPr>
+              <a:t>Acumulado últimos 6 meses: 13.8% (suma simple)</a:t>
+            </a:r>
+          </a:p>
+        </p:txBody>
+      </p:sp>
+      <p:pic>
+        <p:nvPicPr>
+          <p:cNvPr id="7" name="Picture 6" descr="image.png"/>
+          <p:cNvPicPr>
+            <a:picLocks noChangeAspect="1"/>
+          </p:cNvPicPr>
+          <p:nvPr/>
+        </p:nvPicPr>
+        <p:blipFill>
+          <a:blip r:embed="rId2"/>
+          <a:stretch>
+            <a:fillRect/>
+          </a:stretch>
+        </p:blipFill>
+        <p:spPr>
+          <a:xfrm>
+            <a:off x="6080760" y="1691640"/>
+            <a:ext cx="5669280" cy="2560320"/>
+          </a:xfrm>
+          <a:prstGeom prst="rect">
+            <a:avLst/>
+          </a:prstGeom>
+        </p:spPr>
+      </p:pic>
+      <p:graphicFrame>
+        <p:nvGraphicFramePr>
+          <p:cNvPr id="8" name="Table 7"/>
+          <p:cNvGraphicFramePr>
+            <a:graphicFrameLocks noGrp="1"/>
+          </p:cNvGraphicFramePr>
+          <p:nvPr/>
+        </p:nvGraphicFramePr>
+        <p:xfrm>
+          <a:off x="6080760" y="4434840"/>
+          <a:ext cx="5669280" cy="2048256"/>
+        </p:xfrm>
+        <a:graphic>
+          <a:graphicData uri="http://schemas.openxmlformats.org/drawingml/2006/table">
+            <a:tbl>
+              <a:tblPr firstRow="1" bandRow="1">
+                <a:tableStyleId>{5C22544A-7EE6-4342-B048-85BDC9FD1C3A}</a:tableStyleId>
+              </a:tblPr>
+              <a:tblGrid>
+                <a:gridCol w="1889760"/>
+                <a:gridCol w="1889760"/>
+                <a:gridCol w="1889760"/>
+              </a:tblGrid>
+              <a:tr h="292608">
+                <a:tc>
+                  <a:txBody>
+                    <a:bodyPr/>
+                    <a:lstStyle/>
+                    <a:p>
+                      <a:pPr algn="l"/>
+                      <a:r>
+                        <a:rPr sz="1000" b="1">
+                          <a:solidFill>
+                            <a:srgbClr val="FFFFFF"/>
+                          </a:solidFill>
+                          <a:latin typeface="Encode Sans"/>
+                        </a:rPr>
+                        <a:t>Mes</a:t>
+                      </a:r>
+                    </a:p>
+                  </a:txBody>
+                  <a:tcPr marL="36576" marR="36576" marT="18288" marB="18288">
+                    <a:solidFill>
+                      <a:srgbClr val="00B2C9"/>
+                    </a:solidFill>
+                  </a:tcPr>
+                </a:tc>
+                <a:tc>
+                  <a:txBody>
+                    <a:bodyPr/>
+                    <a:lstStyle/>
+                    <a:p>
+                      <a:pPr algn="r"/>
+                      <a:r>
+                        <a:rPr sz="1000" b="1">
+                          <a:solidFill>
+                            <a:srgbClr val="FFFFFF"/>
+                          </a:solidFill>
+                          <a:latin typeface="Encode Sans"/>
+                        </a:rPr>
+                        <a:t>VM %</a:t>
+                      </a:r>
+                    </a:p>
+                  </a:txBody>
+                  <a:tcPr marL="36576" marR="36576" marT="18288" marB="18288">
+                    <a:solidFill>
+                      <a:srgbClr val="00B2C9"/>
+                    </a:solidFill>
+                  </a:tcPr>
+                </a:tc>
+                <a:tc>
+                  <a:txBody>
+                    <a:bodyPr/>
+                    <a:lstStyle/>
+                    <a:p>
+                      <a:pPr algn="r"/>
+                      <a:r>
+                        <a:rPr sz="1000" b="1">
+                          <a:solidFill>
+                            <a:srgbClr val="FFFFFF"/>
+                          </a:solidFill>
+                          <a:latin typeface="Encode Sans"/>
+                        </a:rPr>
+                        <a:t>VIA %</a:t>
+                      </a:r>
+                    </a:p>
+                  </a:txBody>
+                  <a:tcPr marL="36576" marR="36576" marT="18288" marB="18288">
+                    <a:solidFill>
+                      <a:srgbClr val="00B2C9"/>
+                    </a:solidFill>
+                  </a:tcPr>
+                </a:tc>
+              </a:tr>
+              <a:tr h="292608">
+                <a:tc>
+                  <a:txBody>
+                    <a:bodyPr/>
+                    <a:lstStyle/>
+                    <a:p>
+                      <a:pPr algn="l"/>
+                      <a:r>
+                        <a:rPr sz="1000">
+                          <a:solidFill>
+                            <a:srgbClr val="3F3F3F"/>
+                          </a:solidFill>
+                          <a:latin typeface="Encode Sans"/>
+                        </a:rPr>
+                        <a:t>Agosto 2026</a:t>
+                      </a:r>
+                    </a:p>
+                  </a:txBody>
+                  <a:tcPr marL="36576" marR="36576" marT="18288" marB="18288">
+                    <a:solidFill>
+                      <a:srgbClr val="FFFFFF"/>
+                    </a:solidFill>
+                  </a:tcPr>
+                </a:tc>
+                <a:tc>
+                  <a:txBody>
+                    <a:bodyPr/>
+                    <a:lstStyle/>
+                    <a:p>
+                      <a:pPr algn="r"/>
+                      <a:r>
+                        <a:rPr sz="1000">
+                          <a:solidFill>
+                            <a:srgbClr val="3F3F3F"/>
+                          </a:solidFill>
+                          <a:latin typeface="Encode Sans"/>
+                        </a:rPr>
+                        <a:t>+1.7%</a:t>
+                      </a:r>
+                    </a:p>
+                  </a:txBody>
+                  <a:tcPr marL="36576" marR="36576" marT="18288" marB="18288">
+                    <a:solidFill>
+                      <a:srgbClr val="FFFFFF"/>
+                    </a:solidFill>
+                  </a:tcPr>
+                </a:tc>
+                <a:tc>
+                  <a:txBody>
+                    <a:bodyPr/>
+                    <a:lstStyle/>
+                    <a:p>
+                      <a:pPr algn="r"/>
+                      <a:r>
+                        <a:rPr sz="1000">
+                          <a:solidFill>
+                            <a:srgbClr val="3F3F3F"/>
+                          </a:solidFill>
+                          <a:latin typeface="Encode Sans"/>
+                        </a:rPr>
+                        <a:t>+33.6%</a:t>
+                      </a:r>
+                    </a:p>
+                  </a:txBody>
+                  <a:tcPr marL="36576" marR="36576" marT="18288" marB="18288">
+                    <a:solidFill>
+                      <a:srgbClr val="FFFFFF"/>
+                    </a:solidFill>
+                  </a:tcPr>
+                </a:tc>
+              </a:tr>
+              <a:tr h="292608">
+                <a:tc>
+                  <a:txBody>
+                    <a:bodyPr/>
+                    <a:lstStyle/>
+                    <a:p>
+                      <a:pPr algn="l"/>
+                      <a:r>
+                        <a:rPr sz="1000">
+                          <a:solidFill>
+                            <a:srgbClr val="3F3F3F"/>
+                          </a:solidFill>
+                          <a:latin typeface="Encode Sans"/>
+                        </a:rPr>
+                        <a:t>Julio 2026</a:t>
+                      </a:r>
+                    </a:p>
+                  </a:txBody>
+                  <a:tcPr marL="36576" marR="36576" marT="18288" marB="18288">
+                    <a:solidFill>
+                      <a:srgbClr val="F8F8F6"/>
+                    </a:solidFill>
+                  </a:tcPr>
+                </a:tc>
+                <a:tc>
+                  <a:txBody>
+                    <a:bodyPr/>
+                    <a:lstStyle/>
+                    <a:p>
+                      <a:pPr algn="r"/>
+                      <a:r>
+                        <a:rPr sz="1000">
+                          <a:solidFill>
+                            <a:srgbClr val="3F3F3F"/>
+                          </a:solidFill>
+                          <a:latin typeface="Encode Sans"/>
+                        </a:rPr>
+                        <a:t>+2.1%</a:t>
+                      </a:r>
+                    </a:p>
+                  </a:txBody>
+                  <a:tcPr marL="36576" marR="36576" marT="18288" marB="18288">
+                    <a:solidFill>
+                      <a:srgbClr val="F8F8F6"/>
+                    </a:solidFill>
+                  </a:tcPr>
+                </a:tc>
+                <a:tc>
+                  <a:txBody>
+                    <a:bodyPr/>
+                    <a:lstStyle/>
+                    <a:p>
+                      <a:pPr algn="r"/>
+                      <a:r>
+                        <a:rPr sz="1000">
+                          <a:solidFill>
+                            <a:srgbClr val="3F3F3F"/>
+                          </a:solidFill>
+                          <a:latin typeface="Encode Sans"/>
+                        </a:rPr>
+                        <a:t>+33.8%</a:t>
+                      </a:r>
+                    </a:p>
+                  </a:txBody>
+                  <a:tcPr marL="36576" marR="36576" marT="18288" marB="18288">
+                    <a:solidFill>
+                      <a:srgbClr val="F8F8F6"/>
+                    </a:solidFill>
+                  </a:tcPr>
+                </a:tc>
+              </a:tr>
+              <a:tr h="292608">
+                <a:tc>
+                  <a:txBody>
+                    <a:bodyPr/>
+                    <a:lstStyle/>
+                    <a:p>
+                      <a:pPr algn="l"/>
+                      <a:r>
+                        <a:rPr sz="1000">
+                          <a:solidFill>
+                            <a:srgbClr val="3F3F3F"/>
+                          </a:solidFill>
+                          <a:latin typeface="Encode Sans"/>
+                        </a:rPr>
+                        <a:t>Junio 2026</a:t>
+                      </a:r>
+                    </a:p>
+                  </a:txBody>
+                  <a:tcPr marL="36576" marR="36576" marT="18288" marB="18288">
+                    <a:solidFill>
+                      <a:srgbClr val="FFFFFF"/>
+                    </a:solidFill>
+                  </a:tcPr>
+                </a:tc>
+                <a:tc>
+                  <a:txBody>
+                    <a:bodyPr/>
+                    <a:lstStyle/>
+                    <a:p>
+                      <a:pPr algn="r"/>
+                      <a:r>
+                        <a:rPr sz="1000">
+                          <a:solidFill>
+                            <a:srgbClr val="3F3F3F"/>
+                          </a:solidFill>
+                          <a:latin typeface="Encode Sans"/>
+                        </a:rPr>
+                        <a:t>+1.9%</a:t>
+                      </a:r>
+                    </a:p>
+                  </a:txBody>
+                  <a:tcPr marL="36576" marR="36576" marT="18288" marB="18288">
+                    <a:solidFill>
+                      <a:srgbClr val="FFFFFF"/>
+                    </a:solidFill>
+                  </a:tcPr>
+                </a:tc>
+                <a:tc>
+                  <a:txBody>
+                    <a:bodyPr/>
+                    <a:lstStyle/>
+                    <a:p>
+                      <a:pPr algn="r"/>
+                      <a:r>
+                        <a:rPr sz="1000">
+                          <a:solidFill>
+                            <a:srgbClr val="3F3F3F"/>
+                          </a:solidFill>
+                          <a:latin typeface="Encode Sans"/>
+                        </a:rPr>
+                        <a:t>+33.5%</a:t>
+                      </a:r>
+                    </a:p>
+                  </a:txBody>
+                  <a:tcPr marL="36576" marR="36576" marT="18288" marB="18288">
+                    <a:solidFill>
+                      <a:srgbClr val="FFFFFF"/>
+                    </a:solidFill>
+                  </a:tcPr>
+                </a:tc>
+              </a:tr>
+              <a:tr h="292608">
+                <a:tc>
+                  <a:txBody>
+                    <a:bodyPr/>
+                    <a:lstStyle/>
+                    <a:p>
+                      <a:pPr algn="l"/>
+                      <a:r>
+                        <a:rPr sz="1000">
+                          <a:solidFill>
+                            <a:srgbClr val="3F3F3F"/>
+                          </a:solidFill>
+                          <a:latin typeface="Encode Sans"/>
+                        </a:rPr>
+                        <a:t>Mayo 2026</a:t>
+                      </a:r>
+                    </a:p>
+                  </a:txBody>
+                  <a:tcPr marL="36576" marR="36576" marT="18288" marB="18288">
+                    <a:solidFill>
+                      <a:srgbClr val="F8F8F6"/>
+                    </a:solidFill>
+                  </a:tcPr>
+                </a:tc>
+                <a:tc>
+                  <a:txBody>
+                    <a:bodyPr/>
+                    <a:lstStyle/>
+                    <a:p>
+                      <a:pPr algn="r"/>
+                      <a:r>
+                        <a:rPr sz="1000">
+                          <a:solidFill>
+                            <a:srgbClr val="3F3F3F"/>
+                          </a:solidFill>
+                          <a:latin typeface="Encode Sans"/>
+                        </a:rPr>
+                        <a:t>+2.1%</a:t>
+                      </a:r>
+                    </a:p>
+                  </a:txBody>
+                  <a:tcPr marL="36576" marR="36576" marT="18288" marB="18288">
+                    <a:solidFill>
+                      <a:srgbClr val="F8F8F6"/>
+                    </a:solidFill>
+                  </a:tcPr>
+                </a:tc>
+                <a:tc>
+                  <a:txBody>
+                    <a:bodyPr/>
+                    <a:lstStyle/>
+                    <a:p>
+                      <a:pPr algn="r"/>
+                      <a:r>
+                        <a:rPr sz="1000">
+                          <a:solidFill>
+                            <a:srgbClr val="3F3F3F"/>
+                          </a:solidFill>
+                          <a:latin typeface="Encode Sans"/>
+                        </a:rPr>
+                        <a:t>+33.2%</a:t>
+                      </a:r>
+                    </a:p>
+                  </a:txBody>
+                  <a:tcPr marL="36576" marR="36576" marT="18288" marB="18288">
+                    <a:solidFill>
+                      <a:srgbClr val="F8F8F6"/>
+                    </a:solidFill>
+                  </a:tcPr>
+                </a:tc>
+              </a:tr>
+              <a:tr h="292608">
+                <a:tc>
+                  <a:txBody>
+                    <a:bodyPr/>
+                    <a:lstStyle/>
+                    <a:p>
+                      <a:pPr algn="l"/>
+                      <a:r>
+                        <a:rPr sz="1000">
+                          <a:solidFill>
+                            <a:srgbClr val="3F3F3F"/>
+                          </a:solidFill>
+                          <a:latin typeface="Encode Sans"/>
+                        </a:rPr>
+                        <a:t>Abril 2026</a:t>
+                      </a:r>
+                    </a:p>
+                  </a:txBody>
+                  <a:tcPr marL="36576" marR="36576" marT="18288" marB="18288">
+                    <a:solidFill>
+                      <a:srgbClr val="FFFFFF"/>
+                    </a:solidFill>
+                  </a:tcPr>
+                </a:tc>
+                <a:tc>
+                  <a:txBody>
+                    <a:bodyPr/>
+                    <a:lstStyle/>
+                    <a:p>
+                      <a:pPr algn="r"/>
+                      <a:r>
+                        <a:rPr sz="1000">
+                          <a:solidFill>
+                            <a:srgbClr val="3F3F3F"/>
+                          </a:solidFill>
+                          <a:latin typeface="Encode Sans"/>
+                        </a:rPr>
+                        <a:t>+2.6%</a:t>
+                      </a:r>
+                    </a:p>
+                  </a:txBody>
+                  <a:tcPr marL="36576" marR="36576" marT="18288" marB="18288">
+                    <a:solidFill>
+                      <a:srgbClr val="FFFFFF"/>
+                    </a:solidFill>
+                  </a:tcPr>
+                </a:tc>
+                <a:tc>
+                  <a:txBody>
+                    <a:bodyPr/>
+                    <a:lstStyle/>
+                    <a:p>
+                      <a:pPr algn="r"/>
+                      <a:r>
+                        <a:rPr sz="1000">
+                          <a:solidFill>
+                            <a:srgbClr val="3F3F3F"/>
+                          </a:solidFill>
+                          <a:latin typeface="Encode Sans"/>
+                        </a:rPr>
+                        <a:t>+32.4%</a:t>
+                      </a:r>
+                    </a:p>
+                  </a:txBody>
+                  <a:tcPr marL="36576" marR="36576" marT="18288" marB="18288">
+                    <a:solidFill>
+                      <a:srgbClr val="FFFFFF"/>
+                    </a:solidFill>
+                  </a:tcPr>
+                </a:tc>
+              </a:tr>
+              <a:tr h="292608">
+                <a:tc>
+                  <a:txBody>
+                    <a:bodyPr/>
+                    <a:lstStyle/>
+                    <a:p>
+                      <a:pPr algn="l"/>
+                      <a:r>
+                        <a:rPr sz="1000">
+                          <a:solidFill>
+                            <a:srgbClr val="3F3F3F"/>
+                          </a:solidFill>
+                          <a:latin typeface="Encode Sans"/>
+                        </a:rPr>
+                        <a:t>Marzo 2026</a:t>
+                      </a:r>
+                    </a:p>
+                  </a:txBody>
+                  <a:tcPr marL="36576" marR="36576" marT="18288" marB="18288">
+                    <a:solidFill>
+                      <a:srgbClr val="F8F8F6"/>
+                    </a:solidFill>
+                  </a:tcPr>
+                </a:tc>
+                <a:tc>
+                  <a:txBody>
+                    <a:bodyPr/>
+                    <a:lstStyle/>
+                    <a:p>
+                      <a:pPr algn="r"/>
+                      <a:r>
+                        <a:rPr sz="1000">
+                          <a:solidFill>
+                            <a:srgbClr val="3F3F3F"/>
+                          </a:solidFill>
+                          <a:latin typeface="Encode Sans"/>
+                        </a:rPr>
+                        <a:t>+3.4%</a:t>
+                      </a:r>
+                    </a:p>
+                  </a:txBody>
+                  <a:tcPr marL="36576" marR="36576" marT="18288" marB="18288">
+                    <a:solidFill>
+                      <a:srgbClr val="F8F8F6"/>
+                    </a:solidFill>
+                  </a:tcPr>
+                </a:tc>
+                <a:tc>
+                  <a:txBody>
+                    <a:bodyPr/>
+                    <a:lstStyle/>
+                    <a:p>
+                      <a:pPr algn="r"/>
+                      <a:r>
+                        <a:rPr sz="1000">
+                          <a:solidFill>
+                            <a:srgbClr val="3F3F3F"/>
+                          </a:solidFill>
+                          <a:latin typeface="Encode Sans"/>
+                        </a:rPr>
+                        <a:t>+32.6%</a:t>
                       </a:r>
                     </a:p>
                   </a:txBody>

</xml_diff>

<commit_message>
data: update 2026-09-11 ( data.json despidos.json scraper/historical_despidos.json publicaciones_semana.pptx rrii_brutas.xlsx)
</commit_message>
<xml_diff>
--- a/publicaciones_semana.pptx
+++ b/publicaciones_semana.pptx
@@ -5079,7 +5079,7 @@
                 </a:solidFill>
                 <a:latin typeface="Encode Sans"/>
               </a:rPr>
-              <a:t>El IPC nivel general aumentó +1.7% mensual en agosto 2026, acumulando 33.59% interanual. INDEC publicó el indicador con la metodología vigente.</a:t>
+              <a:t>El IPC nivel general aumentó +1.7% mensual en agosto 2026, acumulando 33.54% interanual. INDEC publicó el indicador con la metodología vigente.</a:t>
             </a:r>
           </a:p>
         </p:txBody>
@@ -5152,7 +5152,7 @@
                 </a:solidFill>
                 <a:latin typeface="Encode Sans"/>
               </a:rPr>
-              <a:t>Variación interanual: 33.59%</a:t>
+              <a:t>Variación interanual: 33.54%</a:t>
             </a:r>
           </a:p>
           <a:p>
@@ -5360,7 +5360,7 @@
                           </a:solidFill>
                           <a:latin typeface="Encode Sans"/>
                         </a:rPr>
-                        <a:t>+33.6%</a:t>
+                        <a:t>+33.5%</a:t>
                       </a:r>
                     </a:p>
                   </a:txBody>

</xml_diff>